<commit_message>
Clase 02 con la EOD Santiago 2012 y arranque de la Tarea 1
Se agregan los microdatos de la EOD (hogares, personas, viajes y tablas de
parametros) y se rehace la clase 02 sobre ellos, con secciones guiadas por
preguntas sobre Santiago y un concepto central: ¿de quien habla este numero?
Incluye el notebook ejecutado, las slides regeneradas, la actividad como primera
sesion de la tarea, y el enunciado de la Tarea 1: el retrato de una comuna,
que se desarrolla por etapas en las clases 02 a 04.

El enfoque esta inspirado en el material del curso de visualizacion de Eduardo
Graells-Garrido (github.com/zorzalerrante/aves).

Co-Authored-By: Claude Fable 5 <noreply@anthropic.com>
</commit_message>
<xml_diff>
--- a/presentaciones/clase02_pandas_eda.pptx
+++ b/presentaciones/clase02_pandas_eda.pptx
@@ -26,9 +26,6 @@
     <p:sldId id="274" r:id="rId25"/>
     <p:sldId id="275" r:id="rId26"/>
     <p:sldId id="276" r:id="rId27"/>
-    <p:sldId id="277" r:id="rId28"/>
-    <p:sldId id="278" r:id="rId29"/>
-    <p:sldId id="279" r:id="rId30"/>
   </p:sldIdLst>
   <p:sldSz cx="9144000" cy="5138928" type="screen4x3"/>
   <p:notesSz cx="6858000" cy="9144000"/>
@@ -3184,7 +3181,7 @@
                 </a:solidFill>
                 <a:latin typeface="PT Serif"/>
               </a:rPr>
-              <a:t>Manipulación de datos y análisis exploratorio</a:t>
+              <a:t>¿Cómo se mueve Santiago?</a:t>
             </a:r>
           </a:p>
         </p:txBody>
@@ -3237,7 +3234,7 @@
                 </a:solidFill>
                 <a:latin typeface="PT Serif"/>
               </a:rPr>
-              <a:t>Clase 2 · Pandas y EDA</a:t>
+              <a:t>Clase 2 · Pandas (repaso) y análisis exploratorio</a:t>
             </a:r>
           </a:p>
         </p:txBody>
@@ -3378,7 +3375,7 @@
                 </a:solidFill>
                 <a:latin typeface="PT Serif"/>
               </a:rPr>
-              <a:t>Filtrar con condiciones</a:t>
+              <a:t>¿Quiénes son? Derivar una columna</a:t>
             </a:r>
           </a:p>
         </p:txBody>
@@ -3392,7 +3389,7 @@
         <p:spPr>
           <a:xfrm>
             <a:off x="704088" y="1280160"/>
-            <a:ext cx="7744968" cy="3383280"/>
+            <a:ext cx="7744968" cy="2377440"/>
           </a:xfrm>
           <a:prstGeom prst="rect">
             <a:avLst/>
@@ -3433,7 +3430,7 @@
                 </a:solidFill>
                 <a:latin typeface="Menlo"/>
               </a:rPr>
-              <a:t>mp25 = emisiones[emisiones['contaminante'] == 'MP2,5']</a:t>
+              <a:t>personas['Edad'] = 2013 - personas['AnoNac']</a:t>
             </a:r>
           </a:p>
           <a:p>
@@ -3457,7 +3454,7 @@
                 </a:solidFill>
                 <a:latin typeface="Menlo"/>
               </a:rPr>
-              <a:t>rm = emisiones[</a:t>
+              <a:t>personas['Edad'].describe()</a:t>
             </a:r>
           </a:p>
           <a:p>
@@ -3469,31 +3466,7 @@
                 </a:solidFill>
                 <a:latin typeface="Menlo"/>
               </a:rPr>
-              <a:t>    (emisiones['contaminante'] == 'MP2,5')</a:t>
-            </a:r>
-          </a:p>
-          <a:p>
-            <a:pPr/>
-            <a:r>
-              <a:rPr sz="1500" b="0">
-                <a:solidFill>
-                  <a:srgbClr val="1D3557"/>
-                </a:solidFill>
-                <a:latin typeface="Menlo"/>
-              </a:rPr>
-              <a:t>    &amp; (emisiones['region'] == 'Metropolitana')</a:t>
-            </a:r>
-          </a:p>
-          <a:p>
-            <a:pPr/>
-            <a:r>
-              <a:rPr sz="1500" b="0">
-                <a:solidFill>
-                  <a:srgbClr val="1D3557"/>
-                </a:solidFill>
-                <a:latin typeface="Menlo"/>
-              </a:rPr>
-              <a:t>]</a:t>
+              <a:t>personas['Sexo'].value_counts()   # devuelve 1 y 2...</a:t>
             </a:r>
           </a:p>
         </p:txBody>
@@ -3506,7 +3479,7 @@
         </p:nvSpPr>
         <p:spPr>
           <a:xfrm>
-            <a:off x="704088" y="4892040"/>
+            <a:off x="704088" y="3886200"/>
             <a:ext cx="7744968" cy="1097280"/>
           </a:xfrm>
           <a:prstGeom prst="rect">
@@ -3536,7 +3509,7 @@
                 </a:solidFill>
                 <a:latin typeface="PT Serif"/>
               </a:rPr>
-              <a:t>Cada condición va entre paréntesis, y se combinan con &amp; y con |.</a:t>
+              <a:t>No hay columna de edad: se deriva. Y el sexo son códigos que no significan nada solos.</a:t>
             </a:r>
           </a:p>
         </p:txBody>
@@ -3632,21 +3605,124 @@
                 </a:solidFill>
                 <a:latin typeface="PT Serif"/>
               </a:rPr>
-              <a:t>Datos faltantes</a:t>
-            </a:r>
-          </a:p>
-        </p:txBody>
-      </p:sp>
-      <p:sp>
-        <p:nvSpPr>
-          <p:cNvPr id="4" name="TextBox 3"/>
+              <a:t>¿Qué significan los códigos? El merge motivado</a:t>
+            </a:r>
+          </a:p>
+        </p:txBody>
+      </p:sp>
+      <p:sp>
+        <p:nvSpPr>
+          <p:cNvPr id="4" name="Rectangle 3"/>
+          <p:cNvSpPr/>
+          <p:nvPr/>
+        </p:nvSpPr>
+        <p:spPr>
+          <a:xfrm>
+            <a:off x="704088" y="1280160"/>
+            <a:ext cx="7744968" cy="2880360"/>
+          </a:xfrm>
+          <a:prstGeom prst="rect">
+            <a:avLst/>
+          </a:prstGeom>
+          <a:solidFill>
+            <a:srgbClr val="F0F2F5"/>
+          </a:solidFill>
+          <a:ln>
+            <a:solidFill>
+              <a:srgbClr val="D8DDE3"/>
+            </a:solidFill>
+          </a:ln>
+          <a:effectLst/>
+        </p:spPr>
+        <p:style>
+          <a:lnRef idx="1">
+            <a:schemeClr val="accent1"/>
+          </a:lnRef>
+          <a:fillRef idx="3">
+            <a:schemeClr val="accent1"/>
+          </a:fillRef>
+          <a:effectRef idx="2">
+            <a:schemeClr val="accent1"/>
+          </a:effectRef>
+          <a:fontRef idx="minor">
+            <a:schemeClr val="lt1"/>
+          </a:fontRef>
+        </p:style>
+        <p:txBody>
+          <a:bodyPr rtlCol="0" anchor="ctr" wrap="square" lIns="228600" tIns="137160"/>
+          <a:lstStyle/>
+          <a:p>
+            <a:pPr/>
+            <a:r>
+              <a:rPr sz="1500" b="0">
+                <a:solidFill>
+                  <a:srgbClr val="1D3557"/>
+                </a:solidFill>
+                <a:latin typeface="Menlo"/>
+              </a:rPr>
+              <a:t>sexo = pd.read_csv('tablas_parametros/Sexo.csv', sep=';')</a:t>
+            </a:r>
+          </a:p>
+          <a:p>
+            <a:pPr/>
+            <a:r>
+              <a:rPr sz="1500" b="0">
+                <a:solidFill>
+                  <a:srgbClr val="1D3557"/>
+                </a:solidFill>
+                <a:latin typeface="Menlo"/>
+              </a:rPr>
+              <a:t>personas = personas.merge(sexo, left_on='Sexo',</a:t>
+            </a:r>
+          </a:p>
+          <a:p>
+            <a:pPr/>
+            <a:r>
+              <a:rPr sz="1500" b="0">
+                <a:solidFill>
+                  <a:srgbClr val="1D3557"/>
+                </a:solidFill>
+                <a:latin typeface="Menlo"/>
+              </a:rPr>
+              <a:t>                          right_on='Id', how='left')</a:t>
+            </a:r>
+          </a:p>
+          <a:p>
+            <a:pPr/>
+            <a:r>
+              <a:rPr sz="1500" b="0">
+                <a:solidFill>
+                  <a:srgbClr val="1D3557"/>
+                </a:solidFill>
+                <a:latin typeface="Menlo"/>
+              </a:rPr>
+              <a:t/>
+            </a:r>
+          </a:p>
+          <a:p>
+            <a:pPr/>
+            <a:r>
+              <a:rPr sz="1500" b="0">
+                <a:solidFill>
+                  <a:srgbClr val="1D3557"/>
+                </a:solidFill>
+                <a:latin typeface="Menlo"/>
+              </a:rPr>
+              <a:t>personas['Sexo'].isna().sum()   # regla de oro: contar los sin pareja</a:t>
+            </a:r>
+          </a:p>
+        </p:txBody>
+      </p:sp>
+      <p:sp>
+        <p:nvSpPr>
+          <p:cNvPr id="5" name="TextBox 4"/>
           <p:cNvSpPr txBox="1"/>
           <p:nvPr/>
         </p:nvSpPr>
         <p:spPr>
           <a:xfrm>
-            <a:off x="704088" y="1353312"/>
-            <a:ext cx="7744968" cy="3300984"/>
+            <a:off x="704088" y="4389120"/>
+            <a:ext cx="7744968" cy="1097280"/>
           </a:xfrm>
           <a:prstGeom prst="rect">
             <a:avLst/>
@@ -3660,7 +3736,7 @@
           <a:lstStyle/>
           <a:p>
             <a:r>
-              <a:rPr sz="1800" b="1">
+              <a:rPr sz="1600" b="1">
                 <a:solidFill>
                   <a:srgbClr val="E0A437"/>
                 </a:solidFill>
@@ -3669,93 +3745,13 @@
               <a:t>▸ </a:t>
             </a:r>
             <a:r>
-              <a:rPr sz="1800" b="0">
+              <a:rPr sz="1600" b="0">
                 <a:solidFill>
                   <a:srgbClr val="3A4A5C"/>
                 </a:solidFill>
                 <a:latin typeface="PT Serif"/>
               </a:rPr>
-              <a:t>Pandas los representa como NaN, y en datos reales siempre hay.</a:t>
-            </a:r>
-          </a:p>
-          <a:p>
-            <a:r>
-              <a:rPr sz="1800" b="1">
-                <a:solidFill>
-                  <a:srgbClr val="E0A437"/>
-                </a:solidFill>
-                <a:latin typeface="PT Serif"/>
-              </a:rPr>
-              <a:t>▸ </a:t>
-            </a:r>
-            <a:r>
-              <a:rPr sz="1800" b="0">
-                <a:solidFill>
-                  <a:srgbClr val="3A4A5C"/>
-                </a:solidFill>
-                <a:latin typeface="PT Serif"/>
-              </a:rPr>
-              <a:t>En este archivo faltan 58 valores de toneladas y 12 pares de coordenadas.</a:t>
-            </a:r>
-          </a:p>
-          <a:p>
-            <a:r>
-              <a:rPr sz="1400" b="0">
-                <a:solidFill>
-                  <a:srgbClr val="6B7785"/>
-                </a:solidFill>
-                <a:latin typeface="PT Serif"/>
-              </a:rPr>
-              <a:t>     ◦  </a:t>
-            </a:r>
-            <a:r>
-              <a:rPr sz="1400" b="0">
-                <a:solidFill>
-                  <a:srgbClr val="6B7785"/>
-                </a:solidFill>
-                <a:latin typeface="PT Serif"/>
-              </a:rPr>
-              <a:t>isna().sum() cuenta cuántos faltan en cada columna.</a:t>
-            </a:r>
-          </a:p>
-          <a:p>
-            <a:r>
-              <a:rPr sz="1400" b="0">
-                <a:solidFill>
-                  <a:srgbClr val="6B7785"/>
-                </a:solidFill>
-                <a:latin typeface="PT Serif"/>
-              </a:rPr>
-              <a:t>     ◦  </a:t>
-            </a:r>
-            <a:r>
-              <a:rPr sz="1400" b="0">
-                <a:solidFill>
-                  <a:srgbClr val="6B7785"/>
-                </a:solidFill>
-                <a:latin typeface="PT Serif"/>
-              </a:rPr>
-              <a:t>dropna() elimina filas; fillna() las rellena.</a:t>
-            </a:r>
-          </a:p>
-          <a:p>
-            <a:r>
-              <a:rPr sz="1800" b="1">
-                <a:solidFill>
-                  <a:srgbClr val="E0A437"/>
-                </a:solidFill>
-                <a:latin typeface="PT Serif"/>
-              </a:rPr>
-              <a:t>▸ </a:t>
-            </a:r>
-            <a:r>
-              <a:rPr sz="1800" b="1">
-                <a:solidFill>
-                  <a:srgbClr val="1D3557"/>
-                </a:solidFill>
-                <a:latin typeface="PT Serif"/>
-              </a:rPr>
-              <a:t>Qué hacer con ellos no es automático: depende de la pregunta.</a:t>
+              <a:t>Los significados viven en otra tabla: así se diseñan las bases de datos reales.</a:t>
             </a:r>
           </a:p>
         </p:txBody>
@@ -3851,7 +3847,7 @@
                 </a:solidFill>
                 <a:latin typeface="PT Serif"/>
               </a:rPr>
-              <a:t>groupby: separar, resumir y juntar</a:t>
+              <a:t>¿Cuántos viajes hace una persona? groupby y una trampa</a:t>
             </a:r>
           </a:p>
         </p:txBody>
@@ -3865,7 +3861,7 @@
         <p:spPr>
           <a:xfrm>
             <a:off x="704088" y="1280160"/>
-            <a:ext cx="7744968" cy="2880360"/>
+            <a:ext cx="7744968" cy="2377440"/>
           </a:xfrm>
           <a:prstGeom prst="rect">
             <a:avLst/>
@@ -3906,7 +3902,7 @@
                 </a:solidFill>
                 <a:latin typeface="Menlo"/>
               </a:rPr>
-              <a:t>mp25.groupby('region')['cantidad_toneladas'].sum()</a:t>
+              <a:t>viajes_por_persona = viajes.groupby(['Hogar', 'Persona']).size()</a:t>
             </a:r>
           </a:p>
           <a:p>
@@ -3930,7 +3926,7 @@
                 </a:solidFill>
                 <a:latin typeface="Menlo"/>
               </a:rPr>
-              <a:t>mp25.groupby('region')['cantidad_toneladas'].agg(</a:t>
+              <a:t>conteo = personas.set_index(['Hogar', 'Persona']).assign(</a:t>
             </a:r>
           </a:p>
           <a:p>
@@ -3942,19 +3938,7 @@
                 </a:solidFill>
                 <a:latin typeface="Menlo"/>
               </a:rPr>
-              <a:t>    total='sum', promedio='mean', mediana='median',</a:t>
-            </a:r>
-          </a:p>
-          <a:p>
-            <a:pPr/>
-            <a:r>
-              <a:rPr sz="1500" b="0">
-                <a:solidFill>
-                  <a:srgbClr val="1D3557"/>
-                </a:solidFill>
-                <a:latin typeface="Menlo"/>
-              </a:rPr>
-              <a:t>)</a:t>
+              <a:t>    n_viajes=viajes_por_persona)['n_viajes'].fillna(0)</a:t>
             </a:r>
           </a:p>
         </p:txBody>
@@ -3967,7 +3951,7 @@
         </p:nvSpPr>
         <p:spPr>
           <a:xfrm>
-            <a:off x="704088" y="4389120"/>
+            <a:off x="704088" y="3886200"/>
             <a:ext cx="7744968" cy="1097280"/>
           </a:xfrm>
           <a:prstGeom prst="rect">
@@ -3997,7 +3981,7 @@
                 </a:solidFill>
                 <a:latin typeface="PT Serif"/>
               </a:rPr>
-              <a:t>Responde la mayoría de las preguntas descriptivas de un conjunto de datos.</a:t>
+              <a:t>Quien no viajó no aparece en la tabla de viajes: si solo agrupamos, lo perdemos.</a:t>
             </a:r>
           </a:p>
         </p:txBody>
@@ -4093,14 +4077,117 @@
                 </a:solidFill>
                 <a:latin typeface="PT Serif"/>
               </a:rPr>
-              <a:t>Emisiones de MP2,5 por región</a:t>
+              <a:t>Quien no viaja también es dato</a:t>
+            </a:r>
+          </a:p>
+        </p:txBody>
+      </p:sp>
+      <p:sp>
+        <p:nvSpPr>
+          <p:cNvPr id="4" name="TextBox 3"/>
+          <p:cNvSpPr txBox="1"/>
+          <p:nvPr/>
+        </p:nvSpPr>
+        <p:spPr>
+          <a:xfrm>
+            <a:off x="502920" y="1252728"/>
+            <a:ext cx="4023360" cy="3200400"/>
+          </a:xfrm>
+          <a:prstGeom prst="rect">
+            <a:avLst/>
+          </a:prstGeom>
+          <a:noFill/>
+        </p:spPr>
+        <p:txBody>
+          <a:bodyPr wrap="square">
+            <a:spAutoFit/>
+          </a:bodyPr>
+          <a:lstStyle/>
+          <a:p>
+            <a:r>
+              <a:rPr sz="1500" b="1">
+                <a:solidFill>
+                  <a:srgbClr val="E0A437"/>
+                </a:solidFill>
+                <a:latin typeface="PT Serif"/>
+              </a:rPr>
+              <a:t>▸ </a:t>
+            </a:r>
+            <a:r>
+              <a:rPr sz="1500" b="0">
+                <a:solidFill>
+                  <a:srgbClr val="3A4A5C"/>
+                </a:solidFill>
+                <a:latin typeface="PT Serif"/>
+              </a:rPr>
+              <a:t>El 23% de las personas no viajó ese día.</a:t>
+            </a:r>
+          </a:p>
+          <a:p>
+            <a:r>
+              <a:rPr sz="1500" b="1">
+                <a:solidFill>
+                  <a:srgbClr val="E0A437"/>
+                </a:solidFill>
+                <a:latin typeface="PT Serif"/>
+              </a:rPr>
+              <a:t>▸ </a:t>
+            </a:r>
+            <a:r>
+              <a:rPr sz="1500" b="0">
+                <a:solidFill>
+                  <a:srgbClr val="3A4A5C"/>
+                </a:solidFill>
+                <a:latin typeface="PT Serif"/>
+              </a:rPr>
+              <a:t>Media: 1,9 viajes. Mediana: 2 viajes.</a:t>
+            </a:r>
+          </a:p>
+          <a:p>
+            <a:r>
+              <a:rPr sz="1500" b="1">
+                <a:solidFill>
+                  <a:srgbClr val="E0A437"/>
+                </a:solidFill>
+                <a:latin typeface="PT Serif"/>
+              </a:rPr>
+              <a:t>▸ </a:t>
+            </a:r>
+            <a:r>
+              <a:rPr sz="1500" b="0">
+                <a:solidFill>
+                  <a:srgbClr val="3A4A5C"/>
+                </a:solidFill>
+                <a:latin typeface="PT Serif"/>
+              </a:rPr>
+              <a:t>Aquí la media quedó BAJO la mediana: el bloque de ceros la arrastra.</a:t>
+            </a:r>
+          </a:p>
+          <a:p>
+            <a:r>
+              <a:rPr sz="1500" b="1">
+                <a:solidFill>
+                  <a:srgbClr val="E0A437"/>
+                </a:solidFill>
+                <a:latin typeface="PT Serif"/>
+              </a:rPr>
+              <a:t>▸ </a:t>
+            </a:r>
+            <a:r>
+              <a:rPr sz="1500" b="1">
+                <a:solidFill>
+                  <a:srgbClr val="1D3557"/>
+                </a:solidFill>
+                <a:latin typeface="PT Serif"/>
+              </a:rPr>
+              <a:t>La asimetría no siempre empuja hacia el mismo lado: se mira, no se adivina.</a:t>
             </a:r>
           </a:p>
         </p:txBody>
       </p:sp>
       <p:pic>
         <p:nvPicPr>
-          <p:cNvPr id="4" name="Picture 3" descr="04_regiones.png"/>
+          <p:cNvPr id="5" name="Picture 4" descr="02_viajes_por_persona.png"/>
           <p:cNvPicPr>
             <a:picLocks noChangeAspect="1"/>
           </p:cNvPicPr>
@@ -4114,48 +4201,14 @@
         </p:blipFill>
         <p:spPr>
           <a:xfrm>
-            <a:off x="1417320" y="1188720"/>
-            <a:ext cx="6309360" cy="2771071"/>
+            <a:off x="4892040" y="1371600"/>
+            <a:ext cx="3840480" cy="2196274"/>
           </a:xfrm>
           <a:prstGeom prst="rect">
             <a:avLst/>
           </a:prstGeom>
         </p:spPr>
       </p:pic>
-      <p:sp>
-        <p:nvSpPr>
-          <p:cNvPr id="5" name="TextBox 4"/>
-          <p:cNvSpPr txBox="1"/>
-          <p:nvPr/>
-        </p:nvSpPr>
-        <p:spPr>
-          <a:xfrm>
-            <a:off x="704088" y="4434840"/>
-            <a:ext cx="7744968" cy="457200"/>
-          </a:xfrm>
-          <a:prstGeom prst="rect">
-            <a:avLst/>
-          </a:prstGeom>
-          <a:noFill/>
-        </p:spPr>
-        <p:txBody>
-          <a:bodyPr wrap="square">
-            <a:spAutoFit/>
-          </a:bodyPr>
-          <a:lstStyle/>
-          <a:p>
-            <a:r>
-              <a:rPr sz="1300" b="0">
-                <a:solidFill>
-                  <a:srgbClr val="6B7785"/>
-                </a:solidFill>
-                <a:latin typeface="PT Serif"/>
-              </a:rPr>
-              <a:t>Antofagasta y O'Higgins están arriba con mucha menos población: pesa el perfil productivo.</a:t>
-            </a:r>
-          </a:p>
-        </p:txBody>
-      </p:sp>
     </p:spTree>
   </p:cSld>
   <p:clrMapOvr>
@@ -4189,7 +4242,7 @@
             <a:avLst/>
           </a:prstGeom>
           <a:solidFill>
-            <a:srgbClr val="FAFBFC"/>
+            <a:srgbClr val="1D3557"/>
           </a:solidFill>
           <a:ln>
             <a:noFill/>
@@ -4226,8 +4279,8 @@
         </p:nvSpPr>
         <p:spPr>
           <a:xfrm>
-            <a:off x="402336" y="301752"/>
-            <a:ext cx="8348472" cy="795528"/>
+            <a:off x="603504" y="1847088"/>
+            <a:ext cx="7946136" cy="1399032"/>
           </a:xfrm>
           <a:prstGeom prst="rect">
             <a:avLst/>
@@ -4241,135 +4294,24 @@
           <a:lstStyle/>
           <a:p>
             <a:r>
-              <a:rPr sz="2800" b="1">
-                <a:solidFill>
-                  <a:srgbClr val="0F0F0F"/>
-                </a:solidFill>
-                <a:latin typeface="PT Serif"/>
-              </a:rPr>
-              <a:t>merge: combinar dos tablas</a:t>
-            </a:r>
-          </a:p>
-        </p:txBody>
-      </p:sp>
-      <p:sp>
-        <p:nvSpPr>
-          <p:cNvPr id="4" name="Rectangle 3"/>
-          <p:cNvSpPr/>
-          <p:nvPr/>
-        </p:nvSpPr>
-        <p:spPr>
-          <a:xfrm>
-            <a:off x="704088" y="1280160"/>
-            <a:ext cx="7744968" cy="1874520"/>
-          </a:xfrm>
-          <a:prstGeom prst="rect">
-            <a:avLst/>
-          </a:prstGeom>
-          <a:solidFill>
-            <a:srgbClr val="F0F2F5"/>
-          </a:solidFill>
-          <a:ln>
-            <a:solidFill>
-              <a:srgbClr val="D8DDE3"/>
-            </a:solidFill>
-          </a:ln>
-          <a:effectLst/>
-        </p:spPr>
-        <p:style>
-          <a:lnRef idx="1">
-            <a:schemeClr val="accent1"/>
-          </a:lnRef>
-          <a:fillRef idx="3">
-            <a:schemeClr val="accent1"/>
-          </a:fillRef>
-          <a:effectRef idx="2">
-            <a:schemeClr val="accent1"/>
-          </a:effectRef>
-          <a:fontRef idx="minor">
-            <a:schemeClr val="lt1"/>
-          </a:fontRef>
-        </p:style>
-        <p:txBody>
-          <a:bodyPr rtlCol="0" anchor="ctr" wrap="square" lIns="228600" tIns="137160"/>
-          <a:lstStyle/>
-          <a:p>
-            <a:pPr/>
-            <a:r>
-              <a:rPr sz="1500" b="0">
-                <a:solidFill>
-                  <a:srgbClr val="1D3557"/>
-                </a:solidFill>
-                <a:latin typeface="Menlo"/>
-              </a:rPr>
-              <a:t>mp25_zonas = mp25.merge(macrozonas, on='region', how='left')</a:t>
-            </a:r>
-          </a:p>
-          <a:p>
-            <a:pPr/>
-            <a:r>
-              <a:rPr sz="1500" b="0">
-                <a:solidFill>
-                  <a:srgbClr val="1D3557"/>
-                </a:solidFill>
-                <a:latin typeface="Menlo"/>
-              </a:rPr>
-              <a:t/>
-            </a:r>
-          </a:p>
-          <a:p>
-            <a:pPr/>
-            <a:r>
-              <a:rPr sz="1500" b="0">
-                <a:solidFill>
-                  <a:srgbClr val="1D3557"/>
-                </a:solidFill>
-                <a:latin typeface="Menlo"/>
-              </a:rPr>
-              <a:t>mp25_zonas['macrozona'].isna().sum()   # revisar siempre</a:t>
-            </a:r>
-          </a:p>
-        </p:txBody>
-      </p:sp>
-      <p:sp>
-        <p:nvSpPr>
-          <p:cNvPr id="5" name="TextBox 4"/>
-          <p:cNvSpPr txBox="1"/>
-          <p:nvPr/>
-        </p:nvSpPr>
-        <p:spPr>
-          <a:xfrm>
-            <a:off x="704088" y="3383279"/>
-            <a:ext cx="7744968" cy="1097280"/>
-          </a:xfrm>
-          <a:prstGeom prst="rect">
-            <a:avLst/>
-          </a:prstGeom>
-          <a:noFill/>
-        </p:spPr>
-        <p:txBody>
-          <a:bodyPr wrap="square">
-            <a:spAutoFit/>
-          </a:bodyPr>
-          <a:lstStyle/>
-          <a:p>
-            <a:r>
-              <a:rPr sz="1600" b="1">
+              <a:rPr sz="3400" b="1">
+                <a:solidFill>
+                  <a:srgbClr val="FFFFFF"/>
+                </a:solidFill>
+                <a:latin typeface="PT Serif"/>
+              </a:rPr>
+              <a:t>¿A quién representa la encuesta?</a:t>
+            </a:r>
+          </a:p>
+          <a:p>
+            <a:r>
+              <a:rPr sz="1800" b="0">
                 <a:solidFill>
                   <a:srgbClr val="E0A437"/>
                 </a:solidFill>
                 <a:latin typeface="PT Serif"/>
               </a:rPr>
-              <a:t>▸ </a:t>
-            </a:r>
-            <a:r>
-              <a:rPr sz="1600" b="0">
-                <a:solidFill>
-                  <a:srgbClr val="3A4A5C"/>
-                </a:solidFill>
-                <a:latin typeface="PT Serif"/>
-              </a:rPr>
-              <a:t>Un nombre escrito distinto en las dos tablas produce NaN sin avisar.</a:t>
+              <a:t>Los factores de expansión</a:t>
             </a:r>
           </a:p>
         </p:txBody>
@@ -4407,7 +4349,7 @@
             <a:avLst/>
           </a:prstGeom>
           <a:solidFill>
-            <a:srgbClr val="1D3557"/>
+            <a:srgbClr val="FAFBFC"/>
           </a:solidFill>
           <a:ln>
             <a:noFill/>
@@ -4444,8 +4386,8 @@
         </p:nvSpPr>
         <p:spPr>
           <a:xfrm>
-            <a:off x="603504" y="1847088"/>
-            <a:ext cx="7946136" cy="1399032"/>
+            <a:off x="402336" y="301752"/>
+            <a:ext cx="8348472" cy="795528"/>
           </a:xfrm>
           <a:prstGeom prst="rect">
             <a:avLst/>
@@ -4459,24 +4401,156 @@
           <a:lstStyle/>
           <a:p>
             <a:r>
-              <a:rPr sz="3400" b="1">
-                <a:solidFill>
-                  <a:srgbClr val="FFFFFF"/>
-                </a:solidFill>
-                <a:latin typeface="PT Serif"/>
-              </a:rPr>
-              <a:t>Análisis exploratorio</a:t>
-            </a:r>
-          </a:p>
-          <a:p>
+              <a:rPr sz="2800" b="1">
+                <a:solidFill>
+                  <a:srgbClr val="0F0F0F"/>
+                </a:solidFill>
+                <a:latin typeface="PT Serif"/>
+              </a:rPr>
+              <a:t>De 37 mil encuestados a 6,7 millones de personas</a:t>
+            </a:r>
+          </a:p>
+        </p:txBody>
+      </p:sp>
+      <p:sp>
+        <p:nvSpPr>
+          <p:cNvPr id="4" name="TextBox 3"/>
+          <p:cNvSpPr txBox="1"/>
+          <p:nvPr/>
+        </p:nvSpPr>
+        <p:spPr>
+          <a:xfrm>
+            <a:off x="704088" y="1353312"/>
+            <a:ext cx="7744968" cy="3300984"/>
+          </a:xfrm>
+          <a:prstGeom prst="rect">
+            <a:avLst/>
+          </a:prstGeom>
+          <a:noFill/>
+        </p:spPr>
+        <p:txBody>
+          <a:bodyPr wrap="square">
+            <a:spAutoFit/>
+          </a:bodyPr>
+          <a:lstStyle/>
+          <a:p>
+            <a:r>
+              <a:rPr sz="1800" b="1">
+                <a:solidFill>
+                  <a:srgbClr val="E0A437"/>
+                </a:solidFill>
+                <a:latin typeface="PT Serif"/>
+              </a:rPr>
+              <a:t>▸ </a:t>
+            </a:r>
             <a:r>
               <a:rPr sz="1800" b="0">
                 <a:solidFill>
+                  <a:srgbClr val="3A4A5C"/>
+                </a:solidFill>
+                <a:latin typeface="PT Serif"/>
+              </a:rPr>
+              <a:t>Cada encuestado representa a un número de personas parecidas a él.</a:t>
+            </a:r>
+          </a:p>
+          <a:p>
+            <a:r>
+              <a:rPr sz="1800" b="1">
+                <a:solidFill>
                   <a:srgbClr val="E0A437"/>
                 </a:solidFill>
                 <a:latin typeface="PT Serif"/>
               </a:rPr>
-              <a:t>Mirar los datos antes de modelarlos</a:t>
+              <a:t>▸ </a:t>
+            </a:r>
+            <a:r>
+              <a:rPr sz="1800" b="0">
+                <a:solidFill>
+                  <a:srgbClr val="3A4A5C"/>
+                </a:solidFill>
+                <a:latin typeface="PT Serif"/>
+              </a:rPr>
+              <a:t>Ese número es su factor de expansión (Factor_LaboralNormal).</a:t>
+            </a:r>
+          </a:p>
+          <a:p>
+            <a:r>
+              <a:rPr sz="1400" b="0">
+                <a:solidFill>
+                  <a:srgbClr val="6B7785"/>
+                </a:solidFill>
+                <a:latin typeface="PT Serif"/>
+              </a:rPr>
+              <a:t>     ◦  </a:t>
+            </a:r>
+            <a:r>
+              <a:rPr sz="1400" b="0">
+                <a:solidFill>
+                  <a:srgbClr val="6B7785"/>
+                </a:solidFill>
+                <a:latin typeface="PT Serif"/>
+              </a:rPr>
+              <a:t>37.326 personas con factor de día laboral en temporada normal.</a:t>
+            </a:r>
+          </a:p>
+          <a:p>
+            <a:r>
+              <a:rPr sz="1400" b="0">
+                <a:solidFill>
+                  <a:srgbClr val="6B7785"/>
+                </a:solidFill>
+                <a:latin typeface="PT Serif"/>
+              </a:rPr>
+              <a:t>     ◦  </a:t>
+            </a:r>
+            <a:r>
+              <a:rPr sz="1400" b="0">
+                <a:solidFill>
+                  <a:srgbClr val="6B7785"/>
+                </a:solidFill>
+                <a:latin typeface="PT Serif"/>
+              </a:rPr>
+              <a:t>La suma de sus factores: 6.651.735 personas representadas.</a:t>
+            </a:r>
+          </a:p>
+          <a:p>
+            <a:r>
+              <a:rPr sz="1800" b="1">
+                <a:solidFill>
+                  <a:srgbClr val="E0A437"/>
+                </a:solidFill>
+                <a:latin typeface="PT Serif"/>
+              </a:rPr>
+              <a:t>▸ </a:t>
+            </a:r>
+            <a:r>
+              <a:rPr sz="1800" b="0">
+                <a:solidFill>
+                  <a:srgbClr val="3A4A5C"/>
+                </a:solidFill>
+                <a:latin typeface="PT Serif"/>
+              </a:rPr>
+              <a:t>Contar filas responde por la muestra; sumar factores responde por la ciudad.</a:t>
+            </a:r>
+          </a:p>
+          <a:p>
+            <a:r>
+              <a:rPr sz="1800" b="1">
+                <a:solidFill>
+                  <a:srgbClr val="E0A437"/>
+                </a:solidFill>
+                <a:latin typeface="PT Serif"/>
+              </a:rPr>
+              <a:t>▸ </a:t>
+            </a:r>
+            <a:r>
+              <a:rPr sz="1800" b="1">
+                <a:solidFill>
+                  <a:srgbClr val="1D3557"/>
+                </a:solidFill>
+                <a:latin typeface="PT Serif"/>
+              </a:rPr>
+              <a:t>Toda cifra oficial de la EOD, la Casen o la ENUSC está ponderada así.</a:t>
             </a:r>
           </a:p>
         </p:txBody>
@@ -4514,7 +4588,7 @@
             <a:avLst/>
           </a:prstGeom>
           <a:solidFill>
-            <a:srgbClr val="FAFBFC"/>
+            <a:srgbClr val="1D3557"/>
           </a:solidFill>
           <a:ln>
             <a:noFill/>
@@ -4551,8 +4625,8 @@
         </p:nvSpPr>
         <p:spPr>
           <a:xfrm>
-            <a:off x="402336" y="301752"/>
-            <a:ext cx="8348472" cy="795528"/>
+            <a:off x="603504" y="1847088"/>
+            <a:ext cx="7946136" cy="1399032"/>
           </a:xfrm>
           <a:prstGeom prst="rect">
             <a:avLst/>
@@ -4566,136 +4640,24 @@
           <a:lstStyle/>
           <a:p>
             <a:r>
-              <a:rPr sz="2800" b="1">
-                <a:solidFill>
-                  <a:srgbClr val="0F0F0F"/>
-                </a:solidFill>
-                <a:latin typeface="PT Serif"/>
-              </a:rPr>
-              <a:t>Qué es el análisis exploratorio</a:t>
-            </a:r>
-          </a:p>
-        </p:txBody>
-      </p:sp>
-      <p:sp>
-        <p:nvSpPr>
-          <p:cNvPr id="4" name="TextBox 3"/>
-          <p:cNvSpPr txBox="1"/>
-          <p:nvPr/>
-        </p:nvSpPr>
-        <p:spPr>
-          <a:xfrm>
-            <a:off x="704088" y="1353312"/>
-            <a:ext cx="7744968" cy="3300984"/>
-          </a:xfrm>
-          <a:prstGeom prst="rect">
-            <a:avLst/>
-          </a:prstGeom>
-          <a:noFill/>
-        </p:spPr>
-        <p:txBody>
-          <a:bodyPr wrap="square">
-            <a:spAutoFit/>
-          </a:bodyPr>
-          <a:lstStyle/>
-          <a:p>
-            <a:r>
-              <a:rPr sz="1800" b="1">
+              <a:rPr sz="3400" b="1">
+                <a:solidFill>
+                  <a:srgbClr val="FFFFFF"/>
+                </a:solidFill>
+                <a:latin typeface="PT Serif"/>
+              </a:rPr>
+              <a:t>Análisis exploratorio</a:t>
+            </a:r>
+          </a:p>
+          <a:p>
+            <a:r>
+              <a:rPr sz="1800" b="0">
                 <a:solidFill>
                   <a:srgbClr val="E0A437"/>
                 </a:solidFill>
                 <a:latin typeface="PT Serif"/>
               </a:rPr>
-              <a:t>▸ </a:t>
-            </a:r>
-            <a:r>
-              <a:rPr sz="1800" b="0">
-                <a:solidFill>
-                  <a:srgbClr val="3A4A5C"/>
-                </a:solidFill>
-                <a:latin typeface="PT Serif"/>
-              </a:rPr>
-              <a:t>El término lo acuña John Tukey en 1977, en el libro Exploratory Data Analysis.</a:t>
-            </a:r>
-          </a:p>
-          <a:p>
-            <a:r>
-              <a:rPr sz="1800" b="1">
-                <a:solidFill>
-                  <a:srgbClr val="E0A437"/>
-                </a:solidFill>
-                <a:latin typeface="PT Serif"/>
-              </a:rPr>
-              <a:t>▸ </a:t>
-            </a:r>
-            <a:r>
-              <a:rPr sz="1800" b="0">
-                <a:solidFill>
-                  <a:srgbClr val="3A4A5C"/>
-                </a:solidFill>
-                <a:latin typeface="PT Serif"/>
-              </a:rPr>
-              <a:t>La idea: mirar los datos antes de suponer un modelo.</a:t>
-            </a:r>
-          </a:p>
-          <a:p>
-            <a:r>
-              <a:rPr sz="1400" b="0">
-                <a:solidFill>
-                  <a:srgbClr val="6B7785"/>
-                </a:solidFill>
-                <a:latin typeface="PT Serif"/>
-              </a:rPr>
-              <a:t>     ◦  </a:t>
-            </a:r>
-            <a:r>
-              <a:rPr sz="1400" b="0">
-                <a:solidFill>
-                  <a:srgbClr val="6B7785"/>
-                </a:solidFill>
-                <a:latin typeface="PT Serif"/>
-              </a:rPr>
-              <a:t>Describir la forma de la distribución, no solo su centro.</a:t>
-            </a:r>
-          </a:p>
-          <a:p>
-            <a:r>
-              <a:rPr sz="1400" b="0">
-                <a:solidFill>
-                  <a:srgbClr val="6B7785"/>
-                </a:solidFill>
-                <a:latin typeface="PT Serif"/>
-              </a:rPr>
-              <a:t>     ◦  </a:t>
-            </a:r>
-            <a:r>
-              <a:rPr sz="1400" b="0">
-                <a:solidFill>
-                  <a:srgbClr val="6B7785"/>
-                </a:solidFill>
-                <a:latin typeface="PT Serif"/>
-              </a:rPr>
-              <a:t>Detectar errores, valores extremos y patrones inesperados.</a:t>
-            </a:r>
-          </a:p>
-          <a:p>
-            <a:r>
-              <a:rPr sz="1800" b="1">
-                <a:solidFill>
-                  <a:srgbClr val="E0A437"/>
-                </a:solidFill>
-                <a:latin typeface="PT Serif"/>
-              </a:rPr>
-              <a:t>▸ </a:t>
-            </a:r>
-            <a:r>
-              <a:rPr sz="1800" b="1">
-                <a:solidFill>
-                  <a:srgbClr val="1D3557"/>
-                </a:solidFill>
-                <a:latin typeface="PT Serif"/>
-              </a:rPr>
-              <a:t>Es la etapa donde uno se entera de con qué está trabajando.</a:t>
+              <a:t>¿Qué número resume bien una respuesta?</a:t>
             </a:r>
           </a:p>
         </p:txBody>
@@ -4791,7 +4753,7 @@
                 </a:solidFill>
                 <a:latin typeface="PT Serif"/>
               </a:rPr>
-              <a:t>El promedio puede engañar</a:t>
+              <a:t>¿Cuánto gana un hogar típico?</a:t>
             </a:r>
           </a:p>
         </p:txBody>
@@ -4834,67 +4796,7 @@
                 </a:solidFill>
                 <a:latin typeface="PT Serif"/>
               </a:rPr>
-              <a:t>En las emisiones de MP2,5:</a:t>
-            </a:r>
-          </a:p>
-          <a:p>
-            <a:r>
-              <a:rPr sz="1300" b="0">
-                <a:solidFill>
-                  <a:srgbClr val="6B7785"/>
-                </a:solidFill>
-                <a:latin typeface="PT Serif"/>
-              </a:rPr>
-              <a:t>     ◦  </a:t>
-            </a:r>
-            <a:r>
-              <a:rPr sz="1300" b="0">
-                <a:solidFill>
-                  <a:srgbClr val="6B7785"/>
-                </a:solidFill>
-                <a:latin typeface="PT Serif"/>
-              </a:rPr>
-              <a:t>Media: 0,382 toneladas.</a:t>
-            </a:r>
-          </a:p>
-          <a:p>
-            <a:r>
-              <a:rPr sz="1300" b="0">
-                <a:solidFill>
-                  <a:srgbClr val="6B7785"/>
-                </a:solidFill>
-                <a:latin typeface="PT Serif"/>
-              </a:rPr>
-              <a:t>     ◦  </a:t>
-            </a:r>
-            <a:r>
-              <a:rPr sz="1300" b="0">
-                <a:solidFill>
-                  <a:srgbClr val="6B7785"/>
-                </a:solidFill>
-                <a:latin typeface="PT Serif"/>
-              </a:rPr>
-              <a:t>Mediana: 0,006 toneladas.</a:t>
-            </a:r>
-          </a:p>
-          <a:p>
-            <a:r>
-              <a:rPr sz="1300" b="0">
-                <a:solidFill>
-                  <a:srgbClr val="6B7785"/>
-                </a:solidFill>
-                <a:latin typeface="PT Serif"/>
-              </a:rPr>
-              <a:t>     ◦  </a:t>
-            </a:r>
-            <a:r>
-              <a:rPr sz="1300" b="0">
-                <a:solidFill>
-                  <a:srgbClr val="6B7785"/>
-                </a:solidFill>
-                <a:latin typeface="PT Serif"/>
-              </a:rPr>
-              <a:t>Máximo: 299 toneladas.</a:t>
+              <a:t>Media: $688.274. Mediana: $507.826.</a:t>
             </a:r>
           </a:p>
           <a:p>
@@ -4914,7 +4816,7 @@
                 </a:solidFill>
                 <a:latin typeface="PT Serif"/>
               </a:rPr>
-              <a:t>La media es unas 66 veces la mediana.</a:t>
+              <a:t>La media es un 36% más alta que la mediana.</a:t>
             </a:r>
           </a:p>
           <a:p>
@@ -4928,20 +4830,40 @@
               <a:t>▸ </a:t>
             </a:r>
             <a:r>
+              <a:rPr sz="1500" b="0">
+                <a:solidFill>
+                  <a:srgbClr val="3A4A5C"/>
+                </a:solidFill>
+                <a:latin typeface="PT Serif"/>
+              </a:rPr>
+              <a:t>Unos pocos hogares de ingresos muy altos arrastran el promedio.</a:t>
+            </a:r>
+          </a:p>
+          <a:p>
+            <a:r>
               <a:rPr sz="1500" b="1">
                 <a:solidFill>
+                  <a:srgbClr val="E0A437"/>
+                </a:solidFill>
+                <a:latin typeface="PT Serif"/>
+              </a:rPr>
+              <a:t>▸ </a:t>
+            </a:r>
+            <a:r>
+              <a:rPr sz="1500" b="1">
+                <a:solidFill>
                   <a:srgbClr val="1D3557"/>
                 </a:solidFill>
                 <a:latin typeface="PT Serif"/>
               </a:rPr>
-              <a:t>Decir 'el establecimiento promedio emite 0,38 t' describe a casi ninguno.</a:t>
+              <a:t>'El hogar promedio gana $688 mil' describe una situación en la que la mayoría no está.</a:t>
             </a:r>
           </a:p>
         </p:txBody>
       </p:sp>
       <p:pic>
         <p:nvPicPr>
-          <p:cNvPr id="5" name="Picture 4" descr="03_media_vs_mediana.png"/>
+          <p:cNvPr id="5" name="Picture 4" descr="01_ingreso_media_mediana.png"/>
           <p:cNvPicPr>
             <a:picLocks noChangeAspect="1"/>
           </p:cNvPicPr>
@@ -4956,7 +4878,7 @@
         <p:spPr>
           <a:xfrm>
             <a:off x="4892040" y="1371600"/>
-            <a:ext cx="3840480" cy="2209974"/>
+            <a:ext cx="3840480" cy="2189433"/>
           </a:xfrm>
           <a:prstGeom prst="rect">
             <a:avLst/>
@@ -5054,7 +4976,7 @@
                 </a:solidFill>
                 <a:latin typeface="PT Serif"/>
               </a:rPr>
-              <a:t>Medidas robustas</a:t>
+              <a:t>¿Cuánto dura un viaje?</a:t>
             </a:r>
           </a:p>
         </p:txBody>
@@ -5067,8 +4989,8 @@
         </p:nvSpPr>
         <p:spPr>
           <a:xfrm>
-            <a:off x="704088" y="1353312"/>
-            <a:ext cx="7744968" cy="3300984"/>
+            <a:off x="502920" y="1252728"/>
+            <a:ext cx="4023360" cy="3200400"/>
           </a:xfrm>
           <a:prstGeom prst="rect">
             <a:avLst/>
@@ -5082,7 +5004,7 @@
           <a:lstStyle/>
           <a:p>
             <a:r>
-              <a:rPr sz="1800" b="1">
+              <a:rPr sz="1500" b="1">
                 <a:solidFill>
                   <a:srgbClr val="E0A437"/>
                 </a:solidFill>
@@ -5091,78 +5013,18 @@
               <a:t>▸ </a:t>
             </a:r>
             <a:r>
-              <a:rPr sz="1800" b="0">
+              <a:rPr sz="1500" b="0">
                 <a:solidFill>
                   <a:srgbClr val="3A4A5C"/>
                 </a:solidFill>
                 <a:latin typeface="PT Serif"/>
               </a:rPr>
-              <a:t>Una medida es robusta cuando los valores extremos no la alteran demasiado.</a:t>
-            </a:r>
-          </a:p>
-          <a:p>
-            <a:r>
-              <a:rPr sz="1400" b="0">
-                <a:solidFill>
-                  <a:srgbClr val="6B7785"/>
-                </a:solidFill>
-                <a:latin typeface="PT Serif"/>
-              </a:rPr>
-              <a:t>     ◦  </a:t>
-            </a:r>
-            <a:r>
-              <a:rPr sz="1400" b="0">
-                <a:solidFill>
-                  <a:srgbClr val="6B7785"/>
-                </a:solidFill>
-                <a:latin typeface="PT Serif"/>
-              </a:rPr>
-              <a:t>Media completa: 0,382 toneladas.</a:t>
-            </a:r>
-          </a:p>
-          <a:p>
-            <a:r>
-              <a:rPr sz="1400" b="0">
-                <a:solidFill>
-                  <a:srgbClr val="6B7785"/>
-                </a:solidFill>
-                <a:latin typeface="PT Serif"/>
-              </a:rPr>
-              <a:t>     ◦  </a:t>
-            </a:r>
-            <a:r>
-              <a:rPr sz="1400" b="0">
-                <a:solidFill>
-                  <a:srgbClr val="6B7785"/>
-                </a:solidFill>
-                <a:latin typeface="PT Serif"/>
-              </a:rPr>
-              <a:t>Media truncada al 10%: 0,017 toneladas.</a:t>
-            </a:r>
-          </a:p>
-          <a:p>
-            <a:r>
-              <a:rPr sz="1400" b="0">
-                <a:solidFill>
-                  <a:srgbClr val="6B7785"/>
-                </a:solidFill>
-                <a:latin typeface="PT Serif"/>
-              </a:rPr>
-              <a:t>     ◦  </a:t>
-            </a:r>
-            <a:r>
-              <a:rPr sz="1400" b="0">
-                <a:solidFill>
-                  <a:srgbClr val="6B7785"/>
-                </a:solidFill>
-                <a:latin typeface="PT Serif"/>
-              </a:rPr>
-              <a:t>Mediana: 0,006 toneladas.</a:t>
-            </a:r>
-          </a:p>
-          <a:p>
-            <a:r>
-              <a:rPr sz="1800" b="1">
+              <a:t>Mediana: 30 minutos. Percentil 95: 98 minutos.</a:t>
+            </a:r>
+          </a:p>
+          <a:p>
+            <a:r>
+              <a:rPr sz="1500" b="1">
                 <a:solidFill>
                   <a:srgbClr val="E0A437"/>
                 </a:solidFill>
@@ -5171,18 +5033,18 @@
               <a:t>▸ </a:t>
             </a:r>
             <a:r>
-              <a:rPr sz="1800" b="0">
+              <a:rPr sz="1500" b="0">
                 <a:solidFill>
                   <a:srgbClr val="3A4A5C"/>
                 </a:solidFill>
                 <a:latin typeface="PT Serif"/>
               </a:rPr>
-              <a:t>La media truncada descarta un porcentaje de cada extremo antes de promediar.</a:t>
-            </a:r>
-          </a:p>
-          <a:p>
-            <a:r>
-              <a:rPr sz="1800" b="1">
+              <a:t>Máximo registrado: 1.335 minutos, un viaje de 22 horas.</a:t>
+            </a:r>
+          </a:p>
+          <a:p>
+            <a:r>
+              <a:rPr sz="1500" b="1">
                 <a:solidFill>
                   <a:srgbClr val="E0A437"/>
                 </a:solidFill>
@@ -5191,17 +5053,61 @@
               <a:t>▸ </a:t>
             </a:r>
             <a:r>
-              <a:rPr sz="1800" b="1">
+              <a:rPr sz="1500" b="0">
+                <a:solidFill>
+                  <a:srgbClr val="3A4A5C"/>
+                </a:solidFill>
+                <a:latin typeface="PT Serif"/>
+              </a:rPr>
+              <a:t>¿Error de digitación? ¿Turno nocturno mal anotado?</a:t>
+            </a:r>
+          </a:p>
+          <a:p>
+            <a:r>
+              <a:rPr sz="1500" b="1">
+                <a:solidFill>
+                  <a:srgbClr val="E0A437"/>
+                </a:solidFill>
+                <a:latin typeface="PT Serif"/>
+              </a:rPr>
+              <a:t>▸ </a:t>
+            </a:r>
+            <a:r>
+              <a:rPr sz="1500" b="1">
                 <a:solidFill>
                   <a:srgbClr val="1D3557"/>
                 </a:solidFill>
                 <a:latin typeface="PT Serif"/>
               </a:rPr>
-              <a:t>Con distribuciones asimétricas, la mediana describe mejor el caso típico.</a:t>
-            </a:r>
-          </a:p>
-        </p:txBody>
-      </p:sp>
+              <a:t>Los valores extremos no se borran por molestos: se investigan y la decisión se declara.</a:t>
+            </a:r>
+          </a:p>
+        </p:txBody>
+      </p:sp>
+      <p:pic>
+        <p:nvPicPr>
+          <p:cNvPr id="5" name="Picture 4" descr="04_duracion_viajes.png"/>
+          <p:cNvPicPr>
+            <a:picLocks noChangeAspect="1"/>
+          </p:cNvPicPr>
+          <p:nvPr/>
+        </p:nvPicPr>
+        <p:blipFill>
+          <a:blip r:embed="rId2"/>
+          <a:stretch>
+            <a:fillRect/>
+          </a:stretch>
+        </p:blipFill>
+        <p:spPr>
+          <a:xfrm>
+            <a:off x="4892040" y="1371600"/>
+            <a:ext cx="3840480" cy="2196274"/>
+          </a:xfrm>
+          <a:prstGeom prst="rect">
+            <a:avLst/>
+          </a:prstGeom>
+        </p:spPr>
+      </p:pic>
     </p:spTree>
   </p:cSld>
   <p:clrMapOvr>
@@ -5293,7 +5199,7 @@
                 </a:solidFill>
                 <a:latin typeface="PT Serif"/>
               </a:rPr>
-              <a:t>Percentiles: la forma completa</a:t>
+              <a:t>¿En qué se mueve Santiago?</a:t>
             </a:r>
           </a:p>
         </p:txBody>
@@ -5306,8 +5212,8 @@
         </p:nvSpPr>
         <p:spPr>
           <a:xfrm>
-            <a:off x="704088" y="1353312"/>
-            <a:ext cx="7744968" cy="3300984"/>
+            <a:off x="502920" y="1252728"/>
+            <a:ext cx="4023360" cy="3200400"/>
           </a:xfrm>
           <a:prstGeom prst="rect">
             <a:avLst/>
@@ -5321,7 +5227,7 @@
           <a:lstStyle/>
           <a:p>
             <a:r>
-              <a:rPr sz="1800" b="1">
+              <a:rPr sz="1500" b="1">
                 <a:solidFill>
                   <a:srgbClr val="E0A437"/>
                 </a:solidFill>
@@ -5330,18 +5236,18 @@
               <a:t>▸ </a:t>
             </a:r>
             <a:r>
-              <a:rPr sz="1800" b="0">
+              <a:rPr sz="1500" b="0">
                 <a:solidFill>
                   <a:srgbClr val="3A4A5C"/>
                 </a:solidFill>
                 <a:latin typeface="PT Serif"/>
               </a:rPr>
-              <a:t>El percentil 90 es el valor bajo el cual queda el 90% de las observaciones.</a:t>
-            </a:r>
-          </a:p>
-          <a:p>
-            <a:r>
-              <a:rPr sz="1400" b="0">
+              <a:t>Dos merges y un groupby ponderado por factor.</a:t>
+            </a:r>
+          </a:p>
+          <a:p>
+            <a:r>
+              <a:rPr sz="1300" b="0">
                 <a:solidFill>
                   <a:srgbClr val="6B7785"/>
                 </a:solidFill>
@@ -5350,18 +5256,18 @@
               <a:t>     ◦  </a:t>
             </a:r>
             <a:r>
-              <a:rPr sz="1400" b="0">
+              <a:rPr sz="1300" b="0">
                 <a:solidFill>
                   <a:srgbClr val="6B7785"/>
                 </a:solidFill>
                 <a:latin typeface="PT Serif"/>
               </a:rPr>
-              <a:t>Percentil 50: 0,006 t.</a:t>
-            </a:r>
-          </a:p>
-          <a:p>
-            <a:r>
-              <a:rPr sz="1400" b="0">
+              <a:t>Caminata: 34% de los viajes.</a:t>
+            </a:r>
+          </a:p>
+          <a:p>
+            <a:r>
+              <a:rPr sz="1300" b="0">
                 <a:solidFill>
                   <a:srgbClr val="6B7785"/>
                 </a:solidFill>
@@ -5370,18 +5276,18 @@
               <a:t>     ◦  </a:t>
             </a:r>
             <a:r>
-              <a:rPr sz="1400" b="0">
+              <a:rPr sz="1300" b="0">
                 <a:solidFill>
                   <a:srgbClr val="6B7785"/>
                 </a:solidFill>
                 <a:latin typeface="PT Serif"/>
               </a:rPr>
-              <a:t>Percentil 90: 0,153 t.</a:t>
-            </a:r>
-          </a:p>
-          <a:p>
-            <a:r>
-              <a:rPr sz="1400" b="0">
+              <a:t>Transporte público (Bip!): 24%.</a:t>
+            </a:r>
+          </a:p>
+          <a:p>
+            <a:r>
+              <a:rPr sz="1300" b="0">
                 <a:solidFill>
                   <a:srgbClr val="6B7785"/>
                 </a:solidFill>
@@ -5390,38 +5296,18 @@
               <a:t>     ◦  </a:t>
             </a:r>
             <a:r>
-              <a:rPr sz="1400" b="0">
+              <a:rPr sz="1300" b="0">
                 <a:solidFill>
                   <a:srgbClr val="6B7785"/>
                 </a:solidFill>
                 <a:latin typeface="PT Serif"/>
               </a:rPr>
-              <a:t>Percentil 95: 0,672 t.</a:t>
-            </a:r>
-          </a:p>
-          <a:p>
-            <a:r>
-              <a:rPr sz="1400" b="0">
-                <a:solidFill>
-                  <a:srgbClr val="6B7785"/>
-                </a:solidFill>
-                <a:latin typeface="PT Serif"/>
-              </a:rPr>
-              <a:t>     ◦  </a:t>
-            </a:r>
-            <a:r>
-              <a:rPr sz="1400" b="0">
-                <a:solidFill>
-                  <a:srgbClr val="6B7785"/>
-                </a:solidFill>
-                <a:latin typeface="PT Serif"/>
-              </a:rPr>
-              <a:t>Percentil 99: 5,809 t.</a:t>
-            </a:r>
-          </a:p>
-          <a:p>
-            <a:r>
-              <a:rPr sz="1800" b="1">
+              <a:t>Auto: 23%.</a:t>
+            </a:r>
+          </a:p>
+          <a:p>
+            <a:r>
+              <a:rPr sz="1500" b="1">
                 <a:solidFill>
                   <a:srgbClr val="E0A437"/>
                 </a:solidFill>
@@ -5430,17 +5316,41 @@
               <a:t>▸ </a:t>
             </a:r>
             <a:r>
-              <a:rPr sz="1800" b="1">
+              <a:rPr sz="1500" b="1">
                 <a:solidFill>
                   <a:srgbClr val="1D3557"/>
                 </a:solidFill>
                 <a:latin typeface="PT Serif"/>
               </a:rPr>
-              <a:t>El 95% emite menos de 0,7 t al año, y el máximo llega a 299.</a:t>
-            </a:r>
-          </a:p>
-        </p:txBody>
-      </p:sp>
+              <a:t>Esta es la partición modal oficial, calculada por nosotros desde los microdatos.</a:t>
+            </a:r>
+          </a:p>
+        </p:txBody>
+      </p:sp>
+      <p:pic>
+        <p:nvPicPr>
+          <p:cNvPr id="5" name="Picture 4" descr="03_reparto_modal.png"/>
+          <p:cNvPicPr>
+            <a:picLocks noChangeAspect="1"/>
+          </p:cNvPicPr>
+          <p:nvPr/>
+        </p:nvPicPr>
+        <p:blipFill>
+          <a:blip r:embed="rId2"/>
+          <a:stretch>
+            <a:fillRect/>
+          </a:stretch>
+        </p:blipFill>
+        <p:spPr>
+          <a:xfrm>
+            <a:off x="4892040" y="1371600"/>
+            <a:ext cx="3840480" cy="1966813"/>
+          </a:xfrm>
+          <a:prstGeom prst="rect">
+            <a:avLst/>
+          </a:prstGeom>
+        </p:spPr>
+      </p:pic>
     </p:spTree>
   </p:cSld>
   <p:clrMapOvr>
@@ -5575,7 +5485,7 @@
                 </a:solidFill>
                 <a:latin typeface="PT Serif"/>
               </a:rPr>
-              <a:t>Cargar datos reales y describir su estructura.</a:t>
+              <a:t>Le haremos preguntas reales a la Encuesta Origen Destino de Santiago.</a:t>
             </a:r>
           </a:p>
           <a:p>
@@ -5595,7 +5505,47 @@
                 </a:solidFill>
                 <a:latin typeface="PT Serif"/>
               </a:rPr>
-              <a:t>Seleccionar, filtrar y tratar los datos faltantes.</a:t>
+              <a:t>Cada pregunta trae su herramienta: el repaso de Pandas va en el camino.</a:t>
+            </a:r>
+          </a:p>
+          <a:p>
+            <a:r>
+              <a:rPr sz="1400" b="0">
+                <a:solidFill>
+                  <a:srgbClr val="6B7785"/>
+                </a:solidFill>
+                <a:latin typeface="PT Serif"/>
+              </a:rPr>
+              <a:t>     ◦  </a:t>
+            </a:r>
+            <a:r>
+              <a:rPr sz="1400" b="0">
+                <a:solidFill>
+                  <a:srgbClr val="6B7785"/>
+                </a:solidFill>
+                <a:latin typeface="PT Serif"/>
+              </a:rPr>
+              <a:t>Cargar y mirar, derivar columnas, filtrar, merge, groupby.</a:t>
+            </a:r>
+          </a:p>
+          <a:p>
+            <a:r>
+              <a:rPr sz="1400" b="0">
+                <a:solidFill>
+                  <a:srgbClr val="6B7785"/>
+                </a:solidFill>
+                <a:latin typeface="PT Serif"/>
+              </a:rPr>
+              <a:t>     ◦  </a:t>
+            </a:r>
+            <a:r>
+              <a:rPr sz="1400" b="0">
+                <a:solidFill>
+                  <a:srgbClr val="6B7785"/>
+                </a:solidFill>
+                <a:latin typeface="PT Serif"/>
+              </a:rPr>
+              <a:t>Lo probablemente nuevo: tablas de códigos y factores de expansión.</a:t>
             </a:r>
           </a:p>
           <a:p>
@@ -5615,7 +5565,7 @@
                 </a:solidFill>
                 <a:latin typeface="PT Serif"/>
               </a:rPr>
-              <a:t>Resumir con groupby y combinar tablas con merge.</a:t>
+              <a:t>Inicio del análisis exploratorio: qué número resume bien una respuesta.</a:t>
             </a:r>
           </a:p>
           <a:p>
@@ -5629,33 +5579,13 @@
               <a:t>▸ </a:t>
             </a:r>
             <a:r>
-              <a:rPr sz="1800" b="0">
-                <a:solidFill>
-                  <a:srgbClr val="3A4A5C"/>
-                </a:solidFill>
-                <a:latin typeface="PT Serif"/>
-              </a:rPr>
-              <a:t>Empezar el análisis exploratorio: medidas de resumen y primeras figuras.</a:t>
-            </a:r>
-          </a:p>
-          <a:p>
-            <a:r>
               <a:rPr sz="1800" b="1">
                 <a:solidFill>
-                  <a:srgbClr val="E0A437"/>
-                </a:solidFill>
-                <a:latin typeface="PT Serif"/>
-              </a:rPr>
-              <a:t>▸ </a:t>
-            </a:r>
-            <a:r>
-              <a:rPr sz="1800" b="1">
-                <a:solidFill>
                   <a:srgbClr val="1D3557"/>
                 </a:solidFill>
                 <a:latin typeface="PT Serif"/>
               </a:rPr>
-              <a:t>Cerramos con la actividad en parejas, en el segundo bloque.</a:t>
+              <a:t>En el segundo bloque parte la Tarea 1: el retrato de tu comuna.</a:t>
             </a:r>
           </a:p>
         </p:txBody>
@@ -5751,45 +5681,21 @@
                 </a:solidFill>
                 <a:latin typeface="PT Serif"/>
               </a:rPr>
-              <a:t>Un histograma que no se puede leer</a:t>
-            </a:r>
-          </a:p>
-        </p:txBody>
-      </p:sp>
-      <p:pic>
-        <p:nvPicPr>
-          <p:cNvPr id="4" name="Picture 3" descr="01_histograma_crudo.png"/>
-          <p:cNvPicPr>
-            <a:picLocks noChangeAspect="1"/>
-          </p:cNvPicPr>
-          <p:nvPr/>
-        </p:nvPicPr>
-        <p:blipFill>
-          <a:blip r:embed="rId2"/>
-          <a:stretch>
-            <a:fillRect/>
-          </a:stretch>
-        </p:blipFill>
-        <p:spPr>
-          <a:xfrm>
-            <a:off x="1417320" y="1188720"/>
-            <a:ext cx="6309360" cy="3657697"/>
-          </a:xfrm>
-          <a:prstGeom prst="rect">
-            <a:avLst/>
-          </a:prstGeom>
-        </p:spPr>
-      </p:pic>
-      <p:sp>
-        <p:nvSpPr>
-          <p:cNvPr id="5" name="TextBox 4"/>
+              <a:t>Síntesis: ¿de quién habla este número?</a:t>
+            </a:r>
+          </a:p>
+        </p:txBody>
+      </p:sp>
+      <p:sp>
+        <p:nvSpPr>
+          <p:cNvPr id="4" name="TextBox 3"/>
           <p:cNvSpPr txBox="1"/>
           <p:nvPr/>
         </p:nvSpPr>
         <p:spPr>
           <a:xfrm>
-            <a:off x="704088" y="4434840"/>
-            <a:ext cx="7744968" cy="457200"/>
+            <a:off x="704088" y="1353312"/>
+            <a:ext cx="7744968" cy="3300984"/>
           </a:xfrm>
           <a:prstGeom prst="rect">
             <a:avLst/>
@@ -5803,13 +5709,102 @@
           <a:lstStyle/>
           <a:p>
             <a:r>
-              <a:rPr sz="1300" b="0">
-                <a:solidFill>
-                  <a:srgbClr val="6B7785"/>
-                </a:solidFill>
-                <a:latin typeface="PT Serif"/>
-              </a:rPr>
-              <a:t>Pasa siempre que la distribución es muy asimétrica: todo cae en la primera barra.</a:t>
+              <a:rPr sz="1800" b="1">
+                <a:solidFill>
+                  <a:srgbClr val="E0A437"/>
+                </a:solidFill>
+                <a:latin typeface="PT Serif"/>
+              </a:rPr>
+              <a:t>▸ </a:t>
+            </a:r>
+            <a:r>
+              <a:rPr sz="1800" b="0">
+                <a:solidFill>
+                  <a:srgbClr val="3A4A5C"/>
+                </a:solidFill>
+                <a:latin typeface="PT Serif"/>
+              </a:rPr>
+              <a:t>'El hogar promedio gana $688 mil': de casi nadie; la mediana habla del hogar típico.</a:t>
+            </a:r>
+          </a:p>
+          <a:p>
+            <a:r>
+              <a:rPr sz="1800" b="1">
+                <a:solidFill>
+                  <a:srgbClr val="E0A437"/>
+                </a:solidFill>
+                <a:latin typeface="PT Serif"/>
+              </a:rPr>
+              <a:t>▸ </a:t>
+            </a:r>
+            <a:r>
+              <a:rPr sz="1800" b="0">
+                <a:solidFill>
+                  <a:srgbClr val="3A4A5C"/>
+                </a:solidFill>
+                <a:latin typeface="PT Serif"/>
+              </a:rPr>
+              <a:t>'El 53% de los encuestados...': de la muestra; los factores de expansión hablan de la ciudad.</a:t>
+            </a:r>
+          </a:p>
+          <a:p>
+            <a:r>
+              <a:rPr sz="1800" b="1">
+                <a:solidFill>
+                  <a:srgbClr val="E0A437"/>
+                </a:solidFill>
+                <a:latin typeface="PT Serif"/>
+              </a:rPr>
+              <a:t>▸ </a:t>
+            </a:r>
+            <a:r>
+              <a:rPr sz="1800" b="0">
+                <a:solidFill>
+                  <a:srgbClr val="3A4A5C"/>
+                </a:solidFill>
+                <a:latin typeface="PT Serif"/>
+              </a:rPr>
+              <a:t>'1,9 viajes en promedio': solo si contamos a quienes no viajaron y no estaban en la tabla.</a:t>
+            </a:r>
+          </a:p>
+          <a:p>
+            <a:r>
+              <a:rPr sz="1800" b="1">
+                <a:solidFill>
+                  <a:srgbClr val="E0A437"/>
+                </a:solidFill>
+                <a:latin typeface="PT Serif"/>
+              </a:rPr>
+              <a:t>▸ </a:t>
+            </a:r>
+            <a:r>
+              <a:rPr sz="1800" b="0">
+                <a:solidFill>
+                  <a:srgbClr val="3A4A5C"/>
+                </a:solidFill>
+                <a:latin typeface="PT Serif"/>
+              </a:rPr>
+              <a:t>'El sexo es 1 o 2': sin su tabla de códigos, un número no habla de nada.</a:t>
+            </a:r>
+          </a:p>
+          <a:p>
+            <a:r>
+              <a:rPr sz="1800" b="1">
+                <a:solidFill>
+                  <a:srgbClr val="E0A437"/>
+                </a:solidFill>
+                <a:latin typeface="PT Serif"/>
+              </a:rPr>
+              <a:t>▸ </a:t>
+            </a:r>
+            <a:r>
+              <a:rPr sz="1800" b="1">
+                <a:solidFill>
+                  <a:srgbClr val="1D3557"/>
+                </a:solidFill>
+                <a:latin typeface="PT Serif"/>
+              </a:rPr>
+              <a:t>La técnica era repaso; el hábito de interrogar cada cifra es lo que se llevan.</a:t>
             </a:r>
           </a:p>
         </p:txBody>
@@ -5905,45 +5900,21 @@
                 </a:solidFill>
                 <a:latin typeface="PT Serif"/>
               </a:rPr>
-              <a:t>El mismo histograma en escala logarítmica</a:t>
-            </a:r>
-          </a:p>
-        </p:txBody>
-      </p:sp>
-      <p:pic>
-        <p:nvPicPr>
-          <p:cNvPr id="4" name="Picture 3" descr="02_histograma_log.png"/>
-          <p:cNvPicPr>
-            <a:picLocks noChangeAspect="1"/>
-          </p:cNvPicPr>
-          <p:nvPr/>
-        </p:nvPicPr>
-        <p:blipFill>
-          <a:blip r:embed="rId2"/>
-          <a:stretch>
-            <a:fillRect/>
-          </a:stretch>
-        </p:blipFill>
-        <p:spPr>
-          <a:xfrm>
-            <a:off x="1417320" y="1188720"/>
-            <a:ext cx="6309360" cy="3630672"/>
-          </a:xfrm>
-          <a:prstGeom prst="rect">
-            <a:avLst/>
-          </a:prstGeom>
-        </p:spPr>
-      </p:pic>
-      <p:sp>
-        <p:nvSpPr>
-          <p:cNvPr id="5" name="TextBox 4"/>
+              <a:t>Segundo bloque: parte la Tarea 1</a:t>
+            </a:r>
+          </a:p>
+        </p:txBody>
+      </p:sp>
+      <p:sp>
+        <p:nvSpPr>
+          <p:cNvPr id="4" name="TextBox 3"/>
           <p:cNvSpPr txBox="1"/>
           <p:nvPr/>
         </p:nvSpPr>
         <p:spPr>
           <a:xfrm>
-            <a:off x="704088" y="4434840"/>
-            <a:ext cx="7744968" cy="457200"/>
+            <a:off x="704088" y="1353312"/>
+            <a:ext cx="7744968" cy="3300984"/>
           </a:xfrm>
           <a:prstGeom prst="rect">
             <a:avLst/>
@@ -5957,288 +5928,84 @@
           <a:lstStyle/>
           <a:p>
             <a:r>
-              <a:rPr sz="1300" b="0">
+              <a:rPr sz="1800" b="1">
+                <a:solidFill>
+                  <a:srgbClr val="E0A437"/>
+                </a:solidFill>
+                <a:latin typeface="PT Serif"/>
+              </a:rPr>
+              <a:t>▸ </a:t>
+            </a:r>
+            <a:r>
+              <a:rPr sz="1800" b="0">
+                <a:solidFill>
+                  <a:srgbClr val="3A4A5C"/>
+                </a:solidFill>
+                <a:latin typeface="PT Serif"/>
+              </a:rPr>
+              <a:t>El retrato de tu comuna: cada pareja adopta una comuna del Gran Santiago.</a:t>
+            </a:r>
+          </a:p>
+          <a:p>
+            <a:r>
+              <a:rPr sz="1400" b="0">
                 <a:solidFill>
                   <a:srgbClr val="6B7785"/>
                 </a:solidFill>
                 <a:latin typeface="PT Serif"/>
               </a:rPr>
-              <a:t>Ojo: los intervalos también deben ser logarítmicos, no basta con cambiar el eje.</a:t>
-            </a:r>
-          </a:p>
-        </p:txBody>
-      </p:sp>
-    </p:spTree>
-  </p:cSld>
-  <p:clrMapOvr>
-    <a:masterClrMapping/>
-  </p:clrMapOvr>
-</p:sld>
-</file>
-
-<file path=ppt/slides/slide22.xml><?xml version="1.0" encoding="utf-8"?>
-<p:sld xmlns:a="http://schemas.openxmlformats.org/drawingml/2006/main" xmlns:p="http://schemas.openxmlformats.org/presentationml/2006/main" xmlns:r="http://schemas.openxmlformats.org/officeDocument/2006/relationships">
-  <p:cSld>
-    <p:spTree>
-      <p:nvGrpSpPr>
-        <p:cNvPr id="1" name=""/>
-        <p:cNvGrpSpPr/>
-        <p:nvPr/>
-      </p:nvGrpSpPr>
-      <p:grpSpPr/>
-      <p:sp>
-        <p:nvSpPr>
-          <p:cNvPr id="2" name="Rectangle 1"/>
-          <p:cNvSpPr/>
-          <p:nvPr/>
-        </p:nvSpPr>
-        <p:spPr>
-          <a:xfrm>
-            <a:off x="0" y="0"/>
-            <a:ext cx="9144000" cy="5138928"/>
-          </a:xfrm>
-          <a:prstGeom prst="rect">
-            <a:avLst/>
-          </a:prstGeom>
-          <a:solidFill>
-            <a:srgbClr val="FAFBFC"/>
-          </a:solidFill>
-          <a:ln>
-            <a:noFill/>
-          </a:ln>
-          <a:effectLst/>
-        </p:spPr>
-        <p:style>
-          <a:lnRef idx="1">
-            <a:schemeClr val="accent1"/>
-          </a:lnRef>
-          <a:fillRef idx="3">
-            <a:schemeClr val="accent1"/>
-          </a:fillRef>
-          <a:effectRef idx="2">
-            <a:schemeClr val="accent1"/>
-          </a:effectRef>
-          <a:fontRef idx="minor">
-            <a:schemeClr val="lt1"/>
-          </a:fontRef>
-        </p:style>
-        <p:txBody>
-          <a:bodyPr rtlCol="0" anchor="ctr"/>
-          <a:lstStyle/>
-          <a:p>
-            <a:pPr algn="ctr"/>
-          </a:p>
-        </p:txBody>
-      </p:sp>
-      <p:sp>
-        <p:nvSpPr>
-          <p:cNvPr id="3" name="TextBox 2"/>
-          <p:cNvSpPr txBox="1"/>
-          <p:nvPr/>
-        </p:nvSpPr>
-        <p:spPr>
-          <a:xfrm>
-            <a:off x="402336" y="301752"/>
-            <a:ext cx="8348472" cy="795528"/>
-          </a:xfrm>
-          <a:prstGeom prst="rect">
-            <a:avLst/>
-          </a:prstGeom>
-          <a:noFill/>
-        </p:spPr>
-        <p:txBody>
-          <a:bodyPr wrap="square">
-            <a:spAutoFit/>
-          </a:bodyPr>
-          <a:lstStyle/>
-          <a:p>
-            <a:r>
-              <a:rPr sz="2800" b="1">
-                <a:solidFill>
-                  <a:srgbClr val="0F0F0F"/>
-                </a:solidFill>
-                <a:latin typeface="PT Serif"/>
-              </a:rPr>
-              <a:t>Comparar grupos con diagramas de caja</a:t>
-            </a:r>
-          </a:p>
-        </p:txBody>
-      </p:sp>
-      <p:pic>
-        <p:nvPicPr>
-          <p:cNvPr id="4" name="Picture 3" descr="05_boxplot_macrozona.png"/>
-          <p:cNvPicPr>
-            <a:picLocks noChangeAspect="1"/>
-          </p:cNvPicPr>
-          <p:nvPr/>
-        </p:nvPicPr>
-        <p:blipFill>
-          <a:blip r:embed="rId2"/>
-          <a:stretch>
-            <a:fillRect/>
-          </a:stretch>
-        </p:blipFill>
-        <p:spPr>
-          <a:xfrm>
-            <a:off x="1417320" y="1188720"/>
-            <a:ext cx="6309360" cy="3691647"/>
-          </a:xfrm>
-          <a:prstGeom prst="rect">
-            <a:avLst/>
-          </a:prstGeom>
-        </p:spPr>
-      </p:pic>
-      <p:sp>
-        <p:nvSpPr>
-          <p:cNvPr id="5" name="TextBox 4"/>
-          <p:cNvSpPr txBox="1"/>
-          <p:nvPr/>
-        </p:nvSpPr>
-        <p:spPr>
-          <a:xfrm>
-            <a:off x="704088" y="4434840"/>
-            <a:ext cx="7744968" cy="457200"/>
-          </a:xfrm>
-          <a:prstGeom prst="rect">
-            <a:avLst/>
-          </a:prstGeom>
-          <a:noFill/>
-        </p:spPr>
-        <p:txBody>
-          <a:bodyPr wrap="square">
-            <a:spAutoFit/>
-          </a:bodyPr>
-          <a:lstStyle/>
-          <a:p>
-            <a:r>
-              <a:rPr sz="1300" b="0">
+              <a:t>     ◦  </a:t>
+            </a:r>
+            <a:r>
+              <a:rPr sz="1400" b="0">
                 <a:solidFill>
                   <a:srgbClr val="6B7785"/>
                 </a:solidFill>
                 <a:latin typeface="PT Serif"/>
               </a:rPr>
-              <a:t>La caja va del percentil 25 al 75, y la línea del medio es la mediana.</a:t>
-            </a:r>
-          </a:p>
-        </p:txBody>
-      </p:sp>
-    </p:spTree>
-  </p:cSld>
-  <p:clrMapOvr>
-    <a:masterClrMapping/>
-  </p:clrMapOvr>
-</p:sld>
-</file>
-
-<file path=ppt/slides/slide23.xml><?xml version="1.0" encoding="utf-8"?>
-<p:sld xmlns:a="http://schemas.openxmlformats.org/drawingml/2006/main" xmlns:p="http://schemas.openxmlformats.org/presentationml/2006/main" xmlns:r="http://schemas.openxmlformats.org/officeDocument/2006/relationships">
-  <p:cSld>
-    <p:spTree>
-      <p:nvGrpSpPr>
-        <p:cNvPr id="1" name=""/>
-        <p:cNvGrpSpPr/>
-        <p:nvPr/>
-      </p:nvGrpSpPr>
-      <p:grpSpPr/>
-      <p:sp>
-        <p:nvSpPr>
-          <p:cNvPr id="2" name="Rectangle 1"/>
-          <p:cNvSpPr/>
-          <p:nvPr/>
-        </p:nvSpPr>
-        <p:spPr>
-          <a:xfrm>
-            <a:off x="0" y="0"/>
-            <a:ext cx="9144000" cy="5138928"/>
-          </a:xfrm>
-          <a:prstGeom prst="rect">
-            <a:avLst/>
-          </a:prstGeom>
-          <a:solidFill>
-            <a:srgbClr val="FAFBFC"/>
-          </a:solidFill>
-          <a:ln>
-            <a:noFill/>
-          </a:ln>
-          <a:effectLst/>
-        </p:spPr>
-        <p:style>
-          <a:lnRef idx="1">
-            <a:schemeClr val="accent1"/>
-          </a:lnRef>
-          <a:fillRef idx="3">
-            <a:schemeClr val="accent1"/>
-          </a:fillRef>
-          <a:effectRef idx="2">
-            <a:schemeClr val="accent1"/>
-          </a:effectRef>
-          <a:fontRef idx="minor">
-            <a:schemeClr val="lt1"/>
-          </a:fontRef>
-        </p:style>
-        <p:txBody>
-          <a:bodyPr rtlCol="0" anchor="ctr"/>
-          <a:lstStyle/>
-          <a:p>
-            <a:pPr algn="ctr"/>
-          </a:p>
-        </p:txBody>
-      </p:sp>
-      <p:sp>
-        <p:nvSpPr>
-          <p:cNvPr id="3" name="TextBox 2"/>
-          <p:cNvSpPr txBox="1"/>
-          <p:nvPr/>
-        </p:nvSpPr>
-        <p:spPr>
-          <a:xfrm>
-            <a:off x="402336" y="301752"/>
-            <a:ext cx="8348472" cy="795528"/>
-          </a:xfrm>
-          <a:prstGeom prst="rect">
-            <a:avLst/>
-          </a:prstGeom>
-          <a:noFill/>
-        </p:spPr>
-        <p:txBody>
-          <a:bodyPr wrap="square">
-            <a:spAutoFit/>
-          </a:bodyPr>
-          <a:lstStyle/>
-          <a:p>
-            <a:r>
-              <a:rPr sz="2800" b="1">
-                <a:solidFill>
-                  <a:srgbClr val="0F0F0F"/>
-                </a:solidFill>
-                <a:latin typeface="PT Serif"/>
-              </a:rPr>
-              <a:t>Síntesis</a:t>
-            </a:r>
-          </a:p>
-        </p:txBody>
-      </p:sp>
-      <p:sp>
-        <p:nvSpPr>
-          <p:cNvPr id="4" name="TextBox 3"/>
-          <p:cNvSpPr txBox="1"/>
-          <p:nvPr/>
-        </p:nvSpPr>
-        <p:spPr>
-          <a:xfrm>
-            <a:off x="704088" y="1353312"/>
-            <a:ext cx="7744968" cy="3300984"/>
-          </a:xfrm>
-          <a:prstGeom prst="rect">
-            <a:avLst/>
-          </a:prstGeom>
-          <a:noFill/>
-        </p:spPr>
-        <p:txBody>
-          <a:bodyPr wrap="square">
-            <a:spAutoFit/>
-          </a:bodyPr>
-          <a:lstStyle/>
+              <a:t>Hoy: elegir la comuna y construir su retrato numérico.</a:t>
+            </a:r>
+          </a:p>
+          <a:p>
+            <a:r>
+              <a:rPr sz="1400" b="0">
+                <a:solidFill>
+                  <a:srgbClr val="6B7785"/>
+                </a:solidFill>
+                <a:latin typeface="PT Serif"/>
+              </a:rPr>
+              <a:t>     ◦  </a:t>
+            </a:r>
+            <a:r>
+              <a:rPr sz="1400" b="0">
+                <a:solidFill>
+                  <a:srgbClr val="6B7785"/>
+                </a:solidFill>
+                <a:latin typeface="PT Serif"/>
+              </a:rPr>
+              <a:t>Próxima clase: el retrato gráfico, con métodos de visualización.</a:t>
+            </a:r>
+          </a:p>
+          <a:p>
+            <a:r>
+              <a:rPr sz="1400" b="0">
+                <a:solidFill>
+                  <a:srgbClr val="6B7785"/>
+                </a:solidFill>
+                <a:latin typeface="PT Serif"/>
+              </a:rPr>
+              <a:t>     ◦  </a:t>
+            </a:r>
+            <a:r>
+              <a:rPr sz="1400" b="0">
+                <a:solidFill>
+                  <a:srgbClr val="6B7785"/>
+                </a:solidFill>
+                <a:latin typeface="PT Serif"/>
+              </a:rPr>
+              <a:t>Entrega del retrato completo: jueves 10 de septiembre, por Aula.</a:t>
+            </a:r>
+          </a:p>
           <a:p>
             <a:r>
               <a:rPr sz="1800" b="1">
@@ -6256,7 +6023,7 @@
                 </a:solidFill>
                 <a:latin typeface="PT Serif"/>
               </a:rPr>
-              <a:t>Antes de calcular: shape, info() y datos faltantes.</a:t>
+              <a:t>El enunciado está en evaluaciones/tareas/ y la guía de hoy en actividades/.</a:t>
             </a:r>
           </a:p>
           <a:p>
@@ -6270,312 +6037,13 @@
               <a:t>▸ </a:t>
             </a:r>
             <a:r>
-              <a:rPr sz="1800" b="0">
-                <a:solidFill>
-                  <a:srgbClr val="3A4A5C"/>
-                </a:solidFill>
-                <a:latin typeface="PT Serif"/>
-              </a:rPr>
-              <a:t>loc es por etiqueta, iloc por posición, y los filtros son condiciones booleanas.</a:t>
-            </a:r>
-          </a:p>
-          <a:p>
-            <a:r>
               <a:rPr sz="1800" b="1">
                 <a:solidFill>
-                  <a:srgbClr val="E0A437"/>
-                </a:solidFill>
-                <a:latin typeface="PT Serif"/>
-              </a:rPr>
-              <a:t>▸ </a:t>
-            </a:r>
-            <a:r>
-              <a:rPr sz="1800" b="0">
-                <a:solidFill>
-                  <a:srgbClr val="3A4A5C"/>
-                </a:solidFill>
-                <a:latin typeface="PT Serif"/>
-              </a:rPr>
-              <a:t>groupby más una función de resumen responde casi todas las preguntas descriptivas.</a:t>
-            </a:r>
-          </a:p>
-          <a:p>
-            <a:r>
-              <a:rPr sz="1800" b="1">
-                <a:solidFill>
-                  <a:srgbClr val="E0A437"/>
-                </a:solidFill>
-                <a:latin typeface="PT Serif"/>
-              </a:rPr>
-              <a:t>▸ </a:t>
-            </a:r>
-            <a:r>
-              <a:rPr sz="1800" b="0">
-                <a:solidFill>
-                  <a:srgbClr val="3A4A5C"/>
-                </a:solidFill>
-                <a:latin typeface="PT Serif"/>
-              </a:rPr>
-              <a:t>Después de un merge, revise si quedaron filas sin pareja.</a:t>
-            </a:r>
-          </a:p>
-          <a:p>
-            <a:r>
-              <a:rPr sz="1800" b="1">
-                <a:solidFill>
-                  <a:srgbClr val="E0A437"/>
-                </a:solidFill>
-                <a:latin typeface="PT Serif"/>
-              </a:rPr>
-              <a:t>▸ </a:t>
-            </a:r>
-            <a:r>
-              <a:rPr sz="1800" b="1">
-                <a:solidFill>
                   <a:srgbClr val="1D3557"/>
                 </a:solidFill>
                 <a:latin typeface="PT Serif"/>
               </a:rPr>
-              <a:t>Con distribuciones asimétricas, la mediana y los percentiles son más honestos que la media.</a:t>
-            </a:r>
-          </a:p>
-        </p:txBody>
-      </p:sp>
-    </p:spTree>
-  </p:cSld>
-  <p:clrMapOvr>
-    <a:masterClrMapping/>
-  </p:clrMapOvr>
-</p:sld>
-</file>
-
-<file path=ppt/slides/slide24.xml><?xml version="1.0" encoding="utf-8"?>
-<p:sld xmlns:a="http://schemas.openxmlformats.org/drawingml/2006/main" xmlns:p="http://schemas.openxmlformats.org/presentationml/2006/main" xmlns:r="http://schemas.openxmlformats.org/officeDocument/2006/relationships">
-  <p:cSld>
-    <p:spTree>
-      <p:nvGrpSpPr>
-        <p:cNvPr id="1" name=""/>
-        <p:cNvGrpSpPr/>
-        <p:nvPr/>
-      </p:nvGrpSpPr>
-      <p:grpSpPr/>
-      <p:sp>
-        <p:nvSpPr>
-          <p:cNvPr id="2" name="Rectangle 1"/>
-          <p:cNvSpPr/>
-          <p:nvPr/>
-        </p:nvSpPr>
-        <p:spPr>
-          <a:xfrm>
-            <a:off x="0" y="0"/>
-            <a:ext cx="9144000" cy="5138928"/>
-          </a:xfrm>
-          <a:prstGeom prst="rect">
-            <a:avLst/>
-          </a:prstGeom>
-          <a:solidFill>
-            <a:srgbClr val="FAFBFC"/>
-          </a:solidFill>
-          <a:ln>
-            <a:noFill/>
-          </a:ln>
-          <a:effectLst/>
-        </p:spPr>
-        <p:style>
-          <a:lnRef idx="1">
-            <a:schemeClr val="accent1"/>
-          </a:lnRef>
-          <a:fillRef idx="3">
-            <a:schemeClr val="accent1"/>
-          </a:fillRef>
-          <a:effectRef idx="2">
-            <a:schemeClr val="accent1"/>
-          </a:effectRef>
-          <a:fontRef idx="minor">
-            <a:schemeClr val="lt1"/>
-          </a:fontRef>
-        </p:style>
-        <p:txBody>
-          <a:bodyPr rtlCol="0" anchor="ctr"/>
-          <a:lstStyle/>
-          <a:p>
-            <a:pPr algn="ctr"/>
-          </a:p>
-        </p:txBody>
-      </p:sp>
-      <p:sp>
-        <p:nvSpPr>
-          <p:cNvPr id="3" name="TextBox 2"/>
-          <p:cNvSpPr txBox="1"/>
-          <p:nvPr/>
-        </p:nvSpPr>
-        <p:spPr>
-          <a:xfrm>
-            <a:off x="402336" y="301752"/>
-            <a:ext cx="8348472" cy="795528"/>
-          </a:xfrm>
-          <a:prstGeom prst="rect">
-            <a:avLst/>
-          </a:prstGeom>
-          <a:noFill/>
-        </p:spPr>
-        <p:txBody>
-          <a:bodyPr wrap="square">
-            <a:spAutoFit/>
-          </a:bodyPr>
-          <a:lstStyle/>
-          <a:p>
-            <a:r>
-              <a:rPr sz="2800" b="1">
-                <a:solidFill>
-                  <a:srgbClr val="0F0F0F"/>
-                </a:solidFill>
-                <a:latin typeface="PT Serif"/>
-              </a:rPr>
-              <a:t>Actividad de hoy</a:t>
-            </a:r>
-          </a:p>
-        </p:txBody>
-      </p:sp>
-      <p:sp>
-        <p:nvSpPr>
-          <p:cNvPr id="4" name="TextBox 3"/>
-          <p:cNvSpPr txBox="1"/>
-          <p:nvPr/>
-        </p:nvSpPr>
-        <p:spPr>
-          <a:xfrm>
-            <a:off x="704088" y="1353312"/>
-            <a:ext cx="7744968" cy="3300984"/>
-          </a:xfrm>
-          <a:prstGeom prst="rect">
-            <a:avLst/>
-          </a:prstGeom>
-          <a:noFill/>
-        </p:spPr>
-        <p:txBody>
-          <a:bodyPr wrap="square">
-            <a:spAutoFit/>
-          </a:bodyPr>
-          <a:lstStyle/>
-          <a:p>
-            <a:r>
-              <a:rPr sz="1800" b="1">
-                <a:solidFill>
-                  <a:srgbClr val="E0A437"/>
-                </a:solidFill>
-                <a:latin typeface="PT Serif"/>
-              </a:rPr>
-              <a:t>▸ </a:t>
-            </a:r>
-            <a:r>
-              <a:rPr sz="1800" b="0">
-                <a:solidFill>
-                  <a:srgbClr val="3A4A5C"/>
-                </a:solidFill>
-                <a:latin typeface="PT Serif"/>
-              </a:rPr>
-              <a:t>En parejas, en el segundo bloque, sobre el mismo archivo de emisiones.</a:t>
-            </a:r>
-          </a:p>
-          <a:p>
-            <a:r>
-              <a:rPr sz="1400" b="0">
-                <a:solidFill>
-                  <a:srgbClr val="6B7785"/>
-                </a:solidFill>
-                <a:latin typeface="PT Serif"/>
-              </a:rPr>
-              <a:t>     ◦  </a:t>
-            </a:r>
-            <a:r>
-              <a:rPr sz="1400" b="0">
-                <a:solidFill>
-                  <a:srgbClr val="6B7785"/>
-                </a:solidFill>
-                <a:latin typeface="PT Serif"/>
-              </a:rPr>
-              <a:t>Cargar los datos y describir su estructura.</a:t>
-            </a:r>
-          </a:p>
-          <a:p>
-            <a:r>
-              <a:rPr sz="1400" b="0">
-                <a:solidFill>
-                  <a:srgbClr val="6B7785"/>
-                </a:solidFill>
-                <a:latin typeface="PT Serif"/>
-              </a:rPr>
-              <a:t>     ◦  </a:t>
-            </a:r>
-            <a:r>
-              <a:rPr sz="1400" b="0">
-                <a:solidFill>
-                  <a:srgbClr val="6B7785"/>
-                </a:solidFill>
-                <a:latin typeface="PT Serif"/>
-              </a:rPr>
-              <a:t>Comparar MP10 y MP2,5 por región.</a:t>
-            </a:r>
-          </a:p>
-          <a:p>
-            <a:r>
-              <a:rPr sz="1400" b="0">
-                <a:solidFill>
-                  <a:srgbClr val="6B7785"/>
-                </a:solidFill>
-                <a:latin typeface="PT Serif"/>
-              </a:rPr>
-              <a:t>     ◦  </a:t>
-            </a:r>
-            <a:r>
-              <a:rPr sz="1400" b="0">
-                <a:solidFill>
-                  <a:srgbClr val="6B7785"/>
-                </a:solidFill>
-                <a:latin typeface="PT Serif"/>
-              </a:rPr>
-              <a:t>Encontrar los establecimientos que más emiten SO2.</a:t>
-            </a:r>
-          </a:p>
-          <a:p>
-            <a:r>
-              <a:rPr sz="1400" b="0">
-                <a:solidFill>
-                  <a:srgbClr val="6B7785"/>
-                </a:solidFill>
-                <a:latin typeface="PT Serif"/>
-              </a:rPr>
-              <a:t>     ◦  </a:t>
-            </a:r>
-            <a:r>
-              <a:rPr sz="1400" b="0">
-                <a:solidFill>
-                  <a:srgbClr val="6B7785"/>
-                </a:solidFill>
-                <a:latin typeface="PT Serif"/>
-              </a:rPr>
-              <a:t>Decidir qué medida de resumen reportar y justificarlo.</a:t>
-            </a:r>
-          </a:p>
-          <a:p>
-            <a:r>
-              <a:rPr sz="1800" b="1">
-                <a:solidFill>
-                  <a:srgbClr val="E0A437"/>
-                </a:solidFill>
-                <a:latin typeface="PT Serif"/>
-              </a:rPr>
-              <a:t>▸ </a:t>
-            </a:r>
-            <a:r>
-              <a:rPr sz="1800" b="1">
-                <a:solidFill>
-                  <a:srgbClr val="1D3557"/>
-                </a:solidFill>
-                <a:latin typeface="PT Serif"/>
-              </a:rPr>
-              <a:t>El enunciado está en actividades/clase02_actividad.md.</a:t>
+              <a:t>Lo que hagan en este bloque ya es parte de la tarea.</a:t>
             </a:r>
           </a:p>
         </p:txBody>
@@ -6671,7 +6139,7 @@
                 </a:solidFill>
                 <a:latin typeface="PT Serif"/>
               </a:rPr>
-              <a:t>Los datos de hoy</a:t>
+              <a:t>¿De quién habla este número?</a:t>
             </a:r>
           </a:p>
           <a:p>
@@ -6682,7 +6150,7 @@
                 </a:solidFill>
                 <a:latin typeface="PT Serif"/>
               </a:rPr>
-              <a:t>Emisiones al aire declaradas en Chile</a:t>
+              <a:t>El concepto que nos llevamos hoy</a:t>
             </a:r>
           </a:p>
         </p:txBody>
@@ -6778,7 +6246,7 @@
                 </a:solidFill>
                 <a:latin typeface="PT Serif"/>
               </a:rPr>
-              <a:t>De dónde vienen los datos</a:t>
+              <a:t>La pregunta que ordena toda la clase</a:t>
             </a:r>
           </a:p>
         </p:txBody>
@@ -6821,7 +6289,7 @@
                 </a:solidFill>
                 <a:latin typeface="PT Serif"/>
               </a:rPr>
-              <a:t>Registro de Emisiones y Transferencias de Contaminantes (RETC), del Ministerio del Medio Ambiente.</a:t>
+              <a:t>Pandas ya lo conocen: hoy no es el aprendizaje, es la herramienta.</a:t>
             </a:r>
           </a:p>
           <a:p>
@@ -6841,7 +6309,7 @@
                 </a:solidFill>
                 <a:latin typeface="PT Serif"/>
               </a:rPr>
-              <a:t>Emisiones al aire de fuentes puntuales, año 2020.</a:t>
+              <a:t>Lo que se llevan es un hábito: interrogar cada cifra antes de creerle.</a:t>
             </a:r>
           </a:p>
           <a:p>
@@ -6861,7 +6329,7 @@
                 </a:solidFill>
                 <a:latin typeface="PT Serif"/>
               </a:rPr>
-              <a:t>Una fila es un contaminante emitido por un establecimiento.</a:t>
+              <a:t>Un promedio puede describir una situación en la que casi nadie está.</a:t>
             </a:r>
           </a:p>
           <a:p>
@@ -6881,7 +6349,7 @@
                 </a:solidFill>
                 <a:latin typeface="PT Serif"/>
               </a:rPr>
-              <a:t>27.015 filas, 16 regiones, 287 comunas y 19 rubros.</a:t>
+              <a:t>Contar filas de una encuesta habla de la muestra, no de la ciudad.</a:t>
             </a:r>
           </a:p>
           <a:p>
@@ -6901,7 +6369,7 @@
                 </a:solidFill>
                 <a:latin typeface="PT Serif"/>
               </a:rPr>
-              <a:t>MP2,5, MP10 y SO2: los contaminantes de los planes de descontaminación.</a:t>
+              <a:t>Hay personas de las que la tabla no dice nada, y ese silencio informa.</a:t>
             </a:r>
           </a:p>
           <a:p>
@@ -6921,7 +6389,7 @@
                 </a:solidFill>
                 <a:latin typeface="PT Serif"/>
               </a:rPr>
-              <a:t>Son datos reales, con faltantes y con una distribución muy despareja.</a:t>
+              <a:t>Al final de la clase volveremos a esta pregunta con cuatro respuestas.</a:t>
             </a:r>
           </a:p>
         </p:txBody>
@@ -7017,7 +6485,7 @@
                 </a:solidFill>
                 <a:latin typeface="PT Serif"/>
               </a:rPr>
-              <a:t>Pandas</a:t>
+              <a:t>Los datos de hoy</a:t>
             </a:r>
           </a:p>
           <a:p>
@@ -7028,7 +6496,7 @@
                 </a:solidFill>
                 <a:latin typeface="PT Serif"/>
               </a:rPr>
-              <a:t>La herramienta para manipular tablas</a:t>
+              <a:t>Encuesta Origen Destino de Santiago 2012</a:t>
             </a:r>
           </a:p>
         </p:txBody>
@@ -7124,7 +6592,7 @@
                 </a:solidFill>
                 <a:latin typeface="PT Serif"/>
               </a:rPr>
-              <a:t>Las dos estructuras de Pandas</a:t>
+              <a:t>La EOD 2012</a:t>
             </a:r>
           </a:p>
         </p:txBody>
@@ -7167,7 +6635,7 @@
                 </a:solidFill>
                 <a:latin typeface="PT Serif"/>
               </a:rPr>
-              <a:t>DataFrame: una tabla, con filas y columnas con nombre.</a:t>
+              <a:t>La encuesta de movilidad más completa de Chile (SECTRA y U. Alberto Hurtado).</a:t>
             </a:r>
           </a:p>
           <a:p>
@@ -7187,7 +6655,7 @@
                 </a:solidFill>
                 <a:latin typeface="PT Serif"/>
               </a:rPr>
-              <a:t>Series: una columna, con su índice.</a:t>
+              <a:t>Registra todos los viajes de un día de los hogares encuestados.</a:t>
             </a:r>
           </a:p>
           <a:p>
@@ -7207,7 +6675,7 @@
                 </a:solidFill>
                 <a:latin typeface="PT Serif"/>
               </a:rPr>
-              <a:t>Al seleccionar una columna de un DataFrame se obtiene una Series.</a:t>
+              <a:t>18.264 hogares, 60.054 personas, 113.591 viajes.</a:t>
             </a:r>
           </a:p>
           <a:p>
@@ -7227,7 +6695,7 @@
                 </a:solidFill>
                 <a:latin typeface="PT Serif"/>
               </a:rPr>
-              <a:t>El índice es lo que permite alinear datos entre tablas distintas.</a:t>
+              <a:t>Es la base de la planificación de transporte de Santiago.</a:t>
             </a:r>
           </a:p>
           <a:p>
@@ -7241,13 +6709,33 @@
               <a:t>▸ </a:t>
             </a:r>
             <a:r>
+              <a:rPr sz="1800" b="0">
+                <a:solidFill>
+                  <a:srgbClr val="3A4A5C"/>
+                </a:solidFill>
+                <a:latin typeface="PT Serif"/>
+              </a:rPr>
+              <a:t>Es una base relacional: varias tablas conectadas por identificadores.</a:t>
+            </a:r>
+          </a:p>
+          <a:p>
+            <a:r>
               <a:rPr sz="1800" b="1">
                 <a:solidFill>
+                  <a:srgbClr val="E0A437"/>
+                </a:solidFill>
+                <a:latin typeface="PT Serif"/>
+              </a:rPr>
+              <a:t>▸ </a:t>
+            </a:r>
+            <a:r>
+              <a:rPr sz="1800" b="1">
+                <a:solidFill>
                   <a:srgbClr val="1D3557"/>
                 </a:solidFill>
                 <a:latin typeface="PT Serif"/>
               </a:rPr>
-              <a:t>Casi todo el trabajo del curso pasa por estas dos estructuras.</a:t>
+              <a:t>El mismo diseño que van a encontrar en la Casen, el Censo o la ENUSC.</a:t>
             </a:r>
           </a:p>
         </p:txBody>
@@ -7343,124 +6831,21 @@
                 </a:solidFill>
                 <a:latin typeface="PT Serif"/>
               </a:rPr>
-              <a:t>Cargar y mirar antes de calcular</a:t>
-            </a:r>
-          </a:p>
-        </p:txBody>
-      </p:sp>
-      <p:sp>
-        <p:nvSpPr>
-          <p:cNvPr id="4" name="Rectangle 3"/>
-          <p:cNvSpPr/>
-          <p:nvPr/>
-        </p:nvSpPr>
-        <p:spPr>
-          <a:xfrm>
-            <a:off x="704088" y="1280160"/>
-            <a:ext cx="7744968" cy="2880360"/>
-          </a:xfrm>
-          <a:prstGeom prst="rect">
-            <a:avLst/>
-          </a:prstGeom>
-          <a:solidFill>
-            <a:srgbClr val="F0F2F5"/>
-          </a:solidFill>
-          <a:ln>
-            <a:solidFill>
-              <a:srgbClr val="D8DDE3"/>
-            </a:solidFill>
-          </a:ln>
-          <a:effectLst/>
-        </p:spPr>
-        <p:style>
-          <a:lnRef idx="1">
-            <a:schemeClr val="accent1"/>
-          </a:lnRef>
-          <a:fillRef idx="3">
-            <a:schemeClr val="accent1"/>
-          </a:fillRef>
-          <a:effectRef idx="2">
-            <a:schemeClr val="accent1"/>
-          </a:effectRef>
-          <a:fontRef idx="minor">
-            <a:schemeClr val="lt1"/>
-          </a:fontRef>
-        </p:style>
-        <p:txBody>
-          <a:bodyPr rtlCol="0" anchor="ctr" wrap="square" lIns="228600" tIns="137160"/>
-          <a:lstStyle/>
-          <a:p>
-            <a:pPr/>
-            <a:r>
-              <a:rPr sz="1500" b="0">
-                <a:solidFill>
-                  <a:srgbClr val="1D3557"/>
-                </a:solidFill>
-                <a:latin typeface="Menlo"/>
-              </a:rPr>
-              <a:t>emisiones = pd.read_csv('datos/emisiones_aire_2020.csv')</a:t>
-            </a:r>
-          </a:p>
-          <a:p>
-            <a:pPr/>
-            <a:r>
-              <a:rPr sz="1500" b="0">
-                <a:solidFill>
-                  <a:srgbClr val="1D3557"/>
-                </a:solidFill>
-                <a:latin typeface="Menlo"/>
-              </a:rPr>
-              <a:t/>
-            </a:r>
-          </a:p>
-          <a:p>
-            <a:pPr/>
-            <a:r>
-              <a:rPr sz="1500" b="0">
-                <a:solidFill>
-                  <a:srgbClr val="1D3557"/>
-                </a:solidFill>
-                <a:latin typeface="Menlo"/>
-              </a:rPr>
-              <a:t>emisiones.shape      # cuántas filas y columnas</a:t>
-            </a:r>
-          </a:p>
-          <a:p>
-            <a:pPr/>
-            <a:r>
-              <a:rPr sz="1500" b="0">
-                <a:solidFill>
-                  <a:srgbClr val="1D3557"/>
-                </a:solidFill>
-                <a:latin typeface="Menlo"/>
-              </a:rPr>
-              <a:t>emisiones.head()     # las primeras filas</a:t>
-            </a:r>
-          </a:p>
-          <a:p>
-            <a:pPr/>
-            <a:r>
-              <a:rPr sz="1500" b="0">
-                <a:solidFill>
-                  <a:srgbClr val="1D3557"/>
-                </a:solidFill>
-                <a:latin typeface="Menlo"/>
-              </a:rPr>
-              <a:t>emisiones.info()     # tipo de cada columna y cuántos no nulos</a:t>
-            </a:r>
-          </a:p>
-        </p:txBody>
-      </p:sp>
-      <p:sp>
-        <p:nvSpPr>
-          <p:cNvPr id="5" name="TextBox 4"/>
+              <a:t>Las tablas y sus llaves</a:t>
+            </a:r>
+          </a:p>
+        </p:txBody>
+      </p:sp>
+      <p:sp>
+        <p:nvSpPr>
+          <p:cNvPr id="4" name="TextBox 3"/>
           <p:cNvSpPr txBox="1"/>
           <p:nvPr/>
         </p:nvSpPr>
         <p:spPr>
           <a:xfrm>
-            <a:off x="704088" y="4389120"/>
-            <a:ext cx="7744968" cy="1097280"/>
+            <a:off x="704088" y="1353312"/>
+            <a:ext cx="7744968" cy="3300984"/>
           </a:xfrm>
           <a:prstGeom prst="rect">
             <a:avLst/>
@@ -7474,7 +6859,7 @@
           <a:lstStyle/>
           <a:p>
             <a:r>
-              <a:rPr sz="1600" b="1">
+              <a:rPr sz="1800" b="1">
                 <a:solidFill>
                   <a:srgbClr val="E0A437"/>
                 </a:solidFill>
@@ -7483,13 +6868,93 @@
               <a:t>▸ </a:t>
             </a:r>
             <a:r>
-              <a:rPr sz="1600" b="0">
+              <a:rPr sz="1800" b="0">
                 <a:solidFill>
                   <a:srgbClr val="3A4A5C"/>
                 </a:solidFill>
                 <a:latin typeface="PT Serif"/>
               </a:rPr>
-              <a:t>Nunca calcule nada antes de saber qué tiene entre manos.</a:t>
+              <a:t>Hogares.csv: una fila por hogar. Llave: Hogar.</a:t>
+            </a:r>
+          </a:p>
+          <a:p>
+            <a:r>
+              <a:rPr sz="1800" b="1">
+                <a:solidFill>
+                  <a:srgbClr val="E0A437"/>
+                </a:solidFill>
+                <a:latin typeface="PT Serif"/>
+              </a:rPr>
+              <a:t>▸ </a:t>
+            </a:r>
+            <a:r>
+              <a:rPr sz="1800" b="0">
+                <a:solidFill>
+                  <a:srgbClr val="3A4A5C"/>
+                </a:solidFill>
+                <a:latin typeface="PT Serif"/>
+              </a:rPr>
+              <a:t>personas.csv: una fila por persona. Llave: Hogar + Persona.</a:t>
+            </a:r>
+          </a:p>
+          <a:p>
+            <a:r>
+              <a:rPr sz="1800" b="1">
+                <a:solidFill>
+                  <a:srgbClr val="E0A437"/>
+                </a:solidFill>
+                <a:latin typeface="PT Serif"/>
+              </a:rPr>
+              <a:t>▸ </a:t>
+            </a:r>
+            <a:r>
+              <a:rPr sz="1800" b="0">
+                <a:solidFill>
+                  <a:srgbClr val="3A4A5C"/>
+                </a:solidFill>
+                <a:latin typeface="PT Serif"/>
+              </a:rPr>
+              <a:t>viajes.csv: una fila por viaje. Llave: Hogar + Persona + Viaje.</a:t>
+            </a:r>
+          </a:p>
+          <a:p>
+            <a:r>
+              <a:rPr sz="1800" b="1">
+                <a:solidFill>
+                  <a:srgbClr val="E0A437"/>
+                </a:solidFill>
+                <a:latin typeface="PT Serif"/>
+              </a:rPr>
+              <a:t>▸ </a:t>
+            </a:r>
+            <a:r>
+              <a:rPr sz="1800" b="0">
+                <a:solidFill>
+                  <a:srgbClr val="3A4A5C"/>
+                </a:solidFill>
+                <a:latin typeface="PT Serif"/>
+              </a:rPr>
+              <a:t>tablas_parametros/: el significado de cada código.</a:t>
+            </a:r>
+          </a:p>
+          <a:p>
+            <a:r>
+              <a:rPr sz="1800" b="1">
+                <a:solidFill>
+                  <a:srgbClr val="E0A437"/>
+                </a:solidFill>
+                <a:latin typeface="PT Serif"/>
+              </a:rPr>
+              <a:t>▸ </a:t>
+            </a:r>
+            <a:r>
+              <a:rPr sz="1800" b="1">
+                <a:solidFill>
+                  <a:srgbClr val="1D3557"/>
+                </a:solidFill>
+                <a:latin typeface="PT Serif"/>
+              </a:rPr>
+              <a:t>Equivocarse de llave es la fuente clásica de merges malos.</a:t>
             </a:r>
           </a:p>
         </p:txBody>
@@ -7527,7 +6992,7 @@
             <a:avLst/>
           </a:prstGeom>
           <a:solidFill>
-            <a:srgbClr val="FAFBFC"/>
+            <a:srgbClr val="1D3557"/>
           </a:solidFill>
           <a:ln>
             <a:noFill/>
@@ -7564,8 +7029,8 @@
         </p:nvSpPr>
         <p:spPr>
           <a:xfrm>
-            <a:off x="402336" y="301752"/>
-            <a:ext cx="8348472" cy="795528"/>
+            <a:off x="603504" y="1847088"/>
+            <a:ext cx="7946136" cy="1399032"/>
           </a:xfrm>
           <a:prstGeom prst="rect">
             <a:avLst/>
@@ -7579,123 +7044,24 @@
           <a:lstStyle/>
           <a:p>
             <a:r>
-              <a:rPr sz="2800" b="1">
-                <a:solidFill>
-                  <a:srgbClr val="0F0F0F"/>
-                </a:solidFill>
-                <a:latin typeface="PT Serif"/>
-              </a:rPr>
-              <a:t>Seleccionar columnas</a:t>
-            </a:r>
-          </a:p>
-        </p:txBody>
-      </p:sp>
-      <p:sp>
-        <p:nvSpPr>
-          <p:cNvPr id="4" name="Rectangle 3"/>
-          <p:cNvSpPr/>
-          <p:nvPr/>
-        </p:nvSpPr>
-        <p:spPr>
-          <a:xfrm>
-            <a:off x="704088" y="1280160"/>
-            <a:ext cx="7744968" cy="1371600"/>
-          </a:xfrm>
-          <a:prstGeom prst="rect">
-            <a:avLst/>
-          </a:prstGeom>
-          <a:solidFill>
-            <a:srgbClr val="F0F2F5"/>
-          </a:solidFill>
-          <a:ln>
-            <a:solidFill>
-              <a:srgbClr val="D8DDE3"/>
-            </a:solidFill>
-          </a:ln>
-          <a:effectLst/>
-        </p:spPr>
-        <p:style>
-          <a:lnRef idx="1">
-            <a:schemeClr val="accent1"/>
-          </a:lnRef>
-          <a:fillRef idx="3">
-            <a:schemeClr val="accent1"/>
-          </a:fillRef>
-          <a:effectRef idx="2">
-            <a:schemeClr val="accent1"/>
-          </a:effectRef>
-          <a:fontRef idx="minor">
-            <a:schemeClr val="lt1"/>
-          </a:fontRef>
-        </p:style>
-        <p:txBody>
-          <a:bodyPr rtlCol="0" anchor="ctr" wrap="square" lIns="228600" tIns="137160"/>
-          <a:lstStyle/>
-          <a:p>
-            <a:pPr/>
-            <a:r>
-              <a:rPr sz="1500" b="0">
-                <a:solidFill>
-                  <a:srgbClr val="1D3557"/>
-                </a:solidFill>
-                <a:latin typeface="Menlo"/>
-              </a:rPr>
-              <a:t>emisiones['region']                      # una Series</a:t>
-            </a:r>
-          </a:p>
-          <a:p>
-            <a:pPr/>
-            <a:r>
-              <a:rPr sz="1500" b="0">
-                <a:solidFill>
-                  <a:srgbClr val="1D3557"/>
-                </a:solidFill>
-                <a:latin typeface="Menlo"/>
-              </a:rPr>
-              <a:t>emisiones[['region', 'comuna']]          # un DataFrame</a:t>
-            </a:r>
-          </a:p>
-        </p:txBody>
-      </p:sp>
-      <p:sp>
-        <p:nvSpPr>
-          <p:cNvPr id="5" name="TextBox 4"/>
-          <p:cNvSpPr txBox="1"/>
-          <p:nvPr/>
-        </p:nvSpPr>
-        <p:spPr>
-          <a:xfrm>
-            <a:off x="704088" y="2880360"/>
-            <a:ext cx="7744968" cy="1097280"/>
-          </a:xfrm>
-          <a:prstGeom prst="rect">
-            <a:avLst/>
-          </a:prstGeom>
-          <a:noFill/>
-        </p:spPr>
-        <p:txBody>
-          <a:bodyPr wrap="square">
-            <a:spAutoFit/>
-          </a:bodyPr>
-          <a:lstStyle/>
-          <a:p>
-            <a:r>
-              <a:rPr sz="1600" b="1">
+              <a:rPr sz="3400" b="1">
+                <a:solidFill>
+                  <a:srgbClr val="FFFFFF"/>
+                </a:solidFill>
+                <a:latin typeface="PT Serif"/>
+              </a:rPr>
+              <a:t>Repaso de Pandas</a:t>
+            </a:r>
+          </a:p>
+          <a:p>
+            <a:r>
+              <a:rPr sz="1800" b="0">
                 <a:solidFill>
                   <a:srgbClr val="E0A437"/>
                 </a:solidFill>
                 <a:latin typeface="PT Serif"/>
               </a:rPr>
-              <a:t>▸ </a:t>
-            </a:r>
-            <a:r>
-              <a:rPr sz="1600" b="0">
-                <a:solidFill>
-                  <a:srgbClr val="3A4A5C"/>
-                </a:solidFill>
-                <a:latin typeface="PT Serif"/>
-              </a:rPr>
-              <a:t>Los dobles corchetes son la lista de nombres dentro de la selección.</a:t>
+              <a:t>Cinco preguntas, cinco herramientas</a:t>
             </a:r>
           </a:p>
         </p:txBody>
@@ -7791,7 +7157,7 @@
                 </a:solidFill>
                 <a:latin typeface="PT Serif"/>
               </a:rPr>
-              <a:t>loc y iloc: no confundirlos</a:t>
+              <a:t>¿A quiénes les preguntaron? Cargar y mirar</a:t>
             </a:r>
           </a:p>
         </p:txBody>
@@ -7805,7 +7171,7 @@
         <p:spPr>
           <a:xfrm>
             <a:off x="704088" y="1280160"/>
-            <a:ext cx="7744968" cy="1371600"/>
+            <a:ext cx="7744968" cy="2880360"/>
           </a:xfrm>
           <a:prstGeom prst="rect">
             <a:avLst/>
@@ -7846,7 +7212,7 @@
                 </a:solidFill>
                 <a:latin typeface="Menlo"/>
               </a:rPr>
-              <a:t>emisiones.iloc[0:3]                      # por posición</a:t>
+              <a:t>personas = pd.read_csv('datos/eod_stgo/personas.csv',</a:t>
             </a:r>
           </a:p>
           <a:p>
@@ -7858,7 +7224,43 @@
                 </a:solidFill>
                 <a:latin typeface="Menlo"/>
               </a:rPr>
-              <a:t>emisiones.loc[0:2, ['region', 'comuna']] # por etiqueta</a:t>
+              <a:t>                       sep=';', decimal=',')</a:t>
+            </a:r>
+          </a:p>
+          <a:p>
+            <a:pPr/>
+            <a:r>
+              <a:rPr sz="1500" b="0">
+                <a:solidFill>
+                  <a:srgbClr val="1D3557"/>
+                </a:solidFill>
+                <a:latin typeface="Menlo"/>
+              </a:rPr>
+              <a:t/>
+            </a:r>
+          </a:p>
+          <a:p>
+            <a:pPr/>
+            <a:r>
+              <a:rPr sz="1500" b="0">
+                <a:solidFill>
+                  <a:srgbClr val="1D3557"/>
+                </a:solidFill>
+                <a:latin typeface="Menlo"/>
+              </a:rPr>
+              <a:t>personas.shape    # 60.054 filas, 39 columnas</a:t>
+            </a:r>
+          </a:p>
+          <a:p>
+            <a:pPr/>
+            <a:r>
+              <a:rPr sz="1500" b="0">
+                <a:solidFill>
+                  <a:srgbClr val="1D3557"/>
+                </a:solidFill>
+                <a:latin typeface="Menlo"/>
+              </a:rPr>
+              <a:t>personas.info()   # tipos y no nulos, siempre antes de calcular</a:t>
             </a:r>
           </a:p>
         </p:txBody>
@@ -7871,7 +7273,7 @@
         </p:nvSpPr>
         <p:spPr>
           <a:xfrm>
-            <a:off x="704088" y="2880360"/>
+            <a:off x="704088" y="4389120"/>
             <a:ext cx="7744968" cy="1097280"/>
           </a:xfrm>
           <a:prstGeom prst="rect">
@@ -7901,7 +7303,7 @@
                 </a:solidFill>
                 <a:latin typeface="PT Serif"/>
               </a:rPr>
-              <a:t>iloc excluye el extremo derecho, como las listas de Python; loc lo incluye.</a:t>
+              <a:t>Estos archivos usan punto y coma como separador y coma decimal: primer hallazgo.</a:t>
             </a:r>
           </a:p>
         </p:txBody>

</xml_diff>

<commit_message>
Rehacer las slides de la clase 02 y ampliar el notebook
Slides: se reduce el codigo a dos casos concretos (merge con tabla de codigos y
conteo sin perder ausentes), se agregan tres diagramas (tablas y llaves, variantes
del merge, factor de expansion) y se hace una pasada de lenguaje para eliminar
superlativos y frases de venta.

Notebook: seccion detallada de las variantes del merge con demostracion sobre
personas y viajes, reparto modal por comuna, ingreso contra uso de transporte
publico, heatmap de rutinas por dia, y una nota breve sobre alternativas a Pandas
para datos que no caben en memoria.

Co-Authored-By: Claude Fable 5 <noreply@anthropic.com>
</commit_message>
<xml_diff>
--- a/presentaciones/clase02_pandas_eda.pptx
+++ b/presentaciones/clase02_pandas_eda.pptx
@@ -26,6 +26,9 @@
     <p:sldId id="274" r:id="rId25"/>
     <p:sldId id="275" r:id="rId26"/>
     <p:sldId id="276" r:id="rId27"/>
+    <p:sldId id="277" r:id="rId28"/>
+    <p:sldId id="278" r:id="rId29"/>
+    <p:sldId id="279" r:id="rId30"/>
   </p:sldIdLst>
   <p:sldSz cx="9144000" cy="5138928" type="screen4x3"/>
   <p:notesSz cx="6858000" cy="9144000"/>
@@ -3375,102 +3378,35 @@
                 </a:solidFill>
                 <a:latin typeface="PT Serif"/>
               </a:rPr>
-              <a:t>¿Quiénes son? Derivar una columna</a:t>
-            </a:r>
-          </a:p>
-        </p:txBody>
-      </p:sp>
-      <p:sp>
-        <p:nvSpPr>
-          <p:cNvPr id="4" name="Rectangle 3"/>
-          <p:cNvSpPr/>
+              <a:t>Las variantes del merge: qué filas sobreviven</a:t>
+            </a:r>
+          </a:p>
+        </p:txBody>
+      </p:sp>
+      <p:pic>
+        <p:nvPicPr>
+          <p:cNvPr id="4" name="Picture 3" descr="07_diagrama_merge.png"/>
+          <p:cNvPicPr>
+            <a:picLocks noChangeAspect="1"/>
+          </p:cNvPicPr>
           <p:nvPr/>
-        </p:nvSpPr>
-        <p:spPr>
-          <a:xfrm>
-            <a:off x="704088" y="1280160"/>
-            <a:ext cx="7744968" cy="2377440"/>
-          </a:xfrm>
-          <a:prstGeom prst="rect">
-            <a:avLst/>
-          </a:prstGeom>
-          <a:solidFill>
-            <a:srgbClr val="F0F2F5"/>
-          </a:solidFill>
-          <a:ln>
-            <a:solidFill>
-              <a:srgbClr val="D8DDE3"/>
-            </a:solidFill>
-          </a:ln>
-          <a:effectLst/>
-        </p:spPr>
-        <p:style>
-          <a:lnRef idx="1">
-            <a:schemeClr val="accent1"/>
-          </a:lnRef>
-          <a:fillRef idx="3">
-            <a:schemeClr val="accent1"/>
-          </a:fillRef>
-          <a:effectRef idx="2">
-            <a:schemeClr val="accent1"/>
-          </a:effectRef>
-          <a:fontRef idx="minor">
-            <a:schemeClr val="lt1"/>
-          </a:fontRef>
-        </p:style>
-        <p:txBody>
-          <a:bodyPr rtlCol="0" anchor="ctr" wrap="square" lIns="228600" tIns="137160"/>
-          <a:lstStyle/>
-          <a:p>
-            <a:pPr/>
-            <a:r>
-              <a:rPr sz="1500" b="0">
-                <a:solidFill>
-                  <a:srgbClr val="1D3557"/>
-                </a:solidFill>
-                <a:latin typeface="Menlo"/>
-              </a:rPr>
-              <a:t>personas['Edad'] = 2013 - personas['AnoNac']</a:t>
-            </a:r>
-          </a:p>
-          <a:p>
-            <a:pPr/>
-            <a:r>
-              <a:rPr sz="1500" b="0">
-                <a:solidFill>
-                  <a:srgbClr val="1D3557"/>
-                </a:solidFill>
-                <a:latin typeface="Menlo"/>
-              </a:rPr>
-              <a:t/>
-            </a:r>
-          </a:p>
-          <a:p>
-            <a:pPr/>
-            <a:r>
-              <a:rPr sz="1500" b="0">
-                <a:solidFill>
-                  <a:srgbClr val="1D3557"/>
-                </a:solidFill>
-                <a:latin typeface="Menlo"/>
-              </a:rPr>
-              <a:t>personas['Edad'].describe()</a:t>
-            </a:r>
-          </a:p>
-          <a:p>
-            <a:pPr/>
-            <a:r>
-              <a:rPr sz="1500" b="0">
-                <a:solidFill>
-                  <a:srgbClr val="1D3557"/>
-                </a:solidFill>
-                <a:latin typeface="Menlo"/>
-              </a:rPr>
-              <a:t>personas['Sexo'].value_counts()   # devuelve 1 y 2...</a:t>
-            </a:r>
-          </a:p>
-        </p:txBody>
-      </p:sp>
+        </p:nvPicPr>
+        <p:blipFill>
+          <a:blip r:embed="rId2"/>
+          <a:stretch>
+            <a:fillRect/>
+          </a:stretch>
+        </p:blipFill>
+        <p:spPr>
+          <a:xfrm>
+            <a:off x="1417319" y="1143000"/>
+            <a:ext cx="6309360" cy="2373039"/>
+          </a:xfrm>
+          <a:prstGeom prst="rect">
+            <a:avLst/>
+          </a:prstGeom>
+        </p:spPr>
+      </p:pic>
       <p:sp>
         <p:nvSpPr>
           <p:cNvPr id="5" name="TextBox 4"/>
@@ -3479,8 +3415,8 @@
         </p:nvSpPr>
         <p:spPr>
           <a:xfrm>
-            <a:off x="704088" y="3886200"/>
-            <a:ext cx="7744968" cy="1097280"/>
+            <a:off x="704088" y="4434840"/>
+            <a:ext cx="7744968" cy="457200"/>
           </a:xfrm>
           <a:prstGeom prst="rect">
             <a:avLst/>
@@ -3494,22 +3430,13 @@
           <a:lstStyle/>
           <a:p>
             <a:r>
-              <a:rPr sz="1600" b="1">
-                <a:solidFill>
-                  <a:srgbClr val="E0A437"/>
-                </a:solidFill>
-                <a:latin typeface="PT Serif"/>
-              </a:rPr>
-              <a:t>▸ </a:t>
-            </a:r>
-            <a:r>
-              <a:rPr sz="1600" b="0">
-                <a:solidFill>
-                  <a:srgbClr val="3A4A5C"/>
-                </a:solidFill>
-                <a:latin typeface="PT Serif"/>
-              </a:rPr>
-              <a:t>No hay columna de edad: se deriva. Y el sexo son códigos que no significan nada solos.</a:t>
+              <a:rPr sz="1300" b="0">
+                <a:solidFill>
+                  <a:srgbClr val="6B7785"/>
+                </a:solidFill>
+                <a:latin typeface="PT Serif"/>
+              </a:rPr>
+              <a:t>El valor por defecto es inner: descarta sin aviso las filas sin pareja.</a:t>
             </a:r>
           </a:p>
         </p:txBody>
@@ -3605,124 +3532,21 @@
                 </a:solidFill>
                 <a:latin typeface="PT Serif"/>
               </a:rPr>
-              <a:t>¿Qué significan los códigos? El merge motivado</a:t>
-            </a:r>
-          </a:p>
-        </p:txBody>
-      </p:sp>
-      <p:sp>
-        <p:nvSpPr>
-          <p:cNvPr id="4" name="Rectangle 3"/>
-          <p:cNvSpPr/>
-          <p:nvPr/>
-        </p:nvSpPr>
-        <p:spPr>
-          <a:xfrm>
-            <a:off x="704088" y="1280160"/>
-            <a:ext cx="7744968" cy="2880360"/>
-          </a:xfrm>
-          <a:prstGeom prst="rect">
-            <a:avLst/>
-          </a:prstGeom>
-          <a:solidFill>
-            <a:srgbClr val="F0F2F5"/>
-          </a:solidFill>
-          <a:ln>
-            <a:solidFill>
-              <a:srgbClr val="D8DDE3"/>
-            </a:solidFill>
-          </a:ln>
-          <a:effectLst/>
-        </p:spPr>
-        <p:style>
-          <a:lnRef idx="1">
-            <a:schemeClr val="accent1"/>
-          </a:lnRef>
-          <a:fillRef idx="3">
-            <a:schemeClr val="accent1"/>
-          </a:fillRef>
-          <a:effectRef idx="2">
-            <a:schemeClr val="accent1"/>
-          </a:effectRef>
-          <a:fontRef idx="minor">
-            <a:schemeClr val="lt1"/>
-          </a:fontRef>
-        </p:style>
-        <p:txBody>
-          <a:bodyPr rtlCol="0" anchor="ctr" wrap="square" lIns="228600" tIns="137160"/>
-          <a:lstStyle/>
-          <a:p>
-            <a:pPr/>
-            <a:r>
-              <a:rPr sz="1500" b="0">
-                <a:solidFill>
-                  <a:srgbClr val="1D3557"/>
-                </a:solidFill>
-                <a:latin typeface="Menlo"/>
-              </a:rPr>
-              <a:t>sexo = pd.read_csv('tablas_parametros/Sexo.csv', sep=';')</a:t>
-            </a:r>
-          </a:p>
-          <a:p>
-            <a:pPr/>
-            <a:r>
-              <a:rPr sz="1500" b="0">
-                <a:solidFill>
-                  <a:srgbClr val="1D3557"/>
-                </a:solidFill>
-                <a:latin typeface="Menlo"/>
-              </a:rPr>
-              <a:t>personas = personas.merge(sexo, left_on='Sexo',</a:t>
-            </a:r>
-          </a:p>
-          <a:p>
-            <a:pPr/>
-            <a:r>
-              <a:rPr sz="1500" b="0">
-                <a:solidFill>
-                  <a:srgbClr val="1D3557"/>
-                </a:solidFill>
-                <a:latin typeface="Menlo"/>
-              </a:rPr>
-              <a:t>                          right_on='Id', how='left')</a:t>
-            </a:r>
-          </a:p>
-          <a:p>
-            <a:pPr/>
-            <a:r>
-              <a:rPr sz="1500" b="0">
-                <a:solidFill>
-                  <a:srgbClr val="1D3557"/>
-                </a:solidFill>
-                <a:latin typeface="Menlo"/>
-              </a:rPr>
-              <a:t/>
-            </a:r>
-          </a:p>
-          <a:p>
-            <a:pPr/>
-            <a:r>
-              <a:rPr sz="1500" b="0">
-                <a:solidFill>
-                  <a:srgbClr val="1D3557"/>
-                </a:solidFill>
-                <a:latin typeface="Menlo"/>
-              </a:rPr>
-              <a:t>personas['Sexo'].isna().sum()   # regla de oro: contar los sin pareja</a:t>
-            </a:r>
-          </a:p>
-        </p:txBody>
-      </p:sp>
-      <p:sp>
-        <p:nvSpPr>
-          <p:cNvPr id="5" name="TextBox 4"/>
+              <a:t>La elección de how define de quién hablan los números</a:t>
+            </a:r>
+          </a:p>
+        </p:txBody>
+      </p:sp>
+      <p:sp>
+        <p:nvSpPr>
+          <p:cNvPr id="4" name="TextBox 3"/>
           <p:cNvSpPr txBox="1"/>
           <p:nvPr/>
         </p:nvSpPr>
         <p:spPr>
           <a:xfrm>
-            <a:off x="704088" y="4389120"/>
-            <a:ext cx="7744968" cy="1097280"/>
+            <a:off x="704088" y="1353312"/>
+            <a:ext cx="7744968" cy="3300984"/>
           </a:xfrm>
           <a:prstGeom prst="rect">
             <a:avLst/>
@@ -3736,7 +3560,7 @@
           <a:lstStyle/>
           <a:p>
             <a:r>
-              <a:rPr sz="1600" b="1">
+              <a:rPr sz="1800" b="1">
                 <a:solidFill>
                   <a:srgbClr val="E0A437"/>
                 </a:solidFill>
@@ -3745,13 +3569,93 @@
               <a:t>▸ </a:t>
             </a:r>
             <a:r>
-              <a:rPr sz="1600" b="0">
+              <a:rPr sz="1800" b="0">
                 <a:solidFill>
                   <a:srgbClr val="3A4A5C"/>
                 </a:solidFill>
                 <a:latin typeface="PT Serif"/>
               </a:rPr>
-              <a:t>Los significados viven en otra tabla: así se diseñan las bases de datos reales.</a:t>
+              <a:t>Personas con viajes, merge inner: 113.591 filas (una por viaje).</a:t>
+            </a:r>
+          </a:p>
+          <a:p>
+            <a:r>
+              <a:rPr sz="1800" b="1">
+                <a:solidFill>
+                  <a:srgbClr val="E0A437"/>
+                </a:solidFill>
+                <a:latin typeface="PT Serif"/>
+              </a:rPr>
+              <a:t>▸ </a:t>
+            </a:r>
+            <a:r>
+              <a:rPr sz="1800" b="0">
+                <a:solidFill>
+                  <a:srgbClr val="3A4A5C"/>
+                </a:solidFill>
+                <a:latin typeface="PT Serif"/>
+              </a:rPr>
+              <a:t>El mismo merge en left: 127.379 filas.</a:t>
+            </a:r>
+          </a:p>
+          <a:p>
+            <a:r>
+              <a:rPr sz="1400" b="0">
+                <a:solidFill>
+                  <a:srgbClr val="6B7785"/>
+                </a:solidFill>
+                <a:latin typeface="PT Serif"/>
+              </a:rPr>
+              <a:t>     ◦  </a:t>
+            </a:r>
+            <a:r>
+              <a:rPr sz="1400" b="0">
+                <a:solidFill>
+                  <a:srgbClr val="6B7785"/>
+                </a:solidFill>
+                <a:latin typeface="PT Serif"/>
+              </a:rPr>
+              <a:t>La diferencia son 13.788 personas que no viajaron ese día.</a:t>
+            </a:r>
+          </a:p>
+          <a:p>
+            <a:r>
+              <a:rPr sz="1400" b="0">
+                <a:solidFill>
+                  <a:srgbClr val="6B7785"/>
+                </a:solidFill>
+                <a:latin typeface="PT Serif"/>
+              </a:rPr>
+              <a:t>     ◦  </a:t>
+            </a:r>
+            <a:r>
+              <a:rPr sz="1400" b="0">
+                <a:solidFill>
+                  <a:srgbClr val="6B7785"/>
+                </a:solidFill>
+                <a:latin typeface="PT Serif"/>
+              </a:rPr>
+              <a:t>Con inner desaparecen; con left quedan, con NaN en el viaje.</a:t>
+            </a:r>
+          </a:p>
+          <a:p>
+            <a:r>
+              <a:rPr sz="1800" b="1">
+                <a:solidFill>
+                  <a:srgbClr val="E0A437"/>
+                </a:solidFill>
+                <a:latin typeface="PT Serif"/>
+              </a:rPr>
+              <a:t>▸ </a:t>
+            </a:r>
+            <a:r>
+              <a:rPr sz="1800" b="1">
+                <a:solidFill>
+                  <a:srgbClr val="1D3557"/>
+                </a:solidFill>
+                <a:latin typeface="PT Serif"/>
+              </a:rPr>
+              <a:t>Un promedio de viajes calculado sobre el inner habla solo de quienes viajan.</a:t>
             </a:r>
           </a:p>
         </p:txBody>
@@ -3847,7 +3751,7 @@
                 </a:solidFill>
                 <a:latin typeface="PT Serif"/>
               </a:rPr>
-              <a:t>¿Cuántos viajes hace una persona? groupby y una trampa</a:t>
+              <a:t>Caso 2: contar sin perder a los que no aparecen</a:t>
             </a:r>
           </a:p>
         </p:txBody>
@@ -3981,7 +3885,7 @@
                 </a:solidFill>
                 <a:latin typeface="PT Serif"/>
               </a:rPr>
-              <a:t>Quien no viajó no aparece en la tabla de viajes: si solo agrupamos, lo perdemos.</a:t>
+              <a:t>El groupby cuenta sobre la tabla de viajes; el fillna(0) trae de vuelta a los ausentes.</a:t>
             </a:r>
           </a:p>
         </p:txBody>
@@ -4160,7 +4064,7 @@
                 </a:solidFill>
                 <a:latin typeface="PT Serif"/>
               </a:rPr>
-              <a:t>Aquí la media quedó BAJO la mediana: el bloque de ceros la arrastra.</a:t>
+              <a:t>Aquí la media quedó bajo la mediana: el bloque de ceros la baja.</a:t>
             </a:r>
           </a:p>
           <a:p>
@@ -4407,21 +4311,45 @@
                 </a:solidFill>
                 <a:latin typeface="PT Serif"/>
               </a:rPr>
-              <a:t>De 37 mil encuestados a 6,7 millones de personas</a:t>
-            </a:r>
-          </a:p>
-        </p:txBody>
-      </p:sp>
-      <p:sp>
-        <p:nvSpPr>
-          <p:cNvPr id="4" name="TextBox 3"/>
+              <a:t>De la muestra a la ciudad</a:t>
+            </a:r>
+          </a:p>
+        </p:txBody>
+      </p:sp>
+      <p:pic>
+        <p:nvPicPr>
+          <p:cNvPr id="4" name="Picture 3" descr="06_diagrama_factores.png"/>
+          <p:cNvPicPr>
+            <a:picLocks noChangeAspect="1"/>
+          </p:cNvPicPr>
+          <p:nvPr/>
+        </p:nvPicPr>
+        <p:blipFill>
+          <a:blip r:embed="rId2"/>
+          <a:stretch>
+            <a:fillRect/>
+          </a:stretch>
+        </p:blipFill>
+        <p:spPr>
+          <a:xfrm>
+            <a:off x="1417319" y="1143000"/>
+            <a:ext cx="6309360" cy="2869563"/>
+          </a:xfrm>
+          <a:prstGeom prst="rect">
+            <a:avLst/>
+          </a:prstGeom>
+        </p:spPr>
+      </p:pic>
+      <p:sp>
+        <p:nvSpPr>
+          <p:cNvPr id="5" name="TextBox 4"/>
           <p:cNvSpPr txBox="1"/>
           <p:nvPr/>
         </p:nvSpPr>
         <p:spPr>
           <a:xfrm>
-            <a:off x="704088" y="1353312"/>
-            <a:ext cx="7744968" cy="3300984"/>
+            <a:off x="704088" y="4434840"/>
+            <a:ext cx="7744968" cy="457200"/>
           </a:xfrm>
           <a:prstGeom prst="rect">
             <a:avLst/>
@@ -4435,122 +4363,13 @@
           <a:lstStyle/>
           <a:p>
             <a:r>
-              <a:rPr sz="1800" b="1">
-                <a:solidFill>
-                  <a:srgbClr val="E0A437"/>
-                </a:solidFill>
-                <a:latin typeface="PT Serif"/>
-              </a:rPr>
-              <a:t>▸ </a:t>
-            </a:r>
-            <a:r>
-              <a:rPr sz="1800" b="0">
-                <a:solidFill>
-                  <a:srgbClr val="3A4A5C"/>
-                </a:solidFill>
-                <a:latin typeface="PT Serif"/>
-              </a:rPr>
-              <a:t>Cada encuestado representa a un número de personas parecidas a él.</a:t>
-            </a:r>
-          </a:p>
-          <a:p>
-            <a:r>
-              <a:rPr sz="1800" b="1">
-                <a:solidFill>
-                  <a:srgbClr val="E0A437"/>
-                </a:solidFill>
-                <a:latin typeface="PT Serif"/>
-              </a:rPr>
-              <a:t>▸ </a:t>
-            </a:r>
-            <a:r>
-              <a:rPr sz="1800" b="0">
-                <a:solidFill>
-                  <a:srgbClr val="3A4A5C"/>
-                </a:solidFill>
-                <a:latin typeface="PT Serif"/>
-              </a:rPr>
-              <a:t>Ese número es su factor de expansión (Factor_LaboralNormal).</a:t>
-            </a:r>
-          </a:p>
-          <a:p>
-            <a:r>
-              <a:rPr sz="1400" b="0">
+              <a:rPr sz="1300" b="0">
                 <a:solidFill>
                   <a:srgbClr val="6B7785"/>
                 </a:solidFill>
                 <a:latin typeface="PT Serif"/>
               </a:rPr>
-              <a:t>     ◦  </a:t>
-            </a:r>
-            <a:r>
-              <a:rPr sz="1400" b="0">
-                <a:solidFill>
-                  <a:srgbClr val="6B7785"/>
-                </a:solidFill>
-                <a:latin typeface="PT Serif"/>
-              </a:rPr>
-              <a:t>37.326 personas con factor de día laboral en temporada normal.</a:t>
-            </a:r>
-          </a:p>
-          <a:p>
-            <a:r>
-              <a:rPr sz="1400" b="0">
-                <a:solidFill>
-                  <a:srgbClr val="6B7785"/>
-                </a:solidFill>
-                <a:latin typeface="PT Serif"/>
-              </a:rPr>
-              <a:t>     ◦  </a:t>
-            </a:r>
-            <a:r>
-              <a:rPr sz="1400" b="0">
-                <a:solidFill>
-                  <a:srgbClr val="6B7785"/>
-                </a:solidFill>
-                <a:latin typeface="PT Serif"/>
-              </a:rPr>
-              <a:t>La suma de sus factores: 6.651.735 personas representadas.</a:t>
-            </a:r>
-          </a:p>
-          <a:p>
-            <a:r>
-              <a:rPr sz="1800" b="1">
-                <a:solidFill>
-                  <a:srgbClr val="E0A437"/>
-                </a:solidFill>
-                <a:latin typeface="PT Serif"/>
-              </a:rPr>
-              <a:t>▸ </a:t>
-            </a:r>
-            <a:r>
-              <a:rPr sz="1800" b="0">
-                <a:solidFill>
-                  <a:srgbClr val="3A4A5C"/>
-                </a:solidFill>
-                <a:latin typeface="PT Serif"/>
-              </a:rPr>
               <a:t>Contar filas responde por la muestra; sumar factores responde por la ciudad.</a:t>
-            </a:r>
-          </a:p>
-          <a:p>
-            <a:r>
-              <a:rPr sz="1800" b="1">
-                <a:solidFill>
-                  <a:srgbClr val="E0A437"/>
-                </a:solidFill>
-                <a:latin typeface="PT Serif"/>
-              </a:rPr>
-              <a:t>▸ </a:t>
-            </a:r>
-            <a:r>
-              <a:rPr sz="1800" b="1">
-                <a:solidFill>
-                  <a:srgbClr val="1D3557"/>
-                </a:solidFill>
-                <a:latin typeface="PT Serif"/>
-              </a:rPr>
-              <a:t>Toda cifra oficial de la EOD, la Casen o la ENUSC está ponderada así.</a:t>
             </a:r>
           </a:p>
         </p:txBody>
@@ -4836,7 +4655,7 @@
                 </a:solidFill>
                 <a:latin typeface="PT Serif"/>
               </a:rPr>
-              <a:t>Unos pocos hogares de ingresos muy altos arrastran el promedio.</a:t>
+              <a:t>Los ingresos altos desplazan el promedio; la mayoría gana menos.</a:t>
             </a:r>
           </a:p>
           <a:p>
@@ -4856,7 +4675,7 @@
                 </a:solidFill>
                 <a:latin typeface="PT Serif"/>
               </a:rPr>
-              <a:t>'El hogar promedio gana $688 mil' describe una situación en la que la mayoría no está.</a:t>
+              <a:t>El promedio describe una situación en la que la mayoría no está.</a:t>
             </a:r>
           </a:p>
         </p:txBody>
@@ -5079,7 +4898,7 @@
                 </a:solidFill>
                 <a:latin typeface="PT Serif"/>
               </a:rPr>
-              <a:t>Los valores extremos no se borran por molestos: se investigan y la decisión se declara.</a:t>
+              <a:t>Los valores extremos se investigan y la decisión se declara.</a:t>
             </a:r>
           </a:p>
         </p:txBody>
@@ -5322,7 +5141,7 @@
                 </a:solidFill>
                 <a:latin typeface="PT Serif"/>
               </a:rPr>
-              <a:t>Esta es la partición modal oficial, calculada por nosotros desde los microdatos.</a:t>
+              <a:t>La partición modal de un día laboral, calculada desde los microdatos.</a:t>
             </a:r>
           </a:p>
         </p:txBody>
@@ -5485,7 +5304,7 @@
                 </a:solidFill>
                 <a:latin typeface="PT Serif"/>
               </a:rPr>
-              <a:t>Le haremos preguntas reales a la Encuesta Origen Destino de Santiago.</a:t>
+              <a:t>Le haremos preguntas a la Encuesta Origen Destino de Santiago 2012.</a:t>
             </a:r>
           </a:p>
           <a:p>
@@ -5505,7 +5324,7 @@
                 </a:solidFill>
                 <a:latin typeface="PT Serif"/>
               </a:rPr>
-              <a:t>Cada pregunta trae su herramienta: el repaso de Pandas va en el camino.</a:t>
+              <a:t>El repaso de Pandas va en el camino: cada pregunta trae su herramienta.</a:t>
             </a:r>
           </a:p>
           <a:p>
@@ -5525,7 +5344,7 @@
                 </a:solidFill>
                 <a:latin typeface="PT Serif"/>
               </a:rPr>
-              <a:t>Cargar y mirar, derivar columnas, filtrar, merge, groupby.</a:t>
+              <a:t>Merge y sus variantes, groupby, medidas de resumen.</a:t>
             </a:r>
           </a:p>
           <a:p>
@@ -5546,26 +5365,6 @@
                 <a:latin typeface="PT Serif"/>
               </a:rPr>
               <a:t>Lo probablemente nuevo: tablas de códigos y factores de expansión.</a:t>
-            </a:r>
-          </a:p>
-          <a:p>
-            <a:r>
-              <a:rPr sz="1800" b="1">
-                <a:solidFill>
-                  <a:srgbClr val="E0A437"/>
-                </a:solidFill>
-                <a:latin typeface="PT Serif"/>
-              </a:rPr>
-              <a:t>▸ </a:t>
-            </a:r>
-            <a:r>
-              <a:rPr sz="1800" b="0">
-                <a:solidFill>
-                  <a:srgbClr val="3A4A5C"/>
-                </a:solidFill>
-                <a:latin typeface="PT Serif"/>
-              </a:rPr>
-              <a:t>Inicio del análisis exploratorio: qué número resume bien una respuesta.</a:t>
             </a:r>
           </a:p>
           <a:p>
@@ -5681,21 +5480,45 @@
                 </a:solidFill>
                 <a:latin typeface="PT Serif"/>
               </a:rPr>
-              <a:t>Síntesis: ¿de quién habla este número?</a:t>
-            </a:r>
-          </a:p>
-        </p:txBody>
-      </p:sp>
-      <p:sp>
-        <p:nvSpPr>
-          <p:cNvPr id="4" name="TextBox 3"/>
+              <a:t>¿Se mueve igual toda la ciudad?</a:t>
+            </a:r>
+          </a:p>
+        </p:txBody>
+      </p:sp>
+      <p:pic>
+        <p:nvPicPr>
+          <p:cNvPr id="4" name="Picture 3" descr="08_modo_por_comuna.png"/>
+          <p:cNvPicPr>
+            <a:picLocks noChangeAspect="1"/>
+          </p:cNvPicPr>
+          <p:nvPr/>
+        </p:nvPicPr>
+        <p:blipFill>
+          <a:blip r:embed="rId2"/>
+          <a:stretch>
+            <a:fillRect/>
+          </a:stretch>
+        </p:blipFill>
+        <p:spPr>
+          <a:xfrm>
+            <a:off x="2011818" y="1143000"/>
+            <a:ext cx="5120362" cy="3154680"/>
+          </a:xfrm>
+          <a:prstGeom prst="rect">
+            <a:avLst/>
+          </a:prstGeom>
+        </p:spPr>
+      </p:pic>
+      <p:sp>
+        <p:nvSpPr>
+          <p:cNvPr id="5" name="TextBox 4"/>
           <p:cNvSpPr txBox="1"/>
           <p:nvPr/>
         </p:nvSpPr>
         <p:spPr>
           <a:xfrm>
-            <a:off x="704088" y="1353312"/>
-            <a:ext cx="7744968" cy="3300984"/>
+            <a:off x="704088" y="4434840"/>
+            <a:ext cx="7744968" cy="457200"/>
           </a:xfrm>
           <a:prstGeom prst="rect">
             <a:avLst/>
@@ -5709,102 +5532,13 @@
           <a:lstStyle/>
           <a:p>
             <a:r>
-              <a:rPr sz="1800" b="1">
-                <a:solidFill>
-                  <a:srgbClr val="E0A437"/>
-                </a:solidFill>
-                <a:latin typeface="PT Serif"/>
-              </a:rPr>
-              <a:t>▸ </a:t>
-            </a:r>
-            <a:r>
-              <a:rPr sz="1800" b="0">
-                <a:solidFill>
-                  <a:srgbClr val="3A4A5C"/>
-                </a:solidFill>
-                <a:latin typeface="PT Serif"/>
-              </a:rPr>
-              <a:t>'El hogar promedio gana $688 mil': de casi nadie; la mediana habla del hogar típico.</a:t>
-            </a:r>
-          </a:p>
-          <a:p>
-            <a:r>
-              <a:rPr sz="1800" b="1">
-                <a:solidFill>
-                  <a:srgbClr val="E0A437"/>
-                </a:solidFill>
-                <a:latin typeface="PT Serif"/>
-              </a:rPr>
-              <a:t>▸ </a:t>
-            </a:r>
-            <a:r>
-              <a:rPr sz="1800" b="0">
-                <a:solidFill>
-                  <a:srgbClr val="3A4A5C"/>
-                </a:solidFill>
-                <a:latin typeface="PT Serif"/>
-              </a:rPr>
-              <a:t>'El 53% de los encuestados...': de la muestra; los factores de expansión hablan de la ciudad.</a:t>
-            </a:r>
-          </a:p>
-          <a:p>
-            <a:r>
-              <a:rPr sz="1800" b="1">
-                <a:solidFill>
-                  <a:srgbClr val="E0A437"/>
-                </a:solidFill>
-                <a:latin typeface="PT Serif"/>
-              </a:rPr>
-              <a:t>▸ </a:t>
-            </a:r>
-            <a:r>
-              <a:rPr sz="1800" b="0">
-                <a:solidFill>
-                  <a:srgbClr val="3A4A5C"/>
-                </a:solidFill>
-                <a:latin typeface="PT Serif"/>
-              </a:rPr>
-              <a:t>'1,9 viajes en promedio': solo si contamos a quienes no viajaron y no estaban en la tabla.</a:t>
-            </a:r>
-          </a:p>
-          <a:p>
-            <a:r>
-              <a:rPr sz="1800" b="1">
-                <a:solidFill>
-                  <a:srgbClr val="E0A437"/>
-                </a:solidFill>
-                <a:latin typeface="PT Serif"/>
-              </a:rPr>
-              <a:t>▸ </a:t>
-            </a:r>
-            <a:r>
-              <a:rPr sz="1800" b="0">
-                <a:solidFill>
-                  <a:srgbClr val="3A4A5C"/>
-                </a:solidFill>
-                <a:latin typeface="PT Serif"/>
-              </a:rPr>
-              <a:t>'El sexo es 1 o 2': sin su tabla de códigos, un número no habla de nada.</a:t>
-            </a:r>
-          </a:p>
-          <a:p>
-            <a:r>
-              <a:rPr sz="1800" b="1">
-                <a:solidFill>
-                  <a:srgbClr val="E0A437"/>
-                </a:solidFill>
-                <a:latin typeface="PT Serif"/>
-              </a:rPr>
-              <a:t>▸ </a:t>
-            </a:r>
-            <a:r>
-              <a:rPr sz="1800" b="1">
-                <a:solidFill>
-                  <a:srgbClr val="1D3557"/>
-                </a:solidFill>
-                <a:latin typeface="PT Serif"/>
-              </a:rPr>
-              <a:t>La técnica era repaso; el hábito de interrogar cada cifra es lo que se llevan.</a:t>
+              <a:rPr sz="1300" b="0">
+                <a:solidFill>
+                  <a:srgbClr val="6B7785"/>
+                </a:solidFill>
+                <a:latin typeface="PT Serif"/>
+              </a:rPr>
+              <a:t>Normalizar por comuna permite comparar proporciones entre comunas de tamaños muy distintos.</a:t>
             </a:r>
           </a:p>
         </p:txBody>
@@ -5900,6 +5634,622 @@
                 </a:solidFill>
                 <a:latin typeface="PT Serif"/>
               </a:rPr>
+              <a:t>¿El ingreso explica el uso de transporte público?</a:t>
+            </a:r>
+          </a:p>
+        </p:txBody>
+      </p:sp>
+      <p:sp>
+        <p:nvSpPr>
+          <p:cNvPr id="4" name="TextBox 3"/>
+          <p:cNvSpPr txBox="1"/>
+          <p:nvPr/>
+        </p:nvSpPr>
+        <p:spPr>
+          <a:xfrm>
+            <a:off x="502920" y="1252728"/>
+            <a:ext cx="4023360" cy="3200400"/>
+          </a:xfrm>
+          <a:prstGeom prst="rect">
+            <a:avLst/>
+          </a:prstGeom>
+          <a:noFill/>
+        </p:spPr>
+        <p:txBody>
+          <a:bodyPr wrap="square">
+            <a:spAutoFit/>
+          </a:bodyPr>
+          <a:lstStyle/>
+          <a:p>
+            <a:r>
+              <a:rPr sz="1500" b="1">
+                <a:solidFill>
+                  <a:srgbClr val="E0A437"/>
+                </a:solidFill>
+                <a:latin typeface="PT Serif"/>
+              </a:rPr>
+              <a:t>▸ </a:t>
+            </a:r>
+            <a:r>
+              <a:rPr sz="1500" b="0">
+                <a:solidFill>
+                  <a:srgbClr val="3A4A5C"/>
+                </a:solidFill>
+                <a:latin typeface="PT Serif"/>
+              </a:rPr>
+              <a:t>Cada punto es una comuna: ingreso medio contra proporción de viajes en transporte público.</a:t>
+            </a:r>
+          </a:p>
+          <a:p>
+            <a:r>
+              <a:rPr sz="1300" b="0">
+                <a:solidFill>
+                  <a:srgbClr val="6B7785"/>
+                </a:solidFill>
+                <a:latin typeface="PT Serif"/>
+              </a:rPr>
+              <a:t>     ◦  </a:t>
+            </a:r>
+            <a:r>
+              <a:rPr sz="1300" b="0">
+                <a:solidFill>
+                  <a:srgbClr val="6B7785"/>
+                </a:solidFill>
+                <a:latin typeface="PT Serif"/>
+              </a:rPr>
+              <a:t>Periferia (Buin, Melipilla): poco transporte público porque la red no llega.</a:t>
+            </a:r>
+          </a:p>
+          <a:p>
+            <a:r>
+              <a:rPr sz="1300" b="0">
+                <a:solidFill>
+                  <a:srgbClr val="6B7785"/>
+                </a:solidFill>
+                <a:latin typeface="PT Serif"/>
+              </a:rPr>
+              <a:t>     ◦  </a:t>
+            </a:r>
+            <a:r>
+              <a:rPr sz="1300" b="0">
+                <a:solidFill>
+                  <a:srgbClr val="6B7785"/>
+                </a:solidFill>
+                <a:latin typeface="PT Serif"/>
+              </a:rPr>
+              <a:t>Ingresos altos (Vitacura, Lo Barnechea): conectadas, pero con poco uso.</a:t>
+            </a:r>
+          </a:p>
+          <a:p>
+            <a:r>
+              <a:rPr sz="1300" b="0">
+                <a:solidFill>
+                  <a:srgbClr val="6B7785"/>
+                </a:solidFill>
+                <a:latin typeface="PT Serif"/>
+              </a:rPr>
+              <a:t>     ◦  </a:t>
+            </a:r>
+            <a:r>
+              <a:rPr sz="1300" b="0">
+                <a:solidFill>
+                  <a:srgbClr val="6B7785"/>
+                </a:solidFill>
+                <a:latin typeface="PT Serif"/>
+              </a:rPr>
+              <a:t>La Pintana o Conchalí superan el 45%.</a:t>
+            </a:r>
+          </a:p>
+          <a:p>
+            <a:r>
+              <a:rPr sz="1500" b="1">
+                <a:solidFill>
+                  <a:srgbClr val="E0A437"/>
+                </a:solidFill>
+                <a:latin typeface="PT Serif"/>
+              </a:rPr>
+              <a:t>▸ </a:t>
+            </a:r>
+            <a:r>
+              <a:rPr sz="1500" b="1">
+                <a:solidFill>
+                  <a:srgbClr val="1D3557"/>
+                </a:solidFill>
+                <a:latin typeface="PT Serif"/>
+              </a:rPr>
+              <a:t>Un promedio comunal también esconde variación: ¿de quién habla ese punto?</a:t>
+            </a:r>
+          </a:p>
+        </p:txBody>
+      </p:sp>
+      <p:pic>
+        <p:nvPicPr>
+          <p:cNvPr id="5" name="Picture 4" descr="09_ingreso_vs_tp.png"/>
+          <p:cNvPicPr>
+            <a:picLocks noChangeAspect="1"/>
+          </p:cNvPicPr>
+          <p:nvPr/>
+        </p:nvPicPr>
+        <p:blipFill>
+          <a:blip r:embed="rId2"/>
+          <a:stretch>
+            <a:fillRect/>
+          </a:stretch>
+        </p:blipFill>
+        <p:spPr>
+          <a:xfrm>
+            <a:off x="4892040" y="1371600"/>
+            <a:ext cx="3840480" cy="2551368"/>
+          </a:xfrm>
+          <a:prstGeom prst="rect">
+            <a:avLst/>
+          </a:prstGeom>
+        </p:spPr>
+      </p:pic>
+    </p:spTree>
+  </p:cSld>
+  <p:clrMapOvr>
+    <a:masterClrMapping/>
+  </p:clrMapOvr>
+</p:sld>
+</file>
+
+<file path=ppt/slides/slide22.xml><?xml version="1.0" encoding="utf-8"?>
+<p:sld xmlns:a="http://schemas.openxmlformats.org/drawingml/2006/main" xmlns:p="http://schemas.openxmlformats.org/presentationml/2006/main" xmlns:r="http://schemas.openxmlformats.org/officeDocument/2006/relationships">
+  <p:cSld>
+    <p:spTree>
+      <p:nvGrpSpPr>
+        <p:cNvPr id="1" name=""/>
+        <p:cNvGrpSpPr/>
+        <p:nvPr/>
+      </p:nvGrpSpPr>
+      <p:grpSpPr/>
+      <p:sp>
+        <p:nvSpPr>
+          <p:cNvPr id="2" name="Rectangle 1"/>
+          <p:cNvSpPr/>
+          <p:nvPr/>
+        </p:nvSpPr>
+        <p:spPr>
+          <a:xfrm>
+            <a:off x="0" y="0"/>
+            <a:ext cx="9144000" cy="5138928"/>
+          </a:xfrm>
+          <a:prstGeom prst="rect">
+            <a:avLst/>
+          </a:prstGeom>
+          <a:solidFill>
+            <a:srgbClr val="FAFBFC"/>
+          </a:solidFill>
+          <a:ln>
+            <a:noFill/>
+          </a:ln>
+          <a:effectLst/>
+        </p:spPr>
+        <p:style>
+          <a:lnRef idx="1">
+            <a:schemeClr val="accent1"/>
+          </a:lnRef>
+          <a:fillRef idx="3">
+            <a:schemeClr val="accent1"/>
+          </a:fillRef>
+          <a:effectRef idx="2">
+            <a:schemeClr val="accent1"/>
+          </a:effectRef>
+          <a:fontRef idx="minor">
+            <a:schemeClr val="lt1"/>
+          </a:fontRef>
+        </p:style>
+        <p:txBody>
+          <a:bodyPr rtlCol="0" anchor="ctr"/>
+          <a:lstStyle/>
+          <a:p>
+            <a:pPr algn="ctr"/>
+          </a:p>
+        </p:txBody>
+      </p:sp>
+      <p:sp>
+        <p:nvSpPr>
+          <p:cNvPr id="3" name="TextBox 2"/>
+          <p:cNvSpPr txBox="1"/>
+          <p:nvPr/>
+        </p:nvSpPr>
+        <p:spPr>
+          <a:xfrm>
+            <a:off x="402336" y="301752"/>
+            <a:ext cx="8348472" cy="795528"/>
+          </a:xfrm>
+          <a:prstGeom prst="rect">
+            <a:avLst/>
+          </a:prstGeom>
+          <a:noFill/>
+        </p:spPr>
+        <p:txBody>
+          <a:bodyPr wrap="square">
+            <a:spAutoFit/>
+          </a:bodyPr>
+          <a:lstStyle/>
+          <a:p>
+            <a:r>
+              <a:rPr sz="2800" b="1">
+                <a:solidFill>
+                  <a:srgbClr val="0F0F0F"/>
+                </a:solidFill>
+                <a:latin typeface="PT Serif"/>
+              </a:rPr>
+              <a:t>¿Cambian las rutinas durante la semana?</a:t>
+            </a:r>
+          </a:p>
+        </p:txBody>
+      </p:sp>
+      <p:pic>
+        <p:nvPicPr>
+          <p:cNvPr id="4" name="Picture 3" descr="10_heatmap_rutinas.png"/>
+          <p:cNvPicPr>
+            <a:picLocks noChangeAspect="1"/>
+          </p:cNvPicPr>
+          <p:nvPr/>
+        </p:nvPicPr>
+        <p:blipFill>
+          <a:blip r:embed="rId2"/>
+          <a:stretch>
+            <a:fillRect/>
+          </a:stretch>
+        </p:blipFill>
+        <p:spPr>
+          <a:xfrm>
+            <a:off x="1631108" y="1143000"/>
+            <a:ext cx="5881783" cy="3154680"/>
+          </a:xfrm>
+          <a:prstGeom prst="rect">
+            <a:avLst/>
+          </a:prstGeom>
+        </p:spPr>
+      </p:pic>
+      <p:sp>
+        <p:nvSpPr>
+          <p:cNvPr id="5" name="TextBox 4"/>
+          <p:cNvSpPr txBox="1"/>
+          <p:nvPr/>
+        </p:nvSpPr>
+        <p:spPr>
+          <a:xfrm>
+            <a:off x="704088" y="4434840"/>
+            <a:ext cx="7744968" cy="457200"/>
+          </a:xfrm>
+          <a:prstGeom prst="rect">
+            <a:avLst/>
+          </a:prstGeom>
+          <a:noFill/>
+        </p:spPr>
+        <p:txBody>
+          <a:bodyPr wrap="square">
+            <a:spAutoFit/>
+          </a:bodyPr>
+          <a:lstStyle/>
+          <a:p>
+            <a:r>
+              <a:rPr sz="1300" b="0">
+                <a:solidFill>
+                  <a:srgbClr val="6B7785"/>
+                </a:solidFill>
+                <a:latin typeface="PT Serif"/>
+              </a:rPr>
+              <a:t>El heatmap muestra 14 propósitos por 7 días en una sola figura: útil para tablas completas.</a:t>
+            </a:r>
+          </a:p>
+        </p:txBody>
+      </p:sp>
+    </p:spTree>
+  </p:cSld>
+  <p:clrMapOvr>
+    <a:masterClrMapping/>
+  </p:clrMapOvr>
+</p:sld>
+</file>
+
+<file path=ppt/slides/slide23.xml><?xml version="1.0" encoding="utf-8"?>
+<p:sld xmlns:a="http://schemas.openxmlformats.org/drawingml/2006/main" xmlns:p="http://schemas.openxmlformats.org/presentationml/2006/main" xmlns:r="http://schemas.openxmlformats.org/officeDocument/2006/relationships">
+  <p:cSld>
+    <p:spTree>
+      <p:nvGrpSpPr>
+        <p:cNvPr id="1" name=""/>
+        <p:cNvGrpSpPr/>
+        <p:nvPr/>
+      </p:nvGrpSpPr>
+      <p:grpSpPr/>
+      <p:sp>
+        <p:nvSpPr>
+          <p:cNvPr id="2" name="Rectangle 1"/>
+          <p:cNvSpPr/>
+          <p:nvPr/>
+        </p:nvSpPr>
+        <p:spPr>
+          <a:xfrm>
+            <a:off x="0" y="0"/>
+            <a:ext cx="9144000" cy="5138928"/>
+          </a:xfrm>
+          <a:prstGeom prst="rect">
+            <a:avLst/>
+          </a:prstGeom>
+          <a:solidFill>
+            <a:srgbClr val="FAFBFC"/>
+          </a:solidFill>
+          <a:ln>
+            <a:noFill/>
+          </a:ln>
+          <a:effectLst/>
+        </p:spPr>
+        <p:style>
+          <a:lnRef idx="1">
+            <a:schemeClr val="accent1"/>
+          </a:lnRef>
+          <a:fillRef idx="3">
+            <a:schemeClr val="accent1"/>
+          </a:fillRef>
+          <a:effectRef idx="2">
+            <a:schemeClr val="accent1"/>
+          </a:effectRef>
+          <a:fontRef idx="minor">
+            <a:schemeClr val="lt1"/>
+          </a:fontRef>
+        </p:style>
+        <p:txBody>
+          <a:bodyPr rtlCol="0" anchor="ctr"/>
+          <a:lstStyle/>
+          <a:p>
+            <a:pPr algn="ctr"/>
+          </a:p>
+        </p:txBody>
+      </p:sp>
+      <p:sp>
+        <p:nvSpPr>
+          <p:cNvPr id="3" name="TextBox 2"/>
+          <p:cNvSpPr txBox="1"/>
+          <p:nvPr/>
+        </p:nvSpPr>
+        <p:spPr>
+          <a:xfrm>
+            <a:off x="402336" y="301752"/>
+            <a:ext cx="8348472" cy="795528"/>
+          </a:xfrm>
+          <a:prstGeom prst="rect">
+            <a:avLst/>
+          </a:prstGeom>
+          <a:noFill/>
+        </p:spPr>
+        <p:txBody>
+          <a:bodyPr wrap="square">
+            <a:spAutoFit/>
+          </a:bodyPr>
+          <a:lstStyle/>
+          <a:p>
+            <a:r>
+              <a:rPr sz="2800" b="1">
+                <a:solidFill>
+                  <a:srgbClr val="0F0F0F"/>
+                </a:solidFill>
+                <a:latin typeface="PT Serif"/>
+              </a:rPr>
+              <a:t>Síntesis: ¿de quién habla este número?</a:t>
+            </a:r>
+          </a:p>
+        </p:txBody>
+      </p:sp>
+      <p:sp>
+        <p:nvSpPr>
+          <p:cNvPr id="4" name="TextBox 3"/>
+          <p:cNvSpPr txBox="1"/>
+          <p:nvPr/>
+        </p:nvSpPr>
+        <p:spPr>
+          <a:xfrm>
+            <a:off x="704088" y="1353312"/>
+            <a:ext cx="7744968" cy="3300984"/>
+          </a:xfrm>
+          <a:prstGeom prst="rect">
+            <a:avLst/>
+          </a:prstGeom>
+          <a:noFill/>
+        </p:spPr>
+        <p:txBody>
+          <a:bodyPr wrap="square">
+            <a:spAutoFit/>
+          </a:bodyPr>
+          <a:lstStyle/>
+          <a:p>
+            <a:r>
+              <a:rPr sz="1800" b="1">
+                <a:solidFill>
+                  <a:srgbClr val="E0A437"/>
+                </a:solidFill>
+                <a:latin typeface="PT Serif"/>
+              </a:rPr>
+              <a:t>▸ </a:t>
+            </a:r>
+            <a:r>
+              <a:rPr sz="1800" b="0">
+                <a:solidFill>
+                  <a:srgbClr val="3A4A5C"/>
+                </a:solidFill>
+                <a:latin typeface="PT Serif"/>
+              </a:rPr>
+              <a:t>'El hogar promedio gana $688 mil': la mayoría gana menos; la mediana describe al hogar típico.</a:t>
+            </a:r>
+          </a:p>
+          <a:p>
+            <a:r>
+              <a:rPr sz="1800" b="1">
+                <a:solidFill>
+                  <a:srgbClr val="E0A437"/>
+                </a:solidFill>
+                <a:latin typeface="PT Serif"/>
+              </a:rPr>
+              <a:t>▸ </a:t>
+            </a:r>
+            <a:r>
+              <a:rPr sz="1800" b="0">
+                <a:solidFill>
+                  <a:srgbClr val="3A4A5C"/>
+                </a:solidFill>
+                <a:latin typeface="PT Serif"/>
+              </a:rPr>
+              <a:t>'El 53% de los encuestados...': habla de la muestra; los factores de expansión hablan de la ciudad.</a:t>
+            </a:r>
+          </a:p>
+          <a:p>
+            <a:r>
+              <a:rPr sz="1800" b="1">
+                <a:solidFill>
+                  <a:srgbClr val="E0A437"/>
+                </a:solidFill>
+                <a:latin typeface="PT Serif"/>
+              </a:rPr>
+              <a:t>▸ </a:t>
+            </a:r>
+            <a:r>
+              <a:rPr sz="1800" b="0">
+                <a:solidFill>
+                  <a:srgbClr val="3A4A5C"/>
+                </a:solidFill>
+                <a:latin typeface="PT Serif"/>
+              </a:rPr>
+              <a:t>'1,9 viajes en promedio': solo si contamos a quienes no viajaron; un inner los borra sin aviso.</a:t>
+            </a:r>
+          </a:p>
+          <a:p>
+            <a:r>
+              <a:rPr sz="1800" b="1">
+                <a:solidFill>
+                  <a:srgbClr val="E0A437"/>
+                </a:solidFill>
+                <a:latin typeface="PT Serif"/>
+              </a:rPr>
+              <a:t>▸ </a:t>
+            </a:r>
+            <a:r>
+              <a:rPr sz="1800" b="0">
+                <a:solidFill>
+                  <a:srgbClr val="3A4A5C"/>
+                </a:solidFill>
+                <a:latin typeface="PT Serif"/>
+              </a:rPr>
+              <a:t>'En Vitacura casi no se usa transporte público': un promedio comunal esconde la variación interna.</a:t>
+            </a:r>
+          </a:p>
+          <a:p>
+            <a:r>
+              <a:rPr sz="1800" b="1">
+                <a:solidFill>
+                  <a:srgbClr val="E0A437"/>
+                </a:solidFill>
+                <a:latin typeface="PT Serif"/>
+              </a:rPr>
+              <a:t>▸ </a:t>
+            </a:r>
+            <a:r>
+              <a:rPr sz="1800" b="1">
+                <a:solidFill>
+                  <a:srgbClr val="1D3557"/>
+                </a:solidFill>
+                <a:latin typeface="PT Serif"/>
+              </a:rPr>
+              <a:t>La técnica era repaso; el hábito de examinar cada cifra es lo nuevo.</a:t>
+            </a:r>
+          </a:p>
+        </p:txBody>
+      </p:sp>
+    </p:spTree>
+  </p:cSld>
+  <p:clrMapOvr>
+    <a:masterClrMapping/>
+  </p:clrMapOvr>
+</p:sld>
+</file>
+
+<file path=ppt/slides/slide24.xml><?xml version="1.0" encoding="utf-8"?>
+<p:sld xmlns:a="http://schemas.openxmlformats.org/drawingml/2006/main" xmlns:p="http://schemas.openxmlformats.org/presentationml/2006/main" xmlns:r="http://schemas.openxmlformats.org/officeDocument/2006/relationships">
+  <p:cSld>
+    <p:spTree>
+      <p:nvGrpSpPr>
+        <p:cNvPr id="1" name=""/>
+        <p:cNvGrpSpPr/>
+        <p:nvPr/>
+      </p:nvGrpSpPr>
+      <p:grpSpPr/>
+      <p:sp>
+        <p:nvSpPr>
+          <p:cNvPr id="2" name="Rectangle 1"/>
+          <p:cNvSpPr/>
+          <p:nvPr/>
+        </p:nvSpPr>
+        <p:spPr>
+          <a:xfrm>
+            <a:off x="0" y="0"/>
+            <a:ext cx="9144000" cy="5138928"/>
+          </a:xfrm>
+          <a:prstGeom prst="rect">
+            <a:avLst/>
+          </a:prstGeom>
+          <a:solidFill>
+            <a:srgbClr val="FAFBFC"/>
+          </a:solidFill>
+          <a:ln>
+            <a:noFill/>
+          </a:ln>
+          <a:effectLst/>
+        </p:spPr>
+        <p:style>
+          <a:lnRef idx="1">
+            <a:schemeClr val="accent1"/>
+          </a:lnRef>
+          <a:fillRef idx="3">
+            <a:schemeClr val="accent1"/>
+          </a:fillRef>
+          <a:effectRef idx="2">
+            <a:schemeClr val="accent1"/>
+          </a:effectRef>
+          <a:fontRef idx="minor">
+            <a:schemeClr val="lt1"/>
+          </a:fontRef>
+        </p:style>
+        <p:txBody>
+          <a:bodyPr rtlCol="0" anchor="ctr"/>
+          <a:lstStyle/>
+          <a:p>
+            <a:pPr algn="ctr"/>
+          </a:p>
+        </p:txBody>
+      </p:sp>
+      <p:sp>
+        <p:nvSpPr>
+          <p:cNvPr id="3" name="TextBox 2"/>
+          <p:cNvSpPr txBox="1"/>
+          <p:nvPr/>
+        </p:nvSpPr>
+        <p:spPr>
+          <a:xfrm>
+            <a:off x="402336" y="301752"/>
+            <a:ext cx="8348472" cy="795528"/>
+          </a:xfrm>
+          <a:prstGeom prst="rect">
+            <a:avLst/>
+          </a:prstGeom>
+          <a:noFill/>
+        </p:spPr>
+        <p:txBody>
+          <a:bodyPr wrap="square">
+            <a:spAutoFit/>
+          </a:bodyPr>
+          <a:lstStyle/>
+          <a:p>
+            <a:r>
+              <a:rPr sz="2800" b="1">
+                <a:solidFill>
+                  <a:srgbClr val="0F0F0F"/>
+                </a:solidFill>
+                <a:latin typeface="PT Serif"/>
+              </a:rPr>
               <a:t>Segundo bloque: parte la Tarea 1</a:t>
             </a:r>
           </a:p>
@@ -6150,7 +6500,7 @@
                 </a:solidFill>
                 <a:latin typeface="PT Serif"/>
               </a:rPr>
-              <a:t>El concepto que nos llevamos hoy</a:t>
+              <a:t>El concepto de esta clase</a:t>
             </a:r>
           </a:p>
         </p:txBody>
@@ -6246,7 +6596,7 @@
                 </a:solidFill>
                 <a:latin typeface="PT Serif"/>
               </a:rPr>
-              <a:t>La pregunta que ordena toda la clase</a:t>
+              <a:t>La pregunta que ordena la clase</a:t>
             </a:r>
           </a:p>
         </p:txBody>
@@ -6289,7 +6639,7 @@
                 </a:solidFill>
                 <a:latin typeface="PT Serif"/>
               </a:rPr>
-              <a:t>Pandas ya lo conocen: hoy no es el aprendizaje, es la herramienta.</a:t>
+              <a:t>Pandas ya lo conocen: hoy es la herramienta, no el aprendizaje.</a:t>
             </a:r>
           </a:p>
           <a:p>
@@ -6309,7 +6659,7 @@
                 </a:solidFill>
                 <a:latin typeface="PT Serif"/>
               </a:rPr>
-              <a:t>Lo que se llevan es un hábito: interrogar cada cifra antes de creerle.</a:t>
+              <a:t>Lo nuevo es un hábito: examinar cada cifra antes de usarla.</a:t>
             </a:r>
           </a:p>
           <a:p>
@@ -6329,7 +6679,7 @@
                 </a:solidFill>
                 <a:latin typeface="PT Serif"/>
               </a:rPr>
-              <a:t>Un promedio puede describir una situación en la que casi nadie está.</a:t>
+              <a:t>Un promedio puede describir una situación en la que pocos están.</a:t>
             </a:r>
           </a:p>
           <a:p>
@@ -6369,7 +6719,7 @@
                 </a:solidFill>
                 <a:latin typeface="PT Serif"/>
               </a:rPr>
-              <a:t>Hay personas de las que la tabla no dice nada, y ese silencio informa.</a:t>
+              <a:t>Hay personas de las que la tabla no dice nada; esa ausencia informa.</a:t>
             </a:r>
           </a:p>
           <a:p>
@@ -6389,7 +6739,7 @@
                 </a:solidFill>
                 <a:latin typeface="PT Serif"/>
               </a:rPr>
-              <a:t>Al final de la clase volveremos a esta pregunta con cuatro respuestas.</a:t>
+              <a:t>Al cierre volveremos a esta pregunta con las respuestas del día.</a:t>
             </a:r>
           </a:p>
         </p:txBody>
@@ -6635,7 +6985,7 @@
                 </a:solidFill>
                 <a:latin typeface="PT Serif"/>
               </a:rPr>
-              <a:t>La encuesta de movilidad más completa de Chile (SECTRA y U. Alberto Hurtado).</a:t>
+              <a:t>Encuesta de movilidad del Gran Santiago (SECTRA y U. Alberto Hurtado).</a:t>
             </a:r>
           </a:p>
           <a:p>
@@ -6695,7 +7045,7 @@
                 </a:solidFill>
                 <a:latin typeface="PT Serif"/>
               </a:rPr>
-              <a:t>Es la base de la planificación de transporte de Santiago.</a:t>
+              <a:t>Se usa en la planificación de transporte de la ciudad.</a:t>
             </a:r>
           </a:p>
           <a:p>
@@ -6709,33 +7059,13 @@
               <a:t>▸ </a:t>
             </a:r>
             <a:r>
-              <a:rPr sz="1800" b="0">
-                <a:solidFill>
-                  <a:srgbClr val="3A4A5C"/>
-                </a:solidFill>
-                <a:latin typeface="PT Serif"/>
-              </a:rPr>
-              <a:t>Es una base relacional: varias tablas conectadas por identificadores.</a:t>
-            </a:r>
-          </a:p>
-          <a:p>
-            <a:r>
               <a:rPr sz="1800" b="1">
                 <a:solidFill>
-                  <a:srgbClr val="E0A437"/>
-                </a:solidFill>
-                <a:latin typeface="PT Serif"/>
-              </a:rPr>
-              <a:t>▸ </a:t>
-            </a:r>
-            <a:r>
-              <a:rPr sz="1800" b="1">
-                <a:solidFill>
                   <a:srgbClr val="1D3557"/>
                 </a:solidFill>
                 <a:latin typeface="PT Serif"/>
               </a:rPr>
-              <a:t>El mismo diseño que van a encontrar en la Casen, el Censo o la ENUSC.</a:t>
+              <a:t>El mismo diseño relacional de la Casen, el Censo o la ENUSC.</a:t>
             </a:r>
           </a:p>
         </p:txBody>
@@ -6831,21 +7161,45 @@
                 </a:solidFill>
                 <a:latin typeface="PT Serif"/>
               </a:rPr>
-              <a:t>Las tablas y sus llaves</a:t>
-            </a:r>
-          </a:p>
-        </p:txBody>
-      </p:sp>
-      <p:sp>
-        <p:nvSpPr>
-          <p:cNvPr id="4" name="TextBox 3"/>
+              <a:t>Una encuesta, varias tablas</a:t>
+            </a:r>
+          </a:p>
+        </p:txBody>
+      </p:sp>
+      <p:pic>
+        <p:nvPicPr>
+          <p:cNvPr id="4" name="Picture 3" descr="05_diagrama_tablas.png"/>
+          <p:cNvPicPr>
+            <a:picLocks noChangeAspect="1"/>
+          </p:cNvPicPr>
+          <p:nvPr/>
+        </p:nvPicPr>
+        <p:blipFill>
+          <a:blip r:embed="rId2"/>
+          <a:stretch>
+            <a:fillRect/>
+          </a:stretch>
+        </p:blipFill>
+        <p:spPr>
+          <a:xfrm>
+            <a:off x="1555117" y="1143000"/>
+            <a:ext cx="6033765" cy="3154680"/>
+          </a:xfrm>
+          <a:prstGeom prst="rect">
+            <a:avLst/>
+          </a:prstGeom>
+        </p:spPr>
+      </p:pic>
+      <p:sp>
+        <p:nvSpPr>
+          <p:cNvPr id="5" name="TextBox 4"/>
           <p:cNvSpPr txBox="1"/>
           <p:nvPr/>
         </p:nvSpPr>
         <p:spPr>
           <a:xfrm>
-            <a:off x="704088" y="1353312"/>
-            <a:ext cx="7744968" cy="3300984"/>
+            <a:off x="704088" y="4434840"/>
+            <a:ext cx="7744968" cy="457200"/>
           </a:xfrm>
           <a:prstGeom prst="rect">
             <a:avLst/>
@@ -6859,102 +7213,13 @@
           <a:lstStyle/>
           <a:p>
             <a:r>
-              <a:rPr sz="1800" b="1">
-                <a:solidFill>
-                  <a:srgbClr val="E0A437"/>
-                </a:solidFill>
-                <a:latin typeface="PT Serif"/>
-              </a:rPr>
-              <a:t>▸ </a:t>
-            </a:r>
-            <a:r>
-              <a:rPr sz="1800" b="0">
-                <a:solidFill>
-                  <a:srgbClr val="3A4A5C"/>
-                </a:solidFill>
-                <a:latin typeface="PT Serif"/>
-              </a:rPr>
-              <a:t>Hogares.csv: una fila por hogar. Llave: Hogar.</a:t>
-            </a:r>
-          </a:p>
-          <a:p>
-            <a:r>
-              <a:rPr sz="1800" b="1">
-                <a:solidFill>
-                  <a:srgbClr val="E0A437"/>
-                </a:solidFill>
-                <a:latin typeface="PT Serif"/>
-              </a:rPr>
-              <a:t>▸ </a:t>
-            </a:r>
-            <a:r>
-              <a:rPr sz="1800" b="0">
-                <a:solidFill>
-                  <a:srgbClr val="3A4A5C"/>
-                </a:solidFill>
-                <a:latin typeface="PT Serif"/>
-              </a:rPr>
-              <a:t>personas.csv: una fila por persona. Llave: Hogar + Persona.</a:t>
-            </a:r>
-          </a:p>
-          <a:p>
-            <a:r>
-              <a:rPr sz="1800" b="1">
-                <a:solidFill>
-                  <a:srgbClr val="E0A437"/>
-                </a:solidFill>
-                <a:latin typeface="PT Serif"/>
-              </a:rPr>
-              <a:t>▸ </a:t>
-            </a:r>
-            <a:r>
-              <a:rPr sz="1800" b="0">
-                <a:solidFill>
-                  <a:srgbClr val="3A4A5C"/>
-                </a:solidFill>
-                <a:latin typeface="PT Serif"/>
-              </a:rPr>
-              <a:t>viajes.csv: una fila por viaje. Llave: Hogar + Persona + Viaje.</a:t>
-            </a:r>
-          </a:p>
-          <a:p>
-            <a:r>
-              <a:rPr sz="1800" b="1">
-                <a:solidFill>
-                  <a:srgbClr val="E0A437"/>
-                </a:solidFill>
-                <a:latin typeface="PT Serif"/>
-              </a:rPr>
-              <a:t>▸ </a:t>
-            </a:r>
-            <a:r>
-              <a:rPr sz="1800" b="0">
-                <a:solidFill>
-                  <a:srgbClr val="3A4A5C"/>
-                </a:solidFill>
-                <a:latin typeface="PT Serif"/>
-              </a:rPr>
-              <a:t>tablas_parametros/: el significado de cada código.</a:t>
-            </a:r>
-          </a:p>
-          <a:p>
-            <a:r>
-              <a:rPr sz="1800" b="1">
-                <a:solidFill>
-                  <a:srgbClr val="E0A437"/>
-                </a:solidFill>
-                <a:latin typeface="PT Serif"/>
-              </a:rPr>
-              <a:t>▸ </a:t>
-            </a:r>
-            <a:r>
-              <a:rPr sz="1800" b="1">
-                <a:solidFill>
-                  <a:srgbClr val="1D3557"/>
-                </a:solidFill>
-                <a:latin typeface="PT Serif"/>
-              </a:rPr>
-              <a:t>Equivocarse de llave es la fuente clásica de merges malos.</a:t>
+              <a:rPr sz="1300" b="0">
+                <a:solidFill>
+                  <a:srgbClr val="6B7785"/>
+                </a:solidFill>
+                <a:latin typeface="PT Serif"/>
+              </a:rPr>
+              <a:t>Los códigos no significan nada sin sus tablas de parámetros: unirlas es parte del análisis.</a:t>
             </a:r>
           </a:p>
         </p:txBody>
@@ -7061,7 +7326,7 @@
                 </a:solidFill>
                 <a:latin typeface="PT Serif"/>
               </a:rPr>
-              <a:t>Cinco preguntas, cinco herramientas</a:t>
+              <a:t>Dos casos concretos</a:t>
             </a:r>
           </a:p>
         </p:txBody>
@@ -7157,7 +7422,7 @@
                 </a:solidFill>
                 <a:latin typeface="PT Serif"/>
               </a:rPr>
-              <a:t>¿A quiénes les preguntaron? Cargar y mirar</a:t>
+              <a:t>Caso 1: códigos que no significan nada solos</a:t>
             </a:r>
           </a:p>
         </p:txBody>
@@ -7171,7 +7436,7 @@
         <p:spPr>
           <a:xfrm>
             <a:off x="704088" y="1280160"/>
-            <a:ext cx="7744968" cy="2880360"/>
+            <a:ext cx="7744968" cy="3886200"/>
           </a:xfrm>
           <a:prstGeom prst="rect">
             <a:avLst/>
@@ -7212,7 +7477,7 @@
                 </a:solidFill>
                 <a:latin typeface="Menlo"/>
               </a:rPr>
-              <a:t>personas = pd.read_csv('datos/eod_stgo/personas.csv',</a:t>
+              <a:t>personas['Sexo'].value_counts()      # 1 y 2: ¿qué son?</a:t>
             </a:r>
           </a:p>
           <a:p>
@@ -7224,7 +7489,7 @@
                 </a:solidFill>
                 <a:latin typeface="Menlo"/>
               </a:rPr>
-              <a:t>                       sep=';', decimal=',')</a:t>
+              <a:t/>
             </a:r>
           </a:p>
           <a:p>
@@ -7236,6 +7501,42 @@
                 </a:solidFill>
                 <a:latin typeface="Menlo"/>
               </a:rPr>
+              <a:t>sexo = pd.read_csv('tablas_parametros/Sexo.csv', sep=';')</a:t>
+            </a:r>
+          </a:p>
+          <a:p>
+            <a:pPr/>
+            <a:r>
+              <a:rPr sz="1500" b="0">
+                <a:solidFill>
+                  <a:srgbClr val="1D3557"/>
+                </a:solidFill>
+                <a:latin typeface="Menlo"/>
+              </a:rPr>
+              <a:t>personas = personas.merge(sexo, left_on='Sexo',</a:t>
+            </a:r>
+          </a:p>
+          <a:p>
+            <a:pPr/>
+            <a:r>
+              <a:rPr sz="1500" b="0">
+                <a:solidFill>
+                  <a:srgbClr val="1D3557"/>
+                </a:solidFill>
+                <a:latin typeface="Menlo"/>
+              </a:rPr>
+              <a:t>                          right_on='Id', how='left')</a:t>
+            </a:r>
+          </a:p>
+          <a:p>
+            <a:pPr/>
+            <a:r>
+              <a:rPr sz="1500" b="0">
+                <a:solidFill>
+                  <a:srgbClr val="1D3557"/>
+                </a:solidFill>
+                <a:latin typeface="Menlo"/>
+              </a:rPr>
               <a:t/>
             </a:r>
           </a:p>
@@ -7248,19 +7549,7 @@
                 </a:solidFill>
                 <a:latin typeface="Menlo"/>
               </a:rPr>
-              <a:t>personas.shape    # 60.054 filas, 39 columnas</a:t>
-            </a:r>
-          </a:p>
-          <a:p>
-            <a:pPr/>
-            <a:r>
-              <a:rPr sz="1500" b="0">
-                <a:solidFill>
-                  <a:srgbClr val="1D3557"/>
-                </a:solidFill>
-                <a:latin typeface="Menlo"/>
-              </a:rPr>
-              <a:t>personas.info()   # tipos y no nulos, siempre antes de calcular</a:t>
+              <a:t>personas['Sexo'].isna().sum()        # después de todo merge: contar los NaN</a:t>
             </a:r>
           </a:p>
         </p:txBody>
@@ -7273,7 +7562,7 @@
         </p:nvSpPr>
         <p:spPr>
           <a:xfrm>
-            <a:off x="704088" y="4389120"/>
+            <a:off x="704088" y="5394960"/>
             <a:ext cx="7744968" cy="1097280"/>
           </a:xfrm>
           <a:prstGeom prst="rect">
@@ -7303,7 +7592,7 @@
                 </a:solidFill>
                 <a:latin typeface="PT Serif"/>
               </a:rPr>
-              <a:t>Estos archivos usan punto y coma como separador y coma decimal: primer hallazgo.</a:t>
+              <a:t>El detalle completo, con las cuatro variantes de how, está en el notebook.</a:t>
             </a:r>
           </a:p>
         </p:txBody>

</xml_diff>

<commit_message>
Definicion de EDA, correlacion y causalidad, tipos de datos, y Fira Sans
Notebook: seccion que define el analisis exploratorio (Tukey, exploratorio contra
confirmatorio, las cuatro preguntas), subseccion de tipos de datos con la
advertencia de que el dtype no es el tipo estadistico, coeficiente de correlacion
sobre el caso ingreso y transporte publico, y la distincion entre correlacion y
causalidad con variables de confusion. Pasada adicional de lenguaje academico.

Slides: mismas incorporaciones, tipografia Fira Sans y figuras a 300 dpi. Las
evaluaciones no aplicadas (control 1 y su pauta) quedan fuera del repositorio
publico via gitignore.

Co-Authored-By: Claude Fable 5 <noreply@anthropic.com>
</commit_message>
<xml_diff>
--- a/presentaciones/clase02_pandas_eda.pptx
+++ b/presentaciones/clase02_pandas_eda.pptx
@@ -29,6 +29,8 @@
     <p:sldId id="277" r:id="rId28"/>
     <p:sldId id="278" r:id="rId29"/>
     <p:sldId id="279" r:id="rId30"/>
+    <p:sldId id="280" r:id="rId31"/>
+    <p:sldId id="281" r:id="rId32"/>
   </p:sldIdLst>
   <p:sldSz cx="9144000" cy="5138928" type="screen4x3"/>
   <p:notesSz cx="6858000" cy="9144000"/>
@@ -3182,7 +3184,7 @@
                 <a:solidFill>
                   <a:srgbClr val="FFFFFF"/>
                 </a:solidFill>
-                <a:latin typeface="PT Serif"/>
+                <a:latin typeface="Fira Sans"/>
               </a:rPr>
               <a:t>¿Cómo se mueve Santiago?</a:t>
             </a:r>
@@ -3235,7 +3237,7 @@
                 <a:solidFill>
                   <a:srgbClr val="1D3557"/>
                 </a:solidFill>
-                <a:latin typeface="PT Serif"/>
+                <a:latin typeface="Fira Sans"/>
               </a:rPr>
               <a:t>Clase 2 · Pandas (repaso) y análisis exploratorio</a:t>
             </a:r>
@@ -3269,7 +3271,7 @@
                 <a:solidFill>
                   <a:srgbClr val="FFFFFF"/>
                 </a:solidFill>
-                <a:latin typeface="PT Serif"/>
+                <a:latin typeface="Fira Sans"/>
               </a:rPr>
               <a:t>Daniela Opitz</a:t>
             </a:r>
@@ -3280,7 +3282,7 @@
                 <a:solidFill>
                   <a:srgbClr val="B8C4D4"/>
                 </a:solidFill>
-                <a:latin typeface="PT Serif"/>
+                <a:latin typeface="Fira Sans"/>
               </a:rPr>
               <a:t>INF-396 · Departamento de Informática · UTFSM · viernes 21 de agosto, 2026</a:t>
             </a:r>
@@ -3376,7 +3378,7 @@
                 <a:solidFill>
                   <a:srgbClr val="0F0F0F"/>
                 </a:solidFill>
-                <a:latin typeface="PT Serif"/>
+                <a:latin typeface="Fira Sans"/>
               </a:rPr>
               <a:t>Las variantes del merge: qué filas sobreviven</a:t>
             </a:r>
@@ -3400,7 +3402,7 @@
         <p:spPr>
           <a:xfrm>
             <a:off x="1417319" y="1143000"/>
-            <a:ext cx="6309360" cy="2373039"/>
+            <a:ext cx="6309360" cy="2397276"/>
           </a:xfrm>
           <a:prstGeom prst="rect">
             <a:avLst/>
@@ -3434,7 +3436,7 @@
                 <a:solidFill>
                   <a:srgbClr val="6B7785"/>
                 </a:solidFill>
-                <a:latin typeface="PT Serif"/>
+                <a:latin typeface="Fira Sans"/>
               </a:rPr>
               <a:t>El valor por defecto es inner: descarta sin aviso las filas sin pareja.</a:t>
             </a:r>
@@ -3530,9 +3532,9 @@
                 <a:solidFill>
                   <a:srgbClr val="0F0F0F"/>
                 </a:solidFill>
-                <a:latin typeface="PT Serif"/>
-              </a:rPr>
-              <a:t>La elección de how define de quién hablan los números</a:t>
+                <a:latin typeface="Fira Sans"/>
+              </a:rPr>
+              <a:t>El efecto del parámetro how sobre la población analizada</a:t>
             </a:r>
           </a:p>
         </p:txBody>
@@ -3564,7 +3566,7 @@
                 <a:solidFill>
                   <a:srgbClr val="E0A437"/>
                 </a:solidFill>
-                <a:latin typeface="PT Serif"/>
+                <a:latin typeface="Fira Sans"/>
               </a:rPr>
               <a:t>▸ </a:t>
             </a:r>
@@ -3573,7 +3575,7 @@
                 <a:solidFill>
                   <a:srgbClr val="3A4A5C"/>
                 </a:solidFill>
-                <a:latin typeface="PT Serif"/>
+                <a:latin typeface="Fira Sans"/>
               </a:rPr>
               <a:t>Personas con viajes, merge inner: 113.591 filas (una por viaje).</a:t>
             </a:r>
@@ -3584,7 +3586,7 @@
                 <a:solidFill>
                   <a:srgbClr val="E0A437"/>
                 </a:solidFill>
-                <a:latin typeface="PT Serif"/>
+                <a:latin typeface="Fira Sans"/>
               </a:rPr>
               <a:t>▸ </a:t>
             </a:r>
@@ -3593,7 +3595,7 @@
                 <a:solidFill>
                   <a:srgbClr val="3A4A5C"/>
                 </a:solidFill>
-                <a:latin typeface="PT Serif"/>
+                <a:latin typeface="Fira Sans"/>
               </a:rPr>
               <a:t>El mismo merge en left: 127.379 filas.</a:t>
             </a:r>
@@ -3604,7 +3606,7 @@
                 <a:solidFill>
                   <a:srgbClr val="6B7785"/>
                 </a:solidFill>
-                <a:latin typeface="PT Serif"/>
+                <a:latin typeface="Fira Sans"/>
               </a:rPr>
               <a:t>     ◦  </a:t>
             </a:r>
@@ -3613,7 +3615,7 @@
                 <a:solidFill>
                   <a:srgbClr val="6B7785"/>
                 </a:solidFill>
-                <a:latin typeface="PT Serif"/>
+                <a:latin typeface="Fira Sans"/>
               </a:rPr>
               <a:t>La diferencia son 13.788 personas que no viajaron ese día.</a:t>
             </a:r>
@@ -3624,7 +3626,7 @@
                 <a:solidFill>
                   <a:srgbClr val="6B7785"/>
                 </a:solidFill>
-                <a:latin typeface="PT Serif"/>
+                <a:latin typeface="Fira Sans"/>
               </a:rPr>
               <a:t>     ◦  </a:t>
             </a:r>
@@ -3633,7 +3635,7 @@
                 <a:solidFill>
                   <a:srgbClr val="6B7785"/>
                 </a:solidFill>
-                <a:latin typeface="PT Serif"/>
+                <a:latin typeface="Fira Sans"/>
               </a:rPr>
               <a:t>Con inner desaparecen; con left quedan, con NaN en el viaje.</a:t>
             </a:r>
@@ -3644,7 +3646,7 @@
                 <a:solidFill>
                   <a:srgbClr val="E0A437"/>
                 </a:solidFill>
-                <a:latin typeface="PT Serif"/>
+                <a:latin typeface="Fira Sans"/>
               </a:rPr>
               <a:t>▸ </a:t>
             </a:r>
@@ -3653,9 +3655,9 @@
                 <a:solidFill>
                   <a:srgbClr val="1D3557"/>
                 </a:solidFill>
-                <a:latin typeface="PT Serif"/>
-              </a:rPr>
-              <a:t>Un promedio de viajes calculado sobre el inner habla solo de quienes viajan.</a:t>
+                <a:latin typeface="Fira Sans"/>
+              </a:rPr>
+              <a:t>Un promedio calculado sobre el resultado del inner excluye a quienes no viajaron.</a:t>
             </a:r>
           </a:p>
         </p:txBody>
@@ -3749,7 +3751,7 @@
                 <a:solidFill>
                   <a:srgbClr val="0F0F0F"/>
                 </a:solidFill>
-                <a:latin typeface="PT Serif"/>
+                <a:latin typeface="Fira Sans"/>
               </a:rPr>
               <a:t>Caso 2: contar sin perder a los que no aparecen</a:t>
             </a:r>
@@ -3874,7 +3876,7 @@
                 <a:solidFill>
                   <a:srgbClr val="E0A437"/>
                 </a:solidFill>
-                <a:latin typeface="PT Serif"/>
+                <a:latin typeface="Fira Sans"/>
               </a:rPr>
               <a:t>▸ </a:t>
             </a:r>
@@ -3883,7 +3885,7 @@
                 <a:solidFill>
                   <a:srgbClr val="3A4A5C"/>
                 </a:solidFill>
-                <a:latin typeface="PT Serif"/>
+                <a:latin typeface="Fira Sans"/>
               </a:rPr>
               <a:t>El groupby cuenta sobre la tabla de viajes; el fillna(0) trae de vuelta a los ausentes.</a:t>
             </a:r>
@@ -3979,7 +3981,7 @@
                 <a:solidFill>
                   <a:srgbClr val="0F0F0F"/>
                 </a:solidFill>
-                <a:latin typeface="PT Serif"/>
+                <a:latin typeface="Fira Sans"/>
               </a:rPr>
               <a:t>Quien no viaja también es dato</a:t>
             </a:r>
@@ -4013,7 +4015,7 @@
                 <a:solidFill>
                   <a:srgbClr val="E0A437"/>
                 </a:solidFill>
-                <a:latin typeface="PT Serif"/>
+                <a:latin typeface="Fira Sans"/>
               </a:rPr>
               <a:t>▸ </a:t>
             </a:r>
@@ -4022,7 +4024,7 @@
                 <a:solidFill>
                   <a:srgbClr val="3A4A5C"/>
                 </a:solidFill>
-                <a:latin typeface="PT Serif"/>
+                <a:latin typeface="Fira Sans"/>
               </a:rPr>
               <a:t>El 23% de las personas no viajó ese día.</a:t>
             </a:r>
@@ -4033,7 +4035,7 @@
                 <a:solidFill>
                   <a:srgbClr val="E0A437"/>
                 </a:solidFill>
-                <a:latin typeface="PT Serif"/>
+                <a:latin typeface="Fira Sans"/>
               </a:rPr>
               <a:t>▸ </a:t>
             </a:r>
@@ -4042,7 +4044,7 @@
                 <a:solidFill>
                   <a:srgbClr val="3A4A5C"/>
                 </a:solidFill>
-                <a:latin typeface="PT Serif"/>
+                <a:latin typeface="Fira Sans"/>
               </a:rPr>
               <a:t>Media: 1,9 viajes. Mediana: 2 viajes.</a:t>
             </a:r>
@@ -4053,7 +4055,7 @@
                 <a:solidFill>
                   <a:srgbClr val="E0A437"/>
                 </a:solidFill>
-                <a:latin typeface="PT Serif"/>
+                <a:latin typeface="Fira Sans"/>
               </a:rPr>
               <a:t>▸ </a:t>
             </a:r>
@@ -4062,7 +4064,7 @@
                 <a:solidFill>
                   <a:srgbClr val="3A4A5C"/>
                 </a:solidFill>
-                <a:latin typeface="PT Serif"/>
+                <a:latin typeface="Fira Sans"/>
               </a:rPr>
               <a:t>Aquí la media quedó bajo la mediana: el bloque de ceros la baja.</a:t>
             </a:r>
@@ -4073,7 +4075,7 @@
                 <a:solidFill>
                   <a:srgbClr val="E0A437"/>
                 </a:solidFill>
-                <a:latin typeface="PT Serif"/>
+                <a:latin typeface="Fira Sans"/>
               </a:rPr>
               <a:t>▸ </a:t>
             </a:r>
@@ -4082,9 +4084,9 @@
                 <a:solidFill>
                   <a:srgbClr val="1D3557"/>
                 </a:solidFill>
-                <a:latin typeface="PT Serif"/>
-              </a:rPr>
-              <a:t>La asimetría no siempre empuja hacia el mismo lado: se mira, no se adivina.</a:t>
+                <a:latin typeface="Fira Sans"/>
+              </a:rPr>
+              <a:t>La dirección del sesgo depende de la forma de la distribución.</a:t>
             </a:r>
           </a:p>
         </p:txBody>
@@ -4106,7 +4108,7 @@
         <p:spPr>
           <a:xfrm>
             <a:off x="4892040" y="1371600"/>
-            <a:ext cx="3840480" cy="2196274"/>
+            <a:ext cx="3840480" cy="2191739"/>
           </a:xfrm>
           <a:prstGeom prst="rect">
             <a:avLst/>
@@ -4202,7 +4204,7 @@
                 <a:solidFill>
                   <a:srgbClr val="FFFFFF"/>
                 </a:solidFill>
-                <a:latin typeface="PT Serif"/>
+                <a:latin typeface="Fira Sans"/>
               </a:rPr>
               <a:t>¿A quién representa la encuesta?</a:t>
             </a:r>
@@ -4213,7 +4215,7 @@
                 <a:solidFill>
                   <a:srgbClr val="E0A437"/>
                 </a:solidFill>
-                <a:latin typeface="PT Serif"/>
+                <a:latin typeface="Fira Sans"/>
               </a:rPr>
               <a:t>Los factores de expansión</a:t>
             </a:r>
@@ -4309,7 +4311,7 @@
                 <a:solidFill>
                   <a:srgbClr val="0F0F0F"/>
                 </a:solidFill>
-                <a:latin typeface="PT Serif"/>
+                <a:latin typeface="Fira Sans"/>
               </a:rPr>
               <a:t>De la muestra a la ciudad</a:t>
             </a:r>
@@ -4333,7 +4335,7 @@
         <p:spPr>
           <a:xfrm>
             <a:off x="1417319" y="1143000"/>
-            <a:ext cx="6309360" cy="2869563"/>
+            <a:ext cx="6309360" cy="2871234"/>
           </a:xfrm>
           <a:prstGeom prst="rect">
             <a:avLst/>
@@ -4367,7 +4369,7 @@
                 <a:solidFill>
                   <a:srgbClr val="6B7785"/>
                 </a:solidFill>
-                <a:latin typeface="PT Serif"/>
+                <a:latin typeface="Fira Sans"/>
               </a:rPr>
               <a:t>Contar filas responde por la muestra; sumar factores responde por la ciudad.</a:t>
             </a:r>
@@ -4463,7 +4465,7 @@
                 <a:solidFill>
                   <a:srgbClr val="FFFFFF"/>
                 </a:solidFill>
-                <a:latin typeface="PT Serif"/>
+                <a:latin typeface="Fira Sans"/>
               </a:rPr>
               <a:t>Análisis exploratorio</a:t>
             </a:r>
@@ -4474,9 +4476,9 @@
                 <a:solidFill>
                   <a:srgbClr val="E0A437"/>
                 </a:solidFill>
-                <a:latin typeface="PT Serif"/>
-              </a:rPr>
-              <a:t>¿Qué número resume bien una respuesta?</a:t>
+                <a:latin typeface="Fira Sans"/>
+              </a:rPr>
+              <a:t>Examinar los datos antes de modelarlos</a:t>
             </a:r>
           </a:p>
         </p:txBody>
@@ -4570,9 +4572,9 @@
                 <a:solidFill>
                   <a:srgbClr val="0F0F0F"/>
                 </a:solidFill>
-                <a:latin typeface="PT Serif"/>
-              </a:rPr>
-              <a:t>¿Cuánto gana un hogar típico?</a:t>
+                <a:latin typeface="Fira Sans"/>
+              </a:rPr>
+              <a:t>Qué es el análisis exploratorio de datos</a:t>
             </a:r>
           </a:p>
         </p:txBody>
@@ -4585,8 +4587,8 @@
         </p:nvSpPr>
         <p:spPr>
           <a:xfrm>
-            <a:off x="502920" y="1252728"/>
-            <a:ext cx="4023360" cy="3200400"/>
+            <a:off x="704088" y="1353312"/>
+            <a:ext cx="7744968" cy="3300984"/>
           </a:xfrm>
           <a:prstGeom prst="rect">
             <a:avLst/>
@@ -4600,110 +4602,146 @@
           <a:lstStyle/>
           <a:p>
             <a:r>
-              <a:rPr sz="1500" b="1">
+              <a:rPr sz="1800" b="1">
                 <a:solidFill>
                   <a:srgbClr val="E0A437"/>
                 </a:solidFill>
-                <a:latin typeface="PT Serif"/>
+                <a:latin typeface="Fira Sans"/>
               </a:rPr>
               <a:t>▸ </a:t>
             </a:r>
             <a:r>
-              <a:rPr sz="1500" b="0">
+              <a:rPr sz="1800" b="0">
                 <a:solidFill>
                   <a:srgbClr val="3A4A5C"/>
                 </a:solidFill>
-                <a:latin typeface="PT Serif"/>
-              </a:rPr>
-              <a:t>Media: $688.274. Mediana: $507.826.</a:t>
-            </a:r>
-          </a:p>
-          <a:p>
-            <a:r>
-              <a:rPr sz="1500" b="1">
+                <a:latin typeface="Fira Sans"/>
+              </a:rPr>
+              <a:t>La etapa en que se examinan los datos antes de modelarlos (Tukey, 1977).</a:t>
+            </a:r>
+          </a:p>
+          <a:p>
+            <a:r>
+              <a:rPr sz="1800" b="1">
                 <a:solidFill>
                   <a:srgbClr val="E0A437"/>
                 </a:solidFill>
-                <a:latin typeface="PT Serif"/>
+                <a:latin typeface="Fira Sans"/>
               </a:rPr>
               <a:t>▸ </a:t>
             </a:r>
             <a:r>
-              <a:rPr sz="1500" b="0">
+              <a:rPr sz="1800" b="0">
                 <a:solidFill>
                   <a:srgbClr val="3A4A5C"/>
                 </a:solidFill>
-                <a:latin typeface="PT Serif"/>
-              </a:rPr>
-              <a:t>La media es un 36% más alta que la mediana.</a:t>
-            </a:r>
-          </a:p>
-          <a:p>
-            <a:r>
-              <a:rPr sz="1500" b="1">
+                <a:latin typeface="Fira Sans"/>
+              </a:rPr>
+              <a:t>Responde cuatro tipos de pregunta:</a:t>
+            </a:r>
+          </a:p>
+          <a:p>
+            <a:r>
+              <a:rPr sz="1400" b="0">
+                <a:solidFill>
+                  <a:srgbClr val="6B7785"/>
+                </a:solidFill>
+                <a:latin typeface="Fira Sans"/>
+              </a:rPr>
+              <a:t>     ◦  </a:t>
+            </a:r>
+            <a:r>
+              <a:rPr sz="1400" b="0">
+                <a:solidFill>
+                  <a:srgbClr val="6B7785"/>
+                </a:solidFill>
+                <a:latin typeface="Fira Sans"/>
+              </a:rPr>
+              <a:t>La forma: cómo se distribuye cada variable.</a:t>
+            </a:r>
+          </a:p>
+          <a:p>
+            <a:r>
+              <a:rPr sz="1400" b="0">
+                <a:solidFill>
+                  <a:srgbClr val="6B7785"/>
+                </a:solidFill>
+                <a:latin typeface="Fira Sans"/>
+              </a:rPr>
+              <a:t>     ◦  </a:t>
+            </a:r>
+            <a:r>
+              <a:rPr sz="1400" b="0">
+                <a:solidFill>
+                  <a:srgbClr val="6B7785"/>
+                </a:solidFill>
+                <a:latin typeface="Fira Sans"/>
+              </a:rPr>
+              <a:t>Lo típico y lo extremo: qué es frecuente y qué es anómalo.</a:t>
+            </a:r>
+          </a:p>
+          <a:p>
+            <a:r>
+              <a:rPr sz="1400" b="0">
+                <a:solidFill>
+                  <a:srgbClr val="6B7785"/>
+                </a:solidFill>
+                <a:latin typeface="Fira Sans"/>
+              </a:rPr>
+              <a:t>     ◦  </a:t>
+            </a:r>
+            <a:r>
+              <a:rPr sz="1400" b="0">
+                <a:solidFill>
+                  <a:srgbClr val="6B7785"/>
+                </a:solidFill>
+                <a:latin typeface="Fira Sans"/>
+              </a:rPr>
+              <a:t>Lo que falta: qué datos están ausentes y con qué patrón.</a:t>
+            </a:r>
+          </a:p>
+          <a:p>
+            <a:r>
+              <a:rPr sz="1400" b="0">
+                <a:solidFill>
+                  <a:srgbClr val="6B7785"/>
+                </a:solidFill>
+                <a:latin typeface="Fira Sans"/>
+              </a:rPr>
+              <a:t>     ◦  </a:t>
+            </a:r>
+            <a:r>
+              <a:rPr sz="1400" b="0">
+                <a:solidFill>
+                  <a:srgbClr val="6B7785"/>
+                </a:solidFill>
+                <a:latin typeface="Fira Sans"/>
+              </a:rPr>
+              <a:t>Las relaciones: qué variables se asocian con qué otras.</a:t>
+            </a:r>
+          </a:p>
+          <a:p>
+            <a:r>
+              <a:rPr sz="1800" b="1">
                 <a:solidFill>
                   <a:srgbClr val="E0A437"/>
                 </a:solidFill>
-                <a:latin typeface="PT Serif"/>
+                <a:latin typeface="Fira Sans"/>
               </a:rPr>
               <a:t>▸ </a:t>
             </a:r>
             <a:r>
-              <a:rPr sz="1500" b="0">
-                <a:solidFill>
-                  <a:srgbClr val="3A4A5C"/>
-                </a:solidFill>
-                <a:latin typeface="PT Serif"/>
-              </a:rPr>
-              <a:t>Los ingresos altos desplazan el promedio; la mayoría gana menos.</a:t>
-            </a:r>
-          </a:p>
-          <a:p>
-            <a:r>
-              <a:rPr sz="1500" b="1">
-                <a:solidFill>
-                  <a:srgbClr val="E0A437"/>
-                </a:solidFill>
-                <a:latin typeface="PT Serif"/>
-              </a:rPr>
-              <a:t>▸ </a:t>
-            </a:r>
-            <a:r>
-              <a:rPr sz="1500" b="1">
+              <a:rPr sz="1800" b="1">
                 <a:solidFill>
                   <a:srgbClr val="1D3557"/>
                 </a:solidFill>
-                <a:latin typeface="PT Serif"/>
-              </a:rPr>
-              <a:t>El promedio describe una situación en la que la mayoría no está.</a:t>
-            </a:r>
-          </a:p>
-        </p:txBody>
-      </p:sp>
-      <p:pic>
-        <p:nvPicPr>
-          <p:cNvPr id="5" name="Picture 4" descr="01_ingreso_media_mediana.png"/>
-          <p:cNvPicPr>
-            <a:picLocks noChangeAspect="1"/>
-          </p:cNvPicPr>
-          <p:nvPr/>
-        </p:nvPicPr>
-        <p:blipFill>
-          <a:blip r:embed="rId2"/>
-          <a:stretch>
-            <a:fillRect/>
-          </a:stretch>
-        </p:blipFill>
-        <p:spPr>
-          <a:xfrm>
-            <a:off x="4892040" y="1371600"/>
-            <a:ext cx="3840480" cy="2189433"/>
-          </a:xfrm>
-          <a:prstGeom prst="rect">
-            <a:avLst/>
-          </a:prstGeom>
-        </p:spPr>
-      </p:pic>
+                <a:latin typeface="Fira Sans"/>
+              </a:rPr>
+              <a:t>Genera hipótesis; el análisis confirmatorio (unidad 5) las pone a prueba.</a:t>
+            </a:r>
+          </a:p>
+        </p:txBody>
+      </p:sp>
     </p:spTree>
   </p:cSld>
   <p:clrMapOvr>
@@ -4793,9 +4831,9 @@
                 <a:solidFill>
                   <a:srgbClr val="0F0F0F"/>
                 </a:solidFill>
-                <a:latin typeface="PT Serif"/>
-              </a:rPr>
-              <a:t>¿Cuánto dura un viaje?</a:t>
+                <a:latin typeface="Fira Sans"/>
+              </a:rPr>
+              <a:t>¿Cuánto gana un hogar típico?</a:t>
             </a:r>
           </a:p>
         </p:txBody>
@@ -4827,7 +4865,7 @@
                 <a:solidFill>
                   <a:srgbClr val="E0A437"/>
                 </a:solidFill>
-                <a:latin typeface="PT Serif"/>
+                <a:latin typeface="Fira Sans"/>
               </a:rPr>
               <a:t>▸ </a:t>
             </a:r>
@@ -4836,9 +4874,9 @@
                 <a:solidFill>
                   <a:srgbClr val="3A4A5C"/>
                 </a:solidFill>
-                <a:latin typeface="PT Serif"/>
-              </a:rPr>
-              <a:t>Mediana: 30 minutos. Percentil 95: 98 minutos.</a:t>
+                <a:latin typeface="Fira Sans"/>
+              </a:rPr>
+              <a:t>Media: $688.274. Mediana: $507.826.</a:t>
             </a:r>
           </a:p>
           <a:p>
@@ -4847,7 +4885,7 @@
                 <a:solidFill>
                   <a:srgbClr val="E0A437"/>
                 </a:solidFill>
-                <a:latin typeface="PT Serif"/>
+                <a:latin typeface="Fira Sans"/>
               </a:rPr>
               <a:t>▸ </a:t>
             </a:r>
@@ -4856,9 +4894,9 @@
                 <a:solidFill>
                   <a:srgbClr val="3A4A5C"/>
                 </a:solidFill>
-                <a:latin typeface="PT Serif"/>
-              </a:rPr>
-              <a:t>Máximo registrado: 1.335 minutos, un viaje de 22 horas.</a:t>
+                <a:latin typeface="Fira Sans"/>
+              </a:rPr>
+              <a:t>La media es un 36% más alta que la mediana.</a:t>
             </a:r>
           </a:p>
           <a:p>
@@ -4867,7 +4905,7 @@
                 <a:solidFill>
                   <a:srgbClr val="E0A437"/>
                 </a:solidFill>
-                <a:latin typeface="PT Serif"/>
+                <a:latin typeface="Fira Sans"/>
               </a:rPr>
               <a:t>▸ </a:t>
             </a:r>
@@ -4876,9 +4914,9 @@
                 <a:solidFill>
                   <a:srgbClr val="3A4A5C"/>
                 </a:solidFill>
-                <a:latin typeface="PT Serif"/>
-              </a:rPr>
-              <a:t>¿Error de digitación? ¿Turno nocturno mal anotado?</a:t>
+                <a:latin typeface="Fira Sans"/>
+              </a:rPr>
+              <a:t>Los ingresos altos desplazan el promedio; la mayoría gana menos.</a:t>
             </a:r>
           </a:p>
           <a:p>
@@ -4887,7 +4925,7 @@
                 <a:solidFill>
                   <a:srgbClr val="E0A437"/>
                 </a:solidFill>
-                <a:latin typeface="PT Serif"/>
+                <a:latin typeface="Fira Sans"/>
               </a:rPr>
               <a:t>▸ </a:t>
             </a:r>
@@ -4896,16 +4934,16 @@
                 <a:solidFill>
                   <a:srgbClr val="1D3557"/>
                 </a:solidFill>
-                <a:latin typeface="PT Serif"/>
-              </a:rPr>
-              <a:t>Los valores extremos se investigan y la decisión se declara.</a:t>
+                <a:latin typeface="Fira Sans"/>
+              </a:rPr>
+              <a:t>El promedio describe una situación en la que la mayoría no está.</a:t>
             </a:r>
           </a:p>
         </p:txBody>
       </p:sp>
       <p:pic>
         <p:nvPicPr>
-          <p:cNvPr id="5" name="Picture 4" descr="04_duracion_viajes.png"/>
+          <p:cNvPr id="5" name="Picture 4" descr="01_ingreso_media_mediana.png"/>
           <p:cNvPicPr>
             <a:picLocks noChangeAspect="1"/>
           </p:cNvPicPr>
@@ -4920,7 +4958,7 @@
         <p:spPr>
           <a:xfrm>
             <a:off x="4892040" y="1371600"/>
-            <a:ext cx="3840480" cy="2196274"/>
+            <a:ext cx="3840480" cy="2182719"/>
           </a:xfrm>
           <a:prstGeom prst="rect">
             <a:avLst/>
@@ -5016,9 +5054,9 @@
                 <a:solidFill>
                   <a:srgbClr val="0F0F0F"/>
                 </a:solidFill>
-                <a:latin typeface="PT Serif"/>
-              </a:rPr>
-              <a:t>¿En qué se mueve Santiago?</a:t>
+                <a:latin typeface="Fira Sans"/>
+              </a:rPr>
+              <a:t>¿Cuánto dura un viaje?</a:t>
             </a:r>
           </a:p>
         </p:txBody>
@@ -5050,7 +5088,7 @@
                 <a:solidFill>
                   <a:srgbClr val="E0A437"/>
                 </a:solidFill>
-                <a:latin typeface="PT Serif"/>
+                <a:latin typeface="Fira Sans"/>
               </a:rPr>
               <a:t>▸ </a:t>
             </a:r>
@@ -5059,69 +5097,9 @@
                 <a:solidFill>
                   <a:srgbClr val="3A4A5C"/>
                 </a:solidFill>
-                <a:latin typeface="PT Serif"/>
-              </a:rPr>
-              <a:t>Dos merges y un groupby ponderado por factor.</a:t>
-            </a:r>
-          </a:p>
-          <a:p>
-            <a:r>
-              <a:rPr sz="1300" b="0">
-                <a:solidFill>
-                  <a:srgbClr val="6B7785"/>
-                </a:solidFill>
-                <a:latin typeface="PT Serif"/>
-              </a:rPr>
-              <a:t>     ◦  </a:t>
-            </a:r>
-            <a:r>
-              <a:rPr sz="1300" b="0">
-                <a:solidFill>
-                  <a:srgbClr val="6B7785"/>
-                </a:solidFill>
-                <a:latin typeface="PT Serif"/>
-              </a:rPr>
-              <a:t>Caminata: 34% de los viajes.</a:t>
-            </a:r>
-          </a:p>
-          <a:p>
-            <a:r>
-              <a:rPr sz="1300" b="0">
-                <a:solidFill>
-                  <a:srgbClr val="6B7785"/>
-                </a:solidFill>
-                <a:latin typeface="PT Serif"/>
-              </a:rPr>
-              <a:t>     ◦  </a:t>
-            </a:r>
-            <a:r>
-              <a:rPr sz="1300" b="0">
-                <a:solidFill>
-                  <a:srgbClr val="6B7785"/>
-                </a:solidFill>
-                <a:latin typeface="PT Serif"/>
-              </a:rPr>
-              <a:t>Transporte público (Bip!): 24%.</a:t>
-            </a:r>
-          </a:p>
-          <a:p>
-            <a:r>
-              <a:rPr sz="1300" b="0">
-                <a:solidFill>
-                  <a:srgbClr val="6B7785"/>
-                </a:solidFill>
-                <a:latin typeface="PT Serif"/>
-              </a:rPr>
-              <a:t>     ◦  </a:t>
-            </a:r>
-            <a:r>
-              <a:rPr sz="1300" b="0">
-                <a:solidFill>
-                  <a:srgbClr val="6B7785"/>
-                </a:solidFill>
-                <a:latin typeface="PT Serif"/>
-              </a:rPr>
-              <a:t>Auto: 23%.</a:t>
+                <a:latin typeface="Fira Sans"/>
+              </a:rPr>
+              <a:t>Mediana: 30 minutos. Percentil 95: 98 minutos.</a:t>
             </a:r>
           </a:p>
           <a:p>
@@ -5130,25 +5108,65 @@
                 <a:solidFill>
                   <a:srgbClr val="E0A437"/>
                 </a:solidFill>
-                <a:latin typeface="PT Serif"/>
+                <a:latin typeface="Fira Sans"/>
               </a:rPr>
               <a:t>▸ </a:t>
             </a:r>
             <a:r>
+              <a:rPr sz="1500" b="0">
+                <a:solidFill>
+                  <a:srgbClr val="3A4A5C"/>
+                </a:solidFill>
+                <a:latin typeface="Fira Sans"/>
+              </a:rPr>
+              <a:t>Máximo registrado: 1.335 minutos, un viaje de 22 horas.</a:t>
+            </a:r>
+          </a:p>
+          <a:p>
+            <a:r>
               <a:rPr sz="1500" b="1">
                 <a:solidFill>
+                  <a:srgbClr val="E0A437"/>
+                </a:solidFill>
+                <a:latin typeface="Fira Sans"/>
+              </a:rPr>
+              <a:t>▸ </a:t>
+            </a:r>
+            <a:r>
+              <a:rPr sz="1500" b="0">
+                <a:solidFill>
+                  <a:srgbClr val="3A4A5C"/>
+                </a:solidFill>
+                <a:latin typeface="Fira Sans"/>
+              </a:rPr>
+              <a:t>¿Error de digitación? ¿Turno nocturno mal anotado?</a:t>
+            </a:r>
+          </a:p>
+          <a:p>
+            <a:r>
+              <a:rPr sz="1500" b="1">
+                <a:solidFill>
+                  <a:srgbClr val="E0A437"/>
+                </a:solidFill>
+                <a:latin typeface="Fira Sans"/>
+              </a:rPr>
+              <a:t>▸ </a:t>
+            </a:r>
+            <a:r>
+              <a:rPr sz="1500" b="1">
+                <a:solidFill>
                   <a:srgbClr val="1D3557"/>
                 </a:solidFill>
-                <a:latin typeface="PT Serif"/>
-              </a:rPr>
-              <a:t>La partición modal de un día laboral, calculada desde los microdatos.</a:t>
+                <a:latin typeface="Fira Sans"/>
+              </a:rPr>
+              <a:t>Los valores extremos se investigan y la decisión se declara.</a:t>
             </a:r>
           </a:p>
         </p:txBody>
       </p:sp>
       <p:pic>
         <p:nvPicPr>
-          <p:cNvPr id="5" name="Picture 4" descr="03_reparto_modal.png"/>
+          <p:cNvPr id="5" name="Picture 4" descr="04_duracion_viajes.png"/>
           <p:cNvPicPr>
             <a:picLocks noChangeAspect="1"/>
           </p:cNvPicPr>
@@ -5163,7 +5181,7 @@
         <p:spPr>
           <a:xfrm>
             <a:off x="4892040" y="1371600"/>
-            <a:ext cx="3840480" cy="1966813"/>
+            <a:ext cx="3840480" cy="2146492"/>
           </a:xfrm>
           <a:prstGeom prst="rect">
             <a:avLst/>
@@ -5259,7 +5277,7 @@
                 <a:solidFill>
                   <a:srgbClr val="0F0F0F"/>
                 </a:solidFill>
-                <a:latin typeface="PT Serif"/>
+                <a:latin typeface="Fira Sans"/>
               </a:rPr>
               <a:t>Qué veremos hoy</a:t>
             </a:r>
@@ -5293,7 +5311,7 @@
                 <a:solidFill>
                   <a:srgbClr val="E0A437"/>
                 </a:solidFill>
-                <a:latin typeface="PT Serif"/>
+                <a:latin typeface="Fira Sans"/>
               </a:rPr>
               <a:t>▸ </a:t>
             </a:r>
@@ -5302,7 +5320,7 @@
                 <a:solidFill>
                   <a:srgbClr val="3A4A5C"/>
                 </a:solidFill>
-                <a:latin typeface="PT Serif"/>
+                <a:latin typeface="Fira Sans"/>
               </a:rPr>
               <a:t>Le haremos preguntas a la Encuesta Origen Destino de Santiago 2012.</a:t>
             </a:r>
@@ -5313,7 +5331,7 @@
                 <a:solidFill>
                   <a:srgbClr val="E0A437"/>
                 </a:solidFill>
-                <a:latin typeface="PT Serif"/>
+                <a:latin typeface="Fira Sans"/>
               </a:rPr>
               <a:t>▸ </a:t>
             </a:r>
@@ -5322,9 +5340,9 @@
                 <a:solidFill>
                   <a:srgbClr val="3A4A5C"/>
                 </a:solidFill>
-                <a:latin typeface="PT Serif"/>
-              </a:rPr>
-              <a:t>El repaso de Pandas va en el camino: cada pregunta trae su herramienta.</a:t>
+                <a:latin typeface="Fira Sans"/>
+              </a:rPr>
+              <a:t>Repasaremos Pandas aplicándolo a esas preguntas.</a:t>
             </a:r>
           </a:p>
           <a:p>
@@ -5333,7 +5351,7 @@
                 <a:solidFill>
                   <a:srgbClr val="6B7785"/>
                 </a:solidFill>
-                <a:latin typeface="PT Serif"/>
+                <a:latin typeface="Fira Sans"/>
               </a:rPr>
               <a:t>     ◦  </a:t>
             </a:r>
@@ -5342,7 +5360,7 @@
                 <a:solidFill>
                   <a:srgbClr val="6B7785"/>
                 </a:solidFill>
-                <a:latin typeface="PT Serif"/>
+                <a:latin typeface="Fira Sans"/>
               </a:rPr>
               <a:t>Merge y sus variantes, groupby, medidas de resumen.</a:t>
             </a:r>
@@ -5353,7 +5371,7 @@
                 <a:solidFill>
                   <a:srgbClr val="6B7785"/>
                 </a:solidFill>
-                <a:latin typeface="PT Serif"/>
+                <a:latin typeface="Fira Sans"/>
               </a:rPr>
               <a:t>     ◦  </a:t>
             </a:r>
@@ -5362,7 +5380,7 @@
                 <a:solidFill>
                   <a:srgbClr val="6B7785"/>
                 </a:solidFill>
-                <a:latin typeface="PT Serif"/>
+                <a:latin typeface="Fira Sans"/>
               </a:rPr>
               <a:t>Lo probablemente nuevo: tablas de códigos y factores de expansión.</a:t>
             </a:r>
@@ -5373,7 +5391,7 @@
                 <a:solidFill>
                   <a:srgbClr val="E0A437"/>
                 </a:solidFill>
-                <a:latin typeface="PT Serif"/>
+                <a:latin typeface="Fira Sans"/>
               </a:rPr>
               <a:t>▸ </a:t>
             </a:r>
@@ -5382,7 +5400,7 @@
                 <a:solidFill>
                   <a:srgbClr val="1D3557"/>
                 </a:solidFill>
-                <a:latin typeface="PT Serif"/>
+                <a:latin typeface="Fira Sans"/>
               </a:rPr>
               <a:t>En el segundo bloque parte la Tarea 1: el retrato de tu comuna.</a:t>
             </a:r>
@@ -5478,16 +5496,139 @@
                 <a:solidFill>
                   <a:srgbClr val="0F0F0F"/>
                 </a:solidFill>
-                <a:latin typeface="PT Serif"/>
-              </a:rPr>
-              <a:t>¿Se mueve igual toda la ciudad?</a:t>
+                <a:latin typeface="Fira Sans"/>
+              </a:rPr>
+              <a:t>¿En qué se mueve Santiago?</a:t>
+            </a:r>
+          </a:p>
+        </p:txBody>
+      </p:sp>
+      <p:sp>
+        <p:nvSpPr>
+          <p:cNvPr id="4" name="TextBox 3"/>
+          <p:cNvSpPr txBox="1"/>
+          <p:nvPr/>
+        </p:nvSpPr>
+        <p:spPr>
+          <a:xfrm>
+            <a:off x="502920" y="1252728"/>
+            <a:ext cx="4023360" cy="3200400"/>
+          </a:xfrm>
+          <a:prstGeom prst="rect">
+            <a:avLst/>
+          </a:prstGeom>
+          <a:noFill/>
+        </p:spPr>
+        <p:txBody>
+          <a:bodyPr wrap="square">
+            <a:spAutoFit/>
+          </a:bodyPr>
+          <a:lstStyle/>
+          <a:p>
+            <a:r>
+              <a:rPr sz="1500" b="1">
+                <a:solidFill>
+                  <a:srgbClr val="E0A437"/>
+                </a:solidFill>
+                <a:latin typeface="Fira Sans"/>
+              </a:rPr>
+              <a:t>▸ </a:t>
+            </a:r>
+            <a:r>
+              <a:rPr sz="1500" b="0">
+                <a:solidFill>
+                  <a:srgbClr val="3A4A5C"/>
+                </a:solidFill>
+                <a:latin typeface="Fira Sans"/>
+              </a:rPr>
+              <a:t>Dos merges y un groupby ponderado por factor.</a:t>
+            </a:r>
+          </a:p>
+          <a:p>
+            <a:r>
+              <a:rPr sz="1300" b="0">
+                <a:solidFill>
+                  <a:srgbClr val="6B7785"/>
+                </a:solidFill>
+                <a:latin typeface="Fira Sans"/>
+              </a:rPr>
+              <a:t>     ◦  </a:t>
+            </a:r>
+            <a:r>
+              <a:rPr sz="1300" b="0">
+                <a:solidFill>
+                  <a:srgbClr val="6B7785"/>
+                </a:solidFill>
+                <a:latin typeface="Fira Sans"/>
+              </a:rPr>
+              <a:t>Caminata: 34% de los viajes.</a:t>
+            </a:r>
+          </a:p>
+          <a:p>
+            <a:r>
+              <a:rPr sz="1300" b="0">
+                <a:solidFill>
+                  <a:srgbClr val="6B7785"/>
+                </a:solidFill>
+                <a:latin typeface="Fira Sans"/>
+              </a:rPr>
+              <a:t>     ◦  </a:t>
+            </a:r>
+            <a:r>
+              <a:rPr sz="1300" b="0">
+                <a:solidFill>
+                  <a:srgbClr val="6B7785"/>
+                </a:solidFill>
+                <a:latin typeface="Fira Sans"/>
+              </a:rPr>
+              <a:t>Transporte público (Bip!): 24%.</a:t>
+            </a:r>
+          </a:p>
+          <a:p>
+            <a:r>
+              <a:rPr sz="1300" b="0">
+                <a:solidFill>
+                  <a:srgbClr val="6B7785"/>
+                </a:solidFill>
+                <a:latin typeface="Fira Sans"/>
+              </a:rPr>
+              <a:t>     ◦  </a:t>
+            </a:r>
+            <a:r>
+              <a:rPr sz="1300" b="0">
+                <a:solidFill>
+                  <a:srgbClr val="6B7785"/>
+                </a:solidFill>
+                <a:latin typeface="Fira Sans"/>
+              </a:rPr>
+              <a:t>Auto: 23%.</a:t>
+            </a:r>
+          </a:p>
+          <a:p>
+            <a:r>
+              <a:rPr sz="1500" b="1">
+                <a:solidFill>
+                  <a:srgbClr val="E0A437"/>
+                </a:solidFill>
+                <a:latin typeface="Fira Sans"/>
+              </a:rPr>
+              <a:t>▸ </a:t>
+            </a:r>
+            <a:r>
+              <a:rPr sz="1500" b="1">
+                <a:solidFill>
+                  <a:srgbClr val="1D3557"/>
+                </a:solidFill>
+                <a:latin typeface="Fira Sans"/>
+              </a:rPr>
+              <a:t>La partición modal de un día laboral, calculada desde los microdatos.</a:t>
             </a:r>
           </a:p>
         </p:txBody>
       </p:sp>
       <p:pic>
         <p:nvPicPr>
-          <p:cNvPr id="4" name="Picture 3" descr="08_modo_por_comuna.png"/>
+          <p:cNvPr id="5" name="Picture 4" descr="03_reparto_modal.png"/>
           <p:cNvPicPr>
             <a:picLocks noChangeAspect="1"/>
           </p:cNvPicPr>
@@ -5501,48 +5642,14 @@
         </p:blipFill>
         <p:spPr>
           <a:xfrm>
-            <a:off x="2011818" y="1143000"/>
-            <a:ext cx="5120362" cy="3154680"/>
+            <a:off x="4892040" y="1371600"/>
+            <a:ext cx="3840480" cy="1938578"/>
           </a:xfrm>
           <a:prstGeom prst="rect">
             <a:avLst/>
           </a:prstGeom>
         </p:spPr>
       </p:pic>
-      <p:sp>
-        <p:nvSpPr>
-          <p:cNvPr id="5" name="TextBox 4"/>
-          <p:cNvSpPr txBox="1"/>
-          <p:nvPr/>
-        </p:nvSpPr>
-        <p:spPr>
-          <a:xfrm>
-            <a:off x="704088" y="4434840"/>
-            <a:ext cx="7744968" cy="457200"/>
-          </a:xfrm>
-          <a:prstGeom prst="rect">
-            <a:avLst/>
-          </a:prstGeom>
-          <a:noFill/>
-        </p:spPr>
-        <p:txBody>
-          <a:bodyPr wrap="square">
-            <a:spAutoFit/>
-          </a:bodyPr>
-          <a:lstStyle/>
-          <a:p>
-            <a:r>
-              <a:rPr sz="1300" b="0">
-                <a:solidFill>
-                  <a:srgbClr val="6B7785"/>
-                </a:solidFill>
-                <a:latin typeface="PT Serif"/>
-              </a:rPr>
-              <a:t>Normalizar por comuna permite comparar proporciones entre comunas de tamaños muy distintos.</a:t>
-            </a:r>
-          </a:p>
-        </p:txBody>
-      </p:sp>
     </p:spTree>
   </p:cSld>
   <p:clrMapOvr>
@@ -5632,139 +5739,16 @@
                 <a:solidFill>
                   <a:srgbClr val="0F0F0F"/>
                 </a:solidFill>
-                <a:latin typeface="PT Serif"/>
-              </a:rPr>
-              <a:t>¿El ingreso explica el uso de transporte público?</a:t>
-            </a:r>
-          </a:p>
-        </p:txBody>
-      </p:sp>
-      <p:sp>
-        <p:nvSpPr>
-          <p:cNvPr id="4" name="TextBox 3"/>
-          <p:cNvSpPr txBox="1"/>
-          <p:nvPr/>
-        </p:nvSpPr>
-        <p:spPr>
-          <a:xfrm>
-            <a:off x="502920" y="1252728"/>
-            <a:ext cx="4023360" cy="3200400"/>
-          </a:xfrm>
-          <a:prstGeom prst="rect">
-            <a:avLst/>
-          </a:prstGeom>
-          <a:noFill/>
-        </p:spPr>
-        <p:txBody>
-          <a:bodyPr wrap="square">
-            <a:spAutoFit/>
-          </a:bodyPr>
-          <a:lstStyle/>
-          <a:p>
-            <a:r>
-              <a:rPr sz="1500" b="1">
-                <a:solidFill>
-                  <a:srgbClr val="E0A437"/>
-                </a:solidFill>
-                <a:latin typeface="PT Serif"/>
-              </a:rPr>
-              <a:t>▸ </a:t>
-            </a:r>
-            <a:r>
-              <a:rPr sz="1500" b="0">
-                <a:solidFill>
-                  <a:srgbClr val="3A4A5C"/>
-                </a:solidFill>
-                <a:latin typeface="PT Serif"/>
-              </a:rPr>
-              <a:t>Cada punto es una comuna: ingreso medio contra proporción de viajes en transporte público.</a:t>
-            </a:r>
-          </a:p>
-          <a:p>
-            <a:r>
-              <a:rPr sz="1300" b="0">
-                <a:solidFill>
-                  <a:srgbClr val="6B7785"/>
-                </a:solidFill>
-                <a:latin typeface="PT Serif"/>
-              </a:rPr>
-              <a:t>     ◦  </a:t>
-            </a:r>
-            <a:r>
-              <a:rPr sz="1300" b="0">
-                <a:solidFill>
-                  <a:srgbClr val="6B7785"/>
-                </a:solidFill>
-                <a:latin typeface="PT Serif"/>
-              </a:rPr>
-              <a:t>Periferia (Buin, Melipilla): poco transporte público porque la red no llega.</a:t>
-            </a:r>
-          </a:p>
-          <a:p>
-            <a:r>
-              <a:rPr sz="1300" b="0">
-                <a:solidFill>
-                  <a:srgbClr val="6B7785"/>
-                </a:solidFill>
-                <a:latin typeface="PT Serif"/>
-              </a:rPr>
-              <a:t>     ◦  </a:t>
-            </a:r>
-            <a:r>
-              <a:rPr sz="1300" b="0">
-                <a:solidFill>
-                  <a:srgbClr val="6B7785"/>
-                </a:solidFill>
-                <a:latin typeface="PT Serif"/>
-              </a:rPr>
-              <a:t>Ingresos altos (Vitacura, Lo Barnechea): conectadas, pero con poco uso.</a:t>
-            </a:r>
-          </a:p>
-          <a:p>
-            <a:r>
-              <a:rPr sz="1300" b="0">
-                <a:solidFill>
-                  <a:srgbClr val="6B7785"/>
-                </a:solidFill>
-                <a:latin typeface="PT Serif"/>
-              </a:rPr>
-              <a:t>     ◦  </a:t>
-            </a:r>
-            <a:r>
-              <a:rPr sz="1300" b="0">
-                <a:solidFill>
-                  <a:srgbClr val="6B7785"/>
-                </a:solidFill>
-                <a:latin typeface="PT Serif"/>
-              </a:rPr>
-              <a:t>La Pintana o Conchalí superan el 45%.</a:t>
-            </a:r>
-          </a:p>
-          <a:p>
-            <a:r>
-              <a:rPr sz="1500" b="1">
-                <a:solidFill>
-                  <a:srgbClr val="E0A437"/>
-                </a:solidFill>
-                <a:latin typeface="PT Serif"/>
-              </a:rPr>
-              <a:t>▸ </a:t>
-            </a:r>
-            <a:r>
-              <a:rPr sz="1500" b="1">
-                <a:solidFill>
-                  <a:srgbClr val="1D3557"/>
-                </a:solidFill>
-                <a:latin typeface="PT Serif"/>
-              </a:rPr>
-              <a:t>Un promedio comunal también esconde variación: ¿de quién habla ese punto?</a:t>
+                <a:latin typeface="Fira Sans"/>
+              </a:rPr>
+              <a:t>¿Se mueve igual toda la ciudad?</a:t>
             </a:r>
           </a:p>
         </p:txBody>
       </p:sp>
       <p:pic>
         <p:nvPicPr>
-          <p:cNvPr id="5" name="Picture 4" descr="09_ingreso_vs_tp.png"/>
+          <p:cNvPr id="4" name="Picture 3" descr="08_modo_por_comuna.png"/>
           <p:cNvPicPr>
             <a:picLocks noChangeAspect="1"/>
           </p:cNvPicPr>
@@ -5778,14 +5762,48 @@
         </p:blipFill>
         <p:spPr>
           <a:xfrm>
-            <a:off x="4892040" y="1371600"/>
-            <a:ext cx="3840480" cy="2551368"/>
+            <a:off x="1994250" y="1143000"/>
+            <a:ext cx="5155498" cy="3154679"/>
           </a:xfrm>
           <a:prstGeom prst="rect">
             <a:avLst/>
           </a:prstGeom>
         </p:spPr>
       </p:pic>
+      <p:sp>
+        <p:nvSpPr>
+          <p:cNvPr id="5" name="TextBox 4"/>
+          <p:cNvSpPr txBox="1"/>
+          <p:nvPr/>
+        </p:nvSpPr>
+        <p:spPr>
+          <a:xfrm>
+            <a:off x="704088" y="4434840"/>
+            <a:ext cx="7744968" cy="457200"/>
+          </a:xfrm>
+          <a:prstGeom prst="rect">
+            <a:avLst/>
+          </a:prstGeom>
+          <a:noFill/>
+        </p:spPr>
+        <p:txBody>
+          <a:bodyPr wrap="square">
+            <a:spAutoFit/>
+          </a:bodyPr>
+          <a:lstStyle/>
+          <a:p>
+            <a:r>
+              <a:rPr sz="1300" b="0">
+                <a:solidFill>
+                  <a:srgbClr val="6B7785"/>
+                </a:solidFill>
+                <a:latin typeface="Fira Sans"/>
+              </a:rPr>
+              <a:t>Normalizar por comuna permite comparar proporciones entre comunas de tamaños muy distintos.</a:t>
+            </a:r>
+          </a:p>
+        </p:txBody>
+      </p:sp>
     </p:spTree>
   </p:cSld>
   <p:clrMapOvr>
@@ -5875,16 +5893,139 @@
                 <a:solidFill>
                   <a:srgbClr val="0F0F0F"/>
                 </a:solidFill>
-                <a:latin typeface="PT Serif"/>
-              </a:rPr>
-              <a:t>¿Cambian las rutinas durante la semana?</a:t>
+                <a:latin typeface="Fira Sans"/>
+              </a:rPr>
+              <a:t>¿El ingreso explica el uso de transporte público?</a:t>
+            </a:r>
+          </a:p>
+        </p:txBody>
+      </p:sp>
+      <p:sp>
+        <p:nvSpPr>
+          <p:cNvPr id="4" name="TextBox 3"/>
+          <p:cNvSpPr txBox="1"/>
+          <p:nvPr/>
+        </p:nvSpPr>
+        <p:spPr>
+          <a:xfrm>
+            <a:off x="502920" y="1252728"/>
+            <a:ext cx="4023360" cy="3200400"/>
+          </a:xfrm>
+          <a:prstGeom prst="rect">
+            <a:avLst/>
+          </a:prstGeom>
+          <a:noFill/>
+        </p:spPr>
+        <p:txBody>
+          <a:bodyPr wrap="square">
+            <a:spAutoFit/>
+          </a:bodyPr>
+          <a:lstStyle/>
+          <a:p>
+            <a:r>
+              <a:rPr sz="1500" b="1">
+                <a:solidFill>
+                  <a:srgbClr val="E0A437"/>
+                </a:solidFill>
+                <a:latin typeface="Fira Sans"/>
+              </a:rPr>
+              <a:t>▸ </a:t>
+            </a:r>
+            <a:r>
+              <a:rPr sz="1500" b="0">
+                <a:solidFill>
+                  <a:srgbClr val="3A4A5C"/>
+                </a:solidFill>
+                <a:latin typeface="Fira Sans"/>
+              </a:rPr>
+              <a:t>Cada punto es una comuna: ingreso medio contra proporción de viajes en transporte público.</a:t>
+            </a:r>
+          </a:p>
+          <a:p>
+            <a:r>
+              <a:rPr sz="1300" b="0">
+                <a:solidFill>
+                  <a:srgbClr val="6B7785"/>
+                </a:solidFill>
+                <a:latin typeface="Fira Sans"/>
+              </a:rPr>
+              <a:t>     ◦  </a:t>
+            </a:r>
+            <a:r>
+              <a:rPr sz="1300" b="0">
+                <a:solidFill>
+                  <a:srgbClr val="6B7785"/>
+                </a:solidFill>
+                <a:latin typeface="Fira Sans"/>
+              </a:rPr>
+              <a:t>Periferia (Buin, Melipilla): poco transporte público; la red no llega.</a:t>
+            </a:r>
+          </a:p>
+          <a:p>
+            <a:r>
+              <a:rPr sz="1300" b="0">
+                <a:solidFill>
+                  <a:srgbClr val="6B7785"/>
+                </a:solidFill>
+                <a:latin typeface="Fira Sans"/>
+              </a:rPr>
+              <a:t>     ◦  </a:t>
+            </a:r>
+            <a:r>
+              <a:rPr sz="1300" b="0">
+                <a:solidFill>
+                  <a:srgbClr val="6B7785"/>
+                </a:solidFill>
+                <a:latin typeface="Fira Sans"/>
+              </a:rPr>
+              <a:t>Ingresos altos (Vitacura, Lo Barnechea): conectadas, con poco uso.</a:t>
+            </a:r>
+          </a:p>
+          <a:p>
+            <a:r>
+              <a:rPr sz="1300" b="0">
+                <a:solidFill>
+                  <a:srgbClr val="6B7785"/>
+                </a:solidFill>
+                <a:latin typeface="Fira Sans"/>
+              </a:rPr>
+              <a:t>     ◦  </a:t>
+            </a:r>
+            <a:r>
+              <a:rPr sz="1300" b="0">
+                <a:solidFill>
+                  <a:srgbClr val="6B7785"/>
+                </a:solidFill>
+                <a:latin typeface="Fira Sans"/>
+              </a:rPr>
+              <a:t>Correlación de Pearson: -0,17. La asociación lineal es débil.</a:t>
+            </a:r>
+          </a:p>
+          <a:p>
+            <a:r>
+              <a:rPr sz="1500" b="1">
+                <a:solidFill>
+                  <a:srgbClr val="E0A437"/>
+                </a:solidFill>
+                <a:latin typeface="Fira Sans"/>
+              </a:rPr>
+              <a:t>▸ </a:t>
+            </a:r>
+            <a:r>
+              <a:rPr sz="1500" b="1">
+                <a:solidFill>
+                  <a:srgbClr val="1D3557"/>
+                </a:solidFill>
+                <a:latin typeface="Fira Sans"/>
+              </a:rPr>
+              <a:t>El coeficiente no reemplaza al gráfico: la estructura está en los grupos.</a:t>
             </a:r>
           </a:p>
         </p:txBody>
       </p:sp>
       <p:pic>
         <p:nvPicPr>
-          <p:cNvPr id="4" name="Picture 3" descr="10_heatmap_rutinas.png"/>
+          <p:cNvPr id="5" name="Picture 4" descr="09_ingreso_vs_tp.png"/>
           <p:cNvPicPr>
             <a:picLocks noChangeAspect="1"/>
           </p:cNvPicPr>
@@ -5898,48 +6039,14 @@
         </p:blipFill>
         <p:spPr>
           <a:xfrm>
-            <a:off x="1631108" y="1143000"/>
-            <a:ext cx="5881783" cy="3154680"/>
+            <a:off x="4892040" y="1371600"/>
+            <a:ext cx="3840480" cy="2526979"/>
           </a:xfrm>
           <a:prstGeom prst="rect">
             <a:avLst/>
           </a:prstGeom>
         </p:spPr>
       </p:pic>
-      <p:sp>
-        <p:nvSpPr>
-          <p:cNvPr id="5" name="TextBox 4"/>
-          <p:cNvSpPr txBox="1"/>
-          <p:nvPr/>
-        </p:nvSpPr>
-        <p:spPr>
-          <a:xfrm>
-            <a:off x="704088" y="4434840"/>
-            <a:ext cx="7744968" cy="457200"/>
-          </a:xfrm>
-          <a:prstGeom prst="rect">
-            <a:avLst/>
-          </a:prstGeom>
-          <a:noFill/>
-        </p:spPr>
-        <p:txBody>
-          <a:bodyPr wrap="square">
-            <a:spAutoFit/>
-          </a:bodyPr>
-          <a:lstStyle/>
-          <a:p>
-            <a:r>
-              <a:rPr sz="1300" b="0">
-                <a:solidFill>
-                  <a:srgbClr val="6B7785"/>
-                </a:solidFill>
-                <a:latin typeface="PT Serif"/>
-              </a:rPr>
-              <a:t>El heatmap muestra 14 propósitos por 7 días en una sola figura: útil para tablas completas.</a:t>
-            </a:r>
-          </a:p>
-        </p:txBody>
-      </p:sp>
     </p:spTree>
   </p:cSld>
   <p:clrMapOvr>
@@ -6029,9 +6136,9 @@
                 <a:solidFill>
                   <a:srgbClr val="0F0F0F"/>
                 </a:solidFill>
-                <a:latin typeface="PT Serif"/>
-              </a:rPr>
-              <a:t>Síntesis: ¿de quién habla este número?</a:t>
+                <a:latin typeface="Fira Sans"/>
+              </a:rPr>
+              <a:t>Correlación y causalidad</a:t>
             </a:r>
           </a:p>
         </p:txBody>
@@ -6063,7 +6170,7 @@
                 <a:solidFill>
                   <a:srgbClr val="E0A437"/>
                 </a:solidFill>
-                <a:latin typeface="PT Serif"/>
+                <a:latin typeface="Fira Sans"/>
               </a:rPr>
               <a:t>▸ </a:t>
             </a:r>
@@ -6072,9 +6179,9 @@
                 <a:solidFill>
                   <a:srgbClr val="3A4A5C"/>
                 </a:solidFill>
-                <a:latin typeface="PT Serif"/>
-              </a:rPr>
-              <a:t>'El hogar promedio gana $688 mil': la mayoría gana menos; la mediana describe al hogar típico.</a:t>
+                <a:latin typeface="Fira Sans"/>
+              </a:rPr>
+              <a:t>Correlación: dos variables varían juntas.</a:t>
             </a:r>
           </a:p>
           <a:p>
@@ -6083,7 +6190,7 @@
                 <a:solidFill>
                   <a:srgbClr val="E0A437"/>
                 </a:solidFill>
-                <a:latin typeface="PT Serif"/>
+                <a:latin typeface="Fira Sans"/>
               </a:rPr>
               <a:t>▸ </a:t>
             </a:r>
@@ -6092,9 +6199,69 @@
                 <a:solidFill>
                   <a:srgbClr val="3A4A5C"/>
                 </a:solidFill>
-                <a:latin typeface="PT Serif"/>
-              </a:rPr>
-              <a:t>'El 53% de los encuestados...': habla de la muestra; los factores de expansión hablan de la ciudad.</a:t>
+                <a:latin typeface="Fira Sans"/>
+              </a:rPr>
+              <a:t>Causalidad: intervenir una cambiaría la otra. Es una afirmación más fuerte.</a:t>
+            </a:r>
+          </a:p>
+          <a:p>
+            <a:r>
+              <a:rPr sz="1400" b="0">
+                <a:solidFill>
+                  <a:srgbClr val="6B7785"/>
+                </a:solidFill>
+                <a:latin typeface="Fira Sans"/>
+              </a:rPr>
+              <a:t>     ◦  </a:t>
+            </a:r>
+            <a:r>
+              <a:rPr sz="1400" b="0">
+                <a:solidFill>
+                  <a:srgbClr val="6B7785"/>
+                </a:solidFill>
+                <a:latin typeface="Fira Sans"/>
+              </a:rPr>
+              <a:t>Los datos observacionales muestran lo primero, no bastan para lo segundo.</a:t>
+            </a:r>
+          </a:p>
+          <a:p>
+            <a:r>
+              <a:rPr sz="1400" b="0">
+                <a:solidFill>
+                  <a:srgbClr val="6B7785"/>
+                </a:solidFill>
+                <a:latin typeface="Fira Sans"/>
+              </a:rPr>
+              <a:t>     ◦  </a:t>
+            </a:r>
+            <a:r>
+              <a:rPr sz="1400" b="0">
+                <a:solidFill>
+                  <a:srgbClr val="6B7785"/>
+                </a:solidFill>
+                <a:latin typeface="Fira Sans"/>
+              </a:rPr>
+              <a:t>Variable de confusión: la cobertura de la red afecta el uso y no es independiente del ingreso.</a:t>
+            </a:r>
+          </a:p>
+          <a:p>
+            <a:r>
+              <a:rPr sz="1400" b="0">
+                <a:solidFill>
+                  <a:srgbClr val="6B7785"/>
+                </a:solidFill>
+                <a:latin typeface="Fira Sans"/>
+              </a:rPr>
+              <a:t>     ◦  </a:t>
+            </a:r>
+            <a:r>
+              <a:rPr sz="1400" b="0">
+                <a:solidFill>
+                  <a:srgbClr val="6B7785"/>
+                </a:solidFill>
+                <a:latin typeface="Fira Sans"/>
+              </a:rPr>
+              <a:t>La inferencia causal tiene métodos propios; este curso no los cubre.</a:t>
             </a:r>
           </a:p>
           <a:p>
@@ -6103,58 +6270,18 @@
                 <a:solidFill>
                   <a:srgbClr val="E0A437"/>
                 </a:solidFill>
-                <a:latin typeface="PT Serif"/>
+                <a:latin typeface="Fira Sans"/>
               </a:rPr>
               <a:t>▸ </a:t>
             </a:r>
             <a:r>
-              <a:rPr sz="1800" b="0">
-                <a:solidFill>
-                  <a:srgbClr val="3A4A5C"/>
-                </a:solidFill>
-                <a:latin typeface="PT Serif"/>
-              </a:rPr>
-              <a:t>'1,9 viajes en promedio': solo si contamos a quienes no viajaron; un inner los borra sin aviso.</a:t>
-            </a:r>
-          </a:p>
-          <a:p>
-            <a:r>
               <a:rPr sz="1800" b="1">
                 <a:solidFill>
-                  <a:srgbClr val="E0A437"/>
-                </a:solidFill>
-                <a:latin typeface="PT Serif"/>
-              </a:rPr>
-              <a:t>▸ </a:t>
-            </a:r>
-            <a:r>
-              <a:rPr sz="1800" b="0">
-                <a:solidFill>
-                  <a:srgbClr val="3A4A5C"/>
-                </a:solidFill>
-                <a:latin typeface="PT Serif"/>
-              </a:rPr>
-              <a:t>'En Vitacura casi no se usa transporte público': un promedio comunal esconde la variación interna.</a:t>
-            </a:r>
-          </a:p>
-          <a:p>
-            <a:r>
-              <a:rPr sz="1800" b="1">
-                <a:solidFill>
-                  <a:srgbClr val="E0A437"/>
-                </a:solidFill>
-                <a:latin typeface="PT Serif"/>
-              </a:rPr>
-              <a:t>▸ </a:t>
-            </a:r>
-            <a:r>
-              <a:rPr sz="1800" b="1">
-                <a:solidFill>
                   <a:srgbClr val="1D3557"/>
                 </a:solidFill>
-                <a:latin typeface="PT Serif"/>
-              </a:rPr>
-              <a:t>La técnica era repaso; el hábito de examinar cada cifra es lo nuevo.</a:t>
+                <a:latin typeface="Fira Sans"/>
+              </a:rPr>
+              <a:t>Una asociación se reporta como asociación, sin verbos causales que los datos no respaldan.</a:t>
             </a:r>
           </a:p>
         </p:txBody>
@@ -6248,23 +6375,47 @@
                 <a:solidFill>
                   <a:srgbClr val="0F0F0F"/>
                 </a:solidFill>
-                <a:latin typeface="PT Serif"/>
-              </a:rPr>
-              <a:t>Segundo bloque: parte la Tarea 1</a:t>
-            </a:r>
-          </a:p>
-        </p:txBody>
-      </p:sp>
-      <p:sp>
-        <p:nvSpPr>
-          <p:cNvPr id="4" name="TextBox 3"/>
+                <a:latin typeface="Fira Sans"/>
+              </a:rPr>
+              <a:t>¿Cambian las rutinas durante la semana?</a:t>
+            </a:r>
+          </a:p>
+        </p:txBody>
+      </p:sp>
+      <p:pic>
+        <p:nvPicPr>
+          <p:cNvPr id="4" name="Picture 3" descr="10_heatmap_rutinas.png"/>
+          <p:cNvPicPr>
+            <a:picLocks noChangeAspect="1"/>
+          </p:cNvPicPr>
+          <p:nvPr/>
+        </p:nvPicPr>
+        <p:blipFill>
+          <a:blip r:embed="rId2"/>
+          <a:stretch>
+            <a:fillRect/>
+          </a:stretch>
+        </p:blipFill>
+        <p:spPr>
+          <a:xfrm>
+            <a:off x="1563778" y="1143000"/>
+            <a:ext cx="6016443" cy="3154680"/>
+          </a:xfrm>
+          <a:prstGeom prst="rect">
+            <a:avLst/>
+          </a:prstGeom>
+        </p:spPr>
+      </p:pic>
+      <p:sp>
+        <p:nvSpPr>
+          <p:cNvPr id="5" name="TextBox 4"/>
           <p:cNvSpPr txBox="1"/>
           <p:nvPr/>
         </p:nvSpPr>
         <p:spPr>
           <a:xfrm>
-            <a:off x="704088" y="1353312"/>
-            <a:ext cx="7744968" cy="3300984"/>
+            <a:off x="704088" y="4434840"/>
+            <a:ext cx="7744968" cy="457200"/>
           </a:xfrm>
           <a:prstGeom prst="rect">
             <a:avLst/>
@@ -6278,11 +6429,141 @@
           <a:lstStyle/>
           <a:p>
             <a:r>
+              <a:rPr sz="1300" b="0">
+                <a:solidFill>
+                  <a:srgbClr val="6B7785"/>
+                </a:solidFill>
+                <a:latin typeface="Fira Sans"/>
+              </a:rPr>
+              <a:t>El heatmap muestra 14 propósitos por 7 días en una sola figura: útil para tablas completas.</a:t>
+            </a:r>
+          </a:p>
+        </p:txBody>
+      </p:sp>
+    </p:spTree>
+  </p:cSld>
+  <p:clrMapOvr>
+    <a:masterClrMapping/>
+  </p:clrMapOvr>
+</p:sld>
+</file>
+
+<file path=ppt/slides/slide25.xml><?xml version="1.0" encoding="utf-8"?>
+<p:sld xmlns:a="http://schemas.openxmlformats.org/drawingml/2006/main" xmlns:p="http://schemas.openxmlformats.org/presentationml/2006/main" xmlns:r="http://schemas.openxmlformats.org/officeDocument/2006/relationships">
+  <p:cSld>
+    <p:spTree>
+      <p:nvGrpSpPr>
+        <p:cNvPr id="1" name=""/>
+        <p:cNvGrpSpPr/>
+        <p:nvPr/>
+      </p:nvGrpSpPr>
+      <p:grpSpPr/>
+      <p:sp>
+        <p:nvSpPr>
+          <p:cNvPr id="2" name="Rectangle 1"/>
+          <p:cNvSpPr/>
+          <p:nvPr/>
+        </p:nvSpPr>
+        <p:spPr>
+          <a:xfrm>
+            <a:off x="0" y="0"/>
+            <a:ext cx="9144000" cy="5138928"/>
+          </a:xfrm>
+          <a:prstGeom prst="rect">
+            <a:avLst/>
+          </a:prstGeom>
+          <a:solidFill>
+            <a:srgbClr val="FAFBFC"/>
+          </a:solidFill>
+          <a:ln>
+            <a:noFill/>
+          </a:ln>
+          <a:effectLst/>
+        </p:spPr>
+        <p:style>
+          <a:lnRef idx="1">
+            <a:schemeClr val="accent1"/>
+          </a:lnRef>
+          <a:fillRef idx="3">
+            <a:schemeClr val="accent1"/>
+          </a:fillRef>
+          <a:effectRef idx="2">
+            <a:schemeClr val="accent1"/>
+          </a:effectRef>
+          <a:fontRef idx="minor">
+            <a:schemeClr val="lt1"/>
+          </a:fontRef>
+        </p:style>
+        <p:txBody>
+          <a:bodyPr rtlCol="0" anchor="ctr"/>
+          <a:lstStyle/>
+          <a:p>
+            <a:pPr algn="ctr"/>
+          </a:p>
+        </p:txBody>
+      </p:sp>
+      <p:sp>
+        <p:nvSpPr>
+          <p:cNvPr id="3" name="TextBox 2"/>
+          <p:cNvSpPr txBox="1"/>
+          <p:nvPr/>
+        </p:nvSpPr>
+        <p:spPr>
+          <a:xfrm>
+            <a:off x="402336" y="301752"/>
+            <a:ext cx="8348472" cy="795528"/>
+          </a:xfrm>
+          <a:prstGeom prst="rect">
+            <a:avLst/>
+          </a:prstGeom>
+          <a:noFill/>
+        </p:spPr>
+        <p:txBody>
+          <a:bodyPr wrap="square">
+            <a:spAutoFit/>
+          </a:bodyPr>
+          <a:lstStyle/>
+          <a:p>
+            <a:r>
+              <a:rPr sz="2800" b="1">
+                <a:solidFill>
+                  <a:srgbClr val="0F0F0F"/>
+                </a:solidFill>
+                <a:latin typeface="Fira Sans"/>
+              </a:rPr>
+              <a:t>Síntesis: ¿de quién habla este número?</a:t>
+            </a:r>
+          </a:p>
+        </p:txBody>
+      </p:sp>
+      <p:sp>
+        <p:nvSpPr>
+          <p:cNvPr id="4" name="TextBox 3"/>
+          <p:cNvSpPr txBox="1"/>
+          <p:nvPr/>
+        </p:nvSpPr>
+        <p:spPr>
+          <a:xfrm>
+            <a:off x="704088" y="1353312"/>
+            <a:ext cx="7744968" cy="3300984"/>
+          </a:xfrm>
+          <a:prstGeom prst="rect">
+            <a:avLst/>
+          </a:prstGeom>
+          <a:noFill/>
+        </p:spPr>
+        <p:txBody>
+          <a:bodyPr wrap="square">
+            <a:spAutoFit/>
+          </a:bodyPr>
+          <a:lstStyle/>
+          <a:p>
+            <a:r>
               <a:rPr sz="1800" b="1">
                 <a:solidFill>
                   <a:srgbClr val="E0A437"/>
                 </a:solidFill>
-                <a:latin typeface="PT Serif"/>
+                <a:latin typeface="Fira Sans"/>
               </a:rPr>
               <a:t>▸ </a:t>
             </a:r>
@@ -6291,7 +6572,226 @@
                 <a:solidFill>
                   <a:srgbClr val="3A4A5C"/>
                 </a:solidFill>
-                <a:latin typeface="PT Serif"/>
+                <a:latin typeface="Fira Sans"/>
+              </a:rPr>
+              <a:t>'El hogar promedio gana $688 mil': la mayoría gana menos; la mediana describe al hogar típico.</a:t>
+            </a:r>
+          </a:p>
+          <a:p>
+            <a:r>
+              <a:rPr sz="1800" b="1">
+                <a:solidFill>
+                  <a:srgbClr val="E0A437"/>
+                </a:solidFill>
+                <a:latin typeface="Fira Sans"/>
+              </a:rPr>
+              <a:t>▸ </a:t>
+            </a:r>
+            <a:r>
+              <a:rPr sz="1800" b="0">
+                <a:solidFill>
+                  <a:srgbClr val="3A4A5C"/>
+                </a:solidFill>
+                <a:latin typeface="Fira Sans"/>
+              </a:rPr>
+              <a:t>'El 53% de los encuestados...': habla de la muestra; los factores de expansión hablan de la ciudad.</a:t>
+            </a:r>
+          </a:p>
+          <a:p>
+            <a:r>
+              <a:rPr sz="1800" b="1">
+                <a:solidFill>
+                  <a:srgbClr val="E0A437"/>
+                </a:solidFill>
+                <a:latin typeface="Fira Sans"/>
+              </a:rPr>
+              <a:t>▸ </a:t>
+            </a:r>
+            <a:r>
+              <a:rPr sz="1800" b="0">
+                <a:solidFill>
+                  <a:srgbClr val="3A4A5C"/>
+                </a:solidFill>
+                <a:latin typeface="Fira Sans"/>
+              </a:rPr>
+              <a:t>'1,9 viajes en promedio': solo si contamos a quienes no viajaron; un inner los borra sin aviso.</a:t>
+            </a:r>
+          </a:p>
+          <a:p>
+            <a:r>
+              <a:rPr sz="1800" b="1">
+                <a:solidFill>
+                  <a:srgbClr val="E0A437"/>
+                </a:solidFill>
+                <a:latin typeface="Fira Sans"/>
+              </a:rPr>
+              <a:t>▸ </a:t>
+            </a:r>
+            <a:r>
+              <a:rPr sz="1800" b="0">
+                <a:solidFill>
+                  <a:srgbClr val="3A4A5C"/>
+                </a:solidFill>
+                <a:latin typeface="Fira Sans"/>
+              </a:rPr>
+              <a:t>'En Vitacura casi no se usa transporte público': un promedio comunal esconde la variación interna.</a:t>
+            </a:r>
+          </a:p>
+          <a:p>
+            <a:r>
+              <a:rPr sz="1800" b="1">
+                <a:solidFill>
+                  <a:srgbClr val="E0A437"/>
+                </a:solidFill>
+                <a:latin typeface="Fira Sans"/>
+              </a:rPr>
+              <a:t>▸ </a:t>
+            </a:r>
+            <a:r>
+              <a:rPr sz="1800" b="1">
+                <a:solidFill>
+                  <a:srgbClr val="1D3557"/>
+                </a:solidFill>
+                <a:latin typeface="Fira Sans"/>
+              </a:rPr>
+              <a:t>Las operaciones eran repaso; lo nuevo es examinar qué representa cada cifra.</a:t>
+            </a:r>
+          </a:p>
+        </p:txBody>
+      </p:sp>
+    </p:spTree>
+  </p:cSld>
+  <p:clrMapOvr>
+    <a:masterClrMapping/>
+  </p:clrMapOvr>
+</p:sld>
+</file>
+
+<file path=ppt/slides/slide26.xml><?xml version="1.0" encoding="utf-8"?>
+<p:sld xmlns:a="http://schemas.openxmlformats.org/drawingml/2006/main" xmlns:p="http://schemas.openxmlformats.org/presentationml/2006/main" xmlns:r="http://schemas.openxmlformats.org/officeDocument/2006/relationships">
+  <p:cSld>
+    <p:spTree>
+      <p:nvGrpSpPr>
+        <p:cNvPr id="1" name=""/>
+        <p:cNvGrpSpPr/>
+        <p:nvPr/>
+      </p:nvGrpSpPr>
+      <p:grpSpPr/>
+      <p:sp>
+        <p:nvSpPr>
+          <p:cNvPr id="2" name="Rectangle 1"/>
+          <p:cNvSpPr/>
+          <p:nvPr/>
+        </p:nvSpPr>
+        <p:spPr>
+          <a:xfrm>
+            <a:off x="0" y="0"/>
+            <a:ext cx="9144000" cy="5138928"/>
+          </a:xfrm>
+          <a:prstGeom prst="rect">
+            <a:avLst/>
+          </a:prstGeom>
+          <a:solidFill>
+            <a:srgbClr val="FAFBFC"/>
+          </a:solidFill>
+          <a:ln>
+            <a:noFill/>
+          </a:ln>
+          <a:effectLst/>
+        </p:spPr>
+        <p:style>
+          <a:lnRef idx="1">
+            <a:schemeClr val="accent1"/>
+          </a:lnRef>
+          <a:fillRef idx="3">
+            <a:schemeClr val="accent1"/>
+          </a:fillRef>
+          <a:effectRef idx="2">
+            <a:schemeClr val="accent1"/>
+          </a:effectRef>
+          <a:fontRef idx="minor">
+            <a:schemeClr val="lt1"/>
+          </a:fontRef>
+        </p:style>
+        <p:txBody>
+          <a:bodyPr rtlCol="0" anchor="ctr"/>
+          <a:lstStyle/>
+          <a:p>
+            <a:pPr algn="ctr"/>
+          </a:p>
+        </p:txBody>
+      </p:sp>
+      <p:sp>
+        <p:nvSpPr>
+          <p:cNvPr id="3" name="TextBox 2"/>
+          <p:cNvSpPr txBox="1"/>
+          <p:nvPr/>
+        </p:nvSpPr>
+        <p:spPr>
+          <a:xfrm>
+            <a:off x="402336" y="301752"/>
+            <a:ext cx="8348472" cy="795528"/>
+          </a:xfrm>
+          <a:prstGeom prst="rect">
+            <a:avLst/>
+          </a:prstGeom>
+          <a:noFill/>
+        </p:spPr>
+        <p:txBody>
+          <a:bodyPr wrap="square">
+            <a:spAutoFit/>
+          </a:bodyPr>
+          <a:lstStyle/>
+          <a:p>
+            <a:r>
+              <a:rPr sz="2800" b="1">
+                <a:solidFill>
+                  <a:srgbClr val="0F0F0F"/>
+                </a:solidFill>
+                <a:latin typeface="Fira Sans"/>
+              </a:rPr>
+              <a:t>Segundo bloque: parte la Tarea 1</a:t>
+            </a:r>
+          </a:p>
+        </p:txBody>
+      </p:sp>
+      <p:sp>
+        <p:nvSpPr>
+          <p:cNvPr id="4" name="TextBox 3"/>
+          <p:cNvSpPr txBox="1"/>
+          <p:nvPr/>
+        </p:nvSpPr>
+        <p:spPr>
+          <a:xfrm>
+            <a:off x="704088" y="1353312"/>
+            <a:ext cx="7744968" cy="3300984"/>
+          </a:xfrm>
+          <a:prstGeom prst="rect">
+            <a:avLst/>
+          </a:prstGeom>
+          <a:noFill/>
+        </p:spPr>
+        <p:txBody>
+          <a:bodyPr wrap="square">
+            <a:spAutoFit/>
+          </a:bodyPr>
+          <a:lstStyle/>
+          <a:p>
+            <a:r>
+              <a:rPr sz="1800" b="1">
+                <a:solidFill>
+                  <a:srgbClr val="E0A437"/>
+                </a:solidFill>
+                <a:latin typeface="Fira Sans"/>
+              </a:rPr>
+              <a:t>▸ </a:t>
+            </a:r>
+            <a:r>
+              <a:rPr sz="1800" b="0">
+                <a:solidFill>
+                  <a:srgbClr val="3A4A5C"/>
+                </a:solidFill>
+                <a:latin typeface="Fira Sans"/>
               </a:rPr>
               <a:t>El retrato de tu comuna: cada pareja adopta una comuna del Gran Santiago.</a:t>
             </a:r>
@@ -6302,7 +6802,7 @@
                 <a:solidFill>
                   <a:srgbClr val="6B7785"/>
                 </a:solidFill>
-                <a:latin typeface="PT Serif"/>
+                <a:latin typeface="Fira Sans"/>
               </a:rPr>
               <a:t>     ◦  </a:t>
             </a:r>
@@ -6311,7 +6811,7 @@
                 <a:solidFill>
                   <a:srgbClr val="6B7785"/>
                 </a:solidFill>
-                <a:latin typeface="PT Serif"/>
+                <a:latin typeface="Fira Sans"/>
               </a:rPr>
               <a:t>Hoy: elegir la comuna y construir su retrato numérico.</a:t>
             </a:r>
@@ -6322,7 +6822,7 @@
                 <a:solidFill>
                   <a:srgbClr val="6B7785"/>
                 </a:solidFill>
-                <a:latin typeface="PT Serif"/>
+                <a:latin typeface="Fira Sans"/>
               </a:rPr>
               <a:t>     ◦  </a:t>
             </a:r>
@@ -6331,7 +6831,7 @@
                 <a:solidFill>
                   <a:srgbClr val="6B7785"/>
                 </a:solidFill>
-                <a:latin typeface="PT Serif"/>
+                <a:latin typeface="Fira Sans"/>
               </a:rPr>
               <a:t>Próxima clase: el retrato gráfico, con métodos de visualización.</a:t>
             </a:r>
@@ -6342,7 +6842,7 @@
                 <a:solidFill>
                   <a:srgbClr val="6B7785"/>
                 </a:solidFill>
-                <a:latin typeface="PT Serif"/>
+                <a:latin typeface="Fira Sans"/>
               </a:rPr>
               <a:t>     ◦  </a:t>
             </a:r>
@@ -6351,7 +6851,7 @@
                 <a:solidFill>
                   <a:srgbClr val="6B7785"/>
                 </a:solidFill>
-                <a:latin typeface="PT Serif"/>
+                <a:latin typeface="Fira Sans"/>
               </a:rPr>
               <a:t>Entrega del retrato completo: jueves 10 de septiembre, por Aula.</a:t>
             </a:r>
@@ -6362,7 +6862,7 @@
                 <a:solidFill>
                   <a:srgbClr val="E0A437"/>
                 </a:solidFill>
-                <a:latin typeface="PT Serif"/>
+                <a:latin typeface="Fira Sans"/>
               </a:rPr>
               <a:t>▸ </a:t>
             </a:r>
@@ -6371,7 +6871,7 @@
                 <a:solidFill>
                   <a:srgbClr val="3A4A5C"/>
                 </a:solidFill>
-                <a:latin typeface="PT Serif"/>
+                <a:latin typeface="Fira Sans"/>
               </a:rPr>
               <a:t>El enunciado está en evaluaciones/tareas/ y la guía de hoy en actividades/.</a:t>
             </a:r>
@@ -6382,7 +6882,7 @@
                 <a:solidFill>
                   <a:srgbClr val="E0A437"/>
                 </a:solidFill>
-                <a:latin typeface="PT Serif"/>
+                <a:latin typeface="Fira Sans"/>
               </a:rPr>
               <a:t>▸ </a:t>
             </a:r>
@@ -6391,7 +6891,7 @@
                 <a:solidFill>
                   <a:srgbClr val="1D3557"/>
                 </a:solidFill>
-                <a:latin typeface="PT Serif"/>
+                <a:latin typeface="Fira Sans"/>
               </a:rPr>
               <a:t>Lo que hagan en este bloque ya es parte de la tarea.</a:t>
             </a:r>
@@ -6487,7 +6987,7 @@
                 <a:solidFill>
                   <a:srgbClr val="FFFFFF"/>
                 </a:solidFill>
-                <a:latin typeface="PT Serif"/>
+                <a:latin typeface="Fira Sans"/>
               </a:rPr>
               <a:t>¿De quién habla este número?</a:t>
             </a:r>
@@ -6498,7 +6998,7 @@
                 <a:solidFill>
                   <a:srgbClr val="E0A437"/>
                 </a:solidFill>
-                <a:latin typeface="PT Serif"/>
+                <a:latin typeface="Fira Sans"/>
               </a:rPr>
               <a:t>El concepto de esta clase</a:t>
             </a:r>
@@ -6594,9 +7094,9 @@
                 <a:solidFill>
                   <a:srgbClr val="0F0F0F"/>
                 </a:solidFill>
-                <a:latin typeface="PT Serif"/>
-              </a:rPr>
-              <a:t>La pregunta que ordena la clase</a:t>
+                <a:latin typeface="Fira Sans"/>
+              </a:rPr>
+              <a:t>Qué preguntarle a una cifra</a:t>
             </a:r>
           </a:p>
         </p:txBody>
@@ -6628,7 +7128,7 @@
                 <a:solidFill>
                   <a:srgbClr val="E0A437"/>
                 </a:solidFill>
-                <a:latin typeface="PT Serif"/>
+                <a:latin typeface="Fira Sans"/>
               </a:rPr>
               <a:t>▸ </a:t>
             </a:r>
@@ -6637,9 +7137,9 @@
                 <a:solidFill>
                   <a:srgbClr val="3A4A5C"/>
                 </a:solidFill>
-                <a:latin typeface="PT Serif"/>
-              </a:rPr>
-              <a:t>Pandas ya lo conocen: hoy es la herramienta, no el aprendizaje.</a:t>
+                <a:latin typeface="Fira Sans"/>
+              </a:rPr>
+              <a:t>Pandas ya lo conocen; en esta clase es la herramienta de trabajo.</a:t>
             </a:r>
           </a:p>
           <a:p>
@@ -6648,7 +7148,7 @@
                 <a:solidFill>
                   <a:srgbClr val="E0A437"/>
                 </a:solidFill>
-                <a:latin typeface="PT Serif"/>
+                <a:latin typeface="Fira Sans"/>
               </a:rPr>
               <a:t>▸ </a:t>
             </a:r>
@@ -6657,9 +7157,9 @@
                 <a:solidFill>
                   <a:srgbClr val="3A4A5C"/>
                 </a:solidFill>
-                <a:latin typeface="PT Serif"/>
-              </a:rPr>
-              <a:t>Lo nuevo es un hábito: examinar cada cifra antes de usarla.</a:t>
+                <a:latin typeface="Fira Sans"/>
+              </a:rPr>
+              <a:t>El objetivo es examinar qué representa una cifra antes de usarla.</a:t>
             </a:r>
           </a:p>
           <a:p>
@@ -6668,7 +7168,7 @@
                 <a:solidFill>
                   <a:srgbClr val="6B7785"/>
                 </a:solidFill>
-                <a:latin typeface="PT Serif"/>
+                <a:latin typeface="Fira Sans"/>
               </a:rPr>
               <a:t>     ◦  </a:t>
             </a:r>
@@ -6677,7 +7177,7 @@
                 <a:solidFill>
                   <a:srgbClr val="6B7785"/>
                 </a:solidFill>
-                <a:latin typeface="PT Serif"/>
+                <a:latin typeface="Fira Sans"/>
               </a:rPr>
               <a:t>Un promedio puede describir una situación en la que pocos están.</a:t>
             </a:r>
@@ -6688,7 +7188,7 @@
                 <a:solidFill>
                   <a:srgbClr val="6B7785"/>
                 </a:solidFill>
-                <a:latin typeface="PT Serif"/>
+                <a:latin typeface="Fira Sans"/>
               </a:rPr>
               <a:t>     ◦  </a:t>
             </a:r>
@@ -6697,7 +7197,7 @@
                 <a:solidFill>
                   <a:srgbClr val="6B7785"/>
                 </a:solidFill>
-                <a:latin typeface="PT Serif"/>
+                <a:latin typeface="Fira Sans"/>
               </a:rPr>
               <a:t>Contar filas de una encuesta habla de la muestra, no de la ciudad.</a:t>
             </a:r>
@@ -6708,7 +7208,7 @@
                 <a:solidFill>
                   <a:srgbClr val="6B7785"/>
                 </a:solidFill>
-                <a:latin typeface="PT Serif"/>
+                <a:latin typeface="Fira Sans"/>
               </a:rPr>
               <a:t>     ◦  </a:t>
             </a:r>
@@ -6717,7 +7217,7 @@
                 <a:solidFill>
                   <a:srgbClr val="6B7785"/>
                 </a:solidFill>
-                <a:latin typeface="PT Serif"/>
+                <a:latin typeface="Fira Sans"/>
               </a:rPr>
               <a:t>Hay personas de las que la tabla no dice nada; esa ausencia informa.</a:t>
             </a:r>
@@ -6728,7 +7228,7 @@
                 <a:solidFill>
                   <a:srgbClr val="E0A437"/>
                 </a:solidFill>
-                <a:latin typeface="PT Serif"/>
+                <a:latin typeface="Fira Sans"/>
               </a:rPr>
               <a:t>▸ </a:t>
             </a:r>
@@ -6737,9 +7237,9 @@
                 <a:solidFill>
                   <a:srgbClr val="1D3557"/>
                 </a:solidFill>
-                <a:latin typeface="PT Serif"/>
-              </a:rPr>
-              <a:t>Al cierre volveremos a esta pregunta con las respuestas del día.</a:t>
+                <a:latin typeface="Fira Sans"/>
+              </a:rPr>
+              <a:t>Al cierre se retoma esta pregunta con los resultados de la clase.</a:t>
             </a:r>
           </a:p>
         </p:txBody>
@@ -6833,7 +7333,7 @@
                 <a:solidFill>
                   <a:srgbClr val="FFFFFF"/>
                 </a:solidFill>
-                <a:latin typeface="PT Serif"/>
+                <a:latin typeface="Fira Sans"/>
               </a:rPr>
               <a:t>Los datos de hoy</a:t>
             </a:r>
@@ -6844,7 +7344,7 @@
                 <a:solidFill>
                   <a:srgbClr val="E0A437"/>
                 </a:solidFill>
-                <a:latin typeface="PT Serif"/>
+                <a:latin typeface="Fira Sans"/>
               </a:rPr>
               <a:t>Encuesta Origen Destino de Santiago 2012</a:t>
             </a:r>
@@ -6940,7 +7440,7 @@
                 <a:solidFill>
                   <a:srgbClr val="0F0F0F"/>
                 </a:solidFill>
-                <a:latin typeface="PT Serif"/>
+                <a:latin typeface="Fira Sans"/>
               </a:rPr>
               <a:t>La EOD 2012</a:t>
             </a:r>
@@ -6974,7 +7474,7 @@
                 <a:solidFill>
                   <a:srgbClr val="E0A437"/>
                 </a:solidFill>
-                <a:latin typeface="PT Serif"/>
+                <a:latin typeface="Fira Sans"/>
               </a:rPr>
               <a:t>▸ </a:t>
             </a:r>
@@ -6983,7 +7483,7 @@
                 <a:solidFill>
                   <a:srgbClr val="3A4A5C"/>
                 </a:solidFill>
-                <a:latin typeface="PT Serif"/>
+                <a:latin typeface="Fira Sans"/>
               </a:rPr>
               <a:t>Encuesta de movilidad del Gran Santiago (SECTRA y U. Alberto Hurtado).</a:t>
             </a:r>
@@ -6994,7 +7494,7 @@
                 <a:solidFill>
                   <a:srgbClr val="E0A437"/>
                 </a:solidFill>
-                <a:latin typeface="PT Serif"/>
+                <a:latin typeface="Fira Sans"/>
               </a:rPr>
               <a:t>▸ </a:t>
             </a:r>
@@ -7003,7 +7503,7 @@
                 <a:solidFill>
                   <a:srgbClr val="3A4A5C"/>
                 </a:solidFill>
-                <a:latin typeface="PT Serif"/>
+                <a:latin typeface="Fira Sans"/>
               </a:rPr>
               <a:t>Registra todos los viajes de un día de los hogares encuestados.</a:t>
             </a:r>
@@ -7014,7 +7514,7 @@
                 <a:solidFill>
                   <a:srgbClr val="6B7785"/>
                 </a:solidFill>
-                <a:latin typeface="PT Serif"/>
+                <a:latin typeface="Fira Sans"/>
               </a:rPr>
               <a:t>     ◦  </a:t>
             </a:r>
@@ -7023,7 +7523,7 @@
                 <a:solidFill>
                   <a:srgbClr val="6B7785"/>
                 </a:solidFill>
-                <a:latin typeface="PT Serif"/>
+                <a:latin typeface="Fira Sans"/>
               </a:rPr>
               <a:t>18.264 hogares, 60.054 personas, 113.591 viajes.</a:t>
             </a:r>
@@ -7034,7 +7534,7 @@
                 <a:solidFill>
                   <a:srgbClr val="6B7785"/>
                 </a:solidFill>
-                <a:latin typeface="PT Serif"/>
+                <a:latin typeface="Fira Sans"/>
               </a:rPr>
               <a:t>     ◦  </a:t>
             </a:r>
@@ -7043,7 +7543,7 @@
                 <a:solidFill>
                   <a:srgbClr val="6B7785"/>
                 </a:solidFill>
-                <a:latin typeface="PT Serif"/>
+                <a:latin typeface="Fira Sans"/>
               </a:rPr>
               <a:t>Se usa en la planificación de transporte de la ciudad.</a:t>
             </a:r>
@@ -7054,7 +7554,7 @@
                 <a:solidFill>
                   <a:srgbClr val="E0A437"/>
                 </a:solidFill>
-                <a:latin typeface="PT Serif"/>
+                <a:latin typeface="Fira Sans"/>
               </a:rPr>
               <a:t>▸ </a:t>
             </a:r>
@@ -7063,7 +7563,7 @@
                 <a:solidFill>
                   <a:srgbClr val="1D3557"/>
                 </a:solidFill>
-                <a:latin typeface="PT Serif"/>
+                <a:latin typeface="Fira Sans"/>
               </a:rPr>
               <a:t>El mismo diseño relacional de la Casen, el Censo o la ENUSC.</a:t>
             </a:r>
@@ -7159,7 +7659,7 @@
                 <a:solidFill>
                   <a:srgbClr val="0F0F0F"/>
                 </a:solidFill>
-                <a:latin typeface="PT Serif"/>
+                <a:latin typeface="Fira Sans"/>
               </a:rPr>
               <a:t>Una encuesta, varias tablas</a:t>
             </a:r>
@@ -7182,8 +7682,8 @@
         </p:blipFill>
         <p:spPr>
           <a:xfrm>
-            <a:off x="1555117" y="1143000"/>
-            <a:ext cx="6033765" cy="3154680"/>
+            <a:off x="1553651" y="1143000"/>
+            <a:ext cx="6036697" cy="3154680"/>
           </a:xfrm>
           <a:prstGeom prst="rect">
             <a:avLst/>
@@ -7217,7 +7717,7 @@
                 <a:solidFill>
                   <a:srgbClr val="6B7785"/>
                 </a:solidFill>
-                <a:latin typeface="PT Serif"/>
+                <a:latin typeface="Fira Sans"/>
               </a:rPr>
               <a:t>Los códigos no significan nada sin sus tablas de parámetros: unirlas es parte del análisis.</a:t>
             </a:r>
@@ -7313,7 +7813,7 @@
                 <a:solidFill>
                   <a:srgbClr val="FFFFFF"/>
                 </a:solidFill>
-                <a:latin typeface="PT Serif"/>
+                <a:latin typeface="Fira Sans"/>
               </a:rPr>
               <a:t>Repaso de Pandas</a:t>
             </a:r>
@@ -7324,7 +7824,7 @@
                 <a:solidFill>
                   <a:srgbClr val="E0A437"/>
                 </a:solidFill>
-                <a:latin typeface="PT Serif"/>
+                <a:latin typeface="Fira Sans"/>
               </a:rPr>
               <a:t>Dos casos concretos</a:t>
             </a:r>
@@ -7420,7 +7920,7 @@
                 <a:solidFill>
                   <a:srgbClr val="0F0F0F"/>
                 </a:solidFill>
-                <a:latin typeface="PT Serif"/>
+                <a:latin typeface="Fira Sans"/>
               </a:rPr>
               <a:t>Caso 1: códigos que no significan nada solos</a:t>
             </a:r>
@@ -7581,7 +8081,7 @@
                 <a:solidFill>
                   <a:srgbClr val="E0A437"/>
                 </a:solidFill>
-                <a:latin typeface="PT Serif"/>
+                <a:latin typeface="Fira Sans"/>
               </a:rPr>
               <a:t>▸ </a:t>
             </a:r>
@@ -7590,7 +8090,7 @@
                 <a:solidFill>
                   <a:srgbClr val="3A4A5C"/>
                 </a:solidFill>
-                <a:latin typeface="PT Serif"/>
+                <a:latin typeface="Fira Sans"/>
               </a:rPr>
               <a:t>El detalle completo, con las cuatro variantes de how, está en el notebook.</a:t>
             </a:r>

</xml_diff>

<commit_message>
Profundizar la clase 02: diagramas, correlacion con datos y cierre de escala
Tipos de datos como diagrama de arbol con ejemplos de la EOD. La correlacion gana
una figura real: densidad de distancia contra duracion con la mediana por tramo,
que muestra una relacion monotonica no lineal (Pearson 0,43, Spearman 0,72). Se
retiran las slides de codigo salvo la apertura del dataset; el DataFrame se
muestra como imagen con datos reales. Cierre nuevo sobre la escala de los datos
(Pandas y Polars, DuckDB, PySpark con SQL o DataFrames, Dask) y slide de
referencias con citas verificadas.

Co-Authored-By: Claude Fable 5 <noreply@anthropic.com>
</commit_message>
<xml_diff>
--- a/presentaciones/clase02_pandas_eda.pptx
+++ b/presentaciones/clase02_pandas_eda.pptx
@@ -33,6 +33,10 @@
     <p:sldId id="281" r:id="rId32"/>
     <p:sldId id="282" r:id="rId33"/>
     <p:sldId id="283" r:id="rId34"/>
+    <p:sldId id="284" r:id="rId35"/>
+    <p:sldId id="285" r:id="rId36"/>
+    <p:sldId id="286" r:id="rId37"/>
+    <p:sldId id="287" r:id="rId38"/>
   </p:sldIdLst>
   <p:sldSz cx="9144000" cy="5138928" type="screen4x3"/>
   <p:notesSz cx="6858000" cy="9144000"/>
@@ -3324,7 +3328,7 @@
             <a:avLst/>
           </a:prstGeom>
           <a:solidFill>
-            <a:srgbClr val="1D3557"/>
+            <a:srgbClr val="FAFBFC"/>
           </a:solidFill>
           <a:ln>
             <a:noFill/>
@@ -3361,8 +3365,8 @@
         </p:nvSpPr>
         <p:spPr>
           <a:xfrm>
-            <a:off x="603504" y="1847088"/>
-            <a:ext cx="7946136" cy="1399032"/>
+            <a:off x="402336" y="301752"/>
+            <a:ext cx="8348472" cy="795528"/>
           </a:xfrm>
           <a:prstGeom prst="rect">
             <a:avLst/>
@@ -3376,24 +3380,176 @@
           <a:lstStyle/>
           <a:p>
             <a:r>
-              <a:rPr sz="3400" b="1">
-                <a:solidFill>
-                  <a:srgbClr val="FFFFFF"/>
-                </a:solidFill>
-                <a:latin typeface="Fira Sans"/>
-              </a:rPr>
-              <a:t>Los datos</a:t>
-            </a:r>
-          </a:p>
-          <a:p>
+              <a:rPr sz="2800" b="1">
+                <a:solidFill>
+                  <a:srgbClr val="0F0F0F"/>
+                </a:solidFill>
+                <a:latin typeface="Fira Sans"/>
+              </a:rPr>
+              <a:t>El tipo estadístico no es el tipo computacional</a:t>
+            </a:r>
+          </a:p>
+        </p:txBody>
+      </p:sp>
+      <p:sp>
+        <p:nvSpPr>
+          <p:cNvPr id="4" name="TextBox 3"/>
+          <p:cNvSpPr txBox="1"/>
+          <p:nvPr/>
+        </p:nvSpPr>
+        <p:spPr>
+          <a:xfrm>
+            <a:off x="704088" y="1353312"/>
+            <a:ext cx="7744968" cy="3300984"/>
+          </a:xfrm>
+          <a:prstGeom prst="rect">
+            <a:avLst/>
+          </a:prstGeom>
+          <a:noFill/>
+        </p:spPr>
+        <p:txBody>
+          <a:bodyPr wrap="square">
+            <a:spAutoFit/>
+          </a:bodyPr>
+          <a:lstStyle/>
+          <a:p>
+            <a:pPr>
+              <a:lnSpc>
+                <a:spcPct val="112000"/>
+              </a:lnSpc>
+              <a:spcAft>
+                <a:spcPts val="900"/>
+              </a:spcAft>
+            </a:pPr>
+            <a:r>
+              <a:rPr sz="1800" b="1">
+                <a:solidFill>
+                  <a:srgbClr val="E0A437"/>
+                </a:solidFill>
+                <a:latin typeface="Fira Sans"/>
+              </a:rPr>
+              <a:t>▸ </a:t>
+            </a:r>
             <a:r>
               <a:rPr sz="1800" b="0">
                 <a:solidFill>
+                  <a:srgbClr val="000000"/>
+                </a:solidFill>
+                <a:latin typeface="Fira Sans"/>
+              </a:rPr>
+              <a:t>En la EOD el sexo viene codificado 1 o 2: para Pandas es un entero (int64).</a:t>
+            </a:r>
+          </a:p>
+          <a:p>
+            <a:pPr>
+              <a:lnSpc>
+                <a:spcPct val="112000"/>
+              </a:lnSpc>
+              <a:spcAft>
+                <a:spcPts val="900"/>
+              </a:spcAft>
+            </a:pPr>
+            <a:r>
+              <a:rPr sz="1800" b="1">
+                <a:solidFill>
                   <a:srgbClr val="E0A437"/>
                 </a:solidFill>
                 <a:latin typeface="Fira Sans"/>
               </a:rPr>
-              <a:t>Encuesta Origen Destino de Santiago 2012</a:t>
+              <a:t>▸ </a:t>
+            </a:r>
+            <a:r>
+              <a:rPr sz="1800" b="0">
+                <a:solidFill>
+                  <a:srgbClr val="000000"/>
+                </a:solidFill>
+                <a:latin typeface="Fira Sans"/>
+              </a:rPr>
+              <a:t>El tipo computacional permite operar; el tipo estadístico decide si la operación significa algo.</a:t>
+            </a:r>
+          </a:p>
+          <a:p>
+            <a:pPr>
+              <a:lnSpc>
+                <a:spcPct val="112000"/>
+              </a:lnSpc>
+              <a:spcAft>
+                <a:spcPts val="500"/>
+              </a:spcAft>
+            </a:pPr>
+            <a:r>
+              <a:rPr sz="1400" b="0">
+                <a:solidFill>
+                  <a:srgbClr val="333333"/>
+                </a:solidFill>
+                <a:latin typeface="Fira Sans"/>
+              </a:rPr>
+              <a:t>     ◦  </a:t>
+            </a:r>
+            <a:r>
+              <a:rPr sz="1400" b="0">
+                <a:solidFill>
+                  <a:srgbClr val="333333"/>
+                </a:solidFill>
+                <a:latin typeface="Fira Sans"/>
+              </a:rPr>
+              <a:t>El promedio de Sexo en la EOD es 1,53: aritméticamente correcto, sin significado.</a:t>
+            </a:r>
+          </a:p>
+          <a:p>
+            <a:pPr>
+              <a:lnSpc>
+                <a:spcPct val="112000"/>
+              </a:lnSpc>
+              <a:spcAft>
+                <a:spcPts val="500"/>
+              </a:spcAft>
+            </a:pPr>
+            <a:r>
+              <a:rPr sz="1400" b="0">
+                <a:solidFill>
+                  <a:srgbClr val="333333"/>
+                </a:solidFill>
+                <a:latin typeface="Fira Sans"/>
+              </a:rPr>
+              <a:t>     ◦  </a:t>
+            </a:r>
+            <a:r>
+              <a:rPr sz="1400" b="0">
+                <a:solidFill>
+                  <a:srgbClr val="333333"/>
+                </a:solidFill>
+                <a:latin typeface="Fira Sans"/>
+              </a:rPr>
+              <a:t>El promedio de Edad sí es interpretable: la variable es numérica.</a:t>
+            </a:r>
+          </a:p>
+          <a:p>
+            <a:pPr>
+              <a:lnSpc>
+                <a:spcPct val="112000"/>
+              </a:lnSpc>
+              <a:spcAft>
+                <a:spcPts val="900"/>
+              </a:spcAft>
+            </a:pPr>
+            <a:r>
+              <a:rPr sz="1800" b="1">
+                <a:solidFill>
+                  <a:srgbClr val="E0A437"/>
+                </a:solidFill>
+                <a:latin typeface="Fira Sans"/>
+              </a:rPr>
+              <a:t>▸ </a:t>
+            </a:r>
+            <a:r>
+              <a:rPr sz="1800" b="1">
+                <a:solidFill>
+                  <a:srgbClr val="1D3557"/>
+                </a:solidFill>
+                <a:latin typeface="Fira Sans"/>
+              </a:rPr>
+              <a:t>Identificar el tipo de cada variable es un paso del análisis, no una formalidad.</a:t>
             </a:r>
           </a:p>
         </p:txBody>
@@ -3489,7 +3645,7 @@
                 </a:solidFill>
                 <a:latin typeface="Fira Sans"/>
               </a:rPr>
-              <a:t>La EOD 2012</a:t>
+              <a:t>El análisis exploratorio de datos</a:t>
             </a:r>
           </a:p>
         </p:txBody>
@@ -3540,7 +3696,7 @@
                 </a:solidFill>
                 <a:latin typeface="Fira Sans"/>
               </a:rPr>
-              <a:t>Encuesta de movilidad del Gran Santiago (SECTRA y U. Alberto Hurtado).</a:t>
+              <a:t>La etapa en que se examinan los datos antes de modelarlos (Tukey, 1977).</a:t>
             </a:r>
           </a:p>
           <a:p>
@@ -3568,7 +3724,7 @@
                 </a:solidFill>
                 <a:latin typeface="Fira Sans"/>
               </a:rPr>
-              <a:t>Registra todos los viajes de un día de los hogares encuestados.</a:t>
+              <a:t>Responde cuatro tipos de pregunta:</a:t>
             </a:r>
           </a:p>
           <a:p>
@@ -3596,7 +3752,7 @@
                 </a:solidFill>
                 <a:latin typeface="Fira Sans"/>
               </a:rPr>
-              <a:t>18.264 hogares, 60.054 personas, 113.591 viajes.</a:t>
+              <a:t>La forma: cómo se distribuye cada variable.</a:t>
             </a:r>
           </a:p>
           <a:p>
@@ -3624,7 +3780,63 @@
                 </a:solidFill>
                 <a:latin typeface="Fira Sans"/>
               </a:rPr>
-              <a:t>Se usa en la planificación de transporte de la ciudad.</a:t>
+              <a:t>Lo típico y lo extremo: qué es frecuente y qué es anómalo.</a:t>
+            </a:r>
+          </a:p>
+          <a:p>
+            <a:pPr>
+              <a:lnSpc>
+                <a:spcPct val="112000"/>
+              </a:lnSpc>
+              <a:spcAft>
+                <a:spcPts val="500"/>
+              </a:spcAft>
+            </a:pPr>
+            <a:r>
+              <a:rPr sz="1400" b="0">
+                <a:solidFill>
+                  <a:srgbClr val="333333"/>
+                </a:solidFill>
+                <a:latin typeface="Fira Sans"/>
+              </a:rPr>
+              <a:t>     ◦  </a:t>
+            </a:r>
+            <a:r>
+              <a:rPr sz="1400" b="0">
+                <a:solidFill>
+                  <a:srgbClr val="333333"/>
+                </a:solidFill>
+                <a:latin typeface="Fira Sans"/>
+              </a:rPr>
+              <a:t>Lo que falta: qué datos están ausentes y con qué patrón.</a:t>
+            </a:r>
+          </a:p>
+          <a:p>
+            <a:pPr>
+              <a:lnSpc>
+                <a:spcPct val="112000"/>
+              </a:lnSpc>
+              <a:spcAft>
+                <a:spcPts val="500"/>
+              </a:spcAft>
+            </a:pPr>
+            <a:r>
+              <a:rPr sz="1400" b="0">
+                <a:solidFill>
+                  <a:srgbClr val="333333"/>
+                </a:solidFill>
+                <a:latin typeface="Fira Sans"/>
+              </a:rPr>
+              <a:t>     ◦  </a:t>
+            </a:r>
+            <a:r>
+              <a:rPr sz="1400" b="0">
+                <a:solidFill>
+                  <a:srgbClr val="333333"/>
+                </a:solidFill>
+                <a:latin typeface="Fira Sans"/>
+              </a:rPr>
+              <a:t>Las relaciones: qué variables se asocian con qué otras.</a:t>
             </a:r>
           </a:p>
           <a:p>
@@ -3646,13 +3858,41 @@
               <a:t>▸ </a:t>
             </a:r>
             <a:r>
+              <a:rPr sz="1800" b="0">
+                <a:solidFill>
+                  <a:srgbClr val="000000"/>
+                </a:solidFill>
+                <a:latin typeface="Fira Sans"/>
+              </a:rPr>
+              <a:t>Genera hipótesis; el análisis confirmatorio (unidad 5) las pone a prueba.</a:t>
+            </a:r>
+          </a:p>
+          <a:p>
+            <a:pPr>
+              <a:lnSpc>
+                <a:spcPct val="112000"/>
+              </a:lnSpc>
+              <a:spcAft>
+                <a:spcPts val="900"/>
+              </a:spcAft>
+            </a:pPr>
+            <a:r>
               <a:rPr sz="1800" b="1">
                 <a:solidFill>
+                  <a:srgbClr val="E0A437"/>
+                </a:solidFill>
+                <a:latin typeface="Fira Sans"/>
+              </a:rPr>
+              <a:t>▸ </a:t>
+            </a:r>
+            <a:r>
+              <a:rPr sz="1800" b="1">
+                <a:solidFill>
                   <a:srgbClr val="1D3557"/>
                 </a:solidFill>
                 <a:latin typeface="Fira Sans"/>
               </a:rPr>
-              <a:t>El mismo diseño relacional de la Casen, el Censo o la ENUSC.</a:t>
+              <a:t>Una pregunta transversal para toda cifra resumen: ¿de quién habla este número? ¿De la muestra, de un subgrupo, de la ciudad?</a:t>
             </a:r>
           </a:p>
         </p:txBody>
@@ -3690,7 +3930,7 @@
             <a:avLst/>
           </a:prstGeom>
           <a:solidFill>
-            <a:srgbClr val="FAFBFC"/>
+            <a:srgbClr val="1D3557"/>
           </a:solidFill>
           <a:ln>
             <a:noFill/>
@@ -3727,8 +3967,8 @@
         </p:nvSpPr>
         <p:spPr>
           <a:xfrm>
-            <a:off x="402336" y="301752"/>
-            <a:ext cx="8348472" cy="795528"/>
+            <a:off x="603504" y="1847088"/>
+            <a:ext cx="7946136" cy="1399032"/>
           </a:xfrm>
           <a:prstGeom prst="rect">
             <a:avLst/>
@@ -3742,71 +3982,24 @@
           <a:lstStyle/>
           <a:p>
             <a:r>
-              <a:rPr sz="2800" b="1">
-                <a:solidFill>
-                  <a:srgbClr val="0F0F0F"/>
-                </a:solidFill>
-                <a:latin typeface="Fira Sans"/>
-              </a:rPr>
-              <a:t>Una encuesta, varias tablas</a:t>
-            </a:r>
-          </a:p>
-        </p:txBody>
-      </p:sp>
-      <p:pic>
-        <p:nvPicPr>
-          <p:cNvPr id="4" name="Picture 3" descr="05_diagrama_tablas.png"/>
-          <p:cNvPicPr>
-            <a:picLocks noChangeAspect="1"/>
-          </p:cNvPicPr>
-          <p:nvPr/>
-        </p:nvPicPr>
-        <p:blipFill>
-          <a:blip r:embed="rId2"/>
-          <a:stretch>
-            <a:fillRect/>
-          </a:stretch>
-        </p:blipFill>
-        <p:spPr>
-          <a:xfrm>
-            <a:off x="1553651" y="1143000"/>
-            <a:ext cx="6036697" cy="3154680"/>
-          </a:xfrm>
-          <a:prstGeom prst="rect">
-            <a:avLst/>
-          </a:prstGeom>
-        </p:spPr>
-      </p:pic>
-      <p:sp>
-        <p:nvSpPr>
-          <p:cNvPr id="5" name="TextBox 4"/>
-          <p:cNvSpPr txBox="1"/>
-          <p:nvPr/>
-        </p:nvSpPr>
-        <p:spPr>
-          <a:xfrm>
-            <a:off x="704088" y="4434840"/>
-            <a:ext cx="7744968" cy="457200"/>
-          </a:xfrm>
-          <a:prstGeom prst="rect">
-            <a:avLst/>
-          </a:prstGeom>
-          <a:noFill/>
-        </p:spPr>
-        <p:txBody>
-          <a:bodyPr wrap="square">
-            <a:spAutoFit/>
-          </a:bodyPr>
-          <a:lstStyle/>
-          <a:p>
-            <a:r>
-              <a:rPr sz="1300" b="0">
-                <a:solidFill>
-                  <a:srgbClr val="333333"/>
-                </a:solidFill>
-                <a:latin typeface="Fira Sans"/>
-              </a:rPr>
-              <a:t>Los códigos no significan nada sin sus tablas de parámetros: unirlas es parte del análisis.</a:t>
+              <a:rPr sz="3400" b="1">
+                <a:solidFill>
+                  <a:srgbClr val="FFFFFF"/>
+                </a:solidFill>
+                <a:latin typeface="Fira Sans"/>
+              </a:rPr>
+              <a:t>Los datos</a:t>
+            </a:r>
+          </a:p>
+          <a:p>
+            <a:r>
+              <a:rPr sz="1800" b="0">
+                <a:solidFill>
+                  <a:srgbClr val="E0A437"/>
+                </a:solidFill>
+                <a:latin typeface="Fira Sans"/>
+              </a:rPr>
+              <a:t>Encuesta Origen Destino de Santiago 2012</a:t>
             </a:r>
           </a:p>
         </p:txBody>
@@ -3844,7 +4037,7 @@
             <a:avLst/>
           </a:prstGeom>
           <a:solidFill>
-            <a:srgbClr val="1D3557"/>
+            <a:srgbClr val="FAFBFC"/>
           </a:solidFill>
           <a:ln>
             <a:noFill/>
@@ -3881,8 +4074,8 @@
         </p:nvSpPr>
         <p:spPr>
           <a:xfrm>
-            <a:off x="603504" y="1847088"/>
-            <a:ext cx="7946136" cy="1399032"/>
+            <a:off x="402336" y="301752"/>
+            <a:ext cx="8348472" cy="795528"/>
           </a:xfrm>
           <a:prstGeom prst="rect">
             <a:avLst/>
@@ -3896,24 +4089,176 @@
           <a:lstStyle/>
           <a:p>
             <a:r>
-              <a:rPr sz="3400" b="1">
-                <a:solidFill>
-                  <a:srgbClr val="FFFFFF"/>
-                </a:solidFill>
-                <a:latin typeface="Fira Sans"/>
-              </a:rPr>
-              <a:t>Repaso de Pandas</a:t>
-            </a:r>
-          </a:p>
-          <a:p>
+              <a:rPr sz="2800" b="1">
+                <a:solidFill>
+                  <a:srgbClr val="0F0F0F"/>
+                </a:solidFill>
+                <a:latin typeface="Fira Sans"/>
+              </a:rPr>
+              <a:t>La EOD 2012</a:t>
+            </a:r>
+          </a:p>
+        </p:txBody>
+      </p:sp>
+      <p:sp>
+        <p:nvSpPr>
+          <p:cNvPr id="4" name="TextBox 3"/>
+          <p:cNvSpPr txBox="1"/>
+          <p:nvPr/>
+        </p:nvSpPr>
+        <p:spPr>
+          <a:xfrm>
+            <a:off x="704088" y="1353312"/>
+            <a:ext cx="7744968" cy="3300984"/>
+          </a:xfrm>
+          <a:prstGeom prst="rect">
+            <a:avLst/>
+          </a:prstGeom>
+          <a:noFill/>
+        </p:spPr>
+        <p:txBody>
+          <a:bodyPr wrap="square">
+            <a:spAutoFit/>
+          </a:bodyPr>
+          <a:lstStyle/>
+          <a:p>
+            <a:pPr>
+              <a:lnSpc>
+                <a:spcPct val="112000"/>
+              </a:lnSpc>
+              <a:spcAft>
+                <a:spcPts val="900"/>
+              </a:spcAft>
+            </a:pPr>
+            <a:r>
+              <a:rPr sz="1800" b="1">
+                <a:solidFill>
+                  <a:srgbClr val="E0A437"/>
+                </a:solidFill>
+                <a:latin typeface="Fira Sans"/>
+              </a:rPr>
+              <a:t>▸ </a:t>
+            </a:r>
             <a:r>
               <a:rPr sz="1800" b="0">
                 <a:solidFill>
+                  <a:srgbClr val="000000"/>
+                </a:solidFill>
+                <a:latin typeface="Fira Sans"/>
+              </a:rPr>
+              <a:t>Encuesta de movilidad del Gran Santiago (SECTRA y U. Alberto Hurtado).</a:t>
+            </a:r>
+          </a:p>
+          <a:p>
+            <a:pPr>
+              <a:lnSpc>
+                <a:spcPct val="112000"/>
+              </a:lnSpc>
+              <a:spcAft>
+                <a:spcPts val="900"/>
+              </a:spcAft>
+            </a:pPr>
+            <a:r>
+              <a:rPr sz="1800" b="1">
+                <a:solidFill>
                   <a:srgbClr val="E0A437"/>
                 </a:solidFill>
                 <a:latin typeface="Fira Sans"/>
               </a:rPr>
-              <a:t>Dos casos concretos con la EOD</a:t>
+              <a:t>▸ </a:t>
+            </a:r>
+            <a:r>
+              <a:rPr sz="1800" b="0">
+                <a:solidFill>
+                  <a:srgbClr val="000000"/>
+                </a:solidFill>
+                <a:latin typeface="Fira Sans"/>
+              </a:rPr>
+              <a:t>Registra todos los viajes de un día de los hogares encuestados.</a:t>
+            </a:r>
+          </a:p>
+          <a:p>
+            <a:pPr>
+              <a:lnSpc>
+                <a:spcPct val="112000"/>
+              </a:lnSpc>
+              <a:spcAft>
+                <a:spcPts val="500"/>
+              </a:spcAft>
+            </a:pPr>
+            <a:r>
+              <a:rPr sz="1400" b="0">
+                <a:solidFill>
+                  <a:srgbClr val="333333"/>
+                </a:solidFill>
+                <a:latin typeface="Fira Sans"/>
+              </a:rPr>
+              <a:t>     ◦  </a:t>
+            </a:r>
+            <a:r>
+              <a:rPr sz="1400" b="0">
+                <a:solidFill>
+                  <a:srgbClr val="333333"/>
+                </a:solidFill>
+                <a:latin typeface="Fira Sans"/>
+              </a:rPr>
+              <a:t>18.264 hogares, 60.054 personas, 113.591 viajes.</a:t>
+            </a:r>
+          </a:p>
+          <a:p>
+            <a:pPr>
+              <a:lnSpc>
+                <a:spcPct val="112000"/>
+              </a:lnSpc>
+              <a:spcAft>
+                <a:spcPts val="500"/>
+              </a:spcAft>
+            </a:pPr>
+            <a:r>
+              <a:rPr sz="1400" b="0">
+                <a:solidFill>
+                  <a:srgbClr val="333333"/>
+                </a:solidFill>
+                <a:latin typeface="Fira Sans"/>
+              </a:rPr>
+              <a:t>     ◦  </a:t>
+            </a:r>
+            <a:r>
+              <a:rPr sz="1400" b="0">
+                <a:solidFill>
+                  <a:srgbClr val="333333"/>
+                </a:solidFill>
+                <a:latin typeface="Fira Sans"/>
+              </a:rPr>
+              <a:t>Se usa en la planificación de transporte de la ciudad.</a:t>
+            </a:r>
+          </a:p>
+          <a:p>
+            <a:pPr>
+              <a:lnSpc>
+                <a:spcPct val="112000"/>
+              </a:lnSpc>
+              <a:spcAft>
+                <a:spcPts val="900"/>
+              </a:spcAft>
+            </a:pPr>
+            <a:r>
+              <a:rPr sz="1800" b="1">
+                <a:solidFill>
+                  <a:srgbClr val="E0A437"/>
+                </a:solidFill>
+                <a:latin typeface="Fira Sans"/>
+              </a:rPr>
+              <a:t>▸ </a:t>
+            </a:r>
+            <a:r>
+              <a:rPr sz="1800" b="1">
+                <a:solidFill>
+                  <a:srgbClr val="1D3557"/>
+                </a:solidFill>
+                <a:latin typeface="Fira Sans"/>
+              </a:rPr>
+              <a:t>El mismo diseño relacional de la Casen, el Censo o la ENUSC.</a:t>
             </a:r>
           </a:p>
         </p:txBody>
@@ -4009,138 +4354,35 @@
                 </a:solidFill>
                 <a:latin typeface="Fira Sans"/>
               </a:rPr>
-              <a:t>Caso 1: códigos que requieren su tabla de parámetros</a:t>
-            </a:r>
-          </a:p>
-        </p:txBody>
-      </p:sp>
-      <p:sp>
-        <p:nvSpPr>
-          <p:cNvPr id="4" name="Rectangle 3"/>
-          <p:cNvSpPr/>
-          <p:nvPr/>
-        </p:nvSpPr>
-        <p:spPr>
-          <a:xfrm>
-            <a:off x="704088" y="1280160"/>
-            <a:ext cx="7744968" cy="3886200"/>
-          </a:xfrm>
-          <a:prstGeom prst="rect">
-            <a:avLst/>
-          </a:prstGeom>
-          <a:solidFill>
-            <a:srgbClr val="F0F2F5"/>
-          </a:solidFill>
-          <a:ln>
-            <a:solidFill>
-              <a:srgbClr val="D8DDE3"/>
-            </a:solidFill>
-          </a:ln>
-          <a:effectLst/>
-        </p:spPr>
-        <p:style>
-          <a:lnRef idx="1">
-            <a:schemeClr val="accent1"/>
-          </a:lnRef>
-          <a:fillRef idx="3">
-            <a:schemeClr val="accent1"/>
-          </a:fillRef>
-          <a:effectRef idx="2">
-            <a:schemeClr val="accent1"/>
-          </a:effectRef>
-          <a:fontRef idx="minor">
-            <a:schemeClr val="lt1"/>
-          </a:fontRef>
-        </p:style>
-        <p:txBody>
-          <a:bodyPr rtlCol="0" anchor="ctr" wrap="square" lIns="228600" tIns="137160"/>
-          <a:lstStyle/>
-          <a:p>
-            <a:pPr/>
-            <a:r>
-              <a:rPr sz="1500" b="0">
-                <a:solidFill>
-                  <a:srgbClr val="1D3557"/>
-                </a:solidFill>
-                <a:latin typeface="Menlo"/>
-              </a:rPr>
-              <a:t>personas['Sexo'].value_counts()      # 1 y 2: ¿qué son?</a:t>
-            </a:r>
-          </a:p>
-          <a:p>
-            <a:pPr/>
-            <a:r>
-              <a:rPr sz="1500" b="0">
-                <a:solidFill>
-                  <a:srgbClr val="1D3557"/>
-                </a:solidFill>
-                <a:latin typeface="Menlo"/>
-              </a:rPr>
-              <a:t/>
-            </a:r>
-          </a:p>
-          <a:p>
-            <a:pPr/>
-            <a:r>
-              <a:rPr sz="1500" b="0">
-                <a:solidFill>
-                  <a:srgbClr val="1D3557"/>
-                </a:solidFill>
-                <a:latin typeface="Menlo"/>
-              </a:rPr>
-              <a:t>sexo = pd.read_csv('tablas_parametros/Sexo.csv', sep=';')</a:t>
-            </a:r>
-          </a:p>
-          <a:p>
-            <a:pPr/>
-            <a:r>
-              <a:rPr sz="1500" b="0">
-                <a:solidFill>
-                  <a:srgbClr val="1D3557"/>
-                </a:solidFill>
-                <a:latin typeface="Menlo"/>
-              </a:rPr>
-              <a:t>personas = personas.merge(sexo, left_on='Sexo',</a:t>
-            </a:r>
-          </a:p>
-          <a:p>
-            <a:pPr/>
-            <a:r>
-              <a:rPr sz="1500" b="0">
-                <a:solidFill>
-                  <a:srgbClr val="1D3557"/>
-                </a:solidFill>
-                <a:latin typeface="Menlo"/>
-              </a:rPr>
-              <a:t>                          right_on='Id', how='left')</a:t>
-            </a:r>
-          </a:p>
-          <a:p>
-            <a:pPr/>
-            <a:r>
-              <a:rPr sz="1500" b="0">
-                <a:solidFill>
-                  <a:srgbClr val="1D3557"/>
-                </a:solidFill>
-                <a:latin typeface="Menlo"/>
-              </a:rPr>
-              <a:t/>
-            </a:r>
-          </a:p>
-          <a:p>
-            <a:pPr/>
-            <a:r>
-              <a:rPr sz="1500" b="0">
-                <a:solidFill>
-                  <a:srgbClr val="1D3557"/>
-                </a:solidFill>
-                <a:latin typeface="Menlo"/>
-              </a:rPr>
-              <a:t>personas['Sexo'].isna().sum()        # después de todo merge: contar los NaN</a:t>
-            </a:r>
-          </a:p>
-        </p:txBody>
-      </p:sp>
+              <a:t>Una encuesta, varias tablas</a:t>
+            </a:r>
+          </a:p>
+        </p:txBody>
+      </p:sp>
+      <p:pic>
+        <p:nvPicPr>
+          <p:cNvPr id="4" name="Picture 3" descr="05_diagrama_tablas.png"/>
+          <p:cNvPicPr>
+            <a:picLocks noChangeAspect="1"/>
+          </p:cNvPicPr>
+          <p:nvPr/>
+        </p:nvPicPr>
+        <p:blipFill>
+          <a:blip r:embed="rId2"/>
+          <a:stretch>
+            <a:fillRect/>
+          </a:stretch>
+        </p:blipFill>
+        <p:spPr>
+          <a:xfrm>
+            <a:off x="1553651" y="1143000"/>
+            <a:ext cx="6036697" cy="3154680"/>
+          </a:xfrm>
+          <a:prstGeom prst="rect">
+            <a:avLst/>
+          </a:prstGeom>
+        </p:spPr>
+      </p:pic>
       <p:sp>
         <p:nvSpPr>
           <p:cNvPr id="5" name="TextBox 4"/>
@@ -4149,8 +4391,8 @@
         </p:nvSpPr>
         <p:spPr>
           <a:xfrm>
-            <a:off x="704088" y="5394960"/>
-            <a:ext cx="7744968" cy="1097280"/>
+            <a:off x="704088" y="4434840"/>
+            <a:ext cx="7744968" cy="457200"/>
           </a:xfrm>
           <a:prstGeom prst="rect">
             <a:avLst/>
@@ -4163,31 +4405,14 @@
           </a:bodyPr>
           <a:lstStyle/>
           <a:p>
-            <a:pPr>
-              <a:lnSpc>
-                <a:spcPct val="112000"/>
-              </a:lnSpc>
-              <a:spcAft>
-                <a:spcPts val="900"/>
-              </a:spcAft>
-            </a:pPr>
-            <a:r>
-              <a:rPr sz="1600" b="1">
-                <a:solidFill>
-                  <a:srgbClr val="E0A437"/>
-                </a:solidFill>
-                <a:latin typeface="Fira Sans"/>
-              </a:rPr>
-              <a:t>▸ </a:t>
-            </a:r>
-            <a:r>
-              <a:rPr sz="1600" b="0">
-                <a:solidFill>
-                  <a:srgbClr val="000000"/>
-                </a:solidFill>
-                <a:latin typeface="Fira Sans"/>
-              </a:rPr>
-              <a:t>El detalle completo, con las cuatro variantes de how, está en el notebook.</a:t>
+            <a:r>
+              <a:rPr sz="1300" b="0">
+                <a:solidFill>
+                  <a:srgbClr val="333333"/>
+                </a:solidFill>
+                <a:latin typeface="Fira Sans"/>
+              </a:rPr>
+              <a:t>Los códigos no significan nada sin sus tablas de parámetros: unirlas es parte del análisis.</a:t>
             </a:r>
           </a:p>
         </p:txBody>
@@ -4225,7 +4450,7 @@
             <a:avLst/>
           </a:prstGeom>
           <a:solidFill>
-            <a:srgbClr val="FAFBFC"/>
+            <a:srgbClr val="1D3557"/>
           </a:solidFill>
           <a:ln>
             <a:noFill/>
@@ -4262,8 +4487,8 @@
         </p:nvSpPr>
         <p:spPr>
           <a:xfrm>
-            <a:off x="402336" y="301752"/>
-            <a:ext cx="8348472" cy="795528"/>
+            <a:off x="603504" y="1847088"/>
+            <a:ext cx="7946136" cy="1399032"/>
           </a:xfrm>
           <a:prstGeom prst="rect">
             <a:avLst/>
@@ -4277,71 +4502,24 @@
           <a:lstStyle/>
           <a:p>
             <a:r>
-              <a:rPr sz="2800" b="1">
-                <a:solidFill>
-                  <a:srgbClr val="0F0F0F"/>
-                </a:solidFill>
-                <a:latin typeface="Fira Sans"/>
-              </a:rPr>
-              <a:t>Las variantes del merge: qué filas se conservan</a:t>
-            </a:r>
-          </a:p>
-        </p:txBody>
-      </p:sp>
-      <p:pic>
-        <p:nvPicPr>
-          <p:cNvPr id="4" name="Picture 3" descr="07_diagrama_merge.png"/>
-          <p:cNvPicPr>
-            <a:picLocks noChangeAspect="1"/>
-          </p:cNvPicPr>
-          <p:nvPr/>
-        </p:nvPicPr>
-        <p:blipFill>
-          <a:blip r:embed="rId2"/>
-          <a:stretch>
-            <a:fillRect/>
-          </a:stretch>
-        </p:blipFill>
-        <p:spPr>
-          <a:xfrm>
-            <a:off x="1417319" y="1143000"/>
-            <a:ext cx="6309360" cy="2397276"/>
-          </a:xfrm>
-          <a:prstGeom prst="rect">
-            <a:avLst/>
-          </a:prstGeom>
-        </p:spPr>
-      </p:pic>
-      <p:sp>
-        <p:nvSpPr>
-          <p:cNvPr id="5" name="TextBox 4"/>
-          <p:cNvSpPr txBox="1"/>
-          <p:nvPr/>
-        </p:nvSpPr>
-        <p:spPr>
-          <a:xfrm>
-            <a:off x="704088" y="4434840"/>
-            <a:ext cx="7744968" cy="457200"/>
-          </a:xfrm>
-          <a:prstGeom prst="rect">
-            <a:avLst/>
-          </a:prstGeom>
-          <a:noFill/>
-        </p:spPr>
-        <p:txBody>
-          <a:bodyPr wrap="square">
-            <a:spAutoFit/>
-          </a:bodyPr>
-          <a:lstStyle/>
-          <a:p>
-            <a:r>
-              <a:rPr sz="1300" b="0">
-                <a:solidFill>
-                  <a:srgbClr val="333333"/>
-                </a:solidFill>
-                <a:latin typeface="Fira Sans"/>
-              </a:rPr>
-              <a:t>El valor por defecto es inner: descarta sin aviso las filas sin pareja.</a:t>
+              <a:rPr sz="3400" b="1">
+                <a:solidFill>
+                  <a:srgbClr val="FFFFFF"/>
+                </a:solidFill>
+                <a:latin typeface="Fira Sans"/>
+              </a:rPr>
+              <a:t>Repaso de Pandas</a:t>
+            </a:r>
+          </a:p>
+          <a:p>
+            <a:r>
+              <a:rPr sz="1800" b="0">
+                <a:solidFill>
+                  <a:srgbClr val="E0A437"/>
+                </a:solidFill>
+                <a:latin typeface="Fira Sans"/>
+              </a:rPr>
+              <a:t>Dos casos concretos con la EOD</a:t>
             </a:r>
           </a:p>
         </p:txBody>
@@ -4437,21 +4615,112 @@
                 </a:solidFill>
                 <a:latin typeface="Fira Sans"/>
               </a:rPr>
-              <a:t>El efecto del parámetro how sobre la población analizada</a:t>
-            </a:r>
-          </a:p>
-        </p:txBody>
-      </p:sp>
-      <p:sp>
-        <p:nvSpPr>
-          <p:cNvPr id="4" name="TextBox 3"/>
+              <a:t>Abrir el dataset</a:t>
+            </a:r>
+          </a:p>
+        </p:txBody>
+      </p:sp>
+      <p:sp>
+        <p:nvSpPr>
+          <p:cNvPr id="4" name="Rectangle 3"/>
+          <p:cNvSpPr/>
+          <p:nvPr/>
+        </p:nvSpPr>
+        <p:spPr>
+          <a:xfrm>
+            <a:off x="704088" y="1280160"/>
+            <a:ext cx="7744968" cy="2377440"/>
+          </a:xfrm>
+          <a:prstGeom prst="rect">
+            <a:avLst/>
+          </a:prstGeom>
+          <a:solidFill>
+            <a:srgbClr val="F0F2F5"/>
+          </a:solidFill>
+          <a:ln>
+            <a:solidFill>
+              <a:srgbClr val="D8DDE3"/>
+            </a:solidFill>
+          </a:ln>
+          <a:effectLst/>
+        </p:spPr>
+        <p:style>
+          <a:lnRef idx="1">
+            <a:schemeClr val="accent1"/>
+          </a:lnRef>
+          <a:fillRef idx="3">
+            <a:schemeClr val="accent1"/>
+          </a:fillRef>
+          <a:effectRef idx="2">
+            <a:schemeClr val="accent1"/>
+          </a:effectRef>
+          <a:fontRef idx="minor">
+            <a:schemeClr val="lt1"/>
+          </a:fontRef>
+        </p:style>
+        <p:txBody>
+          <a:bodyPr rtlCol="0" anchor="ctr" wrap="square" lIns="228600" tIns="137160"/>
+          <a:lstStyle/>
+          <a:p>
+            <a:pPr/>
+            <a:r>
+              <a:rPr sz="1500" b="0">
+                <a:solidFill>
+                  <a:srgbClr val="1D3557"/>
+                </a:solidFill>
+                <a:latin typeface="Menlo"/>
+              </a:rPr>
+              <a:t>import pandas as pd</a:t>
+            </a:r>
+          </a:p>
+          <a:p>
+            <a:pPr/>
+            <a:r>
+              <a:rPr sz="1500" b="0">
+                <a:solidFill>
+                  <a:srgbClr val="1D3557"/>
+                </a:solidFill>
+                <a:latin typeface="Menlo"/>
+              </a:rPr>
+              <a:t/>
+            </a:r>
+          </a:p>
+          <a:p>
+            <a:pPr/>
+            <a:r>
+              <a:rPr sz="1500" b="0">
+                <a:solidFill>
+                  <a:srgbClr val="1D3557"/>
+                </a:solidFill>
+                <a:latin typeface="Menlo"/>
+              </a:rPr>
+              <a:t>viajes = pd.read_csv('datos/eod_stgo/viajes.csv',</a:t>
+            </a:r>
+          </a:p>
+          <a:p>
+            <a:pPr/>
+            <a:r>
+              <a:rPr sz="1500" b="0">
+                <a:solidFill>
+                  <a:srgbClr val="1D3557"/>
+                </a:solidFill>
+                <a:latin typeface="Menlo"/>
+              </a:rPr>
+              <a:t>                     sep=';', decimal=',')</a:t>
+            </a:r>
+          </a:p>
+        </p:txBody>
+      </p:sp>
+      <p:sp>
+        <p:nvSpPr>
+          <p:cNvPr id="5" name="TextBox 4"/>
           <p:cNvSpPr txBox="1"/>
           <p:nvPr/>
         </p:nvSpPr>
         <p:spPr>
           <a:xfrm>
-            <a:off x="704088" y="1353312"/>
-            <a:ext cx="7744968" cy="3300984"/>
+            <a:off x="704088" y="3886200"/>
+            <a:ext cx="7744968" cy="1097280"/>
           </a:xfrm>
           <a:prstGeom prst="rect">
             <a:avLst/>
@@ -4473,7 +4742,7 @@
               </a:spcAft>
             </a:pPr>
             <a:r>
-              <a:rPr sz="1800" b="1">
+              <a:rPr sz="1600" b="1">
                 <a:solidFill>
                   <a:srgbClr val="E0A437"/>
                 </a:solidFill>
@@ -4482,125 +4751,13 @@
               <a:t>▸ </a:t>
             </a:r>
             <a:r>
-              <a:rPr sz="1800" b="0">
+              <a:rPr sz="1600" b="0">
                 <a:solidFill>
                   <a:srgbClr val="000000"/>
                 </a:solidFill>
                 <a:latin typeface="Fira Sans"/>
               </a:rPr>
-              <a:t>Personas con viajes, merge inner: 113.591 filas (una por viaje).</a:t>
-            </a:r>
-          </a:p>
-          <a:p>
-            <a:pPr>
-              <a:lnSpc>
-                <a:spcPct val="112000"/>
-              </a:lnSpc>
-              <a:spcAft>
-                <a:spcPts val="900"/>
-              </a:spcAft>
-            </a:pPr>
-            <a:r>
-              <a:rPr sz="1800" b="1">
-                <a:solidFill>
-                  <a:srgbClr val="E0A437"/>
-                </a:solidFill>
-                <a:latin typeface="Fira Sans"/>
-              </a:rPr>
-              <a:t>▸ </a:t>
-            </a:r>
-            <a:r>
-              <a:rPr sz="1800" b="0">
-                <a:solidFill>
-                  <a:srgbClr val="000000"/>
-                </a:solidFill>
-                <a:latin typeface="Fira Sans"/>
-              </a:rPr>
-              <a:t>El mismo merge en left: 127.379 filas.</a:t>
-            </a:r>
-          </a:p>
-          <a:p>
-            <a:pPr>
-              <a:lnSpc>
-                <a:spcPct val="112000"/>
-              </a:lnSpc>
-              <a:spcAft>
-                <a:spcPts val="500"/>
-              </a:spcAft>
-            </a:pPr>
-            <a:r>
-              <a:rPr sz="1400" b="0">
-                <a:solidFill>
-                  <a:srgbClr val="333333"/>
-                </a:solidFill>
-                <a:latin typeface="Fira Sans"/>
-              </a:rPr>
-              <a:t>     ◦  </a:t>
-            </a:r>
-            <a:r>
-              <a:rPr sz="1400" b="0">
-                <a:solidFill>
-                  <a:srgbClr val="333333"/>
-                </a:solidFill>
-                <a:latin typeface="Fira Sans"/>
-              </a:rPr>
-              <a:t>La diferencia son 13.788 personas que no viajaron ese día.</a:t>
-            </a:r>
-          </a:p>
-          <a:p>
-            <a:pPr>
-              <a:lnSpc>
-                <a:spcPct val="112000"/>
-              </a:lnSpc>
-              <a:spcAft>
-                <a:spcPts val="500"/>
-              </a:spcAft>
-            </a:pPr>
-            <a:r>
-              <a:rPr sz="1400" b="0">
-                <a:solidFill>
-                  <a:srgbClr val="333333"/>
-                </a:solidFill>
-                <a:latin typeface="Fira Sans"/>
-              </a:rPr>
-              <a:t>     ◦  </a:t>
-            </a:r>
-            <a:r>
-              <a:rPr sz="1400" b="0">
-                <a:solidFill>
-                  <a:srgbClr val="333333"/>
-                </a:solidFill>
-                <a:latin typeface="Fira Sans"/>
-              </a:rPr>
-              <a:t>Con inner desaparecen; con left quedan, con NaN en el viaje.</a:t>
-            </a:r>
-          </a:p>
-          <a:p>
-            <a:pPr>
-              <a:lnSpc>
-                <a:spcPct val="112000"/>
-              </a:lnSpc>
-              <a:spcAft>
-                <a:spcPts val="900"/>
-              </a:spcAft>
-            </a:pPr>
-            <a:r>
-              <a:rPr sz="1800" b="1">
-                <a:solidFill>
-                  <a:srgbClr val="E0A437"/>
-                </a:solidFill>
-                <a:latin typeface="Fira Sans"/>
-              </a:rPr>
-              <a:t>▸ </a:t>
-            </a:r>
-            <a:r>
-              <a:rPr sz="1800" b="1">
-                <a:solidFill>
-                  <a:srgbClr val="1D3557"/>
-                </a:solidFill>
-                <a:latin typeface="Fira Sans"/>
-              </a:rPr>
-              <a:t>Un promedio calculado sobre el resultado del inner excluye a quienes no viajaron.</a:t>
+              <a:t>Todo el código de la clase está en el notebook 02_pandas_eda.ipynb del repositorio.</a:t>
             </a:r>
           </a:p>
         </p:txBody>
@@ -4696,102 +4853,35 @@
                 </a:solidFill>
                 <a:latin typeface="Fira Sans"/>
               </a:rPr>
-              <a:t>Caso 2: contar sin perder a los que no aparecen</a:t>
-            </a:r>
-          </a:p>
-        </p:txBody>
-      </p:sp>
-      <p:sp>
-        <p:nvSpPr>
-          <p:cNvPr id="4" name="Rectangle 3"/>
-          <p:cNvSpPr/>
-          <p:nvPr/>
-        </p:nvSpPr>
-        <p:spPr>
-          <a:xfrm>
-            <a:off x="704088" y="1280160"/>
-            <a:ext cx="7744968" cy="2377440"/>
-          </a:xfrm>
-          <a:prstGeom prst="rect">
-            <a:avLst/>
-          </a:prstGeom>
-          <a:solidFill>
-            <a:srgbClr val="F0F2F5"/>
-          </a:solidFill>
-          <a:ln>
-            <a:solidFill>
-              <a:srgbClr val="D8DDE3"/>
-            </a:solidFill>
-          </a:ln>
-          <a:effectLst/>
-        </p:spPr>
-        <p:style>
-          <a:lnRef idx="1">
-            <a:schemeClr val="accent1"/>
-          </a:lnRef>
-          <a:fillRef idx="3">
-            <a:schemeClr val="accent1"/>
-          </a:fillRef>
-          <a:effectRef idx="2">
-            <a:schemeClr val="accent1"/>
-          </a:effectRef>
-          <a:fontRef idx="minor">
-            <a:schemeClr val="lt1"/>
-          </a:fontRef>
-        </p:style>
-        <p:txBody>
-          <a:bodyPr rtlCol="0" anchor="ctr" wrap="square" lIns="228600" tIns="137160"/>
-          <a:lstStyle/>
-          <a:p>
-            <a:pPr/>
-            <a:r>
-              <a:rPr sz="1500" b="0">
-                <a:solidFill>
-                  <a:srgbClr val="1D3557"/>
-                </a:solidFill>
-                <a:latin typeface="Menlo"/>
-              </a:rPr>
-              <a:t>viajes_por_persona = viajes.groupby(['Hogar', 'Persona']).size()</a:t>
-            </a:r>
-          </a:p>
-          <a:p>
-            <a:pPr/>
-            <a:r>
-              <a:rPr sz="1500" b="0">
-                <a:solidFill>
-                  <a:srgbClr val="1D3557"/>
-                </a:solidFill>
-                <a:latin typeface="Menlo"/>
-              </a:rPr>
-              <a:t/>
-            </a:r>
-          </a:p>
-          <a:p>
-            <a:pPr/>
-            <a:r>
-              <a:rPr sz="1500" b="0">
-                <a:solidFill>
-                  <a:srgbClr val="1D3557"/>
-                </a:solidFill>
-                <a:latin typeface="Menlo"/>
-              </a:rPr>
-              <a:t>conteo = personas.set_index(['Hogar', 'Persona']).assign(</a:t>
-            </a:r>
-          </a:p>
-          <a:p>
-            <a:pPr/>
-            <a:r>
-              <a:rPr sz="1500" b="0">
-                <a:solidFill>
-                  <a:srgbClr val="1D3557"/>
-                </a:solidFill>
-                <a:latin typeface="Menlo"/>
-              </a:rPr>
-              <a:t>    n_viajes=viajes_por_persona)['n_viajes'].fillna(0)</a:t>
-            </a:r>
-          </a:p>
-        </p:txBody>
-      </p:sp>
+              <a:t>El DataFrame: la estructura central de Pandas</a:t>
+            </a:r>
+          </a:p>
+        </p:txBody>
+      </p:sp>
+      <p:pic>
+        <p:nvPicPr>
+          <p:cNvPr id="4" name="Picture 3" descr="13_dataframe.png"/>
+          <p:cNvPicPr>
+            <a:picLocks noChangeAspect="1"/>
+          </p:cNvPicPr>
+          <p:nvPr/>
+        </p:nvPicPr>
+        <p:blipFill>
+          <a:blip r:embed="rId2"/>
+          <a:stretch>
+            <a:fillRect/>
+          </a:stretch>
+        </p:blipFill>
+        <p:spPr>
+          <a:xfrm>
+            <a:off x="1417319" y="1143000"/>
+            <a:ext cx="6309360" cy="2553789"/>
+          </a:xfrm>
+          <a:prstGeom prst="rect">
+            <a:avLst/>
+          </a:prstGeom>
+        </p:spPr>
+      </p:pic>
       <p:sp>
         <p:nvSpPr>
           <p:cNvPr id="5" name="TextBox 4"/>
@@ -4800,8 +4890,8 @@
         </p:nvSpPr>
         <p:spPr>
           <a:xfrm>
-            <a:off x="704088" y="3886200"/>
-            <a:ext cx="7744968" cy="1097280"/>
+            <a:off x="704088" y="4434840"/>
+            <a:ext cx="7744968" cy="457200"/>
           </a:xfrm>
           <a:prstGeom prst="rect">
             <a:avLst/>
@@ -4814,31 +4904,14 @@
           </a:bodyPr>
           <a:lstStyle/>
           <a:p>
-            <a:pPr>
-              <a:lnSpc>
-                <a:spcPct val="112000"/>
-              </a:lnSpc>
-              <a:spcAft>
-                <a:spcPts val="900"/>
-              </a:spcAft>
-            </a:pPr>
-            <a:r>
-              <a:rPr sz="1600" b="1">
-                <a:solidFill>
-                  <a:srgbClr val="E0A437"/>
-                </a:solidFill>
-                <a:latin typeface="Fira Sans"/>
-              </a:rPr>
-              <a:t>▸ </a:t>
-            </a:r>
-            <a:r>
-              <a:rPr sz="1600" b="0">
-                <a:solidFill>
-                  <a:srgbClr val="000000"/>
-                </a:solidFill>
-                <a:latin typeface="Fira Sans"/>
-              </a:rPr>
-              <a:t>El groupby cuenta sobre la tabla de viajes; el fillna(0) reincorpora a los ausentes.</a:t>
+            <a:r>
+              <a:rPr sz="1300" b="0">
+                <a:solidFill>
+                  <a:srgbClr val="333333"/>
+                </a:solidFill>
+                <a:latin typeface="Fira Sans"/>
+              </a:rPr>
+              <a:t>Una tabla con filas indexadas y columnas con nombre y tipo. Los códigos (comuna, propósito) se traducen con las tablas de parámetros, uniéndolas con merge.</a:t>
             </a:r>
           </a:p>
         </p:txBody>
@@ -4876,7 +4949,7 @@
             <a:avLst/>
           </a:prstGeom>
           <a:solidFill>
-            <a:srgbClr val="1D3557"/>
+            <a:srgbClr val="FAFBFC"/>
           </a:solidFill>
           <a:ln>
             <a:noFill/>
@@ -4913,8 +4986,8 @@
         </p:nvSpPr>
         <p:spPr>
           <a:xfrm>
-            <a:off x="603504" y="1847088"/>
-            <a:ext cx="7946136" cy="1399032"/>
+            <a:off x="402336" y="301752"/>
+            <a:ext cx="8348472" cy="795528"/>
           </a:xfrm>
           <a:prstGeom prst="rect">
             <a:avLst/>
@@ -4928,24 +5001,71 @@
           <a:lstStyle/>
           <a:p>
             <a:r>
-              <a:rPr sz="3400" b="1">
-                <a:solidFill>
-                  <a:srgbClr val="FFFFFF"/>
-                </a:solidFill>
-                <a:latin typeface="Fira Sans"/>
-              </a:rPr>
-              <a:t>Exploración de la EOD</a:t>
-            </a:r>
-          </a:p>
-          <a:p>
-            <a:r>
-              <a:rPr sz="1800" b="0">
-                <a:solidFill>
-                  <a:srgbClr val="E0A437"/>
-                </a:solidFill>
-                <a:latin typeface="Fira Sans"/>
-              </a:rPr>
-              <a:t>Estadística descriptiva sobre datos reales</a:t>
+              <a:rPr sz="2800" b="1">
+                <a:solidFill>
+                  <a:srgbClr val="0F0F0F"/>
+                </a:solidFill>
+                <a:latin typeface="Fira Sans"/>
+              </a:rPr>
+              <a:t>Las variantes del merge: qué filas se conservan</a:t>
+            </a:r>
+          </a:p>
+        </p:txBody>
+      </p:sp>
+      <p:pic>
+        <p:nvPicPr>
+          <p:cNvPr id="4" name="Picture 3" descr="07_diagrama_merge.png"/>
+          <p:cNvPicPr>
+            <a:picLocks noChangeAspect="1"/>
+          </p:cNvPicPr>
+          <p:nvPr/>
+        </p:nvPicPr>
+        <p:blipFill>
+          <a:blip r:embed="rId2"/>
+          <a:stretch>
+            <a:fillRect/>
+          </a:stretch>
+        </p:blipFill>
+        <p:spPr>
+          <a:xfrm>
+            <a:off x="1417319" y="1143000"/>
+            <a:ext cx="6309360" cy="2397276"/>
+          </a:xfrm>
+          <a:prstGeom prst="rect">
+            <a:avLst/>
+          </a:prstGeom>
+        </p:spPr>
+      </p:pic>
+      <p:sp>
+        <p:nvSpPr>
+          <p:cNvPr id="5" name="TextBox 4"/>
+          <p:cNvSpPr txBox="1"/>
+          <p:nvPr/>
+        </p:nvSpPr>
+        <p:spPr>
+          <a:xfrm>
+            <a:off x="704088" y="4434840"/>
+            <a:ext cx="7744968" cy="457200"/>
+          </a:xfrm>
+          <a:prstGeom prst="rect">
+            <a:avLst/>
+          </a:prstGeom>
+          <a:noFill/>
+        </p:spPr>
+        <p:txBody>
+          <a:bodyPr wrap="square">
+            <a:spAutoFit/>
+          </a:bodyPr>
+          <a:lstStyle/>
+          <a:p>
+            <a:r>
+              <a:rPr sz="1300" b="0">
+                <a:solidFill>
+                  <a:srgbClr val="333333"/>
+                </a:solidFill>
+                <a:latin typeface="Fira Sans"/>
+              </a:rPr>
+              <a:t>El valor por defecto es inner: descarta sin aviso las filas sin pareja.</a:t>
             </a:r>
           </a:p>
         </p:txBody>
@@ -5041,7 +5161,7 @@
                 </a:solidFill>
                 <a:latin typeface="Fira Sans"/>
               </a:rPr>
-              <a:t>Viajes por persona: los ausentes también cuentan</a:t>
+              <a:t>El efecto del parámetro how sobre la población analizada</a:t>
             </a:r>
           </a:p>
         </p:txBody>
@@ -5054,8 +5174,8 @@
         </p:nvSpPr>
         <p:spPr>
           <a:xfrm>
-            <a:off x="502920" y="1252728"/>
-            <a:ext cx="4023360" cy="3200400"/>
+            <a:off x="704088" y="1353312"/>
+            <a:ext cx="7744968" cy="3300984"/>
           </a:xfrm>
           <a:prstGeom prst="rect">
             <a:avLst/>
@@ -5077,7 +5197,7 @@
               </a:spcAft>
             </a:pPr>
             <a:r>
-              <a:rPr sz="1500" b="1">
+              <a:rPr sz="1800" b="1">
                 <a:solidFill>
                   <a:srgbClr val="E0A437"/>
                 </a:solidFill>
@@ -5086,13 +5206,13 @@
               <a:t>▸ </a:t>
             </a:r>
             <a:r>
-              <a:rPr sz="1500" b="0">
+              <a:rPr sz="1800" b="0">
                 <a:solidFill>
                   <a:srgbClr val="000000"/>
                 </a:solidFill>
                 <a:latin typeface="Fira Sans"/>
               </a:rPr>
-              <a:t>El 23% de las personas no viajó ese día.</a:t>
+              <a:t>Personas con viajes, merge inner: 113.591 filas (una por viaje).</a:t>
             </a:r>
           </a:p>
           <a:p>
@@ -5105,7 +5225,7 @@
               </a:spcAft>
             </a:pPr>
             <a:r>
-              <a:rPr sz="1500" b="1">
+              <a:rPr sz="1800" b="1">
                 <a:solidFill>
                   <a:srgbClr val="E0A437"/>
                 </a:solidFill>
@@ -5114,13 +5234,69 @@
               <a:t>▸ </a:t>
             </a:r>
             <a:r>
-              <a:rPr sz="1500" b="0">
+              <a:rPr sz="1800" b="0">
                 <a:solidFill>
                   <a:srgbClr val="000000"/>
                 </a:solidFill>
                 <a:latin typeface="Fira Sans"/>
               </a:rPr>
-              <a:t>Media: 1,9 viajes. Mediana: 2 viajes.</a:t>
+              <a:t>El mismo merge en left: 127.379 filas.</a:t>
+            </a:r>
+          </a:p>
+          <a:p>
+            <a:pPr>
+              <a:lnSpc>
+                <a:spcPct val="112000"/>
+              </a:lnSpc>
+              <a:spcAft>
+                <a:spcPts val="500"/>
+              </a:spcAft>
+            </a:pPr>
+            <a:r>
+              <a:rPr sz="1400" b="0">
+                <a:solidFill>
+                  <a:srgbClr val="333333"/>
+                </a:solidFill>
+                <a:latin typeface="Fira Sans"/>
+              </a:rPr>
+              <a:t>     ◦  </a:t>
+            </a:r>
+            <a:r>
+              <a:rPr sz="1400" b="0">
+                <a:solidFill>
+                  <a:srgbClr val="333333"/>
+                </a:solidFill>
+                <a:latin typeface="Fira Sans"/>
+              </a:rPr>
+              <a:t>La diferencia son 13.788 personas que no viajaron ese día.</a:t>
+            </a:r>
+          </a:p>
+          <a:p>
+            <a:pPr>
+              <a:lnSpc>
+                <a:spcPct val="112000"/>
+              </a:lnSpc>
+              <a:spcAft>
+                <a:spcPts val="500"/>
+              </a:spcAft>
+            </a:pPr>
+            <a:r>
+              <a:rPr sz="1400" b="0">
+                <a:solidFill>
+                  <a:srgbClr val="333333"/>
+                </a:solidFill>
+                <a:latin typeface="Fira Sans"/>
+              </a:rPr>
+              <a:t>     ◦  </a:t>
+            </a:r>
+            <a:r>
+              <a:rPr sz="1400" b="0">
+                <a:solidFill>
+                  <a:srgbClr val="333333"/>
+                </a:solidFill>
+                <a:latin typeface="Fira Sans"/>
+              </a:rPr>
+              <a:t>Con inner desaparecen; con left quedan, con NaN en el viaje.</a:t>
             </a:r>
           </a:p>
           <a:p>
@@ -5133,7 +5309,7 @@
               </a:spcAft>
             </a:pPr>
             <a:r>
-              <a:rPr sz="1500" b="1">
+              <a:rPr sz="1800" b="1">
                 <a:solidFill>
                   <a:srgbClr val="E0A437"/>
                 </a:solidFill>
@@ -5142,69 +5318,17 @@
               <a:t>▸ </a:t>
             </a:r>
             <a:r>
-              <a:rPr sz="1500" b="0">
-                <a:solidFill>
-                  <a:srgbClr val="000000"/>
-                </a:solidFill>
-                <a:latin typeface="Fira Sans"/>
-              </a:rPr>
-              <a:t>La media quedó bajo la mediana: la masa de ceros la desplaza.</a:t>
-            </a:r>
-          </a:p>
-          <a:p>
-            <a:pPr>
-              <a:lnSpc>
-                <a:spcPct val="112000"/>
-              </a:lnSpc>
-              <a:spcAft>
-                <a:spcPts val="900"/>
-              </a:spcAft>
-            </a:pPr>
-            <a:r>
-              <a:rPr sz="1500" b="1">
-                <a:solidFill>
-                  <a:srgbClr val="E0A437"/>
-                </a:solidFill>
-                <a:latin typeface="Fira Sans"/>
-              </a:rPr>
-              <a:t>▸ </a:t>
-            </a:r>
-            <a:r>
-              <a:rPr sz="1500" b="1">
+              <a:rPr sz="1800" b="1">
                 <a:solidFill>
                   <a:srgbClr val="1D3557"/>
                 </a:solidFill>
                 <a:latin typeface="Fira Sans"/>
               </a:rPr>
-              <a:t>La dirección del sesgo depende de la forma de la distribución.</a:t>
-            </a:r>
-          </a:p>
-        </p:txBody>
-      </p:sp>
-      <p:pic>
-        <p:nvPicPr>
-          <p:cNvPr id="5" name="Picture 4" descr="02_viajes_por_persona.png"/>
-          <p:cNvPicPr>
-            <a:picLocks noChangeAspect="1"/>
-          </p:cNvPicPr>
-          <p:nvPr/>
-        </p:nvPicPr>
-        <p:blipFill>
-          <a:blip r:embed="rId2"/>
-          <a:stretch>
-            <a:fillRect/>
-          </a:stretch>
-        </p:blipFill>
-        <p:spPr>
-          <a:xfrm>
-            <a:off x="4892040" y="1371600"/>
-            <a:ext cx="3840480" cy="2191739"/>
-          </a:xfrm>
-          <a:prstGeom prst="rect">
-            <a:avLst/>
-          </a:prstGeom>
-        </p:spPr>
-      </p:pic>
+              <a:t>Un promedio calculado sobre el resultado del inner excluye a quienes no viajaron.</a:t>
+            </a:r>
+          </a:p>
+        </p:txBody>
+      </p:sp>
     </p:spTree>
   </p:cSld>
   <p:clrMapOvr>
@@ -5553,7 +5677,7 @@
             <a:avLst/>
           </a:prstGeom>
           <a:solidFill>
-            <a:srgbClr val="FAFBFC"/>
+            <a:srgbClr val="1D3557"/>
           </a:solidFill>
           <a:ln>
             <a:noFill/>
@@ -5590,8 +5714,8 @@
         </p:nvSpPr>
         <p:spPr>
           <a:xfrm>
-            <a:off x="402336" y="301752"/>
-            <a:ext cx="8348472" cy="795528"/>
+            <a:off x="603504" y="1847088"/>
+            <a:ext cx="7946136" cy="1399032"/>
           </a:xfrm>
           <a:prstGeom prst="rect">
             <a:avLst/>
@@ -5605,71 +5729,24 @@
           <a:lstStyle/>
           <a:p>
             <a:r>
-              <a:rPr sz="2800" b="1">
-                <a:solidFill>
-                  <a:srgbClr val="0F0F0F"/>
-                </a:solidFill>
-                <a:latin typeface="Fira Sans"/>
-              </a:rPr>
-              <a:t>Los factores de expansión: de la muestra a la ciudad</a:t>
-            </a:r>
-          </a:p>
-        </p:txBody>
-      </p:sp>
-      <p:pic>
-        <p:nvPicPr>
-          <p:cNvPr id="4" name="Picture 3" descr="06_diagrama_factores.png"/>
-          <p:cNvPicPr>
-            <a:picLocks noChangeAspect="1"/>
-          </p:cNvPicPr>
-          <p:nvPr/>
-        </p:nvPicPr>
-        <p:blipFill>
-          <a:blip r:embed="rId2"/>
-          <a:stretch>
-            <a:fillRect/>
-          </a:stretch>
-        </p:blipFill>
-        <p:spPr>
-          <a:xfrm>
-            <a:off x="1417319" y="1143000"/>
-            <a:ext cx="6309360" cy="2871234"/>
-          </a:xfrm>
-          <a:prstGeom prst="rect">
-            <a:avLst/>
-          </a:prstGeom>
-        </p:spPr>
-      </p:pic>
-      <p:sp>
-        <p:nvSpPr>
-          <p:cNvPr id="5" name="TextBox 4"/>
-          <p:cNvSpPr txBox="1"/>
-          <p:nvPr/>
-        </p:nvSpPr>
-        <p:spPr>
-          <a:xfrm>
-            <a:off x="704088" y="4434840"/>
-            <a:ext cx="7744968" cy="457200"/>
-          </a:xfrm>
-          <a:prstGeom prst="rect">
-            <a:avLst/>
-          </a:prstGeom>
-          <a:noFill/>
-        </p:spPr>
-        <p:txBody>
-          <a:bodyPr wrap="square">
-            <a:spAutoFit/>
-          </a:bodyPr>
-          <a:lstStyle/>
-          <a:p>
-            <a:r>
-              <a:rPr sz="1300" b="0">
-                <a:solidFill>
-                  <a:srgbClr val="333333"/>
-                </a:solidFill>
-                <a:latin typeface="Fira Sans"/>
-              </a:rPr>
-              <a:t>Contar filas responde por la muestra; sumar factores responde por la ciudad.</a:t>
+              <a:rPr sz="3400" b="1">
+                <a:solidFill>
+                  <a:srgbClr val="FFFFFF"/>
+                </a:solidFill>
+                <a:latin typeface="Fira Sans"/>
+              </a:rPr>
+              <a:t>Exploración de la EOD</a:t>
+            </a:r>
+          </a:p>
+          <a:p>
+            <a:r>
+              <a:rPr sz="1800" b="0">
+                <a:solidFill>
+                  <a:srgbClr val="E0A437"/>
+                </a:solidFill>
+                <a:latin typeface="Fira Sans"/>
+              </a:rPr>
+              <a:t>Estadística descriptiva sobre datos reales</a:t>
             </a:r>
           </a:p>
         </p:txBody>
@@ -5765,7 +5842,7 @@
                 </a:solidFill>
                 <a:latin typeface="Fira Sans"/>
               </a:rPr>
-              <a:t>El ingreso de los hogares: media y mediana</a:t>
+              <a:t>Viajes por persona: los ausentes también cuentan</a:t>
             </a:r>
           </a:p>
         </p:txBody>
@@ -5816,7 +5893,7 @@
                 </a:solidFill>
                 <a:latin typeface="Fira Sans"/>
               </a:rPr>
-              <a:t>Media: $688.274. Mediana: $507.826.</a:t>
+              <a:t>El 23% de las personas no viajó ese día.</a:t>
             </a:r>
           </a:p>
           <a:p>
@@ -5844,7 +5921,7 @@
                 </a:solidFill>
                 <a:latin typeface="Fira Sans"/>
               </a:rPr>
-              <a:t>La media es un 36% más alta que la mediana.</a:t>
+              <a:t>Media: 1,9 viajes. Mediana: 2 viajes.</a:t>
             </a:r>
           </a:p>
           <a:p>
@@ -5872,7 +5949,7 @@
                 </a:solidFill>
                 <a:latin typeface="Fira Sans"/>
               </a:rPr>
-              <a:t>Los ingresos altos desplazan el promedio; la mayoría gana menos.</a:t>
+              <a:t>La media quedó bajo la mediana: la masa de ceros la desplaza.</a:t>
             </a:r>
           </a:p>
           <a:p>
@@ -5900,14 +5977,14 @@
                 </a:solidFill>
                 <a:latin typeface="Fira Sans"/>
               </a:rPr>
-              <a:t>El promedio describe una situación en la que la mayoría no está.</a:t>
+              <a:t>La dirección del sesgo depende de la forma de la distribución.</a:t>
             </a:r>
           </a:p>
         </p:txBody>
       </p:sp>
       <p:pic>
         <p:nvPicPr>
-          <p:cNvPr id="5" name="Picture 4" descr="01_ingreso_media_mediana.png"/>
+          <p:cNvPr id="5" name="Picture 4" descr="02_viajes_por_persona.png"/>
           <p:cNvPicPr>
             <a:picLocks noChangeAspect="1"/>
           </p:cNvPicPr>
@@ -5922,7 +5999,7 @@
         <p:spPr>
           <a:xfrm>
             <a:off x="4892040" y="1371600"/>
-            <a:ext cx="3840480" cy="2182719"/>
+            <a:ext cx="3840480" cy="2191739"/>
           </a:xfrm>
           <a:prstGeom prst="rect">
             <a:avLst/>
@@ -6020,149 +6097,14 @@
                 </a:solidFill>
                 <a:latin typeface="Fira Sans"/>
               </a:rPr>
-              <a:t>La duración de los viajes: valores extremos</a:t>
-            </a:r>
-          </a:p>
-        </p:txBody>
-      </p:sp>
-      <p:sp>
-        <p:nvSpPr>
-          <p:cNvPr id="4" name="TextBox 3"/>
-          <p:cNvSpPr txBox="1"/>
-          <p:nvPr/>
-        </p:nvSpPr>
-        <p:spPr>
-          <a:xfrm>
-            <a:off x="502920" y="1252728"/>
-            <a:ext cx="4023360" cy="3200400"/>
-          </a:xfrm>
-          <a:prstGeom prst="rect">
-            <a:avLst/>
-          </a:prstGeom>
-          <a:noFill/>
-        </p:spPr>
-        <p:txBody>
-          <a:bodyPr wrap="square">
-            <a:spAutoFit/>
-          </a:bodyPr>
-          <a:lstStyle/>
-          <a:p>
-            <a:pPr>
-              <a:lnSpc>
-                <a:spcPct val="112000"/>
-              </a:lnSpc>
-              <a:spcAft>
-                <a:spcPts val="900"/>
-              </a:spcAft>
-            </a:pPr>
-            <a:r>
-              <a:rPr sz="1500" b="1">
-                <a:solidFill>
-                  <a:srgbClr val="E0A437"/>
-                </a:solidFill>
-                <a:latin typeface="Fira Sans"/>
-              </a:rPr>
-              <a:t>▸ </a:t>
-            </a:r>
-            <a:r>
-              <a:rPr sz="1500" b="0">
-                <a:solidFill>
-                  <a:srgbClr val="000000"/>
-                </a:solidFill>
-                <a:latin typeface="Fira Sans"/>
-              </a:rPr>
-              <a:t>Mediana: 30 minutos. Percentil 95: 98 minutos.</a:t>
-            </a:r>
-          </a:p>
-          <a:p>
-            <a:pPr>
-              <a:lnSpc>
-                <a:spcPct val="112000"/>
-              </a:lnSpc>
-              <a:spcAft>
-                <a:spcPts val="900"/>
-              </a:spcAft>
-            </a:pPr>
-            <a:r>
-              <a:rPr sz="1500" b="1">
-                <a:solidFill>
-                  <a:srgbClr val="E0A437"/>
-                </a:solidFill>
-                <a:latin typeface="Fira Sans"/>
-              </a:rPr>
-              <a:t>▸ </a:t>
-            </a:r>
-            <a:r>
-              <a:rPr sz="1500" b="0">
-                <a:solidFill>
-                  <a:srgbClr val="000000"/>
-                </a:solidFill>
-                <a:latin typeface="Fira Sans"/>
-              </a:rPr>
-              <a:t>Máximo registrado: 1.335 minutos, un viaje de 22 horas.</a:t>
-            </a:r>
-          </a:p>
-          <a:p>
-            <a:pPr>
-              <a:lnSpc>
-                <a:spcPct val="112000"/>
-              </a:lnSpc>
-              <a:spcAft>
-                <a:spcPts val="900"/>
-              </a:spcAft>
-            </a:pPr>
-            <a:r>
-              <a:rPr sz="1500" b="1">
-                <a:solidFill>
-                  <a:srgbClr val="E0A437"/>
-                </a:solidFill>
-                <a:latin typeface="Fira Sans"/>
-              </a:rPr>
-              <a:t>▸ </a:t>
-            </a:r>
-            <a:r>
-              <a:rPr sz="1500" b="0">
-                <a:solidFill>
-                  <a:srgbClr val="000000"/>
-                </a:solidFill>
-                <a:latin typeface="Fira Sans"/>
-              </a:rPr>
-              <a:t>¿Error de digitación? ¿Turno nocturno mal anotado?</a:t>
-            </a:r>
-          </a:p>
-          <a:p>
-            <a:pPr>
-              <a:lnSpc>
-                <a:spcPct val="112000"/>
-              </a:lnSpc>
-              <a:spcAft>
-                <a:spcPts val="900"/>
-              </a:spcAft>
-            </a:pPr>
-            <a:r>
-              <a:rPr sz="1500" b="1">
-                <a:solidFill>
-                  <a:srgbClr val="E0A437"/>
-                </a:solidFill>
-                <a:latin typeface="Fira Sans"/>
-              </a:rPr>
-              <a:t>▸ </a:t>
-            </a:r>
-            <a:r>
-              <a:rPr sz="1500" b="1">
-                <a:solidFill>
-                  <a:srgbClr val="1D3557"/>
-                </a:solidFill>
-                <a:latin typeface="Fira Sans"/>
-              </a:rPr>
-              <a:t>Los valores extremos se investigan y la decisión se declara.</a:t>
+              <a:t>Los factores de expansión: de la muestra a la ciudad</a:t>
             </a:r>
           </a:p>
         </p:txBody>
       </p:sp>
       <p:pic>
         <p:nvPicPr>
-          <p:cNvPr id="5" name="Picture 4" descr="04_duracion_viajes.png"/>
+          <p:cNvPr id="4" name="Picture 3" descr="06_diagrama_factores.png"/>
           <p:cNvPicPr>
             <a:picLocks noChangeAspect="1"/>
           </p:cNvPicPr>
@@ -6176,14 +6118,48 @@
         </p:blipFill>
         <p:spPr>
           <a:xfrm>
-            <a:off x="4892040" y="1371600"/>
-            <a:ext cx="3840480" cy="2146492"/>
+            <a:off x="1417319" y="1143000"/>
+            <a:ext cx="6309360" cy="2871234"/>
           </a:xfrm>
           <a:prstGeom prst="rect">
             <a:avLst/>
           </a:prstGeom>
         </p:spPr>
       </p:pic>
+      <p:sp>
+        <p:nvSpPr>
+          <p:cNvPr id="5" name="TextBox 4"/>
+          <p:cNvSpPr txBox="1"/>
+          <p:nvPr/>
+        </p:nvSpPr>
+        <p:spPr>
+          <a:xfrm>
+            <a:off x="704088" y="4434840"/>
+            <a:ext cx="7744968" cy="457200"/>
+          </a:xfrm>
+          <a:prstGeom prst="rect">
+            <a:avLst/>
+          </a:prstGeom>
+          <a:noFill/>
+        </p:spPr>
+        <p:txBody>
+          <a:bodyPr wrap="square">
+            <a:spAutoFit/>
+          </a:bodyPr>
+          <a:lstStyle/>
+          <a:p>
+            <a:r>
+              <a:rPr sz="1300" b="0">
+                <a:solidFill>
+                  <a:srgbClr val="333333"/>
+                </a:solidFill>
+                <a:latin typeface="Fira Sans"/>
+              </a:rPr>
+              <a:t>Contar filas responde por la muestra; sumar factores responde por la ciudad.</a:t>
+            </a:r>
+          </a:p>
+        </p:txBody>
+      </p:sp>
     </p:spTree>
   </p:cSld>
   <p:clrMapOvr>
@@ -6275,7 +6251,7 @@
                 </a:solidFill>
                 <a:latin typeface="Fira Sans"/>
               </a:rPr>
-              <a:t>La partición modal del Gran Santiago</a:t>
+              <a:t>El ingreso de los hogares: media y mediana</a:t>
             </a:r>
           </a:p>
         </p:txBody>
@@ -6326,91 +6302,7 @@
                 </a:solidFill>
                 <a:latin typeface="Fira Sans"/>
               </a:rPr>
-              <a:t>Dos merges y un groupby ponderado por factor.</a:t>
-            </a:r>
-          </a:p>
-          <a:p>
-            <a:pPr>
-              <a:lnSpc>
-                <a:spcPct val="112000"/>
-              </a:lnSpc>
-              <a:spcAft>
-                <a:spcPts val="500"/>
-              </a:spcAft>
-            </a:pPr>
-            <a:r>
-              <a:rPr sz="1300" b="0">
-                <a:solidFill>
-                  <a:srgbClr val="333333"/>
-                </a:solidFill>
-                <a:latin typeface="Fira Sans"/>
-              </a:rPr>
-              <a:t>     ◦  </a:t>
-            </a:r>
-            <a:r>
-              <a:rPr sz="1300" b="0">
-                <a:solidFill>
-                  <a:srgbClr val="333333"/>
-                </a:solidFill>
-                <a:latin typeface="Fira Sans"/>
-              </a:rPr>
-              <a:t>Caminata: 34% de los viajes.</a:t>
-            </a:r>
-          </a:p>
-          <a:p>
-            <a:pPr>
-              <a:lnSpc>
-                <a:spcPct val="112000"/>
-              </a:lnSpc>
-              <a:spcAft>
-                <a:spcPts val="500"/>
-              </a:spcAft>
-            </a:pPr>
-            <a:r>
-              <a:rPr sz="1300" b="0">
-                <a:solidFill>
-                  <a:srgbClr val="333333"/>
-                </a:solidFill>
-                <a:latin typeface="Fira Sans"/>
-              </a:rPr>
-              <a:t>     ◦  </a:t>
-            </a:r>
-            <a:r>
-              <a:rPr sz="1300" b="0">
-                <a:solidFill>
-                  <a:srgbClr val="333333"/>
-                </a:solidFill>
-                <a:latin typeface="Fira Sans"/>
-              </a:rPr>
-              <a:t>Transporte público (Bip!): 24%.</a:t>
-            </a:r>
-          </a:p>
-          <a:p>
-            <a:pPr>
-              <a:lnSpc>
-                <a:spcPct val="112000"/>
-              </a:lnSpc>
-              <a:spcAft>
-                <a:spcPts val="500"/>
-              </a:spcAft>
-            </a:pPr>
-            <a:r>
-              <a:rPr sz="1300" b="0">
-                <a:solidFill>
-                  <a:srgbClr val="333333"/>
-                </a:solidFill>
-                <a:latin typeface="Fira Sans"/>
-              </a:rPr>
-              <a:t>     ◦  </a:t>
-            </a:r>
-            <a:r>
-              <a:rPr sz="1300" b="0">
-                <a:solidFill>
-                  <a:srgbClr val="333333"/>
-                </a:solidFill>
-                <a:latin typeface="Fira Sans"/>
-              </a:rPr>
-              <a:t>Auto: 23%.</a:t>
+              <a:t>Media: $688.274. Mediana: $507.826.</a:t>
             </a:r>
           </a:p>
           <a:p>
@@ -6432,20 +6324,76 @@
               <a:t>▸ </a:t>
             </a:r>
             <a:r>
+              <a:rPr sz="1500" b="0">
+                <a:solidFill>
+                  <a:srgbClr val="000000"/>
+                </a:solidFill>
+                <a:latin typeface="Fira Sans"/>
+              </a:rPr>
+              <a:t>La media es un 36% más alta que la mediana.</a:t>
+            </a:r>
+          </a:p>
+          <a:p>
+            <a:pPr>
+              <a:lnSpc>
+                <a:spcPct val="112000"/>
+              </a:lnSpc>
+              <a:spcAft>
+                <a:spcPts val="900"/>
+              </a:spcAft>
+            </a:pPr>
+            <a:r>
               <a:rPr sz="1500" b="1">
                 <a:solidFill>
+                  <a:srgbClr val="E0A437"/>
+                </a:solidFill>
+                <a:latin typeface="Fira Sans"/>
+              </a:rPr>
+              <a:t>▸ </a:t>
+            </a:r>
+            <a:r>
+              <a:rPr sz="1500" b="0">
+                <a:solidFill>
+                  <a:srgbClr val="000000"/>
+                </a:solidFill>
+                <a:latin typeface="Fira Sans"/>
+              </a:rPr>
+              <a:t>Los ingresos altos desplazan el promedio; la mayoría gana menos.</a:t>
+            </a:r>
+          </a:p>
+          <a:p>
+            <a:pPr>
+              <a:lnSpc>
+                <a:spcPct val="112000"/>
+              </a:lnSpc>
+              <a:spcAft>
+                <a:spcPts val="900"/>
+              </a:spcAft>
+            </a:pPr>
+            <a:r>
+              <a:rPr sz="1500" b="1">
+                <a:solidFill>
+                  <a:srgbClr val="E0A437"/>
+                </a:solidFill>
+                <a:latin typeface="Fira Sans"/>
+              </a:rPr>
+              <a:t>▸ </a:t>
+            </a:r>
+            <a:r>
+              <a:rPr sz="1500" b="1">
+                <a:solidFill>
                   <a:srgbClr val="1D3557"/>
                 </a:solidFill>
                 <a:latin typeface="Fira Sans"/>
               </a:rPr>
-              <a:t>Calculada desde los microdatos, con los factores de un día laboral.</a:t>
+              <a:t>El promedio describe una situación en la que la mayoría no está.</a:t>
             </a:r>
           </a:p>
         </p:txBody>
       </p:sp>
       <p:pic>
         <p:nvPicPr>
-          <p:cNvPr id="5" name="Picture 4" descr="03_reparto_modal.png"/>
+          <p:cNvPr id="5" name="Picture 4" descr="01_ingreso_media_mediana.png"/>
           <p:cNvPicPr>
             <a:picLocks noChangeAspect="1"/>
           </p:cNvPicPr>
@@ -6460,7 +6408,7 @@
         <p:spPr>
           <a:xfrm>
             <a:off x="4892040" y="1371600"/>
-            <a:ext cx="3840480" cy="1938578"/>
+            <a:ext cx="3840480" cy="2182719"/>
           </a:xfrm>
           <a:prstGeom prst="rect">
             <a:avLst/>
@@ -6558,14 +6506,149 @@
                 </a:solidFill>
                 <a:latin typeface="Fira Sans"/>
               </a:rPr>
-              <a:t>El reparto modal difiere entre comunas</a:t>
+              <a:t>La duración de los viajes: valores extremos</a:t>
+            </a:r>
+          </a:p>
+        </p:txBody>
+      </p:sp>
+      <p:sp>
+        <p:nvSpPr>
+          <p:cNvPr id="4" name="TextBox 3"/>
+          <p:cNvSpPr txBox="1"/>
+          <p:nvPr/>
+        </p:nvSpPr>
+        <p:spPr>
+          <a:xfrm>
+            <a:off x="502920" y="1252728"/>
+            <a:ext cx="4023360" cy="3200400"/>
+          </a:xfrm>
+          <a:prstGeom prst="rect">
+            <a:avLst/>
+          </a:prstGeom>
+          <a:noFill/>
+        </p:spPr>
+        <p:txBody>
+          <a:bodyPr wrap="square">
+            <a:spAutoFit/>
+          </a:bodyPr>
+          <a:lstStyle/>
+          <a:p>
+            <a:pPr>
+              <a:lnSpc>
+                <a:spcPct val="112000"/>
+              </a:lnSpc>
+              <a:spcAft>
+                <a:spcPts val="900"/>
+              </a:spcAft>
+            </a:pPr>
+            <a:r>
+              <a:rPr sz="1500" b="1">
+                <a:solidFill>
+                  <a:srgbClr val="E0A437"/>
+                </a:solidFill>
+                <a:latin typeface="Fira Sans"/>
+              </a:rPr>
+              <a:t>▸ </a:t>
+            </a:r>
+            <a:r>
+              <a:rPr sz="1500" b="0">
+                <a:solidFill>
+                  <a:srgbClr val="000000"/>
+                </a:solidFill>
+                <a:latin typeface="Fira Sans"/>
+              </a:rPr>
+              <a:t>Mediana: 30 minutos. Percentil 95: 98 minutos.</a:t>
+            </a:r>
+          </a:p>
+          <a:p>
+            <a:pPr>
+              <a:lnSpc>
+                <a:spcPct val="112000"/>
+              </a:lnSpc>
+              <a:spcAft>
+                <a:spcPts val="900"/>
+              </a:spcAft>
+            </a:pPr>
+            <a:r>
+              <a:rPr sz="1500" b="1">
+                <a:solidFill>
+                  <a:srgbClr val="E0A437"/>
+                </a:solidFill>
+                <a:latin typeface="Fira Sans"/>
+              </a:rPr>
+              <a:t>▸ </a:t>
+            </a:r>
+            <a:r>
+              <a:rPr sz="1500" b="0">
+                <a:solidFill>
+                  <a:srgbClr val="000000"/>
+                </a:solidFill>
+                <a:latin typeface="Fira Sans"/>
+              </a:rPr>
+              <a:t>Máximo registrado: 1.335 minutos, un viaje de 22 horas.</a:t>
+            </a:r>
+          </a:p>
+          <a:p>
+            <a:pPr>
+              <a:lnSpc>
+                <a:spcPct val="112000"/>
+              </a:lnSpc>
+              <a:spcAft>
+                <a:spcPts val="900"/>
+              </a:spcAft>
+            </a:pPr>
+            <a:r>
+              <a:rPr sz="1500" b="1">
+                <a:solidFill>
+                  <a:srgbClr val="E0A437"/>
+                </a:solidFill>
+                <a:latin typeface="Fira Sans"/>
+              </a:rPr>
+              <a:t>▸ </a:t>
+            </a:r>
+            <a:r>
+              <a:rPr sz="1500" b="0">
+                <a:solidFill>
+                  <a:srgbClr val="000000"/>
+                </a:solidFill>
+                <a:latin typeface="Fira Sans"/>
+              </a:rPr>
+              <a:t>¿Error de digitación? ¿Turno nocturno mal anotado?</a:t>
+            </a:r>
+          </a:p>
+          <a:p>
+            <a:pPr>
+              <a:lnSpc>
+                <a:spcPct val="112000"/>
+              </a:lnSpc>
+              <a:spcAft>
+                <a:spcPts val="900"/>
+              </a:spcAft>
+            </a:pPr>
+            <a:r>
+              <a:rPr sz="1500" b="1">
+                <a:solidFill>
+                  <a:srgbClr val="E0A437"/>
+                </a:solidFill>
+                <a:latin typeface="Fira Sans"/>
+              </a:rPr>
+              <a:t>▸ </a:t>
+            </a:r>
+            <a:r>
+              <a:rPr sz="1500" b="1">
+                <a:solidFill>
+                  <a:srgbClr val="1D3557"/>
+                </a:solidFill>
+                <a:latin typeface="Fira Sans"/>
+              </a:rPr>
+              <a:t>Los valores extremos se investigan y la decisión se declara.</a:t>
             </a:r>
           </a:p>
         </p:txBody>
       </p:sp>
       <p:pic>
         <p:nvPicPr>
-          <p:cNvPr id="4" name="Picture 3" descr="08_modo_por_comuna.png"/>
+          <p:cNvPr id="5" name="Picture 4" descr="04_duracion_viajes.png"/>
           <p:cNvPicPr>
             <a:picLocks noChangeAspect="1"/>
           </p:cNvPicPr>
@@ -6579,48 +6662,14 @@
         </p:blipFill>
         <p:spPr>
           <a:xfrm>
-            <a:off x="1994250" y="1143000"/>
-            <a:ext cx="5155498" cy="3154679"/>
+            <a:off x="4892040" y="1371600"/>
+            <a:ext cx="3840480" cy="2146492"/>
           </a:xfrm>
           <a:prstGeom prst="rect">
             <a:avLst/>
           </a:prstGeom>
         </p:spPr>
       </p:pic>
-      <p:sp>
-        <p:nvSpPr>
-          <p:cNvPr id="5" name="TextBox 4"/>
-          <p:cNvSpPr txBox="1"/>
-          <p:nvPr/>
-        </p:nvSpPr>
-        <p:spPr>
-          <a:xfrm>
-            <a:off x="704088" y="4434840"/>
-            <a:ext cx="7744968" cy="457200"/>
-          </a:xfrm>
-          <a:prstGeom prst="rect">
-            <a:avLst/>
-          </a:prstGeom>
-          <a:noFill/>
-        </p:spPr>
-        <p:txBody>
-          <a:bodyPr wrap="square">
-            <a:spAutoFit/>
-          </a:bodyPr>
-          <a:lstStyle/>
-          <a:p>
-            <a:r>
-              <a:rPr sz="1300" b="0">
-                <a:solidFill>
-                  <a:srgbClr val="333333"/>
-                </a:solidFill>
-                <a:latin typeface="Fira Sans"/>
-              </a:rPr>
-              <a:t>Normalizar por comuna permite comparar proporciones entre comunas de tamaños muy distintos.</a:t>
-            </a:r>
-          </a:p>
-        </p:txBody>
-      </p:sp>
     </p:spTree>
   </p:cSld>
   <p:clrMapOvr>
@@ -6712,7 +6761,7 @@
                 </a:solidFill>
                 <a:latin typeface="Fira Sans"/>
               </a:rPr>
-              <a:t>Ingreso y uso de transporte público</a:t>
+              <a:t>La partición modal del Gran Santiago</a:t>
             </a:r>
           </a:p>
         </p:txBody>
@@ -6763,7 +6812,7 @@
                 </a:solidFill>
                 <a:latin typeface="Fira Sans"/>
               </a:rPr>
-              <a:t>Cada punto es una comuna: ingreso medio contra proporción de viajes en transporte público.</a:t>
+              <a:t>Dos merges y un groupby ponderado por factor.</a:t>
             </a:r>
           </a:p>
           <a:p>
@@ -6791,7 +6840,7 @@
                 </a:solidFill>
                 <a:latin typeface="Fira Sans"/>
               </a:rPr>
-              <a:t>Periferia (Buin, Melipilla): poco transporte público; la red no llega.</a:t>
+              <a:t>Caminata: 34% de los viajes.</a:t>
             </a:r>
           </a:p>
           <a:p>
@@ -6819,7 +6868,7 @@
                 </a:solidFill>
                 <a:latin typeface="Fira Sans"/>
               </a:rPr>
-              <a:t>Ingresos altos (Vitacura, Lo Barnechea): conectadas, con poco uso.</a:t>
+              <a:t>Transporte público (Bip!): 24%.</a:t>
             </a:r>
           </a:p>
           <a:p>
@@ -6847,7 +6896,7 @@
                 </a:solidFill>
                 <a:latin typeface="Fira Sans"/>
               </a:rPr>
-              <a:t>Correlación de Pearson: -0,17. La asociación lineal es débil.</a:t>
+              <a:t>Auto: 23%.</a:t>
             </a:r>
           </a:p>
           <a:p>
@@ -6875,14 +6924,14 @@
                 </a:solidFill>
                 <a:latin typeface="Fira Sans"/>
               </a:rPr>
-              <a:t>Como vimos en el marco conceptual: el coeficiente no reemplaza al gráfico, y la asociación no autoriza verbos causales.</a:t>
+              <a:t>Calculada desde los microdatos, con los factores de un día laboral.</a:t>
             </a:r>
           </a:p>
         </p:txBody>
       </p:sp>
       <p:pic>
         <p:nvPicPr>
-          <p:cNvPr id="5" name="Picture 4" descr="09_ingreso_vs_tp.png"/>
+          <p:cNvPr id="5" name="Picture 4" descr="03_reparto_modal.png"/>
           <p:cNvPicPr>
             <a:picLocks noChangeAspect="1"/>
           </p:cNvPicPr>
@@ -6897,7 +6946,7 @@
         <p:spPr>
           <a:xfrm>
             <a:off x="4892040" y="1371600"/>
-            <a:ext cx="3840480" cy="2526979"/>
+            <a:ext cx="3840480" cy="1938578"/>
           </a:xfrm>
           <a:prstGeom prst="rect">
             <a:avLst/>
@@ -6995,14 +7044,14 @@
                 </a:solidFill>
                 <a:latin typeface="Fira Sans"/>
               </a:rPr>
-              <a:t>Los propósitos de viaje según el día de la semana</a:t>
+              <a:t>El reparto modal difiere entre comunas</a:t>
             </a:r>
           </a:p>
         </p:txBody>
       </p:sp>
       <p:pic>
         <p:nvPicPr>
-          <p:cNvPr id="4" name="Picture 3" descr="10_heatmap_rutinas.png"/>
+          <p:cNvPr id="4" name="Picture 3" descr="08_modo_por_comuna.png"/>
           <p:cNvPicPr>
             <a:picLocks noChangeAspect="1"/>
           </p:cNvPicPr>
@@ -7016,8 +7065,8 @@
         </p:blipFill>
         <p:spPr>
           <a:xfrm>
-            <a:off x="1563778" y="1143000"/>
-            <a:ext cx="6016443" cy="3154680"/>
+            <a:off x="1994250" y="1143000"/>
+            <a:ext cx="5155498" cy="3154679"/>
           </a:xfrm>
           <a:prstGeom prst="rect">
             <a:avLst/>
@@ -7053,7 +7102,7 @@
                 </a:solidFill>
                 <a:latin typeface="Fira Sans"/>
               </a:rPr>
-              <a:t>El heatmap muestra 14 propósitos por 7 días en una sola figura: útil para tablas completas.</a:t>
+              <a:t>Normalizar por comuna permite comparar proporciones entre comunas de tamaños muy distintos.</a:t>
             </a:r>
           </a:p>
         </p:txBody>
@@ -7149,7 +7198,7 @@
                 </a:solidFill>
                 <a:latin typeface="Fira Sans"/>
               </a:rPr>
-              <a:t>Síntesis</a:t>
+              <a:t>Ingreso y uso de transporte público</a:t>
             </a:r>
           </a:p>
         </p:txBody>
@@ -7162,8 +7211,8 @@
         </p:nvSpPr>
         <p:spPr>
           <a:xfrm>
-            <a:off x="704088" y="1353312"/>
-            <a:ext cx="7744968" cy="3300984"/>
+            <a:off x="502920" y="1252728"/>
+            <a:ext cx="4023360" cy="3200400"/>
           </a:xfrm>
           <a:prstGeom prst="rect">
             <a:avLst/>
@@ -7185,7 +7234,7 @@
               </a:spcAft>
             </a:pPr>
             <a:r>
-              <a:rPr sz="1800" b="1">
+              <a:rPr sz="1500" b="1">
                 <a:solidFill>
                   <a:srgbClr val="E0A437"/>
                 </a:solidFill>
@@ -7194,13 +7243,97 @@
               <a:t>▸ </a:t>
             </a:r>
             <a:r>
-              <a:rPr sz="1800" b="0">
+              <a:rPr sz="1500" b="0">
                 <a:solidFill>
                   <a:srgbClr val="000000"/>
                 </a:solidFill>
                 <a:latin typeface="Fira Sans"/>
               </a:rPr>
-              <a:t>Un modelo es una simplificación con decisiones incorporadas; estimarlo puede buscar inferencia o predicción.</a:t>
+              <a:t>Cada punto es una comuna: ingreso medio contra proporción de viajes en transporte público.</a:t>
+            </a:r>
+          </a:p>
+          <a:p>
+            <a:pPr>
+              <a:lnSpc>
+                <a:spcPct val="112000"/>
+              </a:lnSpc>
+              <a:spcAft>
+                <a:spcPts val="500"/>
+              </a:spcAft>
+            </a:pPr>
+            <a:r>
+              <a:rPr sz="1300" b="0">
+                <a:solidFill>
+                  <a:srgbClr val="333333"/>
+                </a:solidFill>
+                <a:latin typeface="Fira Sans"/>
+              </a:rPr>
+              <a:t>     ◦  </a:t>
+            </a:r>
+            <a:r>
+              <a:rPr sz="1300" b="0">
+                <a:solidFill>
+                  <a:srgbClr val="333333"/>
+                </a:solidFill>
+                <a:latin typeface="Fira Sans"/>
+              </a:rPr>
+              <a:t>Periferia (Buin, Melipilla): poco transporte público; la red no llega.</a:t>
+            </a:r>
+          </a:p>
+          <a:p>
+            <a:pPr>
+              <a:lnSpc>
+                <a:spcPct val="112000"/>
+              </a:lnSpc>
+              <a:spcAft>
+                <a:spcPts val="500"/>
+              </a:spcAft>
+            </a:pPr>
+            <a:r>
+              <a:rPr sz="1300" b="0">
+                <a:solidFill>
+                  <a:srgbClr val="333333"/>
+                </a:solidFill>
+                <a:latin typeface="Fira Sans"/>
+              </a:rPr>
+              <a:t>     ◦  </a:t>
+            </a:r>
+            <a:r>
+              <a:rPr sz="1300" b="0">
+                <a:solidFill>
+                  <a:srgbClr val="333333"/>
+                </a:solidFill>
+                <a:latin typeface="Fira Sans"/>
+              </a:rPr>
+              <a:t>Ingresos altos (Vitacura, Lo Barnechea): conectadas, con poco uso.</a:t>
+            </a:r>
+          </a:p>
+          <a:p>
+            <a:pPr>
+              <a:lnSpc>
+                <a:spcPct val="112000"/>
+              </a:lnSpc>
+              <a:spcAft>
+                <a:spcPts val="500"/>
+              </a:spcAft>
+            </a:pPr>
+            <a:r>
+              <a:rPr sz="1300" b="0">
+                <a:solidFill>
+                  <a:srgbClr val="333333"/>
+                </a:solidFill>
+                <a:latin typeface="Fira Sans"/>
+              </a:rPr>
+              <a:t>     ◦  </a:t>
+            </a:r>
+            <a:r>
+              <a:rPr sz="1300" b="0">
+                <a:solidFill>
+                  <a:srgbClr val="333333"/>
+                </a:solidFill>
+                <a:latin typeface="Fira Sans"/>
+              </a:rPr>
+              <a:t>Correlación de Pearson: -0,17. La asociación lineal es débil.</a:t>
             </a:r>
           </a:p>
           <a:p>
@@ -7213,7 +7346,7 @@
               </a:spcAft>
             </a:pPr>
             <a:r>
-              <a:rPr sz="1800" b="1">
+              <a:rPr sz="1500" b="1">
                 <a:solidFill>
                   <a:srgbClr val="E0A437"/>
                 </a:solidFill>
@@ -7222,101 +7355,41 @@
               <a:t>▸ </a:t>
             </a:r>
             <a:r>
-              <a:rPr sz="1800" b="0">
-                <a:solidFill>
-                  <a:srgbClr val="000000"/>
-                </a:solidFill>
-                <a:latin typeface="Fira Sans"/>
-              </a:rPr>
-              <a:t>Las asociaciones se reportan como asociaciones: la causalidad exige más que datos observacionales.</a:t>
-            </a:r>
-          </a:p>
-          <a:p>
-            <a:pPr>
-              <a:lnSpc>
-                <a:spcPct val="112000"/>
-              </a:lnSpc>
-              <a:spcAft>
-                <a:spcPts val="900"/>
-              </a:spcAft>
-            </a:pPr>
-            <a:r>
-              <a:rPr sz="1800" b="1">
-                <a:solidFill>
-                  <a:srgbClr val="E0A437"/>
-                </a:solidFill>
-                <a:latin typeface="Fira Sans"/>
-              </a:rPr>
-              <a:t>▸ </a:t>
-            </a:r>
-            <a:r>
-              <a:rPr sz="1800" b="0">
-                <a:solidFill>
-                  <a:srgbClr val="000000"/>
-                </a:solidFill>
-                <a:latin typeface="Fira Sans"/>
-              </a:rPr>
-              <a:t>El tipo de la variable, no su dtype, determina qué resúmenes tienen sentido.</a:t>
-            </a:r>
-          </a:p>
-          <a:p>
-            <a:pPr>
-              <a:lnSpc>
-                <a:spcPct val="112000"/>
-              </a:lnSpc>
-              <a:spcAft>
-                <a:spcPts val="900"/>
-              </a:spcAft>
-            </a:pPr>
-            <a:r>
-              <a:rPr sz="1800" b="1">
-                <a:solidFill>
-                  <a:srgbClr val="E0A437"/>
-                </a:solidFill>
-                <a:latin typeface="Fira Sans"/>
-              </a:rPr>
-              <a:t>▸ </a:t>
-            </a:r>
-            <a:r>
-              <a:rPr sz="1800" b="0">
-                <a:solidFill>
-                  <a:srgbClr val="000000"/>
-                </a:solidFill>
-                <a:latin typeface="Fira Sans"/>
-              </a:rPr>
-              <a:t>Con distribuciones asimétricas, la mediana y los percentiles describen mejor lo típico que la media.</a:t>
-            </a:r>
-          </a:p>
-          <a:p>
-            <a:pPr>
-              <a:lnSpc>
-                <a:spcPct val="112000"/>
-              </a:lnSpc>
-              <a:spcAft>
-                <a:spcPts val="900"/>
-              </a:spcAft>
-            </a:pPr>
-            <a:r>
-              <a:rPr sz="1800" b="1">
-                <a:solidFill>
-                  <a:srgbClr val="E0A437"/>
-                </a:solidFill>
-                <a:latin typeface="Fira Sans"/>
-              </a:rPr>
-              <a:t>▸ </a:t>
-            </a:r>
-            <a:r>
-              <a:rPr sz="1800" b="1">
+              <a:rPr sz="1500" b="1">
                 <a:solidFill>
                   <a:srgbClr val="1D3557"/>
                 </a:solidFill>
                 <a:latin typeface="Fira Sans"/>
               </a:rPr>
-              <a:t>Ante toda cifra resumen: ¿de quién habla este número? ¿Muestra, subgrupo o ciudad?</a:t>
-            </a:r>
-          </a:p>
-        </p:txBody>
-      </p:sp>
+              <a:t>Como vimos en el marco conceptual: el coeficiente no reemplaza al gráfico, y la asociación no autoriza verbos causales.</a:t>
+            </a:r>
+          </a:p>
+        </p:txBody>
+      </p:sp>
+      <p:pic>
+        <p:nvPicPr>
+          <p:cNvPr id="5" name="Picture 4" descr="09_ingreso_vs_tp.png"/>
+          <p:cNvPicPr>
+            <a:picLocks noChangeAspect="1"/>
+          </p:cNvPicPr>
+          <p:nvPr/>
+        </p:nvPicPr>
+        <p:blipFill>
+          <a:blip r:embed="rId2"/>
+          <a:stretch>
+            <a:fillRect/>
+          </a:stretch>
+        </p:blipFill>
+        <p:spPr>
+          <a:xfrm>
+            <a:off x="4892040" y="1371600"/>
+            <a:ext cx="3840480" cy="2526979"/>
+          </a:xfrm>
+          <a:prstGeom prst="rect">
+            <a:avLst/>
+          </a:prstGeom>
+        </p:spPr>
+      </p:pic>
     </p:spTree>
   </p:cSld>
   <p:clrMapOvr>
@@ -7408,21 +7481,45 @@
                 </a:solidFill>
                 <a:latin typeface="Fira Sans"/>
               </a:rPr>
-              <a:t>Segundo bloque: comienza la Tarea 1</a:t>
-            </a:r>
-          </a:p>
-        </p:txBody>
-      </p:sp>
-      <p:sp>
-        <p:nvSpPr>
-          <p:cNvPr id="4" name="TextBox 3"/>
+              <a:t>Los propósitos de viaje según el día de la semana</a:t>
+            </a:r>
+          </a:p>
+        </p:txBody>
+      </p:sp>
+      <p:pic>
+        <p:nvPicPr>
+          <p:cNvPr id="4" name="Picture 3" descr="10_heatmap_rutinas.png"/>
+          <p:cNvPicPr>
+            <a:picLocks noChangeAspect="1"/>
+          </p:cNvPicPr>
+          <p:nvPr/>
+        </p:nvPicPr>
+        <p:blipFill>
+          <a:blip r:embed="rId2"/>
+          <a:stretch>
+            <a:fillRect/>
+          </a:stretch>
+        </p:blipFill>
+        <p:spPr>
+          <a:xfrm>
+            <a:off x="1563778" y="1143000"/>
+            <a:ext cx="6016443" cy="3154680"/>
+          </a:xfrm>
+          <a:prstGeom prst="rect">
+            <a:avLst/>
+          </a:prstGeom>
+        </p:spPr>
+      </p:pic>
+      <p:sp>
+        <p:nvSpPr>
+          <p:cNvPr id="5" name="TextBox 4"/>
           <p:cNvSpPr txBox="1"/>
           <p:nvPr/>
         </p:nvSpPr>
         <p:spPr>
           <a:xfrm>
-            <a:off x="704088" y="1353312"/>
-            <a:ext cx="7744968" cy="3300984"/>
+            <a:off x="704088" y="4434840"/>
+            <a:ext cx="7744968" cy="457200"/>
           </a:xfrm>
           <a:prstGeom prst="rect">
             <a:avLst/>
@@ -7435,171 +7532,168 @@
           </a:bodyPr>
           <a:lstStyle/>
           <a:p>
-            <a:pPr>
-              <a:lnSpc>
-                <a:spcPct val="112000"/>
-              </a:lnSpc>
-              <a:spcAft>
-                <a:spcPts val="900"/>
-              </a:spcAft>
-            </a:pPr>
-            <a:r>
-              <a:rPr sz="1800" b="1">
-                <a:solidFill>
-                  <a:srgbClr val="E0A437"/>
-                </a:solidFill>
-                <a:latin typeface="Fira Sans"/>
-              </a:rPr>
-              <a:t>▸ </a:t>
-            </a:r>
-            <a:r>
-              <a:rPr sz="1800" b="0">
-                <a:solidFill>
-                  <a:srgbClr val="000000"/>
-                </a:solidFill>
-                <a:latin typeface="Fira Sans"/>
-              </a:rPr>
-              <a:t>El retrato de tu comuna: cada pareja adopta una comuna del Gran Santiago.</a:t>
-            </a:r>
-          </a:p>
-          <a:p>
-            <a:pPr>
-              <a:lnSpc>
-                <a:spcPct val="112000"/>
-              </a:lnSpc>
-              <a:spcAft>
-                <a:spcPts val="500"/>
-              </a:spcAft>
-            </a:pPr>
-            <a:r>
-              <a:rPr sz="1400" b="0">
+            <a:r>
+              <a:rPr sz="1300" b="0">
                 <a:solidFill>
                   <a:srgbClr val="333333"/>
                 </a:solidFill>
                 <a:latin typeface="Fira Sans"/>
               </a:rPr>
-              <a:t>     ◦  </a:t>
-            </a:r>
-            <a:r>
-              <a:rPr sz="1400" b="0">
+              <a:t>El heatmap muestra 14 propósitos por 7 días en una sola figura: útil para tablas completas.</a:t>
+            </a:r>
+          </a:p>
+        </p:txBody>
+      </p:sp>
+    </p:spTree>
+  </p:cSld>
+  <p:clrMapOvr>
+    <a:masterClrMapping/>
+  </p:clrMapOvr>
+</p:sld>
+</file>
+
+<file path=ppt/slides/slide29.xml><?xml version="1.0" encoding="utf-8"?>
+<p:sld xmlns:a="http://schemas.openxmlformats.org/drawingml/2006/main" xmlns:p="http://schemas.openxmlformats.org/presentationml/2006/main" xmlns:r="http://schemas.openxmlformats.org/officeDocument/2006/relationships">
+  <p:cSld>
+    <p:spTree>
+      <p:nvGrpSpPr>
+        <p:cNvPr id="1" name=""/>
+        <p:cNvGrpSpPr/>
+        <p:nvPr/>
+      </p:nvGrpSpPr>
+      <p:grpSpPr/>
+      <p:sp>
+        <p:nvSpPr>
+          <p:cNvPr id="2" name="Rectangle 1"/>
+          <p:cNvSpPr/>
+          <p:nvPr/>
+        </p:nvSpPr>
+        <p:spPr>
+          <a:xfrm>
+            <a:off x="0" y="0"/>
+            <a:ext cx="9144000" cy="5138928"/>
+          </a:xfrm>
+          <a:prstGeom prst="rect">
+            <a:avLst/>
+          </a:prstGeom>
+          <a:solidFill>
+            <a:srgbClr val="FAFBFC"/>
+          </a:solidFill>
+          <a:ln>
+            <a:noFill/>
+          </a:ln>
+          <a:effectLst/>
+        </p:spPr>
+        <p:style>
+          <a:lnRef idx="1">
+            <a:schemeClr val="accent1"/>
+          </a:lnRef>
+          <a:fillRef idx="3">
+            <a:schemeClr val="accent1"/>
+          </a:fillRef>
+          <a:effectRef idx="2">
+            <a:schemeClr val="accent1"/>
+          </a:effectRef>
+          <a:fontRef idx="minor">
+            <a:schemeClr val="lt1"/>
+          </a:fontRef>
+        </p:style>
+        <p:txBody>
+          <a:bodyPr rtlCol="0" anchor="ctr"/>
+          <a:lstStyle/>
+          <a:p>
+            <a:pPr algn="ctr"/>
+          </a:p>
+        </p:txBody>
+      </p:sp>
+      <p:sp>
+        <p:nvSpPr>
+          <p:cNvPr id="3" name="TextBox 2"/>
+          <p:cNvSpPr txBox="1"/>
+          <p:nvPr/>
+        </p:nvSpPr>
+        <p:spPr>
+          <a:xfrm>
+            <a:off x="402336" y="301752"/>
+            <a:ext cx="8348472" cy="795528"/>
+          </a:xfrm>
+          <a:prstGeom prst="rect">
+            <a:avLst/>
+          </a:prstGeom>
+          <a:noFill/>
+        </p:spPr>
+        <p:txBody>
+          <a:bodyPr wrap="square">
+            <a:spAutoFit/>
+          </a:bodyPr>
+          <a:lstStyle/>
+          <a:p>
+            <a:r>
+              <a:rPr sz="2800" b="1">
+                <a:solidFill>
+                  <a:srgbClr val="0F0F0F"/>
+                </a:solidFill>
+                <a:latin typeface="Fira Sans"/>
+              </a:rPr>
+              <a:t>Cuando los datos crecen</a:t>
+            </a:r>
+          </a:p>
+        </p:txBody>
+      </p:sp>
+      <p:pic>
+        <p:nvPicPr>
+          <p:cNvPr id="4" name="Picture 3" descr="14_escala_datos.png"/>
+          <p:cNvPicPr>
+            <a:picLocks noChangeAspect="1"/>
+          </p:cNvPicPr>
+          <p:nvPr/>
+        </p:nvPicPr>
+        <p:blipFill>
+          <a:blip r:embed="rId2"/>
+          <a:stretch>
+            <a:fillRect/>
+          </a:stretch>
+        </p:blipFill>
+        <p:spPr>
+          <a:xfrm>
+            <a:off x="1417319" y="1143000"/>
+            <a:ext cx="6309360" cy="2324913"/>
+          </a:xfrm>
+          <a:prstGeom prst="rect">
+            <a:avLst/>
+          </a:prstGeom>
+        </p:spPr>
+      </p:pic>
+      <p:sp>
+        <p:nvSpPr>
+          <p:cNvPr id="5" name="TextBox 4"/>
+          <p:cNvSpPr txBox="1"/>
+          <p:nvPr/>
+        </p:nvSpPr>
+        <p:spPr>
+          <a:xfrm>
+            <a:off x="704088" y="4434840"/>
+            <a:ext cx="7744968" cy="457200"/>
+          </a:xfrm>
+          <a:prstGeom prst="rect">
+            <a:avLst/>
+          </a:prstGeom>
+          <a:noFill/>
+        </p:spPr>
+        <p:txBody>
+          <a:bodyPr wrap="square">
+            <a:spAutoFit/>
+          </a:bodyPr>
+          <a:lstStyle/>
+          <a:p>
+            <a:r>
+              <a:rPr sz="1300" b="0">
                 <a:solidFill>
                   <a:srgbClr val="333333"/>
                 </a:solidFill>
                 <a:latin typeface="Fira Sans"/>
               </a:rPr>
-              <a:t>Hoy: elegir la comuna y construir su retrato numérico.</a:t>
-            </a:r>
-          </a:p>
-          <a:p>
-            <a:pPr>
-              <a:lnSpc>
-                <a:spcPct val="112000"/>
-              </a:lnSpc>
-              <a:spcAft>
-                <a:spcPts val="500"/>
-              </a:spcAft>
-            </a:pPr>
-            <a:r>
-              <a:rPr sz="1400" b="0">
-                <a:solidFill>
-                  <a:srgbClr val="333333"/>
-                </a:solidFill>
-                <a:latin typeface="Fira Sans"/>
-              </a:rPr>
-              <a:t>     ◦  </a:t>
-            </a:r>
-            <a:r>
-              <a:rPr sz="1400" b="0">
-                <a:solidFill>
-                  <a:srgbClr val="333333"/>
-                </a:solidFill>
-                <a:latin typeface="Fira Sans"/>
-              </a:rPr>
-              <a:t>Próxima clase: el retrato gráfico, con métodos de visualización.</a:t>
-            </a:r>
-          </a:p>
-          <a:p>
-            <a:pPr>
-              <a:lnSpc>
-                <a:spcPct val="112000"/>
-              </a:lnSpc>
-              <a:spcAft>
-                <a:spcPts val="500"/>
-              </a:spcAft>
-            </a:pPr>
-            <a:r>
-              <a:rPr sz="1400" b="0">
-                <a:solidFill>
-                  <a:srgbClr val="333333"/>
-                </a:solidFill>
-                <a:latin typeface="Fira Sans"/>
-              </a:rPr>
-              <a:t>     ◦  </a:t>
-            </a:r>
-            <a:r>
-              <a:rPr sz="1400" b="0">
-                <a:solidFill>
-                  <a:srgbClr val="333333"/>
-                </a:solidFill>
-                <a:latin typeface="Fira Sans"/>
-              </a:rPr>
-              <a:t>Entrega del retrato completo: jueves 10 de septiembre, por Aula.</a:t>
-            </a:r>
-          </a:p>
-          <a:p>
-            <a:pPr>
-              <a:lnSpc>
-                <a:spcPct val="112000"/>
-              </a:lnSpc>
-              <a:spcAft>
-                <a:spcPts val="900"/>
-              </a:spcAft>
-            </a:pPr>
-            <a:r>
-              <a:rPr sz="1800" b="1">
-                <a:solidFill>
-                  <a:srgbClr val="E0A437"/>
-                </a:solidFill>
-                <a:latin typeface="Fira Sans"/>
-              </a:rPr>
-              <a:t>▸ </a:t>
-            </a:r>
-            <a:r>
-              <a:rPr sz="1800" b="0">
-                <a:solidFill>
-                  <a:srgbClr val="000000"/>
-                </a:solidFill>
-                <a:latin typeface="Fira Sans"/>
-              </a:rPr>
-              <a:t>El enunciado está en evaluaciones/tareas/ y la guía de hoy en actividades/.</a:t>
-            </a:r>
-          </a:p>
-          <a:p>
-            <a:pPr>
-              <a:lnSpc>
-                <a:spcPct val="112000"/>
-              </a:lnSpc>
-              <a:spcAft>
-                <a:spcPts val="900"/>
-              </a:spcAft>
-            </a:pPr>
-            <a:r>
-              <a:rPr sz="1800" b="1">
-                <a:solidFill>
-                  <a:srgbClr val="E0A437"/>
-                </a:solidFill>
-                <a:latin typeface="Fira Sans"/>
-              </a:rPr>
-              <a:t>▸ </a:t>
-            </a:r>
-            <a:r>
-              <a:rPr sz="1800" b="1">
-                <a:solidFill>
-                  <a:srgbClr val="1D3557"/>
-                </a:solidFill>
-                <a:latin typeface="Fira Sans"/>
-              </a:rPr>
-              <a:t>Lo que avancen en este bloque ya es parte de la tarea.</a:t>
+              <a:t>PySpark se usa con SQL o con sus propios DataFrames; Dask reparte operaciones estilo Pandas; Polars y DuckDB rinden en una sola máquina.</a:t>
             </a:r>
           </a:p>
         </p:txBody>
@@ -7719,7 +7813,7 @@
 </p:sld>
 </file>
 
-<file path=ppt/slides/slide4.xml><?xml version="1.0" encoding="utf-8"?>
+<file path=ppt/slides/slide30.xml><?xml version="1.0" encoding="utf-8"?>
 <p:sld xmlns:a="http://schemas.openxmlformats.org/drawingml/2006/main" xmlns:p="http://schemas.openxmlformats.org/presentationml/2006/main" xmlns:r="http://schemas.openxmlformats.org/officeDocument/2006/relationships">
   <p:cSld>
     <p:spTree>
@@ -7802,7 +7896,7 @@
                 </a:solidFill>
                 <a:latin typeface="Fira Sans"/>
               </a:rPr>
-              <a:t>¿Qué es un modelo?</a:t>
+              <a:t>Síntesis</a:t>
             </a:r>
           </a:p>
         </p:txBody>
@@ -7853,7 +7947,812 @@
                 </a:solidFill>
                 <a:latin typeface="Fira Sans"/>
               </a:rPr>
-              <a:t>Una representación simplificada del proceso que genera los datos.</a:t>
+              <a:t>Un modelo es una simplificación con decisiones incorporadas; estimarlo puede buscar inferencia o predicción.</a:t>
+            </a:r>
+          </a:p>
+          <a:p>
+            <a:pPr>
+              <a:lnSpc>
+                <a:spcPct val="112000"/>
+              </a:lnSpc>
+              <a:spcAft>
+                <a:spcPts val="900"/>
+              </a:spcAft>
+            </a:pPr>
+            <a:r>
+              <a:rPr sz="1800" b="1">
+                <a:solidFill>
+                  <a:srgbClr val="E0A437"/>
+                </a:solidFill>
+                <a:latin typeface="Fira Sans"/>
+              </a:rPr>
+              <a:t>▸ </a:t>
+            </a:r>
+            <a:r>
+              <a:rPr sz="1800" b="0">
+                <a:solidFill>
+                  <a:srgbClr val="000000"/>
+                </a:solidFill>
+                <a:latin typeface="Fira Sans"/>
+              </a:rPr>
+              <a:t>Las asociaciones se reportan como asociaciones: la causalidad exige más que datos observacionales.</a:t>
+            </a:r>
+          </a:p>
+          <a:p>
+            <a:pPr>
+              <a:lnSpc>
+                <a:spcPct val="112000"/>
+              </a:lnSpc>
+              <a:spcAft>
+                <a:spcPts val="900"/>
+              </a:spcAft>
+            </a:pPr>
+            <a:r>
+              <a:rPr sz="1800" b="1">
+                <a:solidFill>
+                  <a:srgbClr val="E0A437"/>
+                </a:solidFill>
+                <a:latin typeface="Fira Sans"/>
+              </a:rPr>
+              <a:t>▸ </a:t>
+            </a:r>
+            <a:r>
+              <a:rPr sz="1800" b="0">
+                <a:solidFill>
+                  <a:srgbClr val="000000"/>
+                </a:solidFill>
+                <a:latin typeface="Fira Sans"/>
+              </a:rPr>
+              <a:t>El tipo de la variable, no su dtype, determina qué resúmenes tienen sentido.</a:t>
+            </a:r>
+          </a:p>
+          <a:p>
+            <a:pPr>
+              <a:lnSpc>
+                <a:spcPct val="112000"/>
+              </a:lnSpc>
+              <a:spcAft>
+                <a:spcPts val="900"/>
+              </a:spcAft>
+            </a:pPr>
+            <a:r>
+              <a:rPr sz="1800" b="1">
+                <a:solidFill>
+                  <a:srgbClr val="E0A437"/>
+                </a:solidFill>
+                <a:latin typeface="Fira Sans"/>
+              </a:rPr>
+              <a:t>▸ </a:t>
+            </a:r>
+            <a:r>
+              <a:rPr sz="1800" b="0">
+                <a:solidFill>
+                  <a:srgbClr val="000000"/>
+                </a:solidFill>
+                <a:latin typeface="Fira Sans"/>
+              </a:rPr>
+              <a:t>Con distribuciones asimétricas, la mediana y los percentiles describen mejor lo típico que la media.</a:t>
+            </a:r>
+          </a:p>
+          <a:p>
+            <a:pPr>
+              <a:lnSpc>
+                <a:spcPct val="112000"/>
+              </a:lnSpc>
+              <a:spcAft>
+                <a:spcPts val="900"/>
+              </a:spcAft>
+            </a:pPr>
+            <a:r>
+              <a:rPr sz="1800" b="1">
+                <a:solidFill>
+                  <a:srgbClr val="E0A437"/>
+                </a:solidFill>
+                <a:latin typeface="Fira Sans"/>
+              </a:rPr>
+              <a:t>▸ </a:t>
+            </a:r>
+            <a:r>
+              <a:rPr sz="1800" b="1">
+                <a:solidFill>
+                  <a:srgbClr val="1D3557"/>
+                </a:solidFill>
+                <a:latin typeface="Fira Sans"/>
+              </a:rPr>
+              <a:t>Ante toda cifra resumen: ¿de quién habla este número? ¿Muestra, subgrupo o ciudad?</a:t>
+            </a:r>
+          </a:p>
+        </p:txBody>
+      </p:sp>
+    </p:spTree>
+  </p:cSld>
+  <p:clrMapOvr>
+    <a:masterClrMapping/>
+  </p:clrMapOvr>
+</p:sld>
+</file>
+
+<file path=ppt/slides/slide31.xml><?xml version="1.0" encoding="utf-8"?>
+<p:sld xmlns:a="http://schemas.openxmlformats.org/drawingml/2006/main" xmlns:p="http://schemas.openxmlformats.org/presentationml/2006/main" xmlns:r="http://schemas.openxmlformats.org/officeDocument/2006/relationships">
+  <p:cSld>
+    <p:spTree>
+      <p:nvGrpSpPr>
+        <p:cNvPr id="1" name=""/>
+        <p:cNvGrpSpPr/>
+        <p:nvPr/>
+      </p:nvGrpSpPr>
+      <p:grpSpPr/>
+      <p:sp>
+        <p:nvSpPr>
+          <p:cNvPr id="2" name="Rectangle 1"/>
+          <p:cNvSpPr/>
+          <p:nvPr/>
+        </p:nvSpPr>
+        <p:spPr>
+          <a:xfrm>
+            <a:off x="0" y="0"/>
+            <a:ext cx="9144000" cy="5138928"/>
+          </a:xfrm>
+          <a:prstGeom prst="rect">
+            <a:avLst/>
+          </a:prstGeom>
+          <a:solidFill>
+            <a:srgbClr val="FAFBFC"/>
+          </a:solidFill>
+          <a:ln>
+            <a:noFill/>
+          </a:ln>
+          <a:effectLst/>
+        </p:spPr>
+        <p:style>
+          <a:lnRef idx="1">
+            <a:schemeClr val="accent1"/>
+          </a:lnRef>
+          <a:fillRef idx="3">
+            <a:schemeClr val="accent1"/>
+          </a:fillRef>
+          <a:effectRef idx="2">
+            <a:schemeClr val="accent1"/>
+          </a:effectRef>
+          <a:fontRef idx="minor">
+            <a:schemeClr val="lt1"/>
+          </a:fontRef>
+        </p:style>
+        <p:txBody>
+          <a:bodyPr rtlCol="0" anchor="ctr"/>
+          <a:lstStyle/>
+          <a:p>
+            <a:pPr algn="ctr"/>
+          </a:p>
+        </p:txBody>
+      </p:sp>
+      <p:sp>
+        <p:nvSpPr>
+          <p:cNvPr id="3" name="TextBox 2"/>
+          <p:cNvSpPr txBox="1"/>
+          <p:nvPr/>
+        </p:nvSpPr>
+        <p:spPr>
+          <a:xfrm>
+            <a:off x="402336" y="301752"/>
+            <a:ext cx="8348472" cy="795528"/>
+          </a:xfrm>
+          <a:prstGeom prst="rect">
+            <a:avLst/>
+          </a:prstGeom>
+          <a:noFill/>
+        </p:spPr>
+        <p:txBody>
+          <a:bodyPr wrap="square">
+            <a:spAutoFit/>
+          </a:bodyPr>
+          <a:lstStyle/>
+          <a:p>
+            <a:r>
+              <a:rPr sz="2800" b="1">
+                <a:solidFill>
+                  <a:srgbClr val="0F0F0F"/>
+                </a:solidFill>
+                <a:latin typeface="Fira Sans"/>
+              </a:rPr>
+              <a:t>Segundo bloque: comienza la Tarea 1</a:t>
+            </a:r>
+          </a:p>
+        </p:txBody>
+      </p:sp>
+      <p:sp>
+        <p:nvSpPr>
+          <p:cNvPr id="4" name="TextBox 3"/>
+          <p:cNvSpPr txBox="1"/>
+          <p:nvPr/>
+        </p:nvSpPr>
+        <p:spPr>
+          <a:xfrm>
+            <a:off x="704088" y="1353312"/>
+            <a:ext cx="7744968" cy="3300984"/>
+          </a:xfrm>
+          <a:prstGeom prst="rect">
+            <a:avLst/>
+          </a:prstGeom>
+          <a:noFill/>
+        </p:spPr>
+        <p:txBody>
+          <a:bodyPr wrap="square">
+            <a:spAutoFit/>
+          </a:bodyPr>
+          <a:lstStyle/>
+          <a:p>
+            <a:pPr>
+              <a:lnSpc>
+                <a:spcPct val="112000"/>
+              </a:lnSpc>
+              <a:spcAft>
+                <a:spcPts val="900"/>
+              </a:spcAft>
+            </a:pPr>
+            <a:r>
+              <a:rPr sz="1800" b="1">
+                <a:solidFill>
+                  <a:srgbClr val="E0A437"/>
+                </a:solidFill>
+                <a:latin typeface="Fira Sans"/>
+              </a:rPr>
+              <a:t>▸ </a:t>
+            </a:r>
+            <a:r>
+              <a:rPr sz="1800" b="0">
+                <a:solidFill>
+                  <a:srgbClr val="000000"/>
+                </a:solidFill>
+                <a:latin typeface="Fira Sans"/>
+              </a:rPr>
+              <a:t>El retrato de tu comuna: cada pareja adopta una comuna del Gran Santiago.</a:t>
+            </a:r>
+          </a:p>
+          <a:p>
+            <a:pPr>
+              <a:lnSpc>
+                <a:spcPct val="112000"/>
+              </a:lnSpc>
+              <a:spcAft>
+                <a:spcPts val="500"/>
+              </a:spcAft>
+            </a:pPr>
+            <a:r>
+              <a:rPr sz="1400" b="0">
+                <a:solidFill>
+                  <a:srgbClr val="333333"/>
+                </a:solidFill>
+                <a:latin typeface="Fira Sans"/>
+              </a:rPr>
+              <a:t>     ◦  </a:t>
+            </a:r>
+            <a:r>
+              <a:rPr sz="1400" b="0">
+                <a:solidFill>
+                  <a:srgbClr val="333333"/>
+                </a:solidFill>
+                <a:latin typeface="Fira Sans"/>
+              </a:rPr>
+              <a:t>Hoy: elegir la comuna y construir su retrato numérico.</a:t>
+            </a:r>
+          </a:p>
+          <a:p>
+            <a:pPr>
+              <a:lnSpc>
+                <a:spcPct val="112000"/>
+              </a:lnSpc>
+              <a:spcAft>
+                <a:spcPts val="500"/>
+              </a:spcAft>
+            </a:pPr>
+            <a:r>
+              <a:rPr sz="1400" b="0">
+                <a:solidFill>
+                  <a:srgbClr val="333333"/>
+                </a:solidFill>
+                <a:latin typeface="Fira Sans"/>
+              </a:rPr>
+              <a:t>     ◦  </a:t>
+            </a:r>
+            <a:r>
+              <a:rPr sz="1400" b="0">
+                <a:solidFill>
+                  <a:srgbClr val="333333"/>
+                </a:solidFill>
+                <a:latin typeface="Fira Sans"/>
+              </a:rPr>
+              <a:t>Próxima clase: el retrato gráfico, con métodos de visualización.</a:t>
+            </a:r>
+          </a:p>
+          <a:p>
+            <a:pPr>
+              <a:lnSpc>
+                <a:spcPct val="112000"/>
+              </a:lnSpc>
+              <a:spcAft>
+                <a:spcPts val="500"/>
+              </a:spcAft>
+            </a:pPr>
+            <a:r>
+              <a:rPr sz="1400" b="0">
+                <a:solidFill>
+                  <a:srgbClr val="333333"/>
+                </a:solidFill>
+                <a:latin typeface="Fira Sans"/>
+              </a:rPr>
+              <a:t>     ◦  </a:t>
+            </a:r>
+            <a:r>
+              <a:rPr sz="1400" b="0">
+                <a:solidFill>
+                  <a:srgbClr val="333333"/>
+                </a:solidFill>
+                <a:latin typeface="Fira Sans"/>
+              </a:rPr>
+              <a:t>Entrega del retrato completo: jueves 10 de septiembre, por Aula.</a:t>
+            </a:r>
+          </a:p>
+          <a:p>
+            <a:pPr>
+              <a:lnSpc>
+                <a:spcPct val="112000"/>
+              </a:lnSpc>
+              <a:spcAft>
+                <a:spcPts val="900"/>
+              </a:spcAft>
+            </a:pPr>
+            <a:r>
+              <a:rPr sz="1800" b="1">
+                <a:solidFill>
+                  <a:srgbClr val="E0A437"/>
+                </a:solidFill>
+                <a:latin typeface="Fira Sans"/>
+              </a:rPr>
+              <a:t>▸ </a:t>
+            </a:r>
+            <a:r>
+              <a:rPr sz="1800" b="0">
+                <a:solidFill>
+                  <a:srgbClr val="000000"/>
+                </a:solidFill>
+                <a:latin typeface="Fira Sans"/>
+              </a:rPr>
+              <a:t>El enunciado está en evaluaciones/tareas/ y la guía de hoy en actividades/.</a:t>
+            </a:r>
+          </a:p>
+          <a:p>
+            <a:pPr>
+              <a:lnSpc>
+                <a:spcPct val="112000"/>
+              </a:lnSpc>
+              <a:spcAft>
+                <a:spcPts val="900"/>
+              </a:spcAft>
+            </a:pPr>
+            <a:r>
+              <a:rPr sz="1800" b="1">
+                <a:solidFill>
+                  <a:srgbClr val="E0A437"/>
+                </a:solidFill>
+                <a:latin typeface="Fira Sans"/>
+              </a:rPr>
+              <a:t>▸ </a:t>
+            </a:r>
+            <a:r>
+              <a:rPr sz="1800" b="1">
+                <a:solidFill>
+                  <a:srgbClr val="1D3557"/>
+                </a:solidFill>
+                <a:latin typeface="Fira Sans"/>
+              </a:rPr>
+              <a:t>Lo que avancen en este bloque ya es parte de la tarea.</a:t>
+            </a:r>
+          </a:p>
+        </p:txBody>
+      </p:sp>
+    </p:spTree>
+  </p:cSld>
+  <p:clrMapOvr>
+    <a:masterClrMapping/>
+  </p:clrMapOvr>
+</p:sld>
+</file>
+
+<file path=ppt/slides/slide32.xml><?xml version="1.0" encoding="utf-8"?>
+<p:sld xmlns:a="http://schemas.openxmlformats.org/drawingml/2006/main" xmlns:p="http://schemas.openxmlformats.org/presentationml/2006/main" xmlns:r="http://schemas.openxmlformats.org/officeDocument/2006/relationships">
+  <p:cSld>
+    <p:spTree>
+      <p:nvGrpSpPr>
+        <p:cNvPr id="1" name=""/>
+        <p:cNvGrpSpPr/>
+        <p:nvPr/>
+      </p:nvGrpSpPr>
+      <p:grpSpPr/>
+      <p:sp>
+        <p:nvSpPr>
+          <p:cNvPr id="2" name="Rectangle 1"/>
+          <p:cNvSpPr/>
+          <p:nvPr/>
+        </p:nvSpPr>
+        <p:spPr>
+          <a:xfrm>
+            <a:off x="0" y="0"/>
+            <a:ext cx="9144000" cy="5138928"/>
+          </a:xfrm>
+          <a:prstGeom prst="rect">
+            <a:avLst/>
+          </a:prstGeom>
+          <a:solidFill>
+            <a:srgbClr val="FAFBFC"/>
+          </a:solidFill>
+          <a:ln>
+            <a:noFill/>
+          </a:ln>
+          <a:effectLst/>
+        </p:spPr>
+        <p:style>
+          <a:lnRef idx="1">
+            <a:schemeClr val="accent1"/>
+          </a:lnRef>
+          <a:fillRef idx="3">
+            <a:schemeClr val="accent1"/>
+          </a:fillRef>
+          <a:effectRef idx="2">
+            <a:schemeClr val="accent1"/>
+          </a:effectRef>
+          <a:fontRef idx="minor">
+            <a:schemeClr val="lt1"/>
+          </a:fontRef>
+        </p:style>
+        <p:txBody>
+          <a:bodyPr rtlCol="0" anchor="ctr"/>
+          <a:lstStyle/>
+          <a:p>
+            <a:pPr algn="ctr"/>
+          </a:p>
+        </p:txBody>
+      </p:sp>
+      <p:sp>
+        <p:nvSpPr>
+          <p:cNvPr id="3" name="TextBox 2"/>
+          <p:cNvSpPr txBox="1"/>
+          <p:nvPr/>
+        </p:nvSpPr>
+        <p:spPr>
+          <a:xfrm>
+            <a:off x="402336" y="301752"/>
+            <a:ext cx="8348472" cy="795528"/>
+          </a:xfrm>
+          <a:prstGeom prst="rect">
+            <a:avLst/>
+          </a:prstGeom>
+          <a:noFill/>
+        </p:spPr>
+        <p:txBody>
+          <a:bodyPr wrap="square">
+            <a:spAutoFit/>
+          </a:bodyPr>
+          <a:lstStyle/>
+          <a:p>
+            <a:r>
+              <a:rPr sz="2800" b="1">
+                <a:solidFill>
+                  <a:srgbClr val="0F0F0F"/>
+                </a:solidFill>
+                <a:latin typeface="Fira Sans"/>
+              </a:rPr>
+              <a:t>Referencias</a:t>
+            </a:r>
+          </a:p>
+        </p:txBody>
+      </p:sp>
+      <p:sp>
+        <p:nvSpPr>
+          <p:cNvPr id="4" name="TextBox 3"/>
+          <p:cNvSpPr txBox="1"/>
+          <p:nvPr/>
+        </p:nvSpPr>
+        <p:spPr>
+          <a:xfrm>
+            <a:off x="704088" y="1353312"/>
+            <a:ext cx="7744968" cy="3300984"/>
+          </a:xfrm>
+          <a:prstGeom prst="rect">
+            <a:avLst/>
+          </a:prstGeom>
+          <a:noFill/>
+        </p:spPr>
+        <p:txBody>
+          <a:bodyPr wrap="square">
+            <a:spAutoFit/>
+          </a:bodyPr>
+          <a:lstStyle/>
+          <a:p>
+            <a:pPr>
+              <a:lnSpc>
+                <a:spcPct val="112000"/>
+              </a:lnSpc>
+              <a:spcAft>
+                <a:spcPts val="900"/>
+              </a:spcAft>
+            </a:pPr>
+            <a:r>
+              <a:rPr sz="1800" b="1">
+                <a:solidFill>
+                  <a:srgbClr val="E0A437"/>
+                </a:solidFill>
+                <a:latin typeface="Fira Sans"/>
+              </a:rPr>
+              <a:t>▸ </a:t>
+            </a:r>
+            <a:r>
+              <a:rPr sz="1800" b="0">
+                <a:solidFill>
+                  <a:srgbClr val="000000"/>
+                </a:solidFill>
+                <a:latin typeface="Fira Sans"/>
+              </a:rPr>
+              <a:t>James, G., Witten, D., Hastie, T. y Tibshirani, R. (2023). An Introduction to Statistical Learning with Applications in Python. Springer. Capítulo 2. Descarga gratuita en statlearning.com.</a:t>
+            </a:r>
+          </a:p>
+          <a:p>
+            <a:pPr>
+              <a:lnSpc>
+                <a:spcPct val="112000"/>
+              </a:lnSpc>
+              <a:spcAft>
+                <a:spcPts val="900"/>
+              </a:spcAft>
+            </a:pPr>
+            <a:r>
+              <a:rPr sz="1800" b="1">
+                <a:solidFill>
+                  <a:srgbClr val="E0A437"/>
+                </a:solidFill>
+                <a:latin typeface="Fira Sans"/>
+              </a:rPr>
+              <a:t>▸ </a:t>
+            </a:r>
+            <a:r>
+              <a:rPr sz="1800" b="0">
+                <a:solidFill>
+                  <a:srgbClr val="000000"/>
+                </a:solidFill>
+                <a:latin typeface="Fira Sans"/>
+              </a:rPr>
+              <a:t>Bruce, P., Bruce, A. y Gedeck, P. (2020). Practical Statistics for Data Scientists, 2ª ed. O'Reilly. Capítulo 1.</a:t>
+            </a:r>
+          </a:p>
+          <a:p>
+            <a:pPr>
+              <a:lnSpc>
+                <a:spcPct val="112000"/>
+              </a:lnSpc>
+              <a:spcAft>
+                <a:spcPts val="900"/>
+              </a:spcAft>
+            </a:pPr>
+            <a:r>
+              <a:rPr sz="1800" b="1">
+                <a:solidFill>
+                  <a:srgbClr val="E0A437"/>
+                </a:solidFill>
+                <a:latin typeface="Fira Sans"/>
+              </a:rPr>
+              <a:t>▸ </a:t>
+            </a:r>
+            <a:r>
+              <a:rPr sz="1800" b="0">
+                <a:solidFill>
+                  <a:srgbClr val="000000"/>
+                </a:solidFill>
+                <a:latin typeface="Fira Sans"/>
+              </a:rPr>
+              <a:t>Tukey, J. W. (1977). Exploratory Data Analysis. Addison-Wesley.</a:t>
+            </a:r>
+          </a:p>
+          <a:p>
+            <a:pPr>
+              <a:lnSpc>
+                <a:spcPct val="112000"/>
+              </a:lnSpc>
+              <a:spcAft>
+                <a:spcPts val="900"/>
+              </a:spcAft>
+            </a:pPr>
+            <a:r>
+              <a:rPr sz="1800" b="1">
+                <a:solidFill>
+                  <a:srgbClr val="E0A437"/>
+                </a:solidFill>
+                <a:latin typeface="Fira Sans"/>
+              </a:rPr>
+              <a:t>▸ </a:t>
+            </a:r>
+            <a:r>
+              <a:rPr sz="1800" b="0">
+                <a:solidFill>
+                  <a:srgbClr val="000000"/>
+                </a:solidFill>
+                <a:latin typeface="Fira Sans"/>
+              </a:rPr>
+              <a:t>SECTRA (2014). Encuesta Origen Destino de Viajes Santiago 2012.</a:t>
+            </a:r>
+          </a:p>
+          <a:p>
+            <a:pPr>
+              <a:lnSpc>
+                <a:spcPct val="112000"/>
+              </a:lnSpc>
+              <a:spcAft>
+                <a:spcPts val="900"/>
+              </a:spcAft>
+            </a:pPr>
+            <a:r>
+              <a:rPr sz="1800" b="1">
+                <a:solidFill>
+                  <a:srgbClr val="E0A437"/>
+                </a:solidFill>
+                <a:latin typeface="Fira Sans"/>
+              </a:rPr>
+              <a:t>▸ </a:t>
+            </a:r>
+            <a:r>
+              <a:rPr sz="1800" b="0">
+                <a:solidFill>
+                  <a:srgbClr val="000000"/>
+                </a:solidFill>
+                <a:latin typeface="Fira Sans"/>
+              </a:rPr>
+              <a:t>Material inspirado en el curso de visualización de E. Graells-Garrido (github.com/zorzalerrante/aves).</a:t>
+            </a:r>
+          </a:p>
+        </p:txBody>
+      </p:sp>
+    </p:spTree>
+  </p:cSld>
+  <p:clrMapOvr>
+    <a:masterClrMapping/>
+  </p:clrMapOvr>
+</p:sld>
+</file>
+
+<file path=ppt/slides/slide4.xml><?xml version="1.0" encoding="utf-8"?>
+<p:sld xmlns:a="http://schemas.openxmlformats.org/drawingml/2006/main" xmlns:p="http://schemas.openxmlformats.org/presentationml/2006/main" xmlns:r="http://schemas.openxmlformats.org/officeDocument/2006/relationships">
+  <p:cSld>
+    <p:spTree>
+      <p:nvGrpSpPr>
+        <p:cNvPr id="1" name=""/>
+        <p:cNvGrpSpPr/>
+        <p:nvPr/>
+      </p:nvGrpSpPr>
+      <p:grpSpPr/>
+      <p:sp>
+        <p:nvSpPr>
+          <p:cNvPr id="2" name="Rectangle 1"/>
+          <p:cNvSpPr/>
+          <p:nvPr/>
+        </p:nvSpPr>
+        <p:spPr>
+          <a:xfrm>
+            <a:off x="0" y="0"/>
+            <a:ext cx="9144000" cy="5138928"/>
+          </a:xfrm>
+          <a:prstGeom prst="rect">
+            <a:avLst/>
+          </a:prstGeom>
+          <a:solidFill>
+            <a:srgbClr val="FAFBFC"/>
+          </a:solidFill>
+          <a:ln>
+            <a:noFill/>
+          </a:ln>
+          <a:effectLst/>
+        </p:spPr>
+        <p:style>
+          <a:lnRef idx="1">
+            <a:schemeClr val="accent1"/>
+          </a:lnRef>
+          <a:fillRef idx="3">
+            <a:schemeClr val="accent1"/>
+          </a:fillRef>
+          <a:effectRef idx="2">
+            <a:schemeClr val="accent1"/>
+          </a:effectRef>
+          <a:fontRef idx="minor">
+            <a:schemeClr val="lt1"/>
+          </a:fontRef>
+        </p:style>
+        <p:txBody>
+          <a:bodyPr rtlCol="0" anchor="ctr"/>
+          <a:lstStyle/>
+          <a:p>
+            <a:pPr algn="ctr"/>
+          </a:p>
+        </p:txBody>
+      </p:sp>
+      <p:sp>
+        <p:nvSpPr>
+          <p:cNvPr id="3" name="TextBox 2"/>
+          <p:cNvSpPr txBox="1"/>
+          <p:nvPr/>
+        </p:nvSpPr>
+        <p:spPr>
+          <a:xfrm>
+            <a:off x="402336" y="301752"/>
+            <a:ext cx="8348472" cy="795528"/>
+          </a:xfrm>
+          <a:prstGeom prst="rect">
+            <a:avLst/>
+          </a:prstGeom>
+          <a:noFill/>
+        </p:spPr>
+        <p:txBody>
+          <a:bodyPr wrap="square">
+            <a:spAutoFit/>
+          </a:bodyPr>
+          <a:lstStyle/>
+          <a:p>
+            <a:r>
+              <a:rPr sz="2800" b="1">
+                <a:solidFill>
+                  <a:srgbClr val="0F0F0F"/>
+                </a:solidFill>
+                <a:latin typeface="Fira Sans"/>
+              </a:rPr>
+              <a:t>¿Qué es un modelo?</a:t>
+            </a:r>
+          </a:p>
+        </p:txBody>
+      </p:sp>
+      <p:sp>
+        <p:nvSpPr>
+          <p:cNvPr id="4" name="TextBox 3"/>
+          <p:cNvSpPr txBox="1"/>
+          <p:nvPr/>
+        </p:nvSpPr>
+        <p:spPr>
+          <a:xfrm>
+            <a:off x="704088" y="1353312"/>
+            <a:ext cx="7744968" cy="3300984"/>
+          </a:xfrm>
+          <a:prstGeom prst="rect">
+            <a:avLst/>
+          </a:prstGeom>
+          <a:noFill/>
+        </p:spPr>
+        <p:txBody>
+          <a:bodyPr wrap="square">
+            <a:spAutoFit/>
+          </a:bodyPr>
+          <a:lstStyle/>
+          <a:p>
+            <a:pPr>
+              <a:lnSpc>
+                <a:spcPct val="112000"/>
+              </a:lnSpc>
+              <a:spcAft>
+                <a:spcPts val="900"/>
+              </a:spcAft>
+            </a:pPr>
+            <a:r>
+              <a:rPr sz="1800" b="1">
+                <a:solidFill>
+                  <a:srgbClr val="E0A437"/>
+                </a:solidFill>
+                <a:latin typeface="Fira Sans"/>
+              </a:rPr>
+              <a:t>▸ </a:t>
+            </a:r>
+            <a:r>
+              <a:rPr sz="1800" b="0">
+                <a:solidFill>
+                  <a:srgbClr val="000000"/>
+                </a:solidFill>
+                <a:latin typeface="Fira Sans"/>
+              </a:rPr>
+              <a:t>Una representación simplificada del proceso que genera los datos (James et al., 2023, cap. 2).</a:t>
             </a:r>
           </a:p>
           <a:p>
@@ -8539,7 +9438,7 @@
                 </a:solidFill>
                 <a:latin typeface="Fira Sans"/>
               </a:rPr>
-              <a:t>La correlación cuantifica cuánto varían conjuntamente dos variables numéricas. Veremos dos coeficientes, ambos entre -1 y 1:</a:t>
+              <a:t>La correlación cuantifica cuánto varían conjuntamente dos variables numéricas (Bruce, Bruce y Gedeck, 2020, cap. 1). Dos coeficientes, ambos entre -1 y 1:</a:t>
             </a:r>
           </a:p>
           <a:p>
@@ -8775,21 +9674,45 @@
                 </a:solidFill>
                 <a:latin typeface="Fira Sans"/>
               </a:rPr>
-              <a:t>Correlación y causalidad</a:t>
-            </a:r>
-          </a:p>
-        </p:txBody>
-      </p:sp>
-      <p:sp>
-        <p:nvSpPr>
-          <p:cNvPr id="4" name="TextBox 3"/>
+              <a:t>La correlación, vista en los datos</a:t>
+            </a:r>
+          </a:p>
+        </p:txBody>
+      </p:sp>
+      <p:pic>
+        <p:nvPicPr>
+          <p:cNvPr id="4" name="Picture 3" descr="12_scatter_distancia_tiempo.png"/>
+          <p:cNvPicPr>
+            <a:picLocks noChangeAspect="1"/>
+          </p:cNvPicPr>
+          <p:nvPr/>
+        </p:nvPicPr>
+        <p:blipFill>
+          <a:blip r:embed="rId2"/>
+          <a:stretch>
+            <a:fillRect/>
+          </a:stretch>
+        </p:blipFill>
+        <p:spPr>
+          <a:xfrm>
+            <a:off x="2281014" y="1143000"/>
+            <a:ext cx="4581971" cy="3154680"/>
+          </a:xfrm>
+          <a:prstGeom prst="rect">
+            <a:avLst/>
+          </a:prstGeom>
+        </p:spPr>
+      </p:pic>
+      <p:sp>
+        <p:nvSpPr>
+          <p:cNvPr id="5" name="TextBox 4"/>
           <p:cNvSpPr txBox="1"/>
           <p:nvPr/>
         </p:nvSpPr>
         <p:spPr>
           <a:xfrm>
-            <a:off x="704088" y="1353312"/>
-            <a:ext cx="7744968" cy="3300984"/>
+            <a:off x="704088" y="4434840"/>
+            <a:ext cx="7744968" cy="457200"/>
           </a:xfrm>
           <a:prstGeom prst="rect">
             <a:avLst/>
@@ -8802,143 +9725,14 @@
           </a:bodyPr>
           <a:lstStyle/>
           <a:p>
-            <a:pPr>
-              <a:lnSpc>
-                <a:spcPct val="112000"/>
-              </a:lnSpc>
-              <a:spcAft>
-                <a:spcPts val="900"/>
-              </a:spcAft>
-            </a:pPr>
-            <a:r>
-              <a:rPr sz="1800" b="1">
-                <a:solidFill>
-                  <a:srgbClr val="E0A437"/>
-                </a:solidFill>
-                <a:latin typeface="Fira Sans"/>
-              </a:rPr>
-              <a:t>▸ </a:t>
-            </a:r>
-            <a:r>
-              <a:rPr sz="1800" b="0">
-                <a:solidFill>
-                  <a:srgbClr val="000000"/>
-                </a:solidFill>
-                <a:latin typeface="Fira Sans"/>
-              </a:rPr>
-              <a:t>Causalidad: intervenir X cambiaría Y. Es una afirmación más fuerte que la asociación.</a:t>
-            </a:r>
-          </a:p>
-          <a:p>
-            <a:pPr>
-              <a:lnSpc>
-                <a:spcPct val="112000"/>
-              </a:lnSpc>
-              <a:spcAft>
-                <a:spcPts val="500"/>
-              </a:spcAft>
-            </a:pPr>
-            <a:r>
-              <a:rPr sz="1400" b="0">
+            <a:r>
+              <a:rPr sz="1300" b="0">
                 <a:solidFill>
                   <a:srgbClr val="333333"/>
                 </a:solidFill>
                 <a:latin typeface="Fira Sans"/>
               </a:rPr>
-              <a:t>     ◦  </a:t>
-            </a:r>
-            <a:r>
-              <a:rPr sz="1400" b="0">
-                <a:solidFill>
-                  <a:srgbClr val="333333"/>
-                </a:solidFill>
-                <a:latin typeface="Fira Sans"/>
-              </a:rPr>
-              <a:t>Una asociación observada admite varias explicaciones: X causa Y, Y causa X, o una variable de confusión Z afecta a ambas.</a:t>
-            </a:r>
-          </a:p>
-          <a:p>
-            <a:pPr>
-              <a:lnSpc>
-                <a:spcPct val="112000"/>
-              </a:lnSpc>
-              <a:spcAft>
-                <a:spcPts val="500"/>
-              </a:spcAft>
-            </a:pPr>
-            <a:r>
-              <a:rPr sz="1400" b="0">
-                <a:solidFill>
-                  <a:srgbClr val="333333"/>
-                </a:solidFill>
-                <a:latin typeface="Fira Sans"/>
-              </a:rPr>
-              <a:t>     ◦  </a:t>
-            </a:r>
-            <a:r>
-              <a:rPr sz="1400" b="0">
-                <a:solidFill>
-                  <a:srgbClr val="333333"/>
-                </a:solidFill>
-                <a:latin typeface="Fira Sans"/>
-              </a:rPr>
-              <a:t>Los datos observacionales, como los de una encuesta, muestran asociación; no bastan para establecer causalidad.</a:t>
-            </a:r>
-          </a:p>
-          <a:p>
-            <a:pPr>
-              <a:lnSpc>
-                <a:spcPct val="112000"/>
-              </a:lnSpc>
-              <a:spcAft>
-                <a:spcPts val="500"/>
-              </a:spcAft>
-            </a:pPr>
-            <a:r>
-              <a:rPr sz="1400" b="0">
-                <a:solidFill>
-                  <a:srgbClr val="333333"/>
-                </a:solidFill>
-                <a:latin typeface="Fira Sans"/>
-              </a:rPr>
-              <a:t>     ◦  </a:t>
-            </a:r>
-            <a:r>
-              <a:rPr sz="1400" b="0">
-                <a:solidFill>
-                  <a:srgbClr val="333333"/>
-                </a:solidFill>
-                <a:latin typeface="Fira Sans"/>
-              </a:rPr>
-              <a:t>La inferencia causal tiene métodos propios; este curso no los cubre.</a:t>
-            </a:r>
-          </a:p>
-          <a:p>
-            <a:pPr>
-              <a:lnSpc>
-                <a:spcPct val="112000"/>
-              </a:lnSpc>
-              <a:spcAft>
-                <a:spcPts val="900"/>
-              </a:spcAft>
-            </a:pPr>
-            <a:r>
-              <a:rPr sz="1800" b="1">
-                <a:solidFill>
-                  <a:srgbClr val="E0A437"/>
-                </a:solidFill>
-                <a:latin typeface="Fira Sans"/>
-              </a:rPr>
-              <a:t>▸ </a:t>
-            </a:r>
-            <a:r>
-              <a:rPr sz="1800" b="1">
-                <a:solidFill>
-                  <a:srgbClr val="1D3557"/>
-                </a:solidFill>
-                <a:latin typeface="Fira Sans"/>
-              </a:rPr>
-              <a:t>Regla de trabajo: una asociación se reporta como asociación, sin verbos causales que los datos no respaldan.</a:t>
+              <a:t>La mediana por tramo sube de forma sostenida (Spearman 0,72) pero no recta y con extremos (Pearson 0,43): la diferencia entre coeficientes ya es información.</a:t>
             </a:r>
           </a:p>
         </p:txBody>
@@ -9034,7 +9828,7 @@
                 </a:solidFill>
                 <a:latin typeface="Fira Sans"/>
               </a:rPr>
-              <a:t>Tipos de datos</a:t>
+              <a:t>Correlación y causalidad</a:t>
             </a:r>
           </a:p>
         </p:txBody>
@@ -9085,7 +9879,7 @@
                 </a:solidFill>
                 <a:latin typeface="Fira Sans"/>
               </a:rPr>
-              <a:t>El tipo de una variable determina qué operaciones tienen sentido:</a:t>
+              <a:t>Causalidad: intervenir X cambiaría Y. Es una afirmación más fuerte que la asociación.</a:t>
             </a:r>
           </a:p>
           <a:p>
@@ -9113,7 +9907,7 @@
                 </a:solidFill>
                 <a:latin typeface="Fira Sans"/>
               </a:rPr>
-              <a:t>Categórico nominal: categorías sin orden (sexo, comuna, propósito del viaje).</a:t>
+              <a:t>Una asociación observada admite varias explicaciones: X causa Y, Y causa X, o una variable de confusión Z afecta a ambas.</a:t>
             </a:r>
           </a:p>
           <a:p>
@@ -9141,7 +9935,7 @@
                 </a:solidFill>
                 <a:latin typeface="Fira Sans"/>
               </a:rPr>
-              <a:t>Categórico ordinal: categorías con orden (nivel educacional).</a:t>
+              <a:t>Los datos observacionales, como los de una encuesta, muestran asociación; no bastan para establecer causalidad.</a:t>
             </a:r>
           </a:p>
           <a:p>
@@ -9169,35 +9963,7 @@
                 </a:solidFill>
                 <a:latin typeface="Fira Sans"/>
               </a:rPr>
-              <a:t>Numérico discreto: conteos enteros (viajes por persona).</a:t>
-            </a:r>
-          </a:p>
-          <a:p>
-            <a:pPr>
-              <a:lnSpc>
-                <a:spcPct val="112000"/>
-              </a:lnSpc>
-              <a:spcAft>
-                <a:spcPts val="500"/>
-              </a:spcAft>
-            </a:pPr>
-            <a:r>
-              <a:rPr sz="1400" b="0">
-                <a:solidFill>
-                  <a:srgbClr val="333333"/>
-                </a:solidFill>
-                <a:latin typeface="Fira Sans"/>
-              </a:rPr>
-              <a:t>     ◦  </a:t>
-            </a:r>
-            <a:r>
-              <a:rPr sz="1400" b="0">
-                <a:solidFill>
-                  <a:srgbClr val="333333"/>
-                </a:solidFill>
-                <a:latin typeface="Fira Sans"/>
-              </a:rPr>
-              <a:t>Numérico continuo: mediciones (ingreso del hogar, duración del viaje).</a:t>
+              <a:t>La inferencia causal tiene métodos propios; este curso no los cubre.</a:t>
             </a:r>
           </a:p>
           <a:p>
@@ -9219,41 +9985,13 @@
               <a:t>▸ </a:t>
             </a:r>
             <a:r>
-              <a:rPr sz="1800" b="0">
-                <a:solidFill>
-                  <a:srgbClr val="000000"/>
-                </a:solidFill>
-                <a:latin typeface="Fira Sans"/>
-              </a:rPr>
-              <a:t>El dtype computacional no es el tipo estadístico: un sexo codificado 1 o 2 es un int64 para Pandas, pero sigue siendo nominal.</a:t>
-            </a:r>
-          </a:p>
-          <a:p>
-            <a:pPr>
-              <a:lnSpc>
-                <a:spcPct val="112000"/>
-              </a:lnSpc>
-              <a:spcAft>
-                <a:spcPts val="900"/>
-              </a:spcAft>
-            </a:pPr>
-            <a:r>
               <a:rPr sz="1800" b="1">
                 <a:solidFill>
-                  <a:srgbClr val="E0A437"/>
-                </a:solidFill>
-                <a:latin typeface="Fira Sans"/>
-              </a:rPr>
-              <a:t>▸ </a:t>
-            </a:r>
-            <a:r>
-              <a:rPr sz="1800" b="1">
-                <a:solidFill>
                   <a:srgbClr val="1D3557"/>
                 </a:solidFill>
                 <a:latin typeface="Fira Sans"/>
               </a:rPr>
-              <a:t>Promediar una variable nominal produce un número sin significado: el promedio de Sexo en la EOD es 1,53.</a:t>
+              <a:t>Regla de trabajo: una asociación se reporta como asociación, sin verbos causales que los datos no respaldan.</a:t>
             </a:r>
           </a:p>
         </p:txBody>
@@ -9349,21 +10087,45 @@
                 </a:solidFill>
                 <a:latin typeface="Fira Sans"/>
               </a:rPr>
-              <a:t>El análisis exploratorio de datos</a:t>
-            </a:r>
-          </a:p>
-        </p:txBody>
-      </p:sp>
-      <p:sp>
-        <p:nvSpPr>
-          <p:cNvPr id="4" name="TextBox 3"/>
+              <a:t>Tipos de datos</a:t>
+            </a:r>
+          </a:p>
+        </p:txBody>
+      </p:sp>
+      <p:pic>
+        <p:nvPicPr>
+          <p:cNvPr id="4" name="Picture 3" descr="11_diagrama_tipos.png"/>
+          <p:cNvPicPr>
+            <a:picLocks noChangeAspect="1"/>
+          </p:cNvPicPr>
+          <p:nvPr/>
+        </p:nvPicPr>
+        <p:blipFill>
+          <a:blip r:embed="rId2"/>
+          <a:stretch>
+            <a:fillRect/>
+          </a:stretch>
+        </p:blipFill>
+        <p:spPr>
+          <a:xfrm>
+            <a:off x="2065807" y="1143000"/>
+            <a:ext cx="5012385" cy="3154680"/>
+          </a:xfrm>
+          <a:prstGeom prst="rect">
+            <a:avLst/>
+          </a:prstGeom>
+        </p:spPr>
+      </p:pic>
+      <p:sp>
+        <p:nvSpPr>
+          <p:cNvPr id="5" name="TextBox 4"/>
           <p:cNvSpPr txBox="1"/>
           <p:nvPr/>
         </p:nvSpPr>
         <p:spPr>
           <a:xfrm>
-            <a:off x="704088" y="1353312"/>
-            <a:ext cx="7744968" cy="3300984"/>
+            <a:off x="704088" y="4434840"/>
+            <a:ext cx="7744968" cy="457200"/>
           </a:xfrm>
           <a:prstGeom prst="rect">
             <a:avLst/>
@@ -9376,227 +10138,14 @@
           </a:bodyPr>
           <a:lstStyle/>
           <a:p>
-            <a:pPr>
-              <a:lnSpc>
-                <a:spcPct val="112000"/>
-              </a:lnSpc>
-              <a:spcAft>
-                <a:spcPts val="900"/>
-              </a:spcAft>
-            </a:pPr>
-            <a:r>
-              <a:rPr sz="1800" b="1">
-                <a:solidFill>
-                  <a:srgbClr val="E0A437"/>
-                </a:solidFill>
-                <a:latin typeface="Fira Sans"/>
-              </a:rPr>
-              <a:t>▸ </a:t>
-            </a:r>
-            <a:r>
-              <a:rPr sz="1800" b="0">
-                <a:solidFill>
-                  <a:srgbClr val="000000"/>
-                </a:solidFill>
-                <a:latin typeface="Fira Sans"/>
-              </a:rPr>
-              <a:t>La etapa en que se examinan los datos antes de modelarlos (Tukey, 1977).</a:t>
-            </a:r>
-          </a:p>
-          <a:p>
-            <a:pPr>
-              <a:lnSpc>
-                <a:spcPct val="112000"/>
-              </a:lnSpc>
-              <a:spcAft>
-                <a:spcPts val="900"/>
-              </a:spcAft>
-            </a:pPr>
-            <a:r>
-              <a:rPr sz="1800" b="1">
-                <a:solidFill>
-                  <a:srgbClr val="E0A437"/>
-                </a:solidFill>
-                <a:latin typeface="Fira Sans"/>
-              </a:rPr>
-              <a:t>▸ </a:t>
-            </a:r>
-            <a:r>
-              <a:rPr sz="1800" b="0">
-                <a:solidFill>
-                  <a:srgbClr val="000000"/>
-                </a:solidFill>
-                <a:latin typeface="Fira Sans"/>
-              </a:rPr>
-              <a:t>Responde cuatro tipos de pregunta:</a:t>
-            </a:r>
-          </a:p>
-          <a:p>
-            <a:pPr>
-              <a:lnSpc>
-                <a:spcPct val="112000"/>
-              </a:lnSpc>
-              <a:spcAft>
-                <a:spcPts val="500"/>
-              </a:spcAft>
-            </a:pPr>
-            <a:r>
-              <a:rPr sz="1400" b="0">
+            <a:r>
+              <a:rPr sz="1300" b="0">
                 <a:solidFill>
                   <a:srgbClr val="333333"/>
                 </a:solidFill>
                 <a:latin typeface="Fira Sans"/>
               </a:rPr>
-              <a:t>     ◦  </a:t>
-            </a:r>
-            <a:r>
-              <a:rPr sz="1400" b="0">
-                <a:solidFill>
-                  <a:srgbClr val="333333"/>
-                </a:solidFill>
-                <a:latin typeface="Fira Sans"/>
-              </a:rPr>
-              <a:t>La forma: cómo se distribuye cada variable.</a:t>
-            </a:r>
-          </a:p>
-          <a:p>
-            <a:pPr>
-              <a:lnSpc>
-                <a:spcPct val="112000"/>
-              </a:lnSpc>
-              <a:spcAft>
-                <a:spcPts val="500"/>
-              </a:spcAft>
-            </a:pPr>
-            <a:r>
-              <a:rPr sz="1400" b="0">
-                <a:solidFill>
-                  <a:srgbClr val="333333"/>
-                </a:solidFill>
-                <a:latin typeface="Fira Sans"/>
-              </a:rPr>
-              <a:t>     ◦  </a:t>
-            </a:r>
-            <a:r>
-              <a:rPr sz="1400" b="0">
-                <a:solidFill>
-                  <a:srgbClr val="333333"/>
-                </a:solidFill>
-                <a:latin typeface="Fira Sans"/>
-              </a:rPr>
-              <a:t>Lo típico y lo extremo: qué es frecuente y qué es anómalo.</a:t>
-            </a:r>
-          </a:p>
-          <a:p>
-            <a:pPr>
-              <a:lnSpc>
-                <a:spcPct val="112000"/>
-              </a:lnSpc>
-              <a:spcAft>
-                <a:spcPts val="500"/>
-              </a:spcAft>
-            </a:pPr>
-            <a:r>
-              <a:rPr sz="1400" b="0">
-                <a:solidFill>
-                  <a:srgbClr val="333333"/>
-                </a:solidFill>
-                <a:latin typeface="Fira Sans"/>
-              </a:rPr>
-              <a:t>     ◦  </a:t>
-            </a:r>
-            <a:r>
-              <a:rPr sz="1400" b="0">
-                <a:solidFill>
-                  <a:srgbClr val="333333"/>
-                </a:solidFill>
-                <a:latin typeface="Fira Sans"/>
-              </a:rPr>
-              <a:t>Lo que falta: qué datos están ausentes y con qué patrón.</a:t>
-            </a:r>
-          </a:p>
-          <a:p>
-            <a:pPr>
-              <a:lnSpc>
-                <a:spcPct val="112000"/>
-              </a:lnSpc>
-              <a:spcAft>
-                <a:spcPts val="500"/>
-              </a:spcAft>
-            </a:pPr>
-            <a:r>
-              <a:rPr sz="1400" b="0">
-                <a:solidFill>
-                  <a:srgbClr val="333333"/>
-                </a:solidFill>
-                <a:latin typeface="Fira Sans"/>
-              </a:rPr>
-              <a:t>     ◦  </a:t>
-            </a:r>
-            <a:r>
-              <a:rPr sz="1400" b="0">
-                <a:solidFill>
-                  <a:srgbClr val="333333"/>
-                </a:solidFill>
-                <a:latin typeface="Fira Sans"/>
-              </a:rPr>
-              <a:t>Las relaciones: qué variables se asocian con qué otras.</a:t>
-            </a:r>
-          </a:p>
-          <a:p>
-            <a:pPr>
-              <a:lnSpc>
-                <a:spcPct val="112000"/>
-              </a:lnSpc>
-              <a:spcAft>
-                <a:spcPts val="900"/>
-              </a:spcAft>
-            </a:pPr>
-            <a:r>
-              <a:rPr sz="1800" b="1">
-                <a:solidFill>
-                  <a:srgbClr val="E0A437"/>
-                </a:solidFill>
-                <a:latin typeface="Fira Sans"/>
-              </a:rPr>
-              <a:t>▸ </a:t>
-            </a:r>
-            <a:r>
-              <a:rPr sz="1800" b="0">
-                <a:solidFill>
-                  <a:srgbClr val="000000"/>
-                </a:solidFill>
-                <a:latin typeface="Fira Sans"/>
-              </a:rPr>
-              <a:t>Genera hipótesis; el análisis confirmatorio (unidad 5) las pone a prueba.</a:t>
-            </a:r>
-          </a:p>
-          <a:p>
-            <a:pPr>
-              <a:lnSpc>
-                <a:spcPct val="112000"/>
-              </a:lnSpc>
-              <a:spcAft>
-                <a:spcPts val="900"/>
-              </a:spcAft>
-            </a:pPr>
-            <a:r>
-              <a:rPr sz="1800" b="1">
-                <a:solidFill>
-                  <a:srgbClr val="E0A437"/>
-                </a:solidFill>
-                <a:latin typeface="Fira Sans"/>
-              </a:rPr>
-              <a:t>▸ </a:t>
-            </a:r>
-            <a:r>
-              <a:rPr sz="1800" b="1">
-                <a:solidFill>
-                  <a:srgbClr val="1D3557"/>
-                </a:solidFill>
-                <a:latin typeface="Fira Sans"/>
-              </a:rPr>
-              <a:t>Una pregunta transversal para toda cifra resumen: ¿de quién habla este número? ¿De la muestra, de un subgrupo, de la ciudad?</a:t>
+              <a:t>El tipo de la variable determina qué operaciones tienen sentido (Bruce, Bruce y Gedeck, 2020, cap. 1).</a:t>
             </a:r>
           </a:p>
         </p:txBody>

</xml_diff>

<commit_message>
Correlacion: formulas tipografiadas, simbolos definidos y el caso no lineal
Las slides de Pearson y Spearman componen la formula (renderizada con mathtext)
sobre su grafico, definen cada simbolo (x, y, medias, n, d) y la notacion (r y
rho), y los titulos de los graficos pasan a registro descriptivo. Se agrega una
slide y una seccion del notebook con el caso de asociacion fuerte no monotona:
los viajes por persona segun la edad, donde r = 0,04 y rho = 0,05 pese a la
curva evidente. Se corrige ademas un encabezado duplicado del notebook.

Co-Authored-By: Claude Fable 5 <noreply@anthropic.com>
</commit_message>
<xml_diff>
--- a/presentaciones/clase02_pandas_eda.pptx
+++ b/presentaciones/clase02_pandas_eda.pptx
@@ -39,6 +39,7 @@
     <p:sldId id="287" r:id="rId38"/>
     <p:sldId id="288" r:id="rId39"/>
     <p:sldId id="289" r:id="rId40"/>
+    <p:sldId id="290" r:id="rId41"/>
   </p:sldIdLst>
   <p:sldSz cx="9144000" cy="5138928" type="screen4x3"/>
   <p:notesSz cx="6858000" cy="9144000"/>
@@ -3388,7 +3389,7 @@
                 </a:solidFill>
                 <a:latin typeface="Fira Sans"/>
               </a:rPr>
-              <a:t>Correlación y causalidad</a:t>
+              <a:t>¿Cuándo usar cada coeficiente?</a:t>
             </a:r>
           </a:p>
         </p:txBody>
@@ -3401,8 +3402,8 @@
         </p:nvSpPr>
         <p:spPr>
           <a:xfrm>
-            <a:off x="704088" y="1353312"/>
-            <a:ext cx="7744968" cy="3300984"/>
+            <a:off x="502920" y="1252728"/>
+            <a:ext cx="4023360" cy="3200400"/>
           </a:xfrm>
           <a:prstGeom prst="rect">
             <a:avLst/>
@@ -3424,7 +3425,7 @@
               </a:spcAft>
             </a:pPr>
             <a:r>
-              <a:rPr sz="1800" b="1">
+              <a:rPr sz="1500" b="1">
                 <a:solidFill>
                   <a:srgbClr val="E0A437"/>
                 </a:solidFill>
@@ -3433,13 +3434,41 @@
               <a:t>▸ </a:t>
             </a:r>
             <a:r>
-              <a:rPr sz="1800" b="0">
+              <a:rPr sz="1500" b="0">
                 <a:solidFill>
                   <a:srgbClr val="000000"/>
                 </a:solidFill>
                 <a:latin typeface="Fira Sans"/>
               </a:rPr>
-              <a:t>Causalidad: intervenir X cambiaría Y. Es una afirmación más fuerte que la asociación.</a:t>
+              <a:t>Pearson: relación aproximadamente recta, sin extremos dominantes; antesala del modelo lineal.</a:t>
+            </a:r>
+          </a:p>
+          <a:p>
+            <a:pPr>
+              <a:lnSpc>
+                <a:spcPct val="112000"/>
+              </a:lnSpc>
+              <a:spcAft>
+                <a:spcPts val="900"/>
+              </a:spcAft>
+            </a:pPr>
+            <a:r>
+              <a:rPr sz="1500" b="1">
+                <a:solidFill>
+                  <a:srgbClr val="E0A437"/>
+                </a:solidFill>
+                <a:latin typeface="Fira Sans"/>
+              </a:rPr>
+              <a:t>▸ </a:t>
+            </a:r>
+            <a:r>
+              <a:rPr sz="1500" b="0">
+                <a:solidFill>
+                  <a:srgbClr val="000000"/>
+                </a:solidFill>
+                <a:latin typeface="Fira Sans"/>
+              </a:rPr>
+              <a:t>Spearman: asimetrías, extremos, curvas crecientes, o variables ordinales.</a:t>
             </a:r>
           </a:p>
           <a:p>
@@ -3452,7 +3481,7 @@
               </a:spcAft>
             </a:pPr>
             <a:r>
-              <a:rPr sz="1400" b="0">
+              <a:rPr sz="1300" b="0">
                 <a:solidFill>
                   <a:srgbClr val="333333"/>
                 </a:solidFill>
@@ -3461,13 +3490,13 @@
               <a:t>     ◦  </a:t>
             </a:r>
             <a:r>
-              <a:rPr sz="1400" b="0">
+              <a:rPr sz="1300" b="0">
                 <a:solidFill>
                   <a:srgbClr val="333333"/>
                 </a:solidFill>
                 <a:latin typeface="Fira Sans"/>
               </a:rPr>
-              <a:t>Una asociación observada admite varias explicaciones: X causa Y, Y causa X, o una variable de confusión Z afecta a ambas.</a:t>
+              <a:t>La brecha entre ambos es un diagnóstico: 0,43 contra 0,76 indica curva o extremos.</a:t>
             </a:r>
           </a:p>
           <a:p>
@@ -3480,7 +3509,7 @@
               </a:spcAft>
             </a:pPr>
             <a:r>
-              <a:rPr sz="1400" b="0">
+              <a:rPr sz="1300" b="0">
                 <a:solidFill>
                   <a:srgbClr val="333333"/>
                 </a:solidFill>
@@ -3489,41 +3518,13 @@
               <a:t>     ◦  </a:t>
             </a:r>
             <a:r>
-              <a:rPr sz="1400" b="0">
+              <a:rPr sz="1300" b="0">
                 <a:solidFill>
                   <a:srgbClr val="333333"/>
                 </a:solidFill>
                 <a:latin typeface="Fira Sans"/>
               </a:rPr>
-              <a:t>Los datos observacionales, como los de una encuesta, muestran asociación; no bastan para establecer causalidad.</a:t>
-            </a:r>
-          </a:p>
-          <a:p>
-            <a:pPr>
-              <a:lnSpc>
-                <a:spcPct val="112000"/>
-              </a:lnSpc>
-              <a:spcAft>
-                <a:spcPts val="500"/>
-              </a:spcAft>
-            </a:pPr>
-            <a:r>
-              <a:rPr sz="1400" b="0">
-                <a:solidFill>
-                  <a:srgbClr val="333333"/>
-                </a:solidFill>
-                <a:latin typeface="Fira Sans"/>
-              </a:rPr>
-              <a:t>     ◦  </a:t>
-            </a:r>
-            <a:r>
-              <a:rPr sz="1400" b="0">
-                <a:solidFill>
-                  <a:srgbClr val="333333"/>
-                </a:solidFill>
-                <a:latin typeface="Fira Sans"/>
-              </a:rPr>
-              <a:t>La inferencia causal tiene métodos propios; este curso no los cubre.</a:t>
+              <a:t>Tras el logaritmo, Pearson llega a 0,73, casi igual a Spearman.</a:t>
             </a:r>
           </a:p>
           <a:p>
@@ -3536,7 +3537,7 @@
               </a:spcAft>
             </a:pPr>
             <a:r>
-              <a:rPr sz="1800" b="1">
+              <a:rPr sz="1500" b="1">
                 <a:solidFill>
                   <a:srgbClr val="E0A437"/>
                 </a:solidFill>
@@ -3545,17 +3546,41 @@
               <a:t>▸ </a:t>
             </a:r>
             <a:r>
-              <a:rPr sz="1800" b="1">
+              <a:rPr sz="1500" b="1">
                 <a:solidFill>
                   <a:srgbClr val="1D3557"/>
                 </a:solidFill>
                 <a:latin typeface="Fira Sans"/>
               </a:rPr>
-              <a:t>Regla de trabajo: una asociación se reporta como asociación, sin verbos causales que los datos no respaldan.</a:t>
-            </a:r>
-          </a:p>
-        </p:txBody>
-      </p:sp>
+              <a:t>Calcule ambos; si difieren mucho, mire el gráfico antes de reportar.</a:t>
+            </a:r>
+          </a:p>
+        </p:txBody>
+      </p:sp>
+      <p:pic>
+        <p:nvPicPr>
+          <p:cNvPr id="5" name="Picture 4" descr="18_loglog.png"/>
+          <p:cNvPicPr>
+            <a:picLocks noChangeAspect="1"/>
+          </p:cNvPicPr>
+          <p:nvPr/>
+        </p:nvPicPr>
+        <p:blipFill>
+          <a:blip r:embed="rId2"/>
+          <a:stretch>
+            <a:fillRect/>
+          </a:stretch>
+        </p:blipFill>
+        <p:spPr>
+          <a:xfrm>
+            <a:off x="4892040" y="1371600"/>
+            <a:ext cx="3840480" cy="3350924"/>
+          </a:xfrm>
+          <a:prstGeom prst="rect">
+            <a:avLst/>
+          </a:prstGeom>
+        </p:spPr>
+      </p:pic>
     </p:spTree>
   </p:cSld>
   <p:clrMapOvr>
@@ -3647,45 +3672,21 @@
                 </a:solidFill>
                 <a:latin typeface="Fira Sans"/>
               </a:rPr>
-              <a:t>Tipos de datos</a:t>
-            </a:r>
-          </a:p>
-        </p:txBody>
-      </p:sp>
-      <p:pic>
-        <p:nvPicPr>
-          <p:cNvPr id="4" name="Picture 3" descr="11_diagrama_tipos.png"/>
-          <p:cNvPicPr>
-            <a:picLocks noChangeAspect="1"/>
-          </p:cNvPicPr>
-          <p:nvPr/>
-        </p:nvPicPr>
-        <p:blipFill>
-          <a:blip r:embed="rId2"/>
-          <a:stretch>
-            <a:fillRect/>
-          </a:stretch>
-        </p:blipFill>
-        <p:spPr>
-          <a:xfrm>
-            <a:off x="2065807" y="1143000"/>
-            <a:ext cx="5012385" cy="3154680"/>
-          </a:xfrm>
-          <a:prstGeom prst="rect">
-            <a:avLst/>
-          </a:prstGeom>
-        </p:spPr>
-      </p:pic>
-      <p:sp>
-        <p:nvSpPr>
-          <p:cNvPr id="5" name="TextBox 4"/>
+              <a:t>Correlación y causalidad</a:t>
+            </a:r>
+          </a:p>
+        </p:txBody>
+      </p:sp>
+      <p:sp>
+        <p:nvSpPr>
+          <p:cNvPr id="4" name="TextBox 3"/>
           <p:cNvSpPr txBox="1"/>
           <p:nvPr/>
         </p:nvSpPr>
         <p:spPr>
           <a:xfrm>
-            <a:off x="704088" y="4434840"/>
-            <a:ext cx="7744968" cy="457200"/>
+            <a:off x="704088" y="1353312"/>
+            <a:ext cx="7744968" cy="3300984"/>
           </a:xfrm>
           <a:prstGeom prst="rect">
             <a:avLst/>
@@ -3698,14 +3699,143 @@
           </a:bodyPr>
           <a:lstStyle/>
           <a:p>
-            <a:r>
-              <a:rPr sz="1300" b="0">
+            <a:pPr>
+              <a:lnSpc>
+                <a:spcPct val="112000"/>
+              </a:lnSpc>
+              <a:spcAft>
+                <a:spcPts val="900"/>
+              </a:spcAft>
+            </a:pPr>
+            <a:r>
+              <a:rPr sz="1800" b="1">
+                <a:solidFill>
+                  <a:srgbClr val="E0A437"/>
+                </a:solidFill>
+                <a:latin typeface="Fira Sans"/>
+              </a:rPr>
+              <a:t>▸ </a:t>
+            </a:r>
+            <a:r>
+              <a:rPr sz="1800" b="0">
+                <a:solidFill>
+                  <a:srgbClr val="000000"/>
+                </a:solidFill>
+                <a:latin typeface="Fira Sans"/>
+              </a:rPr>
+              <a:t>Causalidad: intervenir X cambiaría Y. Es una afirmación más fuerte que la asociación.</a:t>
+            </a:r>
+          </a:p>
+          <a:p>
+            <a:pPr>
+              <a:lnSpc>
+                <a:spcPct val="112000"/>
+              </a:lnSpc>
+              <a:spcAft>
+                <a:spcPts val="500"/>
+              </a:spcAft>
+            </a:pPr>
+            <a:r>
+              <a:rPr sz="1400" b="0">
                 <a:solidFill>
                   <a:srgbClr val="333333"/>
                 </a:solidFill>
                 <a:latin typeface="Fira Sans"/>
               </a:rPr>
-              <a:t>El tipo de la variable determina qué operaciones tienen sentido (Bruce, Bruce y Gedeck, 2020, cap. 1).</a:t>
+              <a:t>     ◦  </a:t>
+            </a:r>
+            <a:r>
+              <a:rPr sz="1400" b="0">
+                <a:solidFill>
+                  <a:srgbClr val="333333"/>
+                </a:solidFill>
+                <a:latin typeface="Fira Sans"/>
+              </a:rPr>
+              <a:t>Una asociación observada admite varias explicaciones: X causa Y, Y causa X, o una variable de confusión Z afecta a ambas.</a:t>
+            </a:r>
+          </a:p>
+          <a:p>
+            <a:pPr>
+              <a:lnSpc>
+                <a:spcPct val="112000"/>
+              </a:lnSpc>
+              <a:spcAft>
+                <a:spcPts val="500"/>
+              </a:spcAft>
+            </a:pPr>
+            <a:r>
+              <a:rPr sz="1400" b="0">
+                <a:solidFill>
+                  <a:srgbClr val="333333"/>
+                </a:solidFill>
+                <a:latin typeface="Fira Sans"/>
+              </a:rPr>
+              <a:t>     ◦  </a:t>
+            </a:r>
+            <a:r>
+              <a:rPr sz="1400" b="0">
+                <a:solidFill>
+                  <a:srgbClr val="333333"/>
+                </a:solidFill>
+                <a:latin typeface="Fira Sans"/>
+              </a:rPr>
+              <a:t>Los datos observacionales, como los de una encuesta, muestran asociación; no bastan para establecer causalidad.</a:t>
+            </a:r>
+          </a:p>
+          <a:p>
+            <a:pPr>
+              <a:lnSpc>
+                <a:spcPct val="112000"/>
+              </a:lnSpc>
+              <a:spcAft>
+                <a:spcPts val="500"/>
+              </a:spcAft>
+            </a:pPr>
+            <a:r>
+              <a:rPr sz="1400" b="0">
+                <a:solidFill>
+                  <a:srgbClr val="333333"/>
+                </a:solidFill>
+                <a:latin typeface="Fira Sans"/>
+              </a:rPr>
+              <a:t>     ◦  </a:t>
+            </a:r>
+            <a:r>
+              <a:rPr sz="1400" b="0">
+                <a:solidFill>
+                  <a:srgbClr val="333333"/>
+                </a:solidFill>
+                <a:latin typeface="Fira Sans"/>
+              </a:rPr>
+              <a:t>La inferencia causal tiene métodos propios; este curso no los cubre.</a:t>
+            </a:r>
+          </a:p>
+          <a:p>
+            <a:pPr>
+              <a:lnSpc>
+                <a:spcPct val="112000"/>
+              </a:lnSpc>
+              <a:spcAft>
+                <a:spcPts val="900"/>
+              </a:spcAft>
+            </a:pPr>
+            <a:r>
+              <a:rPr sz="1800" b="1">
+                <a:solidFill>
+                  <a:srgbClr val="E0A437"/>
+                </a:solidFill>
+                <a:latin typeface="Fira Sans"/>
+              </a:rPr>
+              <a:t>▸ </a:t>
+            </a:r>
+            <a:r>
+              <a:rPr sz="1800" b="1">
+                <a:solidFill>
+                  <a:srgbClr val="1D3557"/>
+                </a:solidFill>
+                <a:latin typeface="Fira Sans"/>
+              </a:rPr>
+              <a:t>Regla de trabajo: una asociación se reporta como asociación, sin verbos causales que los datos no respaldan.</a:t>
             </a:r>
           </a:p>
         </p:txBody>
@@ -3801,21 +3931,45 @@
                 </a:solidFill>
                 <a:latin typeface="Fira Sans"/>
               </a:rPr>
-              <a:t>El tipo estadístico no es el tipo computacional</a:t>
-            </a:r>
-          </a:p>
-        </p:txBody>
-      </p:sp>
-      <p:sp>
-        <p:nvSpPr>
-          <p:cNvPr id="4" name="TextBox 3"/>
+              <a:t>Tipos de datos</a:t>
+            </a:r>
+          </a:p>
+        </p:txBody>
+      </p:sp>
+      <p:pic>
+        <p:nvPicPr>
+          <p:cNvPr id="4" name="Picture 3" descr="11_diagrama_tipos.png"/>
+          <p:cNvPicPr>
+            <a:picLocks noChangeAspect="1"/>
+          </p:cNvPicPr>
+          <p:nvPr/>
+        </p:nvPicPr>
+        <p:blipFill>
+          <a:blip r:embed="rId2"/>
+          <a:stretch>
+            <a:fillRect/>
+          </a:stretch>
+        </p:blipFill>
+        <p:spPr>
+          <a:xfrm>
+            <a:off x="2065807" y="1143000"/>
+            <a:ext cx="5012385" cy="3154680"/>
+          </a:xfrm>
+          <a:prstGeom prst="rect">
+            <a:avLst/>
+          </a:prstGeom>
+        </p:spPr>
+      </p:pic>
+      <p:sp>
+        <p:nvSpPr>
+          <p:cNvPr id="5" name="TextBox 4"/>
           <p:cNvSpPr txBox="1"/>
           <p:nvPr/>
         </p:nvSpPr>
         <p:spPr>
           <a:xfrm>
-            <a:off x="704088" y="1353312"/>
-            <a:ext cx="7744968" cy="3300984"/>
+            <a:off x="704088" y="4434840"/>
+            <a:ext cx="7744968" cy="457200"/>
           </a:xfrm>
           <a:prstGeom prst="rect">
             <a:avLst/>
@@ -3828,143 +3982,14 @@
           </a:bodyPr>
           <a:lstStyle/>
           <a:p>
-            <a:pPr>
-              <a:lnSpc>
-                <a:spcPct val="112000"/>
-              </a:lnSpc>
-              <a:spcAft>
-                <a:spcPts val="900"/>
-              </a:spcAft>
-            </a:pPr>
-            <a:r>
-              <a:rPr sz="1800" b="1">
-                <a:solidFill>
-                  <a:srgbClr val="E0A437"/>
-                </a:solidFill>
-                <a:latin typeface="Fira Sans"/>
-              </a:rPr>
-              <a:t>▸ </a:t>
-            </a:r>
-            <a:r>
-              <a:rPr sz="1800" b="0">
-                <a:solidFill>
-                  <a:srgbClr val="000000"/>
-                </a:solidFill>
-                <a:latin typeface="Fira Sans"/>
-              </a:rPr>
-              <a:t>En la EOD el sexo viene codificado 1 o 2: para Pandas es un entero (int64).</a:t>
-            </a:r>
-          </a:p>
-          <a:p>
-            <a:pPr>
-              <a:lnSpc>
-                <a:spcPct val="112000"/>
-              </a:lnSpc>
-              <a:spcAft>
-                <a:spcPts val="900"/>
-              </a:spcAft>
-            </a:pPr>
-            <a:r>
-              <a:rPr sz="1800" b="1">
-                <a:solidFill>
-                  <a:srgbClr val="E0A437"/>
-                </a:solidFill>
-                <a:latin typeface="Fira Sans"/>
-              </a:rPr>
-              <a:t>▸ </a:t>
-            </a:r>
-            <a:r>
-              <a:rPr sz="1800" b="0">
-                <a:solidFill>
-                  <a:srgbClr val="000000"/>
-                </a:solidFill>
-                <a:latin typeface="Fira Sans"/>
-              </a:rPr>
-              <a:t>El tipo computacional permite operar; el tipo estadístico decide si la operación significa algo.</a:t>
-            </a:r>
-          </a:p>
-          <a:p>
-            <a:pPr>
-              <a:lnSpc>
-                <a:spcPct val="112000"/>
-              </a:lnSpc>
-              <a:spcAft>
-                <a:spcPts val="500"/>
-              </a:spcAft>
-            </a:pPr>
-            <a:r>
-              <a:rPr sz="1400" b="0">
+            <a:r>
+              <a:rPr sz="1300" b="0">
                 <a:solidFill>
                   <a:srgbClr val="333333"/>
                 </a:solidFill>
                 <a:latin typeface="Fira Sans"/>
               </a:rPr>
-              <a:t>     ◦  </a:t>
-            </a:r>
-            <a:r>
-              <a:rPr sz="1400" b="0">
-                <a:solidFill>
-                  <a:srgbClr val="333333"/>
-                </a:solidFill>
-                <a:latin typeface="Fira Sans"/>
-              </a:rPr>
-              <a:t>El promedio de Sexo en la EOD es 1,53: aritméticamente correcto, sin significado.</a:t>
-            </a:r>
-          </a:p>
-          <a:p>
-            <a:pPr>
-              <a:lnSpc>
-                <a:spcPct val="112000"/>
-              </a:lnSpc>
-              <a:spcAft>
-                <a:spcPts val="500"/>
-              </a:spcAft>
-            </a:pPr>
-            <a:r>
-              <a:rPr sz="1400" b="0">
-                <a:solidFill>
-                  <a:srgbClr val="333333"/>
-                </a:solidFill>
-                <a:latin typeface="Fira Sans"/>
-              </a:rPr>
-              <a:t>     ◦  </a:t>
-            </a:r>
-            <a:r>
-              <a:rPr sz="1400" b="0">
-                <a:solidFill>
-                  <a:srgbClr val="333333"/>
-                </a:solidFill>
-                <a:latin typeface="Fira Sans"/>
-              </a:rPr>
-              <a:t>El promedio de Edad sí es interpretable: la variable es numérica.</a:t>
-            </a:r>
-          </a:p>
-          <a:p>
-            <a:pPr>
-              <a:lnSpc>
-                <a:spcPct val="112000"/>
-              </a:lnSpc>
-              <a:spcAft>
-                <a:spcPts val="900"/>
-              </a:spcAft>
-            </a:pPr>
-            <a:r>
-              <a:rPr sz="1800" b="1">
-                <a:solidFill>
-                  <a:srgbClr val="E0A437"/>
-                </a:solidFill>
-                <a:latin typeface="Fira Sans"/>
-              </a:rPr>
-              <a:t>▸ </a:t>
-            </a:r>
-            <a:r>
-              <a:rPr sz="1800" b="1">
-                <a:solidFill>
-                  <a:srgbClr val="1D3557"/>
-                </a:solidFill>
-                <a:latin typeface="Fira Sans"/>
-              </a:rPr>
-              <a:t>Identificar el tipo de cada variable es un paso del análisis, no una formalidad.</a:t>
+              <a:t>El tipo de la variable determina qué operaciones tienen sentido (Bruce, Bruce y Gedeck, 2020, cap. 1).</a:t>
             </a:r>
           </a:p>
         </p:txBody>
@@ -4060,7 +4085,7 @@
                 </a:solidFill>
                 <a:latin typeface="Fira Sans"/>
               </a:rPr>
-              <a:t>El análisis exploratorio de datos</a:t>
+              <a:t>El tipo estadístico no es el tipo computacional</a:t>
             </a:r>
           </a:p>
         </p:txBody>
@@ -4111,7 +4136,7 @@
                 </a:solidFill>
                 <a:latin typeface="Fira Sans"/>
               </a:rPr>
-              <a:t>La etapa en que se examinan los datos antes de modelarlos (Tukey, 1977).</a:t>
+              <a:t>En la EOD el sexo viene codificado 1 o 2: para Pandas es un entero (int64).</a:t>
             </a:r>
           </a:p>
           <a:p>
@@ -4139,7 +4164,7 @@
                 </a:solidFill>
                 <a:latin typeface="Fira Sans"/>
               </a:rPr>
-              <a:t>Responde cuatro tipos de pregunta:</a:t>
+              <a:t>El tipo computacional permite operar; el tipo estadístico decide si la operación significa algo.</a:t>
             </a:r>
           </a:p>
           <a:p>
@@ -4167,7 +4192,7 @@
                 </a:solidFill>
                 <a:latin typeface="Fira Sans"/>
               </a:rPr>
-              <a:t>La forma: cómo se distribuye cada variable.</a:t>
+              <a:t>El promedio de Sexo en la EOD es 1,53: aritméticamente correcto, sin significado.</a:t>
             </a:r>
           </a:p>
           <a:p>
@@ -4195,63 +4220,7 @@
                 </a:solidFill>
                 <a:latin typeface="Fira Sans"/>
               </a:rPr>
-              <a:t>Lo típico y lo extremo: qué es frecuente y qué es anómalo.</a:t>
-            </a:r>
-          </a:p>
-          <a:p>
-            <a:pPr>
-              <a:lnSpc>
-                <a:spcPct val="112000"/>
-              </a:lnSpc>
-              <a:spcAft>
-                <a:spcPts val="500"/>
-              </a:spcAft>
-            </a:pPr>
-            <a:r>
-              <a:rPr sz="1400" b="0">
-                <a:solidFill>
-                  <a:srgbClr val="333333"/>
-                </a:solidFill>
-                <a:latin typeface="Fira Sans"/>
-              </a:rPr>
-              <a:t>     ◦  </a:t>
-            </a:r>
-            <a:r>
-              <a:rPr sz="1400" b="0">
-                <a:solidFill>
-                  <a:srgbClr val="333333"/>
-                </a:solidFill>
-                <a:latin typeface="Fira Sans"/>
-              </a:rPr>
-              <a:t>Lo que falta: qué datos están ausentes y con qué patrón.</a:t>
-            </a:r>
-          </a:p>
-          <a:p>
-            <a:pPr>
-              <a:lnSpc>
-                <a:spcPct val="112000"/>
-              </a:lnSpc>
-              <a:spcAft>
-                <a:spcPts val="500"/>
-              </a:spcAft>
-            </a:pPr>
-            <a:r>
-              <a:rPr sz="1400" b="0">
-                <a:solidFill>
-                  <a:srgbClr val="333333"/>
-                </a:solidFill>
-                <a:latin typeface="Fira Sans"/>
-              </a:rPr>
-              <a:t>     ◦  </a:t>
-            </a:r>
-            <a:r>
-              <a:rPr sz="1400" b="0">
-                <a:solidFill>
-                  <a:srgbClr val="333333"/>
-                </a:solidFill>
-                <a:latin typeface="Fira Sans"/>
-              </a:rPr>
-              <a:t>Las relaciones: qué variables se asocian con qué otras.</a:t>
+              <a:t>El promedio de Edad sí es interpretable: la variable es numérica.</a:t>
             </a:r>
           </a:p>
           <a:p>
@@ -4273,41 +4242,13 @@
               <a:t>▸ </a:t>
             </a:r>
             <a:r>
-              <a:rPr sz="1800" b="0">
-                <a:solidFill>
-                  <a:srgbClr val="000000"/>
-                </a:solidFill>
-                <a:latin typeface="Fira Sans"/>
-              </a:rPr>
-              <a:t>Genera hipótesis; el análisis confirmatorio (unidad 5) las pone a prueba.</a:t>
-            </a:r>
-          </a:p>
-          <a:p>
-            <a:pPr>
-              <a:lnSpc>
-                <a:spcPct val="112000"/>
-              </a:lnSpc>
-              <a:spcAft>
-                <a:spcPts val="900"/>
-              </a:spcAft>
-            </a:pPr>
-            <a:r>
               <a:rPr sz="1800" b="1">
                 <a:solidFill>
-                  <a:srgbClr val="E0A437"/>
-                </a:solidFill>
-                <a:latin typeface="Fira Sans"/>
-              </a:rPr>
-              <a:t>▸ </a:t>
-            </a:r>
-            <a:r>
-              <a:rPr sz="1800" b="1">
-                <a:solidFill>
                   <a:srgbClr val="1D3557"/>
                 </a:solidFill>
                 <a:latin typeface="Fira Sans"/>
               </a:rPr>
-              <a:t>Una pregunta transversal para toda cifra resumen: ¿de quién habla este número? ¿De la muestra, de un subgrupo, de la ciudad?</a:t>
+              <a:t>Identificar el tipo de cada variable es un paso del análisis, no una formalidad.</a:t>
             </a:r>
           </a:p>
         </p:txBody>
@@ -4345,7 +4286,7 @@
             <a:avLst/>
           </a:prstGeom>
           <a:solidFill>
-            <a:srgbClr val="1D3557"/>
+            <a:srgbClr val="FAFBFC"/>
           </a:solidFill>
           <a:ln>
             <a:noFill/>
@@ -4382,8 +4323,8 @@
         </p:nvSpPr>
         <p:spPr>
           <a:xfrm>
-            <a:off x="603504" y="1847088"/>
-            <a:ext cx="7946136" cy="1399032"/>
+            <a:off x="402336" y="301752"/>
+            <a:ext cx="8348472" cy="795528"/>
           </a:xfrm>
           <a:prstGeom prst="rect">
             <a:avLst/>
@@ -4397,24 +4338,260 @@
           <a:lstStyle/>
           <a:p>
             <a:r>
-              <a:rPr sz="3400" b="1">
-                <a:solidFill>
-                  <a:srgbClr val="FFFFFF"/>
-                </a:solidFill>
-                <a:latin typeface="Fira Sans"/>
-              </a:rPr>
-              <a:t>Los datos</a:t>
-            </a:r>
-          </a:p>
-          <a:p>
+              <a:rPr sz="2800" b="1">
+                <a:solidFill>
+                  <a:srgbClr val="0F0F0F"/>
+                </a:solidFill>
+                <a:latin typeface="Fira Sans"/>
+              </a:rPr>
+              <a:t>El análisis exploratorio de datos</a:t>
+            </a:r>
+          </a:p>
+        </p:txBody>
+      </p:sp>
+      <p:sp>
+        <p:nvSpPr>
+          <p:cNvPr id="4" name="TextBox 3"/>
+          <p:cNvSpPr txBox="1"/>
+          <p:nvPr/>
+        </p:nvSpPr>
+        <p:spPr>
+          <a:xfrm>
+            <a:off x="704088" y="1353312"/>
+            <a:ext cx="7744968" cy="3300984"/>
+          </a:xfrm>
+          <a:prstGeom prst="rect">
+            <a:avLst/>
+          </a:prstGeom>
+          <a:noFill/>
+        </p:spPr>
+        <p:txBody>
+          <a:bodyPr wrap="square">
+            <a:spAutoFit/>
+          </a:bodyPr>
+          <a:lstStyle/>
+          <a:p>
+            <a:pPr>
+              <a:lnSpc>
+                <a:spcPct val="112000"/>
+              </a:lnSpc>
+              <a:spcAft>
+                <a:spcPts val="900"/>
+              </a:spcAft>
+            </a:pPr>
+            <a:r>
+              <a:rPr sz="1800" b="1">
+                <a:solidFill>
+                  <a:srgbClr val="E0A437"/>
+                </a:solidFill>
+                <a:latin typeface="Fira Sans"/>
+              </a:rPr>
+              <a:t>▸ </a:t>
+            </a:r>
             <a:r>
               <a:rPr sz="1800" b="0">
                 <a:solidFill>
+                  <a:srgbClr val="000000"/>
+                </a:solidFill>
+                <a:latin typeface="Fira Sans"/>
+              </a:rPr>
+              <a:t>La etapa en que se examinan los datos antes de modelarlos (Tukey, 1977).</a:t>
+            </a:r>
+          </a:p>
+          <a:p>
+            <a:pPr>
+              <a:lnSpc>
+                <a:spcPct val="112000"/>
+              </a:lnSpc>
+              <a:spcAft>
+                <a:spcPts val="900"/>
+              </a:spcAft>
+            </a:pPr>
+            <a:r>
+              <a:rPr sz="1800" b="1">
+                <a:solidFill>
                   <a:srgbClr val="E0A437"/>
                 </a:solidFill>
                 <a:latin typeface="Fira Sans"/>
               </a:rPr>
-              <a:t>Encuesta Origen Destino de Santiago 2012</a:t>
+              <a:t>▸ </a:t>
+            </a:r>
+            <a:r>
+              <a:rPr sz="1800" b="0">
+                <a:solidFill>
+                  <a:srgbClr val="000000"/>
+                </a:solidFill>
+                <a:latin typeface="Fira Sans"/>
+              </a:rPr>
+              <a:t>Responde cuatro tipos de pregunta:</a:t>
+            </a:r>
+          </a:p>
+          <a:p>
+            <a:pPr>
+              <a:lnSpc>
+                <a:spcPct val="112000"/>
+              </a:lnSpc>
+              <a:spcAft>
+                <a:spcPts val="500"/>
+              </a:spcAft>
+            </a:pPr>
+            <a:r>
+              <a:rPr sz="1400" b="0">
+                <a:solidFill>
+                  <a:srgbClr val="333333"/>
+                </a:solidFill>
+                <a:latin typeface="Fira Sans"/>
+              </a:rPr>
+              <a:t>     ◦  </a:t>
+            </a:r>
+            <a:r>
+              <a:rPr sz="1400" b="0">
+                <a:solidFill>
+                  <a:srgbClr val="333333"/>
+                </a:solidFill>
+                <a:latin typeface="Fira Sans"/>
+              </a:rPr>
+              <a:t>La forma: cómo se distribuye cada variable.</a:t>
+            </a:r>
+          </a:p>
+          <a:p>
+            <a:pPr>
+              <a:lnSpc>
+                <a:spcPct val="112000"/>
+              </a:lnSpc>
+              <a:spcAft>
+                <a:spcPts val="500"/>
+              </a:spcAft>
+            </a:pPr>
+            <a:r>
+              <a:rPr sz="1400" b="0">
+                <a:solidFill>
+                  <a:srgbClr val="333333"/>
+                </a:solidFill>
+                <a:latin typeface="Fira Sans"/>
+              </a:rPr>
+              <a:t>     ◦  </a:t>
+            </a:r>
+            <a:r>
+              <a:rPr sz="1400" b="0">
+                <a:solidFill>
+                  <a:srgbClr val="333333"/>
+                </a:solidFill>
+                <a:latin typeface="Fira Sans"/>
+              </a:rPr>
+              <a:t>Lo típico y lo extremo: qué es frecuente y qué es anómalo.</a:t>
+            </a:r>
+          </a:p>
+          <a:p>
+            <a:pPr>
+              <a:lnSpc>
+                <a:spcPct val="112000"/>
+              </a:lnSpc>
+              <a:spcAft>
+                <a:spcPts val="500"/>
+              </a:spcAft>
+            </a:pPr>
+            <a:r>
+              <a:rPr sz="1400" b="0">
+                <a:solidFill>
+                  <a:srgbClr val="333333"/>
+                </a:solidFill>
+                <a:latin typeface="Fira Sans"/>
+              </a:rPr>
+              <a:t>     ◦  </a:t>
+            </a:r>
+            <a:r>
+              <a:rPr sz="1400" b="0">
+                <a:solidFill>
+                  <a:srgbClr val="333333"/>
+                </a:solidFill>
+                <a:latin typeface="Fira Sans"/>
+              </a:rPr>
+              <a:t>Lo que falta: qué datos están ausentes y con qué patrón.</a:t>
+            </a:r>
+          </a:p>
+          <a:p>
+            <a:pPr>
+              <a:lnSpc>
+                <a:spcPct val="112000"/>
+              </a:lnSpc>
+              <a:spcAft>
+                <a:spcPts val="500"/>
+              </a:spcAft>
+            </a:pPr>
+            <a:r>
+              <a:rPr sz="1400" b="0">
+                <a:solidFill>
+                  <a:srgbClr val="333333"/>
+                </a:solidFill>
+                <a:latin typeface="Fira Sans"/>
+              </a:rPr>
+              <a:t>     ◦  </a:t>
+            </a:r>
+            <a:r>
+              <a:rPr sz="1400" b="0">
+                <a:solidFill>
+                  <a:srgbClr val="333333"/>
+                </a:solidFill>
+                <a:latin typeface="Fira Sans"/>
+              </a:rPr>
+              <a:t>Las relaciones: qué variables se asocian con qué otras.</a:t>
+            </a:r>
+          </a:p>
+          <a:p>
+            <a:pPr>
+              <a:lnSpc>
+                <a:spcPct val="112000"/>
+              </a:lnSpc>
+              <a:spcAft>
+                <a:spcPts val="900"/>
+              </a:spcAft>
+            </a:pPr>
+            <a:r>
+              <a:rPr sz="1800" b="1">
+                <a:solidFill>
+                  <a:srgbClr val="E0A437"/>
+                </a:solidFill>
+                <a:latin typeface="Fira Sans"/>
+              </a:rPr>
+              <a:t>▸ </a:t>
+            </a:r>
+            <a:r>
+              <a:rPr sz="1800" b="0">
+                <a:solidFill>
+                  <a:srgbClr val="000000"/>
+                </a:solidFill>
+                <a:latin typeface="Fira Sans"/>
+              </a:rPr>
+              <a:t>Genera hipótesis; el análisis confirmatorio (unidad 5) las pone a prueba.</a:t>
+            </a:r>
+          </a:p>
+          <a:p>
+            <a:pPr>
+              <a:lnSpc>
+                <a:spcPct val="112000"/>
+              </a:lnSpc>
+              <a:spcAft>
+                <a:spcPts val="900"/>
+              </a:spcAft>
+            </a:pPr>
+            <a:r>
+              <a:rPr sz="1800" b="1">
+                <a:solidFill>
+                  <a:srgbClr val="E0A437"/>
+                </a:solidFill>
+                <a:latin typeface="Fira Sans"/>
+              </a:rPr>
+              <a:t>▸ </a:t>
+            </a:r>
+            <a:r>
+              <a:rPr sz="1800" b="1">
+                <a:solidFill>
+                  <a:srgbClr val="1D3557"/>
+                </a:solidFill>
+                <a:latin typeface="Fira Sans"/>
+              </a:rPr>
+              <a:t>Una pregunta transversal para toda cifra resumen: ¿de quién habla este número? ¿De la muestra, de un subgrupo, de la ciudad?</a:t>
             </a:r>
           </a:p>
         </p:txBody>
@@ -4452,7 +4629,7 @@
             <a:avLst/>
           </a:prstGeom>
           <a:solidFill>
-            <a:srgbClr val="FAFBFC"/>
+            <a:srgbClr val="1D3557"/>
           </a:solidFill>
           <a:ln>
             <a:noFill/>
@@ -4489,8 +4666,8 @@
         </p:nvSpPr>
         <p:spPr>
           <a:xfrm>
-            <a:off x="402336" y="301752"/>
-            <a:ext cx="8348472" cy="795528"/>
+            <a:off x="603504" y="1847088"/>
+            <a:ext cx="7946136" cy="1399032"/>
           </a:xfrm>
           <a:prstGeom prst="rect">
             <a:avLst/>
@@ -4504,176 +4681,24 @@
           <a:lstStyle/>
           <a:p>
             <a:r>
-              <a:rPr sz="2800" b="1">
-                <a:solidFill>
-                  <a:srgbClr val="0F0F0F"/>
-                </a:solidFill>
-                <a:latin typeface="Fira Sans"/>
-              </a:rPr>
-              <a:t>La EOD 2012</a:t>
-            </a:r>
-          </a:p>
-        </p:txBody>
-      </p:sp>
-      <p:sp>
-        <p:nvSpPr>
-          <p:cNvPr id="4" name="TextBox 3"/>
-          <p:cNvSpPr txBox="1"/>
-          <p:nvPr/>
-        </p:nvSpPr>
-        <p:spPr>
-          <a:xfrm>
-            <a:off x="704088" y="1353312"/>
-            <a:ext cx="7744968" cy="3300984"/>
-          </a:xfrm>
-          <a:prstGeom prst="rect">
-            <a:avLst/>
-          </a:prstGeom>
-          <a:noFill/>
-        </p:spPr>
-        <p:txBody>
-          <a:bodyPr wrap="square">
-            <a:spAutoFit/>
-          </a:bodyPr>
-          <a:lstStyle/>
-          <a:p>
-            <a:pPr>
-              <a:lnSpc>
-                <a:spcPct val="112000"/>
-              </a:lnSpc>
-              <a:spcAft>
-                <a:spcPts val="900"/>
-              </a:spcAft>
-            </a:pPr>
-            <a:r>
-              <a:rPr sz="1800" b="1">
+              <a:rPr sz="3400" b="1">
+                <a:solidFill>
+                  <a:srgbClr val="FFFFFF"/>
+                </a:solidFill>
+                <a:latin typeface="Fira Sans"/>
+              </a:rPr>
+              <a:t>Los datos</a:t>
+            </a:r>
+          </a:p>
+          <a:p>
+            <a:r>
+              <a:rPr sz="1800" b="0">
                 <a:solidFill>
                   <a:srgbClr val="E0A437"/>
                 </a:solidFill>
                 <a:latin typeface="Fira Sans"/>
               </a:rPr>
-              <a:t>▸ </a:t>
-            </a:r>
-            <a:r>
-              <a:rPr sz="1800" b="0">
-                <a:solidFill>
-                  <a:srgbClr val="000000"/>
-                </a:solidFill>
-                <a:latin typeface="Fira Sans"/>
-              </a:rPr>
-              <a:t>Encuesta de movilidad del Gran Santiago (SECTRA y U. Alberto Hurtado).</a:t>
-            </a:r>
-          </a:p>
-          <a:p>
-            <a:pPr>
-              <a:lnSpc>
-                <a:spcPct val="112000"/>
-              </a:lnSpc>
-              <a:spcAft>
-                <a:spcPts val="900"/>
-              </a:spcAft>
-            </a:pPr>
-            <a:r>
-              <a:rPr sz="1800" b="1">
-                <a:solidFill>
-                  <a:srgbClr val="E0A437"/>
-                </a:solidFill>
-                <a:latin typeface="Fira Sans"/>
-              </a:rPr>
-              <a:t>▸ </a:t>
-            </a:r>
-            <a:r>
-              <a:rPr sz="1800" b="0">
-                <a:solidFill>
-                  <a:srgbClr val="000000"/>
-                </a:solidFill>
-                <a:latin typeface="Fira Sans"/>
-              </a:rPr>
-              <a:t>Registra todos los viajes de un día de los hogares encuestados.</a:t>
-            </a:r>
-          </a:p>
-          <a:p>
-            <a:pPr>
-              <a:lnSpc>
-                <a:spcPct val="112000"/>
-              </a:lnSpc>
-              <a:spcAft>
-                <a:spcPts val="500"/>
-              </a:spcAft>
-            </a:pPr>
-            <a:r>
-              <a:rPr sz="1400" b="0">
-                <a:solidFill>
-                  <a:srgbClr val="333333"/>
-                </a:solidFill>
-                <a:latin typeface="Fira Sans"/>
-              </a:rPr>
-              <a:t>     ◦  </a:t>
-            </a:r>
-            <a:r>
-              <a:rPr sz="1400" b="0">
-                <a:solidFill>
-                  <a:srgbClr val="333333"/>
-                </a:solidFill>
-                <a:latin typeface="Fira Sans"/>
-              </a:rPr>
-              <a:t>18.264 hogares, 60.054 personas, 113.591 viajes.</a:t>
-            </a:r>
-          </a:p>
-          <a:p>
-            <a:pPr>
-              <a:lnSpc>
-                <a:spcPct val="112000"/>
-              </a:lnSpc>
-              <a:spcAft>
-                <a:spcPts val="500"/>
-              </a:spcAft>
-            </a:pPr>
-            <a:r>
-              <a:rPr sz="1400" b="0">
-                <a:solidFill>
-                  <a:srgbClr val="333333"/>
-                </a:solidFill>
-                <a:latin typeface="Fira Sans"/>
-              </a:rPr>
-              <a:t>     ◦  </a:t>
-            </a:r>
-            <a:r>
-              <a:rPr sz="1400" b="0">
-                <a:solidFill>
-                  <a:srgbClr val="333333"/>
-                </a:solidFill>
-                <a:latin typeface="Fira Sans"/>
-              </a:rPr>
-              <a:t>Se usa en la planificación de transporte de la ciudad.</a:t>
-            </a:r>
-          </a:p>
-          <a:p>
-            <a:pPr>
-              <a:lnSpc>
-                <a:spcPct val="112000"/>
-              </a:lnSpc>
-              <a:spcAft>
-                <a:spcPts val="900"/>
-              </a:spcAft>
-            </a:pPr>
-            <a:r>
-              <a:rPr sz="1800" b="1">
-                <a:solidFill>
-                  <a:srgbClr val="E0A437"/>
-                </a:solidFill>
-                <a:latin typeface="Fira Sans"/>
-              </a:rPr>
-              <a:t>▸ </a:t>
-            </a:r>
-            <a:r>
-              <a:rPr sz="1800" b="1">
-                <a:solidFill>
-                  <a:srgbClr val="1D3557"/>
-                </a:solidFill>
-                <a:latin typeface="Fira Sans"/>
-              </a:rPr>
-              <a:t>El mismo diseño relacional de la Casen, el Censo o la ENUSC.</a:t>
+              <a:t>Encuesta Origen Destino de Santiago 2012</a:t>
             </a:r>
           </a:p>
         </p:txBody>
@@ -4769,45 +4794,21 @@
                 </a:solidFill>
                 <a:latin typeface="Fira Sans"/>
               </a:rPr>
-              <a:t>Una encuesta, varias tablas</a:t>
-            </a:r>
-          </a:p>
-        </p:txBody>
-      </p:sp>
-      <p:pic>
-        <p:nvPicPr>
-          <p:cNvPr id="4" name="Picture 3" descr="05_diagrama_tablas.png"/>
-          <p:cNvPicPr>
-            <a:picLocks noChangeAspect="1"/>
-          </p:cNvPicPr>
-          <p:nvPr/>
-        </p:nvPicPr>
-        <p:blipFill>
-          <a:blip r:embed="rId2"/>
-          <a:stretch>
-            <a:fillRect/>
-          </a:stretch>
-        </p:blipFill>
-        <p:spPr>
-          <a:xfrm>
-            <a:off x="1553651" y="1143000"/>
-            <a:ext cx="6036697" cy="3154680"/>
-          </a:xfrm>
-          <a:prstGeom prst="rect">
-            <a:avLst/>
-          </a:prstGeom>
-        </p:spPr>
-      </p:pic>
-      <p:sp>
-        <p:nvSpPr>
-          <p:cNvPr id="5" name="TextBox 4"/>
+              <a:t>La EOD 2012</a:t>
+            </a:r>
+          </a:p>
+        </p:txBody>
+      </p:sp>
+      <p:sp>
+        <p:nvSpPr>
+          <p:cNvPr id="4" name="TextBox 3"/>
           <p:cNvSpPr txBox="1"/>
           <p:nvPr/>
         </p:nvSpPr>
         <p:spPr>
           <a:xfrm>
-            <a:off x="704088" y="4434840"/>
-            <a:ext cx="7744968" cy="457200"/>
+            <a:off x="704088" y="1353312"/>
+            <a:ext cx="7744968" cy="3300984"/>
           </a:xfrm>
           <a:prstGeom prst="rect">
             <a:avLst/>
@@ -4820,14 +4821,143 @@
           </a:bodyPr>
           <a:lstStyle/>
           <a:p>
-            <a:r>
-              <a:rPr sz="1300" b="0">
+            <a:pPr>
+              <a:lnSpc>
+                <a:spcPct val="112000"/>
+              </a:lnSpc>
+              <a:spcAft>
+                <a:spcPts val="900"/>
+              </a:spcAft>
+            </a:pPr>
+            <a:r>
+              <a:rPr sz="1800" b="1">
+                <a:solidFill>
+                  <a:srgbClr val="E0A437"/>
+                </a:solidFill>
+                <a:latin typeface="Fira Sans"/>
+              </a:rPr>
+              <a:t>▸ </a:t>
+            </a:r>
+            <a:r>
+              <a:rPr sz="1800" b="0">
+                <a:solidFill>
+                  <a:srgbClr val="000000"/>
+                </a:solidFill>
+                <a:latin typeface="Fira Sans"/>
+              </a:rPr>
+              <a:t>Encuesta de movilidad del Gran Santiago (SECTRA y U. Alberto Hurtado).</a:t>
+            </a:r>
+          </a:p>
+          <a:p>
+            <a:pPr>
+              <a:lnSpc>
+                <a:spcPct val="112000"/>
+              </a:lnSpc>
+              <a:spcAft>
+                <a:spcPts val="900"/>
+              </a:spcAft>
+            </a:pPr>
+            <a:r>
+              <a:rPr sz="1800" b="1">
+                <a:solidFill>
+                  <a:srgbClr val="E0A437"/>
+                </a:solidFill>
+                <a:latin typeface="Fira Sans"/>
+              </a:rPr>
+              <a:t>▸ </a:t>
+            </a:r>
+            <a:r>
+              <a:rPr sz="1800" b="0">
+                <a:solidFill>
+                  <a:srgbClr val="000000"/>
+                </a:solidFill>
+                <a:latin typeface="Fira Sans"/>
+              </a:rPr>
+              <a:t>Registra todos los viajes de un día de los hogares encuestados.</a:t>
+            </a:r>
+          </a:p>
+          <a:p>
+            <a:pPr>
+              <a:lnSpc>
+                <a:spcPct val="112000"/>
+              </a:lnSpc>
+              <a:spcAft>
+                <a:spcPts val="500"/>
+              </a:spcAft>
+            </a:pPr>
+            <a:r>
+              <a:rPr sz="1400" b="0">
                 <a:solidFill>
                   <a:srgbClr val="333333"/>
                 </a:solidFill>
                 <a:latin typeface="Fira Sans"/>
               </a:rPr>
-              <a:t>Los códigos no significan nada sin sus tablas de parámetros: unirlas es parte del análisis.</a:t>
+              <a:t>     ◦  </a:t>
+            </a:r>
+            <a:r>
+              <a:rPr sz="1400" b="0">
+                <a:solidFill>
+                  <a:srgbClr val="333333"/>
+                </a:solidFill>
+                <a:latin typeface="Fira Sans"/>
+              </a:rPr>
+              <a:t>18.264 hogares, 60.054 personas, 113.591 viajes.</a:t>
+            </a:r>
+          </a:p>
+          <a:p>
+            <a:pPr>
+              <a:lnSpc>
+                <a:spcPct val="112000"/>
+              </a:lnSpc>
+              <a:spcAft>
+                <a:spcPts val="500"/>
+              </a:spcAft>
+            </a:pPr>
+            <a:r>
+              <a:rPr sz="1400" b="0">
+                <a:solidFill>
+                  <a:srgbClr val="333333"/>
+                </a:solidFill>
+                <a:latin typeface="Fira Sans"/>
+              </a:rPr>
+              <a:t>     ◦  </a:t>
+            </a:r>
+            <a:r>
+              <a:rPr sz="1400" b="0">
+                <a:solidFill>
+                  <a:srgbClr val="333333"/>
+                </a:solidFill>
+                <a:latin typeface="Fira Sans"/>
+              </a:rPr>
+              <a:t>Se usa en la planificación de transporte de la ciudad.</a:t>
+            </a:r>
+          </a:p>
+          <a:p>
+            <a:pPr>
+              <a:lnSpc>
+                <a:spcPct val="112000"/>
+              </a:lnSpc>
+              <a:spcAft>
+                <a:spcPts val="900"/>
+              </a:spcAft>
+            </a:pPr>
+            <a:r>
+              <a:rPr sz="1800" b="1">
+                <a:solidFill>
+                  <a:srgbClr val="E0A437"/>
+                </a:solidFill>
+                <a:latin typeface="Fira Sans"/>
+              </a:rPr>
+              <a:t>▸ </a:t>
+            </a:r>
+            <a:r>
+              <a:rPr sz="1800" b="1">
+                <a:solidFill>
+                  <a:srgbClr val="1D3557"/>
+                </a:solidFill>
+                <a:latin typeface="Fira Sans"/>
+              </a:rPr>
+              <a:t>El mismo diseño relacional de la Casen, el Censo o la ENUSC.</a:t>
             </a:r>
           </a:p>
         </p:txBody>
@@ -4865,7 +4995,7 @@
             <a:avLst/>
           </a:prstGeom>
           <a:solidFill>
-            <a:srgbClr val="1D3557"/>
+            <a:srgbClr val="FAFBFC"/>
           </a:solidFill>
           <a:ln>
             <a:noFill/>
@@ -4902,8 +5032,8 @@
         </p:nvSpPr>
         <p:spPr>
           <a:xfrm>
-            <a:off x="603504" y="1847088"/>
-            <a:ext cx="7946136" cy="1399032"/>
+            <a:off x="402336" y="301752"/>
+            <a:ext cx="8348472" cy="795528"/>
           </a:xfrm>
           <a:prstGeom prst="rect">
             <a:avLst/>
@@ -4917,24 +5047,71 @@
           <a:lstStyle/>
           <a:p>
             <a:r>
-              <a:rPr sz="3400" b="1">
-                <a:solidFill>
-                  <a:srgbClr val="FFFFFF"/>
-                </a:solidFill>
-                <a:latin typeface="Fira Sans"/>
-              </a:rPr>
-              <a:t>Repaso de Pandas</a:t>
-            </a:r>
-          </a:p>
-          <a:p>
-            <a:r>
-              <a:rPr sz="1800" b="0">
-                <a:solidFill>
-                  <a:srgbClr val="E0A437"/>
-                </a:solidFill>
-                <a:latin typeface="Fira Sans"/>
-              </a:rPr>
-              <a:t>Dos casos concretos con la EOD</a:t>
+              <a:rPr sz="2800" b="1">
+                <a:solidFill>
+                  <a:srgbClr val="0F0F0F"/>
+                </a:solidFill>
+                <a:latin typeface="Fira Sans"/>
+              </a:rPr>
+              <a:t>Una encuesta, varias tablas</a:t>
+            </a:r>
+          </a:p>
+        </p:txBody>
+      </p:sp>
+      <p:pic>
+        <p:nvPicPr>
+          <p:cNvPr id="4" name="Picture 3" descr="05_diagrama_tablas.png"/>
+          <p:cNvPicPr>
+            <a:picLocks noChangeAspect="1"/>
+          </p:cNvPicPr>
+          <p:nvPr/>
+        </p:nvPicPr>
+        <p:blipFill>
+          <a:blip r:embed="rId2"/>
+          <a:stretch>
+            <a:fillRect/>
+          </a:stretch>
+        </p:blipFill>
+        <p:spPr>
+          <a:xfrm>
+            <a:off x="1553651" y="1143000"/>
+            <a:ext cx="6036697" cy="3154680"/>
+          </a:xfrm>
+          <a:prstGeom prst="rect">
+            <a:avLst/>
+          </a:prstGeom>
+        </p:spPr>
+      </p:pic>
+      <p:sp>
+        <p:nvSpPr>
+          <p:cNvPr id="5" name="TextBox 4"/>
+          <p:cNvSpPr txBox="1"/>
+          <p:nvPr/>
+        </p:nvSpPr>
+        <p:spPr>
+          <a:xfrm>
+            <a:off x="704088" y="4434840"/>
+            <a:ext cx="7744968" cy="457200"/>
+          </a:xfrm>
+          <a:prstGeom prst="rect">
+            <a:avLst/>
+          </a:prstGeom>
+          <a:noFill/>
+        </p:spPr>
+        <p:txBody>
+          <a:bodyPr wrap="square">
+            <a:spAutoFit/>
+          </a:bodyPr>
+          <a:lstStyle/>
+          <a:p>
+            <a:r>
+              <a:rPr sz="1300" b="0">
+                <a:solidFill>
+                  <a:srgbClr val="333333"/>
+                </a:solidFill>
+                <a:latin typeface="Fira Sans"/>
+              </a:rPr>
+              <a:t>Los códigos no significan nada sin sus tablas de parámetros: unirlas es parte del análisis.</a:t>
             </a:r>
           </a:p>
         </p:txBody>
@@ -4972,7 +5149,7 @@
             <a:avLst/>
           </a:prstGeom>
           <a:solidFill>
-            <a:srgbClr val="FAFBFC"/>
+            <a:srgbClr val="1D3557"/>
           </a:solidFill>
           <a:ln>
             <a:noFill/>
@@ -5009,8 +5186,8 @@
         </p:nvSpPr>
         <p:spPr>
           <a:xfrm>
-            <a:off x="402336" y="301752"/>
-            <a:ext cx="8348472" cy="795528"/>
+            <a:off x="603504" y="1847088"/>
+            <a:ext cx="7946136" cy="1399032"/>
           </a:xfrm>
           <a:prstGeom prst="rect">
             <a:avLst/>
@@ -5024,155 +5201,24 @@
           <a:lstStyle/>
           <a:p>
             <a:r>
-              <a:rPr sz="2800" b="1">
-                <a:solidFill>
-                  <a:srgbClr val="0F0F0F"/>
-                </a:solidFill>
-                <a:latin typeface="Fira Sans"/>
-              </a:rPr>
-              <a:t>Abrir el dataset</a:t>
-            </a:r>
-          </a:p>
-        </p:txBody>
-      </p:sp>
-      <p:sp>
-        <p:nvSpPr>
-          <p:cNvPr id="4" name="Rectangle 3"/>
-          <p:cNvSpPr/>
-          <p:nvPr/>
-        </p:nvSpPr>
-        <p:spPr>
-          <a:xfrm>
-            <a:off x="704088" y="1280160"/>
-            <a:ext cx="7744968" cy="2377440"/>
-          </a:xfrm>
-          <a:prstGeom prst="rect">
-            <a:avLst/>
-          </a:prstGeom>
-          <a:solidFill>
-            <a:srgbClr val="F0F2F5"/>
-          </a:solidFill>
-          <a:ln>
-            <a:solidFill>
-              <a:srgbClr val="D8DDE3"/>
-            </a:solidFill>
-          </a:ln>
-          <a:effectLst/>
-        </p:spPr>
-        <p:style>
-          <a:lnRef idx="1">
-            <a:schemeClr val="accent1"/>
-          </a:lnRef>
-          <a:fillRef idx="3">
-            <a:schemeClr val="accent1"/>
-          </a:fillRef>
-          <a:effectRef idx="2">
-            <a:schemeClr val="accent1"/>
-          </a:effectRef>
-          <a:fontRef idx="minor">
-            <a:schemeClr val="lt1"/>
-          </a:fontRef>
-        </p:style>
-        <p:txBody>
-          <a:bodyPr rtlCol="0" anchor="ctr" wrap="square" lIns="228600" tIns="137160"/>
-          <a:lstStyle/>
-          <a:p>
-            <a:pPr/>
-            <a:r>
-              <a:rPr sz="1500" b="0">
-                <a:solidFill>
-                  <a:srgbClr val="1D3557"/>
-                </a:solidFill>
-                <a:latin typeface="Menlo"/>
-              </a:rPr>
-              <a:t>import pandas as pd</a:t>
-            </a:r>
-          </a:p>
-          <a:p>
-            <a:pPr/>
-            <a:r>
-              <a:rPr sz="1500" b="0">
-                <a:solidFill>
-                  <a:srgbClr val="1D3557"/>
-                </a:solidFill>
-                <a:latin typeface="Menlo"/>
-              </a:rPr>
-              <a:t/>
-            </a:r>
-          </a:p>
-          <a:p>
-            <a:pPr/>
-            <a:r>
-              <a:rPr sz="1500" b="0">
-                <a:solidFill>
-                  <a:srgbClr val="1D3557"/>
-                </a:solidFill>
-                <a:latin typeface="Menlo"/>
-              </a:rPr>
-              <a:t>viajes = pd.read_csv('datos/eod_stgo/viajes.csv',</a:t>
-            </a:r>
-          </a:p>
-          <a:p>
-            <a:pPr/>
-            <a:r>
-              <a:rPr sz="1500" b="0">
-                <a:solidFill>
-                  <a:srgbClr val="1D3557"/>
-                </a:solidFill>
-                <a:latin typeface="Menlo"/>
-              </a:rPr>
-              <a:t>                     sep=';', decimal=',')</a:t>
-            </a:r>
-          </a:p>
-        </p:txBody>
-      </p:sp>
-      <p:sp>
-        <p:nvSpPr>
-          <p:cNvPr id="5" name="TextBox 4"/>
-          <p:cNvSpPr txBox="1"/>
-          <p:nvPr/>
-        </p:nvSpPr>
-        <p:spPr>
-          <a:xfrm>
-            <a:off x="704088" y="3886200"/>
-            <a:ext cx="7744968" cy="1097280"/>
-          </a:xfrm>
-          <a:prstGeom prst="rect">
-            <a:avLst/>
-          </a:prstGeom>
-          <a:noFill/>
-        </p:spPr>
-        <p:txBody>
-          <a:bodyPr wrap="square">
-            <a:spAutoFit/>
-          </a:bodyPr>
-          <a:lstStyle/>
-          <a:p>
-            <a:pPr>
-              <a:lnSpc>
-                <a:spcPct val="112000"/>
-              </a:lnSpc>
-              <a:spcAft>
-                <a:spcPts val="900"/>
-              </a:spcAft>
-            </a:pPr>
-            <a:r>
-              <a:rPr sz="1600" b="1">
+              <a:rPr sz="3400" b="1">
+                <a:solidFill>
+                  <a:srgbClr val="FFFFFF"/>
+                </a:solidFill>
+                <a:latin typeface="Fira Sans"/>
+              </a:rPr>
+              <a:t>Repaso de Pandas</a:t>
+            </a:r>
+          </a:p>
+          <a:p>
+            <a:r>
+              <a:rPr sz="1800" b="0">
                 <a:solidFill>
                   <a:srgbClr val="E0A437"/>
                 </a:solidFill>
                 <a:latin typeface="Fira Sans"/>
               </a:rPr>
-              <a:t>▸ </a:t>
-            </a:r>
-            <a:r>
-              <a:rPr sz="1600" b="0">
-                <a:solidFill>
-                  <a:srgbClr val="000000"/>
-                </a:solidFill>
-                <a:latin typeface="Fira Sans"/>
-              </a:rPr>
-              <a:t>Todo el código de la clase está en el notebook 02_pandas_eda.ipynb del repositorio.</a:t>
+              <a:t>Dos casos concretos con la EOD</a:t>
             </a:r>
           </a:p>
         </p:txBody>
@@ -5268,35 +5314,102 @@
                 </a:solidFill>
                 <a:latin typeface="Fira Sans"/>
               </a:rPr>
-              <a:t>El DataFrame: la estructura central de Pandas</a:t>
-            </a:r>
-          </a:p>
-        </p:txBody>
-      </p:sp>
-      <p:pic>
-        <p:nvPicPr>
-          <p:cNvPr id="4" name="Picture 3" descr="13_dataframe.png"/>
-          <p:cNvPicPr>
-            <a:picLocks noChangeAspect="1"/>
-          </p:cNvPicPr>
-          <p:nvPr/>
-        </p:nvPicPr>
-        <p:blipFill>
-          <a:blip r:embed="rId2"/>
-          <a:stretch>
-            <a:fillRect/>
-          </a:stretch>
-        </p:blipFill>
-        <p:spPr>
-          <a:xfrm>
-            <a:off x="1417319" y="1143000"/>
-            <a:ext cx="6309360" cy="2553789"/>
-          </a:xfrm>
-          <a:prstGeom prst="rect">
-            <a:avLst/>
-          </a:prstGeom>
-        </p:spPr>
-      </p:pic>
+              <a:t>Abrir el dataset</a:t>
+            </a:r>
+          </a:p>
+        </p:txBody>
+      </p:sp>
+      <p:sp>
+        <p:nvSpPr>
+          <p:cNvPr id="4" name="Rectangle 3"/>
+          <p:cNvSpPr/>
+          <p:nvPr/>
+        </p:nvSpPr>
+        <p:spPr>
+          <a:xfrm>
+            <a:off x="704088" y="1280160"/>
+            <a:ext cx="7744968" cy="2377440"/>
+          </a:xfrm>
+          <a:prstGeom prst="rect">
+            <a:avLst/>
+          </a:prstGeom>
+          <a:solidFill>
+            <a:srgbClr val="F0F2F5"/>
+          </a:solidFill>
+          <a:ln>
+            <a:solidFill>
+              <a:srgbClr val="D8DDE3"/>
+            </a:solidFill>
+          </a:ln>
+          <a:effectLst/>
+        </p:spPr>
+        <p:style>
+          <a:lnRef idx="1">
+            <a:schemeClr val="accent1"/>
+          </a:lnRef>
+          <a:fillRef idx="3">
+            <a:schemeClr val="accent1"/>
+          </a:fillRef>
+          <a:effectRef idx="2">
+            <a:schemeClr val="accent1"/>
+          </a:effectRef>
+          <a:fontRef idx="minor">
+            <a:schemeClr val="lt1"/>
+          </a:fontRef>
+        </p:style>
+        <p:txBody>
+          <a:bodyPr rtlCol="0" anchor="ctr" wrap="square" lIns="228600" tIns="137160"/>
+          <a:lstStyle/>
+          <a:p>
+            <a:pPr/>
+            <a:r>
+              <a:rPr sz="1500" b="0">
+                <a:solidFill>
+                  <a:srgbClr val="1D3557"/>
+                </a:solidFill>
+                <a:latin typeface="Menlo"/>
+              </a:rPr>
+              <a:t>import pandas as pd</a:t>
+            </a:r>
+          </a:p>
+          <a:p>
+            <a:pPr/>
+            <a:r>
+              <a:rPr sz="1500" b="0">
+                <a:solidFill>
+                  <a:srgbClr val="1D3557"/>
+                </a:solidFill>
+                <a:latin typeface="Menlo"/>
+              </a:rPr>
+              <a:t/>
+            </a:r>
+          </a:p>
+          <a:p>
+            <a:pPr/>
+            <a:r>
+              <a:rPr sz="1500" b="0">
+                <a:solidFill>
+                  <a:srgbClr val="1D3557"/>
+                </a:solidFill>
+                <a:latin typeface="Menlo"/>
+              </a:rPr>
+              <a:t>viajes = pd.read_csv('datos/eod_stgo/viajes.csv',</a:t>
+            </a:r>
+          </a:p>
+          <a:p>
+            <a:pPr/>
+            <a:r>
+              <a:rPr sz="1500" b="0">
+                <a:solidFill>
+                  <a:srgbClr val="1D3557"/>
+                </a:solidFill>
+                <a:latin typeface="Menlo"/>
+              </a:rPr>
+              <a:t>                     sep=';', decimal=',')</a:t>
+            </a:r>
+          </a:p>
+        </p:txBody>
+      </p:sp>
       <p:sp>
         <p:nvSpPr>
           <p:cNvPr id="5" name="TextBox 4"/>
@@ -5305,8 +5418,8 @@
         </p:nvSpPr>
         <p:spPr>
           <a:xfrm>
-            <a:off x="704088" y="4434840"/>
-            <a:ext cx="7744968" cy="457200"/>
+            <a:off x="704088" y="3886200"/>
+            <a:ext cx="7744968" cy="1097280"/>
           </a:xfrm>
           <a:prstGeom prst="rect">
             <a:avLst/>
@@ -5319,14 +5432,31 @@
           </a:bodyPr>
           <a:lstStyle/>
           <a:p>
-            <a:r>
-              <a:rPr sz="1300" b="0">
-                <a:solidFill>
-                  <a:srgbClr val="333333"/>
-                </a:solidFill>
-                <a:latin typeface="Fira Sans"/>
-              </a:rPr>
-              <a:t>Una tabla con filas indexadas y columnas con nombre y tipo. Los códigos (comuna, propósito) se traducen con las tablas de parámetros, uniéndolas con merge.</a:t>
+            <a:pPr>
+              <a:lnSpc>
+                <a:spcPct val="112000"/>
+              </a:lnSpc>
+              <a:spcAft>
+                <a:spcPts val="900"/>
+              </a:spcAft>
+            </a:pPr>
+            <a:r>
+              <a:rPr sz="1600" b="1">
+                <a:solidFill>
+                  <a:srgbClr val="E0A437"/>
+                </a:solidFill>
+                <a:latin typeface="Fira Sans"/>
+              </a:rPr>
+              <a:t>▸ </a:t>
+            </a:r>
+            <a:r>
+              <a:rPr sz="1600" b="0">
+                <a:solidFill>
+                  <a:srgbClr val="000000"/>
+                </a:solidFill>
+                <a:latin typeface="Fira Sans"/>
+              </a:rPr>
+              <a:t>Todo el código de la clase está en el notebook 02_pandas_eda.ipynb del repositorio.</a:t>
             </a:r>
           </a:p>
         </p:txBody>
@@ -5737,14 +5867,14 @@
                 </a:solidFill>
                 <a:latin typeface="Fira Sans"/>
               </a:rPr>
-              <a:t>Las variantes del merge: qué filas se conservan</a:t>
+              <a:t>El DataFrame: la estructura central de Pandas</a:t>
             </a:r>
           </a:p>
         </p:txBody>
       </p:sp>
       <p:pic>
         <p:nvPicPr>
-          <p:cNvPr id="4" name="Picture 3" descr="07_diagrama_merge.png"/>
+          <p:cNvPr id="4" name="Picture 3" descr="13_dataframe.png"/>
           <p:cNvPicPr>
             <a:picLocks noChangeAspect="1"/>
           </p:cNvPicPr>
@@ -5759,7 +5889,7 @@
         <p:spPr>
           <a:xfrm>
             <a:off x="1417319" y="1143000"/>
-            <a:ext cx="6309360" cy="2397276"/>
+            <a:ext cx="6309360" cy="2553789"/>
           </a:xfrm>
           <a:prstGeom prst="rect">
             <a:avLst/>
@@ -5795,7 +5925,7 @@
                 </a:solidFill>
                 <a:latin typeface="Fira Sans"/>
               </a:rPr>
-              <a:t>El valor por defecto es inner: descarta sin aviso las filas sin pareja.</a:t>
+              <a:t>Una tabla con filas indexadas y columnas con nombre y tipo. Los códigos (comuna, propósito) se traducen con las tablas de parámetros, uniéndolas con merge.</a:t>
             </a:r>
           </a:p>
         </p:txBody>
@@ -5891,21 +6021,45 @@
                 </a:solidFill>
                 <a:latin typeface="Fira Sans"/>
               </a:rPr>
-              <a:t>El efecto del parámetro how sobre la población analizada</a:t>
-            </a:r>
-          </a:p>
-        </p:txBody>
-      </p:sp>
-      <p:sp>
-        <p:nvSpPr>
-          <p:cNvPr id="4" name="TextBox 3"/>
+              <a:t>Las variantes del merge: qué filas se conservan</a:t>
+            </a:r>
+          </a:p>
+        </p:txBody>
+      </p:sp>
+      <p:pic>
+        <p:nvPicPr>
+          <p:cNvPr id="4" name="Picture 3" descr="07_diagrama_merge.png"/>
+          <p:cNvPicPr>
+            <a:picLocks noChangeAspect="1"/>
+          </p:cNvPicPr>
+          <p:nvPr/>
+        </p:nvPicPr>
+        <p:blipFill>
+          <a:blip r:embed="rId2"/>
+          <a:stretch>
+            <a:fillRect/>
+          </a:stretch>
+        </p:blipFill>
+        <p:spPr>
+          <a:xfrm>
+            <a:off x="1417319" y="1143000"/>
+            <a:ext cx="6309360" cy="2397276"/>
+          </a:xfrm>
+          <a:prstGeom prst="rect">
+            <a:avLst/>
+          </a:prstGeom>
+        </p:spPr>
+      </p:pic>
+      <p:sp>
+        <p:nvSpPr>
+          <p:cNvPr id="5" name="TextBox 4"/>
           <p:cNvSpPr txBox="1"/>
           <p:nvPr/>
         </p:nvSpPr>
         <p:spPr>
           <a:xfrm>
-            <a:off x="704088" y="1353312"/>
-            <a:ext cx="7744968" cy="3300984"/>
+            <a:off x="704088" y="4434840"/>
+            <a:ext cx="7744968" cy="457200"/>
           </a:xfrm>
           <a:prstGeom prst="rect">
             <a:avLst/>
@@ -5918,143 +6072,14 @@
           </a:bodyPr>
           <a:lstStyle/>
           <a:p>
-            <a:pPr>
-              <a:lnSpc>
-                <a:spcPct val="112000"/>
-              </a:lnSpc>
-              <a:spcAft>
-                <a:spcPts val="900"/>
-              </a:spcAft>
-            </a:pPr>
-            <a:r>
-              <a:rPr sz="1800" b="1">
-                <a:solidFill>
-                  <a:srgbClr val="E0A437"/>
-                </a:solidFill>
-                <a:latin typeface="Fira Sans"/>
-              </a:rPr>
-              <a:t>▸ </a:t>
-            </a:r>
-            <a:r>
-              <a:rPr sz="1800" b="0">
-                <a:solidFill>
-                  <a:srgbClr val="000000"/>
-                </a:solidFill>
-                <a:latin typeface="Fira Sans"/>
-              </a:rPr>
-              <a:t>Personas con viajes, merge inner: 113.591 filas (una por viaje).</a:t>
-            </a:r>
-          </a:p>
-          <a:p>
-            <a:pPr>
-              <a:lnSpc>
-                <a:spcPct val="112000"/>
-              </a:lnSpc>
-              <a:spcAft>
-                <a:spcPts val="900"/>
-              </a:spcAft>
-            </a:pPr>
-            <a:r>
-              <a:rPr sz="1800" b="1">
-                <a:solidFill>
-                  <a:srgbClr val="E0A437"/>
-                </a:solidFill>
-                <a:latin typeface="Fira Sans"/>
-              </a:rPr>
-              <a:t>▸ </a:t>
-            </a:r>
-            <a:r>
-              <a:rPr sz="1800" b="0">
-                <a:solidFill>
-                  <a:srgbClr val="000000"/>
-                </a:solidFill>
-                <a:latin typeface="Fira Sans"/>
-              </a:rPr>
-              <a:t>El mismo merge en left: 127.379 filas.</a:t>
-            </a:r>
-          </a:p>
-          <a:p>
-            <a:pPr>
-              <a:lnSpc>
-                <a:spcPct val="112000"/>
-              </a:lnSpc>
-              <a:spcAft>
-                <a:spcPts val="500"/>
-              </a:spcAft>
-            </a:pPr>
-            <a:r>
-              <a:rPr sz="1400" b="0">
+            <a:r>
+              <a:rPr sz="1300" b="0">
                 <a:solidFill>
                   <a:srgbClr val="333333"/>
                 </a:solidFill>
                 <a:latin typeface="Fira Sans"/>
               </a:rPr>
-              <a:t>     ◦  </a:t>
-            </a:r>
-            <a:r>
-              <a:rPr sz="1400" b="0">
-                <a:solidFill>
-                  <a:srgbClr val="333333"/>
-                </a:solidFill>
-                <a:latin typeface="Fira Sans"/>
-              </a:rPr>
-              <a:t>La diferencia son 13.788 personas que no viajaron ese día.</a:t>
-            </a:r>
-          </a:p>
-          <a:p>
-            <a:pPr>
-              <a:lnSpc>
-                <a:spcPct val="112000"/>
-              </a:lnSpc>
-              <a:spcAft>
-                <a:spcPts val="500"/>
-              </a:spcAft>
-            </a:pPr>
-            <a:r>
-              <a:rPr sz="1400" b="0">
-                <a:solidFill>
-                  <a:srgbClr val="333333"/>
-                </a:solidFill>
-                <a:latin typeface="Fira Sans"/>
-              </a:rPr>
-              <a:t>     ◦  </a:t>
-            </a:r>
-            <a:r>
-              <a:rPr sz="1400" b="0">
-                <a:solidFill>
-                  <a:srgbClr val="333333"/>
-                </a:solidFill>
-                <a:latin typeface="Fira Sans"/>
-              </a:rPr>
-              <a:t>Con inner desaparecen; con left quedan, con NaN en el viaje.</a:t>
-            </a:r>
-          </a:p>
-          <a:p>
-            <a:pPr>
-              <a:lnSpc>
-                <a:spcPct val="112000"/>
-              </a:lnSpc>
-              <a:spcAft>
-                <a:spcPts val="900"/>
-              </a:spcAft>
-            </a:pPr>
-            <a:r>
-              <a:rPr sz="1800" b="1">
-                <a:solidFill>
-                  <a:srgbClr val="E0A437"/>
-                </a:solidFill>
-                <a:latin typeface="Fira Sans"/>
-              </a:rPr>
-              <a:t>▸ </a:t>
-            </a:r>
-            <a:r>
-              <a:rPr sz="1800" b="1">
-                <a:solidFill>
-                  <a:srgbClr val="1D3557"/>
-                </a:solidFill>
-                <a:latin typeface="Fira Sans"/>
-              </a:rPr>
-              <a:t>Un promedio calculado sobre el resultado del inner excluye a quienes no viajaron.</a:t>
+              <a:t>El valor por defecto es inner: descarta sin aviso las filas sin pareja.</a:t>
             </a:r>
           </a:p>
         </p:txBody>
@@ -6092,7 +6117,7 @@
             <a:avLst/>
           </a:prstGeom>
           <a:solidFill>
-            <a:srgbClr val="1D3557"/>
+            <a:srgbClr val="FAFBFC"/>
           </a:solidFill>
           <a:ln>
             <a:noFill/>
@@ -6129,8 +6154,8 @@
         </p:nvSpPr>
         <p:spPr>
           <a:xfrm>
-            <a:off x="603504" y="1847088"/>
-            <a:ext cx="7946136" cy="1399032"/>
+            <a:off x="402336" y="301752"/>
+            <a:ext cx="8348472" cy="795528"/>
           </a:xfrm>
           <a:prstGeom prst="rect">
             <a:avLst/>
@@ -6144,24 +6169,176 @@
           <a:lstStyle/>
           <a:p>
             <a:r>
-              <a:rPr sz="3400" b="1">
-                <a:solidFill>
-                  <a:srgbClr val="FFFFFF"/>
-                </a:solidFill>
-                <a:latin typeface="Fira Sans"/>
-              </a:rPr>
-              <a:t>Exploración de la EOD</a:t>
-            </a:r>
-          </a:p>
-          <a:p>
+              <a:rPr sz="2800" b="1">
+                <a:solidFill>
+                  <a:srgbClr val="0F0F0F"/>
+                </a:solidFill>
+                <a:latin typeface="Fira Sans"/>
+              </a:rPr>
+              <a:t>El efecto del parámetro how sobre la población analizada</a:t>
+            </a:r>
+          </a:p>
+        </p:txBody>
+      </p:sp>
+      <p:sp>
+        <p:nvSpPr>
+          <p:cNvPr id="4" name="TextBox 3"/>
+          <p:cNvSpPr txBox="1"/>
+          <p:nvPr/>
+        </p:nvSpPr>
+        <p:spPr>
+          <a:xfrm>
+            <a:off x="704088" y="1353312"/>
+            <a:ext cx="7744968" cy="3300984"/>
+          </a:xfrm>
+          <a:prstGeom prst="rect">
+            <a:avLst/>
+          </a:prstGeom>
+          <a:noFill/>
+        </p:spPr>
+        <p:txBody>
+          <a:bodyPr wrap="square">
+            <a:spAutoFit/>
+          </a:bodyPr>
+          <a:lstStyle/>
+          <a:p>
+            <a:pPr>
+              <a:lnSpc>
+                <a:spcPct val="112000"/>
+              </a:lnSpc>
+              <a:spcAft>
+                <a:spcPts val="900"/>
+              </a:spcAft>
+            </a:pPr>
+            <a:r>
+              <a:rPr sz="1800" b="1">
+                <a:solidFill>
+                  <a:srgbClr val="E0A437"/>
+                </a:solidFill>
+                <a:latin typeface="Fira Sans"/>
+              </a:rPr>
+              <a:t>▸ </a:t>
+            </a:r>
             <a:r>
               <a:rPr sz="1800" b="0">
                 <a:solidFill>
+                  <a:srgbClr val="000000"/>
+                </a:solidFill>
+                <a:latin typeface="Fira Sans"/>
+              </a:rPr>
+              <a:t>Personas con viajes, merge inner: 113.591 filas (una por viaje).</a:t>
+            </a:r>
+          </a:p>
+          <a:p>
+            <a:pPr>
+              <a:lnSpc>
+                <a:spcPct val="112000"/>
+              </a:lnSpc>
+              <a:spcAft>
+                <a:spcPts val="900"/>
+              </a:spcAft>
+            </a:pPr>
+            <a:r>
+              <a:rPr sz="1800" b="1">
+                <a:solidFill>
                   <a:srgbClr val="E0A437"/>
                 </a:solidFill>
                 <a:latin typeface="Fira Sans"/>
               </a:rPr>
-              <a:t>Estadística descriptiva sobre datos reales</a:t>
+              <a:t>▸ </a:t>
+            </a:r>
+            <a:r>
+              <a:rPr sz="1800" b="0">
+                <a:solidFill>
+                  <a:srgbClr val="000000"/>
+                </a:solidFill>
+                <a:latin typeface="Fira Sans"/>
+              </a:rPr>
+              <a:t>El mismo merge en left: 127.379 filas.</a:t>
+            </a:r>
+          </a:p>
+          <a:p>
+            <a:pPr>
+              <a:lnSpc>
+                <a:spcPct val="112000"/>
+              </a:lnSpc>
+              <a:spcAft>
+                <a:spcPts val="500"/>
+              </a:spcAft>
+            </a:pPr>
+            <a:r>
+              <a:rPr sz="1400" b="0">
+                <a:solidFill>
+                  <a:srgbClr val="333333"/>
+                </a:solidFill>
+                <a:latin typeface="Fira Sans"/>
+              </a:rPr>
+              <a:t>     ◦  </a:t>
+            </a:r>
+            <a:r>
+              <a:rPr sz="1400" b="0">
+                <a:solidFill>
+                  <a:srgbClr val="333333"/>
+                </a:solidFill>
+                <a:latin typeface="Fira Sans"/>
+              </a:rPr>
+              <a:t>La diferencia son 13.788 personas que no viajaron ese día.</a:t>
+            </a:r>
+          </a:p>
+          <a:p>
+            <a:pPr>
+              <a:lnSpc>
+                <a:spcPct val="112000"/>
+              </a:lnSpc>
+              <a:spcAft>
+                <a:spcPts val="500"/>
+              </a:spcAft>
+            </a:pPr>
+            <a:r>
+              <a:rPr sz="1400" b="0">
+                <a:solidFill>
+                  <a:srgbClr val="333333"/>
+                </a:solidFill>
+                <a:latin typeface="Fira Sans"/>
+              </a:rPr>
+              <a:t>     ◦  </a:t>
+            </a:r>
+            <a:r>
+              <a:rPr sz="1400" b="0">
+                <a:solidFill>
+                  <a:srgbClr val="333333"/>
+                </a:solidFill>
+                <a:latin typeface="Fira Sans"/>
+              </a:rPr>
+              <a:t>Con inner desaparecen; con left quedan, con NaN en el viaje.</a:t>
+            </a:r>
+          </a:p>
+          <a:p>
+            <a:pPr>
+              <a:lnSpc>
+                <a:spcPct val="112000"/>
+              </a:lnSpc>
+              <a:spcAft>
+                <a:spcPts val="900"/>
+              </a:spcAft>
+            </a:pPr>
+            <a:r>
+              <a:rPr sz="1800" b="1">
+                <a:solidFill>
+                  <a:srgbClr val="E0A437"/>
+                </a:solidFill>
+                <a:latin typeface="Fira Sans"/>
+              </a:rPr>
+              <a:t>▸ </a:t>
+            </a:r>
+            <a:r>
+              <a:rPr sz="1800" b="1">
+                <a:solidFill>
+                  <a:srgbClr val="1D3557"/>
+                </a:solidFill>
+                <a:latin typeface="Fira Sans"/>
+              </a:rPr>
+              <a:t>Un promedio calculado sobre el resultado del inner excluye a quienes no viajaron.</a:t>
             </a:r>
           </a:p>
         </p:txBody>
@@ -6199,7 +6376,7 @@
             <a:avLst/>
           </a:prstGeom>
           <a:solidFill>
-            <a:srgbClr val="FAFBFC"/>
+            <a:srgbClr val="1D3557"/>
           </a:solidFill>
           <a:ln>
             <a:noFill/>
@@ -6236,8 +6413,8 @@
         </p:nvSpPr>
         <p:spPr>
           <a:xfrm>
-            <a:off x="402336" y="301752"/>
-            <a:ext cx="8348472" cy="795528"/>
+            <a:off x="603504" y="1847088"/>
+            <a:ext cx="7946136" cy="1399032"/>
           </a:xfrm>
           <a:prstGeom prst="rect">
             <a:avLst/>
@@ -6251,176 +6428,28 @@
           <a:lstStyle/>
           <a:p>
             <a:r>
-              <a:rPr sz="2800" b="1">
-                <a:solidFill>
-                  <a:srgbClr val="0F0F0F"/>
-                </a:solidFill>
-                <a:latin typeface="Fira Sans"/>
-              </a:rPr>
-              <a:t>Viajes por persona: los ausentes también cuentan</a:t>
-            </a:r>
-          </a:p>
-        </p:txBody>
-      </p:sp>
-      <p:sp>
-        <p:nvSpPr>
-          <p:cNvPr id="4" name="TextBox 3"/>
-          <p:cNvSpPr txBox="1"/>
-          <p:nvPr/>
-        </p:nvSpPr>
-        <p:spPr>
-          <a:xfrm>
-            <a:off x="502920" y="1252728"/>
-            <a:ext cx="4023360" cy="3200400"/>
-          </a:xfrm>
-          <a:prstGeom prst="rect">
-            <a:avLst/>
-          </a:prstGeom>
-          <a:noFill/>
-        </p:spPr>
-        <p:txBody>
-          <a:bodyPr wrap="square">
-            <a:spAutoFit/>
-          </a:bodyPr>
-          <a:lstStyle/>
-          <a:p>
-            <a:pPr>
-              <a:lnSpc>
-                <a:spcPct val="112000"/>
-              </a:lnSpc>
-              <a:spcAft>
-                <a:spcPts val="900"/>
-              </a:spcAft>
-            </a:pPr>
-            <a:r>
-              <a:rPr sz="1500" b="1">
+              <a:rPr sz="3400" b="1">
+                <a:solidFill>
+                  <a:srgbClr val="FFFFFF"/>
+                </a:solidFill>
+                <a:latin typeface="Fira Sans"/>
+              </a:rPr>
+              <a:t>Exploración de la EOD</a:t>
+            </a:r>
+          </a:p>
+          <a:p>
+            <a:r>
+              <a:rPr sz="1800" b="0">
                 <a:solidFill>
                   <a:srgbClr val="E0A437"/>
                 </a:solidFill>
                 <a:latin typeface="Fira Sans"/>
               </a:rPr>
-              <a:t>▸ </a:t>
-            </a:r>
-            <a:r>
-              <a:rPr sz="1500" b="0">
-                <a:solidFill>
-                  <a:srgbClr val="000000"/>
-                </a:solidFill>
-                <a:latin typeface="Fira Sans"/>
-              </a:rPr>
-              <a:t>El 23% de las personas no viajó ese día.</a:t>
-            </a:r>
-          </a:p>
-          <a:p>
-            <a:pPr>
-              <a:lnSpc>
-                <a:spcPct val="112000"/>
-              </a:lnSpc>
-              <a:spcAft>
-                <a:spcPts val="900"/>
-              </a:spcAft>
-            </a:pPr>
-            <a:r>
-              <a:rPr sz="1500" b="1">
-                <a:solidFill>
-                  <a:srgbClr val="E0A437"/>
-                </a:solidFill>
-                <a:latin typeface="Fira Sans"/>
-              </a:rPr>
-              <a:t>▸ </a:t>
-            </a:r>
-            <a:r>
-              <a:rPr sz="1500" b="0">
-                <a:solidFill>
-                  <a:srgbClr val="000000"/>
-                </a:solidFill>
-                <a:latin typeface="Fira Sans"/>
-              </a:rPr>
-              <a:t>Media: 1,9 viajes. Mediana: 2 viajes.</a:t>
-            </a:r>
-          </a:p>
-          <a:p>
-            <a:pPr>
-              <a:lnSpc>
-                <a:spcPct val="112000"/>
-              </a:lnSpc>
-              <a:spcAft>
-                <a:spcPts val="900"/>
-              </a:spcAft>
-            </a:pPr>
-            <a:r>
-              <a:rPr sz="1500" b="1">
-                <a:solidFill>
-                  <a:srgbClr val="E0A437"/>
-                </a:solidFill>
-                <a:latin typeface="Fira Sans"/>
-              </a:rPr>
-              <a:t>▸ </a:t>
-            </a:r>
-            <a:r>
-              <a:rPr sz="1500" b="0">
-                <a:solidFill>
-                  <a:srgbClr val="000000"/>
-                </a:solidFill>
-                <a:latin typeface="Fira Sans"/>
-              </a:rPr>
-              <a:t>La media quedó bajo la mediana: la masa de ceros la desplaza.</a:t>
-            </a:r>
-          </a:p>
-          <a:p>
-            <a:pPr>
-              <a:lnSpc>
-                <a:spcPct val="112000"/>
-              </a:lnSpc>
-              <a:spcAft>
-                <a:spcPts val="900"/>
-              </a:spcAft>
-            </a:pPr>
-            <a:r>
-              <a:rPr sz="1500" b="1">
-                <a:solidFill>
-                  <a:srgbClr val="E0A437"/>
-                </a:solidFill>
-                <a:latin typeface="Fira Sans"/>
-              </a:rPr>
-              <a:t>▸ </a:t>
-            </a:r>
-            <a:r>
-              <a:rPr sz="1500" b="1">
-                <a:solidFill>
-                  <a:srgbClr val="1D3557"/>
-                </a:solidFill>
-                <a:latin typeface="Fira Sans"/>
-              </a:rPr>
-              <a:t>La dirección del sesgo depende de la forma de la distribución.</a:t>
-            </a:r>
-          </a:p>
-        </p:txBody>
-      </p:sp>
-      <p:pic>
-        <p:nvPicPr>
-          <p:cNvPr id="5" name="Picture 4" descr="02_viajes_por_persona.png"/>
-          <p:cNvPicPr>
-            <a:picLocks noChangeAspect="1"/>
-          </p:cNvPicPr>
-          <p:nvPr/>
-        </p:nvPicPr>
-        <p:blipFill>
-          <a:blip r:embed="rId2"/>
-          <a:stretch>
-            <a:fillRect/>
-          </a:stretch>
-        </p:blipFill>
-        <p:spPr>
-          <a:xfrm>
-            <a:off x="4892040" y="1371600"/>
-            <a:ext cx="3840480" cy="2191739"/>
-          </a:xfrm>
-          <a:prstGeom prst="rect">
-            <a:avLst/>
-          </a:prstGeom>
-        </p:spPr>
-      </p:pic>
+              <a:t>Estadística descriptiva sobre datos reales</a:t>
+            </a:r>
+          </a:p>
+        </p:txBody>
+      </p:sp>
     </p:spTree>
   </p:cSld>
   <p:clrMapOvr>
@@ -6512,14 +6541,149 @@
                 </a:solidFill>
                 <a:latin typeface="Fira Sans"/>
               </a:rPr>
-              <a:t>Los factores de expansión: de la muestra a la ciudad</a:t>
+              <a:t>Viajes por persona: los ausentes también cuentan</a:t>
+            </a:r>
+          </a:p>
+        </p:txBody>
+      </p:sp>
+      <p:sp>
+        <p:nvSpPr>
+          <p:cNvPr id="4" name="TextBox 3"/>
+          <p:cNvSpPr txBox="1"/>
+          <p:nvPr/>
+        </p:nvSpPr>
+        <p:spPr>
+          <a:xfrm>
+            <a:off x="502920" y="1252728"/>
+            <a:ext cx="4023360" cy="3200400"/>
+          </a:xfrm>
+          <a:prstGeom prst="rect">
+            <a:avLst/>
+          </a:prstGeom>
+          <a:noFill/>
+        </p:spPr>
+        <p:txBody>
+          <a:bodyPr wrap="square">
+            <a:spAutoFit/>
+          </a:bodyPr>
+          <a:lstStyle/>
+          <a:p>
+            <a:pPr>
+              <a:lnSpc>
+                <a:spcPct val="112000"/>
+              </a:lnSpc>
+              <a:spcAft>
+                <a:spcPts val="900"/>
+              </a:spcAft>
+            </a:pPr>
+            <a:r>
+              <a:rPr sz="1500" b="1">
+                <a:solidFill>
+                  <a:srgbClr val="E0A437"/>
+                </a:solidFill>
+                <a:latin typeface="Fira Sans"/>
+              </a:rPr>
+              <a:t>▸ </a:t>
+            </a:r>
+            <a:r>
+              <a:rPr sz="1500" b="0">
+                <a:solidFill>
+                  <a:srgbClr val="000000"/>
+                </a:solidFill>
+                <a:latin typeface="Fira Sans"/>
+              </a:rPr>
+              <a:t>El 23% de las personas no viajó ese día.</a:t>
+            </a:r>
+          </a:p>
+          <a:p>
+            <a:pPr>
+              <a:lnSpc>
+                <a:spcPct val="112000"/>
+              </a:lnSpc>
+              <a:spcAft>
+                <a:spcPts val="900"/>
+              </a:spcAft>
+            </a:pPr>
+            <a:r>
+              <a:rPr sz="1500" b="1">
+                <a:solidFill>
+                  <a:srgbClr val="E0A437"/>
+                </a:solidFill>
+                <a:latin typeface="Fira Sans"/>
+              </a:rPr>
+              <a:t>▸ </a:t>
+            </a:r>
+            <a:r>
+              <a:rPr sz="1500" b="0">
+                <a:solidFill>
+                  <a:srgbClr val="000000"/>
+                </a:solidFill>
+                <a:latin typeface="Fira Sans"/>
+              </a:rPr>
+              <a:t>Media: 1,9 viajes. Mediana: 2 viajes.</a:t>
+            </a:r>
+          </a:p>
+          <a:p>
+            <a:pPr>
+              <a:lnSpc>
+                <a:spcPct val="112000"/>
+              </a:lnSpc>
+              <a:spcAft>
+                <a:spcPts val="900"/>
+              </a:spcAft>
+            </a:pPr>
+            <a:r>
+              <a:rPr sz="1500" b="1">
+                <a:solidFill>
+                  <a:srgbClr val="E0A437"/>
+                </a:solidFill>
+                <a:latin typeface="Fira Sans"/>
+              </a:rPr>
+              <a:t>▸ </a:t>
+            </a:r>
+            <a:r>
+              <a:rPr sz="1500" b="0">
+                <a:solidFill>
+                  <a:srgbClr val="000000"/>
+                </a:solidFill>
+                <a:latin typeface="Fira Sans"/>
+              </a:rPr>
+              <a:t>La media quedó bajo la mediana: la masa de ceros la desplaza.</a:t>
+            </a:r>
+          </a:p>
+          <a:p>
+            <a:pPr>
+              <a:lnSpc>
+                <a:spcPct val="112000"/>
+              </a:lnSpc>
+              <a:spcAft>
+                <a:spcPts val="900"/>
+              </a:spcAft>
+            </a:pPr>
+            <a:r>
+              <a:rPr sz="1500" b="1">
+                <a:solidFill>
+                  <a:srgbClr val="E0A437"/>
+                </a:solidFill>
+                <a:latin typeface="Fira Sans"/>
+              </a:rPr>
+              <a:t>▸ </a:t>
+            </a:r>
+            <a:r>
+              <a:rPr sz="1500" b="1">
+                <a:solidFill>
+                  <a:srgbClr val="1D3557"/>
+                </a:solidFill>
+                <a:latin typeface="Fira Sans"/>
+              </a:rPr>
+              <a:t>La dirección del sesgo depende de la forma de la distribución.</a:t>
             </a:r>
           </a:p>
         </p:txBody>
       </p:sp>
       <p:pic>
         <p:nvPicPr>
-          <p:cNvPr id="4" name="Picture 3" descr="06_diagrama_factores.png"/>
+          <p:cNvPr id="5" name="Picture 4" descr="02_viajes_por_persona.png"/>
           <p:cNvPicPr>
             <a:picLocks noChangeAspect="1"/>
           </p:cNvPicPr>
@@ -6533,48 +6697,14 @@
         </p:blipFill>
         <p:spPr>
           <a:xfrm>
-            <a:off x="1417319" y="1143000"/>
-            <a:ext cx="6309360" cy="2871234"/>
+            <a:off x="4892040" y="1371600"/>
+            <a:ext cx="3840480" cy="2191739"/>
           </a:xfrm>
           <a:prstGeom prst="rect">
             <a:avLst/>
           </a:prstGeom>
         </p:spPr>
       </p:pic>
-      <p:sp>
-        <p:nvSpPr>
-          <p:cNvPr id="5" name="TextBox 4"/>
-          <p:cNvSpPr txBox="1"/>
-          <p:nvPr/>
-        </p:nvSpPr>
-        <p:spPr>
-          <a:xfrm>
-            <a:off x="704088" y="4434840"/>
-            <a:ext cx="7744968" cy="457200"/>
-          </a:xfrm>
-          <a:prstGeom prst="rect">
-            <a:avLst/>
-          </a:prstGeom>
-          <a:noFill/>
-        </p:spPr>
-        <p:txBody>
-          <a:bodyPr wrap="square">
-            <a:spAutoFit/>
-          </a:bodyPr>
-          <a:lstStyle/>
-          <a:p>
-            <a:r>
-              <a:rPr sz="1300" b="0">
-                <a:solidFill>
-                  <a:srgbClr val="333333"/>
-                </a:solidFill>
-                <a:latin typeface="Fira Sans"/>
-              </a:rPr>
-              <a:t>Contar filas responde por la muestra; sumar factores responde por la ciudad.</a:t>
-            </a:r>
-          </a:p>
-        </p:txBody>
-      </p:sp>
     </p:spTree>
   </p:cSld>
   <p:clrMapOvr>
@@ -6666,149 +6796,14 @@
                 </a:solidFill>
                 <a:latin typeface="Fira Sans"/>
               </a:rPr>
-              <a:t>El ingreso de los hogares: media y mediana</a:t>
-            </a:r>
-          </a:p>
-        </p:txBody>
-      </p:sp>
-      <p:sp>
-        <p:nvSpPr>
-          <p:cNvPr id="4" name="TextBox 3"/>
-          <p:cNvSpPr txBox="1"/>
-          <p:nvPr/>
-        </p:nvSpPr>
-        <p:spPr>
-          <a:xfrm>
-            <a:off x="502920" y="1252728"/>
-            <a:ext cx="4023360" cy="3200400"/>
-          </a:xfrm>
-          <a:prstGeom prst="rect">
-            <a:avLst/>
-          </a:prstGeom>
-          <a:noFill/>
-        </p:spPr>
-        <p:txBody>
-          <a:bodyPr wrap="square">
-            <a:spAutoFit/>
-          </a:bodyPr>
-          <a:lstStyle/>
-          <a:p>
-            <a:pPr>
-              <a:lnSpc>
-                <a:spcPct val="112000"/>
-              </a:lnSpc>
-              <a:spcAft>
-                <a:spcPts val="900"/>
-              </a:spcAft>
-            </a:pPr>
-            <a:r>
-              <a:rPr sz="1500" b="1">
-                <a:solidFill>
-                  <a:srgbClr val="E0A437"/>
-                </a:solidFill>
-                <a:latin typeface="Fira Sans"/>
-              </a:rPr>
-              <a:t>▸ </a:t>
-            </a:r>
-            <a:r>
-              <a:rPr sz="1500" b="0">
-                <a:solidFill>
-                  <a:srgbClr val="000000"/>
-                </a:solidFill>
-                <a:latin typeface="Fira Sans"/>
-              </a:rPr>
-              <a:t>Media: $688.274. Mediana: $507.826.</a:t>
-            </a:r>
-          </a:p>
-          <a:p>
-            <a:pPr>
-              <a:lnSpc>
-                <a:spcPct val="112000"/>
-              </a:lnSpc>
-              <a:spcAft>
-                <a:spcPts val="900"/>
-              </a:spcAft>
-            </a:pPr>
-            <a:r>
-              <a:rPr sz="1500" b="1">
-                <a:solidFill>
-                  <a:srgbClr val="E0A437"/>
-                </a:solidFill>
-                <a:latin typeface="Fira Sans"/>
-              </a:rPr>
-              <a:t>▸ </a:t>
-            </a:r>
-            <a:r>
-              <a:rPr sz="1500" b="0">
-                <a:solidFill>
-                  <a:srgbClr val="000000"/>
-                </a:solidFill>
-                <a:latin typeface="Fira Sans"/>
-              </a:rPr>
-              <a:t>La media es un 36% más alta que la mediana.</a:t>
-            </a:r>
-          </a:p>
-          <a:p>
-            <a:pPr>
-              <a:lnSpc>
-                <a:spcPct val="112000"/>
-              </a:lnSpc>
-              <a:spcAft>
-                <a:spcPts val="900"/>
-              </a:spcAft>
-            </a:pPr>
-            <a:r>
-              <a:rPr sz="1500" b="1">
-                <a:solidFill>
-                  <a:srgbClr val="E0A437"/>
-                </a:solidFill>
-                <a:latin typeface="Fira Sans"/>
-              </a:rPr>
-              <a:t>▸ </a:t>
-            </a:r>
-            <a:r>
-              <a:rPr sz="1500" b="0">
-                <a:solidFill>
-                  <a:srgbClr val="000000"/>
-                </a:solidFill>
-                <a:latin typeface="Fira Sans"/>
-              </a:rPr>
-              <a:t>Los ingresos altos desplazan el promedio; la mayoría gana menos.</a:t>
-            </a:r>
-          </a:p>
-          <a:p>
-            <a:pPr>
-              <a:lnSpc>
-                <a:spcPct val="112000"/>
-              </a:lnSpc>
-              <a:spcAft>
-                <a:spcPts val="900"/>
-              </a:spcAft>
-            </a:pPr>
-            <a:r>
-              <a:rPr sz="1500" b="1">
-                <a:solidFill>
-                  <a:srgbClr val="E0A437"/>
-                </a:solidFill>
-                <a:latin typeface="Fira Sans"/>
-              </a:rPr>
-              <a:t>▸ </a:t>
-            </a:r>
-            <a:r>
-              <a:rPr sz="1500" b="1">
-                <a:solidFill>
-                  <a:srgbClr val="1D3557"/>
-                </a:solidFill>
-                <a:latin typeface="Fira Sans"/>
-              </a:rPr>
-              <a:t>El promedio describe una situación en la que la mayoría no está.</a:t>
+              <a:t>Los factores de expansión: de la muestra a la ciudad</a:t>
             </a:r>
           </a:p>
         </p:txBody>
       </p:sp>
       <p:pic>
         <p:nvPicPr>
-          <p:cNvPr id="5" name="Picture 4" descr="01_ingreso_media_mediana.png"/>
+          <p:cNvPr id="4" name="Picture 3" descr="06_diagrama_factores.png"/>
           <p:cNvPicPr>
             <a:picLocks noChangeAspect="1"/>
           </p:cNvPicPr>
@@ -6822,14 +6817,48 @@
         </p:blipFill>
         <p:spPr>
           <a:xfrm>
-            <a:off x="4892040" y="1371600"/>
-            <a:ext cx="3840480" cy="2182719"/>
+            <a:off x="1417319" y="1143000"/>
+            <a:ext cx="6309360" cy="2871234"/>
           </a:xfrm>
           <a:prstGeom prst="rect">
             <a:avLst/>
           </a:prstGeom>
         </p:spPr>
       </p:pic>
+      <p:sp>
+        <p:nvSpPr>
+          <p:cNvPr id="5" name="TextBox 4"/>
+          <p:cNvSpPr txBox="1"/>
+          <p:nvPr/>
+        </p:nvSpPr>
+        <p:spPr>
+          <a:xfrm>
+            <a:off x="704088" y="4434840"/>
+            <a:ext cx="7744968" cy="457200"/>
+          </a:xfrm>
+          <a:prstGeom prst="rect">
+            <a:avLst/>
+          </a:prstGeom>
+          <a:noFill/>
+        </p:spPr>
+        <p:txBody>
+          <a:bodyPr wrap="square">
+            <a:spAutoFit/>
+          </a:bodyPr>
+          <a:lstStyle/>
+          <a:p>
+            <a:r>
+              <a:rPr sz="1300" b="0">
+                <a:solidFill>
+                  <a:srgbClr val="333333"/>
+                </a:solidFill>
+                <a:latin typeface="Fira Sans"/>
+              </a:rPr>
+              <a:t>Contar filas responde por la muestra; sumar factores responde por la ciudad.</a:t>
+            </a:r>
+          </a:p>
+        </p:txBody>
+      </p:sp>
     </p:spTree>
   </p:cSld>
   <p:clrMapOvr>
@@ -6921,7 +6950,7 @@
                 </a:solidFill>
                 <a:latin typeface="Fira Sans"/>
               </a:rPr>
-              <a:t>La duración de los viajes: valores extremos</a:t>
+              <a:t>El ingreso de los hogares: media y mediana</a:t>
             </a:r>
           </a:p>
         </p:txBody>
@@ -6972,7 +7001,7 @@
                 </a:solidFill>
                 <a:latin typeface="Fira Sans"/>
               </a:rPr>
-              <a:t>Mediana: 30 minutos. Percentil 95: 98 minutos.</a:t>
+              <a:t>Media: $688.274. Mediana: $507.826.</a:t>
             </a:r>
           </a:p>
           <a:p>
@@ -7000,7 +7029,7 @@
                 </a:solidFill>
                 <a:latin typeface="Fira Sans"/>
               </a:rPr>
-              <a:t>Máximo registrado: 1.335 minutos, un viaje de 22 horas.</a:t>
+              <a:t>La media es un 36% más alta que la mediana.</a:t>
             </a:r>
           </a:p>
           <a:p>
@@ -7028,7 +7057,7 @@
                 </a:solidFill>
                 <a:latin typeface="Fira Sans"/>
               </a:rPr>
-              <a:t>¿Error de digitación? ¿Turno nocturno mal anotado?</a:t>
+              <a:t>Los ingresos altos desplazan el promedio; la mayoría gana menos.</a:t>
             </a:r>
           </a:p>
           <a:p>
@@ -7056,14 +7085,14 @@
                 </a:solidFill>
                 <a:latin typeface="Fira Sans"/>
               </a:rPr>
-              <a:t>Los valores extremos se investigan y la decisión se declara.</a:t>
+              <a:t>El promedio describe una situación en la que la mayoría no está.</a:t>
             </a:r>
           </a:p>
         </p:txBody>
       </p:sp>
       <p:pic>
         <p:nvPicPr>
-          <p:cNvPr id="5" name="Picture 4" descr="04_duracion_viajes.png"/>
+          <p:cNvPr id="5" name="Picture 4" descr="01_ingreso_media_mediana.png"/>
           <p:cNvPicPr>
             <a:picLocks noChangeAspect="1"/>
           </p:cNvPicPr>
@@ -7078,7 +7107,7 @@
         <p:spPr>
           <a:xfrm>
             <a:off x="4892040" y="1371600"/>
-            <a:ext cx="3840480" cy="2146492"/>
+            <a:ext cx="3840480" cy="2182719"/>
           </a:xfrm>
           <a:prstGeom prst="rect">
             <a:avLst/>
@@ -7176,7 +7205,7 @@
                 </a:solidFill>
                 <a:latin typeface="Fira Sans"/>
               </a:rPr>
-              <a:t>La partición modal del Gran Santiago</a:t>
+              <a:t>La duración de los viajes: valores extremos</a:t>
             </a:r>
           </a:p>
         </p:txBody>
@@ -7227,91 +7256,7 @@
                 </a:solidFill>
                 <a:latin typeface="Fira Sans"/>
               </a:rPr>
-              <a:t>Dos merges y un groupby ponderado por factor.</a:t>
-            </a:r>
-          </a:p>
-          <a:p>
-            <a:pPr>
-              <a:lnSpc>
-                <a:spcPct val="112000"/>
-              </a:lnSpc>
-              <a:spcAft>
-                <a:spcPts val="500"/>
-              </a:spcAft>
-            </a:pPr>
-            <a:r>
-              <a:rPr sz="1300" b="0">
-                <a:solidFill>
-                  <a:srgbClr val="333333"/>
-                </a:solidFill>
-                <a:latin typeface="Fira Sans"/>
-              </a:rPr>
-              <a:t>     ◦  </a:t>
-            </a:r>
-            <a:r>
-              <a:rPr sz="1300" b="0">
-                <a:solidFill>
-                  <a:srgbClr val="333333"/>
-                </a:solidFill>
-                <a:latin typeface="Fira Sans"/>
-              </a:rPr>
-              <a:t>Caminata: 34% de los viajes.</a:t>
-            </a:r>
-          </a:p>
-          <a:p>
-            <a:pPr>
-              <a:lnSpc>
-                <a:spcPct val="112000"/>
-              </a:lnSpc>
-              <a:spcAft>
-                <a:spcPts val="500"/>
-              </a:spcAft>
-            </a:pPr>
-            <a:r>
-              <a:rPr sz="1300" b="0">
-                <a:solidFill>
-                  <a:srgbClr val="333333"/>
-                </a:solidFill>
-                <a:latin typeface="Fira Sans"/>
-              </a:rPr>
-              <a:t>     ◦  </a:t>
-            </a:r>
-            <a:r>
-              <a:rPr sz="1300" b="0">
-                <a:solidFill>
-                  <a:srgbClr val="333333"/>
-                </a:solidFill>
-                <a:latin typeface="Fira Sans"/>
-              </a:rPr>
-              <a:t>Transporte público (Bip!): 24%.</a:t>
-            </a:r>
-          </a:p>
-          <a:p>
-            <a:pPr>
-              <a:lnSpc>
-                <a:spcPct val="112000"/>
-              </a:lnSpc>
-              <a:spcAft>
-                <a:spcPts val="500"/>
-              </a:spcAft>
-            </a:pPr>
-            <a:r>
-              <a:rPr sz="1300" b="0">
-                <a:solidFill>
-                  <a:srgbClr val="333333"/>
-                </a:solidFill>
-                <a:latin typeface="Fira Sans"/>
-              </a:rPr>
-              <a:t>     ◦  </a:t>
-            </a:r>
-            <a:r>
-              <a:rPr sz="1300" b="0">
-                <a:solidFill>
-                  <a:srgbClr val="333333"/>
-                </a:solidFill>
-                <a:latin typeface="Fira Sans"/>
-              </a:rPr>
-              <a:t>Auto: 23%.</a:t>
+              <a:t>Mediana: 30 minutos. Percentil 95: 98 minutos.</a:t>
             </a:r>
           </a:p>
           <a:p>
@@ -7333,20 +7278,76 @@
               <a:t>▸ </a:t>
             </a:r>
             <a:r>
+              <a:rPr sz="1500" b="0">
+                <a:solidFill>
+                  <a:srgbClr val="000000"/>
+                </a:solidFill>
+                <a:latin typeface="Fira Sans"/>
+              </a:rPr>
+              <a:t>Máximo registrado: 1.335 minutos, un viaje de 22 horas.</a:t>
+            </a:r>
+          </a:p>
+          <a:p>
+            <a:pPr>
+              <a:lnSpc>
+                <a:spcPct val="112000"/>
+              </a:lnSpc>
+              <a:spcAft>
+                <a:spcPts val="900"/>
+              </a:spcAft>
+            </a:pPr>
+            <a:r>
               <a:rPr sz="1500" b="1">
                 <a:solidFill>
+                  <a:srgbClr val="E0A437"/>
+                </a:solidFill>
+                <a:latin typeface="Fira Sans"/>
+              </a:rPr>
+              <a:t>▸ </a:t>
+            </a:r>
+            <a:r>
+              <a:rPr sz="1500" b="0">
+                <a:solidFill>
+                  <a:srgbClr val="000000"/>
+                </a:solidFill>
+                <a:latin typeface="Fira Sans"/>
+              </a:rPr>
+              <a:t>¿Error de digitación? ¿Turno nocturno mal anotado?</a:t>
+            </a:r>
+          </a:p>
+          <a:p>
+            <a:pPr>
+              <a:lnSpc>
+                <a:spcPct val="112000"/>
+              </a:lnSpc>
+              <a:spcAft>
+                <a:spcPts val="900"/>
+              </a:spcAft>
+            </a:pPr>
+            <a:r>
+              <a:rPr sz="1500" b="1">
+                <a:solidFill>
+                  <a:srgbClr val="E0A437"/>
+                </a:solidFill>
+                <a:latin typeface="Fira Sans"/>
+              </a:rPr>
+              <a:t>▸ </a:t>
+            </a:r>
+            <a:r>
+              <a:rPr sz="1500" b="1">
+                <a:solidFill>
                   <a:srgbClr val="1D3557"/>
                 </a:solidFill>
                 <a:latin typeface="Fira Sans"/>
               </a:rPr>
-              <a:t>Calculada desde los microdatos, con los factores de un día laboral.</a:t>
+              <a:t>Los valores extremos se investigan y la decisión se declara.</a:t>
             </a:r>
           </a:p>
         </p:txBody>
       </p:sp>
       <p:pic>
         <p:nvPicPr>
-          <p:cNvPr id="5" name="Picture 4" descr="03_reparto_modal.png"/>
+          <p:cNvPr id="5" name="Picture 4" descr="04_duracion_viajes.png"/>
           <p:cNvPicPr>
             <a:picLocks noChangeAspect="1"/>
           </p:cNvPicPr>
@@ -7361,7 +7362,7 @@
         <p:spPr>
           <a:xfrm>
             <a:off x="4892040" y="1371600"/>
-            <a:ext cx="3840480" cy="1938578"/>
+            <a:ext cx="3840480" cy="2146492"/>
           </a:xfrm>
           <a:prstGeom prst="rect">
             <a:avLst/>
@@ -7459,14 +7460,177 @@
                 </a:solidFill>
                 <a:latin typeface="Fira Sans"/>
               </a:rPr>
-              <a:t>El reparto modal difiere entre comunas</a:t>
+              <a:t>La partición modal del Gran Santiago</a:t>
+            </a:r>
+          </a:p>
+        </p:txBody>
+      </p:sp>
+      <p:sp>
+        <p:nvSpPr>
+          <p:cNvPr id="4" name="TextBox 3"/>
+          <p:cNvSpPr txBox="1"/>
+          <p:nvPr/>
+        </p:nvSpPr>
+        <p:spPr>
+          <a:xfrm>
+            <a:off x="502920" y="1252728"/>
+            <a:ext cx="4023360" cy="3200400"/>
+          </a:xfrm>
+          <a:prstGeom prst="rect">
+            <a:avLst/>
+          </a:prstGeom>
+          <a:noFill/>
+        </p:spPr>
+        <p:txBody>
+          <a:bodyPr wrap="square">
+            <a:spAutoFit/>
+          </a:bodyPr>
+          <a:lstStyle/>
+          <a:p>
+            <a:pPr>
+              <a:lnSpc>
+                <a:spcPct val="112000"/>
+              </a:lnSpc>
+              <a:spcAft>
+                <a:spcPts val="900"/>
+              </a:spcAft>
+            </a:pPr>
+            <a:r>
+              <a:rPr sz="1500" b="1">
+                <a:solidFill>
+                  <a:srgbClr val="E0A437"/>
+                </a:solidFill>
+                <a:latin typeface="Fira Sans"/>
+              </a:rPr>
+              <a:t>▸ </a:t>
+            </a:r>
+            <a:r>
+              <a:rPr sz="1500" b="0">
+                <a:solidFill>
+                  <a:srgbClr val="000000"/>
+                </a:solidFill>
+                <a:latin typeface="Fira Sans"/>
+              </a:rPr>
+              <a:t>Dos merges y un groupby ponderado por factor.</a:t>
+            </a:r>
+          </a:p>
+          <a:p>
+            <a:pPr>
+              <a:lnSpc>
+                <a:spcPct val="112000"/>
+              </a:lnSpc>
+              <a:spcAft>
+                <a:spcPts val="500"/>
+              </a:spcAft>
+            </a:pPr>
+            <a:r>
+              <a:rPr sz="1300" b="0">
+                <a:solidFill>
+                  <a:srgbClr val="333333"/>
+                </a:solidFill>
+                <a:latin typeface="Fira Sans"/>
+              </a:rPr>
+              <a:t>     ◦  </a:t>
+            </a:r>
+            <a:r>
+              <a:rPr sz="1300" b="0">
+                <a:solidFill>
+                  <a:srgbClr val="333333"/>
+                </a:solidFill>
+                <a:latin typeface="Fira Sans"/>
+              </a:rPr>
+              <a:t>Caminata: 34% de los viajes.</a:t>
+            </a:r>
+          </a:p>
+          <a:p>
+            <a:pPr>
+              <a:lnSpc>
+                <a:spcPct val="112000"/>
+              </a:lnSpc>
+              <a:spcAft>
+                <a:spcPts val="500"/>
+              </a:spcAft>
+            </a:pPr>
+            <a:r>
+              <a:rPr sz="1300" b="0">
+                <a:solidFill>
+                  <a:srgbClr val="333333"/>
+                </a:solidFill>
+                <a:latin typeface="Fira Sans"/>
+              </a:rPr>
+              <a:t>     ◦  </a:t>
+            </a:r>
+            <a:r>
+              <a:rPr sz="1300" b="0">
+                <a:solidFill>
+                  <a:srgbClr val="333333"/>
+                </a:solidFill>
+                <a:latin typeface="Fira Sans"/>
+              </a:rPr>
+              <a:t>Transporte público (Bip!): 24%.</a:t>
+            </a:r>
+          </a:p>
+          <a:p>
+            <a:pPr>
+              <a:lnSpc>
+                <a:spcPct val="112000"/>
+              </a:lnSpc>
+              <a:spcAft>
+                <a:spcPts val="500"/>
+              </a:spcAft>
+            </a:pPr>
+            <a:r>
+              <a:rPr sz="1300" b="0">
+                <a:solidFill>
+                  <a:srgbClr val="333333"/>
+                </a:solidFill>
+                <a:latin typeface="Fira Sans"/>
+              </a:rPr>
+              <a:t>     ◦  </a:t>
+            </a:r>
+            <a:r>
+              <a:rPr sz="1300" b="0">
+                <a:solidFill>
+                  <a:srgbClr val="333333"/>
+                </a:solidFill>
+                <a:latin typeface="Fira Sans"/>
+              </a:rPr>
+              <a:t>Auto: 23%.</a:t>
+            </a:r>
+          </a:p>
+          <a:p>
+            <a:pPr>
+              <a:lnSpc>
+                <a:spcPct val="112000"/>
+              </a:lnSpc>
+              <a:spcAft>
+                <a:spcPts val="900"/>
+              </a:spcAft>
+            </a:pPr>
+            <a:r>
+              <a:rPr sz="1500" b="1">
+                <a:solidFill>
+                  <a:srgbClr val="E0A437"/>
+                </a:solidFill>
+                <a:latin typeface="Fira Sans"/>
+              </a:rPr>
+              <a:t>▸ </a:t>
+            </a:r>
+            <a:r>
+              <a:rPr sz="1500" b="1">
+                <a:solidFill>
+                  <a:srgbClr val="1D3557"/>
+                </a:solidFill>
+                <a:latin typeface="Fira Sans"/>
+              </a:rPr>
+              <a:t>Calculada desde los microdatos, con los factores de un día laboral.</a:t>
             </a:r>
           </a:p>
         </p:txBody>
       </p:sp>
       <p:pic>
         <p:nvPicPr>
-          <p:cNvPr id="4" name="Picture 3" descr="08_modo_por_comuna.png"/>
+          <p:cNvPr id="5" name="Picture 4" descr="03_reparto_modal.png"/>
           <p:cNvPicPr>
             <a:picLocks noChangeAspect="1"/>
           </p:cNvPicPr>
@@ -7480,48 +7644,14 @@
         </p:blipFill>
         <p:spPr>
           <a:xfrm>
-            <a:off x="1994250" y="1143000"/>
-            <a:ext cx="5155498" cy="3154679"/>
+            <a:off x="4892040" y="1371600"/>
+            <a:ext cx="3840480" cy="1938578"/>
           </a:xfrm>
           <a:prstGeom prst="rect">
             <a:avLst/>
           </a:prstGeom>
         </p:spPr>
       </p:pic>
-      <p:sp>
-        <p:nvSpPr>
-          <p:cNvPr id="5" name="TextBox 4"/>
-          <p:cNvSpPr txBox="1"/>
-          <p:nvPr/>
-        </p:nvSpPr>
-        <p:spPr>
-          <a:xfrm>
-            <a:off x="704088" y="4434840"/>
-            <a:ext cx="7744968" cy="457200"/>
-          </a:xfrm>
-          <a:prstGeom prst="rect">
-            <a:avLst/>
-          </a:prstGeom>
-          <a:noFill/>
-        </p:spPr>
-        <p:txBody>
-          <a:bodyPr wrap="square">
-            <a:spAutoFit/>
-          </a:bodyPr>
-          <a:lstStyle/>
-          <a:p>
-            <a:r>
-              <a:rPr sz="1300" b="0">
-                <a:solidFill>
-                  <a:srgbClr val="333333"/>
-                </a:solidFill>
-                <a:latin typeface="Fira Sans"/>
-              </a:rPr>
-              <a:t>Normalizar por comuna permite comparar proporciones entre comunas de tamaños muy distintos.</a:t>
-            </a:r>
-          </a:p>
-        </p:txBody>
-      </p:sp>
     </p:spTree>
   </p:cSld>
   <p:clrMapOvr>
@@ -7613,177 +7743,14 @@
                 </a:solidFill>
                 <a:latin typeface="Fira Sans"/>
               </a:rPr>
-              <a:t>Ingreso y uso de transporte público</a:t>
-            </a:r>
-          </a:p>
-        </p:txBody>
-      </p:sp>
-      <p:sp>
-        <p:nvSpPr>
-          <p:cNvPr id="4" name="TextBox 3"/>
-          <p:cNvSpPr txBox="1"/>
-          <p:nvPr/>
-        </p:nvSpPr>
-        <p:spPr>
-          <a:xfrm>
-            <a:off x="502920" y="1252728"/>
-            <a:ext cx="4023360" cy="3200400"/>
-          </a:xfrm>
-          <a:prstGeom prst="rect">
-            <a:avLst/>
-          </a:prstGeom>
-          <a:noFill/>
-        </p:spPr>
-        <p:txBody>
-          <a:bodyPr wrap="square">
-            <a:spAutoFit/>
-          </a:bodyPr>
-          <a:lstStyle/>
-          <a:p>
-            <a:pPr>
-              <a:lnSpc>
-                <a:spcPct val="112000"/>
-              </a:lnSpc>
-              <a:spcAft>
-                <a:spcPts val="900"/>
-              </a:spcAft>
-            </a:pPr>
-            <a:r>
-              <a:rPr sz="1500" b="1">
-                <a:solidFill>
-                  <a:srgbClr val="E0A437"/>
-                </a:solidFill>
-                <a:latin typeface="Fira Sans"/>
-              </a:rPr>
-              <a:t>▸ </a:t>
-            </a:r>
-            <a:r>
-              <a:rPr sz="1500" b="0">
-                <a:solidFill>
-                  <a:srgbClr val="000000"/>
-                </a:solidFill>
-                <a:latin typeface="Fira Sans"/>
-              </a:rPr>
-              <a:t>Cada punto es una comuna: ingreso medio contra proporción de viajes en transporte público.</a:t>
-            </a:r>
-          </a:p>
-          <a:p>
-            <a:pPr>
-              <a:lnSpc>
-                <a:spcPct val="112000"/>
-              </a:lnSpc>
-              <a:spcAft>
-                <a:spcPts val="500"/>
-              </a:spcAft>
-            </a:pPr>
-            <a:r>
-              <a:rPr sz="1300" b="0">
-                <a:solidFill>
-                  <a:srgbClr val="333333"/>
-                </a:solidFill>
-                <a:latin typeface="Fira Sans"/>
-              </a:rPr>
-              <a:t>     ◦  </a:t>
-            </a:r>
-            <a:r>
-              <a:rPr sz="1300" b="0">
-                <a:solidFill>
-                  <a:srgbClr val="333333"/>
-                </a:solidFill>
-                <a:latin typeface="Fira Sans"/>
-              </a:rPr>
-              <a:t>Periferia (Buin, Melipilla): poco transporte público; la red no llega.</a:t>
-            </a:r>
-          </a:p>
-          <a:p>
-            <a:pPr>
-              <a:lnSpc>
-                <a:spcPct val="112000"/>
-              </a:lnSpc>
-              <a:spcAft>
-                <a:spcPts val="500"/>
-              </a:spcAft>
-            </a:pPr>
-            <a:r>
-              <a:rPr sz="1300" b="0">
-                <a:solidFill>
-                  <a:srgbClr val="333333"/>
-                </a:solidFill>
-                <a:latin typeface="Fira Sans"/>
-              </a:rPr>
-              <a:t>     ◦  </a:t>
-            </a:r>
-            <a:r>
-              <a:rPr sz="1300" b="0">
-                <a:solidFill>
-                  <a:srgbClr val="333333"/>
-                </a:solidFill>
-                <a:latin typeface="Fira Sans"/>
-              </a:rPr>
-              <a:t>Ingresos altos (Vitacura, Lo Barnechea): conectadas, con poco uso.</a:t>
-            </a:r>
-          </a:p>
-          <a:p>
-            <a:pPr>
-              <a:lnSpc>
-                <a:spcPct val="112000"/>
-              </a:lnSpc>
-              <a:spcAft>
-                <a:spcPts val="500"/>
-              </a:spcAft>
-            </a:pPr>
-            <a:r>
-              <a:rPr sz="1300" b="0">
-                <a:solidFill>
-                  <a:srgbClr val="333333"/>
-                </a:solidFill>
-                <a:latin typeface="Fira Sans"/>
-              </a:rPr>
-              <a:t>     ◦  </a:t>
-            </a:r>
-            <a:r>
-              <a:rPr sz="1300" b="0">
-                <a:solidFill>
-                  <a:srgbClr val="333333"/>
-                </a:solidFill>
-                <a:latin typeface="Fira Sans"/>
-              </a:rPr>
-              <a:t>Correlación de Pearson: -0,17. La asociación lineal es débil.</a:t>
-            </a:r>
-          </a:p>
-          <a:p>
-            <a:pPr>
-              <a:lnSpc>
-                <a:spcPct val="112000"/>
-              </a:lnSpc>
-              <a:spcAft>
-                <a:spcPts val="900"/>
-              </a:spcAft>
-            </a:pPr>
-            <a:r>
-              <a:rPr sz="1500" b="1">
-                <a:solidFill>
-                  <a:srgbClr val="E0A437"/>
-                </a:solidFill>
-                <a:latin typeface="Fira Sans"/>
-              </a:rPr>
-              <a:t>▸ </a:t>
-            </a:r>
-            <a:r>
-              <a:rPr sz="1500" b="1">
-                <a:solidFill>
-                  <a:srgbClr val="1D3557"/>
-                </a:solidFill>
-                <a:latin typeface="Fira Sans"/>
-              </a:rPr>
-              <a:t>Como vimos en el marco conceptual: el coeficiente no reemplaza al gráfico, y la asociación no autoriza verbos causales.</a:t>
+              <a:t>El reparto modal difiere entre comunas</a:t>
             </a:r>
           </a:p>
         </p:txBody>
       </p:sp>
       <p:pic>
         <p:nvPicPr>
-          <p:cNvPr id="5" name="Picture 4" descr="09_ingreso_vs_tp.png"/>
+          <p:cNvPr id="4" name="Picture 3" descr="08_modo_por_comuna.png"/>
           <p:cNvPicPr>
             <a:picLocks noChangeAspect="1"/>
           </p:cNvPicPr>
@@ -7797,14 +7764,48 @@
         </p:blipFill>
         <p:spPr>
           <a:xfrm>
-            <a:off x="4892040" y="1371600"/>
-            <a:ext cx="3840480" cy="2526979"/>
+            <a:off x="1994250" y="1143000"/>
+            <a:ext cx="5155498" cy="3154679"/>
           </a:xfrm>
           <a:prstGeom prst="rect">
             <a:avLst/>
           </a:prstGeom>
         </p:spPr>
       </p:pic>
+      <p:sp>
+        <p:nvSpPr>
+          <p:cNvPr id="5" name="TextBox 4"/>
+          <p:cNvSpPr txBox="1"/>
+          <p:nvPr/>
+        </p:nvSpPr>
+        <p:spPr>
+          <a:xfrm>
+            <a:off x="704088" y="4434840"/>
+            <a:ext cx="7744968" cy="457200"/>
+          </a:xfrm>
+          <a:prstGeom prst="rect">
+            <a:avLst/>
+          </a:prstGeom>
+          <a:noFill/>
+        </p:spPr>
+        <p:txBody>
+          <a:bodyPr wrap="square">
+            <a:spAutoFit/>
+          </a:bodyPr>
+          <a:lstStyle/>
+          <a:p>
+            <a:r>
+              <a:rPr sz="1300" b="0">
+                <a:solidFill>
+                  <a:srgbClr val="333333"/>
+                </a:solidFill>
+                <a:latin typeface="Fira Sans"/>
+              </a:rPr>
+              <a:t>Normalizar por comuna permite comparar proporciones entre comunas de tamaños muy distintos.</a:t>
+            </a:r>
+          </a:p>
+        </p:txBody>
+      </p:sp>
     </p:spTree>
   </p:cSld>
   <p:clrMapOvr>
@@ -8003,14 +8004,177 @@
                 </a:solidFill>
                 <a:latin typeface="Fira Sans"/>
               </a:rPr>
-              <a:t>Los propósitos de viaje según el día de la semana</a:t>
+              <a:t>Ingreso y uso de transporte público</a:t>
+            </a:r>
+          </a:p>
+        </p:txBody>
+      </p:sp>
+      <p:sp>
+        <p:nvSpPr>
+          <p:cNvPr id="4" name="TextBox 3"/>
+          <p:cNvSpPr txBox="1"/>
+          <p:nvPr/>
+        </p:nvSpPr>
+        <p:spPr>
+          <a:xfrm>
+            <a:off x="502920" y="1252728"/>
+            <a:ext cx="4023360" cy="3200400"/>
+          </a:xfrm>
+          <a:prstGeom prst="rect">
+            <a:avLst/>
+          </a:prstGeom>
+          <a:noFill/>
+        </p:spPr>
+        <p:txBody>
+          <a:bodyPr wrap="square">
+            <a:spAutoFit/>
+          </a:bodyPr>
+          <a:lstStyle/>
+          <a:p>
+            <a:pPr>
+              <a:lnSpc>
+                <a:spcPct val="112000"/>
+              </a:lnSpc>
+              <a:spcAft>
+                <a:spcPts val="900"/>
+              </a:spcAft>
+            </a:pPr>
+            <a:r>
+              <a:rPr sz="1500" b="1">
+                <a:solidFill>
+                  <a:srgbClr val="E0A437"/>
+                </a:solidFill>
+                <a:latin typeface="Fira Sans"/>
+              </a:rPr>
+              <a:t>▸ </a:t>
+            </a:r>
+            <a:r>
+              <a:rPr sz="1500" b="0">
+                <a:solidFill>
+                  <a:srgbClr val="000000"/>
+                </a:solidFill>
+                <a:latin typeface="Fira Sans"/>
+              </a:rPr>
+              <a:t>Cada punto es una comuna: ingreso medio contra proporción de viajes en transporte público.</a:t>
+            </a:r>
+          </a:p>
+          <a:p>
+            <a:pPr>
+              <a:lnSpc>
+                <a:spcPct val="112000"/>
+              </a:lnSpc>
+              <a:spcAft>
+                <a:spcPts val="500"/>
+              </a:spcAft>
+            </a:pPr>
+            <a:r>
+              <a:rPr sz="1300" b="0">
+                <a:solidFill>
+                  <a:srgbClr val="333333"/>
+                </a:solidFill>
+                <a:latin typeface="Fira Sans"/>
+              </a:rPr>
+              <a:t>     ◦  </a:t>
+            </a:r>
+            <a:r>
+              <a:rPr sz="1300" b="0">
+                <a:solidFill>
+                  <a:srgbClr val="333333"/>
+                </a:solidFill>
+                <a:latin typeface="Fira Sans"/>
+              </a:rPr>
+              <a:t>Periferia (Buin, Melipilla): poco transporte público; la red no llega.</a:t>
+            </a:r>
+          </a:p>
+          <a:p>
+            <a:pPr>
+              <a:lnSpc>
+                <a:spcPct val="112000"/>
+              </a:lnSpc>
+              <a:spcAft>
+                <a:spcPts val="500"/>
+              </a:spcAft>
+            </a:pPr>
+            <a:r>
+              <a:rPr sz="1300" b="0">
+                <a:solidFill>
+                  <a:srgbClr val="333333"/>
+                </a:solidFill>
+                <a:latin typeface="Fira Sans"/>
+              </a:rPr>
+              <a:t>     ◦  </a:t>
+            </a:r>
+            <a:r>
+              <a:rPr sz="1300" b="0">
+                <a:solidFill>
+                  <a:srgbClr val="333333"/>
+                </a:solidFill>
+                <a:latin typeface="Fira Sans"/>
+              </a:rPr>
+              <a:t>Ingresos altos (Vitacura, Lo Barnechea): conectadas, con poco uso.</a:t>
+            </a:r>
+          </a:p>
+          <a:p>
+            <a:pPr>
+              <a:lnSpc>
+                <a:spcPct val="112000"/>
+              </a:lnSpc>
+              <a:spcAft>
+                <a:spcPts val="500"/>
+              </a:spcAft>
+            </a:pPr>
+            <a:r>
+              <a:rPr sz="1300" b="0">
+                <a:solidFill>
+                  <a:srgbClr val="333333"/>
+                </a:solidFill>
+                <a:latin typeface="Fira Sans"/>
+              </a:rPr>
+              <a:t>     ◦  </a:t>
+            </a:r>
+            <a:r>
+              <a:rPr sz="1300" b="0">
+                <a:solidFill>
+                  <a:srgbClr val="333333"/>
+                </a:solidFill>
+                <a:latin typeface="Fira Sans"/>
+              </a:rPr>
+              <a:t>Correlación de Pearson: -0,17. La asociación lineal es débil.</a:t>
+            </a:r>
+          </a:p>
+          <a:p>
+            <a:pPr>
+              <a:lnSpc>
+                <a:spcPct val="112000"/>
+              </a:lnSpc>
+              <a:spcAft>
+                <a:spcPts val="900"/>
+              </a:spcAft>
+            </a:pPr>
+            <a:r>
+              <a:rPr sz="1500" b="1">
+                <a:solidFill>
+                  <a:srgbClr val="E0A437"/>
+                </a:solidFill>
+                <a:latin typeface="Fira Sans"/>
+              </a:rPr>
+              <a:t>▸ </a:t>
+            </a:r>
+            <a:r>
+              <a:rPr sz="1500" b="1">
+                <a:solidFill>
+                  <a:srgbClr val="1D3557"/>
+                </a:solidFill>
+                <a:latin typeface="Fira Sans"/>
+              </a:rPr>
+              <a:t>Como vimos en el marco conceptual: el coeficiente no reemplaza al gráfico, y la asociación no autoriza verbos causales.</a:t>
             </a:r>
           </a:p>
         </p:txBody>
       </p:sp>
       <p:pic>
         <p:nvPicPr>
-          <p:cNvPr id="4" name="Picture 3" descr="10_heatmap_rutinas.png"/>
+          <p:cNvPr id="5" name="Picture 4" descr="09_ingreso_vs_tp.png"/>
           <p:cNvPicPr>
             <a:picLocks noChangeAspect="1"/>
           </p:cNvPicPr>
@@ -8024,48 +8188,14 @@
         </p:blipFill>
         <p:spPr>
           <a:xfrm>
-            <a:off x="1563778" y="1143000"/>
-            <a:ext cx="6016443" cy="3154680"/>
+            <a:off x="4892040" y="1371600"/>
+            <a:ext cx="3840480" cy="2526979"/>
           </a:xfrm>
           <a:prstGeom prst="rect">
             <a:avLst/>
           </a:prstGeom>
         </p:spPr>
       </p:pic>
-      <p:sp>
-        <p:nvSpPr>
-          <p:cNvPr id="5" name="TextBox 4"/>
-          <p:cNvSpPr txBox="1"/>
-          <p:nvPr/>
-        </p:nvSpPr>
-        <p:spPr>
-          <a:xfrm>
-            <a:off x="704088" y="4434840"/>
-            <a:ext cx="7744968" cy="457200"/>
-          </a:xfrm>
-          <a:prstGeom prst="rect">
-            <a:avLst/>
-          </a:prstGeom>
-          <a:noFill/>
-        </p:spPr>
-        <p:txBody>
-          <a:bodyPr wrap="square">
-            <a:spAutoFit/>
-          </a:bodyPr>
-          <a:lstStyle/>
-          <a:p>
-            <a:r>
-              <a:rPr sz="1300" b="0">
-                <a:solidFill>
-                  <a:srgbClr val="333333"/>
-                </a:solidFill>
-                <a:latin typeface="Fira Sans"/>
-              </a:rPr>
-              <a:t>El heatmap muestra 14 propósitos por 7 días en una sola figura: útil para tablas completas.</a:t>
-            </a:r>
-          </a:p>
-        </p:txBody>
-      </p:sp>
     </p:spTree>
   </p:cSld>
   <p:clrMapOvr>
@@ -8157,14 +8287,14 @@
                 </a:solidFill>
                 <a:latin typeface="Fira Sans"/>
               </a:rPr>
-              <a:t>Cuando los datos crecen</a:t>
+              <a:t>Los propósitos de viaje según el día de la semana</a:t>
             </a:r>
           </a:p>
         </p:txBody>
       </p:sp>
       <p:pic>
         <p:nvPicPr>
-          <p:cNvPr id="4" name="Picture 3" descr="14_escala_datos.png"/>
+          <p:cNvPr id="4" name="Picture 3" descr="10_heatmap_rutinas.png"/>
           <p:cNvPicPr>
             <a:picLocks noChangeAspect="1"/>
           </p:cNvPicPr>
@@ -8178,8 +8308,8 @@
         </p:blipFill>
         <p:spPr>
           <a:xfrm>
-            <a:off x="1417319" y="1143000"/>
-            <a:ext cx="6309360" cy="2324913"/>
+            <a:off x="1563778" y="1143000"/>
+            <a:ext cx="6016443" cy="3154680"/>
           </a:xfrm>
           <a:prstGeom prst="rect">
             <a:avLst/>
@@ -8215,7 +8345,7 @@
                 </a:solidFill>
                 <a:latin typeface="Fira Sans"/>
               </a:rPr>
-              <a:t>PySpark se usa con SQL o con sus propios DataFrames; Dask reparte operaciones estilo Pandas; Polars y DuckDB rinden en una sola máquina.</a:t>
+              <a:t>El heatmap muestra 14 propósitos por 7 días en una sola figura: útil para tablas completas.</a:t>
             </a:r>
           </a:p>
         </p:txBody>
@@ -8311,21 +8441,45 @@
                 </a:solidFill>
                 <a:latin typeface="Fira Sans"/>
               </a:rPr>
-              <a:t>Síntesis</a:t>
-            </a:r>
-          </a:p>
-        </p:txBody>
-      </p:sp>
-      <p:sp>
-        <p:nvSpPr>
-          <p:cNvPr id="4" name="TextBox 3"/>
+              <a:t>Cuando los datos crecen</a:t>
+            </a:r>
+          </a:p>
+        </p:txBody>
+      </p:sp>
+      <p:pic>
+        <p:nvPicPr>
+          <p:cNvPr id="4" name="Picture 3" descr="14_escala_datos.png"/>
+          <p:cNvPicPr>
+            <a:picLocks noChangeAspect="1"/>
+          </p:cNvPicPr>
+          <p:nvPr/>
+        </p:nvPicPr>
+        <p:blipFill>
+          <a:blip r:embed="rId2"/>
+          <a:stretch>
+            <a:fillRect/>
+          </a:stretch>
+        </p:blipFill>
+        <p:spPr>
+          <a:xfrm>
+            <a:off x="1417319" y="1143000"/>
+            <a:ext cx="6309360" cy="2324913"/>
+          </a:xfrm>
+          <a:prstGeom prst="rect">
+            <a:avLst/>
+          </a:prstGeom>
+        </p:spPr>
+      </p:pic>
+      <p:sp>
+        <p:nvSpPr>
+          <p:cNvPr id="5" name="TextBox 4"/>
           <p:cNvSpPr txBox="1"/>
           <p:nvPr/>
         </p:nvSpPr>
         <p:spPr>
           <a:xfrm>
-            <a:off x="704088" y="1353312"/>
-            <a:ext cx="7744968" cy="3300984"/>
+            <a:off x="704088" y="4434840"/>
+            <a:ext cx="7744968" cy="457200"/>
           </a:xfrm>
           <a:prstGeom prst="rect">
             <a:avLst/>
@@ -8338,143 +8492,14 @@
           </a:bodyPr>
           <a:lstStyle/>
           <a:p>
-            <a:pPr>
-              <a:lnSpc>
-                <a:spcPct val="112000"/>
-              </a:lnSpc>
-              <a:spcAft>
-                <a:spcPts val="900"/>
-              </a:spcAft>
-            </a:pPr>
-            <a:r>
-              <a:rPr sz="1800" b="1">
-                <a:solidFill>
-                  <a:srgbClr val="E0A437"/>
-                </a:solidFill>
-                <a:latin typeface="Fira Sans"/>
-              </a:rPr>
-              <a:t>▸ </a:t>
-            </a:r>
-            <a:r>
-              <a:rPr sz="1800" b="0">
-                <a:solidFill>
-                  <a:srgbClr val="000000"/>
-                </a:solidFill>
-                <a:latin typeface="Fira Sans"/>
-              </a:rPr>
-              <a:t>Un modelo es una simplificación con decisiones incorporadas; estimarlo puede buscar inferencia o predicción.</a:t>
-            </a:r>
-          </a:p>
-          <a:p>
-            <a:pPr>
-              <a:lnSpc>
-                <a:spcPct val="112000"/>
-              </a:lnSpc>
-              <a:spcAft>
-                <a:spcPts val="900"/>
-              </a:spcAft>
-            </a:pPr>
-            <a:r>
-              <a:rPr sz="1800" b="1">
-                <a:solidFill>
-                  <a:srgbClr val="E0A437"/>
-                </a:solidFill>
-                <a:latin typeface="Fira Sans"/>
-              </a:rPr>
-              <a:t>▸ </a:t>
-            </a:r>
-            <a:r>
-              <a:rPr sz="1800" b="0">
-                <a:solidFill>
-                  <a:srgbClr val="000000"/>
-                </a:solidFill>
-                <a:latin typeface="Fira Sans"/>
-              </a:rPr>
-              <a:t>Las asociaciones se reportan como asociaciones: la causalidad exige más que datos observacionales.</a:t>
-            </a:r>
-          </a:p>
-          <a:p>
-            <a:pPr>
-              <a:lnSpc>
-                <a:spcPct val="112000"/>
-              </a:lnSpc>
-              <a:spcAft>
-                <a:spcPts val="900"/>
-              </a:spcAft>
-            </a:pPr>
-            <a:r>
-              <a:rPr sz="1800" b="1">
-                <a:solidFill>
-                  <a:srgbClr val="E0A437"/>
-                </a:solidFill>
-                <a:latin typeface="Fira Sans"/>
-              </a:rPr>
-              <a:t>▸ </a:t>
-            </a:r>
-            <a:r>
-              <a:rPr sz="1800" b="0">
-                <a:solidFill>
-                  <a:srgbClr val="000000"/>
-                </a:solidFill>
-                <a:latin typeface="Fira Sans"/>
-              </a:rPr>
-              <a:t>El tipo de la variable, no su dtype, determina qué resúmenes tienen sentido.</a:t>
-            </a:r>
-          </a:p>
-          <a:p>
-            <a:pPr>
-              <a:lnSpc>
-                <a:spcPct val="112000"/>
-              </a:lnSpc>
-              <a:spcAft>
-                <a:spcPts val="900"/>
-              </a:spcAft>
-            </a:pPr>
-            <a:r>
-              <a:rPr sz="1800" b="1">
-                <a:solidFill>
-                  <a:srgbClr val="E0A437"/>
-                </a:solidFill>
-                <a:latin typeface="Fira Sans"/>
-              </a:rPr>
-              <a:t>▸ </a:t>
-            </a:r>
-            <a:r>
-              <a:rPr sz="1800" b="0">
-                <a:solidFill>
-                  <a:srgbClr val="000000"/>
-                </a:solidFill>
-                <a:latin typeface="Fira Sans"/>
-              </a:rPr>
-              <a:t>Con distribuciones asimétricas, la mediana y los percentiles describen mejor lo típico que la media.</a:t>
-            </a:r>
-          </a:p>
-          <a:p>
-            <a:pPr>
-              <a:lnSpc>
-                <a:spcPct val="112000"/>
-              </a:lnSpc>
-              <a:spcAft>
-                <a:spcPts val="900"/>
-              </a:spcAft>
-            </a:pPr>
-            <a:r>
-              <a:rPr sz="1800" b="1">
-                <a:solidFill>
-                  <a:srgbClr val="E0A437"/>
-                </a:solidFill>
-                <a:latin typeface="Fira Sans"/>
-              </a:rPr>
-              <a:t>▸ </a:t>
-            </a:r>
-            <a:r>
-              <a:rPr sz="1800" b="1">
-                <a:solidFill>
-                  <a:srgbClr val="1D3557"/>
-                </a:solidFill>
-                <a:latin typeface="Fira Sans"/>
-              </a:rPr>
-              <a:t>Ante toda cifra resumen: ¿de quién habla este número? ¿Muestra, subgrupo o ciudad?</a:t>
+            <a:r>
+              <a:rPr sz="1300" b="0">
+                <a:solidFill>
+                  <a:srgbClr val="333333"/>
+                </a:solidFill>
+                <a:latin typeface="Fira Sans"/>
+              </a:rPr>
+              <a:t>PySpark se usa con SQL o con sus propios DataFrames; Dask reparte operaciones estilo Pandas; Polars y DuckDB rinden en una sola máquina.</a:t>
             </a:r>
           </a:p>
         </p:txBody>
@@ -8570,7 +8595,7 @@
                 </a:solidFill>
                 <a:latin typeface="Fira Sans"/>
               </a:rPr>
-              <a:t>Segundo bloque: comienza la Tarea 1</a:t>
+              <a:t>Síntesis</a:t>
             </a:r>
           </a:p>
         </p:txBody>
@@ -8621,91 +8646,7 @@
                 </a:solidFill>
                 <a:latin typeface="Fira Sans"/>
               </a:rPr>
-              <a:t>El retrato de tu comuna: cada pareja adopta una comuna del Gran Santiago.</a:t>
-            </a:r>
-          </a:p>
-          <a:p>
-            <a:pPr>
-              <a:lnSpc>
-                <a:spcPct val="112000"/>
-              </a:lnSpc>
-              <a:spcAft>
-                <a:spcPts val="500"/>
-              </a:spcAft>
-            </a:pPr>
-            <a:r>
-              <a:rPr sz="1400" b="0">
-                <a:solidFill>
-                  <a:srgbClr val="333333"/>
-                </a:solidFill>
-                <a:latin typeface="Fira Sans"/>
-              </a:rPr>
-              <a:t>     ◦  </a:t>
-            </a:r>
-            <a:r>
-              <a:rPr sz="1400" b="0">
-                <a:solidFill>
-                  <a:srgbClr val="333333"/>
-                </a:solidFill>
-                <a:latin typeface="Fira Sans"/>
-              </a:rPr>
-              <a:t>Hoy: elegir la comuna y construir su retrato numérico.</a:t>
-            </a:r>
-          </a:p>
-          <a:p>
-            <a:pPr>
-              <a:lnSpc>
-                <a:spcPct val="112000"/>
-              </a:lnSpc>
-              <a:spcAft>
-                <a:spcPts val="500"/>
-              </a:spcAft>
-            </a:pPr>
-            <a:r>
-              <a:rPr sz="1400" b="0">
-                <a:solidFill>
-                  <a:srgbClr val="333333"/>
-                </a:solidFill>
-                <a:latin typeface="Fira Sans"/>
-              </a:rPr>
-              <a:t>     ◦  </a:t>
-            </a:r>
-            <a:r>
-              <a:rPr sz="1400" b="0">
-                <a:solidFill>
-                  <a:srgbClr val="333333"/>
-                </a:solidFill>
-                <a:latin typeface="Fira Sans"/>
-              </a:rPr>
-              <a:t>Próxima clase: el retrato gráfico, con métodos de visualización.</a:t>
-            </a:r>
-          </a:p>
-          <a:p>
-            <a:pPr>
-              <a:lnSpc>
-                <a:spcPct val="112000"/>
-              </a:lnSpc>
-              <a:spcAft>
-                <a:spcPts val="500"/>
-              </a:spcAft>
-            </a:pPr>
-            <a:r>
-              <a:rPr sz="1400" b="0">
-                <a:solidFill>
-                  <a:srgbClr val="333333"/>
-                </a:solidFill>
-                <a:latin typeface="Fira Sans"/>
-              </a:rPr>
-              <a:t>     ◦  </a:t>
-            </a:r>
-            <a:r>
-              <a:rPr sz="1400" b="0">
-                <a:solidFill>
-                  <a:srgbClr val="333333"/>
-                </a:solidFill>
-                <a:latin typeface="Fira Sans"/>
-              </a:rPr>
-              <a:t>Entrega del retrato completo: jueves 10 de septiembre, por Aula.</a:t>
+              <a:t>Un modelo es una simplificación con decisiones incorporadas; estimarlo puede buscar inferencia o predicción.</a:t>
             </a:r>
           </a:p>
           <a:p>
@@ -8733,7 +8674,7 @@
                 </a:solidFill>
                 <a:latin typeface="Fira Sans"/>
               </a:rPr>
-              <a:t>El enunciado está en evaluaciones/tareas/ y la guía de hoy en actividades/.</a:t>
+              <a:t>Las asociaciones se reportan como asociaciones: la causalidad exige más que datos observacionales.</a:t>
             </a:r>
           </a:p>
           <a:p>
@@ -8755,13 +8696,69 @@
               <a:t>▸ </a:t>
             </a:r>
             <a:r>
+              <a:rPr sz="1800" b="0">
+                <a:solidFill>
+                  <a:srgbClr val="000000"/>
+                </a:solidFill>
+                <a:latin typeface="Fira Sans"/>
+              </a:rPr>
+              <a:t>El tipo de la variable, no su dtype, determina qué resúmenes tienen sentido.</a:t>
+            </a:r>
+          </a:p>
+          <a:p>
+            <a:pPr>
+              <a:lnSpc>
+                <a:spcPct val="112000"/>
+              </a:lnSpc>
+              <a:spcAft>
+                <a:spcPts val="900"/>
+              </a:spcAft>
+            </a:pPr>
+            <a:r>
               <a:rPr sz="1800" b="1">
                 <a:solidFill>
+                  <a:srgbClr val="E0A437"/>
+                </a:solidFill>
+                <a:latin typeface="Fira Sans"/>
+              </a:rPr>
+              <a:t>▸ </a:t>
+            </a:r>
+            <a:r>
+              <a:rPr sz="1800" b="0">
+                <a:solidFill>
+                  <a:srgbClr val="000000"/>
+                </a:solidFill>
+                <a:latin typeface="Fira Sans"/>
+              </a:rPr>
+              <a:t>Con distribuciones asimétricas, la mediana y los percentiles describen mejor lo típico que la media.</a:t>
+            </a:r>
+          </a:p>
+          <a:p>
+            <a:pPr>
+              <a:lnSpc>
+                <a:spcPct val="112000"/>
+              </a:lnSpc>
+              <a:spcAft>
+                <a:spcPts val="900"/>
+              </a:spcAft>
+            </a:pPr>
+            <a:r>
+              <a:rPr sz="1800" b="1">
+                <a:solidFill>
+                  <a:srgbClr val="E0A437"/>
+                </a:solidFill>
+                <a:latin typeface="Fira Sans"/>
+              </a:rPr>
+              <a:t>▸ </a:t>
+            </a:r>
+            <a:r>
+              <a:rPr sz="1800" b="1">
+                <a:solidFill>
                   <a:srgbClr val="1D3557"/>
                 </a:solidFill>
                 <a:latin typeface="Fira Sans"/>
               </a:rPr>
-              <a:t>Lo que avancen en este bloque ya es parte de la tarea.</a:t>
+              <a:t>Ante toda cifra resumen: ¿de quién habla este número? ¿Muestra, subgrupo o ciudad?</a:t>
             </a:r>
           </a:p>
         </p:txBody>
@@ -8857,6 +8854,293 @@
                 </a:solidFill>
                 <a:latin typeface="Fira Sans"/>
               </a:rPr>
+              <a:t>Segundo bloque: comienza la Tarea 1</a:t>
+            </a:r>
+          </a:p>
+        </p:txBody>
+      </p:sp>
+      <p:sp>
+        <p:nvSpPr>
+          <p:cNvPr id="4" name="TextBox 3"/>
+          <p:cNvSpPr txBox="1"/>
+          <p:nvPr/>
+        </p:nvSpPr>
+        <p:spPr>
+          <a:xfrm>
+            <a:off x="704088" y="1353312"/>
+            <a:ext cx="7744968" cy="3300984"/>
+          </a:xfrm>
+          <a:prstGeom prst="rect">
+            <a:avLst/>
+          </a:prstGeom>
+          <a:noFill/>
+        </p:spPr>
+        <p:txBody>
+          <a:bodyPr wrap="square">
+            <a:spAutoFit/>
+          </a:bodyPr>
+          <a:lstStyle/>
+          <a:p>
+            <a:pPr>
+              <a:lnSpc>
+                <a:spcPct val="112000"/>
+              </a:lnSpc>
+              <a:spcAft>
+                <a:spcPts val="900"/>
+              </a:spcAft>
+            </a:pPr>
+            <a:r>
+              <a:rPr sz="1800" b="1">
+                <a:solidFill>
+                  <a:srgbClr val="E0A437"/>
+                </a:solidFill>
+                <a:latin typeface="Fira Sans"/>
+              </a:rPr>
+              <a:t>▸ </a:t>
+            </a:r>
+            <a:r>
+              <a:rPr sz="1800" b="0">
+                <a:solidFill>
+                  <a:srgbClr val="000000"/>
+                </a:solidFill>
+                <a:latin typeface="Fira Sans"/>
+              </a:rPr>
+              <a:t>El retrato de tu comuna: cada pareja adopta una comuna del Gran Santiago.</a:t>
+            </a:r>
+          </a:p>
+          <a:p>
+            <a:pPr>
+              <a:lnSpc>
+                <a:spcPct val="112000"/>
+              </a:lnSpc>
+              <a:spcAft>
+                <a:spcPts val="500"/>
+              </a:spcAft>
+            </a:pPr>
+            <a:r>
+              <a:rPr sz="1400" b="0">
+                <a:solidFill>
+                  <a:srgbClr val="333333"/>
+                </a:solidFill>
+                <a:latin typeface="Fira Sans"/>
+              </a:rPr>
+              <a:t>     ◦  </a:t>
+            </a:r>
+            <a:r>
+              <a:rPr sz="1400" b="0">
+                <a:solidFill>
+                  <a:srgbClr val="333333"/>
+                </a:solidFill>
+                <a:latin typeface="Fira Sans"/>
+              </a:rPr>
+              <a:t>Hoy: elegir la comuna y construir su retrato numérico.</a:t>
+            </a:r>
+          </a:p>
+          <a:p>
+            <a:pPr>
+              <a:lnSpc>
+                <a:spcPct val="112000"/>
+              </a:lnSpc>
+              <a:spcAft>
+                <a:spcPts val="500"/>
+              </a:spcAft>
+            </a:pPr>
+            <a:r>
+              <a:rPr sz="1400" b="0">
+                <a:solidFill>
+                  <a:srgbClr val="333333"/>
+                </a:solidFill>
+                <a:latin typeface="Fira Sans"/>
+              </a:rPr>
+              <a:t>     ◦  </a:t>
+            </a:r>
+            <a:r>
+              <a:rPr sz="1400" b="0">
+                <a:solidFill>
+                  <a:srgbClr val="333333"/>
+                </a:solidFill>
+                <a:latin typeface="Fira Sans"/>
+              </a:rPr>
+              <a:t>Próxima clase: el retrato gráfico, con métodos de visualización.</a:t>
+            </a:r>
+          </a:p>
+          <a:p>
+            <a:pPr>
+              <a:lnSpc>
+                <a:spcPct val="112000"/>
+              </a:lnSpc>
+              <a:spcAft>
+                <a:spcPts val="500"/>
+              </a:spcAft>
+            </a:pPr>
+            <a:r>
+              <a:rPr sz="1400" b="0">
+                <a:solidFill>
+                  <a:srgbClr val="333333"/>
+                </a:solidFill>
+                <a:latin typeface="Fira Sans"/>
+              </a:rPr>
+              <a:t>     ◦  </a:t>
+            </a:r>
+            <a:r>
+              <a:rPr sz="1400" b="0">
+                <a:solidFill>
+                  <a:srgbClr val="333333"/>
+                </a:solidFill>
+                <a:latin typeface="Fira Sans"/>
+              </a:rPr>
+              <a:t>Entrega del retrato completo: jueves 10 de septiembre, por Aula.</a:t>
+            </a:r>
+          </a:p>
+          <a:p>
+            <a:pPr>
+              <a:lnSpc>
+                <a:spcPct val="112000"/>
+              </a:lnSpc>
+              <a:spcAft>
+                <a:spcPts val="900"/>
+              </a:spcAft>
+            </a:pPr>
+            <a:r>
+              <a:rPr sz="1800" b="1">
+                <a:solidFill>
+                  <a:srgbClr val="E0A437"/>
+                </a:solidFill>
+                <a:latin typeface="Fira Sans"/>
+              </a:rPr>
+              <a:t>▸ </a:t>
+            </a:r>
+            <a:r>
+              <a:rPr sz="1800" b="0">
+                <a:solidFill>
+                  <a:srgbClr val="000000"/>
+                </a:solidFill>
+                <a:latin typeface="Fira Sans"/>
+              </a:rPr>
+              <a:t>El enunciado está en evaluaciones/tareas/ y la guía de hoy en actividades/.</a:t>
+            </a:r>
+          </a:p>
+          <a:p>
+            <a:pPr>
+              <a:lnSpc>
+                <a:spcPct val="112000"/>
+              </a:lnSpc>
+              <a:spcAft>
+                <a:spcPts val="900"/>
+              </a:spcAft>
+            </a:pPr>
+            <a:r>
+              <a:rPr sz="1800" b="1">
+                <a:solidFill>
+                  <a:srgbClr val="E0A437"/>
+                </a:solidFill>
+                <a:latin typeface="Fira Sans"/>
+              </a:rPr>
+              <a:t>▸ </a:t>
+            </a:r>
+            <a:r>
+              <a:rPr sz="1800" b="1">
+                <a:solidFill>
+                  <a:srgbClr val="1D3557"/>
+                </a:solidFill>
+                <a:latin typeface="Fira Sans"/>
+              </a:rPr>
+              <a:t>Lo que avancen en este bloque ya es parte de la tarea.</a:t>
+            </a:r>
+          </a:p>
+        </p:txBody>
+      </p:sp>
+    </p:spTree>
+  </p:cSld>
+  <p:clrMapOvr>
+    <a:masterClrMapping/>
+  </p:clrMapOvr>
+</p:sld>
+</file>
+
+<file path=ppt/slides/slide35.xml><?xml version="1.0" encoding="utf-8"?>
+<p:sld xmlns:a="http://schemas.openxmlformats.org/drawingml/2006/main" xmlns:p="http://schemas.openxmlformats.org/presentationml/2006/main" xmlns:r="http://schemas.openxmlformats.org/officeDocument/2006/relationships">
+  <p:cSld>
+    <p:spTree>
+      <p:nvGrpSpPr>
+        <p:cNvPr id="1" name=""/>
+        <p:cNvGrpSpPr/>
+        <p:nvPr/>
+      </p:nvGrpSpPr>
+      <p:grpSpPr/>
+      <p:sp>
+        <p:nvSpPr>
+          <p:cNvPr id="2" name="Rectangle 1"/>
+          <p:cNvSpPr/>
+          <p:nvPr/>
+        </p:nvSpPr>
+        <p:spPr>
+          <a:xfrm>
+            <a:off x="0" y="0"/>
+            <a:ext cx="9144000" cy="5138928"/>
+          </a:xfrm>
+          <a:prstGeom prst="rect">
+            <a:avLst/>
+          </a:prstGeom>
+          <a:solidFill>
+            <a:srgbClr val="FAFBFC"/>
+          </a:solidFill>
+          <a:ln>
+            <a:noFill/>
+          </a:ln>
+          <a:effectLst/>
+        </p:spPr>
+        <p:style>
+          <a:lnRef idx="1">
+            <a:schemeClr val="accent1"/>
+          </a:lnRef>
+          <a:fillRef idx="3">
+            <a:schemeClr val="accent1"/>
+          </a:fillRef>
+          <a:effectRef idx="2">
+            <a:schemeClr val="accent1"/>
+          </a:effectRef>
+          <a:fontRef idx="minor">
+            <a:schemeClr val="lt1"/>
+          </a:fontRef>
+        </p:style>
+        <p:txBody>
+          <a:bodyPr rtlCol="0" anchor="ctr"/>
+          <a:lstStyle/>
+          <a:p>
+            <a:pPr algn="ctr"/>
+          </a:p>
+        </p:txBody>
+      </p:sp>
+      <p:sp>
+        <p:nvSpPr>
+          <p:cNvPr id="3" name="TextBox 2"/>
+          <p:cNvSpPr txBox="1"/>
+          <p:nvPr/>
+        </p:nvSpPr>
+        <p:spPr>
+          <a:xfrm>
+            <a:off x="402336" y="301752"/>
+            <a:ext cx="8348472" cy="795528"/>
+          </a:xfrm>
+          <a:prstGeom prst="rect">
+            <a:avLst/>
+          </a:prstGeom>
+          <a:noFill/>
+        </p:spPr>
+        <p:txBody>
+          <a:bodyPr wrap="square">
+            <a:spAutoFit/>
+          </a:bodyPr>
+          <a:lstStyle/>
+          <a:p>
+            <a:r>
+              <a:rPr sz="2800" b="1">
+                <a:solidFill>
+                  <a:srgbClr val="0F0F0F"/>
+                </a:solidFill>
+                <a:latin typeface="Fira Sans"/>
+              </a:rPr>
               <a:t>Referencias</a:t>
             </a:r>
           </a:p>
@@ -9853,7 +10137,7 @@
                 </a:solidFill>
                 <a:latin typeface="Fira Sans"/>
               </a:rPr>
-              <a:t>Mide la asociación lineal: qué tan bien se ajustan los puntos a una recta. Entre -1 y 1 (Bruce, Bruce y Gedeck, 2020).</a:t>
+              <a:t>Mide la asociación lineal entre dos variables numéricas: qué tan bien se ajustan los puntos a una recta. Se denota r (Bruce, Bruce y Gedeck, 2020).</a:t>
             </a:r>
           </a:p>
           <a:p>
@@ -9881,7 +10165,7 @@
                 </a:solidFill>
                 <a:latin typeface="Fira Sans"/>
               </a:rPr>
-              <a:t>r = cov(X, Y) / (σX · σY): la covarianza estandarizada.</a:t>
+              <a:t>En la fórmula: xᵢ e yᵢ son los valores del par i; x̄ e ȳ, sus medias; n, el número de pares.</a:t>
             </a:r>
           </a:p>
           <a:p>
@@ -9909,7 +10193,7 @@
                 </a:solidFill>
                 <a:latin typeface="Fira Sans"/>
               </a:rPr>
-              <a:t>Un extremo entra multiplicando y puede dominar el resultado.</a:t>
+              <a:t>r = 1: recta creciente exacta; r = -1: decreciente exacta.</a:t>
             </a:r>
           </a:p>
           <a:p>
@@ -9937,35 +10221,7 @@
                 </a:solidFill>
                 <a:latin typeface="Fira Sans"/>
               </a:rPr>
-              <a:t>Una relación curva baja el coeficiente aunque la asociación sea fuerte.</a:t>
-            </a:r>
-          </a:p>
-          <a:p>
-            <a:pPr>
-              <a:lnSpc>
-                <a:spcPct val="112000"/>
-              </a:lnSpc>
-              <a:spcAft>
-                <a:spcPts val="500"/>
-              </a:spcAft>
-            </a:pPr>
-            <a:r>
-              <a:rPr sz="1300" b="0">
-                <a:solidFill>
-                  <a:srgbClr val="333333"/>
-                </a:solidFill>
-                <a:latin typeface="Fira Sans"/>
-              </a:rPr>
-              <a:t>     ◦  </a:t>
-            </a:r>
-            <a:r>
-              <a:rPr sz="1300" b="0">
-                <a:solidFill>
-                  <a:srgbClr val="333333"/>
-                </a:solidFill>
-                <a:latin typeface="Fira Sans"/>
-              </a:rPr>
-              <a:t>Transformar los datos cambia su valor.</a:t>
+              <a:t>r = 0: sin asociación lineal (puede existir asociación de otra forma).</a:t>
             </a:r>
           </a:p>
           <a:p>
@@ -10015,7 +10271,7 @@
         <p:spPr>
           <a:xfrm>
             <a:off x="4892040" y="1371600"/>
-            <a:ext cx="3840480" cy="3313850"/>
+            <a:ext cx="3840480" cy="3465730"/>
           </a:xfrm>
           <a:prstGeom prst="rect">
             <a:avLst/>
@@ -10164,7 +10420,7 @@
                 </a:solidFill>
                 <a:latin typeface="Fira Sans"/>
               </a:rPr>
-              <a:t>El mismo Pearson, calculado sobre los rangos: la posición de cada valor al ordenar.</a:t>
+              <a:t>El mismo Pearson, calculado sobre los rangos: la posición de cada valor al ordenar (1 = el menor). Se denota ρ (rho).</a:t>
             </a:r>
           </a:p>
           <a:p>
@@ -10192,7 +10448,7 @@
                 </a:solidFill>
                 <a:latin typeface="Fira Sans"/>
               </a:rPr>
-              <a:t>Sin empates:  ρ = 1 - 6·Σd² / (n·(n² - 1)),  con d la diferencia de rangos.</a:t>
+              <a:t>En la fórmula: dᵢ es la diferencia entre los rangos del caso i en ambas variables; n, el número de pares. Vale sin empates.</a:t>
             </a:r>
           </a:p>
           <a:p>
@@ -10220,7 +10476,7 @@
                 </a:solidFill>
                 <a:latin typeface="Fira Sans"/>
               </a:rPr>
-              <a:t>Los valores 5, 12, 8 y 200 tienen rangos 1, 3, 2 y 4: el 200 pasa a ser solo el cuarto.</a:t>
+              <a:t>Los valores 5, 12, 8 y 200 tienen rangos 1, 3, 2 y 4: la magnitud desaparece, queda el orden.</a:t>
             </a:r>
           </a:p>
           <a:p>
@@ -10248,7 +10504,7 @@
                 </a:solidFill>
                 <a:latin typeface="Fira Sans"/>
               </a:rPr>
-              <a:t>Robusto a extremos, invariante ante transformaciones monótonas, y válido para variables ordinales.</a:t>
+              <a:t>Mide asociación monotónica: robusto a extremos, invariante ante transformaciones monótonas, válido para ordinales.</a:t>
             </a:r>
           </a:p>
         </p:txBody>
@@ -10270,7 +10526,7 @@
         <p:spPr>
           <a:xfrm>
             <a:off x="4892040" y="1371600"/>
-            <a:ext cx="3840480" cy="3382599"/>
+            <a:ext cx="3840480" cy="3527147"/>
           </a:xfrm>
           <a:prstGeom prst="rect">
             <a:avLst/>
@@ -10522,7 +10778,7 @@
                 </a:solidFill>
                 <a:latin typeface="Fira Sans"/>
               </a:rPr>
-              <a:t>¿Cuándo usar cada coeficiente?</a:t>
+              <a:t>Cuando la relación no es lineal, el coeficiente puede ocultarla</a:t>
             </a:r>
           </a:p>
         </p:txBody>
@@ -10573,7 +10829,7 @@
                 </a:solidFill>
                 <a:latin typeface="Fira Sans"/>
               </a:rPr>
-              <a:t>Pearson: relación aproximadamente recta, sin extremos dominantes; antesala del modelo lineal.</a:t>
+              <a:t>Los viajes por persona según la edad: suben hasta los 30 a 40 años y luego bajan.</a:t>
             </a:r>
           </a:p>
           <a:p>
@@ -10601,7 +10857,7 @@
                 </a:solidFill>
                 <a:latin typeface="Fira Sans"/>
               </a:rPr>
-              <a:t>Spearman: asimetrías, extremos, curvas crecientes, o variables ordinales.</a:t>
+              <a:t>La asociación es clara, pero r = 0,04 y ρ = 0,05.</a:t>
             </a:r>
           </a:p>
           <a:p>
@@ -10629,7 +10885,7 @@
                 </a:solidFill>
                 <a:latin typeface="Fira Sans"/>
               </a:rPr>
-              <a:t>La brecha entre ambos es un diagnóstico: 0,43 contra 0,76 indica curva o extremos.</a:t>
+              <a:t>La relación no es monótona: el tramo que sube y el que baja se cancelan.</a:t>
             </a:r>
           </a:p>
           <a:p>
@@ -10657,7 +10913,7 @@
                 </a:solidFill>
                 <a:latin typeface="Fira Sans"/>
               </a:rPr>
-              <a:t>Tras el logaritmo, Pearson llega a 0,73, casi igual a Spearman.</a:t>
+              <a:t>Ni Pearson ni Spearman están diseñados para esta forma.</a:t>
             </a:r>
           </a:p>
           <a:p>
@@ -10685,14 +10941,14 @@
                 </a:solidFill>
                 <a:latin typeface="Fira Sans"/>
               </a:rPr>
-              <a:t>Calcule ambos; si difieren mucho, mire el gráfico antes de reportar.</a:t>
+              <a:t>Un coeficiente cercano a cero no demuestra ausencia de asociación: el gráfico sí la muestra.</a:t>
             </a:r>
           </a:p>
         </p:txBody>
       </p:sp>
       <p:pic>
         <p:nvPicPr>
-          <p:cNvPr id="5" name="Picture 4" descr="18_loglog.png"/>
+          <p:cNvPr id="5" name="Picture 4" descr="19_edad_viajes.png"/>
           <p:cNvPicPr>
             <a:picLocks noChangeAspect="1"/>
           </p:cNvPicPr>
@@ -10707,7 +10963,7 @@
         <p:spPr>
           <a:xfrm>
             <a:off x="4892040" y="1371600"/>
-            <a:ext cx="3840480" cy="3350924"/>
+            <a:ext cx="3840480" cy="2479524"/>
           </a:xfrm>
           <a:prstGeom prst="rect">
             <a:avLst/>

</xml_diff>

<commit_message>
Reemplazar pies de figura sentenciosos por datos concretos
El diagrama de tablas anota las llaves y la ruta de las tablas de parametros; el
DataFrame anota como se resuelven los codigos. Sin moralejas.

Co-Authored-By: Claude Fable 5 <noreply@anthropic.com>
</commit_message>
<xml_diff>
--- a/presentaciones/clase02_pandas_eda.pptx
+++ b/presentaciones/clase02_pandas_eda.pptx
@@ -5395,7 +5395,7 @@
                 </a:solidFill>
                 <a:latin typeface="Fira Sans"/>
               </a:rPr>
-              <a:t>Los códigos no significan nada sin sus tablas de parámetros: unirlas es parte del análisis.</a:t>
+              <a:t>Llaves: Hogar · Hogar + Persona · Hogar + Persona + Viaje. Los códigos se resuelven contra tablas_parametros/.</a:t>
             </a:r>
           </a:p>
         </p:txBody>
@@ -6209,7 +6209,7 @@
                 </a:solidFill>
                 <a:latin typeface="Fira Sans"/>
               </a:rPr>
-              <a:t>Una tabla con filas indexadas y columnas con nombre y tipo. Los códigos (comuna, propósito) se traducen con las tablas de parámetros, uniéndolas con merge.</a:t>
+              <a:t>Los códigos (ComunaOrigen, Proposito) se resuelven contra tablas_parametros/ con merge.</a:t>
             </a:r>
           </a:p>
         </p:txBody>

</xml_diff>

<commit_message>
Usar la sigla EDA y anteponer los factores de expansion en la exploracion
La definicion del analisis exploratorio incorpora la sigla EDA, la seccion de
exploracion la usa en su bajada, y los factores de expansion abren la seccion
antes de las demas figuras, porque condicionan todos los calculos que siguen.

Co-Authored-By: Claude Fable 5 <noreply@anthropic.com>
</commit_message>
<xml_diff>
--- a/presentaciones/clase02_pandas_eda.pptx
+++ b/presentaciones/clase02_pandas_eda.pptx
@@ -4628,7 +4628,7 @@
                 </a:solidFill>
                 <a:latin typeface="Fira Sans"/>
               </a:rPr>
-              <a:t>El análisis exploratorio de datos</a:t>
+              <a:t>El análisis exploratorio de datos (EDA)</a:t>
             </a:r>
           </a:p>
         </p:txBody>
@@ -4679,7 +4679,7 @@
                 </a:solidFill>
                 <a:latin typeface="Fira Sans"/>
               </a:rPr>
-              <a:t>La etapa en que se examinan los datos antes de modelarlos (Tukey, 1977).</a:t>
+              <a:t>La etapa en que se examinan los datos antes de modelarlos (EDA, por exploratory data analysis; Tukey, 1977).</a:t>
             </a:r>
           </a:p>
           <a:p>
@@ -6729,7 +6729,7 @@
                 </a:solidFill>
                 <a:latin typeface="Fira Sans"/>
               </a:rPr>
-              <a:t>Estadística descriptiva sobre datos reales</a:t>
+              <a:t>EDA sobre la EOD: estadística descriptiva ponderada</a:t>
             </a:r>
           </a:p>
         </p:txBody>
@@ -6825,149 +6825,14 @@
                 </a:solidFill>
                 <a:latin typeface="Fira Sans"/>
               </a:rPr>
-              <a:t>Viajes por persona: los ausentes también cuentan</a:t>
-            </a:r>
-          </a:p>
-        </p:txBody>
-      </p:sp>
-      <p:sp>
-        <p:nvSpPr>
-          <p:cNvPr id="4" name="TextBox 3"/>
-          <p:cNvSpPr txBox="1"/>
-          <p:nvPr/>
-        </p:nvSpPr>
-        <p:spPr>
-          <a:xfrm>
-            <a:off x="502920" y="1252728"/>
-            <a:ext cx="4023360" cy="3200400"/>
-          </a:xfrm>
-          <a:prstGeom prst="rect">
-            <a:avLst/>
-          </a:prstGeom>
-          <a:noFill/>
-        </p:spPr>
-        <p:txBody>
-          <a:bodyPr wrap="square">
-            <a:spAutoFit/>
-          </a:bodyPr>
-          <a:lstStyle/>
-          <a:p>
-            <a:pPr>
-              <a:lnSpc>
-                <a:spcPct val="112000"/>
-              </a:lnSpc>
-              <a:spcAft>
-                <a:spcPts val="900"/>
-              </a:spcAft>
-            </a:pPr>
-            <a:r>
-              <a:rPr sz="1500" b="1">
-                <a:solidFill>
-                  <a:srgbClr val="E0A437"/>
-                </a:solidFill>
-                <a:latin typeface="Fira Sans"/>
-              </a:rPr>
-              <a:t>▸ </a:t>
-            </a:r>
-            <a:r>
-              <a:rPr sz="1500" b="0">
-                <a:solidFill>
-                  <a:srgbClr val="000000"/>
-                </a:solidFill>
-                <a:latin typeface="Fira Sans"/>
-              </a:rPr>
-              <a:t>El 23% de las personas no viajó ese día.</a:t>
-            </a:r>
-          </a:p>
-          <a:p>
-            <a:pPr>
-              <a:lnSpc>
-                <a:spcPct val="112000"/>
-              </a:lnSpc>
-              <a:spcAft>
-                <a:spcPts val="900"/>
-              </a:spcAft>
-            </a:pPr>
-            <a:r>
-              <a:rPr sz="1500" b="1">
-                <a:solidFill>
-                  <a:srgbClr val="E0A437"/>
-                </a:solidFill>
-                <a:latin typeface="Fira Sans"/>
-              </a:rPr>
-              <a:t>▸ </a:t>
-            </a:r>
-            <a:r>
-              <a:rPr sz="1500" b="0">
-                <a:solidFill>
-                  <a:srgbClr val="000000"/>
-                </a:solidFill>
-                <a:latin typeface="Fira Sans"/>
-              </a:rPr>
-              <a:t>Media: 1,9 viajes. Mediana: 2 viajes.</a:t>
-            </a:r>
-          </a:p>
-          <a:p>
-            <a:pPr>
-              <a:lnSpc>
-                <a:spcPct val="112000"/>
-              </a:lnSpc>
-              <a:spcAft>
-                <a:spcPts val="900"/>
-              </a:spcAft>
-            </a:pPr>
-            <a:r>
-              <a:rPr sz="1500" b="1">
-                <a:solidFill>
-                  <a:srgbClr val="E0A437"/>
-                </a:solidFill>
-                <a:latin typeface="Fira Sans"/>
-              </a:rPr>
-              <a:t>▸ </a:t>
-            </a:r>
-            <a:r>
-              <a:rPr sz="1500" b="0">
-                <a:solidFill>
-                  <a:srgbClr val="000000"/>
-                </a:solidFill>
-                <a:latin typeface="Fira Sans"/>
-              </a:rPr>
-              <a:t>La media quedó bajo la mediana: la masa de ceros la desplaza.</a:t>
-            </a:r>
-          </a:p>
-          <a:p>
-            <a:pPr>
-              <a:lnSpc>
-                <a:spcPct val="112000"/>
-              </a:lnSpc>
-              <a:spcAft>
-                <a:spcPts val="900"/>
-              </a:spcAft>
-            </a:pPr>
-            <a:r>
-              <a:rPr sz="1500" b="1">
-                <a:solidFill>
-                  <a:srgbClr val="E0A437"/>
-                </a:solidFill>
-                <a:latin typeface="Fira Sans"/>
-              </a:rPr>
-              <a:t>▸ </a:t>
-            </a:r>
-            <a:r>
-              <a:rPr sz="1500" b="1">
-                <a:solidFill>
-                  <a:srgbClr val="1D3557"/>
-                </a:solidFill>
-                <a:latin typeface="Fira Sans"/>
-              </a:rPr>
-              <a:t>La dirección del sesgo depende de la forma de la distribución.</a:t>
+              <a:t>Los factores de expansión: de la muestra a la ciudad</a:t>
             </a:r>
           </a:p>
         </p:txBody>
       </p:sp>
       <p:pic>
         <p:nvPicPr>
-          <p:cNvPr id="5" name="Picture 4" descr="02_viajes_por_persona.png"/>
+          <p:cNvPr id="4" name="Picture 3" descr="06_diagrama_factores.png"/>
           <p:cNvPicPr>
             <a:picLocks noChangeAspect="1"/>
           </p:cNvPicPr>
@@ -6981,14 +6846,48 @@
         </p:blipFill>
         <p:spPr>
           <a:xfrm>
-            <a:off x="4892040" y="1371600"/>
-            <a:ext cx="3840480" cy="2191739"/>
+            <a:off x="1417319" y="1143000"/>
+            <a:ext cx="6309360" cy="2871234"/>
           </a:xfrm>
           <a:prstGeom prst="rect">
             <a:avLst/>
           </a:prstGeom>
         </p:spPr>
       </p:pic>
+      <p:sp>
+        <p:nvSpPr>
+          <p:cNvPr id="5" name="TextBox 4"/>
+          <p:cNvSpPr txBox="1"/>
+          <p:nvPr/>
+        </p:nvSpPr>
+        <p:spPr>
+          <a:xfrm>
+            <a:off x="704088" y="4434840"/>
+            <a:ext cx="7744968" cy="457200"/>
+          </a:xfrm>
+          <a:prstGeom prst="rect">
+            <a:avLst/>
+          </a:prstGeom>
+          <a:noFill/>
+        </p:spPr>
+        <p:txBody>
+          <a:bodyPr wrap="square">
+            <a:spAutoFit/>
+          </a:bodyPr>
+          <a:lstStyle/>
+          <a:p>
+            <a:r>
+              <a:rPr sz="1300" b="0">
+                <a:solidFill>
+                  <a:srgbClr val="333333"/>
+                </a:solidFill>
+                <a:latin typeface="Fira Sans"/>
+              </a:rPr>
+              <a:t>Contar filas responde por la muestra; sumar factores responde por la ciudad.</a:t>
+            </a:r>
+          </a:p>
+        </p:txBody>
+      </p:sp>
     </p:spTree>
   </p:cSld>
   <p:clrMapOvr>
@@ -7080,14 +6979,149 @@
                 </a:solidFill>
                 <a:latin typeface="Fira Sans"/>
               </a:rPr>
-              <a:t>Los factores de expansión: de la muestra a la ciudad</a:t>
+              <a:t>Viajes por persona: los ausentes también cuentan</a:t>
+            </a:r>
+          </a:p>
+        </p:txBody>
+      </p:sp>
+      <p:sp>
+        <p:nvSpPr>
+          <p:cNvPr id="4" name="TextBox 3"/>
+          <p:cNvSpPr txBox="1"/>
+          <p:nvPr/>
+        </p:nvSpPr>
+        <p:spPr>
+          <a:xfrm>
+            <a:off x="502920" y="1252728"/>
+            <a:ext cx="4023360" cy="3200400"/>
+          </a:xfrm>
+          <a:prstGeom prst="rect">
+            <a:avLst/>
+          </a:prstGeom>
+          <a:noFill/>
+        </p:spPr>
+        <p:txBody>
+          <a:bodyPr wrap="square">
+            <a:spAutoFit/>
+          </a:bodyPr>
+          <a:lstStyle/>
+          <a:p>
+            <a:pPr>
+              <a:lnSpc>
+                <a:spcPct val="112000"/>
+              </a:lnSpc>
+              <a:spcAft>
+                <a:spcPts val="900"/>
+              </a:spcAft>
+            </a:pPr>
+            <a:r>
+              <a:rPr sz="1500" b="1">
+                <a:solidFill>
+                  <a:srgbClr val="E0A437"/>
+                </a:solidFill>
+                <a:latin typeface="Fira Sans"/>
+              </a:rPr>
+              <a:t>▸ </a:t>
+            </a:r>
+            <a:r>
+              <a:rPr sz="1500" b="0">
+                <a:solidFill>
+                  <a:srgbClr val="000000"/>
+                </a:solidFill>
+                <a:latin typeface="Fira Sans"/>
+              </a:rPr>
+              <a:t>El 23% de las personas no viajó ese día.</a:t>
+            </a:r>
+          </a:p>
+          <a:p>
+            <a:pPr>
+              <a:lnSpc>
+                <a:spcPct val="112000"/>
+              </a:lnSpc>
+              <a:spcAft>
+                <a:spcPts val="900"/>
+              </a:spcAft>
+            </a:pPr>
+            <a:r>
+              <a:rPr sz="1500" b="1">
+                <a:solidFill>
+                  <a:srgbClr val="E0A437"/>
+                </a:solidFill>
+                <a:latin typeface="Fira Sans"/>
+              </a:rPr>
+              <a:t>▸ </a:t>
+            </a:r>
+            <a:r>
+              <a:rPr sz="1500" b="0">
+                <a:solidFill>
+                  <a:srgbClr val="000000"/>
+                </a:solidFill>
+                <a:latin typeface="Fira Sans"/>
+              </a:rPr>
+              <a:t>Media: 1,9 viajes. Mediana: 2 viajes.</a:t>
+            </a:r>
+          </a:p>
+          <a:p>
+            <a:pPr>
+              <a:lnSpc>
+                <a:spcPct val="112000"/>
+              </a:lnSpc>
+              <a:spcAft>
+                <a:spcPts val="900"/>
+              </a:spcAft>
+            </a:pPr>
+            <a:r>
+              <a:rPr sz="1500" b="1">
+                <a:solidFill>
+                  <a:srgbClr val="E0A437"/>
+                </a:solidFill>
+                <a:latin typeface="Fira Sans"/>
+              </a:rPr>
+              <a:t>▸ </a:t>
+            </a:r>
+            <a:r>
+              <a:rPr sz="1500" b="0">
+                <a:solidFill>
+                  <a:srgbClr val="000000"/>
+                </a:solidFill>
+                <a:latin typeface="Fira Sans"/>
+              </a:rPr>
+              <a:t>La media quedó bajo la mediana: la masa de ceros la desplaza.</a:t>
+            </a:r>
+          </a:p>
+          <a:p>
+            <a:pPr>
+              <a:lnSpc>
+                <a:spcPct val="112000"/>
+              </a:lnSpc>
+              <a:spcAft>
+                <a:spcPts val="900"/>
+              </a:spcAft>
+            </a:pPr>
+            <a:r>
+              <a:rPr sz="1500" b="1">
+                <a:solidFill>
+                  <a:srgbClr val="E0A437"/>
+                </a:solidFill>
+                <a:latin typeface="Fira Sans"/>
+              </a:rPr>
+              <a:t>▸ </a:t>
+            </a:r>
+            <a:r>
+              <a:rPr sz="1500" b="1">
+                <a:solidFill>
+                  <a:srgbClr val="1D3557"/>
+                </a:solidFill>
+                <a:latin typeface="Fira Sans"/>
+              </a:rPr>
+              <a:t>La dirección del sesgo depende de la forma de la distribución.</a:t>
             </a:r>
           </a:p>
         </p:txBody>
       </p:sp>
       <p:pic>
         <p:nvPicPr>
-          <p:cNvPr id="4" name="Picture 3" descr="06_diagrama_factores.png"/>
+          <p:cNvPr id="5" name="Picture 4" descr="02_viajes_por_persona.png"/>
           <p:cNvPicPr>
             <a:picLocks noChangeAspect="1"/>
           </p:cNvPicPr>
@@ -7101,48 +7135,14 @@
         </p:blipFill>
         <p:spPr>
           <a:xfrm>
-            <a:off x="1417319" y="1143000"/>
-            <a:ext cx="6309360" cy="2871234"/>
+            <a:off x="4892040" y="1371600"/>
+            <a:ext cx="3840480" cy="2191739"/>
           </a:xfrm>
           <a:prstGeom prst="rect">
             <a:avLst/>
           </a:prstGeom>
         </p:spPr>
       </p:pic>
-      <p:sp>
-        <p:nvSpPr>
-          <p:cNvPr id="5" name="TextBox 4"/>
-          <p:cNvSpPr txBox="1"/>
-          <p:nvPr/>
-        </p:nvSpPr>
-        <p:spPr>
-          <a:xfrm>
-            <a:off x="704088" y="4434840"/>
-            <a:ext cx="7744968" cy="457200"/>
-          </a:xfrm>
-          <a:prstGeom prst="rect">
-            <a:avLst/>
-          </a:prstGeom>
-          <a:noFill/>
-        </p:spPr>
-        <p:txBody>
-          <a:bodyPr wrap="square">
-            <a:spAutoFit/>
-          </a:bodyPr>
-          <a:lstStyle/>
-          <a:p>
-            <a:r>
-              <a:rPr sz="1300" b="0">
-                <a:solidFill>
-                  <a:srgbClr val="333333"/>
-                </a:solidFill>
-                <a:latin typeface="Fira Sans"/>
-              </a:rPr>
-              <a:t>Contar filas responde por la muestra; sumar factores responde por la ciudad.</a:t>
-            </a:r>
-          </a:p>
-        </p:txBody>
-      </p:sp>
     </p:spTree>
   </p:cSld>
   <p:clrMapOvr>

</xml_diff>

<commit_message>
Definicion tecnica del DataFrame con sus fuentes
Slide nueva al inicio del repaso: origen del concepto (data.frame del lenguaje S,
Chambers y Hastie 1992; pandas, McKinney 2010) y las propiedades que explican su
rendimiento: columnas como arreglos tipados contiguos con operaciones vectorizadas,
alineacion por indice y algebra relacional en memoria. El notebook lleva la misma
nota y ambos suman las dos referencias, verificadas. Ademas quedan aplicados los
titulos descriptivos en las figuras y las consistencias de mayusculas y porcentajes.

Co-Authored-By: Claude Fable 5 <noreply@anthropic.com>
</commit_message>
<xml_diff>
--- a/presentaciones/clase02_pandas_eda.pptx
+++ b/presentaciones/clase02_pandas_eda.pptx
@@ -41,6 +41,7 @@
     <p:sldId id="289" r:id="rId40"/>
     <p:sldId id="290" r:id="rId41"/>
     <p:sldId id="291" r:id="rId42"/>
+    <p:sldId id="292" r:id="rId43"/>
   </p:sldIdLst>
   <p:sldSz cx="9144000" cy="5138928" type="screen4x3"/>
   <p:notesSz cx="6858000" cy="9144000"/>
@@ -5913,112 +5914,21 @@
                 </a:solidFill>
                 <a:latin typeface="Fira Sans"/>
               </a:rPr>
-              <a:t>Abrir el dataset</a:t>
-            </a:r>
-          </a:p>
-        </p:txBody>
-      </p:sp>
-      <p:sp>
-        <p:nvSpPr>
-          <p:cNvPr id="4" name="Rectangle 3"/>
-          <p:cNvSpPr/>
-          <p:nvPr/>
-        </p:nvSpPr>
-        <p:spPr>
-          <a:xfrm>
-            <a:off x="704088" y="1280160"/>
-            <a:ext cx="7744968" cy="2377440"/>
-          </a:xfrm>
-          <a:prstGeom prst="rect">
-            <a:avLst/>
-          </a:prstGeom>
-          <a:solidFill>
-            <a:srgbClr val="F0F2F5"/>
-          </a:solidFill>
-          <a:ln>
-            <a:solidFill>
-              <a:srgbClr val="D8DDE3"/>
-            </a:solidFill>
-          </a:ln>
-          <a:effectLst/>
-        </p:spPr>
-        <p:style>
-          <a:lnRef idx="1">
-            <a:schemeClr val="accent1"/>
-          </a:lnRef>
-          <a:fillRef idx="3">
-            <a:schemeClr val="accent1"/>
-          </a:fillRef>
-          <a:effectRef idx="2">
-            <a:schemeClr val="accent1"/>
-          </a:effectRef>
-          <a:fontRef idx="minor">
-            <a:schemeClr val="lt1"/>
-          </a:fontRef>
-        </p:style>
-        <p:txBody>
-          <a:bodyPr rtlCol="0" anchor="ctr" wrap="square" lIns="228600" tIns="137160"/>
-          <a:lstStyle/>
-          <a:p>
-            <a:pPr/>
-            <a:r>
-              <a:rPr sz="1500" b="0">
-                <a:solidFill>
-                  <a:srgbClr val="1D3557"/>
-                </a:solidFill>
-                <a:latin typeface="Menlo"/>
-              </a:rPr>
-              <a:t>import pandas as pd</a:t>
-            </a:r>
-          </a:p>
-          <a:p>
-            <a:pPr/>
-            <a:r>
-              <a:rPr sz="1500" b="0">
-                <a:solidFill>
-                  <a:srgbClr val="1D3557"/>
-                </a:solidFill>
-                <a:latin typeface="Menlo"/>
-              </a:rPr>
-              <a:t/>
-            </a:r>
-          </a:p>
-          <a:p>
-            <a:pPr/>
-            <a:r>
-              <a:rPr sz="1500" b="0">
-                <a:solidFill>
-                  <a:srgbClr val="1D3557"/>
-                </a:solidFill>
-                <a:latin typeface="Menlo"/>
-              </a:rPr>
-              <a:t>viajes = pd.read_csv('datos/eod_stgo/viajes.csv',</a:t>
-            </a:r>
-          </a:p>
-          <a:p>
-            <a:pPr/>
-            <a:r>
-              <a:rPr sz="1500" b="0">
-                <a:solidFill>
-                  <a:srgbClr val="1D3557"/>
-                </a:solidFill>
-                <a:latin typeface="Menlo"/>
-              </a:rPr>
-              <a:t>                     sep=';', decimal=',')</a:t>
-            </a:r>
-          </a:p>
-        </p:txBody>
-      </p:sp>
-      <p:sp>
-        <p:nvSpPr>
-          <p:cNvPr id="5" name="TextBox 4"/>
+              <a:t>El DataFrame: origen y propiedades</a:t>
+            </a:r>
+          </a:p>
+        </p:txBody>
+      </p:sp>
+      <p:sp>
+        <p:nvSpPr>
+          <p:cNvPr id="4" name="TextBox 3"/>
           <p:cNvSpPr txBox="1"/>
           <p:nvPr/>
         </p:nvSpPr>
         <p:spPr>
           <a:xfrm>
-            <a:off x="704088" y="3886200"/>
-            <a:ext cx="7744968" cy="1097280"/>
+            <a:off x="704088" y="1353312"/>
+            <a:ext cx="7744968" cy="3300984"/>
           </a:xfrm>
           <a:prstGeom prst="rect">
             <a:avLst/>
@@ -6040,7 +5950,7 @@
               </a:spcAft>
             </a:pPr>
             <a:r>
-              <a:rPr sz="1600" b="1">
+              <a:rPr sz="1800" b="1">
                 <a:solidFill>
                   <a:srgbClr val="E0A437"/>
                 </a:solidFill>
@@ -6049,13 +5959,153 @@
               <a:t>▸ </a:t>
             </a:r>
             <a:r>
-              <a:rPr sz="1600" b="0">
+              <a:rPr sz="1800" b="0">
                 <a:solidFill>
                   <a:srgbClr val="000000"/>
                 </a:solidFill>
                 <a:latin typeface="Fira Sans"/>
               </a:rPr>
-              <a:t>Todo el código de la clase está en el notebook 02_pandas_eda.ipynb del repositorio.</a:t>
+              <a:t>Estructura tabular bidimensional: columnas con nombre y tipo propio, filas indexadas.</a:t>
+            </a:r>
+          </a:p>
+          <a:p>
+            <a:pPr>
+              <a:lnSpc>
+                <a:spcPct val="112000"/>
+              </a:lnSpc>
+              <a:spcAft>
+                <a:spcPts val="900"/>
+              </a:spcAft>
+            </a:pPr>
+            <a:r>
+              <a:rPr sz="1800" b="1">
+                <a:solidFill>
+                  <a:srgbClr val="E0A437"/>
+                </a:solidFill>
+                <a:latin typeface="Fira Sans"/>
+              </a:rPr>
+              <a:t>▸ </a:t>
+            </a:r>
+            <a:r>
+              <a:rPr sz="1800" b="0">
+                <a:solidFill>
+                  <a:srgbClr val="000000"/>
+                </a:solidFill>
+                <a:latin typeface="Fira Sans"/>
+              </a:rPr>
+              <a:t>El concepto viene del lenguaje S: los objetos data.frame (Chambers y Hastie, 1992). Wes McKinney lo llevó a Python con pandas (McKinney, 2010).</a:t>
+            </a:r>
+          </a:p>
+          <a:p>
+            <a:pPr>
+              <a:lnSpc>
+                <a:spcPct val="112000"/>
+              </a:lnSpc>
+              <a:spcAft>
+                <a:spcPts val="500"/>
+              </a:spcAft>
+            </a:pPr>
+            <a:r>
+              <a:rPr sz="1400" b="0">
+                <a:solidFill>
+                  <a:srgbClr val="333333"/>
+                </a:solidFill>
+                <a:latin typeface="Fira Sans"/>
+              </a:rPr>
+              <a:t>     ◦  </a:t>
+            </a:r>
+            <a:r>
+              <a:rPr sz="1400" b="0">
+                <a:solidFill>
+                  <a:srgbClr val="333333"/>
+                </a:solidFill>
+                <a:latin typeface="Fira Sans"/>
+              </a:rPr>
+              <a:t>Cada columna es un arreglo tipado contiguo: las operaciones son vectorizadas, no ciclos de Python.</a:t>
+            </a:r>
+          </a:p>
+          <a:p>
+            <a:pPr>
+              <a:lnSpc>
+                <a:spcPct val="112000"/>
+              </a:lnSpc>
+              <a:spcAft>
+                <a:spcPts val="500"/>
+              </a:spcAft>
+            </a:pPr>
+            <a:r>
+              <a:rPr sz="1400" b="0">
+                <a:solidFill>
+                  <a:srgbClr val="333333"/>
+                </a:solidFill>
+                <a:latin typeface="Fira Sans"/>
+              </a:rPr>
+              <a:t>     ◦  </a:t>
+            </a:r>
+            <a:r>
+              <a:rPr sz="1400" b="0">
+                <a:solidFill>
+                  <a:srgbClr val="333333"/>
+                </a:solidFill>
+                <a:latin typeface="Fira Sans"/>
+              </a:rPr>
+              <a:t>El índice alinea los datos automáticamente en operaciones entre tablas y series.</a:t>
+            </a:r>
+          </a:p>
+          <a:p>
+            <a:pPr>
+              <a:lnSpc>
+                <a:spcPct val="112000"/>
+              </a:lnSpc>
+              <a:spcAft>
+                <a:spcPts val="500"/>
+              </a:spcAft>
+            </a:pPr>
+            <a:r>
+              <a:rPr sz="1400" b="0">
+                <a:solidFill>
+                  <a:srgbClr val="333333"/>
+                </a:solidFill>
+                <a:latin typeface="Fira Sans"/>
+              </a:rPr>
+              <a:t>     ◦  </a:t>
+            </a:r>
+            <a:r>
+              <a:rPr sz="1400" b="0">
+                <a:solidFill>
+                  <a:srgbClr val="333333"/>
+                </a:solidFill>
+                <a:latin typeface="Fira Sans"/>
+              </a:rPr>
+              <a:t>Implementa el álgebra relacional en memoria: selección, proyección, join (merge) y agregación (groupby).</a:t>
+            </a:r>
+          </a:p>
+          <a:p>
+            <a:pPr>
+              <a:lnSpc>
+                <a:spcPct val="112000"/>
+              </a:lnSpc>
+              <a:spcAft>
+                <a:spcPts val="900"/>
+              </a:spcAft>
+            </a:pPr>
+            <a:r>
+              <a:rPr sz="1800" b="1">
+                <a:solidFill>
+                  <a:srgbClr val="E0A437"/>
+                </a:solidFill>
+                <a:latin typeface="Fira Sans"/>
+              </a:rPr>
+              <a:t>▸ </a:t>
+            </a:r>
+            <a:r>
+              <a:rPr sz="1800" b="1">
+                <a:solidFill>
+                  <a:srgbClr val="1D3557"/>
+                </a:solidFill>
+                <a:latin typeface="Fira Sans"/>
+              </a:rPr>
+              <a:t>La interfaz se volvió un estándar: Spark, Polars y Dask implementan DataFrames con esta misma idea.</a:t>
             </a:r>
           </a:p>
         </p:txBody>
@@ -6151,35 +6201,102 @@
                 </a:solidFill>
                 <a:latin typeface="Fira Sans"/>
               </a:rPr>
-              <a:t>El DataFrame: la estructura central de Pandas</a:t>
-            </a:r>
-          </a:p>
-        </p:txBody>
-      </p:sp>
-      <p:pic>
-        <p:nvPicPr>
-          <p:cNvPr id="4" name="Picture 3" descr="13_dataframe.png"/>
-          <p:cNvPicPr>
-            <a:picLocks noChangeAspect="1"/>
-          </p:cNvPicPr>
-          <p:nvPr/>
-        </p:nvPicPr>
-        <p:blipFill>
-          <a:blip r:embed="rId2"/>
-          <a:stretch>
-            <a:fillRect/>
-          </a:stretch>
-        </p:blipFill>
-        <p:spPr>
-          <a:xfrm>
-            <a:off x="1417319" y="1143000"/>
-            <a:ext cx="6309360" cy="2553789"/>
-          </a:xfrm>
-          <a:prstGeom prst="rect">
-            <a:avLst/>
-          </a:prstGeom>
-        </p:spPr>
-      </p:pic>
+              <a:t>Abrir el dataset</a:t>
+            </a:r>
+          </a:p>
+        </p:txBody>
+      </p:sp>
+      <p:sp>
+        <p:nvSpPr>
+          <p:cNvPr id="4" name="Rectangle 3"/>
+          <p:cNvSpPr/>
+          <p:nvPr/>
+        </p:nvSpPr>
+        <p:spPr>
+          <a:xfrm>
+            <a:off x="704088" y="1280160"/>
+            <a:ext cx="7744968" cy="2377440"/>
+          </a:xfrm>
+          <a:prstGeom prst="rect">
+            <a:avLst/>
+          </a:prstGeom>
+          <a:solidFill>
+            <a:srgbClr val="F0F2F5"/>
+          </a:solidFill>
+          <a:ln>
+            <a:solidFill>
+              <a:srgbClr val="D8DDE3"/>
+            </a:solidFill>
+          </a:ln>
+          <a:effectLst/>
+        </p:spPr>
+        <p:style>
+          <a:lnRef idx="1">
+            <a:schemeClr val="accent1"/>
+          </a:lnRef>
+          <a:fillRef idx="3">
+            <a:schemeClr val="accent1"/>
+          </a:fillRef>
+          <a:effectRef idx="2">
+            <a:schemeClr val="accent1"/>
+          </a:effectRef>
+          <a:fontRef idx="minor">
+            <a:schemeClr val="lt1"/>
+          </a:fontRef>
+        </p:style>
+        <p:txBody>
+          <a:bodyPr rtlCol="0" anchor="ctr" wrap="square" lIns="228600" tIns="137160"/>
+          <a:lstStyle/>
+          <a:p>
+            <a:pPr/>
+            <a:r>
+              <a:rPr sz="1500" b="0">
+                <a:solidFill>
+                  <a:srgbClr val="1D3557"/>
+                </a:solidFill>
+                <a:latin typeface="Menlo"/>
+              </a:rPr>
+              <a:t>import pandas as pd</a:t>
+            </a:r>
+          </a:p>
+          <a:p>
+            <a:pPr/>
+            <a:r>
+              <a:rPr sz="1500" b="0">
+                <a:solidFill>
+                  <a:srgbClr val="1D3557"/>
+                </a:solidFill>
+                <a:latin typeface="Menlo"/>
+              </a:rPr>
+              <a:t/>
+            </a:r>
+          </a:p>
+          <a:p>
+            <a:pPr/>
+            <a:r>
+              <a:rPr sz="1500" b="0">
+                <a:solidFill>
+                  <a:srgbClr val="1D3557"/>
+                </a:solidFill>
+                <a:latin typeface="Menlo"/>
+              </a:rPr>
+              <a:t>viajes = pd.read_csv('datos/eod_stgo/viajes.csv',</a:t>
+            </a:r>
+          </a:p>
+          <a:p>
+            <a:pPr/>
+            <a:r>
+              <a:rPr sz="1500" b="0">
+                <a:solidFill>
+                  <a:srgbClr val="1D3557"/>
+                </a:solidFill>
+                <a:latin typeface="Menlo"/>
+              </a:rPr>
+              <a:t>                     sep=';', decimal=',')</a:t>
+            </a:r>
+          </a:p>
+        </p:txBody>
+      </p:sp>
       <p:sp>
         <p:nvSpPr>
           <p:cNvPr id="5" name="TextBox 4"/>
@@ -6188,8 +6305,8 @@
         </p:nvSpPr>
         <p:spPr>
           <a:xfrm>
-            <a:off x="704088" y="4434840"/>
-            <a:ext cx="7744968" cy="457200"/>
+            <a:off x="704088" y="3886200"/>
+            <a:ext cx="7744968" cy="1097280"/>
           </a:xfrm>
           <a:prstGeom prst="rect">
             <a:avLst/>
@@ -6202,14 +6319,31 @@
           </a:bodyPr>
           <a:lstStyle/>
           <a:p>
-            <a:r>
-              <a:rPr sz="1300" b="0">
-                <a:solidFill>
-                  <a:srgbClr val="333333"/>
-                </a:solidFill>
-                <a:latin typeface="Fira Sans"/>
-              </a:rPr>
-              <a:t>Los códigos (ComunaOrigen, Proposito) se resuelven contra tablas_parametros/ con merge.</a:t>
+            <a:pPr>
+              <a:lnSpc>
+                <a:spcPct val="112000"/>
+              </a:lnSpc>
+              <a:spcAft>
+                <a:spcPts val="900"/>
+              </a:spcAft>
+            </a:pPr>
+            <a:r>
+              <a:rPr sz="1600" b="1">
+                <a:solidFill>
+                  <a:srgbClr val="E0A437"/>
+                </a:solidFill>
+                <a:latin typeface="Fira Sans"/>
+              </a:rPr>
+              <a:t>▸ </a:t>
+            </a:r>
+            <a:r>
+              <a:rPr sz="1600" b="0">
+                <a:solidFill>
+                  <a:srgbClr val="000000"/>
+                </a:solidFill>
+                <a:latin typeface="Fira Sans"/>
+              </a:rPr>
+              <a:t>Todo el código de la clase está en el notebook 02_pandas_eda.ipynb del repositorio.</a:t>
             </a:r>
           </a:p>
         </p:txBody>
@@ -6305,14 +6439,14 @@
                 </a:solidFill>
                 <a:latin typeface="Fira Sans"/>
               </a:rPr>
-              <a:t>Las variantes del merge: qué filas se conservan</a:t>
+              <a:t>El DataFrame: la estructura central de Pandas</a:t>
             </a:r>
           </a:p>
         </p:txBody>
       </p:sp>
       <p:pic>
         <p:nvPicPr>
-          <p:cNvPr id="4" name="Picture 3" descr="07_diagrama_merge.png"/>
+          <p:cNvPr id="4" name="Picture 3" descr="13_dataframe.png"/>
           <p:cNvPicPr>
             <a:picLocks noChangeAspect="1"/>
           </p:cNvPicPr>
@@ -6327,7 +6461,7 @@
         <p:spPr>
           <a:xfrm>
             <a:off x="1417319" y="1143000"/>
-            <a:ext cx="6309360" cy="2397276"/>
+            <a:ext cx="6309360" cy="2553789"/>
           </a:xfrm>
           <a:prstGeom prst="rect">
             <a:avLst/>
@@ -6363,7 +6497,7 @@
                 </a:solidFill>
                 <a:latin typeface="Fira Sans"/>
               </a:rPr>
-              <a:t>El valor por defecto es inner: descarta sin aviso las filas sin pareja.</a:t>
+              <a:t>Los códigos (ComunaOrigen, Proposito) se resuelven contra tablas_parametros/ con merge.</a:t>
             </a:r>
           </a:p>
         </p:txBody>
@@ -6459,21 +6593,45 @@
                 </a:solidFill>
                 <a:latin typeface="Fira Sans"/>
               </a:rPr>
-              <a:t>El efecto del parámetro how sobre la población analizada</a:t>
-            </a:r>
-          </a:p>
-        </p:txBody>
-      </p:sp>
-      <p:sp>
-        <p:nvSpPr>
-          <p:cNvPr id="4" name="TextBox 3"/>
+              <a:t>Las variantes del merge: qué filas se conservan</a:t>
+            </a:r>
+          </a:p>
+        </p:txBody>
+      </p:sp>
+      <p:pic>
+        <p:nvPicPr>
+          <p:cNvPr id="4" name="Picture 3" descr="07_diagrama_merge.png"/>
+          <p:cNvPicPr>
+            <a:picLocks noChangeAspect="1"/>
+          </p:cNvPicPr>
+          <p:nvPr/>
+        </p:nvPicPr>
+        <p:blipFill>
+          <a:blip r:embed="rId2"/>
+          <a:stretch>
+            <a:fillRect/>
+          </a:stretch>
+        </p:blipFill>
+        <p:spPr>
+          <a:xfrm>
+            <a:off x="1417319" y="1143000"/>
+            <a:ext cx="6309360" cy="2397276"/>
+          </a:xfrm>
+          <a:prstGeom prst="rect">
+            <a:avLst/>
+          </a:prstGeom>
+        </p:spPr>
+      </p:pic>
+      <p:sp>
+        <p:nvSpPr>
+          <p:cNvPr id="5" name="TextBox 4"/>
           <p:cNvSpPr txBox="1"/>
           <p:nvPr/>
         </p:nvSpPr>
         <p:spPr>
           <a:xfrm>
-            <a:off x="704088" y="1353312"/>
-            <a:ext cx="7744968" cy="3300984"/>
+            <a:off x="704088" y="4434840"/>
+            <a:ext cx="7744968" cy="457200"/>
           </a:xfrm>
           <a:prstGeom prst="rect">
             <a:avLst/>
@@ -6486,143 +6644,14 @@
           </a:bodyPr>
           <a:lstStyle/>
           <a:p>
-            <a:pPr>
-              <a:lnSpc>
-                <a:spcPct val="112000"/>
-              </a:lnSpc>
-              <a:spcAft>
-                <a:spcPts val="900"/>
-              </a:spcAft>
-            </a:pPr>
-            <a:r>
-              <a:rPr sz="1800" b="1">
-                <a:solidFill>
-                  <a:srgbClr val="E0A437"/>
-                </a:solidFill>
-                <a:latin typeface="Fira Sans"/>
-              </a:rPr>
-              <a:t>▸ </a:t>
-            </a:r>
-            <a:r>
-              <a:rPr sz="1800" b="0">
-                <a:solidFill>
-                  <a:srgbClr val="000000"/>
-                </a:solidFill>
-                <a:latin typeface="Fira Sans"/>
-              </a:rPr>
-              <a:t>Personas con viajes, merge inner: 113.591 filas (una por viaje).</a:t>
-            </a:r>
-          </a:p>
-          <a:p>
-            <a:pPr>
-              <a:lnSpc>
-                <a:spcPct val="112000"/>
-              </a:lnSpc>
-              <a:spcAft>
-                <a:spcPts val="900"/>
-              </a:spcAft>
-            </a:pPr>
-            <a:r>
-              <a:rPr sz="1800" b="1">
-                <a:solidFill>
-                  <a:srgbClr val="E0A437"/>
-                </a:solidFill>
-                <a:latin typeface="Fira Sans"/>
-              </a:rPr>
-              <a:t>▸ </a:t>
-            </a:r>
-            <a:r>
-              <a:rPr sz="1800" b="0">
-                <a:solidFill>
-                  <a:srgbClr val="000000"/>
-                </a:solidFill>
-                <a:latin typeface="Fira Sans"/>
-              </a:rPr>
-              <a:t>El mismo merge en left: 127.379 filas.</a:t>
-            </a:r>
-          </a:p>
-          <a:p>
-            <a:pPr>
-              <a:lnSpc>
-                <a:spcPct val="112000"/>
-              </a:lnSpc>
-              <a:spcAft>
-                <a:spcPts val="500"/>
-              </a:spcAft>
-            </a:pPr>
-            <a:r>
-              <a:rPr sz="1400" b="0">
+            <a:r>
+              <a:rPr sz="1300" b="0">
                 <a:solidFill>
                   <a:srgbClr val="333333"/>
                 </a:solidFill>
                 <a:latin typeface="Fira Sans"/>
               </a:rPr>
-              <a:t>     ◦  </a:t>
-            </a:r>
-            <a:r>
-              <a:rPr sz="1400" b="0">
-                <a:solidFill>
-                  <a:srgbClr val="333333"/>
-                </a:solidFill>
-                <a:latin typeface="Fira Sans"/>
-              </a:rPr>
-              <a:t>La diferencia son 13.788 personas que no viajaron ese día.</a:t>
-            </a:r>
-          </a:p>
-          <a:p>
-            <a:pPr>
-              <a:lnSpc>
-                <a:spcPct val="112000"/>
-              </a:lnSpc>
-              <a:spcAft>
-                <a:spcPts val="500"/>
-              </a:spcAft>
-            </a:pPr>
-            <a:r>
-              <a:rPr sz="1400" b="0">
-                <a:solidFill>
-                  <a:srgbClr val="333333"/>
-                </a:solidFill>
-                <a:latin typeface="Fira Sans"/>
-              </a:rPr>
-              <a:t>     ◦  </a:t>
-            </a:r>
-            <a:r>
-              <a:rPr sz="1400" b="0">
-                <a:solidFill>
-                  <a:srgbClr val="333333"/>
-                </a:solidFill>
-                <a:latin typeface="Fira Sans"/>
-              </a:rPr>
-              <a:t>Con inner desaparecen; con left quedan, con NaN en el viaje.</a:t>
-            </a:r>
-          </a:p>
-          <a:p>
-            <a:pPr>
-              <a:lnSpc>
-                <a:spcPct val="112000"/>
-              </a:lnSpc>
-              <a:spcAft>
-                <a:spcPts val="900"/>
-              </a:spcAft>
-            </a:pPr>
-            <a:r>
-              <a:rPr sz="1800" b="1">
-                <a:solidFill>
-                  <a:srgbClr val="E0A437"/>
-                </a:solidFill>
-                <a:latin typeface="Fira Sans"/>
-              </a:rPr>
-              <a:t>▸ </a:t>
-            </a:r>
-            <a:r>
-              <a:rPr sz="1800" b="1">
-                <a:solidFill>
-                  <a:srgbClr val="1D3557"/>
-                </a:solidFill>
-                <a:latin typeface="Fira Sans"/>
-              </a:rPr>
-              <a:t>Un promedio calculado sobre el resultado del inner excluye a quienes no viajaron.</a:t>
+              <a:t>El valor por defecto es inner: descarta sin aviso las filas sin pareja.</a:t>
             </a:r>
           </a:p>
         </p:txBody>
@@ -6660,7 +6689,7 @@
             <a:avLst/>
           </a:prstGeom>
           <a:solidFill>
-            <a:srgbClr val="1D3557"/>
+            <a:srgbClr val="FAFBFC"/>
           </a:solidFill>
           <a:ln>
             <a:noFill/>
@@ -6697,8 +6726,8 @@
         </p:nvSpPr>
         <p:spPr>
           <a:xfrm>
-            <a:off x="603504" y="1847088"/>
-            <a:ext cx="7946136" cy="1399032"/>
+            <a:off x="402336" y="301752"/>
+            <a:ext cx="8348472" cy="795528"/>
           </a:xfrm>
           <a:prstGeom prst="rect">
             <a:avLst/>
@@ -6712,24 +6741,176 @@
           <a:lstStyle/>
           <a:p>
             <a:r>
-              <a:rPr sz="3400" b="1">
-                <a:solidFill>
-                  <a:srgbClr val="FFFFFF"/>
-                </a:solidFill>
-                <a:latin typeface="Fira Sans"/>
-              </a:rPr>
-              <a:t>Exploración de la EOD</a:t>
-            </a:r>
-          </a:p>
-          <a:p>
+              <a:rPr sz="2800" b="1">
+                <a:solidFill>
+                  <a:srgbClr val="0F0F0F"/>
+                </a:solidFill>
+                <a:latin typeface="Fira Sans"/>
+              </a:rPr>
+              <a:t>El efecto del parámetro how sobre la población analizada</a:t>
+            </a:r>
+          </a:p>
+        </p:txBody>
+      </p:sp>
+      <p:sp>
+        <p:nvSpPr>
+          <p:cNvPr id="4" name="TextBox 3"/>
+          <p:cNvSpPr txBox="1"/>
+          <p:nvPr/>
+        </p:nvSpPr>
+        <p:spPr>
+          <a:xfrm>
+            <a:off x="704088" y="1353312"/>
+            <a:ext cx="7744968" cy="3300984"/>
+          </a:xfrm>
+          <a:prstGeom prst="rect">
+            <a:avLst/>
+          </a:prstGeom>
+          <a:noFill/>
+        </p:spPr>
+        <p:txBody>
+          <a:bodyPr wrap="square">
+            <a:spAutoFit/>
+          </a:bodyPr>
+          <a:lstStyle/>
+          <a:p>
+            <a:pPr>
+              <a:lnSpc>
+                <a:spcPct val="112000"/>
+              </a:lnSpc>
+              <a:spcAft>
+                <a:spcPts val="900"/>
+              </a:spcAft>
+            </a:pPr>
+            <a:r>
+              <a:rPr sz="1800" b="1">
+                <a:solidFill>
+                  <a:srgbClr val="E0A437"/>
+                </a:solidFill>
+                <a:latin typeface="Fira Sans"/>
+              </a:rPr>
+              <a:t>▸ </a:t>
+            </a:r>
             <a:r>
               <a:rPr sz="1800" b="0">
                 <a:solidFill>
+                  <a:srgbClr val="000000"/>
+                </a:solidFill>
+                <a:latin typeface="Fira Sans"/>
+              </a:rPr>
+              <a:t>Personas con viajes, merge inner: 113.591 filas (una por viaje).</a:t>
+            </a:r>
+          </a:p>
+          <a:p>
+            <a:pPr>
+              <a:lnSpc>
+                <a:spcPct val="112000"/>
+              </a:lnSpc>
+              <a:spcAft>
+                <a:spcPts val="900"/>
+              </a:spcAft>
+            </a:pPr>
+            <a:r>
+              <a:rPr sz="1800" b="1">
+                <a:solidFill>
                   <a:srgbClr val="E0A437"/>
                 </a:solidFill>
                 <a:latin typeface="Fira Sans"/>
               </a:rPr>
-              <a:t>EDA sobre la EOD: estadística descriptiva ponderada</a:t>
+              <a:t>▸ </a:t>
+            </a:r>
+            <a:r>
+              <a:rPr sz="1800" b="0">
+                <a:solidFill>
+                  <a:srgbClr val="000000"/>
+                </a:solidFill>
+                <a:latin typeface="Fira Sans"/>
+              </a:rPr>
+              <a:t>El mismo merge en left: 127.379 filas.</a:t>
+            </a:r>
+          </a:p>
+          <a:p>
+            <a:pPr>
+              <a:lnSpc>
+                <a:spcPct val="112000"/>
+              </a:lnSpc>
+              <a:spcAft>
+                <a:spcPts val="500"/>
+              </a:spcAft>
+            </a:pPr>
+            <a:r>
+              <a:rPr sz="1400" b="0">
+                <a:solidFill>
+                  <a:srgbClr val="333333"/>
+                </a:solidFill>
+                <a:latin typeface="Fira Sans"/>
+              </a:rPr>
+              <a:t>     ◦  </a:t>
+            </a:r>
+            <a:r>
+              <a:rPr sz="1400" b="0">
+                <a:solidFill>
+                  <a:srgbClr val="333333"/>
+                </a:solidFill>
+                <a:latin typeface="Fira Sans"/>
+              </a:rPr>
+              <a:t>La diferencia son 13.788 personas que no viajaron ese día.</a:t>
+            </a:r>
+          </a:p>
+          <a:p>
+            <a:pPr>
+              <a:lnSpc>
+                <a:spcPct val="112000"/>
+              </a:lnSpc>
+              <a:spcAft>
+                <a:spcPts val="500"/>
+              </a:spcAft>
+            </a:pPr>
+            <a:r>
+              <a:rPr sz="1400" b="0">
+                <a:solidFill>
+                  <a:srgbClr val="333333"/>
+                </a:solidFill>
+                <a:latin typeface="Fira Sans"/>
+              </a:rPr>
+              <a:t>     ◦  </a:t>
+            </a:r>
+            <a:r>
+              <a:rPr sz="1400" b="0">
+                <a:solidFill>
+                  <a:srgbClr val="333333"/>
+                </a:solidFill>
+                <a:latin typeface="Fira Sans"/>
+              </a:rPr>
+              <a:t>Con inner desaparecen; con left quedan, con NaN en el viaje.</a:t>
+            </a:r>
+          </a:p>
+          <a:p>
+            <a:pPr>
+              <a:lnSpc>
+                <a:spcPct val="112000"/>
+              </a:lnSpc>
+              <a:spcAft>
+                <a:spcPts val="900"/>
+              </a:spcAft>
+            </a:pPr>
+            <a:r>
+              <a:rPr sz="1800" b="1">
+                <a:solidFill>
+                  <a:srgbClr val="E0A437"/>
+                </a:solidFill>
+                <a:latin typeface="Fira Sans"/>
+              </a:rPr>
+              <a:t>▸ </a:t>
+            </a:r>
+            <a:r>
+              <a:rPr sz="1800" b="1">
+                <a:solidFill>
+                  <a:srgbClr val="1D3557"/>
+                </a:solidFill>
+                <a:latin typeface="Fira Sans"/>
+              </a:rPr>
+              <a:t>Un promedio calculado sobre el resultado del inner excluye a quienes no viajaron.</a:t>
             </a:r>
           </a:p>
         </p:txBody>
@@ -6767,7 +6948,7 @@
             <a:avLst/>
           </a:prstGeom>
           <a:solidFill>
-            <a:srgbClr val="FAFBFC"/>
+            <a:srgbClr val="1D3557"/>
           </a:solidFill>
           <a:ln>
             <a:noFill/>
@@ -6804,8 +6985,8 @@
         </p:nvSpPr>
         <p:spPr>
           <a:xfrm>
-            <a:off x="402336" y="301752"/>
-            <a:ext cx="8348472" cy="795528"/>
+            <a:off x="603504" y="1847088"/>
+            <a:ext cx="7946136" cy="1399032"/>
           </a:xfrm>
           <a:prstGeom prst="rect">
             <a:avLst/>
@@ -6819,71 +7000,24 @@
           <a:lstStyle/>
           <a:p>
             <a:r>
-              <a:rPr sz="2800" b="1">
-                <a:solidFill>
-                  <a:srgbClr val="0F0F0F"/>
-                </a:solidFill>
-                <a:latin typeface="Fira Sans"/>
-              </a:rPr>
-              <a:t>Los factores de expansión: de la muestra a la ciudad</a:t>
-            </a:r>
-          </a:p>
-        </p:txBody>
-      </p:sp>
-      <p:pic>
-        <p:nvPicPr>
-          <p:cNvPr id="4" name="Picture 3" descr="06_diagrama_factores.png"/>
-          <p:cNvPicPr>
-            <a:picLocks noChangeAspect="1"/>
-          </p:cNvPicPr>
-          <p:nvPr/>
-        </p:nvPicPr>
-        <p:blipFill>
-          <a:blip r:embed="rId2"/>
-          <a:stretch>
-            <a:fillRect/>
-          </a:stretch>
-        </p:blipFill>
-        <p:spPr>
-          <a:xfrm>
-            <a:off x="1417319" y="1143000"/>
-            <a:ext cx="6309360" cy="2871234"/>
-          </a:xfrm>
-          <a:prstGeom prst="rect">
-            <a:avLst/>
-          </a:prstGeom>
-        </p:spPr>
-      </p:pic>
-      <p:sp>
-        <p:nvSpPr>
-          <p:cNvPr id="5" name="TextBox 4"/>
-          <p:cNvSpPr txBox="1"/>
-          <p:nvPr/>
-        </p:nvSpPr>
-        <p:spPr>
-          <a:xfrm>
-            <a:off x="704088" y="4434840"/>
-            <a:ext cx="7744968" cy="457200"/>
-          </a:xfrm>
-          <a:prstGeom prst="rect">
-            <a:avLst/>
-          </a:prstGeom>
-          <a:noFill/>
-        </p:spPr>
-        <p:txBody>
-          <a:bodyPr wrap="square">
-            <a:spAutoFit/>
-          </a:bodyPr>
-          <a:lstStyle/>
-          <a:p>
-            <a:r>
-              <a:rPr sz="1300" b="0">
-                <a:solidFill>
-                  <a:srgbClr val="333333"/>
-                </a:solidFill>
-                <a:latin typeface="Fira Sans"/>
-              </a:rPr>
-              <a:t>Contar filas responde por la muestra; sumar factores responde por la ciudad.</a:t>
+              <a:rPr sz="3400" b="1">
+                <a:solidFill>
+                  <a:srgbClr val="FFFFFF"/>
+                </a:solidFill>
+                <a:latin typeface="Fira Sans"/>
+              </a:rPr>
+              <a:t>Exploración de la EOD</a:t>
+            </a:r>
+          </a:p>
+          <a:p>
+            <a:r>
+              <a:rPr sz="1800" b="0">
+                <a:solidFill>
+                  <a:srgbClr val="E0A437"/>
+                </a:solidFill>
+                <a:latin typeface="Fira Sans"/>
+              </a:rPr>
+              <a:t>EDA sobre la EOD: estadística descriptiva ponderada</a:t>
             </a:r>
           </a:p>
         </p:txBody>
@@ -6979,149 +7113,14 @@
                 </a:solidFill>
                 <a:latin typeface="Fira Sans"/>
               </a:rPr>
-              <a:t>Viajes por persona: los ausentes también cuentan</a:t>
-            </a:r>
-          </a:p>
-        </p:txBody>
-      </p:sp>
-      <p:sp>
-        <p:nvSpPr>
-          <p:cNvPr id="4" name="TextBox 3"/>
-          <p:cNvSpPr txBox="1"/>
-          <p:nvPr/>
-        </p:nvSpPr>
-        <p:spPr>
-          <a:xfrm>
-            <a:off x="502920" y="1252728"/>
-            <a:ext cx="4023360" cy="3200400"/>
-          </a:xfrm>
-          <a:prstGeom prst="rect">
-            <a:avLst/>
-          </a:prstGeom>
-          <a:noFill/>
-        </p:spPr>
-        <p:txBody>
-          <a:bodyPr wrap="square">
-            <a:spAutoFit/>
-          </a:bodyPr>
-          <a:lstStyle/>
-          <a:p>
-            <a:pPr>
-              <a:lnSpc>
-                <a:spcPct val="112000"/>
-              </a:lnSpc>
-              <a:spcAft>
-                <a:spcPts val="900"/>
-              </a:spcAft>
-            </a:pPr>
-            <a:r>
-              <a:rPr sz="1500" b="1">
-                <a:solidFill>
-                  <a:srgbClr val="E0A437"/>
-                </a:solidFill>
-                <a:latin typeface="Fira Sans"/>
-              </a:rPr>
-              <a:t>▸ </a:t>
-            </a:r>
-            <a:r>
-              <a:rPr sz="1500" b="0">
-                <a:solidFill>
-                  <a:srgbClr val="000000"/>
-                </a:solidFill>
-                <a:latin typeface="Fira Sans"/>
-              </a:rPr>
-              <a:t>El 23% de las personas no viajó ese día.</a:t>
-            </a:r>
-          </a:p>
-          <a:p>
-            <a:pPr>
-              <a:lnSpc>
-                <a:spcPct val="112000"/>
-              </a:lnSpc>
-              <a:spcAft>
-                <a:spcPts val="900"/>
-              </a:spcAft>
-            </a:pPr>
-            <a:r>
-              <a:rPr sz="1500" b="1">
-                <a:solidFill>
-                  <a:srgbClr val="E0A437"/>
-                </a:solidFill>
-                <a:latin typeface="Fira Sans"/>
-              </a:rPr>
-              <a:t>▸ </a:t>
-            </a:r>
-            <a:r>
-              <a:rPr sz="1500" b="0">
-                <a:solidFill>
-                  <a:srgbClr val="000000"/>
-                </a:solidFill>
-                <a:latin typeface="Fira Sans"/>
-              </a:rPr>
-              <a:t>Media: 1,9 viajes. Mediana: 2 viajes.</a:t>
-            </a:r>
-          </a:p>
-          <a:p>
-            <a:pPr>
-              <a:lnSpc>
-                <a:spcPct val="112000"/>
-              </a:lnSpc>
-              <a:spcAft>
-                <a:spcPts val="900"/>
-              </a:spcAft>
-            </a:pPr>
-            <a:r>
-              <a:rPr sz="1500" b="1">
-                <a:solidFill>
-                  <a:srgbClr val="E0A437"/>
-                </a:solidFill>
-                <a:latin typeface="Fira Sans"/>
-              </a:rPr>
-              <a:t>▸ </a:t>
-            </a:r>
-            <a:r>
-              <a:rPr sz="1500" b="0">
-                <a:solidFill>
-                  <a:srgbClr val="000000"/>
-                </a:solidFill>
-                <a:latin typeface="Fira Sans"/>
-              </a:rPr>
-              <a:t>La media quedó bajo la mediana: la masa de ceros la desplaza.</a:t>
-            </a:r>
-          </a:p>
-          <a:p>
-            <a:pPr>
-              <a:lnSpc>
-                <a:spcPct val="112000"/>
-              </a:lnSpc>
-              <a:spcAft>
-                <a:spcPts val="900"/>
-              </a:spcAft>
-            </a:pPr>
-            <a:r>
-              <a:rPr sz="1500" b="1">
-                <a:solidFill>
-                  <a:srgbClr val="E0A437"/>
-                </a:solidFill>
-                <a:latin typeface="Fira Sans"/>
-              </a:rPr>
-              <a:t>▸ </a:t>
-            </a:r>
-            <a:r>
-              <a:rPr sz="1500" b="1">
-                <a:solidFill>
-                  <a:srgbClr val="1D3557"/>
-                </a:solidFill>
-                <a:latin typeface="Fira Sans"/>
-              </a:rPr>
-              <a:t>La dirección del sesgo depende de la forma de la distribución.</a:t>
+              <a:t>Los factores de expansión: de la muestra a la ciudad</a:t>
             </a:r>
           </a:p>
         </p:txBody>
       </p:sp>
       <p:pic>
         <p:nvPicPr>
-          <p:cNvPr id="5" name="Picture 4" descr="02_viajes_por_persona.png"/>
+          <p:cNvPr id="4" name="Picture 3" descr="06_diagrama_factores.png"/>
           <p:cNvPicPr>
             <a:picLocks noChangeAspect="1"/>
           </p:cNvPicPr>
@@ -7135,14 +7134,48 @@
         </p:blipFill>
         <p:spPr>
           <a:xfrm>
-            <a:off x="4892040" y="1371600"/>
-            <a:ext cx="3840480" cy="2191739"/>
+            <a:off x="1417319" y="1143000"/>
+            <a:ext cx="6309360" cy="2871234"/>
           </a:xfrm>
           <a:prstGeom prst="rect">
             <a:avLst/>
           </a:prstGeom>
         </p:spPr>
       </p:pic>
+      <p:sp>
+        <p:nvSpPr>
+          <p:cNvPr id="5" name="TextBox 4"/>
+          <p:cNvSpPr txBox="1"/>
+          <p:nvPr/>
+        </p:nvSpPr>
+        <p:spPr>
+          <a:xfrm>
+            <a:off x="704088" y="4434840"/>
+            <a:ext cx="7744968" cy="457200"/>
+          </a:xfrm>
+          <a:prstGeom prst="rect">
+            <a:avLst/>
+          </a:prstGeom>
+          <a:noFill/>
+        </p:spPr>
+        <p:txBody>
+          <a:bodyPr wrap="square">
+            <a:spAutoFit/>
+          </a:bodyPr>
+          <a:lstStyle/>
+          <a:p>
+            <a:r>
+              <a:rPr sz="1300" b="0">
+                <a:solidFill>
+                  <a:srgbClr val="333333"/>
+                </a:solidFill>
+                <a:latin typeface="Fira Sans"/>
+              </a:rPr>
+              <a:t>Contar filas responde por la muestra; sumar factores responde por la ciudad.</a:t>
+            </a:r>
+          </a:p>
+        </p:txBody>
+      </p:sp>
     </p:spTree>
   </p:cSld>
   <p:clrMapOvr>
@@ -7234,7 +7267,7 @@
                 </a:solidFill>
                 <a:latin typeface="Fira Sans"/>
               </a:rPr>
-              <a:t>El ingreso de los hogares: media y mediana</a:t>
+              <a:t>Viajes por persona: los ausentes también cuentan</a:t>
             </a:r>
           </a:p>
         </p:txBody>
@@ -7285,7 +7318,7 @@
                 </a:solidFill>
                 <a:latin typeface="Fira Sans"/>
               </a:rPr>
-              <a:t>Media: $688.274. Mediana: $507.826.</a:t>
+              <a:t>El 23% de las personas no viajó ese día.</a:t>
             </a:r>
           </a:p>
           <a:p>
@@ -7313,7 +7346,7 @@
                 </a:solidFill>
                 <a:latin typeface="Fira Sans"/>
               </a:rPr>
-              <a:t>La media es un 36% más alta que la mediana.</a:t>
+              <a:t>Media: 1,9 viajes. Mediana: 2 viajes.</a:t>
             </a:r>
           </a:p>
           <a:p>
@@ -7341,7 +7374,7 @@
                 </a:solidFill>
                 <a:latin typeface="Fira Sans"/>
               </a:rPr>
-              <a:t>Los ingresos altos desplazan el promedio; la mayoría gana menos.</a:t>
+              <a:t>La media quedó bajo la mediana: la masa de ceros la desplaza.</a:t>
             </a:r>
           </a:p>
           <a:p>
@@ -7369,14 +7402,14 @@
                 </a:solidFill>
                 <a:latin typeface="Fira Sans"/>
               </a:rPr>
-              <a:t>El promedio describe una situación en la que la mayoría no está.</a:t>
+              <a:t>La dirección del sesgo depende de la forma de la distribución.</a:t>
             </a:r>
           </a:p>
         </p:txBody>
       </p:sp>
       <p:pic>
         <p:nvPicPr>
-          <p:cNvPr id="5" name="Picture 4" descr="01_ingreso_media_mediana.png"/>
+          <p:cNvPr id="5" name="Picture 4" descr="02_viajes_por_persona.png"/>
           <p:cNvPicPr>
             <a:picLocks noChangeAspect="1"/>
           </p:cNvPicPr>
@@ -7391,7 +7424,7 @@
         <p:spPr>
           <a:xfrm>
             <a:off x="4892040" y="1371600"/>
-            <a:ext cx="3840480" cy="2182719"/>
+            <a:ext cx="3840480" cy="2199656"/>
           </a:xfrm>
           <a:prstGeom prst="rect">
             <a:avLst/>
@@ -7489,7 +7522,7 @@
                 </a:solidFill>
                 <a:latin typeface="Fira Sans"/>
               </a:rPr>
-              <a:t>La duración de los viajes: valores extremos</a:t>
+              <a:t>El ingreso de los hogares: media y mediana</a:t>
             </a:r>
           </a:p>
         </p:txBody>
@@ -7540,7 +7573,7 @@
                 </a:solidFill>
                 <a:latin typeface="Fira Sans"/>
               </a:rPr>
-              <a:t>Mediana: 30 minutos. Percentil 95: 98 minutos.</a:t>
+              <a:t>Media: $688.274. Mediana: $507.826.</a:t>
             </a:r>
           </a:p>
           <a:p>
@@ -7568,7 +7601,7 @@
                 </a:solidFill>
                 <a:latin typeface="Fira Sans"/>
               </a:rPr>
-              <a:t>Máximo registrado: 1.335 minutos, un viaje de 22 horas.</a:t>
+              <a:t>La media es un 36% más alta que la mediana.</a:t>
             </a:r>
           </a:p>
           <a:p>
@@ -7596,7 +7629,7 @@
                 </a:solidFill>
                 <a:latin typeface="Fira Sans"/>
               </a:rPr>
-              <a:t>¿Error de digitación? ¿Turno nocturno mal anotado?</a:t>
+              <a:t>Los ingresos altos desplazan el promedio; la mayoría gana menos.</a:t>
             </a:r>
           </a:p>
           <a:p>
@@ -7624,14 +7657,14 @@
                 </a:solidFill>
                 <a:latin typeface="Fira Sans"/>
               </a:rPr>
-              <a:t>Los valores extremos se investigan y la decisión se declara.</a:t>
+              <a:t>El promedio describe una situación en la que la mayoría no está.</a:t>
             </a:r>
           </a:p>
         </p:txBody>
       </p:sp>
       <p:pic>
         <p:nvPicPr>
-          <p:cNvPr id="5" name="Picture 4" descr="04_duracion_viajes.png"/>
+          <p:cNvPr id="5" name="Picture 4" descr="01_ingreso_media_mediana.png"/>
           <p:cNvPicPr>
             <a:picLocks noChangeAspect="1"/>
           </p:cNvPicPr>
@@ -7646,7 +7679,7 @@
         <p:spPr>
           <a:xfrm>
             <a:off x="4892040" y="1371600"/>
-            <a:ext cx="3840480" cy="2146492"/>
+            <a:ext cx="3840480" cy="2182719"/>
           </a:xfrm>
           <a:prstGeom prst="rect">
             <a:avLst/>
@@ -7744,7 +7777,7 @@
                 </a:solidFill>
                 <a:latin typeface="Fira Sans"/>
               </a:rPr>
-              <a:t>La partición modal del Gran Santiago</a:t>
+              <a:t>La duración de los viajes: valores extremos</a:t>
             </a:r>
           </a:p>
         </p:txBody>
@@ -7795,91 +7828,7 @@
                 </a:solidFill>
                 <a:latin typeface="Fira Sans"/>
               </a:rPr>
-              <a:t>Dos merges y un groupby ponderado por factor.</a:t>
-            </a:r>
-          </a:p>
-          <a:p>
-            <a:pPr>
-              <a:lnSpc>
-                <a:spcPct val="112000"/>
-              </a:lnSpc>
-              <a:spcAft>
-                <a:spcPts val="500"/>
-              </a:spcAft>
-            </a:pPr>
-            <a:r>
-              <a:rPr sz="1300" b="0">
-                <a:solidFill>
-                  <a:srgbClr val="333333"/>
-                </a:solidFill>
-                <a:latin typeface="Fira Sans"/>
-              </a:rPr>
-              <a:t>     ◦  </a:t>
-            </a:r>
-            <a:r>
-              <a:rPr sz="1300" b="0">
-                <a:solidFill>
-                  <a:srgbClr val="333333"/>
-                </a:solidFill>
-                <a:latin typeface="Fira Sans"/>
-              </a:rPr>
-              <a:t>Caminata: 34% de los viajes.</a:t>
-            </a:r>
-          </a:p>
-          <a:p>
-            <a:pPr>
-              <a:lnSpc>
-                <a:spcPct val="112000"/>
-              </a:lnSpc>
-              <a:spcAft>
-                <a:spcPts val="500"/>
-              </a:spcAft>
-            </a:pPr>
-            <a:r>
-              <a:rPr sz="1300" b="0">
-                <a:solidFill>
-                  <a:srgbClr val="333333"/>
-                </a:solidFill>
-                <a:latin typeface="Fira Sans"/>
-              </a:rPr>
-              <a:t>     ◦  </a:t>
-            </a:r>
-            <a:r>
-              <a:rPr sz="1300" b="0">
-                <a:solidFill>
-                  <a:srgbClr val="333333"/>
-                </a:solidFill>
-                <a:latin typeface="Fira Sans"/>
-              </a:rPr>
-              <a:t>Transporte público (Bip!): 24%.</a:t>
-            </a:r>
-          </a:p>
-          <a:p>
-            <a:pPr>
-              <a:lnSpc>
-                <a:spcPct val="112000"/>
-              </a:lnSpc>
-              <a:spcAft>
-                <a:spcPts val="500"/>
-              </a:spcAft>
-            </a:pPr>
-            <a:r>
-              <a:rPr sz="1300" b="0">
-                <a:solidFill>
-                  <a:srgbClr val="333333"/>
-                </a:solidFill>
-                <a:latin typeface="Fira Sans"/>
-              </a:rPr>
-              <a:t>     ◦  </a:t>
-            </a:r>
-            <a:r>
-              <a:rPr sz="1300" b="0">
-                <a:solidFill>
-                  <a:srgbClr val="333333"/>
-                </a:solidFill>
-                <a:latin typeface="Fira Sans"/>
-              </a:rPr>
-              <a:t>Auto: 23%.</a:t>
+              <a:t>Mediana: 30 minutos. Percentil 95: 98 minutos.</a:t>
             </a:r>
           </a:p>
           <a:p>
@@ -7901,20 +7850,76 @@
               <a:t>▸ </a:t>
             </a:r>
             <a:r>
+              <a:rPr sz="1500" b="0">
+                <a:solidFill>
+                  <a:srgbClr val="000000"/>
+                </a:solidFill>
+                <a:latin typeface="Fira Sans"/>
+              </a:rPr>
+              <a:t>Máximo registrado: 1.335 minutos, un viaje de 22 horas.</a:t>
+            </a:r>
+          </a:p>
+          <a:p>
+            <a:pPr>
+              <a:lnSpc>
+                <a:spcPct val="112000"/>
+              </a:lnSpc>
+              <a:spcAft>
+                <a:spcPts val="900"/>
+              </a:spcAft>
+            </a:pPr>
+            <a:r>
               <a:rPr sz="1500" b="1">
                 <a:solidFill>
+                  <a:srgbClr val="E0A437"/>
+                </a:solidFill>
+                <a:latin typeface="Fira Sans"/>
+              </a:rPr>
+              <a:t>▸ </a:t>
+            </a:r>
+            <a:r>
+              <a:rPr sz="1500" b="0">
+                <a:solidFill>
+                  <a:srgbClr val="000000"/>
+                </a:solidFill>
+                <a:latin typeface="Fira Sans"/>
+              </a:rPr>
+              <a:t>¿Error de digitación? ¿Turno nocturno mal anotado?</a:t>
+            </a:r>
+          </a:p>
+          <a:p>
+            <a:pPr>
+              <a:lnSpc>
+                <a:spcPct val="112000"/>
+              </a:lnSpc>
+              <a:spcAft>
+                <a:spcPts val="900"/>
+              </a:spcAft>
+            </a:pPr>
+            <a:r>
+              <a:rPr sz="1500" b="1">
+                <a:solidFill>
+                  <a:srgbClr val="E0A437"/>
+                </a:solidFill>
+                <a:latin typeface="Fira Sans"/>
+              </a:rPr>
+              <a:t>▸ </a:t>
+            </a:r>
+            <a:r>
+              <a:rPr sz="1500" b="1">
+                <a:solidFill>
                   <a:srgbClr val="1D3557"/>
                 </a:solidFill>
                 <a:latin typeface="Fira Sans"/>
               </a:rPr>
-              <a:t>Calculada desde los microdatos, con los factores de un día laboral.</a:t>
+              <a:t>Los valores extremos se investigan y la decisión se declara.</a:t>
             </a:r>
           </a:p>
         </p:txBody>
       </p:sp>
       <p:pic>
         <p:nvPicPr>
-          <p:cNvPr id="5" name="Picture 4" descr="03_reparto_modal.png"/>
+          <p:cNvPr id="5" name="Picture 4" descr="04_duracion_viajes.png"/>
           <p:cNvPicPr>
             <a:picLocks noChangeAspect="1"/>
           </p:cNvPicPr>
@@ -7929,7 +7934,7 @@
         <p:spPr>
           <a:xfrm>
             <a:off x="4892040" y="1371600"/>
-            <a:ext cx="3840480" cy="1938578"/>
+            <a:ext cx="3840480" cy="2170536"/>
           </a:xfrm>
           <a:prstGeom prst="rect">
             <a:avLst/>
@@ -8134,14 +8139,177 @@
                 </a:solidFill>
                 <a:latin typeface="Fira Sans"/>
               </a:rPr>
-              <a:t>El reparto modal difiere entre comunas</a:t>
+              <a:t>La partición modal del Gran Santiago</a:t>
+            </a:r>
+          </a:p>
+        </p:txBody>
+      </p:sp>
+      <p:sp>
+        <p:nvSpPr>
+          <p:cNvPr id="4" name="TextBox 3"/>
+          <p:cNvSpPr txBox="1"/>
+          <p:nvPr/>
+        </p:nvSpPr>
+        <p:spPr>
+          <a:xfrm>
+            <a:off x="502920" y="1252728"/>
+            <a:ext cx="4023360" cy="3200400"/>
+          </a:xfrm>
+          <a:prstGeom prst="rect">
+            <a:avLst/>
+          </a:prstGeom>
+          <a:noFill/>
+        </p:spPr>
+        <p:txBody>
+          <a:bodyPr wrap="square">
+            <a:spAutoFit/>
+          </a:bodyPr>
+          <a:lstStyle/>
+          <a:p>
+            <a:pPr>
+              <a:lnSpc>
+                <a:spcPct val="112000"/>
+              </a:lnSpc>
+              <a:spcAft>
+                <a:spcPts val="900"/>
+              </a:spcAft>
+            </a:pPr>
+            <a:r>
+              <a:rPr sz="1500" b="1">
+                <a:solidFill>
+                  <a:srgbClr val="E0A437"/>
+                </a:solidFill>
+                <a:latin typeface="Fira Sans"/>
+              </a:rPr>
+              <a:t>▸ </a:t>
+            </a:r>
+            <a:r>
+              <a:rPr sz="1500" b="0">
+                <a:solidFill>
+                  <a:srgbClr val="000000"/>
+                </a:solidFill>
+                <a:latin typeface="Fira Sans"/>
+              </a:rPr>
+              <a:t>Dos merges y un groupby ponderado por factor.</a:t>
+            </a:r>
+          </a:p>
+          <a:p>
+            <a:pPr>
+              <a:lnSpc>
+                <a:spcPct val="112000"/>
+              </a:lnSpc>
+              <a:spcAft>
+                <a:spcPts val="500"/>
+              </a:spcAft>
+            </a:pPr>
+            <a:r>
+              <a:rPr sz="1300" b="0">
+                <a:solidFill>
+                  <a:srgbClr val="333333"/>
+                </a:solidFill>
+                <a:latin typeface="Fira Sans"/>
+              </a:rPr>
+              <a:t>     ◦  </a:t>
+            </a:r>
+            <a:r>
+              <a:rPr sz="1300" b="0">
+                <a:solidFill>
+                  <a:srgbClr val="333333"/>
+                </a:solidFill>
+                <a:latin typeface="Fira Sans"/>
+              </a:rPr>
+              <a:t>Caminata: 34% de los viajes.</a:t>
+            </a:r>
+          </a:p>
+          <a:p>
+            <a:pPr>
+              <a:lnSpc>
+                <a:spcPct val="112000"/>
+              </a:lnSpc>
+              <a:spcAft>
+                <a:spcPts val="500"/>
+              </a:spcAft>
+            </a:pPr>
+            <a:r>
+              <a:rPr sz="1300" b="0">
+                <a:solidFill>
+                  <a:srgbClr val="333333"/>
+                </a:solidFill>
+                <a:latin typeface="Fira Sans"/>
+              </a:rPr>
+              <a:t>     ◦  </a:t>
+            </a:r>
+            <a:r>
+              <a:rPr sz="1300" b="0">
+                <a:solidFill>
+                  <a:srgbClr val="333333"/>
+                </a:solidFill>
+                <a:latin typeface="Fira Sans"/>
+              </a:rPr>
+              <a:t>Transporte público (Bip!): 24%.</a:t>
+            </a:r>
+          </a:p>
+          <a:p>
+            <a:pPr>
+              <a:lnSpc>
+                <a:spcPct val="112000"/>
+              </a:lnSpc>
+              <a:spcAft>
+                <a:spcPts val="500"/>
+              </a:spcAft>
+            </a:pPr>
+            <a:r>
+              <a:rPr sz="1300" b="0">
+                <a:solidFill>
+                  <a:srgbClr val="333333"/>
+                </a:solidFill>
+                <a:latin typeface="Fira Sans"/>
+              </a:rPr>
+              <a:t>     ◦  </a:t>
+            </a:r>
+            <a:r>
+              <a:rPr sz="1300" b="0">
+                <a:solidFill>
+                  <a:srgbClr val="333333"/>
+                </a:solidFill>
+                <a:latin typeface="Fira Sans"/>
+              </a:rPr>
+              <a:t>Auto: 23%.</a:t>
+            </a:r>
+          </a:p>
+          <a:p>
+            <a:pPr>
+              <a:lnSpc>
+                <a:spcPct val="112000"/>
+              </a:lnSpc>
+              <a:spcAft>
+                <a:spcPts val="900"/>
+              </a:spcAft>
+            </a:pPr>
+            <a:r>
+              <a:rPr sz="1500" b="1">
+                <a:solidFill>
+                  <a:srgbClr val="E0A437"/>
+                </a:solidFill>
+                <a:latin typeface="Fira Sans"/>
+              </a:rPr>
+              <a:t>▸ </a:t>
+            </a:r>
+            <a:r>
+              <a:rPr sz="1500" b="1">
+                <a:solidFill>
+                  <a:srgbClr val="1D3557"/>
+                </a:solidFill>
+                <a:latin typeface="Fira Sans"/>
+              </a:rPr>
+              <a:t>Calculada desde los microdatos, con los factores de un día laboral.</a:t>
             </a:r>
           </a:p>
         </p:txBody>
       </p:sp>
       <p:pic>
         <p:nvPicPr>
-          <p:cNvPr id="4" name="Picture 3" descr="08_modo_por_comuna.png"/>
+          <p:cNvPr id="5" name="Picture 4" descr="03_reparto_modal.png"/>
           <p:cNvPicPr>
             <a:picLocks noChangeAspect="1"/>
           </p:cNvPicPr>
@@ -8155,48 +8323,14 @@
         </p:blipFill>
         <p:spPr>
           <a:xfrm>
-            <a:off x="1994250" y="1143000"/>
-            <a:ext cx="5155498" cy="3154679"/>
+            <a:off x="4892040" y="1371600"/>
+            <a:ext cx="3840480" cy="1909061"/>
           </a:xfrm>
           <a:prstGeom prst="rect">
             <a:avLst/>
           </a:prstGeom>
         </p:spPr>
       </p:pic>
-      <p:sp>
-        <p:nvSpPr>
-          <p:cNvPr id="5" name="TextBox 4"/>
-          <p:cNvSpPr txBox="1"/>
-          <p:nvPr/>
-        </p:nvSpPr>
-        <p:spPr>
-          <a:xfrm>
-            <a:off x="704088" y="4434840"/>
-            <a:ext cx="7744968" cy="457200"/>
-          </a:xfrm>
-          <a:prstGeom prst="rect">
-            <a:avLst/>
-          </a:prstGeom>
-          <a:noFill/>
-        </p:spPr>
-        <p:txBody>
-          <a:bodyPr wrap="square">
-            <a:spAutoFit/>
-          </a:bodyPr>
-          <a:lstStyle/>
-          <a:p>
-            <a:r>
-              <a:rPr sz="1300" b="0">
-                <a:solidFill>
-                  <a:srgbClr val="333333"/>
-                </a:solidFill>
-                <a:latin typeface="Fira Sans"/>
-              </a:rPr>
-              <a:t>Normalizar por comuna permite comparar proporciones entre comunas de tamaños muy distintos.</a:t>
-            </a:r>
-          </a:p>
-        </p:txBody>
-      </p:sp>
     </p:spTree>
   </p:cSld>
   <p:clrMapOvr>
@@ -8288,177 +8422,14 @@
                 </a:solidFill>
                 <a:latin typeface="Fira Sans"/>
               </a:rPr>
-              <a:t>Ingreso y uso de transporte público</a:t>
-            </a:r>
-          </a:p>
-        </p:txBody>
-      </p:sp>
-      <p:sp>
-        <p:nvSpPr>
-          <p:cNvPr id="4" name="TextBox 3"/>
-          <p:cNvSpPr txBox="1"/>
-          <p:nvPr/>
-        </p:nvSpPr>
-        <p:spPr>
-          <a:xfrm>
-            <a:off x="502920" y="1252728"/>
-            <a:ext cx="4023360" cy="3200400"/>
-          </a:xfrm>
-          <a:prstGeom prst="rect">
-            <a:avLst/>
-          </a:prstGeom>
-          <a:noFill/>
-        </p:spPr>
-        <p:txBody>
-          <a:bodyPr wrap="square">
-            <a:spAutoFit/>
-          </a:bodyPr>
-          <a:lstStyle/>
-          <a:p>
-            <a:pPr>
-              <a:lnSpc>
-                <a:spcPct val="112000"/>
-              </a:lnSpc>
-              <a:spcAft>
-                <a:spcPts val="900"/>
-              </a:spcAft>
-            </a:pPr>
-            <a:r>
-              <a:rPr sz="1500" b="1">
-                <a:solidFill>
-                  <a:srgbClr val="E0A437"/>
-                </a:solidFill>
-                <a:latin typeface="Fira Sans"/>
-              </a:rPr>
-              <a:t>▸ </a:t>
-            </a:r>
-            <a:r>
-              <a:rPr sz="1500" b="0">
-                <a:solidFill>
-                  <a:srgbClr val="000000"/>
-                </a:solidFill>
-                <a:latin typeface="Fira Sans"/>
-              </a:rPr>
-              <a:t>Cada punto es una comuna: ingreso medio contra proporción de viajes en transporte público.</a:t>
-            </a:r>
-          </a:p>
-          <a:p>
-            <a:pPr>
-              <a:lnSpc>
-                <a:spcPct val="112000"/>
-              </a:lnSpc>
-              <a:spcAft>
-                <a:spcPts val="500"/>
-              </a:spcAft>
-            </a:pPr>
-            <a:r>
-              <a:rPr sz="1300" b="0">
-                <a:solidFill>
-                  <a:srgbClr val="333333"/>
-                </a:solidFill>
-                <a:latin typeface="Fira Sans"/>
-              </a:rPr>
-              <a:t>     ◦  </a:t>
-            </a:r>
-            <a:r>
-              <a:rPr sz="1300" b="0">
-                <a:solidFill>
-                  <a:srgbClr val="333333"/>
-                </a:solidFill>
-                <a:latin typeface="Fira Sans"/>
-              </a:rPr>
-              <a:t>Periferia (Buin, Melipilla): poco transporte público; la red no llega.</a:t>
-            </a:r>
-          </a:p>
-          <a:p>
-            <a:pPr>
-              <a:lnSpc>
-                <a:spcPct val="112000"/>
-              </a:lnSpc>
-              <a:spcAft>
-                <a:spcPts val="500"/>
-              </a:spcAft>
-            </a:pPr>
-            <a:r>
-              <a:rPr sz="1300" b="0">
-                <a:solidFill>
-                  <a:srgbClr val="333333"/>
-                </a:solidFill>
-                <a:latin typeface="Fira Sans"/>
-              </a:rPr>
-              <a:t>     ◦  </a:t>
-            </a:r>
-            <a:r>
-              <a:rPr sz="1300" b="0">
-                <a:solidFill>
-                  <a:srgbClr val="333333"/>
-                </a:solidFill>
-                <a:latin typeface="Fira Sans"/>
-              </a:rPr>
-              <a:t>Ingresos altos (Vitacura, Lo Barnechea): conectadas, con poco uso.</a:t>
-            </a:r>
-          </a:p>
-          <a:p>
-            <a:pPr>
-              <a:lnSpc>
-                <a:spcPct val="112000"/>
-              </a:lnSpc>
-              <a:spcAft>
-                <a:spcPts val="500"/>
-              </a:spcAft>
-            </a:pPr>
-            <a:r>
-              <a:rPr sz="1300" b="0">
-                <a:solidFill>
-                  <a:srgbClr val="333333"/>
-                </a:solidFill>
-                <a:latin typeface="Fira Sans"/>
-              </a:rPr>
-              <a:t>     ◦  </a:t>
-            </a:r>
-            <a:r>
-              <a:rPr sz="1300" b="0">
-                <a:solidFill>
-                  <a:srgbClr val="333333"/>
-                </a:solidFill>
-                <a:latin typeface="Fira Sans"/>
-              </a:rPr>
-              <a:t>Correlación de Pearson: -0,17. La asociación lineal es débil.</a:t>
-            </a:r>
-          </a:p>
-          <a:p>
-            <a:pPr>
-              <a:lnSpc>
-                <a:spcPct val="112000"/>
-              </a:lnSpc>
-              <a:spcAft>
-                <a:spcPts val="900"/>
-              </a:spcAft>
-            </a:pPr>
-            <a:r>
-              <a:rPr sz="1500" b="1">
-                <a:solidFill>
-                  <a:srgbClr val="E0A437"/>
-                </a:solidFill>
-                <a:latin typeface="Fira Sans"/>
-              </a:rPr>
-              <a:t>▸ </a:t>
-            </a:r>
-            <a:r>
-              <a:rPr sz="1500" b="1">
-                <a:solidFill>
-                  <a:srgbClr val="1D3557"/>
-                </a:solidFill>
-                <a:latin typeface="Fira Sans"/>
-              </a:rPr>
-              <a:t>Como vimos en el marco conceptual: el coeficiente no reemplaza al gráfico, y la asociación no autoriza verbos causales.</a:t>
+              <a:t>El reparto modal difiere entre comunas</a:t>
             </a:r>
           </a:p>
         </p:txBody>
       </p:sp>
       <p:pic>
         <p:nvPicPr>
-          <p:cNvPr id="5" name="Picture 4" descr="09_ingreso_vs_tp.png"/>
+          <p:cNvPr id="4" name="Picture 3" descr="08_modo_por_comuna.png"/>
           <p:cNvPicPr>
             <a:picLocks noChangeAspect="1"/>
           </p:cNvPicPr>
@@ -8472,14 +8443,48 @@
         </p:blipFill>
         <p:spPr>
           <a:xfrm>
-            <a:off x="4892040" y="1371600"/>
-            <a:ext cx="3840480" cy="2526979"/>
+            <a:off x="1994250" y="1143000"/>
+            <a:ext cx="5155498" cy="3154679"/>
           </a:xfrm>
           <a:prstGeom prst="rect">
             <a:avLst/>
           </a:prstGeom>
         </p:spPr>
       </p:pic>
+      <p:sp>
+        <p:nvSpPr>
+          <p:cNvPr id="5" name="TextBox 4"/>
+          <p:cNvSpPr txBox="1"/>
+          <p:nvPr/>
+        </p:nvSpPr>
+        <p:spPr>
+          <a:xfrm>
+            <a:off x="704088" y="4434840"/>
+            <a:ext cx="7744968" cy="457200"/>
+          </a:xfrm>
+          <a:prstGeom prst="rect">
+            <a:avLst/>
+          </a:prstGeom>
+          <a:noFill/>
+        </p:spPr>
+        <p:txBody>
+          <a:bodyPr wrap="square">
+            <a:spAutoFit/>
+          </a:bodyPr>
+          <a:lstStyle/>
+          <a:p>
+            <a:r>
+              <a:rPr sz="1300" b="0">
+                <a:solidFill>
+                  <a:srgbClr val="333333"/>
+                </a:solidFill>
+                <a:latin typeface="Fira Sans"/>
+              </a:rPr>
+              <a:t>Normalizar por comuna permite comparar proporciones entre comunas de tamaños muy distintos.</a:t>
+            </a:r>
+          </a:p>
+        </p:txBody>
+      </p:sp>
     </p:spTree>
   </p:cSld>
   <p:clrMapOvr>
@@ -8571,14 +8576,177 @@
                 </a:solidFill>
                 <a:latin typeface="Fira Sans"/>
               </a:rPr>
-              <a:t>Los propósitos de viaje según el día de la semana</a:t>
+              <a:t>Ingreso y uso de transporte público</a:t>
+            </a:r>
+          </a:p>
+        </p:txBody>
+      </p:sp>
+      <p:sp>
+        <p:nvSpPr>
+          <p:cNvPr id="4" name="TextBox 3"/>
+          <p:cNvSpPr txBox="1"/>
+          <p:nvPr/>
+        </p:nvSpPr>
+        <p:spPr>
+          <a:xfrm>
+            <a:off x="502920" y="1252728"/>
+            <a:ext cx="4023360" cy="3200400"/>
+          </a:xfrm>
+          <a:prstGeom prst="rect">
+            <a:avLst/>
+          </a:prstGeom>
+          <a:noFill/>
+        </p:spPr>
+        <p:txBody>
+          <a:bodyPr wrap="square">
+            <a:spAutoFit/>
+          </a:bodyPr>
+          <a:lstStyle/>
+          <a:p>
+            <a:pPr>
+              <a:lnSpc>
+                <a:spcPct val="112000"/>
+              </a:lnSpc>
+              <a:spcAft>
+                <a:spcPts val="900"/>
+              </a:spcAft>
+            </a:pPr>
+            <a:r>
+              <a:rPr sz="1500" b="1">
+                <a:solidFill>
+                  <a:srgbClr val="E0A437"/>
+                </a:solidFill>
+                <a:latin typeface="Fira Sans"/>
+              </a:rPr>
+              <a:t>▸ </a:t>
+            </a:r>
+            <a:r>
+              <a:rPr sz="1500" b="0">
+                <a:solidFill>
+                  <a:srgbClr val="000000"/>
+                </a:solidFill>
+                <a:latin typeface="Fira Sans"/>
+              </a:rPr>
+              <a:t>Cada punto es una comuna: ingreso medio contra proporción de viajes en transporte público.</a:t>
+            </a:r>
+          </a:p>
+          <a:p>
+            <a:pPr>
+              <a:lnSpc>
+                <a:spcPct val="112000"/>
+              </a:lnSpc>
+              <a:spcAft>
+                <a:spcPts val="500"/>
+              </a:spcAft>
+            </a:pPr>
+            <a:r>
+              <a:rPr sz="1300" b="0">
+                <a:solidFill>
+                  <a:srgbClr val="333333"/>
+                </a:solidFill>
+                <a:latin typeface="Fira Sans"/>
+              </a:rPr>
+              <a:t>     ◦  </a:t>
+            </a:r>
+            <a:r>
+              <a:rPr sz="1300" b="0">
+                <a:solidFill>
+                  <a:srgbClr val="333333"/>
+                </a:solidFill>
+                <a:latin typeface="Fira Sans"/>
+              </a:rPr>
+              <a:t>Periferia (Buin, Melipilla): poco transporte público; la red no llega.</a:t>
+            </a:r>
+          </a:p>
+          <a:p>
+            <a:pPr>
+              <a:lnSpc>
+                <a:spcPct val="112000"/>
+              </a:lnSpc>
+              <a:spcAft>
+                <a:spcPts val="500"/>
+              </a:spcAft>
+            </a:pPr>
+            <a:r>
+              <a:rPr sz="1300" b="0">
+                <a:solidFill>
+                  <a:srgbClr val="333333"/>
+                </a:solidFill>
+                <a:latin typeface="Fira Sans"/>
+              </a:rPr>
+              <a:t>     ◦  </a:t>
+            </a:r>
+            <a:r>
+              <a:rPr sz="1300" b="0">
+                <a:solidFill>
+                  <a:srgbClr val="333333"/>
+                </a:solidFill>
+                <a:latin typeface="Fira Sans"/>
+              </a:rPr>
+              <a:t>Ingresos altos (Vitacura, Lo Barnechea): conectadas, con poco uso.</a:t>
+            </a:r>
+          </a:p>
+          <a:p>
+            <a:pPr>
+              <a:lnSpc>
+                <a:spcPct val="112000"/>
+              </a:lnSpc>
+              <a:spcAft>
+                <a:spcPts val="500"/>
+              </a:spcAft>
+            </a:pPr>
+            <a:r>
+              <a:rPr sz="1300" b="0">
+                <a:solidFill>
+                  <a:srgbClr val="333333"/>
+                </a:solidFill>
+                <a:latin typeface="Fira Sans"/>
+              </a:rPr>
+              <a:t>     ◦  </a:t>
+            </a:r>
+            <a:r>
+              <a:rPr sz="1300" b="0">
+                <a:solidFill>
+                  <a:srgbClr val="333333"/>
+                </a:solidFill>
+                <a:latin typeface="Fira Sans"/>
+              </a:rPr>
+              <a:t>Correlación de Pearson: -0,17. La asociación lineal es débil.</a:t>
+            </a:r>
+          </a:p>
+          <a:p>
+            <a:pPr>
+              <a:lnSpc>
+                <a:spcPct val="112000"/>
+              </a:lnSpc>
+              <a:spcAft>
+                <a:spcPts val="900"/>
+              </a:spcAft>
+            </a:pPr>
+            <a:r>
+              <a:rPr sz="1500" b="1">
+                <a:solidFill>
+                  <a:srgbClr val="E0A437"/>
+                </a:solidFill>
+                <a:latin typeface="Fira Sans"/>
+              </a:rPr>
+              <a:t>▸ </a:t>
+            </a:r>
+            <a:r>
+              <a:rPr sz="1500" b="1">
+                <a:solidFill>
+                  <a:srgbClr val="1D3557"/>
+                </a:solidFill>
+                <a:latin typeface="Fira Sans"/>
+              </a:rPr>
+              <a:t>Como vimos en el marco conceptual: el coeficiente no reemplaza al gráfico, y la asociación no autoriza verbos causales.</a:t>
             </a:r>
           </a:p>
         </p:txBody>
       </p:sp>
       <p:pic>
         <p:nvPicPr>
-          <p:cNvPr id="4" name="Picture 3" descr="10_heatmap_rutinas.png"/>
+          <p:cNvPr id="5" name="Picture 4" descr="09_ingreso_vs_tp.png"/>
           <p:cNvPicPr>
             <a:picLocks noChangeAspect="1"/>
           </p:cNvPicPr>
@@ -8592,48 +8760,14 @@
         </p:blipFill>
         <p:spPr>
           <a:xfrm>
-            <a:off x="1563778" y="1143000"/>
-            <a:ext cx="6016443" cy="3154680"/>
+            <a:off x="4892040" y="1371600"/>
+            <a:ext cx="3840480" cy="2526979"/>
           </a:xfrm>
           <a:prstGeom prst="rect">
             <a:avLst/>
           </a:prstGeom>
         </p:spPr>
       </p:pic>
-      <p:sp>
-        <p:nvSpPr>
-          <p:cNvPr id="5" name="TextBox 4"/>
-          <p:cNvSpPr txBox="1"/>
-          <p:nvPr/>
-        </p:nvSpPr>
-        <p:spPr>
-          <a:xfrm>
-            <a:off x="704088" y="4434840"/>
-            <a:ext cx="7744968" cy="457200"/>
-          </a:xfrm>
-          <a:prstGeom prst="rect">
-            <a:avLst/>
-          </a:prstGeom>
-          <a:noFill/>
-        </p:spPr>
-        <p:txBody>
-          <a:bodyPr wrap="square">
-            <a:spAutoFit/>
-          </a:bodyPr>
-          <a:lstStyle/>
-          <a:p>
-            <a:r>
-              <a:rPr sz="1300" b="0">
-                <a:solidFill>
-                  <a:srgbClr val="333333"/>
-                </a:solidFill>
-                <a:latin typeface="Fira Sans"/>
-              </a:rPr>
-              <a:t>El heatmap muestra 14 propósitos por 7 días en una sola figura: útil para tablas completas.</a:t>
-            </a:r>
-          </a:p>
-        </p:txBody>
-      </p:sp>
     </p:spTree>
   </p:cSld>
   <p:clrMapOvr>
@@ -8725,14 +8859,14 @@
                 </a:solidFill>
                 <a:latin typeface="Fira Sans"/>
               </a:rPr>
-              <a:t>Cuando los datos crecen</a:t>
+              <a:t>Los propósitos de viaje según el día de la semana</a:t>
             </a:r>
           </a:p>
         </p:txBody>
       </p:sp>
       <p:pic>
         <p:nvPicPr>
-          <p:cNvPr id="4" name="Picture 3" descr="14_escala_datos.png"/>
+          <p:cNvPr id="4" name="Picture 3" descr="10_heatmap_rutinas.png"/>
           <p:cNvPicPr>
             <a:picLocks noChangeAspect="1"/>
           </p:cNvPicPr>
@@ -8746,8 +8880,8 @@
         </p:blipFill>
         <p:spPr>
           <a:xfrm>
-            <a:off x="1417319" y="1143000"/>
-            <a:ext cx="6309360" cy="2324913"/>
+            <a:off x="1649319" y="1143000"/>
+            <a:ext cx="5845360" cy="3154680"/>
           </a:xfrm>
           <a:prstGeom prst="rect">
             <a:avLst/>
@@ -8783,7 +8917,7 @@
                 </a:solidFill>
                 <a:latin typeface="Fira Sans"/>
               </a:rPr>
-              <a:t>PySpark se usa con SQL o con sus propios DataFrames; Dask reparte operaciones estilo Pandas; Polars y DuckDB rinden en una sola máquina.</a:t>
+              <a:t>El heatmap muestra 14 propósitos por 7 días en una sola figura: útil para tablas completas.</a:t>
             </a:r>
           </a:p>
         </p:txBody>
@@ -8879,21 +9013,45 @@
                 </a:solidFill>
                 <a:latin typeface="Fira Sans"/>
               </a:rPr>
-              <a:t>Síntesis</a:t>
-            </a:r>
-          </a:p>
-        </p:txBody>
-      </p:sp>
-      <p:sp>
-        <p:nvSpPr>
-          <p:cNvPr id="4" name="TextBox 3"/>
+              <a:t>Cuando los datos crecen</a:t>
+            </a:r>
+          </a:p>
+        </p:txBody>
+      </p:sp>
+      <p:pic>
+        <p:nvPicPr>
+          <p:cNvPr id="4" name="Picture 3" descr="14_escala_datos.png"/>
+          <p:cNvPicPr>
+            <a:picLocks noChangeAspect="1"/>
+          </p:cNvPicPr>
+          <p:nvPr/>
+        </p:nvPicPr>
+        <p:blipFill>
+          <a:blip r:embed="rId2"/>
+          <a:stretch>
+            <a:fillRect/>
+          </a:stretch>
+        </p:blipFill>
+        <p:spPr>
+          <a:xfrm>
+            <a:off x="1417319" y="1143000"/>
+            <a:ext cx="6309360" cy="2324913"/>
+          </a:xfrm>
+          <a:prstGeom prst="rect">
+            <a:avLst/>
+          </a:prstGeom>
+        </p:spPr>
+      </p:pic>
+      <p:sp>
+        <p:nvSpPr>
+          <p:cNvPr id="5" name="TextBox 4"/>
           <p:cNvSpPr txBox="1"/>
           <p:nvPr/>
         </p:nvSpPr>
         <p:spPr>
           <a:xfrm>
-            <a:off x="704088" y="1353312"/>
-            <a:ext cx="7744968" cy="3300984"/>
+            <a:off x="704088" y="4434840"/>
+            <a:ext cx="7744968" cy="457200"/>
           </a:xfrm>
           <a:prstGeom prst="rect">
             <a:avLst/>
@@ -8906,143 +9064,14 @@
           </a:bodyPr>
           <a:lstStyle/>
           <a:p>
-            <a:pPr>
-              <a:lnSpc>
-                <a:spcPct val="112000"/>
-              </a:lnSpc>
-              <a:spcAft>
-                <a:spcPts val="900"/>
-              </a:spcAft>
-            </a:pPr>
-            <a:r>
-              <a:rPr sz="1800" b="1">
-                <a:solidFill>
-                  <a:srgbClr val="E0A437"/>
-                </a:solidFill>
-                <a:latin typeface="Fira Sans"/>
-              </a:rPr>
-              <a:t>▸ </a:t>
-            </a:r>
-            <a:r>
-              <a:rPr sz="1800" b="0">
-                <a:solidFill>
-                  <a:srgbClr val="000000"/>
-                </a:solidFill>
-                <a:latin typeface="Fira Sans"/>
-              </a:rPr>
-              <a:t>Un modelo es una simplificación con decisiones incorporadas; estimarlo puede buscar inferencia o predicción.</a:t>
-            </a:r>
-          </a:p>
-          <a:p>
-            <a:pPr>
-              <a:lnSpc>
-                <a:spcPct val="112000"/>
-              </a:lnSpc>
-              <a:spcAft>
-                <a:spcPts val="900"/>
-              </a:spcAft>
-            </a:pPr>
-            <a:r>
-              <a:rPr sz="1800" b="1">
-                <a:solidFill>
-                  <a:srgbClr val="E0A437"/>
-                </a:solidFill>
-                <a:latin typeface="Fira Sans"/>
-              </a:rPr>
-              <a:t>▸ </a:t>
-            </a:r>
-            <a:r>
-              <a:rPr sz="1800" b="0">
-                <a:solidFill>
-                  <a:srgbClr val="000000"/>
-                </a:solidFill>
-                <a:latin typeface="Fira Sans"/>
-              </a:rPr>
-              <a:t>Las asociaciones se reportan como asociaciones: la causalidad exige más que datos observacionales.</a:t>
-            </a:r>
-          </a:p>
-          <a:p>
-            <a:pPr>
-              <a:lnSpc>
-                <a:spcPct val="112000"/>
-              </a:lnSpc>
-              <a:spcAft>
-                <a:spcPts val="900"/>
-              </a:spcAft>
-            </a:pPr>
-            <a:r>
-              <a:rPr sz="1800" b="1">
-                <a:solidFill>
-                  <a:srgbClr val="E0A437"/>
-                </a:solidFill>
-                <a:latin typeface="Fira Sans"/>
-              </a:rPr>
-              <a:t>▸ </a:t>
-            </a:r>
-            <a:r>
-              <a:rPr sz="1800" b="0">
-                <a:solidFill>
-                  <a:srgbClr val="000000"/>
-                </a:solidFill>
-                <a:latin typeface="Fira Sans"/>
-              </a:rPr>
-              <a:t>El tipo de la variable, no su dtype, determina qué resúmenes tienen sentido.</a:t>
-            </a:r>
-          </a:p>
-          <a:p>
-            <a:pPr>
-              <a:lnSpc>
-                <a:spcPct val="112000"/>
-              </a:lnSpc>
-              <a:spcAft>
-                <a:spcPts val="900"/>
-              </a:spcAft>
-            </a:pPr>
-            <a:r>
-              <a:rPr sz="1800" b="1">
-                <a:solidFill>
-                  <a:srgbClr val="E0A437"/>
-                </a:solidFill>
-                <a:latin typeface="Fira Sans"/>
-              </a:rPr>
-              <a:t>▸ </a:t>
-            </a:r>
-            <a:r>
-              <a:rPr sz="1800" b="0">
-                <a:solidFill>
-                  <a:srgbClr val="000000"/>
-                </a:solidFill>
-                <a:latin typeface="Fira Sans"/>
-              </a:rPr>
-              <a:t>Con distribuciones asimétricas, la mediana y los percentiles describen mejor lo típico que la media.</a:t>
-            </a:r>
-          </a:p>
-          <a:p>
-            <a:pPr>
-              <a:lnSpc>
-                <a:spcPct val="112000"/>
-              </a:lnSpc>
-              <a:spcAft>
-                <a:spcPts val="900"/>
-              </a:spcAft>
-            </a:pPr>
-            <a:r>
-              <a:rPr sz="1800" b="1">
-                <a:solidFill>
-                  <a:srgbClr val="E0A437"/>
-                </a:solidFill>
-                <a:latin typeface="Fira Sans"/>
-              </a:rPr>
-              <a:t>▸ </a:t>
-            </a:r>
-            <a:r>
-              <a:rPr sz="1800" b="1">
-                <a:solidFill>
-                  <a:srgbClr val="1D3557"/>
-                </a:solidFill>
-                <a:latin typeface="Fira Sans"/>
-              </a:rPr>
-              <a:t>Ante toda cifra resumen: ¿de quién habla este número? ¿Muestra, subgrupo o ciudad?</a:t>
+            <a:r>
+              <a:rPr sz="1300" b="0">
+                <a:solidFill>
+                  <a:srgbClr val="333333"/>
+                </a:solidFill>
+                <a:latin typeface="Fira Sans"/>
+              </a:rPr>
+              <a:t>PySpark se usa con SQL o con sus propios DataFrames; Dask reparte operaciones estilo Pandas; Polars y DuckDB rinden en una sola máquina.</a:t>
             </a:r>
           </a:p>
         </p:txBody>
@@ -9138,7 +9167,7 @@
                 </a:solidFill>
                 <a:latin typeface="Fira Sans"/>
               </a:rPr>
-              <a:t>Segundo bloque: comienza la Tarea 1</a:t>
+              <a:t>Síntesis</a:t>
             </a:r>
           </a:p>
         </p:txBody>
@@ -9189,91 +9218,7 @@
                 </a:solidFill>
                 <a:latin typeface="Fira Sans"/>
               </a:rPr>
-              <a:t>El retrato de tu comuna: cada pareja adopta una comuna del Gran Santiago.</a:t>
-            </a:r>
-          </a:p>
-          <a:p>
-            <a:pPr>
-              <a:lnSpc>
-                <a:spcPct val="112000"/>
-              </a:lnSpc>
-              <a:spcAft>
-                <a:spcPts val="500"/>
-              </a:spcAft>
-            </a:pPr>
-            <a:r>
-              <a:rPr sz="1400" b="0">
-                <a:solidFill>
-                  <a:srgbClr val="333333"/>
-                </a:solidFill>
-                <a:latin typeface="Fira Sans"/>
-              </a:rPr>
-              <a:t>     ◦  </a:t>
-            </a:r>
-            <a:r>
-              <a:rPr sz="1400" b="0">
-                <a:solidFill>
-                  <a:srgbClr val="333333"/>
-                </a:solidFill>
-                <a:latin typeface="Fira Sans"/>
-              </a:rPr>
-              <a:t>Hoy: elegir la comuna y construir su retrato numérico.</a:t>
-            </a:r>
-          </a:p>
-          <a:p>
-            <a:pPr>
-              <a:lnSpc>
-                <a:spcPct val="112000"/>
-              </a:lnSpc>
-              <a:spcAft>
-                <a:spcPts val="500"/>
-              </a:spcAft>
-            </a:pPr>
-            <a:r>
-              <a:rPr sz="1400" b="0">
-                <a:solidFill>
-                  <a:srgbClr val="333333"/>
-                </a:solidFill>
-                <a:latin typeface="Fira Sans"/>
-              </a:rPr>
-              <a:t>     ◦  </a:t>
-            </a:r>
-            <a:r>
-              <a:rPr sz="1400" b="0">
-                <a:solidFill>
-                  <a:srgbClr val="333333"/>
-                </a:solidFill>
-                <a:latin typeface="Fira Sans"/>
-              </a:rPr>
-              <a:t>Próxima clase: el retrato gráfico, con métodos de visualización.</a:t>
-            </a:r>
-          </a:p>
-          <a:p>
-            <a:pPr>
-              <a:lnSpc>
-                <a:spcPct val="112000"/>
-              </a:lnSpc>
-              <a:spcAft>
-                <a:spcPts val="500"/>
-              </a:spcAft>
-            </a:pPr>
-            <a:r>
-              <a:rPr sz="1400" b="0">
-                <a:solidFill>
-                  <a:srgbClr val="333333"/>
-                </a:solidFill>
-                <a:latin typeface="Fira Sans"/>
-              </a:rPr>
-              <a:t>     ◦  </a:t>
-            </a:r>
-            <a:r>
-              <a:rPr sz="1400" b="0">
-                <a:solidFill>
-                  <a:srgbClr val="333333"/>
-                </a:solidFill>
-                <a:latin typeface="Fira Sans"/>
-              </a:rPr>
-              <a:t>Entrega del retrato completo: jueves 10 de septiembre, por Aula.</a:t>
+              <a:t>Un modelo es una simplificación con decisiones incorporadas; estimarlo puede buscar inferencia o predicción.</a:t>
             </a:r>
           </a:p>
           <a:p>
@@ -9301,7 +9246,7 @@
                 </a:solidFill>
                 <a:latin typeface="Fira Sans"/>
               </a:rPr>
-              <a:t>El enunciado está en evaluaciones/tareas/ y la guía de hoy en actividades/.</a:t>
+              <a:t>Las asociaciones se reportan como asociaciones: la causalidad exige más que datos observacionales.</a:t>
             </a:r>
           </a:p>
           <a:p>
@@ -9323,13 +9268,69 @@
               <a:t>▸ </a:t>
             </a:r>
             <a:r>
+              <a:rPr sz="1800" b="0">
+                <a:solidFill>
+                  <a:srgbClr val="000000"/>
+                </a:solidFill>
+                <a:latin typeface="Fira Sans"/>
+              </a:rPr>
+              <a:t>El tipo de la variable, no su dtype, determina qué resúmenes tienen sentido.</a:t>
+            </a:r>
+          </a:p>
+          <a:p>
+            <a:pPr>
+              <a:lnSpc>
+                <a:spcPct val="112000"/>
+              </a:lnSpc>
+              <a:spcAft>
+                <a:spcPts val="900"/>
+              </a:spcAft>
+            </a:pPr>
+            <a:r>
               <a:rPr sz="1800" b="1">
                 <a:solidFill>
+                  <a:srgbClr val="E0A437"/>
+                </a:solidFill>
+                <a:latin typeface="Fira Sans"/>
+              </a:rPr>
+              <a:t>▸ </a:t>
+            </a:r>
+            <a:r>
+              <a:rPr sz="1800" b="0">
+                <a:solidFill>
+                  <a:srgbClr val="000000"/>
+                </a:solidFill>
+                <a:latin typeface="Fira Sans"/>
+              </a:rPr>
+              <a:t>Con distribuciones asimétricas, la mediana y los percentiles describen mejor lo típico que la media.</a:t>
+            </a:r>
+          </a:p>
+          <a:p>
+            <a:pPr>
+              <a:lnSpc>
+                <a:spcPct val="112000"/>
+              </a:lnSpc>
+              <a:spcAft>
+                <a:spcPts val="900"/>
+              </a:spcAft>
+            </a:pPr>
+            <a:r>
+              <a:rPr sz="1800" b="1">
+                <a:solidFill>
+                  <a:srgbClr val="E0A437"/>
+                </a:solidFill>
+                <a:latin typeface="Fira Sans"/>
+              </a:rPr>
+              <a:t>▸ </a:t>
+            </a:r>
+            <a:r>
+              <a:rPr sz="1800" b="1">
+                <a:solidFill>
                   <a:srgbClr val="1D3557"/>
                 </a:solidFill>
                 <a:latin typeface="Fira Sans"/>
               </a:rPr>
-              <a:t>Lo que avancen en este bloque ya es parte de la tarea.</a:t>
+              <a:t>Ante toda cifra resumen: ¿de quién habla este número? ¿Muestra, subgrupo o ciudad?</a:t>
             </a:r>
           </a:p>
         </p:txBody>
@@ -9425,7 +9426,7 @@
                 </a:solidFill>
                 <a:latin typeface="Fira Sans"/>
               </a:rPr>
-              <a:t>Referencias</a:t>
+              <a:t>Segundo bloque: comienza la Tarea 1</a:t>
             </a:r>
           </a:p>
         </p:txBody>
@@ -9476,7 +9477,91 @@
                 </a:solidFill>
                 <a:latin typeface="Fira Sans"/>
               </a:rPr>
-              <a:t>James, G., Witten, D., Hastie, T. y Tibshirani, R. (2023). An Introduction to Statistical Learning with Applications in Python. Springer. Capítulo 2. Descarga gratuita en statlearning.com.</a:t>
+              <a:t>El retrato de tu comuna: cada pareja adopta una comuna del Gran Santiago.</a:t>
+            </a:r>
+          </a:p>
+          <a:p>
+            <a:pPr>
+              <a:lnSpc>
+                <a:spcPct val="112000"/>
+              </a:lnSpc>
+              <a:spcAft>
+                <a:spcPts val="500"/>
+              </a:spcAft>
+            </a:pPr>
+            <a:r>
+              <a:rPr sz="1400" b="0">
+                <a:solidFill>
+                  <a:srgbClr val="333333"/>
+                </a:solidFill>
+                <a:latin typeface="Fira Sans"/>
+              </a:rPr>
+              <a:t>     ◦  </a:t>
+            </a:r>
+            <a:r>
+              <a:rPr sz="1400" b="0">
+                <a:solidFill>
+                  <a:srgbClr val="333333"/>
+                </a:solidFill>
+                <a:latin typeface="Fira Sans"/>
+              </a:rPr>
+              <a:t>Hoy: elegir la comuna y construir su retrato numérico.</a:t>
+            </a:r>
+          </a:p>
+          <a:p>
+            <a:pPr>
+              <a:lnSpc>
+                <a:spcPct val="112000"/>
+              </a:lnSpc>
+              <a:spcAft>
+                <a:spcPts val="500"/>
+              </a:spcAft>
+            </a:pPr>
+            <a:r>
+              <a:rPr sz="1400" b="0">
+                <a:solidFill>
+                  <a:srgbClr val="333333"/>
+                </a:solidFill>
+                <a:latin typeface="Fira Sans"/>
+              </a:rPr>
+              <a:t>     ◦  </a:t>
+            </a:r>
+            <a:r>
+              <a:rPr sz="1400" b="0">
+                <a:solidFill>
+                  <a:srgbClr val="333333"/>
+                </a:solidFill>
+                <a:latin typeface="Fira Sans"/>
+              </a:rPr>
+              <a:t>Próxima clase: el retrato gráfico, con métodos de visualización.</a:t>
+            </a:r>
+          </a:p>
+          <a:p>
+            <a:pPr>
+              <a:lnSpc>
+                <a:spcPct val="112000"/>
+              </a:lnSpc>
+              <a:spcAft>
+                <a:spcPts val="500"/>
+              </a:spcAft>
+            </a:pPr>
+            <a:r>
+              <a:rPr sz="1400" b="0">
+                <a:solidFill>
+                  <a:srgbClr val="333333"/>
+                </a:solidFill>
+                <a:latin typeface="Fira Sans"/>
+              </a:rPr>
+              <a:t>     ◦  </a:t>
+            </a:r>
+            <a:r>
+              <a:rPr sz="1400" b="0">
+                <a:solidFill>
+                  <a:srgbClr val="333333"/>
+                </a:solidFill>
+                <a:latin typeface="Fira Sans"/>
+              </a:rPr>
+              <a:t>Entrega del retrato completo: jueves 10 de septiembre, por Aula.</a:t>
             </a:r>
           </a:p>
           <a:p>
@@ -9504,7 +9589,7 @@
                 </a:solidFill>
                 <a:latin typeface="Fira Sans"/>
               </a:rPr>
-              <a:t>Bruce, P., Bruce, A. y Gedeck, P. (2020). Practical Statistics for Data Scientists, 2ª ed. O'Reilly. Capítulo 1.</a:t>
+              <a:t>El enunciado está en evaluaciones/tareas/ y la guía de hoy en actividades/.</a:t>
             </a:r>
           </a:p>
           <a:p>
@@ -9526,13 +9611,272 @@
               <a:t>▸ </a:t>
             </a:r>
             <a:r>
+              <a:rPr sz="1800" b="1">
+                <a:solidFill>
+                  <a:srgbClr val="1D3557"/>
+                </a:solidFill>
+                <a:latin typeface="Fira Sans"/>
+              </a:rPr>
+              <a:t>Lo que avancen en este bloque ya es parte de la tarea.</a:t>
+            </a:r>
+          </a:p>
+        </p:txBody>
+      </p:sp>
+    </p:spTree>
+  </p:cSld>
+  <p:clrMapOvr>
+    <a:masterClrMapping/>
+  </p:clrMapOvr>
+</p:sld>
+</file>
+
+<file path=ppt/slides/slide37.xml><?xml version="1.0" encoding="utf-8"?>
+<p:sld xmlns:a="http://schemas.openxmlformats.org/drawingml/2006/main" xmlns:p="http://schemas.openxmlformats.org/presentationml/2006/main" xmlns:r="http://schemas.openxmlformats.org/officeDocument/2006/relationships">
+  <p:cSld>
+    <p:spTree>
+      <p:nvGrpSpPr>
+        <p:cNvPr id="1" name=""/>
+        <p:cNvGrpSpPr/>
+        <p:nvPr/>
+      </p:nvGrpSpPr>
+      <p:grpSpPr/>
+      <p:sp>
+        <p:nvSpPr>
+          <p:cNvPr id="2" name="Rectangle 1"/>
+          <p:cNvSpPr/>
+          <p:nvPr/>
+        </p:nvSpPr>
+        <p:spPr>
+          <a:xfrm>
+            <a:off x="0" y="0"/>
+            <a:ext cx="9144000" cy="5138928"/>
+          </a:xfrm>
+          <a:prstGeom prst="rect">
+            <a:avLst/>
+          </a:prstGeom>
+          <a:solidFill>
+            <a:srgbClr val="FAFBFC"/>
+          </a:solidFill>
+          <a:ln>
+            <a:noFill/>
+          </a:ln>
+          <a:effectLst/>
+        </p:spPr>
+        <p:style>
+          <a:lnRef idx="1">
+            <a:schemeClr val="accent1"/>
+          </a:lnRef>
+          <a:fillRef idx="3">
+            <a:schemeClr val="accent1"/>
+          </a:fillRef>
+          <a:effectRef idx="2">
+            <a:schemeClr val="accent1"/>
+          </a:effectRef>
+          <a:fontRef idx="minor">
+            <a:schemeClr val="lt1"/>
+          </a:fontRef>
+        </p:style>
+        <p:txBody>
+          <a:bodyPr rtlCol="0" anchor="ctr"/>
+          <a:lstStyle/>
+          <a:p>
+            <a:pPr algn="ctr"/>
+          </a:p>
+        </p:txBody>
+      </p:sp>
+      <p:sp>
+        <p:nvSpPr>
+          <p:cNvPr id="3" name="TextBox 2"/>
+          <p:cNvSpPr txBox="1"/>
+          <p:nvPr/>
+        </p:nvSpPr>
+        <p:spPr>
+          <a:xfrm>
+            <a:off x="402336" y="301752"/>
+            <a:ext cx="8348472" cy="795528"/>
+          </a:xfrm>
+          <a:prstGeom prst="rect">
+            <a:avLst/>
+          </a:prstGeom>
+          <a:noFill/>
+        </p:spPr>
+        <p:txBody>
+          <a:bodyPr wrap="square">
+            <a:spAutoFit/>
+          </a:bodyPr>
+          <a:lstStyle/>
+          <a:p>
+            <a:r>
+              <a:rPr sz="2800" b="1">
+                <a:solidFill>
+                  <a:srgbClr val="0F0F0F"/>
+                </a:solidFill>
+                <a:latin typeface="Fira Sans"/>
+              </a:rPr>
+              <a:t>Referencias</a:t>
+            </a:r>
+          </a:p>
+        </p:txBody>
+      </p:sp>
+      <p:sp>
+        <p:nvSpPr>
+          <p:cNvPr id="4" name="TextBox 3"/>
+          <p:cNvSpPr txBox="1"/>
+          <p:nvPr/>
+        </p:nvSpPr>
+        <p:spPr>
+          <a:xfrm>
+            <a:off x="704088" y="1353312"/>
+            <a:ext cx="7744968" cy="3300984"/>
+          </a:xfrm>
+          <a:prstGeom prst="rect">
+            <a:avLst/>
+          </a:prstGeom>
+          <a:noFill/>
+        </p:spPr>
+        <p:txBody>
+          <a:bodyPr wrap="square">
+            <a:spAutoFit/>
+          </a:bodyPr>
+          <a:lstStyle/>
+          <a:p>
+            <a:pPr>
+              <a:lnSpc>
+                <a:spcPct val="112000"/>
+              </a:lnSpc>
+              <a:spcAft>
+                <a:spcPts val="900"/>
+              </a:spcAft>
+            </a:pPr>
+            <a:r>
+              <a:rPr sz="1800" b="1">
+                <a:solidFill>
+                  <a:srgbClr val="E0A437"/>
+                </a:solidFill>
+                <a:latin typeface="Fira Sans"/>
+              </a:rPr>
+              <a:t>▸ </a:t>
+            </a:r>
+            <a:r>
               <a:rPr sz="1800" b="0">
                 <a:solidFill>
                   <a:srgbClr val="000000"/>
                 </a:solidFill>
                 <a:latin typeface="Fira Sans"/>
               </a:rPr>
+              <a:t>James, G., Witten, D., Hastie, T. y Tibshirani, R. (2023). An Introduction to Statistical Learning with Applications in Python. Springer. Capítulo 2. Descarga gratuita en statlearning.com.</a:t>
+            </a:r>
+          </a:p>
+          <a:p>
+            <a:pPr>
+              <a:lnSpc>
+                <a:spcPct val="112000"/>
+              </a:lnSpc>
+              <a:spcAft>
+                <a:spcPts val="900"/>
+              </a:spcAft>
+            </a:pPr>
+            <a:r>
+              <a:rPr sz="1800" b="1">
+                <a:solidFill>
+                  <a:srgbClr val="E0A437"/>
+                </a:solidFill>
+                <a:latin typeface="Fira Sans"/>
+              </a:rPr>
+              <a:t>▸ </a:t>
+            </a:r>
+            <a:r>
+              <a:rPr sz="1800" b="0">
+                <a:solidFill>
+                  <a:srgbClr val="000000"/>
+                </a:solidFill>
+                <a:latin typeface="Fira Sans"/>
+              </a:rPr>
+              <a:t>Bruce, P., Bruce, A. y Gedeck, P. (2020). Practical Statistics for Data Scientists, 2ª ed. O'Reilly. Capítulo 1.</a:t>
+            </a:r>
+          </a:p>
+          <a:p>
+            <a:pPr>
+              <a:lnSpc>
+                <a:spcPct val="112000"/>
+              </a:lnSpc>
+              <a:spcAft>
+                <a:spcPts val="900"/>
+              </a:spcAft>
+            </a:pPr>
+            <a:r>
+              <a:rPr sz="1800" b="1">
+                <a:solidFill>
+                  <a:srgbClr val="E0A437"/>
+                </a:solidFill>
+                <a:latin typeface="Fira Sans"/>
+              </a:rPr>
+              <a:t>▸ </a:t>
+            </a:r>
+            <a:r>
+              <a:rPr sz="1800" b="0">
+                <a:solidFill>
+                  <a:srgbClr val="000000"/>
+                </a:solidFill>
+                <a:latin typeface="Fira Sans"/>
+              </a:rPr>
               <a:t>Tukey, J. W. (1977). Exploratory Data Analysis. Addison-Wesley.</a:t>
+            </a:r>
+          </a:p>
+          <a:p>
+            <a:pPr>
+              <a:lnSpc>
+                <a:spcPct val="112000"/>
+              </a:lnSpc>
+              <a:spcAft>
+                <a:spcPts val="900"/>
+              </a:spcAft>
+            </a:pPr>
+            <a:r>
+              <a:rPr sz="1800" b="1">
+                <a:solidFill>
+                  <a:srgbClr val="E0A437"/>
+                </a:solidFill>
+                <a:latin typeface="Fira Sans"/>
+              </a:rPr>
+              <a:t>▸ </a:t>
+            </a:r>
+            <a:r>
+              <a:rPr sz="1800" b="0">
+                <a:solidFill>
+                  <a:srgbClr val="000000"/>
+                </a:solidFill>
+                <a:latin typeface="Fira Sans"/>
+              </a:rPr>
+              <a:t>Chambers, J. M. y Hastie, T. J. (1992). Statistical Models in S. Wadsworth &amp; Brooks/Cole.</a:t>
+            </a:r>
+          </a:p>
+          <a:p>
+            <a:pPr>
+              <a:lnSpc>
+                <a:spcPct val="112000"/>
+              </a:lnSpc>
+              <a:spcAft>
+                <a:spcPts val="900"/>
+              </a:spcAft>
+            </a:pPr>
+            <a:r>
+              <a:rPr sz="1800" b="1">
+                <a:solidFill>
+                  <a:srgbClr val="E0A437"/>
+                </a:solidFill>
+                <a:latin typeface="Fira Sans"/>
+              </a:rPr>
+              <a:t>▸ </a:t>
+            </a:r>
+            <a:r>
+              <a:rPr sz="1800" b="0">
+                <a:solidFill>
+                  <a:srgbClr val="000000"/>
+                </a:solidFill>
+                <a:latin typeface="Fira Sans"/>
+              </a:rPr>
+              <a:t>McKinney, W. (2010). Data Structures for Statistical Computing in Python. Proceedings of the 9th Python in Science Conference.</a:t>
             </a:r>
           </a:p>
           <a:p>

</xml_diff>

<commit_message>
El pantallazo del DataFrame abre la seccion de Pandas
Queda como slide 20, antes de la slide de origen y propiedades.

Co-Authored-By: Claude Fable 5 <noreply@anthropic.com>
</commit_message>
<xml_diff>
--- a/presentaciones/clase02_pandas_eda.pptx
+++ b/presentaciones/clase02_pandas_eda.pptx
@@ -5914,21 +5914,45 @@
                 </a:solidFill>
                 <a:latin typeface="Fira Sans"/>
               </a:rPr>
-              <a:t>El DataFrame: origen y propiedades</a:t>
-            </a:r>
-          </a:p>
-        </p:txBody>
-      </p:sp>
-      <p:sp>
-        <p:nvSpPr>
-          <p:cNvPr id="4" name="TextBox 3"/>
+              <a:t>El DataFrame: la estructura central de Pandas</a:t>
+            </a:r>
+          </a:p>
+        </p:txBody>
+      </p:sp>
+      <p:pic>
+        <p:nvPicPr>
+          <p:cNvPr id="4" name="Picture 3" descr="13_dataframe.png"/>
+          <p:cNvPicPr>
+            <a:picLocks noChangeAspect="1"/>
+          </p:cNvPicPr>
+          <p:nvPr/>
+        </p:nvPicPr>
+        <p:blipFill>
+          <a:blip r:embed="rId2"/>
+          <a:stretch>
+            <a:fillRect/>
+          </a:stretch>
+        </p:blipFill>
+        <p:spPr>
+          <a:xfrm>
+            <a:off x="1417319" y="1143000"/>
+            <a:ext cx="6309360" cy="2553789"/>
+          </a:xfrm>
+          <a:prstGeom prst="rect">
+            <a:avLst/>
+          </a:prstGeom>
+        </p:spPr>
+      </p:pic>
+      <p:sp>
+        <p:nvSpPr>
+          <p:cNvPr id="5" name="TextBox 4"/>
           <p:cNvSpPr txBox="1"/>
           <p:nvPr/>
         </p:nvSpPr>
         <p:spPr>
           <a:xfrm>
-            <a:off x="704088" y="1353312"/>
-            <a:ext cx="7744968" cy="3300984"/>
+            <a:off x="704088" y="4434840"/>
+            <a:ext cx="7744968" cy="457200"/>
           </a:xfrm>
           <a:prstGeom prst="rect">
             <a:avLst/>
@@ -5941,171 +5965,14 @@
           </a:bodyPr>
           <a:lstStyle/>
           <a:p>
-            <a:pPr>
-              <a:lnSpc>
-                <a:spcPct val="112000"/>
-              </a:lnSpc>
-              <a:spcAft>
-                <a:spcPts val="900"/>
-              </a:spcAft>
-            </a:pPr>
-            <a:r>
-              <a:rPr sz="1800" b="1">
-                <a:solidFill>
-                  <a:srgbClr val="E0A437"/>
-                </a:solidFill>
-                <a:latin typeface="Fira Sans"/>
-              </a:rPr>
-              <a:t>▸ </a:t>
-            </a:r>
-            <a:r>
-              <a:rPr sz="1800" b="0">
-                <a:solidFill>
-                  <a:srgbClr val="000000"/>
-                </a:solidFill>
-                <a:latin typeface="Fira Sans"/>
-              </a:rPr>
-              <a:t>Estructura tabular bidimensional: columnas con nombre y tipo propio, filas indexadas.</a:t>
-            </a:r>
-          </a:p>
-          <a:p>
-            <a:pPr>
-              <a:lnSpc>
-                <a:spcPct val="112000"/>
-              </a:lnSpc>
-              <a:spcAft>
-                <a:spcPts val="900"/>
-              </a:spcAft>
-            </a:pPr>
-            <a:r>
-              <a:rPr sz="1800" b="1">
-                <a:solidFill>
-                  <a:srgbClr val="E0A437"/>
-                </a:solidFill>
-                <a:latin typeface="Fira Sans"/>
-              </a:rPr>
-              <a:t>▸ </a:t>
-            </a:r>
-            <a:r>
-              <a:rPr sz="1800" b="0">
-                <a:solidFill>
-                  <a:srgbClr val="000000"/>
-                </a:solidFill>
-                <a:latin typeface="Fira Sans"/>
-              </a:rPr>
-              <a:t>El concepto viene del lenguaje S: los objetos data.frame (Chambers y Hastie, 1992). Wes McKinney lo llevó a Python con pandas (McKinney, 2010).</a:t>
-            </a:r>
-          </a:p>
-          <a:p>
-            <a:pPr>
-              <a:lnSpc>
-                <a:spcPct val="112000"/>
-              </a:lnSpc>
-              <a:spcAft>
-                <a:spcPts val="500"/>
-              </a:spcAft>
-            </a:pPr>
-            <a:r>
-              <a:rPr sz="1400" b="0">
+            <a:r>
+              <a:rPr sz="1300" b="0">
                 <a:solidFill>
                   <a:srgbClr val="333333"/>
                 </a:solidFill>
                 <a:latin typeface="Fira Sans"/>
               </a:rPr>
-              <a:t>     ◦  </a:t>
-            </a:r>
-            <a:r>
-              <a:rPr sz="1400" b="0">
-                <a:solidFill>
-                  <a:srgbClr val="333333"/>
-                </a:solidFill>
-                <a:latin typeface="Fira Sans"/>
-              </a:rPr>
-              <a:t>Cada columna es un arreglo tipado contiguo: las operaciones son vectorizadas, no ciclos de Python.</a:t>
-            </a:r>
-          </a:p>
-          <a:p>
-            <a:pPr>
-              <a:lnSpc>
-                <a:spcPct val="112000"/>
-              </a:lnSpc>
-              <a:spcAft>
-                <a:spcPts val="500"/>
-              </a:spcAft>
-            </a:pPr>
-            <a:r>
-              <a:rPr sz="1400" b="0">
-                <a:solidFill>
-                  <a:srgbClr val="333333"/>
-                </a:solidFill>
-                <a:latin typeface="Fira Sans"/>
-              </a:rPr>
-              <a:t>     ◦  </a:t>
-            </a:r>
-            <a:r>
-              <a:rPr sz="1400" b="0">
-                <a:solidFill>
-                  <a:srgbClr val="333333"/>
-                </a:solidFill>
-                <a:latin typeface="Fira Sans"/>
-              </a:rPr>
-              <a:t>El índice alinea los datos automáticamente en operaciones entre tablas y series.</a:t>
-            </a:r>
-          </a:p>
-          <a:p>
-            <a:pPr>
-              <a:lnSpc>
-                <a:spcPct val="112000"/>
-              </a:lnSpc>
-              <a:spcAft>
-                <a:spcPts val="500"/>
-              </a:spcAft>
-            </a:pPr>
-            <a:r>
-              <a:rPr sz="1400" b="0">
-                <a:solidFill>
-                  <a:srgbClr val="333333"/>
-                </a:solidFill>
-                <a:latin typeface="Fira Sans"/>
-              </a:rPr>
-              <a:t>     ◦  </a:t>
-            </a:r>
-            <a:r>
-              <a:rPr sz="1400" b="0">
-                <a:solidFill>
-                  <a:srgbClr val="333333"/>
-                </a:solidFill>
-                <a:latin typeface="Fira Sans"/>
-              </a:rPr>
-              <a:t>Implementa el álgebra relacional en memoria: selección, proyección, join (merge) y agregación (groupby).</a:t>
-            </a:r>
-          </a:p>
-          <a:p>
-            <a:pPr>
-              <a:lnSpc>
-                <a:spcPct val="112000"/>
-              </a:lnSpc>
-              <a:spcAft>
-                <a:spcPts val="900"/>
-              </a:spcAft>
-            </a:pPr>
-            <a:r>
-              <a:rPr sz="1800" b="1">
-                <a:solidFill>
-                  <a:srgbClr val="E0A437"/>
-                </a:solidFill>
-                <a:latin typeface="Fira Sans"/>
-              </a:rPr>
-              <a:t>▸ </a:t>
-            </a:r>
-            <a:r>
-              <a:rPr sz="1800" b="1">
-                <a:solidFill>
-                  <a:srgbClr val="1D3557"/>
-                </a:solidFill>
-                <a:latin typeface="Fira Sans"/>
-              </a:rPr>
-              <a:t>La interfaz se volvió un estándar: Spark, Polars y Dask implementan DataFrames con esta misma idea.</a:t>
+              <a:t>Los códigos (ComunaOrigen, Proposito) se resuelven contra tablas_parametros/ con merge.</a:t>
             </a:r>
           </a:p>
         </p:txBody>
@@ -6201,112 +6068,21 @@
                 </a:solidFill>
                 <a:latin typeface="Fira Sans"/>
               </a:rPr>
-              <a:t>Abrir el dataset</a:t>
-            </a:r>
-          </a:p>
-        </p:txBody>
-      </p:sp>
-      <p:sp>
-        <p:nvSpPr>
-          <p:cNvPr id="4" name="Rectangle 3"/>
-          <p:cNvSpPr/>
-          <p:nvPr/>
-        </p:nvSpPr>
-        <p:spPr>
-          <a:xfrm>
-            <a:off x="704088" y="1280160"/>
-            <a:ext cx="7744968" cy="2377440"/>
-          </a:xfrm>
-          <a:prstGeom prst="rect">
-            <a:avLst/>
-          </a:prstGeom>
-          <a:solidFill>
-            <a:srgbClr val="F0F2F5"/>
-          </a:solidFill>
-          <a:ln>
-            <a:solidFill>
-              <a:srgbClr val="D8DDE3"/>
-            </a:solidFill>
-          </a:ln>
-          <a:effectLst/>
-        </p:spPr>
-        <p:style>
-          <a:lnRef idx="1">
-            <a:schemeClr val="accent1"/>
-          </a:lnRef>
-          <a:fillRef idx="3">
-            <a:schemeClr val="accent1"/>
-          </a:fillRef>
-          <a:effectRef idx="2">
-            <a:schemeClr val="accent1"/>
-          </a:effectRef>
-          <a:fontRef idx="minor">
-            <a:schemeClr val="lt1"/>
-          </a:fontRef>
-        </p:style>
-        <p:txBody>
-          <a:bodyPr rtlCol="0" anchor="ctr" wrap="square" lIns="228600" tIns="137160"/>
-          <a:lstStyle/>
-          <a:p>
-            <a:pPr/>
-            <a:r>
-              <a:rPr sz="1500" b="0">
-                <a:solidFill>
-                  <a:srgbClr val="1D3557"/>
-                </a:solidFill>
-                <a:latin typeface="Menlo"/>
-              </a:rPr>
-              <a:t>import pandas as pd</a:t>
-            </a:r>
-          </a:p>
-          <a:p>
-            <a:pPr/>
-            <a:r>
-              <a:rPr sz="1500" b="0">
-                <a:solidFill>
-                  <a:srgbClr val="1D3557"/>
-                </a:solidFill>
-                <a:latin typeface="Menlo"/>
-              </a:rPr>
-              <a:t/>
-            </a:r>
-          </a:p>
-          <a:p>
-            <a:pPr/>
-            <a:r>
-              <a:rPr sz="1500" b="0">
-                <a:solidFill>
-                  <a:srgbClr val="1D3557"/>
-                </a:solidFill>
-                <a:latin typeface="Menlo"/>
-              </a:rPr>
-              <a:t>viajes = pd.read_csv('datos/eod_stgo/viajes.csv',</a:t>
-            </a:r>
-          </a:p>
-          <a:p>
-            <a:pPr/>
-            <a:r>
-              <a:rPr sz="1500" b="0">
-                <a:solidFill>
-                  <a:srgbClr val="1D3557"/>
-                </a:solidFill>
-                <a:latin typeface="Menlo"/>
-              </a:rPr>
-              <a:t>                     sep=';', decimal=',')</a:t>
-            </a:r>
-          </a:p>
-        </p:txBody>
-      </p:sp>
-      <p:sp>
-        <p:nvSpPr>
-          <p:cNvPr id="5" name="TextBox 4"/>
+              <a:t>El DataFrame: origen y propiedades</a:t>
+            </a:r>
+          </a:p>
+        </p:txBody>
+      </p:sp>
+      <p:sp>
+        <p:nvSpPr>
+          <p:cNvPr id="4" name="TextBox 3"/>
           <p:cNvSpPr txBox="1"/>
           <p:nvPr/>
         </p:nvSpPr>
         <p:spPr>
           <a:xfrm>
-            <a:off x="704088" y="3886200"/>
-            <a:ext cx="7744968" cy="1097280"/>
+            <a:off x="704088" y="1353312"/>
+            <a:ext cx="7744968" cy="3300984"/>
           </a:xfrm>
           <a:prstGeom prst="rect">
             <a:avLst/>
@@ -6328,7 +6104,7 @@
               </a:spcAft>
             </a:pPr>
             <a:r>
-              <a:rPr sz="1600" b="1">
+              <a:rPr sz="1800" b="1">
                 <a:solidFill>
                   <a:srgbClr val="E0A437"/>
                 </a:solidFill>
@@ -6337,13 +6113,153 @@
               <a:t>▸ </a:t>
             </a:r>
             <a:r>
-              <a:rPr sz="1600" b="0">
+              <a:rPr sz="1800" b="0">
                 <a:solidFill>
                   <a:srgbClr val="000000"/>
                 </a:solidFill>
                 <a:latin typeface="Fira Sans"/>
               </a:rPr>
-              <a:t>Todo el código de la clase está en el notebook 02_pandas_eda.ipynb del repositorio.</a:t>
+              <a:t>Estructura tabular bidimensional: columnas con nombre y tipo propio, filas indexadas.</a:t>
+            </a:r>
+          </a:p>
+          <a:p>
+            <a:pPr>
+              <a:lnSpc>
+                <a:spcPct val="112000"/>
+              </a:lnSpc>
+              <a:spcAft>
+                <a:spcPts val="900"/>
+              </a:spcAft>
+            </a:pPr>
+            <a:r>
+              <a:rPr sz="1800" b="1">
+                <a:solidFill>
+                  <a:srgbClr val="E0A437"/>
+                </a:solidFill>
+                <a:latin typeface="Fira Sans"/>
+              </a:rPr>
+              <a:t>▸ </a:t>
+            </a:r>
+            <a:r>
+              <a:rPr sz="1800" b="0">
+                <a:solidFill>
+                  <a:srgbClr val="000000"/>
+                </a:solidFill>
+                <a:latin typeface="Fira Sans"/>
+              </a:rPr>
+              <a:t>El concepto viene del lenguaje S: los objetos data.frame (Chambers y Hastie, 1992). Wes McKinney lo llevó a Python con pandas (McKinney, 2010).</a:t>
+            </a:r>
+          </a:p>
+          <a:p>
+            <a:pPr>
+              <a:lnSpc>
+                <a:spcPct val="112000"/>
+              </a:lnSpc>
+              <a:spcAft>
+                <a:spcPts val="500"/>
+              </a:spcAft>
+            </a:pPr>
+            <a:r>
+              <a:rPr sz="1400" b="0">
+                <a:solidFill>
+                  <a:srgbClr val="333333"/>
+                </a:solidFill>
+                <a:latin typeface="Fira Sans"/>
+              </a:rPr>
+              <a:t>     ◦  </a:t>
+            </a:r>
+            <a:r>
+              <a:rPr sz="1400" b="0">
+                <a:solidFill>
+                  <a:srgbClr val="333333"/>
+                </a:solidFill>
+                <a:latin typeface="Fira Sans"/>
+              </a:rPr>
+              <a:t>Cada columna es un arreglo tipado contiguo: las operaciones son vectorizadas, no ciclos de Python.</a:t>
+            </a:r>
+          </a:p>
+          <a:p>
+            <a:pPr>
+              <a:lnSpc>
+                <a:spcPct val="112000"/>
+              </a:lnSpc>
+              <a:spcAft>
+                <a:spcPts val="500"/>
+              </a:spcAft>
+            </a:pPr>
+            <a:r>
+              <a:rPr sz="1400" b="0">
+                <a:solidFill>
+                  <a:srgbClr val="333333"/>
+                </a:solidFill>
+                <a:latin typeface="Fira Sans"/>
+              </a:rPr>
+              <a:t>     ◦  </a:t>
+            </a:r>
+            <a:r>
+              <a:rPr sz="1400" b="0">
+                <a:solidFill>
+                  <a:srgbClr val="333333"/>
+                </a:solidFill>
+                <a:latin typeface="Fira Sans"/>
+              </a:rPr>
+              <a:t>El índice alinea los datos automáticamente en operaciones entre tablas y series.</a:t>
+            </a:r>
+          </a:p>
+          <a:p>
+            <a:pPr>
+              <a:lnSpc>
+                <a:spcPct val="112000"/>
+              </a:lnSpc>
+              <a:spcAft>
+                <a:spcPts val="500"/>
+              </a:spcAft>
+            </a:pPr>
+            <a:r>
+              <a:rPr sz="1400" b="0">
+                <a:solidFill>
+                  <a:srgbClr val="333333"/>
+                </a:solidFill>
+                <a:latin typeface="Fira Sans"/>
+              </a:rPr>
+              <a:t>     ◦  </a:t>
+            </a:r>
+            <a:r>
+              <a:rPr sz="1400" b="0">
+                <a:solidFill>
+                  <a:srgbClr val="333333"/>
+                </a:solidFill>
+                <a:latin typeface="Fira Sans"/>
+              </a:rPr>
+              <a:t>Implementa el álgebra relacional en memoria: selección, proyección, join (merge) y agregación (groupby).</a:t>
+            </a:r>
+          </a:p>
+          <a:p>
+            <a:pPr>
+              <a:lnSpc>
+                <a:spcPct val="112000"/>
+              </a:lnSpc>
+              <a:spcAft>
+                <a:spcPts val="900"/>
+              </a:spcAft>
+            </a:pPr>
+            <a:r>
+              <a:rPr sz="1800" b="1">
+                <a:solidFill>
+                  <a:srgbClr val="E0A437"/>
+                </a:solidFill>
+                <a:latin typeface="Fira Sans"/>
+              </a:rPr>
+              <a:t>▸ </a:t>
+            </a:r>
+            <a:r>
+              <a:rPr sz="1800" b="1">
+                <a:solidFill>
+                  <a:srgbClr val="1D3557"/>
+                </a:solidFill>
+                <a:latin typeface="Fira Sans"/>
+              </a:rPr>
+              <a:t>La interfaz se volvió un estándar: Spark, Polars y Dask implementan DataFrames con esta misma idea.</a:t>
             </a:r>
           </a:p>
         </p:txBody>
@@ -6439,35 +6355,102 @@
                 </a:solidFill>
                 <a:latin typeface="Fira Sans"/>
               </a:rPr>
-              <a:t>El DataFrame: la estructura central de Pandas</a:t>
-            </a:r>
-          </a:p>
-        </p:txBody>
-      </p:sp>
-      <p:pic>
-        <p:nvPicPr>
-          <p:cNvPr id="4" name="Picture 3" descr="13_dataframe.png"/>
-          <p:cNvPicPr>
-            <a:picLocks noChangeAspect="1"/>
-          </p:cNvPicPr>
-          <p:nvPr/>
-        </p:nvPicPr>
-        <p:blipFill>
-          <a:blip r:embed="rId2"/>
-          <a:stretch>
-            <a:fillRect/>
-          </a:stretch>
-        </p:blipFill>
-        <p:spPr>
-          <a:xfrm>
-            <a:off x="1417319" y="1143000"/>
-            <a:ext cx="6309360" cy="2553789"/>
-          </a:xfrm>
-          <a:prstGeom prst="rect">
-            <a:avLst/>
-          </a:prstGeom>
-        </p:spPr>
-      </p:pic>
+              <a:t>Abrir el dataset</a:t>
+            </a:r>
+          </a:p>
+        </p:txBody>
+      </p:sp>
+      <p:sp>
+        <p:nvSpPr>
+          <p:cNvPr id="4" name="Rectangle 3"/>
+          <p:cNvSpPr/>
+          <p:nvPr/>
+        </p:nvSpPr>
+        <p:spPr>
+          <a:xfrm>
+            <a:off x="704088" y="1280160"/>
+            <a:ext cx="7744968" cy="2377440"/>
+          </a:xfrm>
+          <a:prstGeom prst="rect">
+            <a:avLst/>
+          </a:prstGeom>
+          <a:solidFill>
+            <a:srgbClr val="F0F2F5"/>
+          </a:solidFill>
+          <a:ln>
+            <a:solidFill>
+              <a:srgbClr val="D8DDE3"/>
+            </a:solidFill>
+          </a:ln>
+          <a:effectLst/>
+        </p:spPr>
+        <p:style>
+          <a:lnRef idx="1">
+            <a:schemeClr val="accent1"/>
+          </a:lnRef>
+          <a:fillRef idx="3">
+            <a:schemeClr val="accent1"/>
+          </a:fillRef>
+          <a:effectRef idx="2">
+            <a:schemeClr val="accent1"/>
+          </a:effectRef>
+          <a:fontRef idx="minor">
+            <a:schemeClr val="lt1"/>
+          </a:fontRef>
+        </p:style>
+        <p:txBody>
+          <a:bodyPr rtlCol="0" anchor="ctr" wrap="square" lIns="228600" tIns="137160"/>
+          <a:lstStyle/>
+          <a:p>
+            <a:pPr/>
+            <a:r>
+              <a:rPr sz="1500" b="0">
+                <a:solidFill>
+                  <a:srgbClr val="1D3557"/>
+                </a:solidFill>
+                <a:latin typeface="Menlo"/>
+              </a:rPr>
+              <a:t>import pandas as pd</a:t>
+            </a:r>
+          </a:p>
+          <a:p>
+            <a:pPr/>
+            <a:r>
+              <a:rPr sz="1500" b="0">
+                <a:solidFill>
+                  <a:srgbClr val="1D3557"/>
+                </a:solidFill>
+                <a:latin typeface="Menlo"/>
+              </a:rPr>
+              <a:t/>
+            </a:r>
+          </a:p>
+          <a:p>
+            <a:pPr/>
+            <a:r>
+              <a:rPr sz="1500" b="0">
+                <a:solidFill>
+                  <a:srgbClr val="1D3557"/>
+                </a:solidFill>
+                <a:latin typeface="Menlo"/>
+              </a:rPr>
+              <a:t>viajes = pd.read_csv('datos/eod_stgo/viajes.csv',</a:t>
+            </a:r>
+          </a:p>
+          <a:p>
+            <a:pPr/>
+            <a:r>
+              <a:rPr sz="1500" b="0">
+                <a:solidFill>
+                  <a:srgbClr val="1D3557"/>
+                </a:solidFill>
+                <a:latin typeface="Menlo"/>
+              </a:rPr>
+              <a:t>                     sep=';', decimal=',')</a:t>
+            </a:r>
+          </a:p>
+        </p:txBody>
+      </p:sp>
       <p:sp>
         <p:nvSpPr>
           <p:cNvPr id="5" name="TextBox 4"/>
@@ -6476,8 +6459,8 @@
         </p:nvSpPr>
         <p:spPr>
           <a:xfrm>
-            <a:off x="704088" y="4434840"/>
-            <a:ext cx="7744968" cy="457200"/>
+            <a:off x="704088" y="3886200"/>
+            <a:ext cx="7744968" cy="1097280"/>
           </a:xfrm>
           <a:prstGeom prst="rect">
             <a:avLst/>
@@ -6490,14 +6473,31 @@
           </a:bodyPr>
           <a:lstStyle/>
           <a:p>
-            <a:r>
-              <a:rPr sz="1300" b="0">
-                <a:solidFill>
-                  <a:srgbClr val="333333"/>
-                </a:solidFill>
-                <a:latin typeface="Fira Sans"/>
-              </a:rPr>
-              <a:t>Los códigos (ComunaOrigen, Proposito) se resuelven contra tablas_parametros/ con merge.</a:t>
+            <a:pPr>
+              <a:lnSpc>
+                <a:spcPct val="112000"/>
+              </a:lnSpc>
+              <a:spcAft>
+                <a:spcPts val="900"/>
+              </a:spcAft>
+            </a:pPr>
+            <a:r>
+              <a:rPr sz="1600" b="1">
+                <a:solidFill>
+                  <a:srgbClr val="E0A437"/>
+                </a:solidFill>
+                <a:latin typeface="Fira Sans"/>
+              </a:rPr>
+              <a:t>▸ </a:t>
+            </a:r>
+            <a:r>
+              <a:rPr sz="1600" b="0">
+                <a:solidFill>
+                  <a:srgbClr val="000000"/>
+                </a:solidFill>
+                <a:latin typeface="Fira Sans"/>
+              </a:rPr>
+              <a:t>Todo el código de la clase está en el notebook 02_pandas_eda.ipynb del repositorio.</a:t>
             </a:r>
           </a:p>
         </p:txBody>

</xml_diff>

<commit_message>
Explicar la vectorizacion con una medicion real
La slide del DataFrame cuantifica la diferencia (sumar TiempoViaje: 0,08 ms
vectorizado contra 7 ms del ciclo) y el notebook explica el mecanismo (una llamada
a codigo compilado sobre el arreglo contiguo contra pasar por el interprete en
cada elemento) con una celda que mide la diferencia en vivo.

Co-Authored-By: Claude Fable 5 <noreply@anthropic.com>
</commit_message>
<xml_diff>
--- a/presentaciones/clase02_pandas_eda.pptx
+++ b/presentaciones/clase02_pandas_eda.pptx
@@ -6175,7 +6175,35 @@
                 </a:solidFill>
                 <a:latin typeface="Fira Sans"/>
               </a:rPr>
-              <a:t>Cada columna es un arreglo tipado contiguo: las operaciones son vectorizadas, no ciclos de Python.</a:t>
+              <a:t>Cada columna es un arreglo tipado y contiguo en memoria.</a:t>
+            </a:r>
+          </a:p>
+          <a:p>
+            <a:pPr>
+              <a:lnSpc>
+                <a:spcPct val="112000"/>
+              </a:lnSpc>
+              <a:spcAft>
+                <a:spcPts val="500"/>
+              </a:spcAft>
+            </a:pPr>
+            <a:r>
+              <a:rPr sz="1400" b="0">
+                <a:solidFill>
+                  <a:srgbClr val="333333"/>
+                </a:solidFill>
+                <a:latin typeface="Fira Sans"/>
+              </a:rPr>
+              <a:t>     ◦  </a:t>
+            </a:r>
+            <a:r>
+              <a:rPr sz="1400" b="0">
+                <a:solidFill>
+                  <a:srgbClr val="333333"/>
+                </a:solidFill>
+                <a:latin typeface="Fira Sans"/>
+              </a:rPr>
+              <a:t>Por eso las operaciones se ejecutan en código compilado sobre la columna completa, en vez de interpretar un ciclo elemento por elemento: sumar TiempoViaje toma 0,08 ms contra 7 ms del ciclo equivalente.</a:t>
             </a:r>
           </a:p>
           <a:p>

</xml_diff>

<commit_message>
El concepto de la clase 02 es el EDA
El notebook y las slides lo declaran al inicio y lo cierran en la sintesis: el
EDA como etapa de examinar los datos antes de modelarlos, con el marco conceptual
como los lentes y la exploracion de la EOD como su practica. La pregunta de quien
habla cada numero queda como transversal, subordinada al concepto.

Co-Authored-By: Claude Fable 5 <noreply@anthropic.com>
</commit_message>
<xml_diff>
--- a/presentaciones/clase02_pandas_eda.pptx
+++ b/presentaciones/clase02_pandas_eda.pptx
@@ -5818,7 +5818,7 @@
                 </a:solidFill>
                 <a:latin typeface="Fira Sans"/>
               </a:rPr>
-              <a:t>En el segundo bloque comienza la Tarea 1.</a:t>
+              <a:t>El concepto de la clase es el EDA: examinar los datos antes de modelarlos. Los puntos 1 a 4 entregan los lentes; el 6 lo pone en práctica.</a:t>
             </a:r>
           </a:p>
         </p:txBody>
@@ -9358,7 +9358,7 @@
                 </a:solidFill>
                 <a:latin typeface="Fira Sans"/>
               </a:rPr>
-              <a:t>Ante toda cifra resumen: ¿de quién habla este número? ¿Muestra, subgrupo o ciudad?</a:t>
+              <a:t>El concepto de la clase: el EDA, examinar los datos antes de modelarlos, preguntando ante cada cifra de quién habla.</a:t>
             </a:r>
           </a:p>
         </p:txBody>

</xml_diff>

<commit_message>
Factores de expansion al inicio y toda la exploracion ponderada
Los factores pasan a la seccion 3 del notebook, con su formulacion (w = 1/pi,
estimadores de Horvitz y Thompson) y una funcion de cuantiles ponderados que se
reutiliza en toda la clase. Ingreso, viajes por persona y duracion quedan
ponderados: media $729.898 y mediana $520.000, 2,23 viajes por persona con un 15,1%
sin viajes, mediana de duracion 25 minutos. La comparacion se descompone con
honestidad en tres cifras (ingenua 23,0%, universo laboral sin ponderar 16,2%,
ponderado 15,1%): primero se define la poblacion y luego se pondera. Las slides
suman la lamina formal del factor con formulas y la comparacion de tres barras, y
la correlacion declara su nota metodologica (sin ponderar, interesa la forma).

Co-Authored-By: Claude Fable 5 <noreply@anthropic.com>
</commit_message>
<xml_diff>
--- a/presentaciones/clase02_pandas_eda.pptx
+++ b/presentaciones/clase02_pandas_eda.pptx
@@ -42,6 +42,7 @@
     <p:sldId id="290" r:id="rId41"/>
     <p:sldId id="291" r:id="rId42"/>
     <p:sldId id="292" r:id="rId43"/>
+    <p:sldId id="293" r:id="rId44"/>
   </p:sldIdLst>
   <p:sldSz cx="9144000" cy="5138928" type="screen4x3"/>
   <p:notesSz cx="6858000" cy="9144000"/>
@@ -7295,7 +7296,7 @@
                 </a:solidFill>
                 <a:latin typeface="Fira Sans"/>
               </a:rPr>
-              <a:t>Viajes por persona: los ausentes también cuentan</a:t>
+              <a:t>El factor de expansión, formalmente</a:t>
             </a:r>
           </a:p>
         </p:txBody>
@@ -7346,7 +7347,7 @@
                 </a:solidFill>
                 <a:latin typeface="Fira Sans"/>
               </a:rPr>
-              <a:t>El 23% de las personas no viajó ese día.</a:t>
+              <a:t>Cada persona i tiene una probabilidad πᵢ de ser incluida en la muestra (según su zona, su hogar y el día asignado).</a:t>
             </a:r>
           </a:p>
           <a:p>
@@ -7374,7 +7375,63 @@
                 </a:solidFill>
                 <a:latin typeface="Fira Sans"/>
               </a:rPr>
-              <a:t>Media: 1,9 viajes. Mediana: 2 viajes.</a:t>
+              <a:t>Su factor es el inverso: wᵢ = 1/πᵢ, las personas de la población que representa (Horvitz y Thompson, 1952).</a:t>
+            </a:r>
+          </a:p>
+          <a:p>
+            <a:pPr>
+              <a:lnSpc>
+                <a:spcPct val="112000"/>
+              </a:lnSpc>
+              <a:spcAft>
+                <a:spcPts val="500"/>
+              </a:spcAft>
+            </a:pPr>
+            <a:r>
+              <a:rPr sz="1300" b="0">
+                <a:solidFill>
+                  <a:srgbClr val="333333"/>
+                </a:solidFill>
+                <a:latin typeface="Fira Sans"/>
+              </a:rPr>
+              <a:t>     ◦  </a:t>
+            </a:r>
+            <a:r>
+              <a:rPr sz="1300" b="0">
+                <a:solidFill>
+                  <a:srgbClr val="333333"/>
+                </a:solidFill>
+                <a:latin typeface="Fira Sans"/>
+              </a:rPr>
+              <a:t>El total poblacional se estima sumando factores; las medias, ponderando por ellos.</a:t>
+            </a:r>
+          </a:p>
+          <a:p>
+            <a:pPr>
+              <a:lnSpc>
+                <a:spcPct val="112000"/>
+              </a:lnSpc>
+              <a:spcAft>
+                <a:spcPts val="500"/>
+              </a:spcAft>
+            </a:pPr>
+            <a:r>
+              <a:rPr sz="1300" b="0">
+                <a:solidFill>
+                  <a:srgbClr val="333333"/>
+                </a:solidFill>
+                <a:latin typeface="Fira Sans"/>
+              </a:rPr>
+              <a:t>     ◦  </a:t>
+            </a:r>
+            <a:r>
+              <a:rPr sz="1300" b="0">
+                <a:solidFill>
+                  <a:srgbClr val="333333"/>
+                </a:solidFill>
+                <a:latin typeface="Fira Sans"/>
+              </a:rPr>
+              <a:t>En la EOD: Factor_LaboralNormal (persona) y FactorLaboralNormal (viaje).</a:t>
             </a:r>
           </a:p>
           <a:p>
@@ -7396,48 +7453,20 @@
               <a:t>▸ </a:t>
             </a:r>
             <a:r>
-              <a:rPr sz="1500" b="0">
-                <a:solidFill>
-                  <a:srgbClr val="000000"/>
-                </a:solidFill>
-                <a:latin typeface="Fira Sans"/>
-              </a:rPr>
-              <a:t>La media quedó bajo la mediana: la masa de ceros la desplaza.</a:t>
-            </a:r>
-          </a:p>
-          <a:p>
-            <a:pPr>
-              <a:lnSpc>
-                <a:spcPct val="112000"/>
-              </a:lnSpc>
-              <a:spcAft>
-                <a:spcPts val="900"/>
-              </a:spcAft>
-            </a:pPr>
-            <a:r>
               <a:rPr sz="1500" b="1">
                 <a:solidFill>
-                  <a:srgbClr val="E0A437"/>
-                </a:solidFill>
-                <a:latin typeface="Fira Sans"/>
-              </a:rPr>
-              <a:t>▸ </a:t>
-            </a:r>
-            <a:r>
-              <a:rPr sz="1500" b="1">
-                <a:solidFill>
                   <a:srgbClr val="1D3557"/>
                 </a:solidFill>
                 <a:latin typeface="Fira Sans"/>
               </a:rPr>
-              <a:t>La dirección del sesgo depende de la forma de la distribución.</a:t>
+              <a:t>Dos pasos, en orden: definir la población (¿día laboral?) y ponderar dentro de ella. La cifra ingenua decía 23% sin viajes; la estimación correcta es 15%.</a:t>
             </a:r>
           </a:p>
         </p:txBody>
       </p:sp>
       <p:pic>
         <p:nvPicPr>
-          <p:cNvPr id="5" name="Picture 4" descr="02_viajes_por_persona.png"/>
+          <p:cNvPr id="5" name="Picture 4" descr="21_factor_formulas.png"/>
           <p:cNvPicPr>
             <a:picLocks noChangeAspect="1"/>
           </p:cNvPicPr>
@@ -7452,7 +7481,7 @@
         <p:spPr>
           <a:xfrm>
             <a:off x="4892040" y="1371600"/>
-            <a:ext cx="3840480" cy="2199656"/>
+            <a:ext cx="3840480" cy="3506775"/>
           </a:xfrm>
           <a:prstGeom prst="rect">
             <a:avLst/>
@@ -7550,7 +7579,7 @@
                 </a:solidFill>
                 <a:latin typeface="Fira Sans"/>
               </a:rPr>
-              <a:t>El ingreso de los hogares: media y mediana</a:t>
+              <a:t>Viajes por persona: los ausentes también cuentan</a:t>
             </a:r>
           </a:p>
         </p:txBody>
@@ -7601,7 +7630,7 @@
                 </a:solidFill>
                 <a:latin typeface="Fira Sans"/>
               </a:rPr>
-              <a:t>Media: $688.274. Mediana: $507.826.</a:t>
+              <a:t>Quien no viajó no está en la tabla de viajes: hay que reincorporarlo antes de calcular.</a:t>
             </a:r>
           </a:p>
           <a:p>
@@ -7629,7 +7658,7 @@
                 </a:solidFill>
                 <a:latin typeface="Fira Sans"/>
               </a:rPr>
-              <a:t>La media es un 36% más alta que la mediana.</a:t>
+              <a:t>Ponderado: el 15% de las personas no viajó; media de 2,2 viajes, mediana de 2.</a:t>
             </a:r>
           </a:p>
           <a:p>
@@ -7657,7 +7686,7 @@
                 </a:solidFill>
                 <a:latin typeface="Fira Sans"/>
               </a:rPr>
-              <a:t>Los ingresos altos desplazan el promedio; la mayoría gana menos.</a:t>
+              <a:t>El 59% de la población hace exactamente 2 viajes: la ida y la vuelta.</a:t>
             </a:r>
           </a:p>
           <a:p>
@@ -7685,14 +7714,14 @@
                 </a:solidFill>
                 <a:latin typeface="Fira Sans"/>
               </a:rPr>
-              <a:t>El promedio describe una situación en la que la mayoría no está.</a:t>
+              <a:t>La cifra ingenua decía 23%: mezclaba días de fin de semana y omitía los factores.</a:t>
             </a:r>
           </a:p>
         </p:txBody>
       </p:sp>
       <p:pic>
         <p:nvPicPr>
-          <p:cNvPr id="5" name="Picture 4" descr="01_ingreso_media_mediana.png"/>
+          <p:cNvPr id="5" name="Picture 4" descr="02_viajes_por_persona.png"/>
           <p:cNvPicPr>
             <a:picLocks noChangeAspect="1"/>
           </p:cNvPicPr>
@@ -7707,7 +7736,7 @@
         <p:spPr>
           <a:xfrm>
             <a:off x="4892040" y="1371600"/>
-            <a:ext cx="3840480" cy="2182719"/>
+            <a:ext cx="3840480" cy="2335791"/>
           </a:xfrm>
           <a:prstGeom prst="rect">
             <a:avLst/>
@@ -7805,7 +7834,7 @@
                 </a:solidFill>
                 <a:latin typeface="Fira Sans"/>
               </a:rPr>
-              <a:t>La duración de los viajes: valores extremos</a:t>
+              <a:t>El ingreso de los hogares: media y mediana</a:t>
             </a:r>
           </a:p>
         </p:txBody>
@@ -7856,7 +7885,7 @@
                 </a:solidFill>
                 <a:latin typeface="Fira Sans"/>
               </a:rPr>
-              <a:t>Mediana: 30 minutos. Percentil 95: 98 minutos.</a:t>
+              <a:t>Ponderado por el factor del hogar: media $729.898, mediana $520.000.</a:t>
             </a:r>
           </a:p>
           <a:p>
@@ -7884,7 +7913,7 @@
                 </a:solidFill>
                 <a:latin typeface="Fira Sans"/>
               </a:rPr>
-              <a:t>Máximo registrado: 1.335 minutos, un viaje de 22 horas.</a:t>
+              <a:t>La media es un 40% más alta que la mediana.</a:t>
             </a:r>
           </a:p>
           <a:p>
@@ -7912,7 +7941,7 @@
                 </a:solidFill>
                 <a:latin typeface="Fira Sans"/>
               </a:rPr>
-              <a:t>¿Error de digitación? ¿Turno nocturno mal anotado?</a:t>
+              <a:t>Los ingresos altos desplazan el promedio; la mayoría gana menos.</a:t>
             </a:r>
           </a:p>
           <a:p>
@@ -7940,14 +7969,14 @@
                 </a:solidFill>
                 <a:latin typeface="Fira Sans"/>
               </a:rPr>
-              <a:t>Los valores extremos se investigan y la decisión se declara.</a:t>
+              <a:t>El promedio describe una situación en la que la mayoría no está.</a:t>
             </a:r>
           </a:p>
         </p:txBody>
       </p:sp>
       <p:pic>
         <p:nvPicPr>
-          <p:cNvPr id="5" name="Picture 4" descr="04_duracion_viajes.png"/>
+          <p:cNvPr id="5" name="Picture 4" descr="01_ingreso_media_mediana.png"/>
           <p:cNvPicPr>
             <a:picLocks noChangeAspect="1"/>
           </p:cNvPicPr>
@@ -7962,7 +7991,7 @@
         <p:spPr>
           <a:xfrm>
             <a:off x="4892040" y="1371600"/>
-            <a:ext cx="3840480" cy="2170536"/>
+            <a:ext cx="3840480" cy="2119546"/>
           </a:xfrm>
           <a:prstGeom prst="rect">
             <a:avLst/>
@@ -8167,7 +8196,7 @@
                 </a:solidFill>
                 <a:latin typeface="Fira Sans"/>
               </a:rPr>
-              <a:t>La partición modal del Gran Santiago</a:t>
+              <a:t>La duración de los viajes: valores extremos</a:t>
             </a:r>
           </a:p>
         </p:txBody>
@@ -8218,91 +8247,7 @@
                 </a:solidFill>
                 <a:latin typeface="Fira Sans"/>
               </a:rPr>
-              <a:t>Dos merges y un groupby ponderado por factor.</a:t>
-            </a:r>
-          </a:p>
-          <a:p>
-            <a:pPr>
-              <a:lnSpc>
-                <a:spcPct val="112000"/>
-              </a:lnSpc>
-              <a:spcAft>
-                <a:spcPts val="500"/>
-              </a:spcAft>
-            </a:pPr>
-            <a:r>
-              <a:rPr sz="1300" b="0">
-                <a:solidFill>
-                  <a:srgbClr val="333333"/>
-                </a:solidFill>
-                <a:latin typeface="Fira Sans"/>
-              </a:rPr>
-              <a:t>     ◦  </a:t>
-            </a:r>
-            <a:r>
-              <a:rPr sz="1300" b="0">
-                <a:solidFill>
-                  <a:srgbClr val="333333"/>
-                </a:solidFill>
-                <a:latin typeface="Fira Sans"/>
-              </a:rPr>
-              <a:t>Caminata: 34% de los viajes.</a:t>
-            </a:r>
-          </a:p>
-          <a:p>
-            <a:pPr>
-              <a:lnSpc>
-                <a:spcPct val="112000"/>
-              </a:lnSpc>
-              <a:spcAft>
-                <a:spcPts val="500"/>
-              </a:spcAft>
-            </a:pPr>
-            <a:r>
-              <a:rPr sz="1300" b="0">
-                <a:solidFill>
-                  <a:srgbClr val="333333"/>
-                </a:solidFill>
-                <a:latin typeface="Fira Sans"/>
-              </a:rPr>
-              <a:t>     ◦  </a:t>
-            </a:r>
-            <a:r>
-              <a:rPr sz="1300" b="0">
-                <a:solidFill>
-                  <a:srgbClr val="333333"/>
-                </a:solidFill>
-                <a:latin typeface="Fira Sans"/>
-              </a:rPr>
-              <a:t>Transporte público (Bip!): 24%.</a:t>
-            </a:r>
-          </a:p>
-          <a:p>
-            <a:pPr>
-              <a:lnSpc>
-                <a:spcPct val="112000"/>
-              </a:lnSpc>
-              <a:spcAft>
-                <a:spcPts val="500"/>
-              </a:spcAft>
-            </a:pPr>
-            <a:r>
-              <a:rPr sz="1300" b="0">
-                <a:solidFill>
-                  <a:srgbClr val="333333"/>
-                </a:solidFill>
-                <a:latin typeface="Fira Sans"/>
-              </a:rPr>
-              <a:t>     ◦  </a:t>
-            </a:r>
-            <a:r>
-              <a:rPr sz="1300" b="0">
-                <a:solidFill>
-                  <a:srgbClr val="333333"/>
-                </a:solidFill>
-                <a:latin typeface="Fira Sans"/>
-              </a:rPr>
-              <a:t>Auto: 23%.</a:t>
+              <a:t>Ponderado por el factor del viaje: mediana de 25 minutos, percentil 95 de 90.</a:t>
             </a:r>
           </a:p>
           <a:p>
@@ -8324,20 +8269,76 @@
               <a:t>▸ </a:t>
             </a:r>
             <a:r>
+              <a:rPr sz="1500" b="0">
+                <a:solidFill>
+                  <a:srgbClr val="000000"/>
+                </a:solidFill>
+                <a:latin typeface="Fira Sans"/>
+              </a:rPr>
+              <a:t>Máximo registrado: 1.335 minutos, un viaje de 22 horas.</a:t>
+            </a:r>
+          </a:p>
+          <a:p>
+            <a:pPr>
+              <a:lnSpc>
+                <a:spcPct val="112000"/>
+              </a:lnSpc>
+              <a:spcAft>
+                <a:spcPts val="900"/>
+              </a:spcAft>
+            </a:pPr>
+            <a:r>
               <a:rPr sz="1500" b="1">
                 <a:solidFill>
+                  <a:srgbClr val="E0A437"/>
+                </a:solidFill>
+                <a:latin typeface="Fira Sans"/>
+              </a:rPr>
+              <a:t>▸ </a:t>
+            </a:r>
+            <a:r>
+              <a:rPr sz="1500" b="0">
+                <a:solidFill>
+                  <a:srgbClr val="000000"/>
+                </a:solidFill>
+                <a:latin typeface="Fira Sans"/>
+              </a:rPr>
+              <a:t>¿Error de digitación? ¿Turno nocturno mal anotado?</a:t>
+            </a:r>
+          </a:p>
+          <a:p>
+            <a:pPr>
+              <a:lnSpc>
+                <a:spcPct val="112000"/>
+              </a:lnSpc>
+              <a:spcAft>
+                <a:spcPts val="900"/>
+              </a:spcAft>
+            </a:pPr>
+            <a:r>
+              <a:rPr sz="1500" b="1">
+                <a:solidFill>
+                  <a:srgbClr val="E0A437"/>
+                </a:solidFill>
+                <a:latin typeface="Fira Sans"/>
+              </a:rPr>
+              <a:t>▸ </a:t>
+            </a:r>
+            <a:r>
+              <a:rPr sz="1500" b="1">
+                <a:solidFill>
                   <a:srgbClr val="1D3557"/>
                 </a:solidFill>
                 <a:latin typeface="Fira Sans"/>
               </a:rPr>
-              <a:t>Calculada desde los microdatos, con los factores de un día laboral.</a:t>
+              <a:t>Los valores extremos se investigan y la decisión se declara.</a:t>
             </a:r>
           </a:p>
         </p:txBody>
       </p:sp>
       <p:pic>
         <p:nvPicPr>
-          <p:cNvPr id="5" name="Picture 4" descr="03_reparto_modal.png"/>
+          <p:cNvPr id="5" name="Picture 4" descr="04_duracion_viajes.png"/>
           <p:cNvPicPr>
             <a:picLocks noChangeAspect="1"/>
           </p:cNvPicPr>
@@ -8352,7 +8353,7 @@
         <p:spPr>
           <a:xfrm>
             <a:off x="4892040" y="1371600"/>
-            <a:ext cx="3840480" cy="1909061"/>
+            <a:ext cx="3840480" cy="2170536"/>
           </a:xfrm>
           <a:prstGeom prst="rect">
             <a:avLst/>
@@ -8450,14 +8451,177 @@
                 </a:solidFill>
                 <a:latin typeface="Fira Sans"/>
               </a:rPr>
-              <a:t>El reparto modal difiere entre comunas</a:t>
+              <a:t>La partición modal del Gran Santiago</a:t>
+            </a:r>
+          </a:p>
+        </p:txBody>
+      </p:sp>
+      <p:sp>
+        <p:nvSpPr>
+          <p:cNvPr id="4" name="TextBox 3"/>
+          <p:cNvSpPr txBox="1"/>
+          <p:nvPr/>
+        </p:nvSpPr>
+        <p:spPr>
+          <a:xfrm>
+            <a:off x="502920" y="1252728"/>
+            <a:ext cx="4023360" cy="3200400"/>
+          </a:xfrm>
+          <a:prstGeom prst="rect">
+            <a:avLst/>
+          </a:prstGeom>
+          <a:noFill/>
+        </p:spPr>
+        <p:txBody>
+          <a:bodyPr wrap="square">
+            <a:spAutoFit/>
+          </a:bodyPr>
+          <a:lstStyle/>
+          <a:p>
+            <a:pPr>
+              <a:lnSpc>
+                <a:spcPct val="112000"/>
+              </a:lnSpc>
+              <a:spcAft>
+                <a:spcPts val="900"/>
+              </a:spcAft>
+            </a:pPr>
+            <a:r>
+              <a:rPr sz="1500" b="1">
+                <a:solidFill>
+                  <a:srgbClr val="E0A437"/>
+                </a:solidFill>
+                <a:latin typeface="Fira Sans"/>
+              </a:rPr>
+              <a:t>▸ </a:t>
+            </a:r>
+            <a:r>
+              <a:rPr sz="1500" b="0">
+                <a:solidFill>
+                  <a:srgbClr val="000000"/>
+                </a:solidFill>
+                <a:latin typeface="Fira Sans"/>
+              </a:rPr>
+              <a:t>Dos merges y un groupby ponderado por factor.</a:t>
+            </a:r>
+          </a:p>
+          <a:p>
+            <a:pPr>
+              <a:lnSpc>
+                <a:spcPct val="112000"/>
+              </a:lnSpc>
+              <a:spcAft>
+                <a:spcPts val="500"/>
+              </a:spcAft>
+            </a:pPr>
+            <a:r>
+              <a:rPr sz="1300" b="0">
+                <a:solidFill>
+                  <a:srgbClr val="333333"/>
+                </a:solidFill>
+                <a:latin typeface="Fira Sans"/>
+              </a:rPr>
+              <a:t>     ◦  </a:t>
+            </a:r>
+            <a:r>
+              <a:rPr sz="1300" b="0">
+                <a:solidFill>
+                  <a:srgbClr val="333333"/>
+                </a:solidFill>
+                <a:latin typeface="Fira Sans"/>
+              </a:rPr>
+              <a:t>Caminata: 34% de los viajes.</a:t>
+            </a:r>
+          </a:p>
+          <a:p>
+            <a:pPr>
+              <a:lnSpc>
+                <a:spcPct val="112000"/>
+              </a:lnSpc>
+              <a:spcAft>
+                <a:spcPts val="500"/>
+              </a:spcAft>
+            </a:pPr>
+            <a:r>
+              <a:rPr sz="1300" b="0">
+                <a:solidFill>
+                  <a:srgbClr val="333333"/>
+                </a:solidFill>
+                <a:latin typeface="Fira Sans"/>
+              </a:rPr>
+              <a:t>     ◦  </a:t>
+            </a:r>
+            <a:r>
+              <a:rPr sz="1300" b="0">
+                <a:solidFill>
+                  <a:srgbClr val="333333"/>
+                </a:solidFill>
+                <a:latin typeface="Fira Sans"/>
+              </a:rPr>
+              <a:t>Transporte público (Bip!): 24%.</a:t>
+            </a:r>
+          </a:p>
+          <a:p>
+            <a:pPr>
+              <a:lnSpc>
+                <a:spcPct val="112000"/>
+              </a:lnSpc>
+              <a:spcAft>
+                <a:spcPts val="500"/>
+              </a:spcAft>
+            </a:pPr>
+            <a:r>
+              <a:rPr sz="1300" b="0">
+                <a:solidFill>
+                  <a:srgbClr val="333333"/>
+                </a:solidFill>
+                <a:latin typeface="Fira Sans"/>
+              </a:rPr>
+              <a:t>     ◦  </a:t>
+            </a:r>
+            <a:r>
+              <a:rPr sz="1300" b="0">
+                <a:solidFill>
+                  <a:srgbClr val="333333"/>
+                </a:solidFill>
+                <a:latin typeface="Fira Sans"/>
+              </a:rPr>
+              <a:t>Auto: 23%.</a:t>
+            </a:r>
+          </a:p>
+          <a:p>
+            <a:pPr>
+              <a:lnSpc>
+                <a:spcPct val="112000"/>
+              </a:lnSpc>
+              <a:spcAft>
+                <a:spcPts val="900"/>
+              </a:spcAft>
+            </a:pPr>
+            <a:r>
+              <a:rPr sz="1500" b="1">
+                <a:solidFill>
+                  <a:srgbClr val="E0A437"/>
+                </a:solidFill>
+                <a:latin typeface="Fira Sans"/>
+              </a:rPr>
+              <a:t>▸ </a:t>
+            </a:r>
+            <a:r>
+              <a:rPr sz="1500" b="1">
+                <a:solidFill>
+                  <a:srgbClr val="1D3557"/>
+                </a:solidFill>
+                <a:latin typeface="Fira Sans"/>
+              </a:rPr>
+              <a:t>Calculada desde los microdatos, con los factores de un día laboral.</a:t>
             </a:r>
           </a:p>
         </p:txBody>
       </p:sp>
       <p:pic>
         <p:nvPicPr>
-          <p:cNvPr id="4" name="Picture 3" descr="08_modo_por_comuna.png"/>
+          <p:cNvPr id="5" name="Picture 4" descr="03_reparto_modal.png"/>
           <p:cNvPicPr>
             <a:picLocks noChangeAspect="1"/>
           </p:cNvPicPr>
@@ -8471,48 +8635,14 @@
         </p:blipFill>
         <p:spPr>
           <a:xfrm>
-            <a:off x="1994250" y="1143000"/>
-            <a:ext cx="5155498" cy="3154679"/>
+            <a:off x="4892040" y="1371600"/>
+            <a:ext cx="3840480" cy="1909061"/>
           </a:xfrm>
           <a:prstGeom prst="rect">
             <a:avLst/>
           </a:prstGeom>
         </p:spPr>
       </p:pic>
-      <p:sp>
-        <p:nvSpPr>
-          <p:cNvPr id="5" name="TextBox 4"/>
-          <p:cNvSpPr txBox="1"/>
-          <p:nvPr/>
-        </p:nvSpPr>
-        <p:spPr>
-          <a:xfrm>
-            <a:off x="704088" y="4434840"/>
-            <a:ext cx="7744968" cy="457200"/>
-          </a:xfrm>
-          <a:prstGeom prst="rect">
-            <a:avLst/>
-          </a:prstGeom>
-          <a:noFill/>
-        </p:spPr>
-        <p:txBody>
-          <a:bodyPr wrap="square">
-            <a:spAutoFit/>
-          </a:bodyPr>
-          <a:lstStyle/>
-          <a:p>
-            <a:r>
-              <a:rPr sz="1300" b="0">
-                <a:solidFill>
-                  <a:srgbClr val="333333"/>
-                </a:solidFill>
-                <a:latin typeface="Fira Sans"/>
-              </a:rPr>
-              <a:t>Normalizar por comuna permite comparar proporciones entre comunas de tamaños muy distintos.</a:t>
-            </a:r>
-          </a:p>
-        </p:txBody>
-      </p:sp>
     </p:spTree>
   </p:cSld>
   <p:clrMapOvr>
@@ -8604,177 +8734,14 @@
                 </a:solidFill>
                 <a:latin typeface="Fira Sans"/>
               </a:rPr>
-              <a:t>Ingreso y uso de transporte público</a:t>
-            </a:r>
-          </a:p>
-        </p:txBody>
-      </p:sp>
-      <p:sp>
-        <p:nvSpPr>
-          <p:cNvPr id="4" name="TextBox 3"/>
-          <p:cNvSpPr txBox="1"/>
-          <p:nvPr/>
-        </p:nvSpPr>
-        <p:spPr>
-          <a:xfrm>
-            <a:off x="502920" y="1252728"/>
-            <a:ext cx="4023360" cy="3200400"/>
-          </a:xfrm>
-          <a:prstGeom prst="rect">
-            <a:avLst/>
-          </a:prstGeom>
-          <a:noFill/>
-        </p:spPr>
-        <p:txBody>
-          <a:bodyPr wrap="square">
-            <a:spAutoFit/>
-          </a:bodyPr>
-          <a:lstStyle/>
-          <a:p>
-            <a:pPr>
-              <a:lnSpc>
-                <a:spcPct val="112000"/>
-              </a:lnSpc>
-              <a:spcAft>
-                <a:spcPts val="900"/>
-              </a:spcAft>
-            </a:pPr>
-            <a:r>
-              <a:rPr sz="1500" b="1">
-                <a:solidFill>
-                  <a:srgbClr val="E0A437"/>
-                </a:solidFill>
-                <a:latin typeface="Fira Sans"/>
-              </a:rPr>
-              <a:t>▸ </a:t>
-            </a:r>
-            <a:r>
-              <a:rPr sz="1500" b="0">
-                <a:solidFill>
-                  <a:srgbClr val="000000"/>
-                </a:solidFill>
-                <a:latin typeface="Fira Sans"/>
-              </a:rPr>
-              <a:t>Cada punto es una comuna: ingreso medio contra proporción de viajes en transporte público.</a:t>
-            </a:r>
-          </a:p>
-          <a:p>
-            <a:pPr>
-              <a:lnSpc>
-                <a:spcPct val="112000"/>
-              </a:lnSpc>
-              <a:spcAft>
-                <a:spcPts val="500"/>
-              </a:spcAft>
-            </a:pPr>
-            <a:r>
-              <a:rPr sz="1300" b="0">
-                <a:solidFill>
-                  <a:srgbClr val="333333"/>
-                </a:solidFill>
-                <a:latin typeface="Fira Sans"/>
-              </a:rPr>
-              <a:t>     ◦  </a:t>
-            </a:r>
-            <a:r>
-              <a:rPr sz="1300" b="0">
-                <a:solidFill>
-                  <a:srgbClr val="333333"/>
-                </a:solidFill>
-                <a:latin typeface="Fira Sans"/>
-              </a:rPr>
-              <a:t>Periferia (Buin, Melipilla): poco transporte público; la red no llega.</a:t>
-            </a:r>
-          </a:p>
-          <a:p>
-            <a:pPr>
-              <a:lnSpc>
-                <a:spcPct val="112000"/>
-              </a:lnSpc>
-              <a:spcAft>
-                <a:spcPts val="500"/>
-              </a:spcAft>
-            </a:pPr>
-            <a:r>
-              <a:rPr sz="1300" b="0">
-                <a:solidFill>
-                  <a:srgbClr val="333333"/>
-                </a:solidFill>
-                <a:latin typeface="Fira Sans"/>
-              </a:rPr>
-              <a:t>     ◦  </a:t>
-            </a:r>
-            <a:r>
-              <a:rPr sz="1300" b="0">
-                <a:solidFill>
-                  <a:srgbClr val="333333"/>
-                </a:solidFill>
-                <a:latin typeface="Fira Sans"/>
-              </a:rPr>
-              <a:t>Ingresos altos (Vitacura, Lo Barnechea): conectadas, con poco uso.</a:t>
-            </a:r>
-          </a:p>
-          <a:p>
-            <a:pPr>
-              <a:lnSpc>
-                <a:spcPct val="112000"/>
-              </a:lnSpc>
-              <a:spcAft>
-                <a:spcPts val="500"/>
-              </a:spcAft>
-            </a:pPr>
-            <a:r>
-              <a:rPr sz="1300" b="0">
-                <a:solidFill>
-                  <a:srgbClr val="333333"/>
-                </a:solidFill>
-                <a:latin typeface="Fira Sans"/>
-              </a:rPr>
-              <a:t>     ◦  </a:t>
-            </a:r>
-            <a:r>
-              <a:rPr sz="1300" b="0">
-                <a:solidFill>
-                  <a:srgbClr val="333333"/>
-                </a:solidFill>
-                <a:latin typeface="Fira Sans"/>
-              </a:rPr>
-              <a:t>Correlación de Pearson: -0,17. La asociación lineal es débil.</a:t>
-            </a:r>
-          </a:p>
-          <a:p>
-            <a:pPr>
-              <a:lnSpc>
-                <a:spcPct val="112000"/>
-              </a:lnSpc>
-              <a:spcAft>
-                <a:spcPts val="900"/>
-              </a:spcAft>
-            </a:pPr>
-            <a:r>
-              <a:rPr sz="1500" b="1">
-                <a:solidFill>
-                  <a:srgbClr val="E0A437"/>
-                </a:solidFill>
-                <a:latin typeface="Fira Sans"/>
-              </a:rPr>
-              <a:t>▸ </a:t>
-            </a:r>
-            <a:r>
-              <a:rPr sz="1500" b="1">
-                <a:solidFill>
-                  <a:srgbClr val="1D3557"/>
-                </a:solidFill>
-                <a:latin typeface="Fira Sans"/>
-              </a:rPr>
-              <a:t>Como vimos en el marco conceptual: el coeficiente no reemplaza al gráfico, y la asociación no autoriza verbos causales.</a:t>
+              <a:t>El reparto modal difiere entre comunas</a:t>
             </a:r>
           </a:p>
         </p:txBody>
       </p:sp>
       <p:pic>
         <p:nvPicPr>
-          <p:cNvPr id="5" name="Picture 4" descr="09_ingreso_vs_tp.png"/>
+          <p:cNvPr id="4" name="Picture 3" descr="08_modo_por_comuna.png"/>
           <p:cNvPicPr>
             <a:picLocks noChangeAspect="1"/>
           </p:cNvPicPr>
@@ -8788,14 +8755,48 @@
         </p:blipFill>
         <p:spPr>
           <a:xfrm>
-            <a:off x="4892040" y="1371600"/>
-            <a:ext cx="3840480" cy="2526979"/>
+            <a:off x="1994250" y="1143000"/>
+            <a:ext cx="5155498" cy="3154679"/>
           </a:xfrm>
           <a:prstGeom prst="rect">
             <a:avLst/>
           </a:prstGeom>
         </p:spPr>
       </p:pic>
+      <p:sp>
+        <p:nvSpPr>
+          <p:cNvPr id="5" name="TextBox 4"/>
+          <p:cNvSpPr txBox="1"/>
+          <p:nvPr/>
+        </p:nvSpPr>
+        <p:spPr>
+          <a:xfrm>
+            <a:off x="704088" y="4434840"/>
+            <a:ext cx="7744968" cy="457200"/>
+          </a:xfrm>
+          <a:prstGeom prst="rect">
+            <a:avLst/>
+          </a:prstGeom>
+          <a:noFill/>
+        </p:spPr>
+        <p:txBody>
+          <a:bodyPr wrap="square">
+            <a:spAutoFit/>
+          </a:bodyPr>
+          <a:lstStyle/>
+          <a:p>
+            <a:r>
+              <a:rPr sz="1300" b="0">
+                <a:solidFill>
+                  <a:srgbClr val="333333"/>
+                </a:solidFill>
+                <a:latin typeface="Fira Sans"/>
+              </a:rPr>
+              <a:t>Normalizar por comuna permite comparar proporciones entre comunas de tamaños muy distintos.</a:t>
+            </a:r>
+          </a:p>
+        </p:txBody>
+      </p:sp>
     </p:spTree>
   </p:cSld>
   <p:clrMapOvr>
@@ -8887,14 +8888,177 @@
                 </a:solidFill>
                 <a:latin typeface="Fira Sans"/>
               </a:rPr>
-              <a:t>Los propósitos de viaje según el día de la semana</a:t>
+              <a:t>Ingreso y uso de transporte público</a:t>
+            </a:r>
+          </a:p>
+        </p:txBody>
+      </p:sp>
+      <p:sp>
+        <p:nvSpPr>
+          <p:cNvPr id="4" name="TextBox 3"/>
+          <p:cNvSpPr txBox="1"/>
+          <p:nvPr/>
+        </p:nvSpPr>
+        <p:spPr>
+          <a:xfrm>
+            <a:off x="502920" y="1252728"/>
+            <a:ext cx="4023360" cy="3200400"/>
+          </a:xfrm>
+          <a:prstGeom prst="rect">
+            <a:avLst/>
+          </a:prstGeom>
+          <a:noFill/>
+        </p:spPr>
+        <p:txBody>
+          <a:bodyPr wrap="square">
+            <a:spAutoFit/>
+          </a:bodyPr>
+          <a:lstStyle/>
+          <a:p>
+            <a:pPr>
+              <a:lnSpc>
+                <a:spcPct val="112000"/>
+              </a:lnSpc>
+              <a:spcAft>
+                <a:spcPts val="900"/>
+              </a:spcAft>
+            </a:pPr>
+            <a:r>
+              <a:rPr sz="1500" b="1">
+                <a:solidFill>
+                  <a:srgbClr val="E0A437"/>
+                </a:solidFill>
+                <a:latin typeface="Fira Sans"/>
+              </a:rPr>
+              <a:t>▸ </a:t>
+            </a:r>
+            <a:r>
+              <a:rPr sz="1500" b="0">
+                <a:solidFill>
+                  <a:srgbClr val="000000"/>
+                </a:solidFill>
+                <a:latin typeface="Fira Sans"/>
+              </a:rPr>
+              <a:t>Cada punto es una comuna: ingreso medio contra proporción de viajes en transporte público.</a:t>
+            </a:r>
+          </a:p>
+          <a:p>
+            <a:pPr>
+              <a:lnSpc>
+                <a:spcPct val="112000"/>
+              </a:lnSpc>
+              <a:spcAft>
+                <a:spcPts val="500"/>
+              </a:spcAft>
+            </a:pPr>
+            <a:r>
+              <a:rPr sz="1300" b="0">
+                <a:solidFill>
+                  <a:srgbClr val="333333"/>
+                </a:solidFill>
+                <a:latin typeface="Fira Sans"/>
+              </a:rPr>
+              <a:t>     ◦  </a:t>
+            </a:r>
+            <a:r>
+              <a:rPr sz="1300" b="0">
+                <a:solidFill>
+                  <a:srgbClr val="333333"/>
+                </a:solidFill>
+                <a:latin typeface="Fira Sans"/>
+              </a:rPr>
+              <a:t>Periferia (Buin, Melipilla): poco transporte público; la red no llega.</a:t>
+            </a:r>
+          </a:p>
+          <a:p>
+            <a:pPr>
+              <a:lnSpc>
+                <a:spcPct val="112000"/>
+              </a:lnSpc>
+              <a:spcAft>
+                <a:spcPts val="500"/>
+              </a:spcAft>
+            </a:pPr>
+            <a:r>
+              <a:rPr sz="1300" b="0">
+                <a:solidFill>
+                  <a:srgbClr val="333333"/>
+                </a:solidFill>
+                <a:latin typeface="Fira Sans"/>
+              </a:rPr>
+              <a:t>     ◦  </a:t>
+            </a:r>
+            <a:r>
+              <a:rPr sz="1300" b="0">
+                <a:solidFill>
+                  <a:srgbClr val="333333"/>
+                </a:solidFill>
+                <a:latin typeface="Fira Sans"/>
+              </a:rPr>
+              <a:t>Ingresos altos (Vitacura, Lo Barnechea): conectadas, con poco uso.</a:t>
+            </a:r>
+          </a:p>
+          <a:p>
+            <a:pPr>
+              <a:lnSpc>
+                <a:spcPct val="112000"/>
+              </a:lnSpc>
+              <a:spcAft>
+                <a:spcPts val="500"/>
+              </a:spcAft>
+            </a:pPr>
+            <a:r>
+              <a:rPr sz="1300" b="0">
+                <a:solidFill>
+                  <a:srgbClr val="333333"/>
+                </a:solidFill>
+                <a:latin typeface="Fira Sans"/>
+              </a:rPr>
+              <a:t>     ◦  </a:t>
+            </a:r>
+            <a:r>
+              <a:rPr sz="1300" b="0">
+                <a:solidFill>
+                  <a:srgbClr val="333333"/>
+                </a:solidFill>
+                <a:latin typeface="Fira Sans"/>
+              </a:rPr>
+              <a:t>Correlación de Pearson: -0,17. La asociación lineal es débil.</a:t>
+            </a:r>
+          </a:p>
+          <a:p>
+            <a:pPr>
+              <a:lnSpc>
+                <a:spcPct val="112000"/>
+              </a:lnSpc>
+              <a:spcAft>
+                <a:spcPts val="900"/>
+              </a:spcAft>
+            </a:pPr>
+            <a:r>
+              <a:rPr sz="1500" b="1">
+                <a:solidFill>
+                  <a:srgbClr val="E0A437"/>
+                </a:solidFill>
+                <a:latin typeface="Fira Sans"/>
+              </a:rPr>
+              <a:t>▸ </a:t>
+            </a:r>
+            <a:r>
+              <a:rPr sz="1500" b="1">
+                <a:solidFill>
+                  <a:srgbClr val="1D3557"/>
+                </a:solidFill>
+                <a:latin typeface="Fira Sans"/>
+              </a:rPr>
+              <a:t>Como vimos en el marco conceptual: el coeficiente no reemplaza al gráfico, y la asociación no autoriza verbos causales.</a:t>
             </a:r>
           </a:p>
         </p:txBody>
       </p:sp>
       <p:pic>
         <p:nvPicPr>
-          <p:cNvPr id="4" name="Picture 3" descr="10_heatmap_rutinas.png"/>
+          <p:cNvPr id="5" name="Picture 4" descr="09_ingreso_vs_tp.png"/>
           <p:cNvPicPr>
             <a:picLocks noChangeAspect="1"/>
           </p:cNvPicPr>
@@ -8908,48 +9072,14 @@
         </p:blipFill>
         <p:spPr>
           <a:xfrm>
-            <a:off x="1649319" y="1143000"/>
-            <a:ext cx="5845360" cy="3154680"/>
+            <a:off x="4892040" y="1371600"/>
+            <a:ext cx="3840480" cy="2526979"/>
           </a:xfrm>
           <a:prstGeom prst="rect">
             <a:avLst/>
           </a:prstGeom>
         </p:spPr>
       </p:pic>
-      <p:sp>
-        <p:nvSpPr>
-          <p:cNvPr id="5" name="TextBox 4"/>
-          <p:cNvSpPr txBox="1"/>
-          <p:nvPr/>
-        </p:nvSpPr>
-        <p:spPr>
-          <a:xfrm>
-            <a:off x="704088" y="4434840"/>
-            <a:ext cx="7744968" cy="457200"/>
-          </a:xfrm>
-          <a:prstGeom prst="rect">
-            <a:avLst/>
-          </a:prstGeom>
-          <a:noFill/>
-        </p:spPr>
-        <p:txBody>
-          <a:bodyPr wrap="square">
-            <a:spAutoFit/>
-          </a:bodyPr>
-          <a:lstStyle/>
-          <a:p>
-            <a:r>
-              <a:rPr sz="1300" b="0">
-                <a:solidFill>
-                  <a:srgbClr val="333333"/>
-                </a:solidFill>
-                <a:latin typeface="Fira Sans"/>
-              </a:rPr>
-              <a:t>El heatmap muestra 14 propósitos por 7 días en una sola figura: útil para tablas completas.</a:t>
-            </a:r>
-          </a:p>
-        </p:txBody>
-      </p:sp>
     </p:spTree>
   </p:cSld>
   <p:clrMapOvr>
@@ -9041,14 +9171,14 @@
                 </a:solidFill>
                 <a:latin typeface="Fira Sans"/>
               </a:rPr>
-              <a:t>Cuando los datos crecen</a:t>
+              <a:t>Los propósitos de viaje según el día de la semana</a:t>
             </a:r>
           </a:p>
         </p:txBody>
       </p:sp>
       <p:pic>
         <p:nvPicPr>
-          <p:cNvPr id="4" name="Picture 3" descr="14_escala_datos.png"/>
+          <p:cNvPr id="4" name="Picture 3" descr="10_heatmap_rutinas.png"/>
           <p:cNvPicPr>
             <a:picLocks noChangeAspect="1"/>
           </p:cNvPicPr>
@@ -9062,8 +9192,8 @@
         </p:blipFill>
         <p:spPr>
           <a:xfrm>
-            <a:off x="1417319" y="1143000"/>
-            <a:ext cx="6309360" cy="2324913"/>
+            <a:off x="1649319" y="1143000"/>
+            <a:ext cx="5845360" cy="3154680"/>
           </a:xfrm>
           <a:prstGeom prst="rect">
             <a:avLst/>
@@ -9099,7 +9229,7 @@
                 </a:solidFill>
                 <a:latin typeface="Fira Sans"/>
               </a:rPr>
-              <a:t>PySpark se usa con SQL o con sus propios DataFrames; Dask reparte operaciones estilo Pandas; Polars y DuckDB rinden en una sola máquina.</a:t>
+              <a:t>El heatmap muestra 14 propósitos por 7 días en una sola figura: útil para tablas completas.</a:t>
             </a:r>
           </a:p>
         </p:txBody>
@@ -9195,21 +9325,45 @@
                 </a:solidFill>
                 <a:latin typeface="Fira Sans"/>
               </a:rPr>
-              <a:t>Síntesis</a:t>
-            </a:r>
-          </a:p>
-        </p:txBody>
-      </p:sp>
-      <p:sp>
-        <p:nvSpPr>
-          <p:cNvPr id="4" name="TextBox 3"/>
+              <a:t>Cuando los datos crecen</a:t>
+            </a:r>
+          </a:p>
+        </p:txBody>
+      </p:sp>
+      <p:pic>
+        <p:nvPicPr>
+          <p:cNvPr id="4" name="Picture 3" descr="14_escala_datos.png"/>
+          <p:cNvPicPr>
+            <a:picLocks noChangeAspect="1"/>
+          </p:cNvPicPr>
+          <p:nvPr/>
+        </p:nvPicPr>
+        <p:blipFill>
+          <a:blip r:embed="rId2"/>
+          <a:stretch>
+            <a:fillRect/>
+          </a:stretch>
+        </p:blipFill>
+        <p:spPr>
+          <a:xfrm>
+            <a:off x="1417319" y="1143000"/>
+            <a:ext cx="6309360" cy="2324913"/>
+          </a:xfrm>
+          <a:prstGeom prst="rect">
+            <a:avLst/>
+          </a:prstGeom>
+        </p:spPr>
+      </p:pic>
+      <p:sp>
+        <p:nvSpPr>
+          <p:cNvPr id="5" name="TextBox 4"/>
           <p:cNvSpPr txBox="1"/>
           <p:nvPr/>
         </p:nvSpPr>
         <p:spPr>
           <a:xfrm>
-            <a:off x="704088" y="1353312"/>
-            <a:ext cx="7744968" cy="3300984"/>
+            <a:off x="704088" y="4434840"/>
+            <a:ext cx="7744968" cy="457200"/>
           </a:xfrm>
           <a:prstGeom prst="rect">
             <a:avLst/>
@@ -9222,143 +9376,14 @@
           </a:bodyPr>
           <a:lstStyle/>
           <a:p>
-            <a:pPr>
-              <a:lnSpc>
-                <a:spcPct val="112000"/>
-              </a:lnSpc>
-              <a:spcAft>
-                <a:spcPts val="900"/>
-              </a:spcAft>
-            </a:pPr>
-            <a:r>
-              <a:rPr sz="1800" b="1">
-                <a:solidFill>
-                  <a:srgbClr val="E0A437"/>
-                </a:solidFill>
-                <a:latin typeface="Fira Sans"/>
-              </a:rPr>
-              <a:t>▸ </a:t>
-            </a:r>
-            <a:r>
-              <a:rPr sz="1800" b="0">
-                <a:solidFill>
-                  <a:srgbClr val="000000"/>
-                </a:solidFill>
-                <a:latin typeface="Fira Sans"/>
-              </a:rPr>
-              <a:t>Un modelo es una simplificación con decisiones incorporadas; estimarlo puede buscar inferencia o predicción.</a:t>
-            </a:r>
-          </a:p>
-          <a:p>
-            <a:pPr>
-              <a:lnSpc>
-                <a:spcPct val="112000"/>
-              </a:lnSpc>
-              <a:spcAft>
-                <a:spcPts val="900"/>
-              </a:spcAft>
-            </a:pPr>
-            <a:r>
-              <a:rPr sz="1800" b="1">
-                <a:solidFill>
-                  <a:srgbClr val="E0A437"/>
-                </a:solidFill>
-                <a:latin typeface="Fira Sans"/>
-              </a:rPr>
-              <a:t>▸ </a:t>
-            </a:r>
-            <a:r>
-              <a:rPr sz="1800" b="0">
-                <a:solidFill>
-                  <a:srgbClr val="000000"/>
-                </a:solidFill>
-                <a:latin typeface="Fira Sans"/>
-              </a:rPr>
-              <a:t>Las asociaciones se reportan como asociaciones: la causalidad exige más que datos observacionales.</a:t>
-            </a:r>
-          </a:p>
-          <a:p>
-            <a:pPr>
-              <a:lnSpc>
-                <a:spcPct val="112000"/>
-              </a:lnSpc>
-              <a:spcAft>
-                <a:spcPts val="900"/>
-              </a:spcAft>
-            </a:pPr>
-            <a:r>
-              <a:rPr sz="1800" b="1">
-                <a:solidFill>
-                  <a:srgbClr val="E0A437"/>
-                </a:solidFill>
-                <a:latin typeface="Fira Sans"/>
-              </a:rPr>
-              <a:t>▸ </a:t>
-            </a:r>
-            <a:r>
-              <a:rPr sz="1800" b="0">
-                <a:solidFill>
-                  <a:srgbClr val="000000"/>
-                </a:solidFill>
-                <a:latin typeface="Fira Sans"/>
-              </a:rPr>
-              <a:t>El tipo de la variable, no su dtype, determina qué resúmenes tienen sentido.</a:t>
-            </a:r>
-          </a:p>
-          <a:p>
-            <a:pPr>
-              <a:lnSpc>
-                <a:spcPct val="112000"/>
-              </a:lnSpc>
-              <a:spcAft>
-                <a:spcPts val="900"/>
-              </a:spcAft>
-            </a:pPr>
-            <a:r>
-              <a:rPr sz="1800" b="1">
-                <a:solidFill>
-                  <a:srgbClr val="E0A437"/>
-                </a:solidFill>
-                <a:latin typeface="Fira Sans"/>
-              </a:rPr>
-              <a:t>▸ </a:t>
-            </a:r>
-            <a:r>
-              <a:rPr sz="1800" b="0">
-                <a:solidFill>
-                  <a:srgbClr val="000000"/>
-                </a:solidFill>
-                <a:latin typeface="Fira Sans"/>
-              </a:rPr>
-              <a:t>Con distribuciones asimétricas, la mediana y los percentiles describen mejor lo típico que la media.</a:t>
-            </a:r>
-          </a:p>
-          <a:p>
-            <a:pPr>
-              <a:lnSpc>
-                <a:spcPct val="112000"/>
-              </a:lnSpc>
-              <a:spcAft>
-                <a:spcPts val="900"/>
-              </a:spcAft>
-            </a:pPr>
-            <a:r>
-              <a:rPr sz="1800" b="1">
-                <a:solidFill>
-                  <a:srgbClr val="E0A437"/>
-                </a:solidFill>
-                <a:latin typeface="Fira Sans"/>
-              </a:rPr>
-              <a:t>▸ </a:t>
-            </a:r>
-            <a:r>
-              <a:rPr sz="1800" b="1">
-                <a:solidFill>
-                  <a:srgbClr val="1D3557"/>
-                </a:solidFill>
-                <a:latin typeface="Fira Sans"/>
-              </a:rPr>
-              <a:t>El concepto de la clase: el EDA, examinar los datos antes de modelarlos, preguntando ante cada cifra de quién habla.</a:t>
+            <a:r>
+              <a:rPr sz="1300" b="0">
+                <a:solidFill>
+                  <a:srgbClr val="333333"/>
+                </a:solidFill>
+                <a:latin typeface="Fira Sans"/>
+              </a:rPr>
+              <a:t>PySpark se usa con SQL o con sus propios DataFrames; Dask reparte operaciones estilo Pandas; Polars y DuckDB rinden en una sola máquina.</a:t>
             </a:r>
           </a:p>
         </p:txBody>
@@ -9454,7 +9479,7 @@
                 </a:solidFill>
                 <a:latin typeface="Fira Sans"/>
               </a:rPr>
-              <a:t>Segundo bloque: comienza la Tarea 1</a:t>
+              <a:t>Síntesis</a:t>
             </a:r>
           </a:p>
         </p:txBody>
@@ -9505,91 +9530,7 @@
                 </a:solidFill>
                 <a:latin typeface="Fira Sans"/>
               </a:rPr>
-              <a:t>El retrato de tu comuna: cada pareja adopta una comuna del Gran Santiago.</a:t>
-            </a:r>
-          </a:p>
-          <a:p>
-            <a:pPr>
-              <a:lnSpc>
-                <a:spcPct val="112000"/>
-              </a:lnSpc>
-              <a:spcAft>
-                <a:spcPts val="500"/>
-              </a:spcAft>
-            </a:pPr>
-            <a:r>
-              <a:rPr sz="1400" b="0">
-                <a:solidFill>
-                  <a:srgbClr val="333333"/>
-                </a:solidFill>
-                <a:latin typeface="Fira Sans"/>
-              </a:rPr>
-              <a:t>     ◦  </a:t>
-            </a:r>
-            <a:r>
-              <a:rPr sz="1400" b="0">
-                <a:solidFill>
-                  <a:srgbClr val="333333"/>
-                </a:solidFill>
-                <a:latin typeface="Fira Sans"/>
-              </a:rPr>
-              <a:t>Hoy: elegir la comuna y construir su retrato numérico.</a:t>
-            </a:r>
-          </a:p>
-          <a:p>
-            <a:pPr>
-              <a:lnSpc>
-                <a:spcPct val="112000"/>
-              </a:lnSpc>
-              <a:spcAft>
-                <a:spcPts val="500"/>
-              </a:spcAft>
-            </a:pPr>
-            <a:r>
-              <a:rPr sz="1400" b="0">
-                <a:solidFill>
-                  <a:srgbClr val="333333"/>
-                </a:solidFill>
-                <a:latin typeface="Fira Sans"/>
-              </a:rPr>
-              <a:t>     ◦  </a:t>
-            </a:r>
-            <a:r>
-              <a:rPr sz="1400" b="0">
-                <a:solidFill>
-                  <a:srgbClr val="333333"/>
-                </a:solidFill>
-                <a:latin typeface="Fira Sans"/>
-              </a:rPr>
-              <a:t>Próxima clase: el retrato gráfico, con métodos de visualización.</a:t>
-            </a:r>
-          </a:p>
-          <a:p>
-            <a:pPr>
-              <a:lnSpc>
-                <a:spcPct val="112000"/>
-              </a:lnSpc>
-              <a:spcAft>
-                <a:spcPts val="500"/>
-              </a:spcAft>
-            </a:pPr>
-            <a:r>
-              <a:rPr sz="1400" b="0">
-                <a:solidFill>
-                  <a:srgbClr val="333333"/>
-                </a:solidFill>
-                <a:latin typeface="Fira Sans"/>
-              </a:rPr>
-              <a:t>     ◦  </a:t>
-            </a:r>
-            <a:r>
-              <a:rPr sz="1400" b="0">
-                <a:solidFill>
-                  <a:srgbClr val="333333"/>
-                </a:solidFill>
-                <a:latin typeface="Fira Sans"/>
-              </a:rPr>
-              <a:t>Entrega del retrato completo: jueves 10 de septiembre, por Aula.</a:t>
+              <a:t>Un modelo es una simplificación con decisiones incorporadas; estimarlo puede buscar inferencia o predicción.</a:t>
             </a:r>
           </a:p>
           <a:p>
@@ -9617,7 +9558,7 @@
                 </a:solidFill>
                 <a:latin typeface="Fira Sans"/>
               </a:rPr>
-              <a:t>El enunciado está en evaluaciones/tareas/ y la guía de hoy en actividades/.</a:t>
+              <a:t>Las asociaciones se reportan como asociaciones: la causalidad exige más que datos observacionales.</a:t>
             </a:r>
           </a:p>
           <a:p>
@@ -9639,13 +9580,97 @@
               <a:t>▸ </a:t>
             </a:r>
             <a:r>
+              <a:rPr sz="1800" b="0">
+                <a:solidFill>
+                  <a:srgbClr val="000000"/>
+                </a:solidFill>
+                <a:latin typeface="Fira Sans"/>
+              </a:rPr>
+              <a:t>El tipo de la variable, no su dtype, determina qué resúmenes tienen sentido.</a:t>
+            </a:r>
+          </a:p>
+          <a:p>
+            <a:pPr>
+              <a:lnSpc>
+                <a:spcPct val="112000"/>
+              </a:lnSpc>
+              <a:spcAft>
+                <a:spcPts val="900"/>
+              </a:spcAft>
+            </a:pPr>
+            <a:r>
               <a:rPr sz="1800" b="1">
                 <a:solidFill>
+                  <a:srgbClr val="E0A437"/>
+                </a:solidFill>
+                <a:latin typeface="Fira Sans"/>
+              </a:rPr>
+              <a:t>▸ </a:t>
+            </a:r>
+            <a:r>
+              <a:rPr sz="1800" b="0">
+                <a:solidFill>
+                  <a:srgbClr val="000000"/>
+                </a:solidFill>
+                <a:latin typeface="Fira Sans"/>
+              </a:rPr>
+              <a:t>Con distribuciones asimétricas, la mediana y los percentiles describen mejor lo típico que la media.</a:t>
+            </a:r>
+          </a:p>
+          <a:p>
+            <a:pPr>
+              <a:lnSpc>
+                <a:spcPct val="112000"/>
+              </a:lnSpc>
+              <a:spcAft>
+                <a:spcPts val="900"/>
+              </a:spcAft>
+            </a:pPr>
+            <a:r>
+              <a:rPr sz="1800" b="1">
+                <a:solidFill>
+                  <a:srgbClr val="E0A437"/>
+                </a:solidFill>
+                <a:latin typeface="Fira Sans"/>
+              </a:rPr>
+              <a:t>▸ </a:t>
+            </a:r>
+            <a:r>
+              <a:rPr sz="1800" b="0">
+                <a:solidFill>
+                  <a:srgbClr val="000000"/>
+                </a:solidFill>
+                <a:latin typeface="Fira Sans"/>
+              </a:rPr>
+              <a:t>En una encuesta, primero se define la población y luego se pondera por los factores: la cifra ingenua del 23% sin viajes era en realidad un 15%.</a:t>
+            </a:r>
+          </a:p>
+          <a:p>
+            <a:pPr>
+              <a:lnSpc>
+                <a:spcPct val="112000"/>
+              </a:lnSpc>
+              <a:spcAft>
+                <a:spcPts val="900"/>
+              </a:spcAft>
+            </a:pPr>
+            <a:r>
+              <a:rPr sz="1800" b="1">
+                <a:solidFill>
+                  <a:srgbClr val="E0A437"/>
+                </a:solidFill>
+                <a:latin typeface="Fira Sans"/>
+              </a:rPr>
+              <a:t>▸ </a:t>
+            </a:r>
+            <a:r>
+              <a:rPr sz="1800" b="1">
+                <a:solidFill>
                   <a:srgbClr val="1D3557"/>
                 </a:solidFill>
                 <a:latin typeface="Fira Sans"/>
               </a:rPr>
-              <a:t>Lo que avancen en este bloque ya es parte de la tarea.</a:t>
+              <a:t>El concepto de la clase: el EDA, examinar los datos antes de modelarlos, preguntando ante cada cifra de quién habla.</a:t>
             </a:r>
           </a:p>
         </p:txBody>
@@ -9741,7 +9766,7 @@
                 </a:solidFill>
                 <a:latin typeface="Fira Sans"/>
               </a:rPr>
-              <a:t>Referencias</a:t>
+              <a:t>Segundo bloque: comienza la Tarea 1</a:t>
             </a:r>
           </a:p>
         </p:txBody>
@@ -9792,6 +9817,293 @@
                 </a:solidFill>
                 <a:latin typeface="Fira Sans"/>
               </a:rPr>
+              <a:t>El retrato de tu comuna: cada pareja adopta una comuna del Gran Santiago.</a:t>
+            </a:r>
+          </a:p>
+          <a:p>
+            <a:pPr>
+              <a:lnSpc>
+                <a:spcPct val="112000"/>
+              </a:lnSpc>
+              <a:spcAft>
+                <a:spcPts val="500"/>
+              </a:spcAft>
+            </a:pPr>
+            <a:r>
+              <a:rPr sz="1400" b="0">
+                <a:solidFill>
+                  <a:srgbClr val="333333"/>
+                </a:solidFill>
+                <a:latin typeface="Fira Sans"/>
+              </a:rPr>
+              <a:t>     ◦  </a:t>
+            </a:r>
+            <a:r>
+              <a:rPr sz="1400" b="0">
+                <a:solidFill>
+                  <a:srgbClr val="333333"/>
+                </a:solidFill>
+                <a:latin typeface="Fira Sans"/>
+              </a:rPr>
+              <a:t>Hoy: elegir la comuna y construir su retrato numérico.</a:t>
+            </a:r>
+          </a:p>
+          <a:p>
+            <a:pPr>
+              <a:lnSpc>
+                <a:spcPct val="112000"/>
+              </a:lnSpc>
+              <a:spcAft>
+                <a:spcPts val="500"/>
+              </a:spcAft>
+            </a:pPr>
+            <a:r>
+              <a:rPr sz="1400" b="0">
+                <a:solidFill>
+                  <a:srgbClr val="333333"/>
+                </a:solidFill>
+                <a:latin typeface="Fira Sans"/>
+              </a:rPr>
+              <a:t>     ◦  </a:t>
+            </a:r>
+            <a:r>
+              <a:rPr sz="1400" b="0">
+                <a:solidFill>
+                  <a:srgbClr val="333333"/>
+                </a:solidFill>
+                <a:latin typeface="Fira Sans"/>
+              </a:rPr>
+              <a:t>Próxima clase: el retrato gráfico, con métodos de visualización.</a:t>
+            </a:r>
+          </a:p>
+          <a:p>
+            <a:pPr>
+              <a:lnSpc>
+                <a:spcPct val="112000"/>
+              </a:lnSpc>
+              <a:spcAft>
+                <a:spcPts val="500"/>
+              </a:spcAft>
+            </a:pPr>
+            <a:r>
+              <a:rPr sz="1400" b="0">
+                <a:solidFill>
+                  <a:srgbClr val="333333"/>
+                </a:solidFill>
+                <a:latin typeface="Fira Sans"/>
+              </a:rPr>
+              <a:t>     ◦  </a:t>
+            </a:r>
+            <a:r>
+              <a:rPr sz="1400" b="0">
+                <a:solidFill>
+                  <a:srgbClr val="333333"/>
+                </a:solidFill>
+                <a:latin typeface="Fira Sans"/>
+              </a:rPr>
+              <a:t>Entrega del retrato completo: jueves 10 de septiembre, por Aula.</a:t>
+            </a:r>
+          </a:p>
+          <a:p>
+            <a:pPr>
+              <a:lnSpc>
+                <a:spcPct val="112000"/>
+              </a:lnSpc>
+              <a:spcAft>
+                <a:spcPts val="900"/>
+              </a:spcAft>
+            </a:pPr>
+            <a:r>
+              <a:rPr sz="1800" b="1">
+                <a:solidFill>
+                  <a:srgbClr val="E0A437"/>
+                </a:solidFill>
+                <a:latin typeface="Fira Sans"/>
+              </a:rPr>
+              <a:t>▸ </a:t>
+            </a:r>
+            <a:r>
+              <a:rPr sz="1800" b="0">
+                <a:solidFill>
+                  <a:srgbClr val="000000"/>
+                </a:solidFill>
+                <a:latin typeface="Fira Sans"/>
+              </a:rPr>
+              <a:t>El enunciado está en evaluaciones/tareas/ y la guía de hoy en actividades/.</a:t>
+            </a:r>
+          </a:p>
+          <a:p>
+            <a:pPr>
+              <a:lnSpc>
+                <a:spcPct val="112000"/>
+              </a:lnSpc>
+              <a:spcAft>
+                <a:spcPts val="900"/>
+              </a:spcAft>
+            </a:pPr>
+            <a:r>
+              <a:rPr sz="1800" b="1">
+                <a:solidFill>
+                  <a:srgbClr val="E0A437"/>
+                </a:solidFill>
+                <a:latin typeface="Fira Sans"/>
+              </a:rPr>
+              <a:t>▸ </a:t>
+            </a:r>
+            <a:r>
+              <a:rPr sz="1800" b="1">
+                <a:solidFill>
+                  <a:srgbClr val="1D3557"/>
+                </a:solidFill>
+                <a:latin typeface="Fira Sans"/>
+              </a:rPr>
+              <a:t>Lo que avancen en este bloque ya es parte de la tarea.</a:t>
+            </a:r>
+          </a:p>
+        </p:txBody>
+      </p:sp>
+    </p:spTree>
+  </p:cSld>
+  <p:clrMapOvr>
+    <a:masterClrMapping/>
+  </p:clrMapOvr>
+</p:sld>
+</file>
+
+<file path=ppt/slides/slide38.xml><?xml version="1.0" encoding="utf-8"?>
+<p:sld xmlns:a="http://schemas.openxmlformats.org/drawingml/2006/main" xmlns:p="http://schemas.openxmlformats.org/presentationml/2006/main" xmlns:r="http://schemas.openxmlformats.org/officeDocument/2006/relationships">
+  <p:cSld>
+    <p:spTree>
+      <p:nvGrpSpPr>
+        <p:cNvPr id="1" name=""/>
+        <p:cNvGrpSpPr/>
+        <p:nvPr/>
+      </p:nvGrpSpPr>
+      <p:grpSpPr/>
+      <p:sp>
+        <p:nvSpPr>
+          <p:cNvPr id="2" name="Rectangle 1"/>
+          <p:cNvSpPr/>
+          <p:nvPr/>
+        </p:nvSpPr>
+        <p:spPr>
+          <a:xfrm>
+            <a:off x="0" y="0"/>
+            <a:ext cx="9144000" cy="5138928"/>
+          </a:xfrm>
+          <a:prstGeom prst="rect">
+            <a:avLst/>
+          </a:prstGeom>
+          <a:solidFill>
+            <a:srgbClr val="FAFBFC"/>
+          </a:solidFill>
+          <a:ln>
+            <a:noFill/>
+          </a:ln>
+          <a:effectLst/>
+        </p:spPr>
+        <p:style>
+          <a:lnRef idx="1">
+            <a:schemeClr val="accent1"/>
+          </a:lnRef>
+          <a:fillRef idx="3">
+            <a:schemeClr val="accent1"/>
+          </a:fillRef>
+          <a:effectRef idx="2">
+            <a:schemeClr val="accent1"/>
+          </a:effectRef>
+          <a:fontRef idx="minor">
+            <a:schemeClr val="lt1"/>
+          </a:fontRef>
+        </p:style>
+        <p:txBody>
+          <a:bodyPr rtlCol="0" anchor="ctr"/>
+          <a:lstStyle/>
+          <a:p>
+            <a:pPr algn="ctr"/>
+          </a:p>
+        </p:txBody>
+      </p:sp>
+      <p:sp>
+        <p:nvSpPr>
+          <p:cNvPr id="3" name="TextBox 2"/>
+          <p:cNvSpPr txBox="1"/>
+          <p:nvPr/>
+        </p:nvSpPr>
+        <p:spPr>
+          <a:xfrm>
+            <a:off x="402336" y="301752"/>
+            <a:ext cx="8348472" cy="795528"/>
+          </a:xfrm>
+          <a:prstGeom prst="rect">
+            <a:avLst/>
+          </a:prstGeom>
+          <a:noFill/>
+        </p:spPr>
+        <p:txBody>
+          <a:bodyPr wrap="square">
+            <a:spAutoFit/>
+          </a:bodyPr>
+          <a:lstStyle/>
+          <a:p>
+            <a:r>
+              <a:rPr sz="2800" b="1">
+                <a:solidFill>
+                  <a:srgbClr val="0F0F0F"/>
+                </a:solidFill>
+                <a:latin typeface="Fira Sans"/>
+              </a:rPr>
+              <a:t>Referencias</a:t>
+            </a:r>
+          </a:p>
+        </p:txBody>
+      </p:sp>
+      <p:sp>
+        <p:nvSpPr>
+          <p:cNvPr id="4" name="TextBox 3"/>
+          <p:cNvSpPr txBox="1"/>
+          <p:nvPr/>
+        </p:nvSpPr>
+        <p:spPr>
+          <a:xfrm>
+            <a:off x="704088" y="1353312"/>
+            <a:ext cx="7744968" cy="3300984"/>
+          </a:xfrm>
+          <a:prstGeom prst="rect">
+            <a:avLst/>
+          </a:prstGeom>
+          <a:noFill/>
+        </p:spPr>
+        <p:txBody>
+          <a:bodyPr wrap="square">
+            <a:spAutoFit/>
+          </a:bodyPr>
+          <a:lstStyle/>
+          <a:p>
+            <a:pPr>
+              <a:lnSpc>
+                <a:spcPct val="112000"/>
+              </a:lnSpc>
+              <a:spcAft>
+                <a:spcPts val="900"/>
+              </a:spcAft>
+            </a:pPr>
+            <a:r>
+              <a:rPr sz="1800" b="1">
+                <a:solidFill>
+                  <a:srgbClr val="E0A437"/>
+                </a:solidFill>
+                <a:latin typeface="Fira Sans"/>
+              </a:rPr>
+              <a:t>▸ </a:t>
+            </a:r>
+            <a:r>
+              <a:rPr sz="1800" b="0">
+                <a:solidFill>
+                  <a:srgbClr val="000000"/>
+                </a:solidFill>
+                <a:latin typeface="Fira Sans"/>
+              </a:rPr>
               <a:t>James, G., Witten, D., Hastie, T. y Tibshirani, R. (2023). An Introduction to Statistical Learning with Applications in Python. Springer. Capítulo 2. Descarga gratuita en statlearning.com.</a:t>
             </a:r>
           </a:p>
@@ -9849,6 +10161,34 @@
                 <a:latin typeface="Fira Sans"/>
               </a:rPr>
               <a:t>Tukey, J. W. (1977). Exploratory Data Analysis. Addison-Wesley.</a:t>
+            </a:r>
+          </a:p>
+          <a:p>
+            <a:pPr>
+              <a:lnSpc>
+                <a:spcPct val="112000"/>
+              </a:lnSpc>
+              <a:spcAft>
+                <a:spcPts val="900"/>
+              </a:spcAft>
+            </a:pPr>
+            <a:r>
+              <a:rPr sz="1800" b="1">
+                <a:solidFill>
+                  <a:srgbClr val="E0A437"/>
+                </a:solidFill>
+                <a:latin typeface="Fira Sans"/>
+              </a:rPr>
+              <a:t>▸ </a:t>
+            </a:r>
+            <a:r>
+              <a:rPr sz="1800" b="0">
+                <a:solidFill>
+                  <a:srgbClr val="000000"/>
+                </a:solidFill>
+                <a:latin typeface="Fira Sans"/>
+              </a:rPr>
+              <a:t>Horvitz, D. G. y Thompson, D. J. (1952). A Generalization of Sampling Without Replacement from a Finite Universe. JASA 47(260).</a:t>
             </a:r>
           </a:p>
           <a:p>

</xml_diff>

<commit_message>
Slides clase 02: quitar ingreso vs transporte publico (pasa a la tarea)
Co-Authored-By: Claude Fable 5 <noreply@anthropic.com>
</commit_message>
<xml_diff>
--- a/presentaciones/clase02_pandas_eda.pptx
+++ b/presentaciones/clase02_pandas_eda.pptx
@@ -42,7 +42,6 @@
     <p:sldId id="290" r:id="rId41"/>
     <p:sldId id="291" r:id="rId42"/>
     <p:sldId id="292" r:id="rId43"/>
-    <p:sldId id="293" r:id="rId44"/>
   </p:sldIdLst>
   <p:sldSz cx="9144000" cy="5138928" type="screen4x3"/>
   <p:notesSz cx="6858000" cy="9144000"/>
@@ -8888,177 +8887,14 @@
                 </a:solidFill>
                 <a:latin typeface="Fira Sans"/>
               </a:rPr>
-              <a:t>Ingreso y uso de transporte público</a:t>
-            </a:r>
-          </a:p>
-        </p:txBody>
-      </p:sp>
-      <p:sp>
-        <p:nvSpPr>
-          <p:cNvPr id="4" name="TextBox 3"/>
-          <p:cNvSpPr txBox="1"/>
-          <p:nvPr/>
-        </p:nvSpPr>
-        <p:spPr>
-          <a:xfrm>
-            <a:off x="502920" y="1252728"/>
-            <a:ext cx="4023360" cy="3200400"/>
-          </a:xfrm>
-          <a:prstGeom prst="rect">
-            <a:avLst/>
-          </a:prstGeom>
-          <a:noFill/>
-        </p:spPr>
-        <p:txBody>
-          <a:bodyPr wrap="square">
-            <a:spAutoFit/>
-          </a:bodyPr>
-          <a:lstStyle/>
-          <a:p>
-            <a:pPr>
-              <a:lnSpc>
-                <a:spcPct val="112000"/>
-              </a:lnSpc>
-              <a:spcAft>
-                <a:spcPts val="900"/>
-              </a:spcAft>
-            </a:pPr>
-            <a:r>
-              <a:rPr sz="1500" b="1">
-                <a:solidFill>
-                  <a:srgbClr val="E0A437"/>
-                </a:solidFill>
-                <a:latin typeface="Fira Sans"/>
-              </a:rPr>
-              <a:t>▸ </a:t>
-            </a:r>
-            <a:r>
-              <a:rPr sz="1500" b="0">
-                <a:solidFill>
-                  <a:srgbClr val="000000"/>
-                </a:solidFill>
-                <a:latin typeface="Fira Sans"/>
-              </a:rPr>
-              <a:t>Cada punto es una comuna: ingreso medio contra proporción de viajes en transporte público.</a:t>
-            </a:r>
-          </a:p>
-          <a:p>
-            <a:pPr>
-              <a:lnSpc>
-                <a:spcPct val="112000"/>
-              </a:lnSpc>
-              <a:spcAft>
-                <a:spcPts val="500"/>
-              </a:spcAft>
-            </a:pPr>
-            <a:r>
-              <a:rPr sz="1300" b="0">
-                <a:solidFill>
-                  <a:srgbClr val="333333"/>
-                </a:solidFill>
-                <a:latin typeface="Fira Sans"/>
-              </a:rPr>
-              <a:t>     ◦  </a:t>
-            </a:r>
-            <a:r>
-              <a:rPr sz="1300" b="0">
-                <a:solidFill>
-                  <a:srgbClr val="333333"/>
-                </a:solidFill>
-                <a:latin typeface="Fira Sans"/>
-              </a:rPr>
-              <a:t>Periferia (Buin, Melipilla): poco transporte público; la red no llega.</a:t>
-            </a:r>
-          </a:p>
-          <a:p>
-            <a:pPr>
-              <a:lnSpc>
-                <a:spcPct val="112000"/>
-              </a:lnSpc>
-              <a:spcAft>
-                <a:spcPts val="500"/>
-              </a:spcAft>
-            </a:pPr>
-            <a:r>
-              <a:rPr sz="1300" b="0">
-                <a:solidFill>
-                  <a:srgbClr val="333333"/>
-                </a:solidFill>
-                <a:latin typeface="Fira Sans"/>
-              </a:rPr>
-              <a:t>     ◦  </a:t>
-            </a:r>
-            <a:r>
-              <a:rPr sz="1300" b="0">
-                <a:solidFill>
-                  <a:srgbClr val="333333"/>
-                </a:solidFill>
-                <a:latin typeface="Fira Sans"/>
-              </a:rPr>
-              <a:t>Ingresos altos (Vitacura, Lo Barnechea): conectadas, con poco uso.</a:t>
-            </a:r>
-          </a:p>
-          <a:p>
-            <a:pPr>
-              <a:lnSpc>
-                <a:spcPct val="112000"/>
-              </a:lnSpc>
-              <a:spcAft>
-                <a:spcPts val="500"/>
-              </a:spcAft>
-            </a:pPr>
-            <a:r>
-              <a:rPr sz="1300" b="0">
-                <a:solidFill>
-                  <a:srgbClr val="333333"/>
-                </a:solidFill>
-                <a:latin typeface="Fira Sans"/>
-              </a:rPr>
-              <a:t>     ◦  </a:t>
-            </a:r>
-            <a:r>
-              <a:rPr sz="1300" b="0">
-                <a:solidFill>
-                  <a:srgbClr val="333333"/>
-                </a:solidFill>
-                <a:latin typeface="Fira Sans"/>
-              </a:rPr>
-              <a:t>Correlación de Pearson: -0,17. La asociación lineal es débil.</a:t>
-            </a:r>
-          </a:p>
-          <a:p>
-            <a:pPr>
-              <a:lnSpc>
-                <a:spcPct val="112000"/>
-              </a:lnSpc>
-              <a:spcAft>
-                <a:spcPts val="900"/>
-              </a:spcAft>
-            </a:pPr>
-            <a:r>
-              <a:rPr sz="1500" b="1">
-                <a:solidFill>
-                  <a:srgbClr val="E0A437"/>
-                </a:solidFill>
-                <a:latin typeface="Fira Sans"/>
-              </a:rPr>
-              <a:t>▸ </a:t>
-            </a:r>
-            <a:r>
-              <a:rPr sz="1500" b="1">
-                <a:solidFill>
-                  <a:srgbClr val="1D3557"/>
-                </a:solidFill>
-                <a:latin typeface="Fira Sans"/>
-              </a:rPr>
-              <a:t>Como vimos en el marco conceptual: el coeficiente no reemplaza al gráfico, y la asociación no autoriza verbos causales.</a:t>
+              <a:t>Los propósitos de viaje según el día de la semana</a:t>
             </a:r>
           </a:p>
         </p:txBody>
       </p:sp>
       <p:pic>
         <p:nvPicPr>
-          <p:cNvPr id="5" name="Picture 4" descr="09_ingreso_vs_tp.png"/>
+          <p:cNvPr id="4" name="Picture 3" descr="10_heatmap_rutinas.png"/>
           <p:cNvPicPr>
             <a:picLocks noChangeAspect="1"/>
           </p:cNvPicPr>
@@ -9072,14 +8908,48 @@
         </p:blipFill>
         <p:spPr>
           <a:xfrm>
-            <a:off x="4892040" y="1371600"/>
-            <a:ext cx="3840480" cy="2526979"/>
+            <a:off x="1649319" y="1143000"/>
+            <a:ext cx="5845360" cy="3154680"/>
           </a:xfrm>
           <a:prstGeom prst="rect">
             <a:avLst/>
           </a:prstGeom>
         </p:spPr>
       </p:pic>
+      <p:sp>
+        <p:nvSpPr>
+          <p:cNvPr id="5" name="TextBox 4"/>
+          <p:cNvSpPr txBox="1"/>
+          <p:nvPr/>
+        </p:nvSpPr>
+        <p:spPr>
+          <a:xfrm>
+            <a:off x="704088" y="4434840"/>
+            <a:ext cx="7744968" cy="457200"/>
+          </a:xfrm>
+          <a:prstGeom prst="rect">
+            <a:avLst/>
+          </a:prstGeom>
+          <a:noFill/>
+        </p:spPr>
+        <p:txBody>
+          <a:bodyPr wrap="square">
+            <a:spAutoFit/>
+          </a:bodyPr>
+          <a:lstStyle/>
+          <a:p>
+            <a:r>
+              <a:rPr sz="1300" b="0">
+                <a:solidFill>
+                  <a:srgbClr val="333333"/>
+                </a:solidFill>
+                <a:latin typeface="Fira Sans"/>
+              </a:rPr>
+              <a:t>El heatmap muestra 14 propósitos por 7 días en una sola figura: útil para tablas completas.</a:t>
+            </a:r>
+          </a:p>
+        </p:txBody>
+      </p:sp>
     </p:spTree>
   </p:cSld>
   <p:clrMapOvr>
@@ -9171,14 +9041,14 @@
                 </a:solidFill>
                 <a:latin typeface="Fira Sans"/>
               </a:rPr>
-              <a:t>Los propósitos de viaje según el día de la semana</a:t>
+              <a:t>Cuando los datos crecen</a:t>
             </a:r>
           </a:p>
         </p:txBody>
       </p:sp>
       <p:pic>
         <p:nvPicPr>
-          <p:cNvPr id="4" name="Picture 3" descr="10_heatmap_rutinas.png"/>
+          <p:cNvPr id="4" name="Picture 3" descr="14_escala_datos.png"/>
           <p:cNvPicPr>
             <a:picLocks noChangeAspect="1"/>
           </p:cNvPicPr>
@@ -9192,8 +9062,8 @@
         </p:blipFill>
         <p:spPr>
           <a:xfrm>
-            <a:off x="1649319" y="1143000"/>
-            <a:ext cx="5845360" cy="3154680"/>
+            <a:off x="1417319" y="1143000"/>
+            <a:ext cx="6309360" cy="2324913"/>
           </a:xfrm>
           <a:prstGeom prst="rect">
             <a:avLst/>
@@ -9229,7 +9099,7 @@
                 </a:solidFill>
                 <a:latin typeface="Fira Sans"/>
               </a:rPr>
-              <a:t>El heatmap muestra 14 propósitos por 7 días en una sola figura: útil para tablas completas.</a:t>
+              <a:t>PySpark se usa con SQL o con sus propios DataFrames; Dask reparte operaciones estilo Pandas; Polars y DuckDB rinden en una sola máquina.</a:t>
             </a:r>
           </a:p>
         </p:txBody>
@@ -9325,45 +9195,21 @@
                 </a:solidFill>
                 <a:latin typeface="Fira Sans"/>
               </a:rPr>
-              <a:t>Cuando los datos crecen</a:t>
-            </a:r>
-          </a:p>
-        </p:txBody>
-      </p:sp>
-      <p:pic>
-        <p:nvPicPr>
-          <p:cNvPr id="4" name="Picture 3" descr="14_escala_datos.png"/>
-          <p:cNvPicPr>
-            <a:picLocks noChangeAspect="1"/>
-          </p:cNvPicPr>
-          <p:nvPr/>
-        </p:nvPicPr>
-        <p:blipFill>
-          <a:blip r:embed="rId2"/>
-          <a:stretch>
-            <a:fillRect/>
-          </a:stretch>
-        </p:blipFill>
-        <p:spPr>
-          <a:xfrm>
-            <a:off x="1417319" y="1143000"/>
-            <a:ext cx="6309360" cy="2324913"/>
-          </a:xfrm>
-          <a:prstGeom prst="rect">
-            <a:avLst/>
-          </a:prstGeom>
-        </p:spPr>
-      </p:pic>
-      <p:sp>
-        <p:nvSpPr>
-          <p:cNvPr id="5" name="TextBox 4"/>
+              <a:t>Síntesis</a:t>
+            </a:r>
+          </a:p>
+        </p:txBody>
+      </p:sp>
+      <p:sp>
+        <p:nvSpPr>
+          <p:cNvPr id="4" name="TextBox 3"/>
           <p:cNvSpPr txBox="1"/>
           <p:nvPr/>
         </p:nvSpPr>
         <p:spPr>
           <a:xfrm>
-            <a:off x="704088" y="4434840"/>
-            <a:ext cx="7744968" cy="457200"/>
+            <a:off x="704088" y="1353312"/>
+            <a:ext cx="7744968" cy="3300984"/>
           </a:xfrm>
           <a:prstGeom prst="rect">
             <a:avLst/>
@@ -9376,14 +9222,171 @@
           </a:bodyPr>
           <a:lstStyle/>
           <a:p>
-            <a:r>
-              <a:rPr sz="1300" b="0">
-                <a:solidFill>
-                  <a:srgbClr val="333333"/>
-                </a:solidFill>
-                <a:latin typeface="Fira Sans"/>
-              </a:rPr>
-              <a:t>PySpark se usa con SQL o con sus propios DataFrames; Dask reparte operaciones estilo Pandas; Polars y DuckDB rinden en una sola máquina.</a:t>
+            <a:pPr>
+              <a:lnSpc>
+                <a:spcPct val="112000"/>
+              </a:lnSpc>
+              <a:spcAft>
+                <a:spcPts val="900"/>
+              </a:spcAft>
+            </a:pPr>
+            <a:r>
+              <a:rPr sz="1800" b="1">
+                <a:solidFill>
+                  <a:srgbClr val="E0A437"/>
+                </a:solidFill>
+                <a:latin typeface="Fira Sans"/>
+              </a:rPr>
+              <a:t>▸ </a:t>
+            </a:r>
+            <a:r>
+              <a:rPr sz="1800" b="0">
+                <a:solidFill>
+                  <a:srgbClr val="000000"/>
+                </a:solidFill>
+                <a:latin typeface="Fira Sans"/>
+              </a:rPr>
+              <a:t>Un modelo es una simplificación con decisiones incorporadas; estimarlo puede buscar inferencia o predicción.</a:t>
+            </a:r>
+          </a:p>
+          <a:p>
+            <a:pPr>
+              <a:lnSpc>
+                <a:spcPct val="112000"/>
+              </a:lnSpc>
+              <a:spcAft>
+                <a:spcPts val="900"/>
+              </a:spcAft>
+            </a:pPr>
+            <a:r>
+              <a:rPr sz="1800" b="1">
+                <a:solidFill>
+                  <a:srgbClr val="E0A437"/>
+                </a:solidFill>
+                <a:latin typeface="Fira Sans"/>
+              </a:rPr>
+              <a:t>▸ </a:t>
+            </a:r>
+            <a:r>
+              <a:rPr sz="1800" b="0">
+                <a:solidFill>
+                  <a:srgbClr val="000000"/>
+                </a:solidFill>
+                <a:latin typeface="Fira Sans"/>
+              </a:rPr>
+              <a:t>Las asociaciones se reportan como asociaciones: la causalidad exige más que datos observacionales.</a:t>
+            </a:r>
+          </a:p>
+          <a:p>
+            <a:pPr>
+              <a:lnSpc>
+                <a:spcPct val="112000"/>
+              </a:lnSpc>
+              <a:spcAft>
+                <a:spcPts val="900"/>
+              </a:spcAft>
+            </a:pPr>
+            <a:r>
+              <a:rPr sz="1800" b="1">
+                <a:solidFill>
+                  <a:srgbClr val="E0A437"/>
+                </a:solidFill>
+                <a:latin typeface="Fira Sans"/>
+              </a:rPr>
+              <a:t>▸ </a:t>
+            </a:r>
+            <a:r>
+              <a:rPr sz="1800" b="0">
+                <a:solidFill>
+                  <a:srgbClr val="000000"/>
+                </a:solidFill>
+                <a:latin typeface="Fira Sans"/>
+              </a:rPr>
+              <a:t>El tipo de la variable, no su dtype, determina qué resúmenes tienen sentido.</a:t>
+            </a:r>
+          </a:p>
+          <a:p>
+            <a:pPr>
+              <a:lnSpc>
+                <a:spcPct val="112000"/>
+              </a:lnSpc>
+              <a:spcAft>
+                <a:spcPts val="900"/>
+              </a:spcAft>
+            </a:pPr>
+            <a:r>
+              <a:rPr sz="1800" b="1">
+                <a:solidFill>
+                  <a:srgbClr val="E0A437"/>
+                </a:solidFill>
+                <a:latin typeface="Fira Sans"/>
+              </a:rPr>
+              <a:t>▸ </a:t>
+            </a:r>
+            <a:r>
+              <a:rPr sz="1800" b="0">
+                <a:solidFill>
+                  <a:srgbClr val="000000"/>
+                </a:solidFill>
+                <a:latin typeface="Fira Sans"/>
+              </a:rPr>
+              <a:t>Con distribuciones asimétricas, la mediana y los percentiles describen mejor lo típico que la media.</a:t>
+            </a:r>
+          </a:p>
+          <a:p>
+            <a:pPr>
+              <a:lnSpc>
+                <a:spcPct val="112000"/>
+              </a:lnSpc>
+              <a:spcAft>
+                <a:spcPts val="900"/>
+              </a:spcAft>
+            </a:pPr>
+            <a:r>
+              <a:rPr sz="1800" b="1">
+                <a:solidFill>
+                  <a:srgbClr val="E0A437"/>
+                </a:solidFill>
+                <a:latin typeface="Fira Sans"/>
+              </a:rPr>
+              <a:t>▸ </a:t>
+            </a:r>
+            <a:r>
+              <a:rPr sz="1800" b="0">
+                <a:solidFill>
+                  <a:srgbClr val="000000"/>
+                </a:solidFill>
+                <a:latin typeface="Fira Sans"/>
+              </a:rPr>
+              <a:t>En una encuesta, primero se define la población y luego se pondera por los factores: la cifra ingenua del 23% sin viajes era en realidad un 15%.</a:t>
+            </a:r>
+          </a:p>
+          <a:p>
+            <a:pPr>
+              <a:lnSpc>
+                <a:spcPct val="112000"/>
+              </a:lnSpc>
+              <a:spcAft>
+                <a:spcPts val="900"/>
+              </a:spcAft>
+            </a:pPr>
+            <a:r>
+              <a:rPr sz="1800" b="1">
+                <a:solidFill>
+                  <a:srgbClr val="E0A437"/>
+                </a:solidFill>
+                <a:latin typeface="Fira Sans"/>
+              </a:rPr>
+              <a:t>▸ </a:t>
+            </a:r>
+            <a:r>
+              <a:rPr sz="1800" b="1">
+                <a:solidFill>
+                  <a:srgbClr val="1D3557"/>
+                </a:solidFill>
+                <a:latin typeface="Fira Sans"/>
+              </a:rPr>
+              <a:t>El concepto de la clase: el EDA, examinar los datos antes de modelarlos, preguntando ante cada cifra de quién habla.</a:t>
             </a:r>
           </a:p>
         </p:txBody>
@@ -9479,7 +9482,7 @@
                 </a:solidFill>
                 <a:latin typeface="Fira Sans"/>
               </a:rPr>
-              <a:t>Síntesis</a:t>
+              <a:t>Segundo bloque: comienza la Tarea 1</a:t>
             </a:r>
           </a:p>
         </p:txBody>
@@ -9530,7 +9533,91 @@
                 </a:solidFill>
                 <a:latin typeface="Fira Sans"/>
               </a:rPr>
-              <a:t>Un modelo es una simplificación con decisiones incorporadas; estimarlo puede buscar inferencia o predicción.</a:t>
+              <a:t>El retrato de tu comuna: cada pareja adopta una comuna del Gran Santiago.</a:t>
+            </a:r>
+          </a:p>
+          <a:p>
+            <a:pPr>
+              <a:lnSpc>
+                <a:spcPct val="112000"/>
+              </a:lnSpc>
+              <a:spcAft>
+                <a:spcPts val="500"/>
+              </a:spcAft>
+            </a:pPr>
+            <a:r>
+              <a:rPr sz="1400" b="0">
+                <a:solidFill>
+                  <a:srgbClr val="333333"/>
+                </a:solidFill>
+                <a:latin typeface="Fira Sans"/>
+              </a:rPr>
+              <a:t>     ◦  </a:t>
+            </a:r>
+            <a:r>
+              <a:rPr sz="1400" b="0">
+                <a:solidFill>
+                  <a:srgbClr val="333333"/>
+                </a:solidFill>
+                <a:latin typeface="Fira Sans"/>
+              </a:rPr>
+              <a:t>Hoy: elegir la comuna y construir su retrato numérico.</a:t>
+            </a:r>
+          </a:p>
+          <a:p>
+            <a:pPr>
+              <a:lnSpc>
+                <a:spcPct val="112000"/>
+              </a:lnSpc>
+              <a:spcAft>
+                <a:spcPts val="500"/>
+              </a:spcAft>
+            </a:pPr>
+            <a:r>
+              <a:rPr sz="1400" b="0">
+                <a:solidFill>
+                  <a:srgbClr val="333333"/>
+                </a:solidFill>
+                <a:latin typeface="Fira Sans"/>
+              </a:rPr>
+              <a:t>     ◦  </a:t>
+            </a:r>
+            <a:r>
+              <a:rPr sz="1400" b="0">
+                <a:solidFill>
+                  <a:srgbClr val="333333"/>
+                </a:solidFill>
+                <a:latin typeface="Fira Sans"/>
+              </a:rPr>
+              <a:t>Próxima clase: el retrato gráfico, con métodos de visualización.</a:t>
+            </a:r>
+          </a:p>
+          <a:p>
+            <a:pPr>
+              <a:lnSpc>
+                <a:spcPct val="112000"/>
+              </a:lnSpc>
+              <a:spcAft>
+                <a:spcPts val="500"/>
+              </a:spcAft>
+            </a:pPr>
+            <a:r>
+              <a:rPr sz="1400" b="0">
+                <a:solidFill>
+                  <a:srgbClr val="333333"/>
+                </a:solidFill>
+                <a:latin typeface="Fira Sans"/>
+              </a:rPr>
+              <a:t>     ◦  </a:t>
+            </a:r>
+            <a:r>
+              <a:rPr sz="1400" b="0">
+                <a:solidFill>
+                  <a:srgbClr val="333333"/>
+                </a:solidFill>
+                <a:latin typeface="Fira Sans"/>
+              </a:rPr>
+              <a:t>Entrega del retrato completo: jueves 10 de septiembre, por Aula.</a:t>
             </a:r>
           </a:p>
           <a:p>
@@ -9558,7 +9645,7 @@
                 </a:solidFill>
                 <a:latin typeface="Fira Sans"/>
               </a:rPr>
-              <a:t>Las asociaciones se reportan como asociaciones: la causalidad exige más que datos observacionales.</a:t>
+              <a:t>El enunciado está en evaluaciones/tareas/ y la guía de hoy en actividades/.</a:t>
             </a:r>
           </a:p>
           <a:p>
@@ -9580,97 +9667,13 @@
               <a:t>▸ </a:t>
             </a:r>
             <a:r>
-              <a:rPr sz="1800" b="0">
-                <a:solidFill>
-                  <a:srgbClr val="000000"/>
-                </a:solidFill>
-                <a:latin typeface="Fira Sans"/>
-              </a:rPr>
-              <a:t>El tipo de la variable, no su dtype, determina qué resúmenes tienen sentido.</a:t>
-            </a:r>
-          </a:p>
-          <a:p>
-            <a:pPr>
-              <a:lnSpc>
-                <a:spcPct val="112000"/>
-              </a:lnSpc>
-              <a:spcAft>
-                <a:spcPts val="900"/>
-              </a:spcAft>
-            </a:pPr>
-            <a:r>
               <a:rPr sz="1800" b="1">
                 <a:solidFill>
-                  <a:srgbClr val="E0A437"/>
-                </a:solidFill>
-                <a:latin typeface="Fira Sans"/>
-              </a:rPr>
-              <a:t>▸ </a:t>
-            </a:r>
-            <a:r>
-              <a:rPr sz="1800" b="0">
-                <a:solidFill>
-                  <a:srgbClr val="000000"/>
-                </a:solidFill>
-                <a:latin typeface="Fira Sans"/>
-              </a:rPr>
-              <a:t>Con distribuciones asimétricas, la mediana y los percentiles describen mejor lo típico que la media.</a:t>
-            </a:r>
-          </a:p>
-          <a:p>
-            <a:pPr>
-              <a:lnSpc>
-                <a:spcPct val="112000"/>
-              </a:lnSpc>
-              <a:spcAft>
-                <a:spcPts val="900"/>
-              </a:spcAft>
-            </a:pPr>
-            <a:r>
-              <a:rPr sz="1800" b="1">
-                <a:solidFill>
-                  <a:srgbClr val="E0A437"/>
-                </a:solidFill>
-                <a:latin typeface="Fira Sans"/>
-              </a:rPr>
-              <a:t>▸ </a:t>
-            </a:r>
-            <a:r>
-              <a:rPr sz="1800" b="0">
-                <a:solidFill>
-                  <a:srgbClr val="000000"/>
-                </a:solidFill>
-                <a:latin typeface="Fira Sans"/>
-              </a:rPr>
-              <a:t>En una encuesta, primero se define la población y luego se pondera por los factores: la cifra ingenua del 23% sin viajes era en realidad un 15%.</a:t>
-            </a:r>
-          </a:p>
-          <a:p>
-            <a:pPr>
-              <a:lnSpc>
-                <a:spcPct val="112000"/>
-              </a:lnSpc>
-              <a:spcAft>
-                <a:spcPts val="900"/>
-              </a:spcAft>
-            </a:pPr>
-            <a:r>
-              <a:rPr sz="1800" b="1">
-                <a:solidFill>
-                  <a:srgbClr val="E0A437"/>
-                </a:solidFill>
-                <a:latin typeface="Fira Sans"/>
-              </a:rPr>
-              <a:t>▸ </a:t>
-            </a:r>
-            <a:r>
-              <a:rPr sz="1800" b="1">
-                <a:solidFill>
                   <a:srgbClr val="1D3557"/>
                 </a:solidFill>
                 <a:latin typeface="Fira Sans"/>
               </a:rPr>
-              <a:t>El concepto de la clase: el EDA, examinar los datos antes de modelarlos, preguntando ante cada cifra de quién habla.</a:t>
+              <a:t>Lo que avancen en este bloque ya es parte de la tarea.</a:t>
             </a:r>
           </a:p>
         </p:txBody>
@@ -9684,293 +9687,6 @@
 </file>
 
 <file path=ppt/slides/slide37.xml><?xml version="1.0" encoding="utf-8"?>
-<p:sld xmlns:a="http://schemas.openxmlformats.org/drawingml/2006/main" xmlns:p="http://schemas.openxmlformats.org/presentationml/2006/main" xmlns:r="http://schemas.openxmlformats.org/officeDocument/2006/relationships">
-  <p:cSld>
-    <p:spTree>
-      <p:nvGrpSpPr>
-        <p:cNvPr id="1" name=""/>
-        <p:cNvGrpSpPr/>
-        <p:nvPr/>
-      </p:nvGrpSpPr>
-      <p:grpSpPr/>
-      <p:sp>
-        <p:nvSpPr>
-          <p:cNvPr id="2" name="Rectangle 1"/>
-          <p:cNvSpPr/>
-          <p:nvPr/>
-        </p:nvSpPr>
-        <p:spPr>
-          <a:xfrm>
-            <a:off x="0" y="0"/>
-            <a:ext cx="9144000" cy="5138928"/>
-          </a:xfrm>
-          <a:prstGeom prst="rect">
-            <a:avLst/>
-          </a:prstGeom>
-          <a:solidFill>
-            <a:srgbClr val="FAFBFC"/>
-          </a:solidFill>
-          <a:ln>
-            <a:noFill/>
-          </a:ln>
-          <a:effectLst/>
-        </p:spPr>
-        <p:style>
-          <a:lnRef idx="1">
-            <a:schemeClr val="accent1"/>
-          </a:lnRef>
-          <a:fillRef idx="3">
-            <a:schemeClr val="accent1"/>
-          </a:fillRef>
-          <a:effectRef idx="2">
-            <a:schemeClr val="accent1"/>
-          </a:effectRef>
-          <a:fontRef idx="minor">
-            <a:schemeClr val="lt1"/>
-          </a:fontRef>
-        </p:style>
-        <p:txBody>
-          <a:bodyPr rtlCol="0" anchor="ctr"/>
-          <a:lstStyle/>
-          <a:p>
-            <a:pPr algn="ctr"/>
-          </a:p>
-        </p:txBody>
-      </p:sp>
-      <p:sp>
-        <p:nvSpPr>
-          <p:cNvPr id="3" name="TextBox 2"/>
-          <p:cNvSpPr txBox="1"/>
-          <p:nvPr/>
-        </p:nvSpPr>
-        <p:spPr>
-          <a:xfrm>
-            <a:off x="402336" y="301752"/>
-            <a:ext cx="8348472" cy="795528"/>
-          </a:xfrm>
-          <a:prstGeom prst="rect">
-            <a:avLst/>
-          </a:prstGeom>
-          <a:noFill/>
-        </p:spPr>
-        <p:txBody>
-          <a:bodyPr wrap="square">
-            <a:spAutoFit/>
-          </a:bodyPr>
-          <a:lstStyle/>
-          <a:p>
-            <a:r>
-              <a:rPr sz="2800" b="1">
-                <a:solidFill>
-                  <a:srgbClr val="0F0F0F"/>
-                </a:solidFill>
-                <a:latin typeface="Fira Sans"/>
-              </a:rPr>
-              <a:t>Segundo bloque: comienza la Tarea 1</a:t>
-            </a:r>
-          </a:p>
-        </p:txBody>
-      </p:sp>
-      <p:sp>
-        <p:nvSpPr>
-          <p:cNvPr id="4" name="TextBox 3"/>
-          <p:cNvSpPr txBox="1"/>
-          <p:nvPr/>
-        </p:nvSpPr>
-        <p:spPr>
-          <a:xfrm>
-            <a:off x="704088" y="1353312"/>
-            <a:ext cx="7744968" cy="3300984"/>
-          </a:xfrm>
-          <a:prstGeom prst="rect">
-            <a:avLst/>
-          </a:prstGeom>
-          <a:noFill/>
-        </p:spPr>
-        <p:txBody>
-          <a:bodyPr wrap="square">
-            <a:spAutoFit/>
-          </a:bodyPr>
-          <a:lstStyle/>
-          <a:p>
-            <a:pPr>
-              <a:lnSpc>
-                <a:spcPct val="112000"/>
-              </a:lnSpc>
-              <a:spcAft>
-                <a:spcPts val="900"/>
-              </a:spcAft>
-            </a:pPr>
-            <a:r>
-              <a:rPr sz="1800" b="1">
-                <a:solidFill>
-                  <a:srgbClr val="E0A437"/>
-                </a:solidFill>
-                <a:latin typeface="Fira Sans"/>
-              </a:rPr>
-              <a:t>▸ </a:t>
-            </a:r>
-            <a:r>
-              <a:rPr sz="1800" b="0">
-                <a:solidFill>
-                  <a:srgbClr val="000000"/>
-                </a:solidFill>
-                <a:latin typeface="Fira Sans"/>
-              </a:rPr>
-              <a:t>El retrato de tu comuna: cada pareja adopta una comuna del Gran Santiago.</a:t>
-            </a:r>
-          </a:p>
-          <a:p>
-            <a:pPr>
-              <a:lnSpc>
-                <a:spcPct val="112000"/>
-              </a:lnSpc>
-              <a:spcAft>
-                <a:spcPts val="500"/>
-              </a:spcAft>
-            </a:pPr>
-            <a:r>
-              <a:rPr sz="1400" b="0">
-                <a:solidFill>
-                  <a:srgbClr val="333333"/>
-                </a:solidFill>
-                <a:latin typeface="Fira Sans"/>
-              </a:rPr>
-              <a:t>     ◦  </a:t>
-            </a:r>
-            <a:r>
-              <a:rPr sz="1400" b="0">
-                <a:solidFill>
-                  <a:srgbClr val="333333"/>
-                </a:solidFill>
-                <a:latin typeface="Fira Sans"/>
-              </a:rPr>
-              <a:t>Hoy: elegir la comuna y construir su retrato numérico.</a:t>
-            </a:r>
-          </a:p>
-          <a:p>
-            <a:pPr>
-              <a:lnSpc>
-                <a:spcPct val="112000"/>
-              </a:lnSpc>
-              <a:spcAft>
-                <a:spcPts val="500"/>
-              </a:spcAft>
-            </a:pPr>
-            <a:r>
-              <a:rPr sz="1400" b="0">
-                <a:solidFill>
-                  <a:srgbClr val="333333"/>
-                </a:solidFill>
-                <a:latin typeface="Fira Sans"/>
-              </a:rPr>
-              <a:t>     ◦  </a:t>
-            </a:r>
-            <a:r>
-              <a:rPr sz="1400" b="0">
-                <a:solidFill>
-                  <a:srgbClr val="333333"/>
-                </a:solidFill>
-                <a:latin typeface="Fira Sans"/>
-              </a:rPr>
-              <a:t>Próxima clase: el retrato gráfico, con métodos de visualización.</a:t>
-            </a:r>
-          </a:p>
-          <a:p>
-            <a:pPr>
-              <a:lnSpc>
-                <a:spcPct val="112000"/>
-              </a:lnSpc>
-              <a:spcAft>
-                <a:spcPts val="500"/>
-              </a:spcAft>
-            </a:pPr>
-            <a:r>
-              <a:rPr sz="1400" b="0">
-                <a:solidFill>
-                  <a:srgbClr val="333333"/>
-                </a:solidFill>
-                <a:latin typeface="Fira Sans"/>
-              </a:rPr>
-              <a:t>     ◦  </a:t>
-            </a:r>
-            <a:r>
-              <a:rPr sz="1400" b="0">
-                <a:solidFill>
-                  <a:srgbClr val="333333"/>
-                </a:solidFill>
-                <a:latin typeface="Fira Sans"/>
-              </a:rPr>
-              <a:t>Entrega del retrato completo: jueves 10 de septiembre, por Aula.</a:t>
-            </a:r>
-          </a:p>
-          <a:p>
-            <a:pPr>
-              <a:lnSpc>
-                <a:spcPct val="112000"/>
-              </a:lnSpc>
-              <a:spcAft>
-                <a:spcPts val="900"/>
-              </a:spcAft>
-            </a:pPr>
-            <a:r>
-              <a:rPr sz="1800" b="1">
-                <a:solidFill>
-                  <a:srgbClr val="E0A437"/>
-                </a:solidFill>
-                <a:latin typeface="Fira Sans"/>
-              </a:rPr>
-              <a:t>▸ </a:t>
-            </a:r>
-            <a:r>
-              <a:rPr sz="1800" b="0">
-                <a:solidFill>
-                  <a:srgbClr val="000000"/>
-                </a:solidFill>
-                <a:latin typeface="Fira Sans"/>
-              </a:rPr>
-              <a:t>El enunciado está en evaluaciones/tareas/ y la guía de hoy en actividades/.</a:t>
-            </a:r>
-          </a:p>
-          <a:p>
-            <a:pPr>
-              <a:lnSpc>
-                <a:spcPct val="112000"/>
-              </a:lnSpc>
-              <a:spcAft>
-                <a:spcPts val="900"/>
-              </a:spcAft>
-            </a:pPr>
-            <a:r>
-              <a:rPr sz="1800" b="1">
-                <a:solidFill>
-                  <a:srgbClr val="E0A437"/>
-                </a:solidFill>
-                <a:latin typeface="Fira Sans"/>
-              </a:rPr>
-              <a:t>▸ </a:t>
-            </a:r>
-            <a:r>
-              <a:rPr sz="1800" b="1">
-                <a:solidFill>
-                  <a:srgbClr val="1D3557"/>
-                </a:solidFill>
-                <a:latin typeface="Fira Sans"/>
-              </a:rPr>
-              <a:t>Lo que avancen en este bloque ya es parte de la tarea.</a:t>
-            </a:r>
-          </a:p>
-        </p:txBody>
-      </p:sp>
-    </p:spTree>
-  </p:cSld>
-  <p:clrMapOvr>
-    <a:masterClrMapping/>
-  </p:clrMapOvr>
-</p:sld>
-</file>
-
-<file path=ppt/slides/slide38.xml><?xml version="1.0" encoding="utf-8"?>
 <p:sld xmlns:a="http://schemas.openxmlformats.org/drawingml/2006/main" xmlns:p="http://schemas.openxmlformats.org/presentationml/2006/main" xmlns:r="http://schemas.openxmlformats.org/officeDocument/2006/relationships">
   <p:cSld>
     <p:spTree>

</xml_diff>

<commit_message>
Slides clase 02: factor de expansion en dos slides simples; quitar duracion extremos y particion modal
Co-Authored-By: Claude Fable 5 <noreply@anthropic.com>
</commit_message>
<xml_diff>
--- a/presentaciones/clase02_pandas_eda.pptx
+++ b/presentaciones/clase02_pandas_eda.pptx
@@ -41,7 +41,6 @@
     <p:sldId id="289" r:id="rId40"/>
     <p:sldId id="290" r:id="rId41"/>
     <p:sldId id="291" r:id="rId42"/>
-    <p:sldId id="292" r:id="rId43"/>
   </p:sldIdLst>
   <p:sldSz cx="9144000" cy="5138928" type="screen4x3"/>
   <p:notesSz cx="6858000" cy="9144000"/>
@@ -7346,7 +7345,7 @@
                 </a:solidFill>
                 <a:latin typeface="Fira Sans"/>
               </a:rPr>
-              <a:t>Cada persona i tiene una probabilidad πᵢ de ser incluida en la muestra (según su zona, su hogar y el día asignado).</a:t>
+              <a:t>Cada persona encuestada i trae un factor de expansión wᵢ (el factor de la persona): cuántas personas de la ciudad representa.</a:t>
             </a:r>
           </a:p>
           <a:p>
@@ -7374,63 +7373,7 @@
                 </a:solidFill>
                 <a:latin typeface="Fira Sans"/>
               </a:rPr>
-              <a:t>Su factor es el inverso: wᵢ = 1/πᵢ, las personas de la población que representa (Horvitz y Thompson, 1952).</a:t>
-            </a:r>
-          </a:p>
-          <a:p>
-            <a:pPr>
-              <a:lnSpc>
-                <a:spcPct val="112000"/>
-              </a:lnSpc>
-              <a:spcAft>
-                <a:spcPts val="500"/>
-              </a:spcAft>
-            </a:pPr>
-            <a:r>
-              <a:rPr sz="1300" b="0">
-                <a:solidFill>
-                  <a:srgbClr val="333333"/>
-                </a:solidFill>
-                <a:latin typeface="Fira Sans"/>
-              </a:rPr>
-              <a:t>     ◦  </a:t>
-            </a:r>
-            <a:r>
-              <a:rPr sz="1300" b="0">
-                <a:solidFill>
-                  <a:srgbClr val="333333"/>
-                </a:solidFill>
-                <a:latin typeface="Fira Sans"/>
-              </a:rPr>
-              <a:t>El total poblacional se estima sumando factores; las medias, ponderando por ellos.</a:t>
-            </a:r>
-          </a:p>
-          <a:p>
-            <a:pPr>
-              <a:lnSpc>
-                <a:spcPct val="112000"/>
-              </a:lnSpc>
-              <a:spcAft>
-                <a:spcPts val="500"/>
-              </a:spcAft>
-            </a:pPr>
-            <a:r>
-              <a:rPr sz="1300" b="0">
-                <a:solidFill>
-                  <a:srgbClr val="333333"/>
-                </a:solidFill>
-                <a:latin typeface="Fira Sans"/>
-              </a:rPr>
-              <a:t>     ◦  </a:t>
-            </a:r>
-            <a:r>
-              <a:rPr sz="1300" b="0">
-                <a:solidFill>
-                  <a:srgbClr val="333333"/>
-                </a:solidFill>
-                <a:latin typeface="Fira Sans"/>
-              </a:rPr>
-              <a:t>Se usa el factor de la unidad analizada: hogar (Factor), persona (Factor_LaboralNormal), viaje (FactorLaboralNormal); dos nombres difieren solo en un guion bajo.</a:t>
+              <a:t>Si a una persona le corresponde un factor de 100, esa fila del dataset representa a 100 personas reales de Santiago con características similares.</a:t>
             </a:r>
           </a:p>
           <a:p>
@@ -7452,13 +7395,41 @@
               <a:t>▸ </a:t>
             </a:r>
             <a:r>
+              <a:rPr sz="1500" b="0">
+                <a:solidFill>
+                  <a:srgbClr val="000000"/>
+                </a:solidFill>
+                <a:latin typeface="Fira Sans"/>
+              </a:rPr>
+              <a:t>Sumar los factores estima el tamaño de la población; ponderar por ellos, sus medias (Horvitz y Thompson, 1952).</a:t>
+            </a:r>
+          </a:p>
+          <a:p>
+            <a:pPr>
+              <a:lnSpc>
+                <a:spcPct val="112000"/>
+              </a:lnSpc>
+              <a:spcAft>
+                <a:spcPts val="900"/>
+              </a:spcAft>
+            </a:pPr>
+            <a:r>
               <a:rPr sz="1500" b="1">
                 <a:solidFill>
+                  <a:srgbClr val="E0A437"/>
+                </a:solidFill>
+                <a:latin typeface="Fira Sans"/>
+              </a:rPr>
+              <a:t>▸ </a:t>
+            </a:r>
+            <a:r>
+              <a:rPr sz="1500" b="1">
+                <a:solidFill>
                   <a:srgbClr val="1D3557"/>
                 </a:solidFill>
                 <a:latin typeface="Fira Sans"/>
               </a:rPr>
-              <a:t>Dos pasos, en orden: definir la población (¿día laboral?) y ponderar dentro de ella. La cifra ingenua decía 23% sin viajes; la estimación correcta es 15%.</a:t>
+              <a:t>Se usa el factor de la unidad analizada: Factor (hogar), Factor_LaboralNormal (persona), FactorLaboralNormal (viaje).</a:t>
             </a:r>
           </a:p>
         </p:txBody>
@@ -7480,7 +7451,7 @@
         <p:spPr>
           <a:xfrm>
             <a:off x="4892040" y="1371600"/>
-            <a:ext cx="3840480" cy="3506775"/>
+            <a:ext cx="3840480" cy="2294047"/>
           </a:xfrm>
           <a:prstGeom prst="rect">
             <a:avLst/>
@@ -7578,149 +7549,14 @@
                 </a:solidFill>
                 <a:latin typeface="Fira Sans"/>
               </a:rPr>
-              <a:t>Viajes por persona: los ausentes también cuentan</a:t>
-            </a:r>
-          </a:p>
-        </p:txBody>
-      </p:sp>
-      <p:sp>
-        <p:nvSpPr>
-          <p:cNvPr id="4" name="TextBox 3"/>
-          <p:cNvSpPr txBox="1"/>
-          <p:nvPr/>
-        </p:nvSpPr>
-        <p:spPr>
-          <a:xfrm>
-            <a:off x="502920" y="1252728"/>
-            <a:ext cx="4023360" cy="3200400"/>
-          </a:xfrm>
-          <a:prstGeom prst="rect">
-            <a:avLst/>
-          </a:prstGeom>
-          <a:noFill/>
-        </p:spPr>
-        <p:txBody>
-          <a:bodyPr wrap="square">
-            <a:spAutoFit/>
-          </a:bodyPr>
-          <a:lstStyle/>
-          <a:p>
-            <a:pPr>
-              <a:lnSpc>
-                <a:spcPct val="112000"/>
-              </a:lnSpc>
-              <a:spcAft>
-                <a:spcPts val="900"/>
-              </a:spcAft>
-            </a:pPr>
-            <a:r>
-              <a:rPr sz="1500" b="1">
-                <a:solidFill>
-                  <a:srgbClr val="E0A437"/>
-                </a:solidFill>
-                <a:latin typeface="Fira Sans"/>
-              </a:rPr>
-              <a:t>▸ </a:t>
-            </a:r>
-            <a:r>
-              <a:rPr sz="1500" b="0">
-                <a:solidFill>
-                  <a:srgbClr val="000000"/>
-                </a:solidFill>
-                <a:latin typeface="Fira Sans"/>
-              </a:rPr>
-              <a:t>Quien no viajó no está en la tabla de viajes: hay que reincorporarlo antes de calcular.</a:t>
-            </a:r>
-          </a:p>
-          <a:p>
-            <a:pPr>
-              <a:lnSpc>
-                <a:spcPct val="112000"/>
-              </a:lnSpc>
-              <a:spcAft>
-                <a:spcPts val="900"/>
-              </a:spcAft>
-            </a:pPr>
-            <a:r>
-              <a:rPr sz="1500" b="1">
-                <a:solidFill>
-                  <a:srgbClr val="E0A437"/>
-                </a:solidFill>
-                <a:latin typeface="Fira Sans"/>
-              </a:rPr>
-              <a:t>▸ </a:t>
-            </a:r>
-            <a:r>
-              <a:rPr sz="1500" b="0">
-                <a:solidFill>
-                  <a:srgbClr val="000000"/>
-                </a:solidFill>
-                <a:latin typeface="Fira Sans"/>
-              </a:rPr>
-              <a:t>Ponderado: el 15% de las personas no viajó; media de 2,2 viajes, mediana de 2.</a:t>
-            </a:r>
-          </a:p>
-          <a:p>
-            <a:pPr>
-              <a:lnSpc>
-                <a:spcPct val="112000"/>
-              </a:lnSpc>
-              <a:spcAft>
-                <a:spcPts val="900"/>
-              </a:spcAft>
-            </a:pPr>
-            <a:r>
-              <a:rPr sz="1500" b="1">
-                <a:solidFill>
-                  <a:srgbClr val="E0A437"/>
-                </a:solidFill>
-                <a:latin typeface="Fira Sans"/>
-              </a:rPr>
-              <a:t>▸ </a:t>
-            </a:r>
-            <a:r>
-              <a:rPr sz="1500" b="0">
-                <a:solidFill>
-                  <a:srgbClr val="000000"/>
-                </a:solidFill>
-                <a:latin typeface="Fira Sans"/>
-              </a:rPr>
-              <a:t>El 59% de la población hace exactamente 2 viajes: la ida y la vuelta.</a:t>
-            </a:r>
-          </a:p>
-          <a:p>
-            <a:pPr>
-              <a:lnSpc>
-                <a:spcPct val="112000"/>
-              </a:lnSpc>
-              <a:spcAft>
-                <a:spcPts val="900"/>
-              </a:spcAft>
-            </a:pPr>
-            <a:r>
-              <a:rPr sz="1500" b="1">
-                <a:solidFill>
-                  <a:srgbClr val="E0A437"/>
-                </a:solidFill>
-                <a:latin typeface="Fira Sans"/>
-              </a:rPr>
-              <a:t>▸ </a:t>
-            </a:r>
-            <a:r>
-              <a:rPr sz="1500" b="1">
-                <a:solidFill>
-                  <a:srgbClr val="1D3557"/>
-                </a:solidFill>
-                <a:latin typeface="Fira Sans"/>
-              </a:rPr>
-              <a:t>La cifra ingenua decía 23%: mezclaba días de fin de semana y omitía los factores.</a:t>
+              <a:t>Primero definir la población, luego ponderar</a:t>
             </a:r>
           </a:p>
         </p:txBody>
       </p:sp>
       <p:pic>
         <p:nvPicPr>
-          <p:cNvPr id="5" name="Picture 4" descr="02_viajes_por_persona.png"/>
+          <p:cNvPr id="4" name="Picture 3" descr="22_definir_poblacion.png"/>
           <p:cNvPicPr>
             <a:picLocks noChangeAspect="1"/>
           </p:cNvPicPr>
@@ -7734,14 +7570,48 @@
         </p:blipFill>
         <p:spPr>
           <a:xfrm>
-            <a:off x="4892040" y="1371600"/>
-            <a:ext cx="3840480" cy="2335791"/>
+            <a:off x="1928389" y="1143000"/>
+            <a:ext cx="5287220" cy="3154679"/>
           </a:xfrm>
           <a:prstGeom prst="rect">
             <a:avLst/>
           </a:prstGeom>
         </p:spPr>
       </p:pic>
+      <p:sp>
+        <p:nvSpPr>
+          <p:cNvPr id="5" name="TextBox 4"/>
+          <p:cNvSpPr txBox="1"/>
+          <p:nvPr/>
+        </p:nvSpPr>
+        <p:spPr>
+          <a:xfrm>
+            <a:off x="704088" y="4434840"/>
+            <a:ext cx="7744968" cy="457200"/>
+          </a:xfrm>
+          <a:prstGeom prst="rect">
+            <a:avLst/>
+          </a:prstGeom>
+          <a:noFill/>
+        </p:spPr>
+        <p:txBody>
+          <a:bodyPr wrap="square">
+            <a:spAutoFit/>
+          </a:bodyPr>
+          <a:lstStyle/>
+          <a:p>
+            <a:r>
+              <a:rPr sz="1300" b="0">
+                <a:solidFill>
+                  <a:srgbClr val="333333"/>
+                </a:solidFill>
+                <a:latin typeface="Fira Sans"/>
+              </a:rPr>
+              <a:t>La cifra ingenua mezcla fin de semana y temporada estival; restringir al día laboral normal da 16,2 % y ponderar dentro de ese universo, 15,1 %.</a:t>
+            </a:r>
+          </a:p>
+        </p:txBody>
+      </p:sp>
     </p:spTree>
   </p:cSld>
   <p:clrMapOvr>
@@ -7833,7 +7703,7 @@
                 </a:solidFill>
                 <a:latin typeface="Fira Sans"/>
               </a:rPr>
-              <a:t>El ingreso de los hogares: media y mediana</a:t>
+              <a:t>Viajes por persona: los ausentes también cuentan</a:t>
             </a:r>
           </a:p>
         </p:txBody>
@@ -7884,7 +7754,7 @@
                 </a:solidFill>
                 <a:latin typeface="Fira Sans"/>
               </a:rPr>
-              <a:t>Ponderado por el factor del hogar: media $729.898, mediana $520.000.</a:t>
+              <a:t>Quien no viajó no está en la tabla de viajes: hay que reincorporarlo antes de calcular.</a:t>
             </a:r>
           </a:p>
           <a:p>
@@ -7912,7 +7782,7 @@
                 </a:solidFill>
                 <a:latin typeface="Fira Sans"/>
               </a:rPr>
-              <a:t>La media es un 40% más alta que la mediana.</a:t>
+              <a:t>Ponderado: el 15% de las personas no viajó; media de 2,2 viajes, mediana de 2.</a:t>
             </a:r>
           </a:p>
           <a:p>
@@ -7940,7 +7810,7 @@
                 </a:solidFill>
                 <a:latin typeface="Fira Sans"/>
               </a:rPr>
-              <a:t>Los ingresos altos desplazan el promedio; la mayoría gana menos.</a:t>
+              <a:t>El 59% de la población hace exactamente 2 viajes: la ida y la vuelta.</a:t>
             </a:r>
           </a:p>
           <a:p>
@@ -7968,14 +7838,14 @@
                 </a:solidFill>
                 <a:latin typeface="Fira Sans"/>
               </a:rPr>
-              <a:t>El promedio describe una situación en la que la mayoría no está.</a:t>
+              <a:t>La cifra ingenua decía 23%: mezclaba días de fin de semana y omitía los factores.</a:t>
             </a:r>
           </a:p>
         </p:txBody>
       </p:sp>
       <p:pic>
         <p:nvPicPr>
-          <p:cNvPr id="5" name="Picture 4" descr="01_ingreso_media_mediana.png"/>
+          <p:cNvPr id="5" name="Picture 4" descr="02_viajes_por_persona.png"/>
           <p:cNvPicPr>
             <a:picLocks noChangeAspect="1"/>
           </p:cNvPicPr>
@@ -7990,7 +7860,7 @@
         <p:spPr>
           <a:xfrm>
             <a:off x="4892040" y="1371600"/>
-            <a:ext cx="3840480" cy="2119546"/>
+            <a:ext cx="3840480" cy="2335791"/>
           </a:xfrm>
           <a:prstGeom prst="rect">
             <a:avLst/>
@@ -8195,7 +8065,7 @@
                 </a:solidFill>
                 <a:latin typeface="Fira Sans"/>
               </a:rPr>
-              <a:t>La duración de los viajes: valores extremos</a:t>
+              <a:t>El ingreso de los hogares: media y mediana</a:t>
             </a:r>
           </a:p>
         </p:txBody>
@@ -8246,7 +8116,7 @@
                 </a:solidFill>
                 <a:latin typeface="Fira Sans"/>
               </a:rPr>
-              <a:t>Ponderado por el factor del viaje: mediana de 25 minutos, percentil 95 de 90.</a:t>
+              <a:t>Ponderado por el factor del hogar: media $729.898, mediana $520.000.</a:t>
             </a:r>
           </a:p>
           <a:p>
@@ -8274,7 +8144,7 @@
                 </a:solidFill>
                 <a:latin typeface="Fira Sans"/>
               </a:rPr>
-              <a:t>Máximo registrado: 1.335 minutos, un viaje de 22 horas.</a:t>
+              <a:t>La media es un 40% más alta que la mediana.</a:t>
             </a:r>
           </a:p>
           <a:p>
@@ -8302,7 +8172,7 @@
                 </a:solidFill>
                 <a:latin typeface="Fira Sans"/>
               </a:rPr>
-              <a:t>¿Error de digitación? ¿Turno nocturno mal anotado?</a:t>
+              <a:t>Los ingresos altos desplazan el promedio; la mayoría gana menos.</a:t>
             </a:r>
           </a:p>
           <a:p>
@@ -8330,14 +8200,14 @@
                 </a:solidFill>
                 <a:latin typeface="Fira Sans"/>
               </a:rPr>
-              <a:t>Los valores extremos se investigan y la decisión se declara.</a:t>
+              <a:t>El promedio describe una situación en la que la mayoría no está.</a:t>
             </a:r>
           </a:p>
         </p:txBody>
       </p:sp>
       <p:pic>
         <p:nvPicPr>
-          <p:cNvPr id="5" name="Picture 4" descr="04_duracion_viajes.png"/>
+          <p:cNvPr id="5" name="Picture 4" descr="01_ingreso_media_mediana.png"/>
           <p:cNvPicPr>
             <a:picLocks noChangeAspect="1"/>
           </p:cNvPicPr>
@@ -8352,7 +8222,7 @@
         <p:spPr>
           <a:xfrm>
             <a:off x="4892040" y="1371600"/>
-            <a:ext cx="3840480" cy="2170536"/>
+            <a:ext cx="3840480" cy="2119546"/>
           </a:xfrm>
           <a:prstGeom prst="rect">
             <a:avLst/>
@@ -8450,177 +8320,14 @@
                 </a:solidFill>
                 <a:latin typeface="Fira Sans"/>
               </a:rPr>
-              <a:t>La partición modal del Gran Santiago</a:t>
-            </a:r>
-          </a:p>
-        </p:txBody>
-      </p:sp>
-      <p:sp>
-        <p:nvSpPr>
-          <p:cNvPr id="4" name="TextBox 3"/>
-          <p:cNvSpPr txBox="1"/>
-          <p:nvPr/>
-        </p:nvSpPr>
-        <p:spPr>
-          <a:xfrm>
-            <a:off x="502920" y="1252728"/>
-            <a:ext cx="4023360" cy="3200400"/>
-          </a:xfrm>
-          <a:prstGeom prst="rect">
-            <a:avLst/>
-          </a:prstGeom>
-          <a:noFill/>
-        </p:spPr>
-        <p:txBody>
-          <a:bodyPr wrap="square">
-            <a:spAutoFit/>
-          </a:bodyPr>
-          <a:lstStyle/>
-          <a:p>
-            <a:pPr>
-              <a:lnSpc>
-                <a:spcPct val="112000"/>
-              </a:lnSpc>
-              <a:spcAft>
-                <a:spcPts val="900"/>
-              </a:spcAft>
-            </a:pPr>
-            <a:r>
-              <a:rPr sz="1500" b="1">
-                <a:solidFill>
-                  <a:srgbClr val="E0A437"/>
-                </a:solidFill>
-                <a:latin typeface="Fira Sans"/>
-              </a:rPr>
-              <a:t>▸ </a:t>
-            </a:r>
-            <a:r>
-              <a:rPr sz="1500" b="0">
-                <a:solidFill>
-                  <a:srgbClr val="000000"/>
-                </a:solidFill>
-                <a:latin typeface="Fira Sans"/>
-              </a:rPr>
-              <a:t>Dos merges y un groupby ponderado por factor.</a:t>
-            </a:r>
-          </a:p>
-          <a:p>
-            <a:pPr>
-              <a:lnSpc>
-                <a:spcPct val="112000"/>
-              </a:lnSpc>
-              <a:spcAft>
-                <a:spcPts val="500"/>
-              </a:spcAft>
-            </a:pPr>
-            <a:r>
-              <a:rPr sz="1300" b="0">
-                <a:solidFill>
-                  <a:srgbClr val="333333"/>
-                </a:solidFill>
-                <a:latin typeface="Fira Sans"/>
-              </a:rPr>
-              <a:t>     ◦  </a:t>
-            </a:r>
-            <a:r>
-              <a:rPr sz="1300" b="0">
-                <a:solidFill>
-                  <a:srgbClr val="333333"/>
-                </a:solidFill>
-                <a:latin typeface="Fira Sans"/>
-              </a:rPr>
-              <a:t>Caminata: 34% de los viajes.</a:t>
-            </a:r>
-          </a:p>
-          <a:p>
-            <a:pPr>
-              <a:lnSpc>
-                <a:spcPct val="112000"/>
-              </a:lnSpc>
-              <a:spcAft>
-                <a:spcPts val="500"/>
-              </a:spcAft>
-            </a:pPr>
-            <a:r>
-              <a:rPr sz="1300" b="0">
-                <a:solidFill>
-                  <a:srgbClr val="333333"/>
-                </a:solidFill>
-                <a:latin typeface="Fira Sans"/>
-              </a:rPr>
-              <a:t>     ◦  </a:t>
-            </a:r>
-            <a:r>
-              <a:rPr sz="1300" b="0">
-                <a:solidFill>
-                  <a:srgbClr val="333333"/>
-                </a:solidFill>
-                <a:latin typeface="Fira Sans"/>
-              </a:rPr>
-              <a:t>Transporte público (Bip!): 24%.</a:t>
-            </a:r>
-          </a:p>
-          <a:p>
-            <a:pPr>
-              <a:lnSpc>
-                <a:spcPct val="112000"/>
-              </a:lnSpc>
-              <a:spcAft>
-                <a:spcPts val="500"/>
-              </a:spcAft>
-            </a:pPr>
-            <a:r>
-              <a:rPr sz="1300" b="0">
-                <a:solidFill>
-                  <a:srgbClr val="333333"/>
-                </a:solidFill>
-                <a:latin typeface="Fira Sans"/>
-              </a:rPr>
-              <a:t>     ◦  </a:t>
-            </a:r>
-            <a:r>
-              <a:rPr sz="1300" b="0">
-                <a:solidFill>
-                  <a:srgbClr val="333333"/>
-                </a:solidFill>
-                <a:latin typeface="Fira Sans"/>
-              </a:rPr>
-              <a:t>Auto: 23%.</a:t>
-            </a:r>
-          </a:p>
-          <a:p>
-            <a:pPr>
-              <a:lnSpc>
-                <a:spcPct val="112000"/>
-              </a:lnSpc>
-              <a:spcAft>
-                <a:spcPts val="900"/>
-              </a:spcAft>
-            </a:pPr>
-            <a:r>
-              <a:rPr sz="1500" b="1">
-                <a:solidFill>
-                  <a:srgbClr val="E0A437"/>
-                </a:solidFill>
-                <a:latin typeface="Fira Sans"/>
-              </a:rPr>
-              <a:t>▸ </a:t>
-            </a:r>
-            <a:r>
-              <a:rPr sz="1500" b="1">
-                <a:solidFill>
-                  <a:srgbClr val="1D3557"/>
-                </a:solidFill>
-                <a:latin typeface="Fira Sans"/>
-              </a:rPr>
-              <a:t>Calculada desde los microdatos, con los factores de un día laboral.</a:t>
+              <a:t>El reparto modal difiere entre comunas</a:t>
             </a:r>
           </a:p>
         </p:txBody>
       </p:sp>
       <p:pic>
         <p:nvPicPr>
-          <p:cNvPr id="5" name="Picture 4" descr="03_reparto_modal.png"/>
+          <p:cNvPr id="4" name="Picture 3" descr="08_modo_por_comuna.png"/>
           <p:cNvPicPr>
             <a:picLocks noChangeAspect="1"/>
           </p:cNvPicPr>
@@ -8634,14 +8341,48 @@
         </p:blipFill>
         <p:spPr>
           <a:xfrm>
-            <a:off x="4892040" y="1371600"/>
-            <a:ext cx="3840480" cy="1909061"/>
+            <a:off x="1994250" y="1143000"/>
+            <a:ext cx="5155498" cy="3154679"/>
           </a:xfrm>
           <a:prstGeom prst="rect">
             <a:avLst/>
           </a:prstGeom>
         </p:spPr>
       </p:pic>
+      <p:sp>
+        <p:nvSpPr>
+          <p:cNvPr id="5" name="TextBox 4"/>
+          <p:cNvSpPr txBox="1"/>
+          <p:nvPr/>
+        </p:nvSpPr>
+        <p:spPr>
+          <a:xfrm>
+            <a:off x="704088" y="4434840"/>
+            <a:ext cx="7744968" cy="457200"/>
+          </a:xfrm>
+          <a:prstGeom prst="rect">
+            <a:avLst/>
+          </a:prstGeom>
+          <a:noFill/>
+        </p:spPr>
+        <p:txBody>
+          <a:bodyPr wrap="square">
+            <a:spAutoFit/>
+          </a:bodyPr>
+          <a:lstStyle/>
+          <a:p>
+            <a:r>
+              <a:rPr sz="1300" b="0">
+                <a:solidFill>
+                  <a:srgbClr val="333333"/>
+                </a:solidFill>
+                <a:latin typeface="Fira Sans"/>
+              </a:rPr>
+              <a:t>Normalizar por comuna permite comparar proporciones entre comunas de tamaños muy distintos.</a:t>
+            </a:r>
+          </a:p>
+        </p:txBody>
+      </p:sp>
     </p:spTree>
   </p:cSld>
   <p:clrMapOvr>
@@ -8733,14 +8474,14 @@
                 </a:solidFill>
                 <a:latin typeface="Fira Sans"/>
               </a:rPr>
-              <a:t>El reparto modal difiere entre comunas</a:t>
+              <a:t>Los propósitos de viaje según el día de la semana</a:t>
             </a:r>
           </a:p>
         </p:txBody>
       </p:sp>
       <p:pic>
         <p:nvPicPr>
-          <p:cNvPr id="4" name="Picture 3" descr="08_modo_por_comuna.png"/>
+          <p:cNvPr id="4" name="Picture 3" descr="10_heatmap_rutinas.png"/>
           <p:cNvPicPr>
             <a:picLocks noChangeAspect="1"/>
           </p:cNvPicPr>
@@ -8754,8 +8495,8 @@
         </p:blipFill>
         <p:spPr>
           <a:xfrm>
-            <a:off x="1994250" y="1143000"/>
-            <a:ext cx="5155498" cy="3154679"/>
+            <a:off x="1649319" y="1143000"/>
+            <a:ext cx="5845360" cy="3154680"/>
           </a:xfrm>
           <a:prstGeom prst="rect">
             <a:avLst/>
@@ -8791,7 +8532,7 @@
                 </a:solidFill>
                 <a:latin typeface="Fira Sans"/>
               </a:rPr>
-              <a:t>Normalizar por comuna permite comparar proporciones entre comunas de tamaños muy distintos.</a:t>
+              <a:t>El heatmap muestra 14 propósitos por 7 días en una sola figura: útil para tablas completas.</a:t>
             </a:r>
           </a:p>
         </p:txBody>
@@ -8887,14 +8628,14 @@
                 </a:solidFill>
                 <a:latin typeface="Fira Sans"/>
               </a:rPr>
-              <a:t>Los propósitos de viaje según el día de la semana</a:t>
+              <a:t>Cuando los datos crecen</a:t>
             </a:r>
           </a:p>
         </p:txBody>
       </p:sp>
       <p:pic>
         <p:nvPicPr>
-          <p:cNvPr id="4" name="Picture 3" descr="10_heatmap_rutinas.png"/>
+          <p:cNvPr id="4" name="Picture 3" descr="14_escala_datos.png"/>
           <p:cNvPicPr>
             <a:picLocks noChangeAspect="1"/>
           </p:cNvPicPr>
@@ -8908,8 +8649,8 @@
         </p:blipFill>
         <p:spPr>
           <a:xfrm>
-            <a:off x="1649319" y="1143000"/>
-            <a:ext cx="5845360" cy="3154680"/>
+            <a:off x="1417319" y="1143000"/>
+            <a:ext cx="6309360" cy="2324913"/>
           </a:xfrm>
           <a:prstGeom prst="rect">
             <a:avLst/>
@@ -8945,7 +8686,7 @@
                 </a:solidFill>
                 <a:latin typeface="Fira Sans"/>
               </a:rPr>
-              <a:t>El heatmap muestra 14 propósitos por 7 días en una sola figura: útil para tablas completas.</a:t>
+              <a:t>PySpark se usa con SQL o con sus propios DataFrames; Dask reparte operaciones estilo Pandas; Polars y DuckDB rinden en una sola máquina.</a:t>
             </a:r>
           </a:p>
         </p:txBody>
@@ -9041,45 +8782,21 @@
                 </a:solidFill>
                 <a:latin typeface="Fira Sans"/>
               </a:rPr>
-              <a:t>Cuando los datos crecen</a:t>
-            </a:r>
-          </a:p>
-        </p:txBody>
-      </p:sp>
-      <p:pic>
-        <p:nvPicPr>
-          <p:cNvPr id="4" name="Picture 3" descr="14_escala_datos.png"/>
-          <p:cNvPicPr>
-            <a:picLocks noChangeAspect="1"/>
-          </p:cNvPicPr>
-          <p:nvPr/>
-        </p:nvPicPr>
-        <p:blipFill>
-          <a:blip r:embed="rId2"/>
-          <a:stretch>
-            <a:fillRect/>
-          </a:stretch>
-        </p:blipFill>
-        <p:spPr>
-          <a:xfrm>
-            <a:off x="1417319" y="1143000"/>
-            <a:ext cx="6309360" cy="2324913"/>
-          </a:xfrm>
-          <a:prstGeom prst="rect">
-            <a:avLst/>
-          </a:prstGeom>
-        </p:spPr>
-      </p:pic>
-      <p:sp>
-        <p:nvSpPr>
-          <p:cNvPr id="5" name="TextBox 4"/>
+              <a:t>Síntesis</a:t>
+            </a:r>
+          </a:p>
+        </p:txBody>
+      </p:sp>
+      <p:sp>
+        <p:nvSpPr>
+          <p:cNvPr id="4" name="TextBox 3"/>
           <p:cNvSpPr txBox="1"/>
           <p:nvPr/>
         </p:nvSpPr>
         <p:spPr>
           <a:xfrm>
-            <a:off x="704088" y="4434840"/>
-            <a:ext cx="7744968" cy="457200"/>
+            <a:off x="704088" y="1353312"/>
+            <a:ext cx="7744968" cy="3300984"/>
           </a:xfrm>
           <a:prstGeom prst="rect">
             <a:avLst/>
@@ -9092,14 +8809,171 @@
           </a:bodyPr>
           <a:lstStyle/>
           <a:p>
-            <a:r>
-              <a:rPr sz="1300" b="0">
-                <a:solidFill>
-                  <a:srgbClr val="333333"/>
-                </a:solidFill>
-                <a:latin typeface="Fira Sans"/>
-              </a:rPr>
-              <a:t>PySpark se usa con SQL o con sus propios DataFrames; Dask reparte operaciones estilo Pandas; Polars y DuckDB rinden en una sola máquina.</a:t>
+            <a:pPr>
+              <a:lnSpc>
+                <a:spcPct val="112000"/>
+              </a:lnSpc>
+              <a:spcAft>
+                <a:spcPts val="900"/>
+              </a:spcAft>
+            </a:pPr>
+            <a:r>
+              <a:rPr sz="1800" b="1">
+                <a:solidFill>
+                  <a:srgbClr val="E0A437"/>
+                </a:solidFill>
+                <a:latin typeface="Fira Sans"/>
+              </a:rPr>
+              <a:t>▸ </a:t>
+            </a:r>
+            <a:r>
+              <a:rPr sz="1800" b="0">
+                <a:solidFill>
+                  <a:srgbClr val="000000"/>
+                </a:solidFill>
+                <a:latin typeface="Fira Sans"/>
+              </a:rPr>
+              <a:t>Un modelo es una simplificación con decisiones incorporadas; estimarlo puede buscar inferencia o predicción.</a:t>
+            </a:r>
+          </a:p>
+          <a:p>
+            <a:pPr>
+              <a:lnSpc>
+                <a:spcPct val="112000"/>
+              </a:lnSpc>
+              <a:spcAft>
+                <a:spcPts val="900"/>
+              </a:spcAft>
+            </a:pPr>
+            <a:r>
+              <a:rPr sz="1800" b="1">
+                <a:solidFill>
+                  <a:srgbClr val="E0A437"/>
+                </a:solidFill>
+                <a:latin typeface="Fira Sans"/>
+              </a:rPr>
+              <a:t>▸ </a:t>
+            </a:r>
+            <a:r>
+              <a:rPr sz="1800" b="0">
+                <a:solidFill>
+                  <a:srgbClr val="000000"/>
+                </a:solidFill>
+                <a:latin typeface="Fira Sans"/>
+              </a:rPr>
+              <a:t>Las asociaciones se reportan como asociaciones: la causalidad exige más que datos observacionales.</a:t>
+            </a:r>
+          </a:p>
+          <a:p>
+            <a:pPr>
+              <a:lnSpc>
+                <a:spcPct val="112000"/>
+              </a:lnSpc>
+              <a:spcAft>
+                <a:spcPts val="900"/>
+              </a:spcAft>
+            </a:pPr>
+            <a:r>
+              <a:rPr sz="1800" b="1">
+                <a:solidFill>
+                  <a:srgbClr val="E0A437"/>
+                </a:solidFill>
+                <a:latin typeface="Fira Sans"/>
+              </a:rPr>
+              <a:t>▸ </a:t>
+            </a:r>
+            <a:r>
+              <a:rPr sz="1800" b="0">
+                <a:solidFill>
+                  <a:srgbClr val="000000"/>
+                </a:solidFill>
+                <a:latin typeface="Fira Sans"/>
+              </a:rPr>
+              <a:t>El tipo de la variable, no su dtype, determina qué resúmenes tienen sentido.</a:t>
+            </a:r>
+          </a:p>
+          <a:p>
+            <a:pPr>
+              <a:lnSpc>
+                <a:spcPct val="112000"/>
+              </a:lnSpc>
+              <a:spcAft>
+                <a:spcPts val="900"/>
+              </a:spcAft>
+            </a:pPr>
+            <a:r>
+              <a:rPr sz="1800" b="1">
+                <a:solidFill>
+                  <a:srgbClr val="E0A437"/>
+                </a:solidFill>
+                <a:latin typeface="Fira Sans"/>
+              </a:rPr>
+              <a:t>▸ </a:t>
+            </a:r>
+            <a:r>
+              <a:rPr sz="1800" b="0">
+                <a:solidFill>
+                  <a:srgbClr val="000000"/>
+                </a:solidFill>
+                <a:latin typeface="Fira Sans"/>
+              </a:rPr>
+              <a:t>Con distribuciones asimétricas, la mediana y los percentiles describen mejor lo típico que la media.</a:t>
+            </a:r>
+          </a:p>
+          <a:p>
+            <a:pPr>
+              <a:lnSpc>
+                <a:spcPct val="112000"/>
+              </a:lnSpc>
+              <a:spcAft>
+                <a:spcPts val="900"/>
+              </a:spcAft>
+            </a:pPr>
+            <a:r>
+              <a:rPr sz="1800" b="1">
+                <a:solidFill>
+                  <a:srgbClr val="E0A437"/>
+                </a:solidFill>
+                <a:latin typeface="Fira Sans"/>
+              </a:rPr>
+              <a:t>▸ </a:t>
+            </a:r>
+            <a:r>
+              <a:rPr sz="1800" b="0">
+                <a:solidFill>
+                  <a:srgbClr val="000000"/>
+                </a:solidFill>
+                <a:latin typeface="Fira Sans"/>
+              </a:rPr>
+              <a:t>En una encuesta, primero se define la población y luego se pondera por los factores: la cifra ingenua del 23% sin viajes era en realidad un 15%.</a:t>
+            </a:r>
+          </a:p>
+          <a:p>
+            <a:pPr>
+              <a:lnSpc>
+                <a:spcPct val="112000"/>
+              </a:lnSpc>
+              <a:spcAft>
+                <a:spcPts val="900"/>
+              </a:spcAft>
+            </a:pPr>
+            <a:r>
+              <a:rPr sz="1800" b="1">
+                <a:solidFill>
+                  <a:srgbClr val="E0A437"/>
+                </a:solidFill>
+                <a:latin typeface="Fira Sans"/>
+              </a:rPr>
+              <a:t>▸ </a:t>
+            </a:r>
+            <a:r>
+              <a:rPr sz="1800" b="1">
+                <a:solidFill>
+                  <a:srgbClr val="1D3557"/>
+                </a:solidFill>
+                <a:latin typeface="Fira Sans"/>
+              </a:rPr>
+              <a:t>El concepto de la clase: el EDA, examinar los datos antes de modelarlos, preguntando ante cada cifra de quién habla.</a:t>
             </a:r>
           </a:p>
         </p:txBody>
@@ -9195,7 +9069,7 @@
                 </a:solidFill>
                 <a:latin typeface="Fira Sans"/>
               </a:rPr>
-              <a:t>Síntesis</a:t>
+              <a:t>Segundo bloque: comienza la Tarea 1</a:t>
             </a:r>
           </a:p>
         </p:txBody>
@@ -9246,7 +9120,91 @@
                 </a:solidFill>
                 <a:latin typeface="Fira Sans"/>
               </a:rPr>
-              <a:t>Un modelo es una simplificación con decisiones incorporadas; estimarlo puede buscar inferencia o predicción.</a:t>
+              <a:t>El retrato de tu comuna: cada pareja adopta una comuna del Gran Santiago.</a:t>
+            </a:r>
+          </a:p>
+          <a:p>
+            <a:pPr>
+              <a:lnSpc>
+                <a:spcPct val="112000"/>
+              </a:lnSpc>
+              <a:spcAft>
+                <a:spcPts val="500"/>
+              </a:spcAft>
+            </a:pPr>
+            <a:r>
+              <a:rPr sz="1400" b="0">
+                <a:solidFill>
+                  <a:srgbClr val="333333"/>
+                </a:solidFill>
+                <a:latin typeface="Fira Sans"/>
+              </a:rPr>
+              <a:t>     ◦  </a:t>
+            </a:r>
+            <a:r>
+              <a:rPr sz="1400" b="0">
+                <a:solidFill>
+                  <a:srgbClr val="333333"/>
+                </a:solidFill>
+                <a:latin typeface="Fira Sans"/>
+              </a:rPr>
+              <a:t>Hoy: elegir la comuna y construir su retrato numérico.</a:t>
+            </a:r>
+          </a:p>
+          <a:p>
+            <a:pPr>
+              <a:lnSpc>
+                <a:spcPct val="112000"/>
+              </a:lnSpc>
+              <a:spcAft>
+                <a:spcPts val="500"/>
+              </a:spcAft>
+            </a:pPr>
+            <a:r>
+              <a:rPr sz="1400" b="0">
+                <a:solidFill>
+                  <a:srgbClr val="333333"/>
+                </a:solidFill>
+                <a:latin typeface="Fira Sans"/>
+              </a:rPr>
+              <a:t>     ◦  </a:t>
+            </a:r>
+            <a:r>
+              <a:rPr sz="1400" b="0">
+                <a:solidFill>
+                  <a:srgbClr val="333333"/>
+                </a:solidFill>
+                <a:latin typeface="Fira Sans"/>
+              </a:rPr>
+              <a:t>Próxima clase: el retrato gráfico, con métodos de visualización.</a:t>
+            </a:r>
+          </a:p>
+          <a:p>
+            <a:pPr>
+              <a:lnSpc>
+                <a:spcPct val="112000"/>
+              </a:lnSpc>
+              <a:spcAft>
+                <a:spcPts val="500"/>
+              </a:spcAft>
+            </a:pPr>
+            <a:r>
+              <a:rPr sz="1400" b="0">
+                <a:solidFill>
+                  <a:srgbClr val="333333"/>
+                </a:solidFill>
+                <a:latin typeface="Fira Sans"/>
+              </a:rPr>
+              <a:t>     ◦  </a:t>
+            </a:r>
+            <a:r>
+              <a:rPr sz="1400" b="0">
+                <a:solidFill>
+                  <a:srgbClr val="333333"/>
+                </a:solidFill>
+                <a:latin typeface="Fira Sans"/>
+              </a:rPr>
+              <a:t>Entrega del retrato completo: jueves 10 de septiembre, por Aula.</a:t>
             </a:r>
           </a:p>
           <a:p>
@@ -9274,7 +9232,7 @@
                 </a:solidFill>
                 <a:latin typeface="Fira Sans"/>
               </a:rPr>
-              <a:t>Las asociaciones se reportan como asociaciones: la causalidad exige más que datos observacionales.</a:t>
+              <a:t>El enunciado está en evaluaciones/tareas/ y la guía de hoy en actividades/.</a:t>
             </a:r>
           </a:p>
           <a:p>
@@ -9296,97 +9254,13 @@
               <a:t>▸ </a:t>
             </a:r>
             <a:r>
-              <a:rPr sz="1800" b="0">
-                <a:solidFill>
-                  <a:srgbClr val="000000"/>
-                </a:solidFill>
-                <a:latin typeface="Fira Sans"/>
-              </a:rPr>
-              <a:t>El tipo de la variable, no su dtype, determina qué resúmenes tienen sentido.</a:t>
-            </a:r>
-          </a:p>
-          <a:p>
-            <a:pPr>
-              <a:lnSpc>
-                <a:spcPct val="112000"/>
-              </a:lnSpc>
-              <a:spcAft>
-                <a:spcPts val="900"/>
-              </a:spcAft>
-            </a:pPr>
-            <a:r>
               <a:rPr sz="1800" b="1">
                 <a:solidFill>
-                  <a:srgbClr val="E0A437"/>
-                </a:solidFill>
-                <a:latin typeface="Fira Sans"/>
-              </a:rPr>
-              <a:t>▸ </a:t>
-            </a:r>
-            <a:r>
-              <a:rPr sz="1800" b="0">
-                <a:solidFill>
-                  <a:srgbClr val="000000"/>
-                </a:solidFill>
-                <a:latin typeface="Fira Sans"/>
-              </a:rPr>
-              <a:t>Con distribuciones asimétricas, la mediana y los percentiles describen mejor lo típico que la media.</a:t>
-            </a:r>
-          </a:p>
-          <a:p>
-            <a:pPr>
-              <a:lnSpc>
-                <a:spcPct val="112000"/>
-              </a:lnSpc>
-              <a:spcAft>
-                <a:spcPts val="900"/>
-              </a:spcAft>
-            </a:pPr>
-            <a:r>
-              <a:rPr sz="1800" b="1">
-                <a:solidFill>
-                  <a:srgbClr val="E0A437"/>
-                </a:solidFill>
-                <a:latin typeface="Fira Sans"/>
-              </a:rPr>
-              <a:t>▸ </a:t>
-            </a:r>
-            <a:r>
-              <a:rPr sz="1800" b="0">
-                <a:solidFill>
-                  <a:srgbClr val="000000"/>
-                </a:solidFill>
-                <a:latin typeface="Fira Sans"/>
-              </a:rPr>
-              <a:t>En una encuesta, primero se define la población y luego se pondera por los factores: la cifra ingenua del 23% sin viajes era en realidad un 15%.</a:t>
-            </a:r>
-          </a:p>
-          <a:p>
-            <a:pPr>
-              <a:lnSpc>
-                <a:spcPct val="112000"/>
-              </a:lnSpc>
-              <a:spcAft>
-                <a:spcPts val="900"/>
-              </a:spcAft>
-            </a:pPr>
-            <a:r>
-              <a:rPr sz="1800" b="1">
-                <a:solidFill>
-                  <a:srgbClr val="E0A437"/>
-                </a:solidFill>
-                <a:latin typeface="Fira Sans"/>
-              </a:rPr>
-              <a:t>▸ </a:t>
-            </a:r>
-            <a:r>
-              <a:rPr sz="1800" b="1">
-                <a:solidFill>
                   <a:srgbClr val="1D3557"/>
                 </a:solidFill>
                 <a:latin typeface="Fira Sans"/>
               </a:rPr>
-              <a:t>El concepto de la clase: el EDA, examinar los datos antes de modelarlos, preguntando ante cada cifra de quién habla.</a:t>
+              <a:t>Lo que avancen en este bloque ya es parte de la tarea.</a:t>
             </a:r>
           </a:p>
         </p:txBody>
@@ -9400,293 +9274,6 @@
 </file>
 
 <file path=ppt/slides/slide36.xml><?xml version="1.0" encoding="utf-8"?>
-<p:sld xmlns:a="http://schemas.openxmlformats.org/drawingml/2006/main" xmlns:p="http://schemas.openxmlformats.org/presentationml/2006/main" xmlns:r="http://schemas.openxmlformats.org/officeDocument/2006/relationships">
-  <p:cSld>
-    <p:spTree>
-      <p:nvGrpSpPr>
-        <p:cNvPr id="1" name=""/>
-        <p:cNvGrpSpPr/>
-        <p:nvPr/>
-      </p:nvGrpSpPr>
-      <p:grpSpPr/>
-      <p:sp>
-        <p:nvSpPr>
-          <p:cNvPr id="2" name="Rectangle 1"/>
-          <p:cNvSpPr/>
-          <p:nvPr/>
-        </p:nvSpPr>
-        <p:spPr>
-          <a:xfrm>
-            <a:off x="0" y="0"/>
-            <a:ext cx="9144000" cy="5138928"/>
-          </a:xfrm>
-          <a:prstGeom prst="rect">
-            <a:avLst/>
-          </a:prstGeom>
-          <a:solidFill>
-            <a:srgbClr val="FAFBFC"/>
-          </a:solidFill>
-          <a:ln>
-            <a:noFill/>
-          </a:ln>
-          <a:effectLst/>
-        </p:spPr>
-        <p:style>
-          <a:lnRef idx="1">
-            <a:schemeClr val="accent1"/>
-          </a:lnRef>
-          <a:fillRef idx="3">
-            <a:schemeClr val="accent1"/>
-          </a:fillRef>
-          <a:effectRef idx="2">
-            <a:schemeClr val="accent1"/>
-          </a:effectRef>
-          <a:fontRef idx="minor">
-            <a:schemeClr val="lt1"/>
-          </a:fontRef>
-        </p:style>
-        <p:txBody>
-          <a:bodyPr rtlCol="0" anchor="ctr"/>
-          <a:lstStyle/>
-          <a:p>
-            <a:pPr algn="ctr"/>
-          </a:p>
-        </p:txBody>
-      </p:sp>
-      <p:sp>
-        <p:nvSpPr>
-          <p:cNvPr id="3" name="TextBox 2"/>
-          <p:cNvSpPr txBox="1"/>
-          <p:nvPr/>
-        </p:nvSpPr>
-        <p:spPr>
-          <a:xfrm>
-            <a:off x="402336" y="301752"/>
-            <a:ext cx="8348472" cy="795528"/>
-          </a:xfrm>
-          <a:prstGeom prst="rect">
-            <a:avLst/>
-          </a:prstGeom>
-          <a:noFill/>
-        </p:spPr>
-        <p:txBody>
-          <a:bodyPr wrap="square">
-            <a:spAutoFit/>
-          </a:bodyPr>
-          <a:lstStyle/>
-          <a:p>
-            <a:r>
-              <a:rPr sz="2800" b="1">
-                <a:solidFill>
-                  <a:srgbClr val="0F0F0F"/>
-                </a:solidFill>
-                <a:latin typeface="Fira Sans"/>
-              </a:rPr>
-              <a:t>Segundo bloque: comienza la Tarea 1</a:t>
-            </a:r>
-          </a:p>
-        </p:txBody>
-      </p:sp>
-      <p:sp>
-        <p:nvSpPr>
-          <p:cNvPr id="4" name="TextBox 3"/>
-          <p:cNvSpPr txBox="1"/>
-          <p:nvPr/>
-        </p:nvSpPr>
-        <p:spPr>
-          <a:xfrm>
-            <a:off x="704088" y="1353312"/>
-            <a:ext cx="7744968" cy="3300984"/>
-          </a:xfrm>
-          <a:prstGeom prst="rect">
-            <a:avLst/>
-          </a:prstGeom>
-          <a:noFill/>
-        </p:spPr>
-        <p:txBody>
-          <a:bodyPr wrap="square">
-            <a:spAutoFit/>
-          </a:bodyPr>
-          <a:lstStyle/>
-          <a:p>
-            <a:pPr>
-              <a:lnSpc>
-                <a:spcPct val="112000"/>
-              </a:lnSpc>
-              <a:spcAft>
-                <a:spcPts val="900"/>
-              </a:spcAft>
-            </a:pPr>
-            <a:r>
-              <a:rPr sz="1800" b="1">
-                <a:solidFill>
-                  <a:srgbClr val="E0A437"/>
-                </a:solidFill>
-                <a:latin typeface="Fira Sans"/>
-              </a:rPr>
-              <a:t>▸ </a:t>
-            </a:r>
-            <a:r>
-              <a:rPr sz="1800" b="0">
-                <a:solidFill>
-                  <a:srgbClr val="000000"/>
-                </a:solidFill>
-                <a:latin typeface="Fira Sans"/>
-              </a:rPr>
-              <a:t>El retrato de tu comuna: cada pareja adopta una comuna del Gran Santiago.</a:t>
-            </a:r>
-          </a:p>
-          <a:p>
-            <a:pPr>
-              <a:lnSpc>
-                <a:spcPct val="112000"/>
-              </a:lnSpc>
-              <a:spcAft>
-                <a:spcPts val="500"/>
-              </a:spcAft>
-            </a:pPr>
-            <a:r>
-              <a:rPr sz="1400" b="0">
-                <a:solidFill>
-                  <a:srgbClr val="333333"/>
-                </a:solidFill>
-                <a:latin typeface="Fira Sans"/>
-              </a:rPr>
-              <a:t>     ◦  </a:t>
-            </a:r>
-            <a:r>
-              <a:rPr sz="1400" b="0">
-                <a:solidFill>
-                  <a:srgbClr val="333333"/>
-                </a:solidFill>
-                <a:latin typeface="Fira Sans"/>
-              </a:rPr>
-              <a:t>Hoy: elegir la comuna y construir su retrato numérico.</a:t>
-            </a:r>
-          </a:p>
-          <a:p>
-            <a:pPr>
-              <a:lnSpc>
-                <a:spcPct val="112000"/>
-              </a:lnSpc>
-              <a:spcAft>
-                <a:spcPts val="500"/>
-              </a:spcAft>
-            </a:pPr>
-            <a:r>
-              <a:rPr sz="1400" b="0">
-                <a:solidFill>
-                  <a:srgbClr val="333333"/>
-                </a:solidFill>
-                <a:latin typeface="Fira Sans"/>
-              </a:rPr>
-              <a:t>     ◦  </a:t>
-            </a:r>
-            <a:r>
-              <a:rPr sz="1400" b="0">
-                <a:solidFill>
-                  <a:srgbClr val="333333"/>
-                </a:solidFill>
-                <a:latin typeface="Fira Sans"/>
-              </a:rPr>
-              <a:t>Próxima clase: el retrato gráfico, con métodos de visualización.</a:t>
-            </a:r>
-          </a:p>
-          <a:p>
-            <a:pPr>
-              <a:lnSpc>
-                <a:spcPct val="112000"/>
-              </a:lnSpc>
-              <a:spcAft>
-                <a:spcPts val="500"/>
-              </a:spcAft>
-            </a:pPr>
-            <a:r>
-              <a:rPr sz="1400" b="0">
-                <a:solidFill>
-                  <a:srgbClr val="333333"/>
-                </a:solidFill>
-                <a:latin typeface="Fira Sans"/>
-              </a:rPr>
-              <a:t>     ◦  </a:t>
-            </a:r>
-            <a:r>
-              <a:rPr sz="1400" b="0">
-                <a:solidFill>
-                  <a:srgbClr val="333333"/>
-                </a:solidFill>
-                <a:latin typeface="Fira Sans"/>
-              </a:rPr>
-              <a:t>Entrega del retrato completo: jueves 10 de septiembre, por Aula.</a:t>
-            </a:r>
-          </a:p>
-          <a:p>
-            <a:pPr>
-              <a:lnSpc>
-                <a:spcPct val="112000"/>
-              </a:lnSpc>
-              <a:spcAft>
-                <a:spcPts val="900"/>
-              </a:spcAft>
-            </a:pPr>
-            <a:r>
-              <a:rPr sz="1800" b="1">
-                <a:solidFill>
-                  <a:srgbClr val="E0A437"/>
-                </a:solidFill>
-                <a:latin typeface="Fira Sans"/>
-              </a:rPr>
-              <a:t>▸ </a:t>
-            </a:r>
-            <a:r>
-              <a:rPr sz="1800" b="0">
-                <a:solidFill>
-                  <a:srgbClr val="000000"/>
-                </a:solidFill>
-                <a:latin typeface="Fira Sans"/>
-              </a:rPr>
-              <a:t>El enunciado está en evaluaciones/tareas/ y la guía de hoy en actividades/.</a:t>
-            </a:r>
-          </a:p>
-          <a:p>
-            <a:pPr>
-              <a:lnSpc>
-                <a:spcPct val="112000"/>
-              </a:lnSpc>
-              <a:spcAft>
-                <a:spcPts val="900"/>
-              </a:spcAft>
-            </a:pPr>
-            <a:r>
-              <a:rPr sz="1800" b="1">
-                <a:solidFill>
-                  <a:srgbClr val="E0A437"/>
-                </a:solidFill>
-                <a:latin typeface="Fira Sans"/>
-              </a:rPr>
-              <a:t>▸ </a:t>
-            </a:r>
-            <a:r>
-              <a:rPr sz="1800" b="1">
-                <a:solidFill>
-                  <a:srgbClr val="1D3557"/>
-                </a:solidFill>
-                <a:latin typeface="Fira Sans"/>
-              </a:rPr>
-              <a:t>Lo que avancen en este bloque ya es parte de la tarea.</a:t>
-            </a:r>
-          </a:p>
-        </p:txBody>
-      </p:sp>
-    </p:spTree>
-  </p:cSld>
-  <p:clrMapOvr>
-    <a:masterClrMapping/>
-  </p:clrMapOvr>
-</p:sld>
-</file>
-
-<file path=ppt/slides/slide37.xml><?xml version="1.0" encoding="utf-8"?>
 <p:sld xmlns:a="http://schemas.openxmlformats.org/drawingml/2006/main" xmlns:p="http://schemas.openxmlformats.org/presentationml/2006/main" xmlns:r="http://schemas.openxmlformats.org/officeDocument/2006/relationships">
   <p:cSld>
     <p:spTree>

</xml_diff>

<commit_message>
Slides clase 02: quitar viajes por persona
Co-Authored-By: Claude Fable 5 <noreply@anthropic.com>
</commit_message>
<xml_diff>
--- a/presentaciones/clase02_pandas_eda.pptx
+++ b/presentaciones/clase02_pandas_eda.pptx
@@ -40,7 +40,6 @@
     <p:sldId id="288" r:id="rId39"/>
     <p:sldId id="289" r:id="rId40"/>
     <p:sldId id="290" r:id="rId41"/>
-    <p:sldId id="291" r:id="rId42"/>
   </p:sldIdLst>
   <p:sldSz cx="9144000" cy="5138928" type="screen4x3"/>
   <p:notesSz cx="6858000" cy="9144000"/>
@@ -7703,7 +7702,7 @@
                 </a:solidFill>
                 <a:latin typeface="Fira Sans"/>
               </a:rPr>
-              <a:t>Viajes por persona: los ausentes también cuentan</a:t>
+              <a:t>El ingreso de los hogares: media y mediana</a:t>
             </a:r>
           </a:p>
         </p:txBody>
@@ -7754,7 +7753,7 @@
                 </a:solidFill>
                 <a:latin typeface="Fira Sans"/>
               </a:rPr>
-              <a:t>Quien no viajó no está en la tabla de viajes: hay que reincorporarlo antes de calcular.</a:t>
+              <a:t>Ponderado por el factor del hogar: media $729.898, mediana $520.000.</a:t>
             </a:r>
           </a:p>
           <a:p>
@@ -7782,7 +7781,7 @@
                 </a:solidFill>
                 <a:latin typeface="Fira Sans"/>
               </a:rPr>
-              <a:t>Ponderado: el 15% de las personas no viajó; media de 2,2 viajes, mediana de 2.</a:t>
+              <a:t>La media es un 40% más alta que la mediana.</a:t>
             </a:r>
           </a:p>
           <a:p>
@@ -7810,7 +7809,7 @@
                 </a:solidFill>
                 <a:latin typeface="Fira Sans"/>
               </a:rPr>
-              <a:t>El 59% de la población hace exactamente 2 viajes: la ida y la vuelta.</a:t>
+              <a:t>Los ingresos altos desplazan el promedio; la mayoría gana menos.</a:t>
             </a:r>
           </a:p>
           <a:p>
@@ -7838,14 +7837,14 @@
                 </a:solidFill>
                 <a:latin typeface="Fira Sans"/>
               </a:rPr>
-              <a:t>La cifra ingenua decía 23%: mezclaba días de fin de semana y omitía los factores.</a:t>
+              <a:t>El promedio describe una situación en la que la mayoría no está.</a:t>
             </a:r>
           </a:p>
         </p:txBody>
       </p:sp>
       <p:pic>
         <p:nvPicPr>
-          <p:cNvPr id="5" name="Picture 4" descr="02_viajes_por_persona.png"/>
+          <p:cNvPr id="5" name="Picture 4" descr="01_ingreso_media_mediana.png"/>
           <p:cNvPicPr>
             <a:picLocks noChangeAspect="1"/>
           </p:cNvPicPr>
@@ -7860,7 +7859,7 @@
         <p:spPr>
           <a:xfrm>
             <a:off x="4892040" y="1371600"/>
-            <a:ext cx="3840480" cy="2335791"/>
+            <a:ext cx="3840480" cy="2119546"/>
           </a:xfrm>
           <a:prstGeom prst="rect">
             <a:avLst/>
@@ -8065,149 +8064,14 @@
                 </a:solidFill>
                 <a:latin typeface="Fira Sans"/>
               </a:rPr>
-              <a:t>El ingreso de los hogares: media y mediana</a:t>
-            </a:r>
-          </a:p>
-        </p:txBody>
-      </p:sp>
-      <p:sp>
-        <p:nvSpPr>
-          <p:cNvPr id="4" name="TextBox 3"/>
-          <p:cNvSpPr txBox="1"/>
-          <p:nvPr/>
-        </p:nvSpPr>
-        <p:spPr>
-          <a:xfrm>
-            <a:off x="502920" y="1252728"/>
-            <a:ext cx="4023360" cy="3200400"/>
-          </a:xfrm>
-          <a:prstGeom prst="rect">
-            <a:avLst/>
-          </a:prstGeom>
-          <a:noFill/>
-        </p:spPr>
-        <p:txBody>
-          <a:bodyPr wrap="square">
-            <a:spAutoFit/>
-          </a:bodyPr>
-          <a:lstStyle/>
-          <a:p>
-            <a:pPr>
-              <a:lnSpc>
-                <a:spcPct val="112000"/>
-              </a:lnSpc>
-              <a:spcAft>
-                <a:spcPts val="900"/>
-              </a:spcAft>
-            </a:pPr>
-            <a:r>
-              <a:rPr sz="1500" b="1">
-                <a:solidFill>
-                  <a:srgbClr val="E0A437"/>
-                </a:solidFill>
-                <a:latin typeface="Fira Sans"/>
-              </a:rPr>
-              <a:t>▸ </a:t>
-            </a:r>
-            <a:r>
-              <a:rPr sz="1500" b="0">
-                <a:solidFill>
-                  <a:srgbClr val="000000"/>
-                </a:solidFill>
-                <a:latin typeface="Fira Sans"/>
-              </a:rPr>
-              <a:t>Ponderado por el factor del hogar: media $729.898, mediana $520.000.</a:t>
-            </a:r>
-          </a:p>
-          <a:p>
-            <a:pPr>
-              <a:lnSpc>
-                <a:spcPct val="112000"/>
-              </a:lnSpc>
-              <a:spcAft>
-                <a:spcPts val="900"/>
-              </a:spcAft>
-            </a:pPr>
-            <a:r>
-              <a:rPr sz="1500" b="1">
-                <a:solidFill>
-                  <a:srgbClr val="E0A437"/>
-                </a:solidFill>
-                <a:latin typeface="Fira Sans"/>
-              </a:rPr>
-              <a:t>▸ </a:t>
-            </a:r>
-            <a:r>
-              <a:rPr sz="1500" b="0">
-                <a:solidFill>
-                  <a:srgbClr val="000000"/>
-                </a:solidFill>
-                <a:latin typeface="Fira Sans"/>
-              </a:rPr>
-              <a:t>La media es un 40% más alta que la mediana.</a:t>
-            </a:r>
-          </a:p>
-          <a:p>
-            <a:pPr>
-              <a:lnSpc>
-                <a:spcPct val="112000"/>
-              </a:lnSpc>
-              <a:spcAft>
-                <a:spcPts val="900"/>
-              </a:spcAft>
-            </a:pPr>
-            <a:r>
-              <a:rPr sz="1500" b="1">
-                <a:solidFill>
-                  <a:srgbClr val="E0A437"/>
-                </a:solidFill>
-                <a:latin typeface="Fira Sans"/>
-              </a:rPr>
-              <a:t>▸ </a:t>
-            </a:r>
-            <a:r>
-              <a:rPr sz="1500" b="0">
-                <a:solidFill>
-                  <a:srgbClr val="000000"/>
-                </a:solidFill>
-                <a:latin typeface="Fira Sans"/>
-              </a:rPr>
-              <a:t>Los ingresos altos desplazan el promedio; la mayoría gana menos.</a:t>
-            </a:r>
-          </a:p>
-          <a:p>
-            <a:pPr>
-              <a:lnSpc>
-                <a:spcPct val="112000"/>
-              </a:lnSpc>
-              <a:spcAft>
-                <a:spcPts val="900"/>
-              </a:spcAft>
-            </a:pPr>
-            <a:r>
-              <a:rPr sz="1500" b="1">
-                <a:solidFill>
-                  <a:srgbClr val="E0A437"/>
-                </a:solidFill>
-                <a:latin typeface="Fira Sans"/>
-              </a:rPr>
-              <a:t>▸ </a:t>
-            </a:r>
-            <a:r>
-              <a:rPr sz="1500" b="1">
-                <a:solidFill>
-                  <a:srgbClr val="1D3557"/>
-                </a:solidFill>
-                <a:latin typeface="Fira Sans"/>
-              </a:rPr>
-              <a:t>El promedio describe una situación en la que la mayoría no está.</a:t>
+              <a:t>El reparto modal difiere entre comunas</a:t>
             </a:r>
           </a:p>
         </p:txBody>
       </p:sp>
       <p:pic>
         <p:nvPicPr>
-          <p:cNvPr id="5" name="Picture 4" descr="01_ingreso_media_mediana.png"/>
+          <p:cNvPr id="4" name="Picture 3" descr="08_modo_por_comuna.png"/>
           <p:cNvPicPr>
             <a:picLocks noChangeAspect="1"/>
           </p:cNvPicPr>
@@ -8221,14 +8085,48 @@
         </p:blipFill>
         <p:spPr>
           <a:xfrm>
-            <a:off x="4892040" y="1371600"/>
-            <a:ext cx="3840480" cy="2119546"/>
+            <a:off x="1994250" y="1143000"/>
+            <a:ext cx="5155498" cy="3154679"/>
           </a:xfrm>
           <a:prstGeom prst="rect">
             <a:avLst/>
           </a:prstGeom>
         </p:spPr>
       </p:pic>
+      <p:sp>
+        <p:nvSpPr>
+          <p:cNvPr id="5" name="TextBox 4"/>
+          <p:cNvSpPr txBox="1"/>
+          <p:nvPr/>
+        </p:nvSpPr>
+        <p:spPr>
+          <a:xfrm>
+            <a:off x="704088" y="4434840"/>
+            <a:ext cx="7744968" cy="457200"/>
+          </a:xfrm>
+          <a:prstGeom prst="rect">
+            <a:avLst/>
+          </a:prstGeom>
+          <a:noFill/>
+        </p:spPr>
+        <p:txBody>
+          <a:bodyPr wrap="square">
+            <a:spAutoFit/>
+          </a:bodyPr>
+          <a:lstStyle/>
+          <a:p>
+            <a:r>
+              <a:rPr sz="1300" b="0">
+                <a:solidFill>
+                  <a:srgbClr val="333333"/>
+                </a:solidFill>
+                <a:latin typeface="Fira Sans"/>
+              </a:rPr>
+              <a:t>Normalizar por comuna permite comparar proporciones entre comunas de tamaños muy distintos.</a:t>
+            </a:r>
+          </a:p>
+        </p:txBody>
+      </p:sp>
     </p:spTree>
   </p:cSld>
   <p:clrMapOvr>
@@ -8320,14 +8218,14 @@
                 </a:solidFill>
                 <a:latin typeface="Fira Sans"/>
               </a:rPr>
-              <a:t>El reparto modal difiere entre comunas</a:t>
+              <a:t>Los propósitos de viaje según el día de la semana</a:t>
             </a:r>
           </a:p>
         </p:txBody>
       </p:sp>
       <p:pic>
         <p:nvPicPr>
-          <p:cNvPr id="4" name="Picture 3" descr="08_modo_por_comuna.png"/>
+          <p:cNvPr id="4" name="Picture 3" descr="10_heatmap_rutinas.png"/>
           <p:cNvPicPr>
             <a:picLocks noChangeAspect="1"/>
           </p:cNvPicPr>
@@ -8341,8 +8239,8 @@
         </p:blipFill>
         <p:spPr>
           <a:xfrm>
-            <a:off x="1994250" y="1143000"/>
-            <a:ext cx="5155498" cy="3154679"/>
+            <a:off x="1649319" y="1143000"/>
+            <a:ext cx="5845360" cy="3154680"/>
           </a:xfrm>
           <a:prstGeom prst="rect">
             <a:avLst/>
@@ -8378,7 +8276,7 @@
                 </a:solidFill>
                 <a:latin typeface="Fira Sans"/>
               </a:rPr>
-              <a:t>Normalizar por comuna permite comparar proporciones entre comunas de tamaños muy distintos.</a:t>
+              <a:t>El heatmap muestra 14 propósitos por 7 días en una sola figura: útil para tablas completas.</a:t>
             </a:r>
           </a:p>
         </p:txBody>
@@ -8474,14 +8372,14 @@
                 </a:solidFill>
                 <a:latin typeface="Fira Sans"/>
               </a:rPr>
-              <a:t>Los propósitos de viaje según el día de la semana</a:t>
+              <a:t>Cuando los datos crecen</a:t>
             </a:r>
           </a:p>
         </p:txBody>
       </p:sp>
       <p:pic>
         <p:nvPicPr>
-          <p:cNvPr id="4" name="Picture 3" descr="10_heatmap_rutinas.png"/>
+          <p:cNvPr id="4" name="Picture 3" descr="14_escala_datos.png"/>
           <p:cNvPicPr>
             <a:picLocks noChangeAspect="1"/>
           </p:cNvPicPr>
@@ -8495,8 +8393,8 @@
         </p:blipFill>
         <p:spPr>
           <a:xfrm>
-            <a:off x="1649319" y="1143000"/>
-            <a:ext cx="5845360" cy="3154680"/>
+            <a:off x="1417319" y="1143000"/>
+            <a:ext cx="6309360" cy="2324913"/>
           </a:xfrm>
           <a:prstGeom prst="rect">
             <a:avLst/>
@@ -8532,7 +8430,7 @@
                 </a:solidFill>
                 <a:latin typeface="Fira Sans"/>
               </a:rPr>
-              <a:t>El heatmap muestra 14 propósitos por 7 días en una sola figura: útil para tablas completas.</a:t>
+              <a:t>PySpark se usa con SQL o con sus propios DataFrames; Dask reparte operaciones estilo Pandas; Polars y DuckDB rinden en una sola máquina.</a:t>
             </a:r>
           </a:p>
         </p:txBody>
@@ -8628,45 +8526,21 @@
                 </a:solidFill>
                 <a:latin typeface="Fira Sans"/>
               </a:rPr>
-              <a:t>Cuando los datos crecen</a:t>
-            </a:r>
-          </a:p>
-        </p:txBody>
-      </p:sp>
-      <p:pic>
-        <p:nvPicPr>
-          <p:cNvPr id="4" name="Picture 3" descr="14_escala_datos.png"/>
-          <p:cNvPicPr>
-            <a:picLocks noChangeAspect="1"/>
-          </p:cNvPicPr>
-          <p:nvPr/>
-        </p:nvPicPr>
-        <p:blipFill>
-          <a:blip r:embed="rId2"/>
-          <a:stretch>
-            <a:fillRect/>
-          </a:stretch>
-        </p:blipFill>
-        <p:spPr>
-          <a:xfrm>
-            <a:off x="1417319" y="1143000"/>
-            <a:ext cx="6309360" cy="2324913"/>
-          </a:xfrm>
-          <a:prstGeom prst="rect">
-            <a:avLst/>
-          </a:prstGeom>
-        </p:spPr>
-      </p:pic>
-      <p:sp>
-        <p:nvSpPr>
-          <p:cNvPr id="5" name="TextBox 4"/>
+              <a:t>Síntesis</a:t>
+            </a:r>
+          </a:p>
+        </p:txBody>
+      </p:sp>
+      <p:sp>
+        <p:nvSpPr>
+          <p:cNvPr id="4" name="TextBox 3"/>
           <p:cNvSpPr txBox="1"/>
           <p:nvPr/>
         </p:nvSpPr>
         <p:spPr>
           <a:xfrm>
-            <a:off x="704088" y="4434840"/>
-            <a:ext cx="7744968" cy="457200"/>
+            <a:off x="704088" y="1353312"/>
+            <a:ext cx="7744968" cy="3300984"/>
           </a:xfrm>
           <a:prstGeom prst="rect">
             <a:avLst/>
@@ -8679,14 +8553,171 @@
           </a:bodyPr>
           <a:lstStyle/>
           <a:p>
-            <a:r>
-              <a:rPr sz="1300" b="0">
-                <a:solidFill>
-                  <a:srgbClr val="333333"/>
-                </a:solidFill>
-                <a:latin typeface="Fira Sans"/>
-              </a:rPr>
-              <a:t>PySpark se usa con SQL o con sus propios DataFrames; Dask reparte operaciones estilo Pandas; Polars y DuckDB rinden en una sola máquina.</a:t>
+            <a:pPr>
+              <a:lnSpc>
+                <a:spcPct val="112000"/>
+              </a:lnSpc>
+              <a:spcAft>
+                <a:spcPts val="900"/>
+              </a:spcAft>
+            </a:pPr>
+            <a:r>
+              <a:rPr sz="1800" b="1">
+                <a:solidFill>
+                  <a:srgbClr val="E0A437"/>
+                </a:solidFill>
+                <a:latin typeface="Fira Sans"/>
+              </a:rPr>
+              <a:t>▸ </a:t>
+            </a:r>
+            <a:r>
+              <a:rPr sz="1800" b="0">
+                <a:solidFill>
+                  <a:srgbClr val="000000"/>
+                </a:solidFill>
+                <a:latin typeface="Fira Sans"/>
+              </a:rPr>
+              <a:t>Un modelo es una simplificación con decisiones incorporadas; estimarlo puede buscar inferencia o predicción.</a:t>
+            </a:r>
+          </a:p>
+          <a:p>
+            <a:pPr>
+              <a:lnSpc>
+                <a:spcPct val="112000"/>
+              </a:lnSpc>
+              <a:spcAft>
+                <a:spcPts val="900"/>
+              </a:spcAft>
+            </a:pPr>
+            <a:r>
+              <a:rPr sz="1800" b="1">
+                <a:solidFill>
+                  <a:srgbClr val="E0A437"/>
+                </a:solidFill>
+                <a:latin typeface="Fira Sans"/>
+              </a:rPr>
+              <a:t>▸ </a:t>
+            </a:r>
+            <a:r>
+              <a:rPr sz="1800" b="0">
+                <a:solidFill>
+                  <a:srgbClr val="000000"/>
+                </a:solidFill>
+                <a:latin typeface="Fira Sans"/>
+              </a:rPr>
+              <a:t>Las asociaciones se reportan como asociaciones: la causalidad exige más que datos observacionales.</a:t>
+            </a:r>
+          </a:p>
+          <a:p>
+            <a:pPr>
+              <a:lnSpc>
+                <a:spcPct val="112000"/>
+              </a:lnSpc>
+              <a:spcAft>
+                <a:spcPts val="900"/>
+              </a:spcAft>
+            </a:pPr>
+            <a:r>
+              <a:rPr sz="1800" b="1">
+                <a:solidFill>
+                  <a:srgbClr val="E0A437"/>
+                </a:solidFill>
+                <a:latin typeface="Fira Sans"/>
+              </a:rPr>
+              <a:t>▸ </a:t>
+            </a:r>
+            <a:r>
+              <a:rPr sz="1800" b="0">
+                <a:solidFill>
+                  <a:srgbClr val="000000"/>
+                </a:solidFill>
+                <a:latin typeface="Fira Sans"/>
+              </a:rPr>
+              <a:t>El tipo de la variable, no su dtype, determina qué resúmenes tienen sentido.</a:t>
+            </a:r>
+          </a:p>
+          <a:p>
+            <a:pPr>
+              <a:lnSpc>
+                <a:spcPct val="112000"/>
+              </a:lnSpc>
+              <a:spcAft>
+                <a:spcPts val="900"/>
+              </a:spcAft>
+            </a:pPr>
+            <a:r>
+              <a:rPr sz="1800" b="1">
+                <a:solidFill>
+                  <a:srgbClr val="E0A437"/>
+                </a:solidFill>
+                <a:latin typeface="Fira Sans"/>
+              </a:rPr>
+              <a:t>▸ </a:t>
+            </a:r>
+            <a:r>
+              <a:rPr sz="1800" b="0">
+                <a:solidFill>
+                  <a:srgbClr val="000000"/>
+                </a:solidFill>
+                <a:latin typeface="Fira Sans"/>
+              </a:rPr>
+              <a:t>Con distribuciones asimétricas, la mediana y los percentiles describen mejor lo típico que la media.</a:t>
+            </a:r>
+          </a:p>
+          <a:p>
+            <a:pPr>
+              <a:lnSpc>
+                <a:spcPct val="112000"/>
+              </a:lnSpc>
+              <a:spcAft>
+                <a:spcPts val="900"/>
+              </a:spcAft>
+            </a:pPr>
+            <a:r>
+              <a:rPr sz="1800" b="1">
+                <a:solidFill>
+                  <a:srgbClr val="E0A437"/>
+                </a:solidFill>
+                <a:latin typeface="Fira Sans"/>
+              </a:rPr>
+              <a:t>▸ </a:t>
+            </a:r>
+            <a:r>
+              <a:rPr sz="1800" b="0">
+                <a:solidFill>
+                  <a:srgbClr val="000000"/>
+                </a:solidFill>
+                <a:latin typeface="Fira Sans"/>
+              </a:rPr>
+              <a:t>En una encuesta, primero se define la población y luego se pondera por los factores: la cifra ingenua del 23% sin viajes era en realidad un 15%.</a:t>
+            </a:r>
+          </a:p>
+          <a:p>
+            <a:pPr>
+              <a:lnSpc>
+                <a:spcPct val="112000"/>
+              </a:lnSpc>
+              <a:spcAft>
+                <a:spcPts val="900"/>
+              </a:spcAft>
+            </a:pPr>
+            <a:r>
+              <a:rPr sz="1800" b="1">
+                <a:solidFill>
+                  <a:srgbClr val="E0A437"/>
+                </a:solidFill>
+                <a:latin typeface="Fira Sans"/>
+              </a:rPr>
+              <a:t>▸ </a:t>
+            </a:r>
+            <a:r>
+              <a:rPr sz="1800" b="1">
+                <a:solidFill>
+                  <a:srgbClr val="1D3557"/>
+                </a:solidFill>
+                <a:latin typeface="Fira Sans"/>
+              </a:rPr>
+              <a:t>El concepto de la clase: el EDA, examinar los datos antes de modelarlos, preguntando ante cada cifra de quién habla.</a:t>
             </a:r>
           </a:p>
         </p:txBody>
@@ -8782,7 +8813,7 @@
                 </a:solidFill>
                 <a:latin typeface="Fira Sans"/>
               </a:rPr>
-              <a:t>Síntesis</a:t>
+              <a:t>Segundo bloque: comienza la Tarea 1</a:t>
             </a:r>
           </a:p>
         </p:txBody>
@@ -8833,7 +8864,91 @@
                 </a:solidFill>
                 <a:latin typeface="Fira Sans"/>
               </a:rPr>
-              <a:t>Un modelo es una simplificación con decisiones incorporadas; estimarlo puede buscar inferencia o predicción.</a:t>
+              <a:t>El retrato de tu comuna: cada pareja adopta una comuna del Gran Santiago.</a:t>
+            </a:r>
+          </a:p>
+          <a:p>
+            <a:pPr>
+              <a:lnSpc>
+                <a:spcPct val="112000"/>
+              </a:lnSpc>
+              <a:spcAft>
+                <a:spcPts val="500"/>
+              </a:spcAft>
+            </a:pPr>
+            <a:r>
+              <a:rPr sz="1400" b="0">
+                <a:solidFill>
+                  <a:srgbClr val="333333"/>
+                </a:solidFill>
+                <a:latin typeface="Fira Sans"/>
+              </a:rPr>
+              <a:t>     ◦  </a:t>
+            </a:r>
+            <a:r>
+              <a:rPr sz="1400" b="0">
+                <a:solidFill>
+                  <a:srgbClr val="333333"/>
+                </a:solidFill>
+                <a:latin typeface="Fira Sans"/>
+              </a:rPr>
+              <a:t>Hoy: elegir la comuna y construir su retrato numérico.</a:t>
+            </a:r>
+          </a:p>
+          <a:p>
+            <a:pPr>
+              <a:lnSpc>
+                <a:spcPct val="112000"/>
+              </a:lnSpc>
+              <a:spcAft>
+                <a:spcPts val="500"/>
+              </a:spcAft>
+            </a:pPr>
+            <a:r>
+              <a:rPr sz="1400" b="0">
+                <a:solidFill>
+                  <a:srgbClr val="333333"/>
+                </a:solidFill>
+                <a:latin typeface="Fira Sans"/>
+              </a:rPr>
+              <a:t>     ◦  </a:t>
+            </a:r>
+            <a:r>
+              <a:rPr sz="1400" b="0">
+                <a:solidFill>
+                  <a:srgbClr val="333333"/>
+                </a:solidFill>
+                <a:latin typeface="Fira Sans"/>
+              </a:rPr>
+              <a:t>Próxima clase: el retrato gráfico, con métodos de visualización.</a:t>
+            </a:r>
+          </a:p>
+          <a:p>
+            <a:pPr>
+              <a:lnSpc>
+                <a:spcPct val="112000"/>
+              </a:lnSpc>
+              <a:spcAft>
+                <a:spcPts val="500"/>
+              </a:spcAft>
+            </a:pPr>
+            <a:r>
+              <a:rPr sz="1400" b="0">
+                <a:solidFill>
+                  <a:srgbClr val="333333"/>
+                </a:solidFill>
+                <a:latin typeface="Fira Sans"/>
+              </a:rPr>
+              <a:t>     ◦  </a:t>
+            </a:r>
+            <a:r>
+              <a:rPr sz="1400" b="0">
+                <a:solidFill>
+                  <a:srgbClr val="333333"/>
+                </a:solidFill>
+                <a:latin typeface="Fira Sans"/>
+              </a:rPr>
+              <a:t>Entrega del retrato completo: jueves 10 de septiembre, por Aula.</a:t>
             </a:r>
           </a:p>
           <a:p>
@@ -8861,7 +8976,7 @@
                 </a:solidFill>
                 <a:latin typeface="Fira Sans"/>
               </a:rPr>
-              <a:t>Las asociaciones se reportan como asociaciones: la causalidad exige más que datos observacionales.</a:t>
+              <a:t>El enunciado está en evaluaciones/tareas/ y la guía de hoy en actividades/.</a:t>
             </a:r>
           </a:p>
           <a:p>
@@ -8883,97 +8998,13 @@
               <a:t>▸ </a:t>
             </a:r>
             <a:r>
-              <a:rPr sz="1800" b="0">
-                <a:solidFill>
-                  <a:srgbClr val="000000"/>
-                </a:solidFill>
-                <a:latin typeface="Fira Sans"/>
-              </a:rPr>
-              <a:t>El tipo de la variable, no su dtype, determina qué resúmenes tienen sentido.</a:t>
-            </a:r>
-          </a:p>
-          <a:p>
-            <a:pPr>
-              <a:lnSpc>
-                <a:spcPct val="112000"/>
-              </a:lnSpc>
-              <a:spcAft>
-                <a:spcPts val="900"/>
-              </a:spcAft>
-            </a:pPr>
-            <a:r>
               <a:rPr sz="1800" b="1">
                 <a:solidFill>
-                  <a:srgbClr val="E0A437"/>
-                </a:solidFill>
-                <a:latin typeface="Fira Sans"/>
-              </a:rPr>
-              <a:t>▸ </a:t>
-            </a:r>
-            <a:r>
-              <a:rPr sz="1800" b="0">
-                <a:solidFill>
-                  <a:srgbClr val="000000"/>
-                </a:solidFill>
-                <a:latin typeface="Fira Sans"/>
-              </a:rPr>
-              <a:t>Con distribuciones asimétricas, la mediana y los percentiles describen mejor lo típico que la media.</a:t>
-            </a:r>
-          </a:p>
-          <a:p>
-            <a:pPr>
-              <a:lnSpc>
-                <a:spcPct val="112000"/>
-              </a:lnSpc>
-              <a:spcAft>
-                <a:spcPts val="900"/>
-              </a:spcAft>
-            </a:pPr>
-            <a:r>
-              <a:rPr sz="1800" b="1">
-                <a:solidFill>
-                  <a:srgbClr val="E0A437"/>
-                </a:solidFill>
-                <a:latin typeface="Fira Sans"/>
-              </a:rPr>
-              <a:t>▸ </a:t>
-            </a:r>
-            <a:r>
-              <a:rPr sz="1800" b="0">
-                <a:solidFill>
-                  <a:srgbClr val="000000"/>
-                </a:solidFill>
-                <a:latin typeface="Fira Sans"/>
-              </a:rPr>
-              <a:t>En una encuesta, primero se define la población y luego se pondera por los factores: la cifra ingenua del 23% sin viajes era en realidad un 15%.</a:t>
-            </a:r>
-          </a:p>
-          <a:p>
-            <a:pPr>
-              <a:lnSpc>
-                <a:spcPct val="112000"/>
-              </a:lnSpc>
-              <a:spcAft>
-                <a:spcPts val="900"/>
-              </a:spcAft>
-            </a:pPr>
-            <a:r>
-              <a:rPr sz="1800" b="1">
-                <a:solidFill>
-                  <a:srgbClr val="E0A437"/>
-                </a:solidFill>
-                <a:latin typeface="Fira Sans"/>
-              </a:rPr>
-              <a:t>▸ </a:t>
-            </a:r>
-            <a:r>
-              <a:rPr sz="1800" b="1">
-                <a:solidFill>
                   <a:srgbClr val="1D3557"/>
                 </a:solidFill>
                 <a:latin typeface="Fira Sans"/>
               </a:rPr>
-              <a:t>El concepto de la clase: el EDA, examinar los datos antes de modelarlos, preguntando ante cada cifra de quién habla.</a:t>
+              <a:t>Lo que avancen en este bloque ya es parte de la tarea.</a:t>
             </a:r>
           </a:p>
         </p:txBody>
@@ -8987,293 +9018,6 @@
 </file>
 
 <file path=ppt/slides/slide35.xml><?xml version="1.0" encoding="utf-8"?>
-<p:sld xmlns:a="http://schemas.openxmlformats.org/drawingml/2006/main" xmlns:p="http://schemas.openxmlformats.org/presentationml/2006/main" xmlns:r="http://schemas.openxmlformats.org/officeDocument/2006/relationships">
-  <p:cSld>
-    <p:spTree>
-      <p:nvGrpSpPr>
-        <p:cNvPr id="1" name=""/>
-        <p:cNvGrpSpPr/>
-        <p:nvPr/>
-      </p:nvGrpSpPr>
-      <p:grpSpPr/>
-      <p:sp>
-        <p:nvSpPr>
-          <p:cNvPr id="2" name="Rectangle 1"/>
-          <p:cNvSpPr/>
-          <p:nvPr/>
-        </p:nvSpPr>
-        <p:spPr>
-          <a:xfrm>
-            <a:off x="0" y="0"/>
-            <a:ext cx="9144000" cy="5138928"/>
-          </a:xfrm>
-          <a:prstGeom prst="rect">
-            <a:avLst/>
-          </a:prstGeom>
-          <a:solidFill>
-            <a:srgbClr val="FAFBFC"/>
-          </a:solidFill>
-          <a:ln>
-            <a:noFill/>
-          </a:ln>
-          <a:effectLst/>
-        </p:spPr>
-        <p:style>
-          <a:lnRef idx="1">
-            <a:schemeClr val="accent1"/>
-          </a:lnRef>
-          <a:fillRef idx="3">
-            <a:schemeClr val="accent1"/>
-          </a:fillRef>
-          <a:effectRef idx="2">
-            <a:schemeClr val="accent1"/>
-          </a:effectRef>
-          <a:fontRef idx="minor">
-            <a:schemeClr val="lt1"/>
-          </a:fontRef>
-        </p:style>
-        <p:txBody>
-          <a:bodyPr rtlCol="0" anchor="ctr"/>
-          <a:lstStyle/>
-          <a:p>
-            <a:pPr algn="ctr"/>
-          </a:p>
-        </p:txBody>
-      </p:sp>
-      <p:sp>
-        <p:nvSpPr>
-          <p:cNvPr id="3" name="TextBox 2"/>
-          <p:cNvSpPr txBox="1"/>
-          <p:nvPr/>
-        </p:nvSpPr>
-        <p:spPr>
-          <a:xfrm>
-            <a:off x="402336" y="301752"/>
-            <a:ext cx="8348472" cy="795528"/>
-          </a:xfrm>
-          <a:prstGeom prst="rect">
-            <a:avLst/>
-          </a:prstGeom>
-          <a:noFill/>
-        </p:spPr>
-        <p:txBody>
-          <a:bodyPr wrap="square">
-            <a:spAutoFit/>
-          </a:bodyPr>
-          <a:lstStyle/>
-          <a:p>
-            <a:r>
-              <a:rPr sz="2800" b="1">
-                <a:solidFill>
-                  <a:srgbClr val="0F0F0F"/>
-                </a:solidFill>
-                <a:latin typeface="Fira Sans"/>
-              </a:rPr>
-              <a:t>Segundo bloque: comienza la Tarea 1</a:t>
-            </a:r>
-          </a:p>
-        </p:txBody>
-      </p:sp>
-      <p:sp>
-        <p:nvSpPr>
-          <p:cNvPr id="4" name="TextBox 3"/>
-          <p:cNvSpPr txBox="1"/>
-          <p:nvPr/>
-        </p:nvSpPr>
-        <p:spPr>
-          <a:xfrm>
-            <a:off x="704088" y="1353312"/>
-            <a:ext cx="7744968" cy="3300984"/>
-          </a:xfrm>
-          <a:prstGeom prst="rect">
-            <a:avLst/>
-          </a:prstGeom>
-          <a:noFill/>
-        </p:spPr>
-        <p:txBody>
-          <a:bodyPr wrap="square">
-            <a:spAutoFit/>
-          </a:bodyPr>
-          <a:lstStyle/>
-          <a:p>
-            <a:pPr>
-              <a:lnSpc>
-                <a:spcPct val="112000"/>
-              </a:lnSpc>
-              <a:spcAft>
-                <a:spcPts val="900"/>
-              </a:spcAft>
-            </a:pPr>
-            <a:r>
-              <a:rPr sz="1800" b="1">
-                <a:solidFill>
-                  <a:srgbClr val="E0A437"/>
-                </a:solidFill>
-                <a:latin typeface="Fira Sans"/>
-              </a:rPr>
-              <a:t>▸ </a:t>
-            </a:r>
-            <a:r>
-              <a:rPr sz="1800" b="0">
-                <a:solidFill>
-                  <a:srgbClr val="000000"/>
-                </a:solidFill>
-                <a:latin typeface="Fira Sans"/>
-              </a:rPr>
-              <a:t>El retrato de tu comuna: cada pareja adopta una comuna del Gran Santiago.</a:t>
-            </a:r>
-          </a:p>
-          <a:p>
-            <a:pPr>
-              <a:lnSpc>
-                <a:spcPct val="112000"/>
-              </a:lnSpc>
-              <a:spcAft>
-                <a:spcPts val="500"/>
-              </a:spcAft>
-            </a:pPr>
-            <a:r>
-              <a:rPr sz="1400" b="0">
-                <a:solidFill>
-                  <a:srgbClr val="333333"/>
-                </a:solidFill>
-                <a:latin typeface="Fira Sans"/>
-              </a:rPr>
-              <a:t>     ◦  </a:t>
-            </a:r>
-            <a:r>
-              <a:rPr sz="1400" b="0">
-                <a:solidFill>
-                  <a:srgbClr val="333333"/>
-                </a:solidFill>
-                <a:latin typeface="Fira Sans"/>
-              </a:rPr>
-              <a:t>Hoy: elegir la comuna y construir su retrato numérico.</a:t>
-            </a:r>
-          </a:p>
-          <a:p>
-            <a:pPr>
-              <a:lnSpc>
-                <a:spcPct val="112000"/>
-              </a:lnSpc>
-              <a:spcAft>
-                <a:spcPts val="500"/>
-              </a:spcAft>
-            </a:pPr>
-            <a:r>
-              <a:rPr sz="1400" b="0">
-                <a:solidFill>
-                  <a:srgbClr val="333333"/>
-                </a:solidFill>
-                <a:latin typeface="Fira Sans"/>
-              </a:rPr>
-              <a:t>     ◦  </a:t>
-            </a:r>
-            <a:r>
-              <a:rPr sz="1400" b="0">
-                <a:solidFill>
-                  <a:srgbClr val="333333"/>
-                </a:solidFill>
-                <a:latin typeface="Fira Sans"/>
-              </a:rPr>
-              <a:t>Próxima clase: el retrato gráfico, con métodos de visualización.</a:t>
-            </a:r>
-          </a:p>
-          <a:p>
-            <a:pPr>
-              <a:lnSpc>
-                <a:spcPct val="112000"/>
-              </a:lnSpc>
-              <a:spcAft>
-                <a:spcPts val="500"/>
-              </a:spcAft>
-            </a:pPr>
-            <a:r>
-              <a:rPr sz="1400" b="0">
-                <a:solidFill>
-                  <a:srgbClr val="333333"/>
-                </a:solidFill>
-                <a:latin typeface="Fira Sans"/>
-              </a:rPr>
-              <a:t>     ◦  </a:t>
-            </a:r>
-            <a:r>
-              <a:rPr sz="1400" b="0">
-                <a:solidFill>
-                  <a:srgbClr val="333333"/>
-                </a:solidFill>
-                <a:latin typeface="Fira Sans"/>
-              </a:rPr>
-              <a:t>Entrega del retrato completo: jueves 10 de septiembre, por Aula.</a:t>
-            </a:r>
-          </a:p>
-          <a:p>
-            <a:pPr>
-              <a:lnSpc>
-                <a:spcPct val="112000"/>
-              </a:lnSpc>
-              <a:spcAft>
-                <a:spcPts val="900"/>
-              </a:spcAft>
-            </a:pPr>
-            <a:r>
-              <a:rPr sz="1800" b="1">
-                <a:solidFill>
-                  <a:srgbClr val="E0A437"/>
-                </a:solidFill>
-                <a:latin typeface="Fira Sans"/>
-              </a:rPr>
-              <a:t>▸ </a:t>
-            </a:r>
-            <a:r>
-              <a:rPr sz="1800" b="0">
-                <a:solidFill>
-                  <a:srgbClr val="000000"/>
-                </a:solidFill>
-                <a:latin typeface="Fira Sans"/>
-              </a:rPr>
-              <a:t>El enunciado está en evaluaciones/tareas/ y la guía de hoy en actividades/.</a:t>
-            </a:r>
-          </a:p>
-          <a:p>
-            <a:pPr>
-              <a:lnSpc>
-                <a:spcPct val="112000"/>
-              </a:lnSpc>
-              <a:spcAft>
-                <a:spcPts val="900"/>
-              </a:spcAft>
-            </a:pPr>
-            <a:r>
-              <a:rPr sz="1800" b="1">
-                <a:solidFill>
-                  <a:srgbClr val="E0A437"/>
-                </a:solidFill>
-                <a:latin typeface="Fira Sans"/>
-              </a:rPr>
-              <a:t>▸ </a:t>
-            </a:r>
-            <a:r>
-              <a:rPr sz="1800" b="1">
-                <a:solidFill>
-                  <a:srgbClr val="1D3557"/>
-                </a:solidFill>
-                <a:latin typeface="Fira Sans"/>
-              </a:rPr>
-              <a:t>Lo que avancen en este bloque ya es parte de la tarea.</a:t>
-            </a:r>
-          </a:p>
-        </p:txBody>
-      </p:sp>
-    </p:spTree>
-  </p:cSld>
-  <p:clrMapOvr>
-    <a:masterClrMapping/>
-  </p:clrMapOvr>
-</p:sld>
-</file>
-
-<file path=ppt/slides/slide36.xml><?xml version="1.0" encoding="utf-8"?>
 <p:sld xmlns:a="http://schemas.openxmlformats.org/drawingml/2006/main" xmlns:p="http://schemas.openxmlformats.org/presentationml/2006/main" xmlns:r="http://schemas.openxmlformats.org/officeDocument/2006/relationships">
   <p:cSld>
     <p:spTree>

</xml_diff>